<commit_message>
Add addressable-EPC-market slide covering the current client base
New slide 13: Consumers Energy (>$17B 5-yr plan), DTE ($36.5B 2026-30),
CenterPoint Indiana + Houston ($65B 10-yr, Houston Electric $46.3B),
and MidAmerican/MEC ($3.9B Wind PRIME atop ~$14B since 2004) — each
card pairs the public capital-plan figure with CVR's current foothold,
with a combined ~$120B takeaway band. Figures sourced from July 2026
public announcements and filings. This environment's network policy
blocks all logo hosts (Clearbit, Wikimedia, company sites), so cards
render brand-colored wordmarks; the build script auto-swaps in official
logo art dropped into reports/assets/logos/.

Co-Authored-By: Claude Fable 5 <noreply@anthropic.com>
Claude-Session: https://claude.ai/code/session_0145i7FWr3AQEo26DBw1x2c4
</commit_message>
<xml_diff>
--- a/reports/CVR_Deck_Jun2026.pptx
+++ b/reports/CVR_Deck_Jun2026.pptx
@@ -21,9 +21,10 @@
     <p:sldId id="269" r:id="rId15"/>
     <p:sldId id="270" r:id="rId16"/>
     <p:sldId id="271" r:id="rId17"/>
+    <p:sldId id="272" r:id="rId18"/>
   </p:sldIdLst>
   <p:notesMasterIdLst>
-    <p:notesMasterId r:id="rId18"/>
+    <p:notesMasterId r:id="rId19"/>
   </p:notesMasterIdLst>
   <p:sldSz cx="12192000" cy="6858000"/>
   <p:notesSz cx="6858000" cy="12192000"/>
@@ -1157,6 +1158,94 @@
             <a:fld id="{F7021451-1387-4CA6-816F-3879F97B5CBC}" type="slidenum">
               <a:rPr lang="en-US"/>
               <a:t>16</a:t>
+            </a:fld>
+            <a:endParaRPr lang="en-US"/>
+          </a:p>
+        </p:txBody>
+      </p:sp>
+    </p:spTree>
+    <p:extLst>
+      <p:ext uri="{BB962C8B-B14F-4D97-AF65-F5344CB8AC3E}">
+        <p14:creationId xmlns:p14="http://schemas.microsoft.com/office/powerpoint/2010/main" val="1024086991"/>
+      </p:ext>
+    </p:extLst>
+  </p:cSld>
+  <p:clrMapOvr>
+    <a:masterClrMapping/>
+  </p:clrMapOvr>
+</p:notes>
+</file>
+
+<file path=ppt/notesSlides/notesSlide17.xml><?xml version="1.0" encoding="utf-8"?>
+<p:notes xmlns:a="http://schemas.openxmlformats.org/drawingml/2006/main" xmlns:r="http://schemas.openxmlformats.org/officeDocument/2006/relationships" xmlns:p="http://schemas.openxmlformats.org/presentationml/2006/main">
+  <p:cSld>
+    <p:spTree>
+      <p:nvGrpSpPr>
+        <p:cNvPr id="1" name=""/>
+        <p:cNvGrpSpPr/>
+        <p:nvPr/>
+      </p:nvGrpSpPr>
+      <p:grpSpPr>
+        <a:xfrm>
+          <a:off x="0" y="0"/>
+          <a:ext cx="0" cy="0"/>
+          <a:chOff x="0" y="0"/>
+          <a:chExt cx="0" cy="0"/>
+        </a:xfrm>
+      </p:grpSpPr>
+      <p:sp>
+        <p:nvSpPr>
+          <p:cNvPr id="2" name="Slide Image Placeholder 1"/>
+          <p:cNvSpPr>
+            <a:spLocks noGrp="1" noRot="1" noChangeAspect="1"/>
+          </p:cNvSpPr>
+          <p:nvPr>
+            <p:ph type="sldImg"/>
+          </p:nvPr>
+        </p:nvSpPr>
+        <p:spPr/>
+      </p:sp>
+      <p:sp>
+        <p:nvSpPr>
+          <p:cNvPr id="3" name="Notes Placeholder 2"/>
+          <p:cNvSpPr>
+            <a:spLocks noGrp="1"/>
+          </p:cNvSpPr>
+          <p:nvPr>
+            <p:ph type="body" idx="1"/>
+          </p:nvPr>
+        </p:nvSpPr>
+        <p:spPr/>
+        <p:txBody>
+          <a:bodyPr/>
+          <a:lstStyle/>
+          <a:p>
+            <a:r>
+              <a:rPr lang="en-US" dirty="0"/>
+              <a:t/>
+            </a:r>
+            <a:endParaRPr lang="en-US" dirty="0"/>
+          </a:p>
+        </p:txBody>
+      </p:sp>
+      <p:sp>
+        <p:nvSpPr>
+          <p:cNvPr id="4" name="Slide Number Placeholder 3"/>
+          <p:cNvSpPr>
+            <a:spLocks noGrp="1"/>
+          </p:cNvSpPr>
+          <p:nvPr>
+            <p:ph type="sldNum" sz="quarter" idx="10"/>
+          </p:nvPr>
+        </p:nvSpPr>
+        <p:spPr/>
+        <p:txBody>
+          <a:bodyPr/>
+          <a:lstStyle/>
+          <a:p>
+            <a:fld id="{F7021451-1387-4CA6-816F-3879F97B5CBC}" type="slidenum">
+              <a:rPr lang="en-US"/>
+              <a:t>17</a:t>
             </a:fld>
             <a:endParaRPr lang="en-US"/>
           </a:p>
@@ -8340,6 +8429,1030 @@
                 <a:ea typeface="Calibri" pitchFamily="34" charset="-122"/>
                 <a:cs typeface="Calibri" pitchFamily="34" charset="-120"/>
               </a:rPr>
+              <a:t>STRATEGY — THE CONSOLIDATED OFFERING</a:t>
+            </a:r>
+            <a:endParaRPr lang="en-US" sz="1100" dirty="0"/>
+          </a:p>
+        </p:txBody>
+      </p:sp>
+      <p:sp>
+        <p:nvSpPr>
+          <p:cNvPr id="3" name="Text 1"/>
+          <p:cNvSpPr/>
+          <p:nvPr/>
+        </p:nvSpPr>
+        <p:spPr>
+          <a:xfrm>
+            <a:off x="548640" y="548640"/>
+            <a:ext cx="11064240" cy="502920"/>
+          </a:xfrm>
+          <a:prstGeom prst="rect">
+            <a:avLst/>
+          </a:prstGeom>
+          <a:noFill/>
+          <a:ln/>
+        </p:spPr>
+        <p:txBody>
+          <a:bodyPr wrap="square" lIns="0" tIns="0" rIns="0" bIns="0" rtlCol="0" anchor="ctr"/>
+          <a:lstStyle/>
+          <a:p>
+            <a:pPr indent="0" marL="0">
+              <a:buNone/>
+            </a:pPr>
+            <a:r>
+              <a:rPr lang="en-US" sz="2700" b="1" dirty="0">
+                <a:solidFill>
+                  <a:srgbClr val="0B0B0B"/>
+                </a:solidFill>
+                <a:latin typeface="Calibri" pitchFamily="34" charset="0"/>
+                <a:ea typeface="Calibri" pitchFamily="34" charset="-122"/>
+                <a:cs typeface="Calibri" pitchFamily="34" charset="-120"/>
+              </a:rPr>
+              <a:t>The addressable EPC market in our current client base</a:t>
+            </a:r>
+            <a:endParaRPr lang="en-US" sz="2700" dirty="0"/>
+          </a:p>
+        </p:txBody>
+      </p:sp>
+      <p:sp>
+        <p:nvSpPr>
+          <p:cNvPr id="4" name="Shape 2"/>
+          <p:cNvSpPr/>
+          <p:nvPr/>
+        </p:nvSpPr>
+        <p:spPr>
+          <a:xfrm>
+            <a:off x="548640" y="1371600"/>
+            <a:ext cx="5559552" cy="2084832"/>
+          </a:xfrm>
+          <a:prstGeom prst="roundRect">
+            <a:avLst>
+              <a:gd name="adj" fmla="val 2632"/>
+            </a:avLst>
+          </a:prstGeom>
+          <a:solidFill>
+            <a:srgbClr val="F7F7F5"/>
+          </a:solidFill>
+          <a:ln w="9525">
+            <a:solidFill>
+              <a:srgbClr val="E1E0D9"/>
+            </a:solidFill>
+            <a:prstDash val="solid"/>
+          </a:ln>
+        </p:spPr>
+      </p:sp>
+      <p:sp>
+        <p:nvSpPr>
+          <p:cNvPr id="5" name="Text 3"/>
+          <p:cNvSpPr/>
+          <p:nvPr/>
+        </p:nvSpPr>
+        <p:spPr>
+          <a:xfrm>
+            <a:off x="768096" y="1536192"/>
+            <a:ext cx="3566160" cy="310896"/>
+          </a:xfrm>
+          <a:prstGeom prst="rect">
+            <a:avLst/>
+          </a:prstGeom>
+          <a:noFill/>
+          <a:ln/>
+        </p:spPr>
+        <p:txBody>
+          <a:bodyPr wrap="square" lIns="0" tIns="0" rIns="0" bIns="0" rtlCol="0" anchor="ctr"/>
+          <a:lstStyle/>
+          <a:p>
+            <a:pPr indent="0" marL="0">
+              <a:buNone/>
+            </a:pPr>
+            <a:r>
+              <a:rPr lang="en-US" sz="1700" b="1" dirty="0">
+                <a:solidFill>
+                  <a:srgbClr val="0057B8"/>
+                </a:solidFill>
+                <a:latin typeface="Calibri" pitchFamily="34" charset="0"/>
+                <a:ea typeface="Calibri" pitchFamily="34" charset="-122"/>
+                <a:cs typeface="Calibri" pitchFamily="34" charset="-120"/>
+              </a:rPr>
+              <a:t>Consumers Energy</a:t>
+            </a:r>
+            <a:endParaRPr lang="en-US" sz="1700" dirty="0"/>
+          </a:p>
+        </p:txBody>
+      </p:sp>
+      <p:sp>
+        <p:nvSpPr>
+          <p:cNvPr id="6" name="Text 4"/>
+          <p:cNvSpPr/>
+          <p:nvPr/>
+        </p:nvSpPr>
+        <p:spPr>
+          <a:xfrm>
+            <a:off x="768096" y="1837944"/>
+            <a:ext cx="4206240" cy="237744"/>
+          </a:xfrm>
+          <a:prstGeom prst="rect">
+            <a:avLst/>
+          </a:prstGeom>
+          <a:noFill/>
+          <a:ln/>
+        </p:spPr>
+        <p:txBody>
+          <a:bodyPr wrap="square" lIns="0" tIns="0" rIns="0" bIns="0" rtlCol="0" anchor="ctr"/>
+          <a:lstStyle/>
+          <a:p>
+            <a:pPr indent="0" marL="0">
+              <a:buNone/>
+            </a:pPr>
+            <a:r>
+              <a:rPr lang="en-US" sz="1000" dirty="0">
+                <a:solidFill>
+                  <a:srgbClr val="52514E"/>
+                </a:solidFill>
+                <a:latin typeface="Calibri" pitchFamily="34" charset="0"/>
+                <a:ea typeface="Calibri" pitchFamily="34" charset="-122"/>
+                <a:cs typeface="Calibri" pitchFamily="34" charset="-120"/>
+              </a:rPr>
+              <a:t>Michigan — electric &amp; gas</a:t>
+            </a:r>
+            <a:endParaRPr lang="en-US" sz="1000" dirty="0"/>
+          </a:p>
+        </p:txBody>
+      </p:sp>
+      <p:sp>
+        <p:nvSpPr>
+          <p:cNvPr id="7" name="Text 5"/>
+          <p:cNvSpPr/>
+          <p:nvPr/>
+        </p:nvSpPr>
+        <p:spPr>
+          <a:xfrm>
+            <a:off x="768096" y="2157984"/>
+            <a:ext cx="5120640" cy="713232"/>
+          </a:xfrm>
+          <a:prstGeom prst="rect">
+            <a:avLst/>
+          </a:prstGeom>
+          <a:noFill/>
+          <a:ln/>
+        </p:spPr>
+        <p:txBody>
+          <a:bodyPr wrap="square" lIns="0" tIns="0" rIns="0" bIns="0" rtlCol="0" anchor="ctr"/>
+          <a:lstStyle/>
+          <a:p>
+            <a:pPr indent="0" marL="0">
+              <a:buNone/>
+            </a:pPr>
+            <a:r>
+              <a:rPr lang="en-US" sz="2400" b="1" dirty="0">
+                <a:solidFill>
+                  <a:srgbClr val="0B0B0B"/>
+                </a:solidFill>
+                <a:latin typeface="Calibri" pitchFamily="34" charset="0"/>
+                <a:ea typeface="Calibri" pitchFamily="34" charset="-122"/>
+                <a:cs typeface="Calibri" pitchFamily="34" charset="-120"/>
+              </a:rPr>
+              <a:t>&gt;$17B  </a:t>
+            </a:r>
+            <a:pPr indent="0" marL="0">
+              <a:buNone/>
+            </a:pPr>
+            <a:r>
+              <a:rPr lang="en-US" sz="1050" dirty="0">
+                <a:solidFill>
+                  <a:srgbClr val="52514E"/>
+                </a:solidFill>
+                <a:latin typeface="Calibri" pitchFamily="34" charset="0"/>
+                <a:ea typeface="Calibri" pitchFamily="34" charset="-122"/>
+                <a:cs typeface="Calibri" pitchFamily="34" charset="-120"/>
+              </a:rPr>
+              <a:t>5-year capital plan; $8.5B of distribution reliability &amp; resilience through 2029</a:t>
+            </a:r>
+            <a:endParaRPr lang="en-US" sz="2400" dirty="0"/>
+          </a:p>
+        </p:txBody>
+      </p:sp>
+      <p:sp>
+        <p:nvSpPr>
+          <p:cNvPr id="8" name="Text 6"/>
+          <p:cNvSpPr/>
+          <p:nvPr/>
+        </p:nvSpPr>
+        <p:spPr>
+          <a:xfrm>
+            <a:off x="768096" y="2944368"/>
+            <a:ext cx="5120640" cy="457200"/>
+          </a:xfrm>
+          <a:prstGeom prst="rect">
+            <a:avLst/>
+          </a:prstGeom>
+          <a:noFill/>
+          <a:ln/>
+        </p:spPr>
+        <p:txBody>
+          <a:bodyPr wrap="square" lIns="0" tIns="0" rIns="0" bIns="0" rtlCol="0" anchor="ctr"/>
+          <a:lstStyle/>
+          <a:p>
+            <a:pPr indent="0" marL="0">
+              <a:buNone/>
+            </a:pPr>
+            <a:r>
+              <a:rPr lang="en-US" sz="1000" i="1" dirty="0">
+                <a:solidFill>
+                  <a:srgbClr val="52514E"/>
+                </a:solidFill>
+                <a:latin typeface="Calibri" pitchFamily="34" charset="0"/>
+                <a:ea typeface="Calibri" pitchFamily="34" charset="-122"/>
+                <a:cs typeface="Calibri" pitchFamily="34" charset="-120"/>
+              </a:rPr>
+              <a:t>Foothold: HVD line-sensor &amp; pole programs live; $3.5M EPC-paired pole-replacement bid pending</a:t>
+            </a:r>
+            <a:endParaRPr lang="en-US" sz="1000" dirty="0"/>
+          </a:p>
+        </p:txBody>
+      </p:sp>
+      <p:sp>
+        <p:nvSpPr>
+          <p:cNvPr id="9" name="Shape 7"/>
+          <p:cNvSpPr/>
+          <p:nvPr/>
+        </p:nvSpPr>
+        <p:spPr>
+          <a:xfrm>
+            <a:off x="6291072" y="1371600"/>
+            <a:ext cx="5559552" cy="2084832"/>
+          </a:xfrm>
+          <a:prstGeom prst="roundRect">
+            <a:avLst>
+              <a:gd name="adj" fmla="val 2632"/>
+            </a:avLst>
+          </a:prstGeom>
+          <a:solidFill>
+            <a:srgbClr val="F7F7F5"/>
+          </a:solidFill>
+          <a:ln w="9525">
+            <a:solidFill>
+              <a:srgbClr val="E1E0D9"/>
+            </a:solidFill>
+            <a:prstDash val="solid"/>
+          </a:ln>
+        </p:spPr>
+      </p:sp>
+      <p:sp>
+        <p:nvSpPr>
+          <p:cNvPr id="10" name="Text 8"/>
+          <p:cNvSpPr/>
+          <p:nvPr/>
+        </p:nvSpPr>
+        <p:spPr>
+          <a:xfrm>
+            <a:off x="6510528" y="1536192"/>
+            <a:ext cx="3566160" cy="310896"/>
+          </a:xfrm>
+          <a:prstGeom prst="rect">
+            <a:avLst/>
+          </a:prstGeom>
+          <a:noFill/>
+          <a:ln/>
+        </p:spPr>
+        <p:txBody>
+          <a:bodyPr wrap="square" lIns="0" tIns="0" rIns="0" bIns="0" rtlCol="0" anchor="ctr"/>
+          <a:lstStyle/>
+          <a:p>
+            <a:pPr indent="0" marL="0">
+              <a:buNone/>
+            </a:pPr>
+            <a:r>
+              <a:rPr lang="en-US" sz="1700" b="1" dirty="0">
+                <a:solidFill>
+                  <a:srgbClr val="16376C"/>
+                </a:solidFill>
+                <a:latin typeface="Calibri" pitchFamily="34" charset="0"/>
+                <a:ea typeface="Calibri" pitchFamily="34" charset="-122"/>
+                <a:cs typeface="Calibri" pitchFamily="34" charset="-120"/>
+              </a:rPr>
+              <a:t>DTE Energy</a:t>
+            </a:r>
+            <a:endParaRPr lang="en-US" sz="1700" dirty="0"/>
+          </a:p>
+        </p:txBody>
+      </p:sp>
+      <p:sp>
+        <p:nvSpPr>
+          <p:cNvPr id="11" name="Text 9"/>
+          <p:cNvSpPr/>
+          <p:nvPr/>
+        </p:nvSpPr>
+        <p:spPr>
+          <a:xfrm>
+            <a:off x="6510528" y="1837944"/>
+            <a:ext cx="4206240" cy="237744"/>
+          </a:xfrm>
+          <a:prstGeom prst="rect">
+            <a:avLst/>
+          </a:prstGeom>
+          <a:noFill/>
+          <a:ln/>
+        </p:spPr>
+        <p:txBody>
+          <a:bodyPr wrap="square" lIns="0" tIns="0" rIns="0" bIns="0" rtlCol="0" anchor="ctr"/>
+          <a:lstStyle/>
+          <a:p>
+            <a:pPr indent="0" marL="0">
+              <a:buNone/>
+            </a:pPr>
+            <a:r>
+              <a:rPr lang="en-US" sz="1000" dirty="0">
+                <a:solidFill>
+                  <a:srgbClr val="52514E"/>
+                </a:solidFill>
+                <a:latin typeface="Calibri" pitchFamily="34" charset="0"/>
+                <a:ea typeface="Calibri" pitchFamily="34" charset="-122"/>
+                <a:cs typeface="Calibri" pitchFamily="34" charset="-120"/>
+              </a:rPr>
+              <a:t>Michigan — electric &amp; gas</a:t>
+            </a:r>
+            <a:endParaRPr lang="en-US" sz="1000" dirty="0"/>
+          </a:p>
+        </p:txBody>
+      </p:sp>
+      <p:sp>
+        <p:nvSpPr>
+          <p:cNvPr id="12" name="Text 10"/>
+          <p:cNvSpPr/>
+          <p:nvPr/>
+        </p:nvSpPr>
+        <p:spPr>
+          <a:xfrm>
+            <a:off x="6510528" y="2157984"/>
+            <a:ext cx="5120640" cy="713232"/>
+          </a:xfrm>
+          <a:prstGeom prst="rect">
+            <a:avLst/>
+          </a:prstGeom>
+          <a:noFill/>
+          <a:ln/>
+        </p:spPr>
+        <p:txBody>
+          <a:bodyPr wrap="square" lIns="0" tIns="0" rIns="0" bIns="0" rtlCol="0" anchor="ctr"/>
+          <a:lstStyle/>
+          <a:p>
+            <a:pPr indent="0" marL="0">
+              <a:buNone/>
+            </a:pPr>
+            <a:r>
+              <a:rPr lang="en-US" sz="2400" b="1" dirty="0">
+                <a:solidFill>
+                  <a:srgbClr val="0B0B0B"/>
+                </a:solidFill>
+                <a:latin typeface="Calibri" pitchFamily="34" charset="0"/>
+                <a:ea typeface="Calibri" pitchFamily="34" charset="-122"/>
+                <a:cs typeface="Calibri" pitchFamily="34" charset="-120"/>
+              </a:rPr>
+              <a:t>$36.5B  </a:t>
+            </a:r>
+            <a:pPr indent="0" marL="0">
+              <a:buNone/>
+            </a:pPr>
+            <a:r>
+              <a:rPr lang="en-US" sz="1050" dirty="0">
+                <a:solidFill>
+                  <a:srgbClr val="52514E"/>
+                </a:solidFill>
+                <a:latin typeface="Calibri" pitchFamily="34" charset="0"/>
+                <a:ea typeface="Calibri" pitchFamily="34" charset="-122"/>
+                <a:cs typeface="Calibri" pitchFamily="34" charset="-120"/>
+              </a:rPr>
+              <a:t>5-year plan 2026–30 — up 20% on data-center load and grid reliability spend</a:t>
+            </a:r>
+            <a:endParaRPr lang="en-US" sz="2400" dirty="0"/>
+          </a:p>
+        </p:txBody>
+      </p:sp>
+      <p:sp>
+        <p:nvSpPr>
+          <p:cNvPr id="13" name="Text 11"/>
+          <p:cNvSpPr/>
+          <p:nvPr/>
+        </p:nvSpPr>
+        <p:spPr>
+          <a:xfrm>
+            <a:off x="6510528" y="2944368"/>
+            <a:ext cx="5120640" cy="457200"/>
+          </a:xfrm>
+          <a:prstGeom prst="rect">
+            <a:avLst/>
+          </a:prstGeom>
+          <a:noFill/>
+          <a:ln/>
+        </p:spPr>
+        <p:txBody>
+          <a:bodyPr wrap="square" lIns="0" tIns="0" rIns="0" bIns="0" rtlCol="0" anchor="ctr"/>
+          <a:lstStyle/>
+          <a:p>
+            <a:pPr indent="0" marL="0">
+              <a:buNone/>
+            </a:pPr>
+            <a:r>
+              <a:rPr lang="en-US" sz="1000" i="1" dirty="0">
+                <a:solidFill>
+                  <a:srgbClr val="52514E"/>
+                </a:solidFill>
+                <a:latin typeface="Calibri" pitchFamily="34" charset="0"/>
+                <a:ea typeface="Calibri" pitchFamily="34" charset="-122"/>
+                <a:cs typeface="Calibri" pitchFamily="34" charset="-120"/>
+              </a:rPr>
+              <a:t>Foothold: New Baltimore &amp; Catalina conversions ($2.3M PO); Renaissance 345kV bid on hold</a:t>
+            </a:r>
+            <a:endParaRPr lang="en-US" sz="1000" dirty="0"/>
+          </a:p>
+        </p:txBody>
+      </p:sp>
+      <p:sp>
+        <p:nvSpPr>
+          <p:cNvPr id="14" name="Shape 12"/>
+          <p:cNvSpPr/>
+          <p:nvPr/>
+        </p:nvSpPr>
+        <p:spPr>
+          <a:xfrm>
+            <a:off x="548640" y="3584448"/>
+            <a:ext cx="5559552" cy="2084832"/>
+          </a:xfrm>
+          <a:prstGeom prst="roundRect">
+            <a:avLst>
+              <a:gd name="adj" fmla="val 2632"/>
+            </a:avLst>
+          </a:prstGeom>
+          <a:solidFill>
+            <a:srgbClr val="F7F7F5"/>
+          </a:solidFill>
+          <a:ln w="9525">
+            <a:solidFill>
+              <a:srgbClr val="E1E0D9"/>
+            </a:solidFill>
+            <a:prstDash val="solid"/>
+          </a:ln>
+        </p:spPr>
+      </p:sp>
+      <p:sp>
+        <p:nvSpPr>
+          <p:cNvPr id="15" name="Text 13"/>
+          <p:cNvSpPr/>
+          <p:nvPr/>
+        </p:nvSpPr>
+        <p:spPr>
+          <a:xfrm>
+            <a:off x="768096" y="3749040"/>
+            <a:ext cx="3566160" cy="310896"/>
+          </a:xfrm>
+          <a:prstGeom prst="rect">
+            <a:avLst/>
+          </a:prstGeom>
+          <a:noFill/>
+          <a:ln/>
+        </p:spPr>
+        <p:txBody>
+          <a:bodyPr wrap="square" lIns="0" tIns="0" rIns="0" bIns="0" rtlCol="0" anchor="ctr"/>
+          <a:lstStyle/>
+          <a:p>
+            <a:pPr indent="0" marL="0">
+              <a:buNone/>
+            </a:pPr>
+            <a:r>
+              <a:rPr lang="en-US" sz="1700" b="1" dirty="0">
+                <a:solidFill>
+                  <a:srgbClr val="E31937"/>
+                </a:solidFill>
+                <a:latin typeface="Calibri" pitchFamily="34" charset="0"/>
+                <a:ea typeface="Calibri" pitchFamily="34" charset="-122"/>
+                <a:cs typeface="Calibri" pitchFamily="34" charset="-120"/>
+              </a:rPr>
+              <a:t>CenterPoint Energy</a:t>
+            </a:r>
+            <a:endParaRPr lang="en-US" sz="1700" dirty="0"/>
+          </a:p>
+        </p:txBody>
+      </p:sp>
+      <p:sp>
+        <p:nvSpPr>
+          <p:cNvPr id="16" name="Text 14"/>
+          <p:cNvSpPr/>
+          <p:nvPr/>
+        </p:nvSpPr>
+        <p:spPr>
+          <a:xfrm>
+            <a:off x="768096" y="4050792"/>
+            <a:ext cx="4206240" cy="237744"/>
+          </a:xfrm>
+          <a:prstGeom prst="rect">
+            <a:avLst/>
+          </a:prstGeom>
+          <a:noFill/>
+          <a:ln/>
+        </p:spPr>
+        <p:txBody>
+          <a:bodyPr wrap="square" lIns="0" tIns="0" rIns="0" bIns="0" rtlCol="0" anchor="ctr"/>
+          <a:lstStyle/>
+          <a:p>
+            <a:pPr indent="0" marL="0">
+              <a:buNone/>
+            </a:pPr>
+            <a:r>
+              <a:rPr lang="en-US" sz="1000" dirty="0">
+                <a:solidFill>
+                  <a:srgbClr val="52514E"/>
+                </a:solidFill>
+                <a:latin typeface="Calibri" pitchFamily="34" charset="0"/>
+                <a:ea typeface="Calibri" pitchFamily="34" charset="-122"/>
+                <a:cs typeface="Calibri" pitchFamily="34" charset="-120"/>
+              </a:rPr>
+              <a:t>Indiana Electric + Houston Electric</a:t>
+            </a:r>
+            <a:endParaRPr lang="en-US" sz="1000" dirty="0"/>
+          </a:p>
+        </p:txBody>
+      </p:sp>
+      <p:sp>
+        <p:nvSpPr>
+          <p:cNvPr id="17" name="Text 15"/>
+          <p:cNvSpPr/>
+          <p:nvPr/>
+        </p:nvSpPr>
+        <p:spPr>
+          <a:xfrm>
+            <a:off x="768096" y="4370832"/>
+            <a:ext cx="5120640" cy="713232"/>
+          </a:xfrm>
+          <a:prstGeom prst="rect">
+            <a:avLst/>
+          </a:prstGeom>
+          <a:noFill/>
+          <a:ln/>
+        </p:spPr>
+        <p:txBody>
+          <a:bodyPr wrap="square" lIns="0" tIns="0" rIns="0" bIns="0" rtlCol="0" anchor="ctr"/>
+          <a:lstStyle/>
+          <a:p>
+            <a:pPr indent="0" marL="0">
+              <a:buNone/>
+            </a:pPr>
+            <a:r>
+              <a:rPr lang="en-US" sz="2400" b="1" dirty="0">
+                <a:solidFill>
+                  <a:srgbClr val="0B0B0B"/>
+                </a:solidFill>
+                <a:latin typeface="Calibri" pitchFamily="34" charset="0"/>
+                <a:ea typeface="Calibri" pitchFamily="34" charset="-122"/>
+                <a:cs typeface="Calibri" pitchFamily="34" charset="-120"/>
+              </a:rPr>
+              <a:t>$65B  </a:t>
+            </a:r>
+            <a:pPr indent="0" marL="0">
+              <a:buNone/>
+            </a:pPr>
+            <a:r>
+              <a:rPr lang="en-US" sz="1050" dirty="0">
+                <a:solidFill>
+                  <a:srgbClr val="52514E"/>
+                </a:solidFill>
+                <a:latin typeface="Calibri" pitchFamily="34" charset="0"/>
+                <a:ea typeface="Calibri" pitchFamily="34" charset="-122"/>
+                <a:cs typeface="Calibri" pitchFamily="34" charset="-120"/>
+              </a:rPr>
+              <a:t>10-year plan 2026–35; Houston Electric $46.3B; Indiana transmission &amp; data-center upside</a:t>
+            </a:r>
+            <a:endParaRPr lang="en-US" sz="2400" dirty="0"/>
+          </a:p>
+        </p:txBody>
+      </p:sp>
+      <p:sp>
+        <p:nvSpPr>
+          <p:cNvPr id="18" name="Text 16"/>
+          <p:cNvSpPr/>
+          <p:nvPr/>
+        </p:nvSpPr>
+        <p:spPr>
+          <a:xfrm>
+            <a:off x="768096" y="5157216"/>
+            <a:ext cx="5120640" cy="457200"/>
+          </a:xfrm>
+          <a:prstGeom prst="rect">
+            <a:avLst/>
+          </a:prstGeom>
+          <a:noFill/>
+          <a:ln/>
+        </p:spPr>
+        <p:txBody>
+          <a:bodyPr wrap="square" lIns="0" tIns="0" rIns="0" bIns="0" rtlCol="0" anchor="ctr"/>
+          <a:lstStyle/>
+          <a:p>
+            <a:pPr indent="0" marL="0">
+              <a:buNone/>
+            </a:pPr>
+            <a:r>
+              <a:rPr lang="en-US" sz="1000" i="1" dirty="0">
+                <a:solidFill>
+                  <a:srgbClr val="52514E"/>
+                </a:solidFill>
+                <a:latin typeface="Calibri" pitchFamily="34" charset="0"/>
+                <a:ea typeface="Calibri" pitchFamily="34" charset="-122"/>
+                <a:cs typeface="Calibri" pitchFamily="34" charset="-120"/>
+              </a:rPr>
+              <a:t>Foothold: 7 active Indiana substation jobs; Houston presence = the expansion runway</a:t>
+            </a:r>
+            <a:endParaRPr lang="en-US" sz="1000" dirty="0"/>
+          </a:p>
+        </p:txBody>
+      </p:sp>
+      <p:sp>
+        <p:nvSpPr>
+          <p:cNvPr id="19" name="Shape 17"/>
+          <p:cNvSpPr/>
+          <p:nvPr/>
+        </p:nvSpPr>
+        <p:spPr>
+          <a:xfrm>
+            <a:off x="6291072" y="3584448"/>
+            <a:ext cx="5559552" cy="2084832"/>
+          </a:xfrm>
+          <a:prstGeom prst="roundRect">
+            <a:avLst>
+              <a:gd name="adj" fmla="val 2632"/>
+            </a:avLst>
+          </a:prstGeom>
+          <a:solidFill>
+            <a:srgbClr val="F7F7F5"/>
+          </a:solidFill>
+          <a:ln w="9525">
+            <a:solidFill>
+              <a:srgbClr val="E1E0D9"/>
+            </a:solidFill>
+            <a:prstDash val="solid"/>
+          </a:ln>
+        </p:spPr>
+      </p:sp>
+      <p:sp>
+        <p:nvSpPr>
+          <p:cNvPr id="20" name="Text 18"/>
+          <p:cNvSpPr/>
+          <p:nvPr/>
+        </p:nvSpPr>
+        <p:spPr>
+          <a:xfrm>
+            <a:off x="6510528" y="3749040"/>
+            <a:ext cx="3566160" cy="310896"/>
+          </a:xfrm>
+          <a:prstGeom prst="rect">
+            <a:avLst/>
+          </a:prstGeom>
+          <a:noFill/>
+          <a:ln/>
+        </p:spPr>
+        <p:txBody>
+          <a:bodyPr wrap="square" lIns="0" tIns="0" rIns="0" bIns="0" rtlCol="0" anchor="ctr"/>
+          <a:lstStyle/>
+          <a:p>
+            <a:pPr indent="0" marL="0">
+              <a:buNone/>
+            </a:pPr>
+            <a:r>
+              <a:rPr lang="en-US" sz="1700" b="1" dirty="0">
+                <a:solidFill>
+                  <a:srgbClr val="14477D"/>
+                </a:solidFill>
+                <a:latin typeface="Calibri" pitchFamily="34" charset="0"/>
+                <a:ea typeface="Calibri" pitchFamily="34" charset="-122"/>
+                <a:cs typeface="Calibri" pitchFamily="34" charset="-120"/>
+              </a:rPr>
+              <a:t>MidAmerican Energy (MEC)</a:t>
+            </a:r>
+            <a:endParaRPr lang="en-US" sz="1700" dirty="0"/>
+          </a:p>
+        </p:txBody>
+      </p:sp>
+      <p:sp>
+        <p:nvSpPr>
+          <p:cNvPr id="21" name="Text 19"/>
+          <p:cNvSpPr/>
+          <p:nvPr/>
+        </p:nvSpPr>
+        <p:spPr>
+          <a:xfrm>
+            <a:off x="6510528" y="4050792"/>
+            <a:ext cx="4206240" cy="237744"/>
+          </a:xfrm>
+          <a:prstGeom prst="rect">
+            <a:avLst/>
+          </a:prstGeom>
+          <a:noFill/>
+          <a:ln/>
+        </p:spPr>
+        <p:txBody>
+          <a:bodyPr wrap="square" lIns="0" tIns="0" rIns="0" bIns="0" rtlCol="0" anchor="ctr"/>
+          <a:lstStyle/>
+          <a:p>
+            <a:pPr indent="0" marL="0">
+              <a:buNone/>
+            </a:pPr>
+            <a:r>
+              <a:rPr lang="en-US" sz="1000" dirty="0">
+                <a:solidFill>
+                  <a:srgbClr val="52514E"/>
+                </a:solidFill>
+                <a:latin typeface="Calibri" pitchFamily="34" charset="0"/>
+                <a:ea typeface="Calibri" pitchFamily="34" charset="-122"/>
+                <a:cs typeface="Calibri" pitchFamily="34" charset="-120"/>
+              </a:rPr>
+              <a:t>Iowa — Berkshire Hathaway Energy</a:t>
+            </a:r>
+            <a:endParaRPr lang="en-US" sz="1000" dirty="0"/>
+          </a:p>
+        </p:txBody>
+      </p:sp>
+      <p:sp>
+        <p:nvSpPr>
+          <p:cNvPr id="22" name="Text 20"/>
+          <p:cNvSpPr/>
+          <p:nvPr/>
+        </p:nvSpPr>
+        <p:spPr>
+          <a:xfrm>
+            <a:off x="6510528" y="4370832"/>
+            <a:ext cx="5120640" cy="713232"/>
+          </a:xfrm>
+          <a:prstGeom prst="rect">
+            <a:avLst/>
+          </a:prstGeom>
+          <a:noFill/>
+          <a:ln/>
+        </p:spPr>
+        <p:txBody>
+          <a:bodyPr wrap="square" lIns="0" tIns="0" rIns="0" bIns="0" rtlCol="0" anchor="ctr"/>
+          <a:lstStyle/>
+          <a:p>
+            <a:pPr indent="0" marL="0">
+              <a:buNone/>
+            </a:pPr>
+            <a:r>
+              <a:rPr lang="en-US" sz="2400" b="1" dirty="0">
+                <a:solidFill>
+                  <a:srgbClr val="0B0B0B"/>
+                </a:solidFill>
+                <a:latin typeface="Calibri" pitchFamily="34" charset="0"/>
+                <a:ea typeface="Calibri" pitchFamily="34" charset="-122"/>
+                <a:cs typeface="Calibri" pitchFamily="34" charset="-120"/>
+              </a:rPr>
+              <a:t>$3.9B  </a:t>
+            </a:r>
+            <a:pPr indent="0" marL="0">
+              <a:buNone/>
+            </a:pPr>
+            <a:r>
+              <a:rPr lang="en-US" sz="1050" dirty="0">
+                <a:solidFill>
+                  <a:srgbClr val="52514E"/>
+                </a:solidFill>
+                <a:latin typeface="Calibri" pitchFamily="34" charset="0"/>
+                <a:ea typeface="Calibri" pitchFamily="34" charset="-122"/>
+                <a:cs typeface="Calibri" pitchFamily="34" charset="-120"/>
+              </a:rPr>
+              <a:t>Wind PRIME program, on top of ~$14B invested in Iowa energy infrastructure since 2004</a:t>
+            </a:r>
+            <a:endParaRPr lang="en-US" sz="2400" dirty="0"/>
+          </a:p>
+        </p:txBody>
+      </p:sp>
+      <p:sp>
+        <p:nvSpPr>
+          <p:cNvPr id="23" name="Text 21"/>
+          <p:cNvSpPr/>
+          <p:nvPr/>
+        </p:nvSpPr>
+        <p:spPr>
+          <a:xfrm>
+            <a:off x="6510528" y="5157216"/>
+            <a:ext cx="5120640" cy="457200"/>
+          </a:xfrm>
+          <a:prstGeom prst="rect">
+            <a:avLst/>
+          </a:prstGeom>
+          <a:noFill/>
+          <a:ln/>
+        </p:spPr>
+        <p:txBody>
+          <a:bodyPr wrap="square" lIns="0" tIns="0" rIns="0" bIns="0" rtlCol="0" anchor="ctr"/>
+          <a:lstStyle/>
+          <a:p>
+            <a:pPr indent="0" marL="0">
+              <a:buNone/>
+            </a:pPr>
+            <a:r>
+              <a:rPr lang="en-US" sz="1000" i="1" dirty="0">
+                <a:solidFill>
+                  <a:srgbClr val="52514E"/>
+                </a:solidFill>
+                <a:latin typeface="Calibri" pitchFamily="34" charset="0"/>
+                <a:ea typeface="Calibri" pitchFamily="34" charset="-122"/>
+                <a:cs typeface="Calibri" pitchFamily="34" charset="-120"/>
+              </a:rPr>
+              <a:t>Foothold: 4 active EPC substation projects with HWC ($21.7M PO value)</a:t>
+            </a:r>
+            <a:endParaRPr lang="en-US" sz="1000" dirty="0"/>
+          </a:p>
+        </p:txBody>
+      </p:sp>
+      <p:sp>
+        <p:nvSpPr>
+          <p:cNvPr id="24" name="Shape 22"/>
+          <p:cNvSpPr/>
+          <p:nvPr/>
+        </p:nvSpPr>
+        <p:spPr>
+          <a:xfrm>
+            <a:off x="548640" y="5870448"/>
+            <a:ext cx="11064240" cy="475488"/>
+          </a:xfrm>
+          <a:prstGeom prst="roundRect">
+            <a:avLst>
+              <a:gd name="adj" fmla="val 9615"/>
+            </a:avLst>
+          </a:prstGeom>
+          <a:solidFill>
+            <a:srgbClr val="EAF1FA"/>
+          </a:solidFill>
+          <a:ln w="9525">
+            <a:solidFill>
+              <a:srgbClr val="E1E0D9"/>
+            </a:solidFill>
+            <a:prstDash val="solid"/>
+          </a:ln>
+        </p:spPr>
+      </p:sp>
+      <p:sp>
+        <p:nvSpPr>
+          <p:cNvPr id="25" name="Text 23"/>
+          <p:cNvSpPr/>
+          <p:nvPr/>
+        </p:nvSpPr>
+        <p:spPr>
+          <a:xfrm>
+            <a:off x="731520" y="5943600"/>
+            <a:ext cx="10698480" cy="329184"/>
+          </a:xfrm>
+          <a:prstGeom prst="rect">
+            <a:avLst/>
+          </a:prstGeom>
+          <a:noFill/>
+          <a:ln/>
+        </p:spPr>
+        <p:txBody>
+          <a:bodyPr wrap="square" lIns="0" tIns="0" rIns="0" bIns="0" rtlCol="0" anchor="ctr"/>
+          <a:lstStyle/>
+          <a:p>
+            <a:pPr indent="0" marL="0">
+              <a:buNone/>
+            </a:pPr>
+            <a:r>
+              <a:rPr lang="en-US" sz="1250" b="1" dirty="0">
+                <a:solidFill>
+                  <a:srgbClr val="0B0B0B"/>
+                </a:solidFill>
+                <a:latin typeface="Calibri" pitchFamily="34" charset="0"/>
+                <a:ea typeface="Calibri" pitchFamily="34" charset="-122"/>
+                <a:cs typeface="Calibri" pitchFamily="34" charset="-120"/>
+              </a:rPr>
+              <a:t>≈$120B in disclosed capital plans across this client base.  </a:t>
+            </a:r>
+            <a:pPr indent="0" marL="0">
+              <a:buNone/>
+            </a:pPr>
+            <a:r>
+              <a:rPr lang="en-US" sz="1250" dirty="0">
+                <a:solidFill>
+                  <a:srgbClr val="52514E"/>
+                </a:solidFill>
+                <a:latin typeface="Calibri" pitchFamily="34" charset="0"/>
+                <a:ea typeface="Calibri" pitchFamily="34" charset="-122"/>
+                <a:cs typeface="Calibri" pitchFamily="34" charset="-120"/>
+              </a:rPr>
+              <a:t>0.005% captured as engineering = the $6M Year-2 goal.</a:t>
+            </a:r>
+            <a:endParaRPr lang="en-US" sz="1250" dirty="0"/>
+          </a:p>
+        </p:txBody>
+      </p:sp>
+      <p:sp>
+        <p:nvSpPr>
+          <p:cNvPr id="26" name="Text 24"/>
+          <p:cNvSpPr/>
+          <p:nvPr/>
+        </p:nvSpPr>
+        <p:spPr>
+          <a:xfrm>
+            <a:off x="548640" y="6419088"/>
+            <a:ext cx="11064240" cy="320040"/>
+          </a:xfrm>
+          <a:prstGeom prst="rect">
+            <a:avLst/>
+          </a:prstGeom>
+          <a:noFill/>
+          <a:ln/>
+        </p:spPr>
+        <p:txBody>
+          <a:bodyPr wrap="square" lIns="0" tIns="0" rIns="0" bIns="0" rtlCol="0" anchor="ctr"/>
+          <a:lstStyle/>
+          <a:p>
+            <a:pPr indent="0" marL="0">
+              <a:buNone/>
+            </a:pPr>
+            <a:r>
+              <a:rPr lang="en-US" sz="950" dirty="0">
+                <a:solidFill>
+                  <a:srgbClr val="898781"/>
+                </a:solidFill>
+                <a:latin typeface="Calibri" pitchFamily="34" charset="0"/>
+                <a:ea typeface="Calibri" pitchFamily="34" charset="-122"/>
+                <a:cs typeface="Calibri" pitchFamily="34" charset="-120"/>
+              </a:rPr>
+              <a:t>Public sources: company capital-plan announcements and filings (Utility Dive, SEC 8-K, company releases), July 2026. Wordmarks shown; drop official logo files into reports/assets/logos/ and rebuild to swap them in.</a:t>
+            </a:r>
+            <a:endParaRPr lang="en-US" sz="950" dirty="0"/>
+          </a:p>
+        </p:txBody>
+      </p:sp>
+    </p:spTree>
+  </p:cSld>
+  <p:clrMapOvr>
+    <a:masterClrMapping/>
+  </p:clrMapOvr>
+</p:sld>
+</file>
+
+<file path=ppt/slides/slide14.xml><?xml version="1.0" encoding="utf-8"?>
+<p:sld xmlns:a="http://schemas.openxmlformats.org/drawingml/2006/main" xmlns:r="http://schemas.openxmlformats.org/officeDocument/2006/relationships" xmlns:p="http://schemas.openxmlformats.org/presentationml/2006/main">
+  <p:cSld name="Slide 14">
+    <p:spTree>
+      <p:nvGrpSpPr>
+        <p:cNvPr id="1" name=""/>
+        <p:cNvGrpSpPr/>
+        <p:nvPr/>
+      </p:nvGrpSpPr>
+      <p:grpSpPr>
+        <a:xfrm>
+          <a:off x="0" y="0"/>
+          <a:ext cx="0" cy="0"/>
+          <a:chOff x="0" y="0"/>
+          <a:chExt cx="0" cy="0"/>
+        </a:xfrm>
+      </p:grpSpPr>
+      <p:sp>
+        <p:nvSpPr>
+          <p:cNvPr id="2" name="Text 0"/>
+          <p:cNvSpPr/>
+          <p:nvPr/>
+        </p:nvSpPr>
+        <p:spPr>
+          <a:xfrm>
+            <a:off x="548640" y="292608"/>
+            <a:ext cx="11064240" cy="274320"/>
+          </a:xfrm>
+          <a:prstGeom prst="rect">
+            <a:avLst/>
+          </a:prstGeom>
+          <a:noFill/>
+          <a:ln/>
+        </p:spPr>
+        <p:txBody>
+          <a:bodyPr wrap="square" lIns="0" tIns="0" rIns="0" bIns="0" rtlCol="0" anchor="ctr"/>
+          <a:lstStyle/>
+          <a:p>
+            <a:pPr indent="0" marL="0">
+              <a:buNone/>
+            </a:pPr>
+            <a:r>
+              <a:rPr lang="en-US" sz="1100" b="1" dirty="0">
+                <a:solidFill>
+                  <a:srgbClr val="86B332"/>
+                </a:solidFill>
+                <a:latin typeface="Calibri" pitchFamily="34" charset="0"/>
+                <a:ea typeface="Calibri" pitchFamily="34" charset="-122"/>
+                <a:cs typeface="Calibri" pitchFamily="34" charset="-120"/>
+              </a:rPr>
+              <a:t>— </a:t>
+            </a:r>
+            <a:pPr indent="0" marL="0">
+              <a:buNone/>
+            </a:pPr>
+            <a:r>
+              <a:rPr lang="en-US" sz="1100" b="1" spc="200" kern="0" dirty="0">
+                <a:solidFill>
+                  <a:srgbClr val="52514E"/>
+                </a:solidFill>
+                <a:latin typeface="Calibri" pitchFamily="34" charset="0"/>
+                <a:ea typeface="Calibri" pitchFamily="34" charset="-122"/>
+                <a:cs typeface="Calibri" pitchFamily="34" charset="-120"/>
+              </a:rPr>
               <a:t>FORWARD VIEW — PHASE 2 MODEL, BASE SCENARIO</a:t>
             </a:r>
             <a:endParaRPr lang="en-US" sz="1100" dirty="0"/>
@@ -8690,9 +9803,9 @@
 </p:sld>
 </file>
 
-<file path=ppt/slides/slide14.xml><?xml version="1.0" encoding="utf-8"?>
+<file path=ppt/slides/slide15.xml><?xml version="1.0" encoding="utf-8"?>
 <p:sld xmlns:a="http://schemas.openxmlformats.org/drawingml/2006/main" xmlns:r="http://schemas.openxmlformats.org/officeDocument/2006/relationships" xmlns:p="http://schemas.openxmlformats.org/presentationml/2006/main">
-  <p:cSld name="Slide 14">
+  <p:cSld name="Slide 15">
     <p:spTree>
       <p:nvGrpSpPr>
         <p:cNvPr id="1" name=""/>
@@ -8801,7 +9914,7 @@
       </p:sp>
       <p:graphicFrame>
         <p:nvGraphicFramePr>
-          <p:cNvPr id="15" name="Table 0"/>
+          <p:cNvPr id="16" name="Table 0"/>
           <p:cNvGraphicFramePr>
             <a:graphicFrameLocks noGrp="1"/>
           </p:cNvGraphicFramePr>
@@ -10544,7 +11657,7 @@
       </p:graphicFrame>
       <p:graphicFrame>
         <p:nvGraphicFramePr>
-          <p:cNvPr id="29" name="Table 1"/>
+          <p:cNvPr id="31" name="Table 1"/>
           <p:cNvGraphicFramePr>
             <a:graphicFrameLocks noGrp="1"/>
           </p:cNvGraphicFramePr>
@@ -11399,7 +12512,7 @@
       </p:graphicFrame>
       <p:graphicFrame>
         <p:nvGraphicFramePr>
-          <p:cNvPr id="43" name="Table 2"/>
+          <p:cNvPr id="46" name="Table 2"/>
           <p:cNvGraphicFramePr>
             <a:graphicFrameLocks noGrp="1"/>
           </p:cNvGraphicFramePr>
@@ -13017,9 +14130,9 @@
 </p:sld>
 </file>
 
-<file path=ppt/slides/slide15.xml><?xml version="1.0" encoding="utf-8"?>
+<file path=ppt/slides/slide16.xml><?xml version="1.0" encoding="utf-8"?>
 <p:sld xmlns:a="http://schemas.openxmlformats.org/drawingml/2006/main" xmlns:r="http://schemas.openxmlformats.org/officeDocument/2006/relationships" xmlns:p="http://schemas.openxmlformats.org/presentationml/2006/main">
-  <p:cSld name="Slide 15">
+  <p:cSld name="Slide 16">
     <p:spTree>
       <p:nvGrpSpPr>
         <p:cNvPr id="1" name=""/>
@@ -13431,9 +14544,9 @@
 </p:sld>
 </file>
 
-<file path=ppt/slides/slide16.xml><?xml version="1.0" encoding="utf-8"?>
+<file path=ppt/slides/slide17.xml><?xml version="1.0" encoding="utf-8"?>
 <p:sld xmlns:a="http://schemas.openxmlformats.org/drawingml/2006/main" xmlns:r="http://schemas.openxmlformats.org/officeDocument/2006/relationships" xmlns:p="http://schemas.openxmlformats.org/presentationml/2006/main">
-  <p:cSld name="Slide 16">
+  <p:cSld name="Slide 17">
     <p:bg>
       <p:bgPr>
         <a:solidFill>

</xml_diff>

<commit_message>
Add business development slide: account owners for EPC pursuits
New slide 14 after the addressable-market slide: an account-coverage
table proposing owners for each EPC account (CenterPoint Indiana and
Houston, DTE, Consumers, MEC, the co-op/municipal cluster, and
prospects already receiving BD hours), drawn from current relationships
on the KPI scorecards and flagged as proposals to confirm. Right rail
frames the assign-vs-add decision: name owners from existing leadership
at zero cost, add one dedicated EPC Account Manager for the new-client
cluster and Houston entry (repaid by a single EPC win), and run a
monthly account cadence against the pipeline tab. Deck is now 18 slides.

Co-Authored-By: Claude Fable 5 <noreply@anthropic.com>
Claude-Session: https://claude.ai/code/session_0145i7FWr3AQEo26DBw1x2c4
</commit_message>
<xml_diff>
--- a/reports/CVR_Deck_Jun2026.pptx
+++ b/reports/CVR_Deck_Jun2026.pptx
@@ -22,9 +22,10 @@
     <p:sldId id="270" r:id="rId16"/>
     <p:sldId id="271" r:id="rId17"/>
     <p:sldId id="272" r:id="rId18"/>
+    <p:sldId id="273" r:id="rId19"/>
   </p:sldIdLst>
   <p:notesMasterIdLst>
-    <p:notesMasterId r:id="rId19"/>
+    <p:notesMasterId r:id="rId20"/>
   </p:notesMasterIdLst>
   <p:sldSz cx="12192000" cy="6858000"/>
   <p:notesSz cx="6858000" cy="12192000"/>
@@ -1246,6 +1247,94 @@
             <a:fld id="{F7021451-1387-4CA6-816F-3879F97B5CBC}" type="slidenum">
               <a:rPr lang="en-US"/>
               <a:t>17</a:t>
+            </a:fld>
+            <a:endParaRPr lang="en-US"/>
+          </a:p>
+        </p:txBody>
+      </p:sp>
+    </p:spTree>
+    <p:extLst>
+      <p:ext uri="{BB962C8B-B14F-4D97-AF65-F5344CB8AC3E}">
+        <p14:creationId xmlns:p14="http://schemas.microsoft.com/office/powerpoint/2010/main" val="1024086991"/>
+      </p:ext>
+    </p:extLst>
+  </p:cSld>
+  <p:clrMapOvr>
+    <a:masterClrMapping/>
+  </p:clrMapOvr>
+</p:notes>
+</file>
+
+<file path=ppt/notesSlides/notesSlide18.xml><?xml version="1.0" encoding="utf-8"?>
+<p:notes xmlns:a="http://schemas.openxmlformats.org/drawingml/2006/main" xmlns:r="http://schemas.openxmlformats.org/officeDocument/2006/relationships" xmlns:p="http://schemas.openxmlformats.org/presentationml/2006/main">
+  <p:cSld>
+    <p:spTree>
+      <p:nvGrpSpPr>
+        <p:cNvPr id="1" name=""/>
+        <p:cNvGrpSpPr/>
+        <p:nvPr/>
+      </p:nvGrpSpPr>
+      <p:grpSpPr>
+        <a:xfrm>
+          <a:off x="0" y="0"/>
+          <a:ext cx="0" cy="0"/>
+          <a:chOff x="0" y="0"/>
+          <a:chExt cx="0" cy="0"/>
+        </a:xfrm>
+      </p:grpSpPr>
+      <p:sp>
+        <p:nvSpPr>
+          <p:cNvPr id="2" name="Slide Image Placeholder 1"/>
+          <p:cNvSpPr>
+            <a:spLocks noGrp="1" noRot="1" noChangeAspect="1"/>
+          </p:cNvSpPr>
+          <p:nvPr>
+            <p:ph type="sldImg"/>
+          </p:nvPr>
+        </p:nvSpPr>
+        <p:spPr/>
+      </p:sp>
+      <p:sp>
+        <p:nvSpPr>
+          <p:cNvPr id="3" name="Notes Placeholder 2"/>
+          <p:cNvSpPr>
+            <a:spLocks noGrp="1"/>
+          </p:cNvSpPr>
+          <p:nvPr>
+            <p:ph type="body" idx="1"/>
+          </p:nvPr>
+        </p:nvSpPr>
+        <p:spPr/>
+        <p:txBody>
+          <a:bodyPr/>
+          <a:lstStyle/>
+          <a:p>
+            <a:r>
+              <a:rPr lang="en-US" dirty="0"/>
+              <a:t/>
+            </a:r>
+            <a:endParaRPr lang="en-US" dirty="0"/>
+          </a:p>
+        </p:txBody>
+      </p:sp>
+      <p:sp>
+        <p:nvSpPr>
+          <p:cNvPr id="4" name="Slide Number Placeholder 3"/>
+          <p:cNvSpPr>
+            <a:spLocks noGrp="1"/>
+          </p:cNvSpPr>
+          <p:nvPr>
+            <p:ph type="sldNum" sz="quarter" idx="10"/>
+          </p:nvPr>
+        </p:nvSpPr>
+        <p:spPr/>
+        <p:txBody>
+          <a:bodyPr/>
+          <a:lstStyle/>
+          <a:p>
+            <a:fld id="{F7021451-1387-4CA6-816F-3879F97B5CBC}" type="slidenum">
+              <a:rPr lang="en-US"/>
+              <a:t>18</a:t>
             </a:fld>
             <a:endParaRPr lang="en-US"/>
           </a:p>
@@ -9453,6 +9542,2075 @@
                 <a:ea typeface="Calibri" pitchFamily="34" charset="-122"/>
                 <a:cs typeface="Calibri" pitchFamily="34" charset="-120"/>
               </a:rPr>
+              <a:t>STRATEGY — BUSINESS DEVELOPMENT</a:t>
+            </a:r>
+            <a:endParaRPr lang="en-US" sz="1100" dirty="0"/>
+          </a:p>
+        </p:txBody>
+      </p:sp>
+      <p:sp>
+        <p:nvSpPr>
+          <p:cNvPr id="3" name="Text 1"/>
+          <p:cNvSpPr/>
+          <p:nvPr/>
+        </p:nvSpPr>
+        <p:spPr>
+          <a:xfrm>
+            <a:off x="548640" y="548640"/>
+            <a:ext cx="11064240" cy="502920"/>
+          </a:xfrm>
+          <a:prstGeom prst="rect">
+            <a:avLst/>
+          </a:prstGeom>
+          <a:noFill/>
+          <a:ln/>
+        </p:spPr>
+        <p:txBody>
+          <a:bodyPr wrap="square" lIns="0" tIns="0" rIns="0" bIns="0" rtlCol="0" anchor="ctr"/>
+          <a:lstStyle/>
+          <a:p>
+            <a:pPr indent="0" marL="0">
+              <a:buNone/>
+            </a:pPr>
+            <a:r>
+              <a:rPr lang="en-US" sz="2700" b="1" dirty="0">
+                <a:solidFill>
+                  <a:srgbClr val="0B0B0B"/>
+                </a:solidFill>
+                <a:latin typeface="Calibri" pitchFamily="34" charset="0"/>
+                <a:ea typeface="Calibri" pitchFamily="34" charset="-122"/>
+                <a:cs typeface="Calibri" pitchFamily="34" charset="-120"/>
+              </a:rPr>
+              <a:t>An owner on every EPC account</a:t>
+            </a:r>
+            <a:endParaRPr lang="en-US" sz="2700" dirty="0"/>
+          </a:p>
+        </p:txBody>
+      </p:sp>
+      <p:graphicFrame>
+        <p:nvGraphicFramePr>
+          <p:cNvPr id="15" name="Table 0"/>
+          <p:cNvGraphicFramePr>
+            <a:graphicFrameLocks noGrp="1"/>
+          </p:cNvGraphicFramePr>
+          <p:nvPr>
+            <p:extLst>
+              <p:ext uri="{D42A27DB-BD31-4B8C-83A1-F6EECF244321}">
+                <p14:modId xmlns:p14="http://schemas.microsoft.com/office/powerpoint/2010/main" val="1579011935"/>
+              </p:ext>
+            </p:extLst>
+          </p:nvPr>
+        </p:nvGraphicFramePr>
+        <p:xfrm>
+          <a:off x="548640" y="1371600"/>
+          <a:ext cx="7223760" cy="914400"/>
+        </p:xfrm>
+        <a:graphic>
+          <a:graphicData uri="http://schemas.openxmlformats.org/drawingml/2006/table">
+            <a:tbl>
+              <a:tblPr/>
+              <a:tblGrid>
+                <a:gridCol w="1600200"/>
+                <a:gridCol w="3383280"/>
+                <a:gridCol w="2240280"/>
+              </a:tblGrid>
+              <a:tr h="475488">
+                <a:tc>
+                  <a:txBody>
+                    <a:bodyPr/>
+                    <a:lstStyle/>
+                    <a:p>
+                      <a:pPr algn="l" indent="0" marL="0">
+                        <a:buNone/>
+                      </a:pPr>
+                      <a:r>
+                        <a:rPr lang="en-US" sz="1000" b="1" dirty="0">
+                          <a:solidFill>
+                            <a:srgbClr val="0B0B0B"/>
+                          </a:solidFill>
+                          <a:latin typeface="Calibri" pitchFamily="34" charset="0"/>
+                          <a:ea typeface="Calibri" pitchFamily="34" charset="-122"/>
+                          <a:cs typeface="Calibri" pitchFamily="34" charset="-120"/>
+                        </a:rPr>
+                        <a:t>Account</a:t>
+                      </a:r>
+                      <a:endParaRPr lang="en-US" sz="1000" dirty="0">
+                        <a:latin typeface="Calibri" charset="0"/>
+                        <a:ea typeface="Calibri" charset="0"/>
+                        <a:cs typeface="Calibri" charset="0"/>
+                      </a:endParaRPr>
+                    </a:p>
+                  </a:txBody>
+                  <a:tcPr marL="91440" marR="91440" marT="45720" marB="45720" anchor="ctr">
+                    <a:lnL w="6350" cap="flat" cmpd="sng" algn="ctr">
+                      <a:solidFill>
+                        <a:srgbClr val="E1E0D9"/>
+                      </a:solidFill>
+                      <a:prstDash val="solid"/>
+                      <a:round/>
+                      <a:headEnd type="none" w="med" len="med"/>
+                      <a:tailEnd type="none" w="med" len="med"/>
+                    </a:lnL>
+                    <a:lnR w="6350" cap="flat" cmpd="sng" algn="ctr">
+                      <a:solidFill>
+                        <a:srgbClr val="E1E0D9"/>
+                      </a:solidFill>
+                      <a:prstDash val="solid"/>
+                      <a:round/>
+                      <a:headEnd type="none" w="med" len="med"/>
+                      <a:tailEnd type="none" w="med" len="med"/>
+                    </a:lnR>
+                    <a:lnT w="6350" cap="flat" cmpd="sng" algn="ctr">
+                      <a:solidFill>
+                        <a:srgbClr val="E1E0D9"/>
+                      </a:solidFill>
+                      <a:prstDash val="solid"/>
+                      <a:round/>
+                      <a:headEnd type="none" w="med" len="med"/>
+                      <a:tailEnd type="none" w="med" len="med"/>
+                    </a:lnT>
+                    <a:lnB w="6350" cap="flat" cmpd="sng" algn="ctr">
+                      <a:solidFill>
+                        <a:srgbClr val="E1E0D9"/>
+                      </a:solidFill>
+                      <a:prstDash val="solid"/>
+                      <a:round/>
+                      <a:headEnd type="none" w="med" len="med"/>
+                      <a:tailEnd type="none" w="med" len="med"/>
+                    </a:lnB>
+                    <a:solidFill>
+                      <a:srgbClr val="FFFFFF"/>
+                    </a:solidFill>
+                  </a:tcPr>
+                </a:tc>
+                <a:tc>
+                  <a:txBody>
+                    <a:bodyPr/>
+                    <a:lstStyle/>
+                    <a:p>
+                      <a:pPr algn="l" indent="0" marL="0">
+                        <a:buNone/>
+                      </a:pPr>
+                      <a:r>
+                        <a:rPr lang="en-US" sz="1000" b="1" dirty="0">
+                          <a:solidFill>
+                            <a:srgbClr val="0B0B0B"/>
+                          </a:solidFill>
+                          <a:latin typeface="Calibri" pitchFamily="34" charset="0"/>
+                          <a:ea typeface="Calibri" pitchFamily="34" charset="-122"/>
+                          <a:cs typeface="Calibri" pitchFamily="34" charset="-120"/>
+                        </a:rPr>
+                        <a:t>EPC pursuit focus</a:t>
+                      </a:r>
+                      <a:endParaRPr lang="en-US" sz="1000" dirty="0">
+                        <a:latin typeface="Calibri" charset="0"/>
+                        <a:ea typeface="Calibri" charset="0"/>
+                        <a:cs typeface="Calibri" charset="0"/>
+                      </a:endParaRPr>
+                    </a:p>
+                  </a:txBody>
+                  <a:tcPr marL="91440" marR="91440" marT="45720" marB="45720" anchor="ctr">
+                    <a:lnL w="6350" cap="flat" cmpd="sng" algn="ctr">
+                      <a:solidFill>
+                        <a:srgbClr val="E1E0D9"/>
+                      </a:solidFill>
+                      <a:prstDash val="solid"/>
+                      <a:round/>
+                      <a:headEnd type="none" w="med" len="med"/>
+                      <a:tailEnd type="none" w="med" len="med"/>
+                    </a:lnL>
+                    <a:lnR w="6350" cap="flat" cmpd="sng" algn="ctr">
+                      <a:solidFill>
+                        <a:srgbClr val="E1E0D9"/>
+                      </a:solidFill>
+                      <a:prstDash val="solid"/>
+                      <a:round/>
+                      <a:headEnd type="none" w="med" len="med"/>
+                      <a:tailEnd type="none" w="med" len="med"/>
+                    </a:lnR>
+                    <a:lnT w="6350" cap="flat" cmpd="sng" algn="ctr">
+                      <a:solidFill>
+                        <a:srgbClr val="E1E0D9"/>
+                      </a:solidFill>
+                      <a:prstDash val="solid"/>
+                      <a:round/>
+                      <a:headEnd type="none" w="med" len="med"/>
+                      <a:tailEnd type="none" w="med" len="med"/>
+                    </a:lnT>
+                    <a:lnB w="6350" cap="flat" cmpd="sng" algn="ctr">
+                      <a:solidFill>
+                        <a:srgbClr val="E1E0D9"/>
+                      </a:solidFill>
+                      <a:prstDash val="solid"/>
+                      <a:round/>
+                      <a:headEnd type="none" w="med" len="med"/>
+                      <a:tailEnd type="none" w="med" len="med"/>
+                    </a:lnB>
+                    <a:solidFill>
+                      <a:srgbClr val="FFFFFF"/>
+                    </a:solidFill>
+                  </a:tcPr>
+                </a:tc>
+                <a:tc>
+                  <a:txBody>
+                    <a:bodyPr/>
+                    <a:lstStyle/>
+                    <a:p>
+                      <a:pPr algn="l" indent="0" marL="0">
+                        <a:buNone/>
+                      </a:pPr>
+                      <a:r>
+                        <a:rPr lang="en-US" sz="1000" b="1" dirty="0">
+                          <a:solidFill>
+                            <a:srgbClr val="0B0B0B"/>
+                          </a:solidFill>
+                          <a:latin typeface="Calibri" pitchFamily="34" charset="0"/>
+                          <a:ea typeface="Calibri" pitchFamily="34" charset="-122"/>
+                          <a:cs typeface="Calibri" pitchFamily="34" charset="-120"/>
+                        </a:rPr>
+                        <a:t>Proposed owner *</a:t>
+                      </a:r>
+                      <a:endParaRPr lang="en-US" sz="1000" dirty="0">
+                        <a:latin typeface="Calibri" charset="0"/>
+                        <a:ea typeface="Calibri" charset="0"/>
+                        <a:cs typeface="Calibri" charset="0"/>
+                      </a:endParaRPr>
+                    </a:p>
+                  </a:txBody>
+                  <a:tcPr marL="91440" marR="91440" marT="45720" marB="45720" anchor="ctr">
+                    <a:lnL w="6350" cap="flat" cmpd="sng" algn="ctr">
+                      <a:solidFill>
+                        <a:srgbClr val="E1E0D9"/>
+                      </a:solidFill>
+                      <a:prstDash val="solid"/>
+                      <a:round/>
+                      <a:headEnd type="none" w="med" len="med"/>
+                      <a:tailEnd type="none" w="med" len="med"/>
+                    </a:lnL>
+                    <a:lnR w="6350" cap="flat" cmpd="sng" algn="ctr">
+                      <a:solidFill>
+                        <a:srgbClr val="E1E0D9"/>
+                      </a:solidFill>
+                      <a:prstDash val="solid"/>
+                      <a:round/>
+                      <a:headEnd type="none" w="med" len="med"/>
+                      <a:tailEnd type="none" w="med" len="med"/>
+                    </a:lnR>
+                    <a:lnT w="6350" cap="flat" cmpd="sng" algn="ctr">
+                      <a:solidFill>
+                        <a:srgbClr val="E1E0D9"/>
+                      </a:solidFill>
+                      <a:prstDash val="solid"/>
+                      <a:round/>
+                      <a:headEnd type="none" w="med" len="med"/>
+                      <a:tailEnd type="none" w="med" len="med"/>
+                    </a:lnT>
+                    <a:lnB w="6350" cap="flat" cmpd="sng" algn="ctr">
+                      <a:solidFill>
+                        <a:srgbClr val="E1E0D9"/>
+                      </a:solidFill>
+                      <a:prstDash val="solid"/>
+                      <a:round/>
+                      <a:headEnd type="none" w="med" len="med"/>
+                      <a:tailEnd type="none" w="med" len="med"/>
+                    </a:lnB>
+                    <a:solidFill>
+                      <a:srgbClr val="FFFFFF"/>
+                    </a:solidFill>
+                  </a:tcPr>
+                </a:tc>
+              </a:tr>
+              <a:tr h="475488">
+                <a:tc>
+                  <a:txBody>
+                    <a:bodyPr/>
+                    <a:lstStyle/>
+                    <a:p>
+                      <a:pPr algn="l" indent="0" marL="0">
+                        <a:buNone/>
+                      </a:pPr>
+                      <a:r>
+                        <a:rPr lang="en-US" sz="1000" dirty="0">
+                          <a:solidFill>
+                            <a:srgbClr val="0B0B0B"/>
+                          </a:solidFill>
+                          <a:latin typeface="Calibri" pitchFamily="34" charset="0"/>
+                          <a:ea typeface="Calibri" pitchFamily="34" charset="-122"/>
+                          <a:cs typeface="Calibri" pitchFamily="34" charset="-120"/>
+                        </a:rPr>
+                        <a:t>CenterPoint — Indiana</a:t>
+                      </a:r>
+                      <a:endParaRPr lang="en-US" sz="1000" dirty="0">
+                        <a:latin typeface="Calibri" charset="0"/>
+                        <a:ea typeface="Calibri" charset="0"/>
+                        <a:cs typeface="Calibri" charset="0"/>
+                      </a:endParaRPr>
+                    </a:p>
+                  </a:txBody>
+                  <a:tcPr marL="91440" marR="91440" marT="45720" marB="45720" anchor="ctr">
+                    <a:lnL w="6350" cap="flat" cmpd="sng" algn="ctr">
+                      <a:solidFill>
+                        <a:srgbClr val="E1E0D9"/>
+                      </a:solidFill>
+                      <a:prstDash val="solid"/>
+                      <a:round/>
+                      <a:headEnd type="none" w="med" len="med"/>
+                      <a:tailEnd type="none" w="med" len="med"/>
+                    </a:lnL>
+                    <a:lnR w="6350" cap="flat" cmpd="sng" algn="ctr">
+                      <a:solidFill>
+                        <a:srgbClr val="E1E0D9"/>
+                      </a:solidFill>
+                      <a:prstDash val="solid"/>
+                      <a:round/>
+                      <a:headEnd type="none" w="med" len="med"/>
+                      <a:tailEnd type="none" w="med" len="med"/>
+                    </a:lnR>
+                    <a:lnT w="6350" cap="flat" cmpd="sng" algn="ctr">
+                      <a:solidFill>
+                        <a:srgbClr val="E1E0D9"/>
+                      </a:solidFill>
+                      <a:prstDash val="solid"/>
+                      <a:round/>
+                      <a:headEnd type="none" w="med" len="med"/>
+                      <a:tailEnd type="none" w="med" len="med"/>
+                    </a:lnT>
+                    <a:lnB w="6350" cap="flat" cmpd="sng" algn="ctr">
+                      <a:solidFill>
+                        <a:srgbClr val="E1E0D9"/>
+                      </a:solidFill>
+                      <a:prstDash val="solid"/>
+                      <a:round/>
+                      <a:headEnd type="none" w="med" len="med"/>
+                      <a:tailEnd type="none" w="med" len="med"/>
+                    </a:lnB>
+                    <a:solidFill>
+                      <a:srgbClr val="FFFFFF"/>
+                    </a:solidFill>
+                  </a:tcPr>
+                </a:tc>
+                <a:tc>
+                  <a:txBody>
+                    <a:bodyPr/>
+                    <a:lstStyle/>
+                    <a:p>
+                      <a:pPr algn="l" indent="0" marL="0">
+                        <a:buNone/>
+                      </a:pPr>
+                      <a:r>
+                        <a:rPr lang="en-US" sz="1000" dirty="0">
+                          <a:solidFill>
+                            <a:srgbClr val="0B0B0B"/>
+                          </a:solidFill>
+                          <a:latin typeface="Calibri" pitchFamily="34" charset="0"/>
+                          <a:ea typeface="Calibri" pitchFamily="34" charset="-122"/>
+                          <a:cs typeface="Calibri" pitchFamily="34" charset="-120"/>
+                        </a:rPr>
+                        <a:t>Substation program continuity; move from job-by-job to a program-level agreement</a:t>
+                      </a:r>
+                      <a:endParaRPr lang="en-US" sz="1000" dirty="0">
+                        <a:latin typeface="Calibri" charset="0"/>
+                        <a:ea typeface="Calibri" charset="0"/>
+                        <a:cs typeface="Calibri" charset="0"/>
+                      </a:endParaRPr>
+                    </a:p>
+                  </a:txBody>
+                  <a:tcPr marL="91440" marR="91440" marT="45720" marB="45720" anchor="ctr">
+                    <a:lnL w="6350" cap="flat" cmpd="sng" algn="ctr">
+                      <a:solidFill>
+                        <a:srgbClr val="E1E0D9"/>
+                      </a:solidFill>
+                      <a:prstDash val="solid"/>
+                      <a:round/>
+                      <a:headEnd type="none" w="med" len="med"/>
+                      <a:tailEnd type="none" w="med" len="med"/>
+                    </a:lnL>
+                    <a:lnR w="6350" cap="flat" cmpd="sng" algn="ctr">
+                      <a:solidFill>
+                        <a:srgbClr val="E1E0D9"/>
+                      </a:solidFill>
+                      <a:prstDash val="solid"/>
+                      <a:round/>
+                      <a:headEnd type="none" w="med" len="med"/>
+                      <a:tailEnd type="none" w="med" len="med"/>
+                    </a:lnR>
+                    <a:lnT w="6350" cap="flat" cmpd="sng" algn="ctr">
+                      <a:solidFill>
+                        <a:srgbClr val="E1E0D9"/>
+                      </a:solidFill>
+                      <a:prstDash val="solid"/>
+                      <a:round/>
+                      <a:headEnd type="none" w="med" len="med"/>
+                      <a:tailEnd type="none" w="med" len="med"/>
+                    </a:lnT>
+                    <a:lnB w="6350" cap="flat" cmpd="sng" algn="ctr">
+                      <a:solidFill>
+                        <a:srgbClr val="E1E0D9"/>
+                      </a:solidFill>
+                      <a:prstDash val="solid"/>
+                      <a:round/>
+                      <a:headEnd type="none" w="med" len="med"/>
+                      <a:tailEnd type="none" w="med" len="med"/>
+                    </a:lnB>
+                    <a:solidFill>
+                      <a:srgbClr val="FFFFFF"/>
+                    </a:solidFill>
+                  </a:tcPr>
+                </a:tc>
+                <a:tc>
+                  <a:txBody>
+                    <a:bodyPr/>
+                    <a:lstStyle/>
+                    <a:p>
+                      <a:pPr algn="l" indent="0" marL="0">
+                        <a:buNone/>
+                      </a:pPr>
+                      <a:r>
+                        <a:rPr lang="en-US" sz="1000" dirty="0">
+                          <a:solidFill>
+                            <a:srgbClr val="0B0B0B"/>
+                          </a:solidFill>
+                          <a:latin typeface="Calibri" pitchFamily="34" charset="0"/>
+                          <a:ea typeface="Calibri" pitchFamily="34" charset="-122"/>
+                          <a:cs typeface="Calibri" pitchFamily="34" charset="-120"/>
+                        </a:rPr>
+                        <a:t>Roy Pierce (VP Engineering — current PM)</a:t>
+                      </a:r>
+                      <a:endParaRPr lang="en-US" sz="1000" dirty="0">
+                        <a:latin typeface="Calibri" charset="0"/>
+                        <a:ea typeface="Calibri" charset="0"/>
+                        <a:cs typeface="Calibri" charset="0"/>
+                      </a:endParaRPr>
+                    </a:p>
+                  </a:txBody>
+                  <a:tcPr marL="91440" marR="91440" marT="45720" marB="45720" anchor="ctr">
+                    <a:lnL w="6350" cap="flat" cmpd="sng" algn="ctr">
+                      <a:solidFill>
+                        <a:srgbClr val="E1E0D9"/>
+                      </a:solidFill>
+                      <a:prstDash val="solid"/>
+                      <a:round/>
+                      <a:headEnd type="none" w="med" len="med"/>
+                      <a:tailEnd type="none" w="med" len="med"/>
+                    </a:lnL>
+                    <a:lnR w="6350" cap="flat" cmpd="sng" algn="ctr">
+                      <a:solidFill>
+                        <a:srgbClr val="E1E0D9"/>
+                      </a:solidFill>
+                      <a:prstDash val="solid"/>
+                      <a:round/>
+                      <a:headEnd type="none" w="med" len="med"/>
+                      <a:tailEnd type="none" w="med" len="med"/>
+                    </a:lnR>
+                    <a:lnT w="6350" cap="flat" cmpd="sng" algn="ctr">
+                      <a:solidFill>
+                        <a:srgbClr val="E1E0D9"/>
+                      </a:solidFill>
+                      <a:prstDash val="solid"/>
+                      <a:round/>
+                      <a:headEnd type="none" w="med" len="med"/>
+                      <a:tailEnd type="none" w="med" len="med"/>
+                    </a:lnT>
+                    <a:lnB w="6350" cap="flat" cmpd="sng" algn="ctr">
+                      <a:solidFill>
+                        <a:srgbClr val="E1E0D9"/>
+                      </a:solidFill>
+                      <a:prstDash val="solid"/>
+                      <a:round/>
+                      <a:headEnd type="none" w="med" len="med"/>
+                      <a:tailEnd type="none" w="med" len="med"/>
+                    </a:lnB>
+                    <a:solidFill>
+                      <a:srgbClr val="FFFFFF"/>
+                    </a:solidFill>
+                  </a:tcPr>
+                </a:tc>
+              </a:tr>
+              <a:tr h="475488">
+                <a:tc>
+                  <a:txBody>
+                    <a:bodyPr/>
+                    <a:lstStyle/>
+                    <a:p>
+                      <a:pPr algn="l" indent="0" marL="0">
+                        <a:buNone/>
+                      </a:pPr>
+                      <a:r>
+                        <a:rPr lang="en-US" sz="1000" dirty="0">
+                          <a:solidFill>
+                            <a:srgbClr val="0B0B0B"/>
+                          </a:solidFill>
+                          <a:latin typeface="Calibri" pitchFamily="34" charset="0"/>
+                          <a:ea typeface="Calibri" pitchFamily="34" charset="-122"/>
+                          <a:cs typeface="Calibri" pitchFamily="34" charset="-120"/>
+                        </a:rPr>
+                        <a:t>CenterPoint — Houston</a:t>
+                      </a:r>
+                      <a:endParaRPr lang="en-US" sz="1000" dirty="0">
+                        <a:latin typeface="Calibri" charset="0"/>
+                        <a:ea typeface="Calibri" charset="0"/>
+                        <a:cs typeface="Calibri" charset="0"/>
+                      </a:endParaRPr>
+                    </a:p>
+                  </a:txBody>
+                  <a:tcPr marL="91440" marR="91440" marT="45720" marB="45720" anchor="ctr">
+                    <a:lnL w="6350" cap="flat" cmpd="sng" algn="ctr">
+                      <a:solidFill>
+                        <a:srgbClr val="E1E0D9"/>
+                      </a:solidFill>
+                      <a:prstDash val="solid"/>
+                      <a:round/>
+                      <a:headEnd type="none" w="med" len="med"/>
+                      <a:tailEnd type="none" w="med" len="med"/>
+                    </a:lnL>
+                    <a:lnR w="6350" cap="flat" cmpd="sng" algn="ctr">
+                      <a:solidFill>
+                        <a:srgbClr val="E1E0D9"/>
+                      </a:solidFill>
+                      <a:prstDash val="solid"/>
+                      <a:round/>
+                      <a:headEnd type="none" w="med" len="med"/>
+                      <a:tailEnd type="none" w="med" len="med"/>
+                    </a:lnR>
+                    <a:lnT w="6350" cap="flat" cmpd="sng" algn="ctr">
+                      <a:solidFill>
+                        <a:srgbClr val="E1E0D9"/>
+                      </a:solidFill>
+                      <a:prstDash val="solid"/>
+                      <a:round/>
+                      <a:headEnd type="none" w="med" len="med"/>
+                      <a:tailEnd type="none" w="med" len="med"/>
+                    </a:lnT>
+                    <a:lnB w="6350" cap="flat" cmpd="sng" algn="ctr">
+                      <a:solidFill>
+                        <a:srgbClr val="E1E0D9"/>
+                      </a:solidFill>
+                      <a:prstDash val="solid"/>
+                      <a:round/>
+                      <a:headEnd type="none" w="med" len="med"/>
+                      <a:tailEnd type="none" w="med" len="med"/>
+                    </a:lnB>
+                    <a:solidFill>
+                      <a:srgbClr val="FFFFFF"/>
+                    </a:solidFill>
+                  </a:tcPr>
+                </a:tc>
+                <a:tc>
+                  <a:txBody>
+                    <a:bodyPr/>
+                    <a:lstStyle/>
+                    <a:p>
+                      <a:pPr algn="l" indent="0" marL="0">
+                        <a:buNone/>
+                      </a:pPr>
+                      <a:r>
+                        <a:rPr lang="en-US" sz="1000" dirty="0">
+                          <a:solidFill>
+                            <a:srgbClr val="0B0B0B"/>
+                          </a:solidFill>
+                          <a:latin typeface="Calibri" pitchFamily="34" charset="0"/>
+                          <a:ea typeface="Calibri" pitchFamily="34" charset="-122"/>
+                          <a:cs typeface="Calibri" pitchFamily="34" charset="-120"/>
+                        </a:rPr>
+                        <a:t>Entry into the $46.3B Houston Electric resiliency build — new territory</a:t>
+                      </a:r>
+                      <a:endParaRPr lang="en-US" sz="1000" dirty="0">
+                        <a:latin typeface="Calibri" charset="0"/>
+                        <a:ea typeface="Calibri" charset="0"/>
+                        <a:cs typeface="Calibri" charset="0"/>
+                      </a:endParaRPr>
+                    </a:p>
+                  </a:txBody>
+                  <a:tcPr marL="91440" marR="91440" marT="45720" marB="45720" anchor="ctr">
+                    <a:lnL w="6350" cap="flat" cmpd="sng" algn="ctr">
+                      <a:solidFill>
+                        <a:srgbClr val="E1E0D9"/>
+                      </a:solidFill>
+                      <a:prstDash val="solid"/>
+                      <a:round/>
+                      <a:headEnd type="none" w="med" len="med"/>
+                      <a:tailEnd type="none" w="med" len="med"/>
+                    </a:lnL>
+                    <a:lnR w="6350" cap="flat" cmpd="sng" algn="ctr">
+                      <a:solidFill>
+                        <a:srgbClr val="E1E0D9"/>
+                      </a:solidFill>
+                      <a:prstDash val="solid"/>
+                      <a:round/>
+                      <a:headEnd type="none" w="med" len="med"/>
+                      <a:tailEnd type="none" w="med" len="med"/>
+                    </a:lnR>
+                    <a:lnT w="6350" cap="flat" cmpd="sng" algn="ctr">
+                      <a:solidFill>
+                        <a:srgbClr val="E1E0D9"/>
+                      </a:solidFill>
+                      <a:prstDash val="solid"/>
+                      <a:round/>
+                      <a:headEnd type="none" w="med" len="med"/>
+                      <a:tailEnd type="none" w="med" len="med"/>
+                    </a:lnT>
+                    <a:lnB w="6350" cap="flat" cmpd="sng" algn="ctr">
+                      <a:solidFill>
+                        <a:srgbClr val="E1E0D9"/>
+                      </a:solidFill>
+                      <a:prstDash val="solid"/>
+                      <a:round/>
+                      <a:headEnd type="none" w="med" len="med"/>
+                      <a:tailEnd type="none" w="med" len="med"/>
+                    </a:lnB>
+                    <a:solidFill>
+                      <a:srgbClr val="FFFFFF"/>
+                    </a:solidFill>
+                  </a:tcPr>
+                </a:tc>
+                <a:tc>
+                  <a:txBody>
+                    <a:bodyPr/>
+                    <a:lstStyle/>
+                    <a:p>
+                      <a:pPr algn="l" indent="0" marL="0">
+                        <a:buNone/>
+                      </a:pPr>
+                      <a:r>
+                        <a:rPr lang="en-US" sz="1000" dirty="0">
+                          <a:solidFill>
+                            <a:srgbClr val="0B0B0B"/>
+                          </a:solidFill>
+                          <a:latin typeface="Calibri" pitchFamily="34" charset="0"/>
+                          <a:ea typeface="Calibri" pitchFamily="34" charset="-122"/>
+                          <a:cs typeface="Calibri" pitchFamily="34" charset="-120"/>
+                        </a:rPr>
+                        <a:t>SVP Engineering (Houston-based)</a:t>
+                      </a:r>
+                      <a:endParaRPr lang="en-US" sz="1000" dirty="0">
+                        <a:latin typeface="Calibri" charset="0"/>
+                        <a:ea typeface="Calibri" charset="0"/>
+                        <a:cs typeface="Calibri" charset="0"/>
+                      </a:endParaRPr>
+                    </a:p>
+                  </a:txBody>
+                  <a:tcPr marL="91440" marR="91440" marT="45720" marB="45720" anchor="ctr">
+                    <a:lnL w="6350" cap="flat" cmpd="sng" algn="ctr">
+                      <a:solidFill>
+                        <a:srgbClr val="E1E0D9"/>
+                      </a:solidFill>
+                      <a:prstDash val="solid"/>
+                      <a:round/>
+                      <a:headEnd type="none" w="med" len="med"/>
+                      <a:tailEnd type="none" w="med" len="med"/>
+                    </a:lnL>
+                    <a:lnR w="6350" cap="flat" cmpd="sng" algn="ctr">
+                      <a:solidFill>
+                        <a:srgbClr val="E1E0D9"/>
+                      </a:solidFill>
+                      <a:prstDash val="solid"/>
+                      <a:round/>
+                      <a:headEnd type="none" w="med" len="med"/>
+                      <a:tailEnd type="none" w="med" len="med"/>
+                    </a:lnR>
+                    <a:lnT w="6350" cap="flat" cmpd="sng" algn="ctr">
+                      <a:solidFill>
+                        <a:srgbClr val="E1E0D9"/>
+                      </a:solidFill>
+                      <a:prstDash val="solid"/>
+                      <a:round/>
+                      <a:headEnd type="none" w="med" len="med"/>
+                      <a:tailEnd type="none" w="med" len="med"/>
+                    </a:lnT>
+                    <a:lnB w="6350" cap="flat" cmpd="sng" algn="ctr">
+                      <a:solidFill>
+                        <a:srgbClr val="E1E0D9"/>
+                      </a:solidFill>
+                      <a:prstDash val="solid"/>
+                      <a:round/>
+                      <a:headEnd type="none" w="med" len="med"/>
+                      <a:tailEnd type="none" w="med" len="med"/>
+                    </a:lnB>
+                    <a:solidFill>
+                      <a:srgbClr val="FFFFFF"/>
+                    </a:solidFill>
+                  </a:tcPr>
+                </a:tc>
+              </a:tr>
+              <a:tr h="475488">
+                <a:tc>
+                  <a:txBody>
+                    <a:bodyPr/>
+                    <a:lstStyle/>
+                    <a:p>
+                      <a:pPr algn="l" indent="0" marL="0">
+                        <a:buNone/>
+                      </a:pPr>
+                      <a:r>
+                        <a:rPr lang="en-US" sz="1000" dirty="0">
+                          <a:solidFill>
+                            <a:srgbClr val="0B0B0B"/>
+                          </a:solidFill>
+                          <a:latin typeface="Calibri" pitchFamily="34" charset="0"/>
+                          <a:ea typeface="Calibri" pitchFamily="34" charset="-122"/>
+                          <a:cs typeface="Calibri" pitchFamily="34" charset="-120"/>
+                        </a:rPr>
+                        <a:t>DTE Energy</a:t>
+                      </a:r>
+                      <a:endParaRPr lang="en-US" sz="1000" dirty="0">
+                        <a:latin typeface="Calibri" charset="0"/>
+                        <a:ea typeface="Calibri" charset="0"/>
+                        <a:cs typeface="Calibri" charset="0"/>
+                      </a:endParaRPr>
+                    </a:p>
+                  </a:txBody>
+                  <a:tcPr marL="91440" marR="91440" marT="45720" marB="45720" anchor="ctr">
+                    <a:lnL w="6350" cap="flat" cmpd="sng" algn="ctr">
+                      <a:solidFill>
+                        <a:srgbClr val="E1E0D9"/>
+                      </a:solidFill>
+                      <a:prstDash val="solid"/>
+                      <a:round/>
+                      <a:headEnd type="none" w="med" len="med"/>
+                      <a:tailEnd type="none" w="med" len="med"/>
+                    </a:lnL>
+                    <a:lnR w="6350" cap="flat" cmpd="sng" algn="ctr">
+                      <a:solidFill>
+                        <a:srgbClr val="E1E0D9"/>
+                      </a:solidFill>
+                      <a:prstDash val="solid"/>
+                      <a:round/>
+                      <a:headEnd type="none" w="med" len="med"/>
+                      <a:tailEnd type="none" w="med" len="med"/>
+                    </a:lnR>
+                    <a:lnT w="6350" cap="flat" cmpd="sng" algn="ctr">
+                      <a:solidFill>
+                        <a:srgbClr val="E1E0D9"/>
+                      </a:solidFill>
+                      <a:prstDash val="solid"/>
+                      <a:round/>
+                      <a:headEnd type="none" w="med" len="med"/>
+                      <a:tailEnd type="none" w="med" len="med"/>
+                    </a:lnT>
+                    <a:lnB w="6350" cap="flat" cmpd="sng" algn="ctr">
+                      <a:solidFill>
+                        <a:srgbClr val="E1E0D9"/>
+                      </a:solidFill>
+                      <a:prstDash val="solid"/>
+                      <a:round/>
+                      <a:headEnd type="none" w="med" len="med"/>
+                      <a:tailEnd type="none" w="med" len="med"/>
+                    </a:lnB>
+                    <a:solidFill>
+                      <a:srgbClr val="FFFFFF"/>
+                    </a:solidFill>
+                  </a:tcPr>
+                </a:tc>
+                <a:tc>
+                  <a:txBody>
+                    <a:bodyPr/>
+                    <a:lstStyle/>
+                    <a:p>
+                      <a:pPr algn="l" indent="0" marL="0">
+                        <a:buNone/>
+                      </a:pPr>
+                      <a:r>
+                        <a:rPr lang="en-US" sz="1000" dirty="0">
+                          <a:solidFill>
+                            <a:srgbClr val="0B0B0B"/>
+                          </a:solidFill>
+                          <a:latin typeface="Calibri" pitchFamily="34" charset="0"/>
+                          <a:ea typeface="Calibri" pitchFamily="34" charset="-122"/>
+                          <a:cs typeface="Calibri" pitchFamily="34" charset="-120"/>
+                        </a:rPr>
+                        <a:t>Conversion program follow-on; revive the Renaissance 345kV pursuit</a:t>
+                      </a:r>
+                      <a:endParaRPr lang="en-US" sz="1000" dirty="0">
+                        <a:latin typeface="Calibri" charset="0"/>
+                        <a:ea typeface="Calibri" charset="0"/>
+                        <a:cs typeface="Calibri" charset="0"/>
+                      </a:endParaRPr>
+                    </a:p>
+                  </a:txBody>
+                  <a:tcPr marL="91440" marR="91440" marT="45720" marB="45720" anchor="ctr">
+                    <a:lnL w="6350" cap="flat" cmpd="sng" algn="ctr">
+                      <a:solidFill>
+                        <a:srgbClr val="E1E0D9"/>
+                      </a:solidFill>
+                      <a:prstDash val="solid"/>
+                      <a:round/>
+                      <a:headEnd type="none" w="med" len="med"/>
+                      <a:tailEnd type="none" w="med" len="med"/>
+                    </a:lnL>
+                    <a:lnR w="6350" cap="flat" cmpd="sng" algn="ctr">
+                      <a:solidFill>
+                        <a:srgbClr val="E1E0D9"/>
+                      </a:solidFill>
+                      <a:prstDash val="solid"/>
+                      <a:round/>
+                      <a:headEnd type="none" w="med" len="med"/>
+                      <a:tailEnd type="none" w="med" len="med"/>
+                    </a:lnR>
+                    <a:lnT w="6350" cap="flat" cmpd="sng" algn="ctr">
+                      <a:solidFill>
+                        <a:srgbClr val="E1E0D9"/>
+                      </a:solidFill>
+                      <a:prstDash val="solid"/>
+                      <a:round/>
+                      <a:headEnd type="none" w="med" len="med"/>
+                      <a:tailEnd type="none" w="med" len="med"/>
+                    </a:lnT>
+                    <a:lnB w="6350" cap="flat" cmpd="sng" algn="ctr">
+                      <a:solidFill>
+                        <a:srgbClr val="E1E0D9"/>
+                      </a:solidFill>
+                      <a:prstDash val="solid"/>
+                      <a:round/>
+                      <a:headEnd type="none" w="med" len="med"/>
+                      <a:tailEnd type="none" w="med" len="med"/>
+                    </a:lnB>
+                    <a:solidFill>
+                      <a:srgbClr val="FFFFFF"/>
+                    </a:solidFill>
+                  </a:tcPr>
+                </a:tc>
+                <a:tc>
+                  <a:txBody>
+                    <a:bodyPr/>
+                    <a:lstStyle/>
+                    <a:p>
+                      <a:pPr algn="l" indent="0" marL="0">
+                        <a:buNone/>
+                      </a:pPr>
+                      <a:r>
+                        <a:rPr lang="en-US" sz="1000" dirty="0">
+                          <a:solidFill>
+                            <a:srgbClr val="0B0B0B"/>
+                          </a:solidFill>
+                          <a:latin typeface="Calibri" pitchFamily="34" charset="0"/>
+                          <a:ea typeface="Calibri" pitchFamily="34" charset="-122"/>
+                          <a:cs typeface="Calibri" pitchFamily="34" charset="-120"/>
+                        </a:rPr>
+                        <a:t>Assign — VP Engineering or new AM</a:t>
+                      </a:r>
+                      <a:endParaRPr lang="en-US" sz="1000" dirty="0">
+                        <a:latin typeface="Calibri" charset="0"/>
+                        <a:ea typeface="Calibri" charset="0"/>
+                        <a:cs typeface="Calibri" charset="0"/>
+                      </a:endParaRPr>
+                    </a:p>
+                  </a:txBody>
+                  <a:tcPr marL="91440" marR="91440" marT="45720" marB="45720" anchor="ctr">
+                    <a:lnL w="6350" cap="flat" cmpd="sng" algn="ctr">
+                      <a:solidFill>
+                        <a:srgbClr val="E1E0D9"/>
+                      </a:solidFill>
+                      <a:prstDash val="solid"/>
+                      <a:round/>
+                      <a:headEnd type="none" w="med" len="med"/>
+                      <a:tailEnd type="none" w="med" len="med"/>
+                    </a:lnL>
+                    <a:lnR w="6350" cap="flat" cmpd="sng" algn="ctr">
+                      <a:solidFill>
+                        <a:srgbClr val="E1E0D9"/>
+                      </a:solidFill>
+                      <a:prstDash val="solid"/>
+                      <a:round/>
+                      <a:headEnd type="none" w="med" len="med"/>
+                      <a:tailEnd type="none" w="med" len="med"/>
+                    </a:lnR>
+                    <a:lnT w="6350" cap="flat" cmpd="sng" algn="ctr">
+                      <a:solidFill>
+                        <a:srgbClr val="E1E0D9"/>
+                      </a:solidFill>
+                      <a:prstDash val="solid"/>
+                      <a:round/>
+                      <a:headEnd type="none" w="med" len="med"/>
+                      <a:tailEnd type="none" w="med" len="med"/>
+                    </a:lnT>
+                    <a:lnB w="6350" cap="flat" cmpd="sng" algn="ctr">
+                      <a:solidFill>
+                        <a:srgbClr val="E1E0D9"/>
+                      </a:solidFill>
+                      <a:prstDash val="solid"/>
+                      <a:round/>
+                      <a:headEnd type="none" w="med" len="med"/>
+                      <a:tailEnd type="none" w="med" len="med"/>
+                    </a:lnB>
+                    <a:solidFill>
+                      <a:srgbClr val="FFFFFF"/>
+                    </a:solidFill>
+                  </a:tcPr>
+                </a:tc>
+              </a:tr>
+              <a:tr h="475488">
+                <a:tc>
+                  <a:txBody>
+                    <a:bodyPr/>
+                    <a:lstStyle/>
+                    <a:p>
+                      <a:pPr algn="l" indent="0" marL="0">
+                        <a:buNone/>
+                      </a:pPr>
+                      <a:r>
+                        <a:rPr lang="en-US" sz="1000" dirty="0">
+                          <a:solidFill>
+                            <a:srgbClr val="0B0B0B"/>
+                          </a:solidFill>
+                          <a:latin typeface="Calibri" pitchFamily="34" charset="0"/>
+                          <a:ea typeface="Calibri" pitchFamily="34" charset="-122"/>
+                          <a:cs typeface="Calibri" pitchFamily="34" charset="-120"/>
+                        </a:rPr>
+                        <a:t>Consumers Energy</a:t>
+                      </a:r>
+                      <a:endParaRPr lang="en-US" sz="1000" dirty="0">
+                        <a:latin typeface="Calibri" charset="0"/>
+                        <a:ea typeface="Calibri" charset="0"/>
+                        <a:cs typeface="Calibri" charset="0"/>
+                      </a:endParaRPr>
+                    </a:p>
+                  </a:txBody>
+                  <a:tcPr marL="91440" marR="91440" marT="45720" marB="45720" anchor="ctr">
+                    <a:lnL w="6350" cap="flat" cmpd="sng" algn="ctr">
+                      <a:solidFill>
+                        <a:srgbClr val="E1E0D9"/>
+                      </a:solidFill>
+                      <a:prstDash val="solid"/>
+                      <a:round/>
+                      <a:headEnd type="none" w="med" len="med"/>
+                      <a:tailEnd type="none" w="med" len="med"/>
+                    </a:lnL>
+                    <a:lnR w="6350" cap="flat" cmpd="sng" algn="ctr">
+                      <a:solidFill>
+                        <a:srgbClr val="E1E0D9"/>
+                      </a:solidFill>
+                      <a:prstDash val="solid"/>
+                      <a:round/>
+                      <a:headEnd type="none" w="med" len="med"/>
+                      <a:tailEnd type="none" w="med" len="med"/>
+                    </a:lnR>
+                    <a:lnT w="6350" cap="flat" cmpd="sng" algn="ctr">
+                      <a:solidFill>
+                        <a:srgbClr val="E1E0D9"/>
+                      </a:solidFill>
+                      <a:prstDash val="solid"/>
+                      <a:round/>
+                      <a:headEnd type="none" w="med" len="med"/>
+                      <a:tailEnd type="none" w="med" len="med"/>
+                    </a:lnT>
+                    <a:lnB w="6350" cap="flat" cmpd="sng" algn="ctr">
+                      <a:solidFill>
+                        <a:srgbClr val="E1E0D9"/>
+                      </a:solidFill>
+                      <a:prstDash val="solid"/>
+                      <a:round/>
+                      <a:headEnd type="none" w="med" len="med"/>
+                      <a:tailEnd type="none" w="med" len="med"/>
+                    </a:lnB>
+                    <a:solidFill>
+                      <a:srgbClr val="FFFFFF"/>
+                    </a:solidFill>
+                  </a:tcPr>
+                </a:tc>
+                <a:tc>
+                  <a:txBody>
+                    <a:bodyPr/>
+                    <a:lstStyle/>
+                    <a:p>
+                      <a:pPr algn="l" indent="0" marL="0">
+                        <a:buNone/>
+                      </a:pPr>
+                      <a:r>
+                        <a:rPr lang="en-US" sz="1000" dirty="0">
+                          <a:solidFill>
+                            <a:srgbClr val="0B0B0B"/>
+                          </a:solidFill>
+                          <a:latin typeface="Calibri" pitchFamily="34" charset="0"/>
+                          <a:ea typeface="Calibri" pitchFamily="34" charset="-122"/>
+                          <a:cs typeface="Calibri" pitchFamily="34" charset="-120"/>
+                        </a:rPr>
+                        <a:t>Convert pole/sensor programs into EPC-paired awards</a:t>
+                      </a:r>
+                      <a:endParaRPr lang="en-US" sz="1000" dirty="0">
+                        <a:latin typeface="Calibri" charset="0"/>
+                        <a:ea typeface="Calibri" charset="0"/>
+                        <a:cs typeface="Calibri" charset="0"/>
+                      </a:endParaRPr>
+                    </a:p>
+                  </a:txBody>
+                  <a:tcPr marL="91440" marR="91440" marT="45720" marB="45720" anchor="ctr">
+                    <a:lnL w="6350" cap="flat" cmpd="sng" algn="ctr">
+                      <a:solidFill>
+                        <a:srgbClr val="E1E0D9"/>
+                      </a:solidFill>
+                      <a:prstDash val="solid"/>
+                      <a:round/>
+                      <a:headEnd type="none" w="med" len="med"/>
+                      <a:tailEnd type="none" w="med" len="med"/>
+                    </a:lnL>
+                    <a:lnR w="6350" cap="flat" cmpd="sng" algn="ctr">
+                      <a:solidFill>
+                        <a:srgbClr val="E1E0D9"/>
+                      </a:solidFill>
+                      <a:prstDash val="solid"/>
+                      <a:round/>
+                      <a:headEnd type="none" w="med" len="med"/>
+                      <a:tailEnd type="none" w="med" len="med"/>
+                    </a:lnR>
+                    <a:lnT w="6350" cap="flat" cmpd="sng" algn="ctr">
+                      <a:solidFill>
+                        <a:srgbClr val="E1E0D9"/>
+                      </a:solidFill>
+                      <a:prstDash val="solid"/>
+                      <a:round/>
+                      <a:headEnd type="none" w="med" len="med"/>
+                      <a:tailEnd type="none" w="med" len="med"/>
+                    </a:lnT>
+                    <a:lnB w="6350" cap="flat" cmpd="sng" algn="ctr">
+                      <a:solidFill>
+                        <a:srgbClr val="E1E0D9"/>
+                      </a:solidFill>
+                      <a:prstDash val="solid"/>
+                      <a:round/>
+                      <a:headEnd type="none" w="med" len="med"/>
+                      <a:tailEnd type="none" w="med" len="med"/>
+                    </a:lnB>
+                    <a:solidFill>
+                      <a:srgbClr val="FFFFFF"/>
+                    </a:solidFill>
+                  </a:tcPr>
+                </a:tc>
+                <a:tc>
+                  <a:txBody>
+                    <a:bodyPr/>
+                    <a:lstStyle/>
+                    <a:p>
+                      <a:pPr algn="l" indent="0" marL="0">
+                        <a:buNone/>
+                      </a:pPr>
+                      <a:r>
+                        <a:rPr lang="en-US" sz="1000" dirty="0">
+                          <a:solidFill>
+                            <a:srgbClr val="0B0B0B"/>
+                          </a:solidFill>
+                          <a:latin typeface="Calibri" pitchFamily="34" charset="0"/>
+                          <a:ea typeface="Calibri" pitchFamily="34" charset="-122"/>
+                          <a:cs typeface="Calibri" pitchFamily="34" charset="-120"/>
+                        </a:rPr>
+                        <a:t>Frank Miller (Director of Estimating)</a:t>
+                      </a:r>
+                      <a:endParaRPr lang="en-US" sz="1000" dirty="0">
+                        <a:latin typeface="Calibri" charset="0"/>
+                        <a:ea typeface="Calibri" charset="0"/>
+                        <a:cs typeface="Calibri" charset="0"/>
+                      </a:endParaRPr>
+                    </a:p>
+                  </a:txBody>
+                  <a:tcPr marL="91440" marR="91440" marT="45720" marB="45720" anchor="ctr">
+                    <a:lnL w="6350" cap="flat" cmpd="sng" algn="ctr">
+                      <a:solidFill>
+                        <a:srgbClr val="E1E0D9"/>
+                      </a:solidFill>
+                      <a:prstDash val="solid"/>
+                      <a:round/>
+                      <a:headEnd type="none" w="med" len="med"/>
+                      <a:tailEnd type="none" w="med" len="med"/>
+                    </a:lnL>
+                    <a:lnR w="6350" cap="flat" cmpd="sng" algn="ctr">
+                      <a:solidFill>
+                        <a:srgbClr val="E1E0D9"/>
+                      </a:solidFill>
+                      <a:prstDash val="solid"/>
+                      <a:round/>
+                      <a:headEnd type="none" w="med" len="med"/>
+                      <a:tailEnd type="none" w="med" len="med"/>
+                    </a:lnR>
+                    <a:lnT w="6350" cap="flat" cmpd="sng" algn="ctr">
+                      <a:solidFill>
+                        <a:srgbClr val="E1E0D9"/>
+                      </a:solidFill>
+                      <a:prstDash val="solid"/>
+                      <a:round/>
+                      <a:headEnd type="none" w="med" len="med"/>
+                      <a:tailEnd type="none" w="med" len="med"/>
+                    </a:lnT>
+                    <a:lnB w="6350" cap="flat" cmpd="sng" algn="ctr">
+                      <a:solidFill>
+                        <a:srgbClr val="E1E0D9"/>
+                      </a:solidFill>
+                      <a:prstDash val="solid"/>
+                      <a:round/>
+                      <a:headEnd type="none" w="med" len="med"/>
+                      <a:tailEnd type="none" w="med" len="med"/>
+                    </a:lnB>
+                    <a:solidFill>
+                      <a:srgbClr val="FFFFFF"/>
+                    </a:solidFill>
+                  </a:tcPr>
+                </a:tc>
+              </a:tr>
+              <a:tr h="475488">
+                <a:tc>
+                  <a:txBody>
+                    <a:bodyPr/>
+                    <a:lstStyle/>
+                    <a:p>
+                      <a:pPr algn="l" indent="0" marL="0">
+                        <a:buNone/>
+                      </a:pPr>
+                      <a:r>
+                        <a:rPr lang="en-US" sz="1000" dirty="0">
+                          <a:solidFill>
+                            <a:srgbClr val="0B0B0B"/>
+                          </a:solidFill>
+                          <a:latin typeface="Calibri" pitchFamily="34" charset="0"/>
+                          <a:ea typeface="Calibri" pitchFamily="34" charset="-122"/>
+                          <a:cs typeface="Calibri" pitchFamily="34" charset="-120"/>
+                        </a:rPr>
+                        <a:t>MidAmerican (MEC)</a:t>
+                      </a:r>
+                      <a:endParaRPr lang="en-US" sz="1000" dirty="0">
+                        <a:latin typeface="Calibri" charset="0"/>
+                        <a:ea typeface="Calibri" charset="0"/>
+                        <a:cs typeface="Calibri" charset="0"/>
+                      </a:endParaRPr>
+                    </a:p>
+                  </a:txBody>
+                  <a:tcPr marL="91440" marR="91440" marT="45720" marB="45720" anchor="ctr">
+                    <a:lnL w="6350" cap="flat" cmpd="sng" algn="ctr">
+                      <a:solidFill>
+                        <a:srgbClr val="E1E0D9"/>
+                      </a:solidFill>
+                      <a:prstDash val="solid"/>
+                      <a:round/>
+                      <a:headEnd type="none" w="med" len="med"/>
+                      <a:tailEnd type="none" w="med" len="med"/>
+                    </a:lnL>
+                    <a:lnR w="6350" cap="flat" cmpd="sng" algn="ctr">
+                      <a:solidFill>
+                        <a:srgbClr val="E1E0D9"/>
+                      </a:solidFill>
+                      <a:prstDash val="solid"/>
+                      <a:round/>
+                      <a:headEnd type="none" w="med" len="med"/>
+                      <a:tailEnd type="none" w="med" len="med"/>
+                    </a:lnR>
+                    <a:lnT w="6350" cap="flat" cmpd="sng" algn="ctr">
+                      <a:solidFill>
+                        <a:srgbClr val="E1E0D9"/>
+                      </a:solidFill>
+                      <a:prstDash val="solid"/>
+                      <a:round/>
+                      <a:headEnd type="none" w="med" len="med"/>
+                      <a:tailEnd type="none" w="med" len="med"/>
+                    </a:lnT>
+                    <a:lnB w="6350" cap="flat" cmpd="sng" algn="ctr">
+                      <a:solidFill>
+                        <a:srgbClr val="E1E0D9"/>
+                      </a:solidFill>
+                      <a:prstDash val="solid"/>
+                      <a:round/>
+                      <a:headEnd type="none" w="med" len="med"/>
+                      <a:tailEnd type="none" w="med" len="med"/>
+                    </a:lnB>
+                    <a:solidFill>
+                      <a:srgbClr val="FFFFFF"/>
+                    </a:solidFill>
+                  </a:tcPr>
+                </a:tc>
+                <a:tc>
+                  <a:txBody>
+                    <a:bodyPr/>
+                    <a:lstStyle/>
+                    <a:p>
+                      <a:pPr algn="l" indent="0" marL="0">
+                        <a:buNone/>
+                      </a:pPr>
+                      <a:r>
+                        <a:rPr lang="en-US" sz="1000" dirty="0">
+                          <a:solidFill>
+                            <a:srgbClr val="0B0B0B"/>
+                          </a:solidFill>
+                          <a:latin typeface="Calibri" pitchFamily="34" charset="0"/>
+                          <a:ea typeface="Calibri" pitchFamily="34" charset="-122"/>
+                          <a:cs typeface="Calibri" pitchFamily="34" charset="-120"/>
+                        </a:rPr>
+                        <a:t>Extend the 4-project EPC substation program</a:t>
+                      </a:r>
+                      <a:endParaRPr lang="en-US" sz="1000" dirty="0">
+                        <a:latin typeface="Calibri" charset="0"/>
+                        <a:ea typeface="Calibri" charset="0"/>
+                        <a:cs typeface="Calibri" charset="0"/>
+                      </a:endParaRPr>
+                    </a:p>
+                  </a:txBody>
+                  <a:tcPr marL="91440" marR="91440" marT="45720" marB="45720" anchor="ctr">
+                    <a:lnL w="6350" cap="flat" cmpd="sng" algn="ctr">
+                      <a:solidFill>
+                        <a:srgbClr val="E1E0D9"/>
+                      </a:solidFill>
+                      <a:prstDash val="solid"/>
+                      <a:round/>
+                      <a:headEnd type="none" w="med" len="med"/>
+                      <a:tailEnd type="none" w="med" len="med"/>
+                    </a:lnL>
+                    <a:lnR w="6350" cap="flat" cmpd="sng" algn="ctr">
+                      <a:solidFill>
+                        <a:srgbClr val="E1E0D9"/>
+                      </a:solidFill>
+                      <a:prstDash val="solid"/>
+                      <a:round/>
+                      <a:headEnd type="none" w="med" len="med"/>
+                      <a:tailEnd type="none" w="med" len="med"/>
+                    </a:lnR>
+                    <a:lnT w="6350" cap="flat" cmpd="sng" algn="ctr">
+                      <a:solidFill>
+                        <a:srgbClr val="E1E0D9"/>
+                      </a:solidFill>
+                      <a:prstDash val="solid"/>
+                      <a:round/>
+                      <a:headEnd type="none" w="med" len="med"/>
+                      <a:tailEnd type="none" w="med" len="med"/>
+                    </a:lnT>
+                    <a:lnB w="6350" cap="flat" cmpd="sng" algn="ctr">
+                      <a:solidFill>
+                        <a:srgbClr val="E1E0D9"/>
+                      </a:solidFill>
+                      <a:prstDash val="solid"/>
+                      <a:round/>
+                      <a:headEnd type="none" w="med" len="med"/>
+                      <a:tailEnd type="none" w="med" len="med"/>
+                    </a:lnB>
+                    <a:solidFill>
+                      <a:srgbClr val="FFFFFF"/>
+                    </a:solidFill>
+                  </a:tcPr>
+                </a:tc>
+                <a:tc>
+                  <a:txBody>
+                    <a:bodyPr/>
+                    <a:lstStyle/>
+                    <a:p>
+                      <a:pPr algn="l" indent="0" marL="0">
+                        <a:buNone/>
+                      </a:pPr>
+                      <a:r>
+                        <a:rPr lang="en-US" sz="1000" dirty="0">
+                          <a:solidFill>
+                            <a:srgbClr val="0B0B0B"/>
+                          </a:solidFill>
+                          <a:latin typeface="Calibri" pitchFamily="34" charset="0"/>
+                          <a:ea typeface="Calibri" pitchFamily="34" charset="-122"/>
+                          <a:cs typeface="Calibri" pitchFamily="34" charset="-120"/>
+                        </a:rPr>
+                        <a:t>Ethan McDaniel (EPC PM — current)</a:t>
+                      </a:r>
+                      <a:endParaRPr lang="en-US" sz="1000" dirty="0">
+                        <a:latin typeface="Calibri" charset="0"/>
+                        <a:ea typeface="Calibri" charset="0"/>
+                        <a:cs typeface="Calibri" charset="0"/>
+                      </a:endParaRPr>
+                    </a:p>
+                  </a:txBody>
+                  <a:tcPr marL="91440" marR="91440" marT="45720" marB="45720" anchor="ctr">
+                    <a:lnL w="6350" cap="flat" cmpd="sng" algn="ctr">
+                      <a:solidFill>
+                        <a:srgbClr val="E1E0D9"/>
+                      </a:solidFill>
+                      <a:prstDash val="solid"/>
+                      <a:round/>
+                      <a:headEnd type="none" w="med" len="med"/>
+                      <a:tailEnd type="none" w="med" len="med"/>
+                    </a:lnL>
+                    <a:lnR w="6350" cap="flat" cmpd="sng" algn="ctr">
+                      <a:solidFill>
+                        <a:srgbClr val="E1E0D9"/>
+                      </a:solidFill>
+                      <a:prstDash val="solid"/>
+                      <a:round/>
+                      <a:headEnd type="none" w="med" len="med"/>
+                      <a:tailEnd type="none" w="med" len="med"/>
+                    </a:lnR>
+                    <a:lnT w="6350" cap="flat" cmpd="sng" algn="ctr">
+                      <a:solidFill>
+                        <a:srgbClr val="E1E0D9"/>
+                      </a:solidFill>
+                      <a:prstDash val="solid"/>
+                      <a:round/>
+                      <a:headEnd type="none" w="med" len="med"/>
+                      <a:tailEnd type="none" w="med" len="med"/>
+                    </a:lnT>
+                    <a:lnB w="6350" cap="flat" cmpd="sng" algn="ctr">
+                      <a:solidFill>
+                        <a:srgbClr val="E1E0D9"/>
+                      </a:solidFill>
+                      <a:prstDash val="solid"/>
+                      <a:round/>
+                      <a:headEnd type="none" w="med" len="med"/>
+                      <a:tailEnd type="none" w="med" len="med"/>
+                    </a:lnB>
+                    <a:solidFill>
+                      <a:srgbClr val="FFFFFF"/>
+                    </a:solidFill>
+                  </a:tcPr>
+                </a:tc>
+              </a:tr>
+              <a:tr h="475488">
+                <a:tc>
+                  <a:txBody>
+                    <a:bodyPr/>
+                    <a:lstStyle/>
+                    <a:p>
+                      <a:pPr algn="l" indent="0" marL="0">
+                        <a:buNone/>
+                      </a:pPr>
+                      <a:r>
+                        <a:rPr lang="en-US" sz="1000" dirty="0">
+                          <a:solidFill>
+                            <a:srgbClr val="0B0B0B"/>
+                          </a:solidFill>
+                          <a:latin typeface="Calibri" pitchFamily="34" charset="0"/>
+                          <a:ea typeface="Calibri" pitchFamily="34" charset="-122"/>
+                          <a:cs typeface="Calibri" pitchFamily="34" charset="-120"/>
+                        </a:rPr>
+                        <a:t>Co-op &amp; municipal cluster</a:t>
+                      </a:r>
+                      <a:endParaRPr lang="en-US" sz="1000" dirty="0">
+                        <a:latin typeface="Calibri" charset="0"/>
+                        <a:ea typeface="Calibri" charset="0"/>
+                        <a:cs typeface="Calibri" charset="0"/>
+                      </a:endParaRPr>
+                    </a:p>
+                  </a:txBody>
+                  <a:tcPr marL="91440" marR="91440" marT="45720" marB="45720" anchor="ctr">
+                    <a:lnL w="6350" cap="flat" cmpd="sng" algn="ctr">
+                      <a:solidFill>
+                        <a:srgbClr val="E1E0D9"/>
+                      </a:solidFill>
+                      <a:prstDash val="solid"/>
+                      <a:round/>
+                      <a:headEnd type="none" w="med" len="med"/>
+                      <a:tailEnd type="none" w="med" len="med"/>
+                    </a:lnL>
+                    <a:lnR w="6350" cap="flat" cmpd="sng" algn="ctr">
+                      <a:solidFill>
+                        <a:srgbClr val="E1E0D9"/>
+                      </a:solidFill>
+                      <a:prstDash val="solid"/>
+                      <a:round/>
+                      <a:headEnd type="none" w="med" len="med"/>
+                      <a:tailEnd type="none" w="med" len="med"/>
+                    </a:lnR>
+                    <a:lnT w="6350" cap="flat" cmpd="sng" algn="ctr">
+                      <a:solidFill>
+                        <a:srgbClr val="E1E0D9"/>
+                      </a:solidFill>
+                      <a:prstDash val="solid"/>
+                      <a:round/>
+                      <a:headEnd type="none" w="med" len="med"/>
+                      <a:tailEnd type="none" w="med" len="med"/>
+                    </a:lnT>
+                    <a:lnB w="6350" cap="flat" cmpd="sng" algn="ctr">
+                      <a:solidFill>
+                        <a:srgbClr val="E1E0D9"/>
+                      </a:solidFill>
+                      <a:prstDash val="solid"/>
+                      <a:round/>
+                      <a:headEnd type="none" w="med" len="med"/>
+                      <a:tailEnd type="none" w="med" len="med"/>
+                    </a:lnB>
+                    <a:solidFill>
+                      <a:srgbClr val="FFFFFF"/>
+                    </a:solidFill>
+                  </a:tcPr>
+                </a:tc>
+                <a:tc>
+                  <a:txBody>
+                    <a:bodyPr/>
+                    <a:lstStyle/>
+                    <a:p>
+                      <a:pPr algn="l" indent="0" marL="0">
+                        <a:buNone/>
+                      </a:pPr>
+                      <a:r>
+                        <a:rPr lang="en-US" sz="1000" dirty="0">
+                          <a:solidFill>
+                            <a:srgbClr val="0B0B0B"/>
+                          </a:solidFill>
+                          <a:latin typeface="Calibri" pitchFamily="34" charset="0"/>
+                          <a:ea typeface="Calibri" pitchFamily="34" charset="-122"/>
+                          <a:cs typeface="Calibri" pitchFamily="34" charset="-120"/>
+                        </a:rPr>
+                        <a:t>Hoosier, Steuben, Lansing BWL, Great Lakes — the consolidated-offer beachhead</a:t>
+                      </a:r>
+                      <a:endParaRPr lang="en-US" sz="1000" dirty="0">
+                        <a:latin typeface="Calibri" charset="0"/>
+                        <a:ea typeface="Calibri" charset="0"/>
+                        <a:cs typeface="Calibri" charset="0"/>
+                      </a:endParaRPr>
+                    </a:p>
+                  </a:txBody>
+                  <a:tcPr marL="91440" marR="91440" marT="45720" marB="45720" anchor="ctr">
+                    <a:lnL w="6350" cap="flat" cmpd="sng" algn="ctr">
+                      <a:solidFill>
+                        <a:srgbClr val="E1E0D9"/>
+                      </a:solidFill>
+                      <a:prstDash val="solid"/>
+                      <a:round/>
+                      <a:headEnd type="none" w="med" len="med"/>
+                      <a:tailEnd type="none" w="med" len="med"/>
+                    </a:lnL>
+                    <a:lnR w="6350" cap="flat" cmpd="sng" algn="ctr">
+                      <a:solidFill>
+                        <a:srgbClr val="E1E0D9"/>
+                      </a:solidFill>
+                      <a:prstDash val="solid"/>
+                      <a:round/>
+                      <a:headEnd type="none" w="med" len="med"/>
+                      <a:tailEnd type="none" w="med" len="med"/>
+                    </a:lnR>
+                    <a:lnT w="6350" cap="flat" cmpd="sng" algn="ctr">
+                      <a:solidFill>
+                        <a:srgbClr val="E1E0D9"/>
+                      </a:solidFill>
+                      <a:prstDash val="solid"/>
+                      <a:round/>
+                      <a:headEnd type="none" w="med" len="med"/>
+                      <a:tailEnd type="none" w="med" len="med"/>
+                    </a:lnT>
+                    <a:lnB w="6350" cap="flat" cmpd="sng" algn="ctr">
+                      <a:solidFill>
+                        <a:srgbClr val="E1E0D9"/>
+                      </a:solidFill>
+                      <a:prstDash val="solid"/>
+                      <a:round/>
+                      <a:headEnd type="none" w="med" len="med"/>
+                      <a:tailEnd type="none" w="med" len="med"/>
+                    </a:lnB>
+                    <a:solidFill>
+                      <a:srgbClr val="FFFFFF"/>
+                    </a:solidFill>
+                  </a:tcPr>
+                </a:tc>
+                <a:tc>
+                  <a:txBody>
+                    <a:bodyPr/>
+                    <a:lstStyle/>
+                    <a:p>
+                      <a:pPr algn="l" indent="0" marL="0">
+                        <a:buNone/>
+                      </a:pPr>
+                      <a:r>
+                        <a:rPr lang="en-US" sz="1000" dirty="0">
+                          <a:solidFill>
+                            <a:srgbClr val="0B0B0B"/>
+                          </a:solidFill>
+                          <a:latin typeface="Calibri" pitchFamily="34" charset="0"/>
+                          <a:ea typeface="Calibri" pitchFamily="34" charset="-122"/>
+                          <a:cs typeface="Calibri" pitchFamily="34" charset="-120"/>
+                        </a:rPr>
+                        <a:t>New EPC Account Manager (hire)</a:t>
+                      </a:r>
+                      <a:endParaRPr lang="en-US" sz="1000" dirty="0">
+                        <a:latin typeface="Calibri" charset="0"/>
+                        <a:ea typeface="Calibri" charset="0"/>
+                        <a:cs typeface="Calibri" charset="0"/>
+                      </a:endParaRPr>
+                    </a:p>
+                  </a:txBody>
+                  <a:tcPr marL="91440" marR="91440" marT="45720" marB="45720" anchor="ctr">
+                    <a:lnL w="6350" cap="flat" cmpd="sng" algn="ctr">
+                      <a:solidFill>
+                        <a:srgbClr val="E1E0D9"/>
+                      </a:solidFill>
+                      <a:prstDash val="solid"/>
+                      <a:round/>
+                      <a:headEnd type="none" w="med" len="med"/>
+                      <a:tailEnd type="none" w="med" len="med"/>
+                    </a:lnL>
+                    <a:lnR w="6350" cap="flat" cmpd="sng" algn="ctr">
+                      <a:solidFill>
+                        <a:srgbClr val="E1E0D9"/>
+                      </a:solidFill>
+                      <a:prstDash val="solid"/>
+                      <a:round/>
+                      <a:headEnd type="none" w="med" len="med"/>
+                      <a:tailEnd type="none" w="med" len="med"/>
+                    </a:lnR>
+                    <a:lnT w="6350" cap="flat" cmpd="sng" algn="ctr">
+                      <a:solidFill>
+                        <a:srgbClr val="E1E0D9"/>
+                      </a:solidFill>
+                      <a:prstDash val="solid"/>
+                      <a:round/>
+                      <a:headEnd type="none" w="med" len="med"/>
+                      <a:tailEnd type="none" w="med" len="med"/>
+                    </a:lnT>
+                    <a:lnB w="6350" cap="flat" cmpd="sng" algn="ctr">
+                      <a:solidFill>
+                        <a:srgbClr val="E1E0D9"/>
+                      </a:solidFill>
+                      <a:prstDash val="solid"/>
+                      <a:round/>
+                      <a:headEnd type="none" w="med" len="med"/>
+                      <a:tailEnd type="none" w="med" len="med"/>
+                    </a:lnB>
+                    <a:solidFill>
+                      <a:srgbClr val="FFFFFF"/>
+                    </a:solidFill>
+                  </a:tcPr>
+                </a:tc>
+              </a:tr>
+              <a:tr h="475488">
+                <a:tc>
+                  <a:txBody>
+                    <a:bodyPr/>
+                    <a:lstStyle/>
+                    <a:p>
+                      <a:pPr algn="l" indent="0" marL="0">
+                        <a:buNone/>
+                      </a:pPr>
+                      <a:r>
+                        <a:rPr lang="en-US" sz="1000" dirty="0">
+                          <a:solidFill>
+                            <a:srgbClr val="0B0B0B"/>
+                          </a:solidFill>
+                          <a:latin typeface="Calibri" pitchFamily="34" charset="0"/>
+                          <a:ea typeface="Calibri" pitchFamily="34" charset="-122"/>
+                          <a:cs typeface="Calibri" pitchFamily="34" charset="-120"/>
+                        </a:rPr>
+                        <a:t>Prospects in motion</a:t>
+                      </a:r>
+                      <a:endParaRPr lang="en-US" sz="1000" dirty="0">
+                        <a:latin typeface="Calibri" charset="0"/>
+                        <a:ea typeface="Calibri" charset="0"/>
+                        <a:cs typeface="Calibri" charset="0"/>
+                      </a:endParaRPr>
+                    </a:p>
+                  </a:txBody>
+                  <a:tcPr marL="91440" marR="91440" marT="45720" marB="45720" anchor="ctr">
+                    <a:lnL w="6350" cap="flat" cmpd="sng" algn="ctr">
+                      <a:solidFill>
+                        <a:srgbClr val="E1E0D9"/>
+                      </a:solidFill>
+                      <a:prstDash val="solid"/>
+                      <a:round/>
+                      <a:headEnd type="none" w="med" len="med"/>
+                      <a:tailEnd type="none" w="med" len="med"/>
+                    </a:lnL>
+                    <a:lnR w="6350" cap="flat" cmpd="sng" algn="ctr">
+                      <a:solidFill>
+                        <a:srgbClr val="E1E0D9"/>
+                      </a:solidFill>
+                      <a:prstDash val="solid"/>
+                      <a:round/>
+                      <a:headEnd type="none" w="med" len="med"/>
+                      <a:tailEnd type="none" w="med" len="med"/>
+                    </a:lnR>
+                    <a:lnT w="6350" cap="flat" cmpd="sng" algn="ctr">
+                      <a:solidFill>
+                        <a:srgbClr val="E1E0D9"/>
+                      </a:solidFill>
+                      <a:prstDash val="solid"/>
+                      <a:round/>
+                      <a:headEnd type="none" w="med" len="med"/>
+                      <a:tailEnd type="none" w="med" len="med"/>
+                    </a:lnT>
+                    <a:lnB w="6350" cap="flat" cmpd="sng" algn="ctr">
+                      <a:solidFill>
+                        <a:srgbClr val="E1E0D9"/>
+                      </a:solidFill>
+                      <a:prstDash val="solid"/>
+                      <a:round/>
+                      <a:headEnd type="none" w="med" len="med"/>
+                      <a:tailEnd type="none" w="med" len="med"/>
+                    </a:lnB>
+                    <a:solidFill>
+                      <a:srgbClr val="FFFFFF"/>
+                    </a:solidFill>
+                  </a:tcPr>
+                </a:tc>
+                <a:tc>
+                  <a:txBody>
+                    <a:bodyPr/>
+                    <a:lstStyle/>
+                    <a:p>
+                      <a:pPr algn="l" indent="0" marL="0">
+                        <a:buNone/>
+                      </a:pPr>
+                      <a:r>
+                        <a:rPr lang="en-US" sz="1000" dirty="0">
+                          <a:solidFill>
+                            <a:srgbClr val="0B0B0B"/>
+                          </a:solidFill>
+                          <a:latin typeface="Calibri" pitchFamily="34" charset="0"/>
+                          <a:ea typeface="Calibri" pitchFamily="34" charset="-122"/>
+                          <a:cs typeface="Calibri" pitchFamily="34" charset="-120"/>
+                        </a:rPr>
+                        <a:t>NIPSCO, AES Ohio, AES Indiana, Duke — BD hours already flowing, no owner yet</a:t>
+                      </a:r>
+                      <a:endParaRPr lang="en-US" sz="1000" dirty="0">
+                        <a:latin typeface="Calibri" charset="0"/>
+                        <a:ea typeface="Calibri" charset="0"/>
+                        <a:cs typeface="Calibri" charset="0"/>
+                      </a:endParaRPr>
+                    </a:p>
+                  </a:txBody>
+                  <a:tcPr marL="91440" marR="91440" marT="45720" marB="45720" anchor="ctr">
+                    <a:lnL w="6350" cap="flat" cmpd="sng" algn="ctr">
+                      <a:solidFill>
+                        <a:srgbClr val="E1E0D9"/>
+                      </a:solidFill>
+                      <a:prstDash val="solid"/>
+                      <a:round/>
+                      <a:headEnd type="none" w="med" len="med"/>
+                      <a:tailEnd type="none" w="med" len="med"/>
+                    </a:lnL>
+                    <a:lnR w="6350" cap="flat" cmpd="sng" algn="ctr">
+                      <a:solidFill>
+                        <a:srgbClr val="E1E0D9"/>
+                      </a:solidFill>
+                      <a:prstDash val="solid"/>
+                      <a:round/>
+                      <a:headEnd type="none" w="med" len="med"/>
+                      <a:tailEnd type="none" w="med" len="med"/>
+                    </a:lnR>
+                    <a:lnT w="6350" cap="flat" cmpd="sng" algn="ctr">
+                      <a:solidFill>
+                        <a:srgbClr val="E1E0D9"/>
+                      </a:solidFill>
+                      <a:prstDash val="solid"/>
+                      <a:round/>
+                      <a:headEnd type="none" w="med" len="med"/>
+                      <a:tailEnd type="none" w="med" len="med"/>
+                    </a:lnT>
+                    <a:lnB w="6350" cap="flat" cmpd="sng" algn="ctr">
+                      <a:solidFill>
+                        <a:srgbClr val="E1E0D9"/>
+                      </a:solidFill>
+                      <a:prstDash val="solid"/>
+                      <a:round/>
+                      <a:headEnd type="none" w="med" len="med"/>
+                      <a:tailEnd type="none" w="med" len="med"/>
+                    </a:lnB>
+                    <a:solidFill>
+                      <a:srgbClr val="FFFFFF"/>
+                    </a:solidFill>
+                  </a:tcPr>
+                </a:tc>
+                <a:tc>
+                  <a:txBody>
+                    <a:bodyPr/>
+                    <a:lstStyle/>
+                    <a:p>
+                      <a:pPr algn="l" indent="0" marL="0">
+                        <a:buNone/>
+                      </a:pPr>
+                      <a:r>
+                        <a:rPr lang="en-US" sz="1000" dirty="0">
+                          <a:solidFill>
+                            <a:srgbClr val="0B0B0B"/>
+                          </a:solidFill>
+                          <a:latin typeface="Calibri" pitchFamily="34" charset="0"/>
+                          <a:ea typeface="Calibri" pitchFamily="34" charset="-122"/>
+                          <a:cs typeface="Calibri" pitchFamily="34" charset="-120"/>
+                        </a:rPr>
+                        <a:t>New EPC Account Manager (hire)</a:t>
+                      </a:r>
+                      <a:endParaRPr lang="en-US" sz="1000" dirty="0">
+                        <a:latin typeface="Calibri" charset="0"/>
+                        <a:ea typeface="Calibri" charset="0"/>
+                        <a:cs typeface="Calibri" charset="0"/>
+                      </a:endParaRPr>
+                    </a:p>
+                  </a:txBody>
+                  <a:tcPr marL="91440" marR="91440" marT="45720" marB="45720" anchor="ctr">
+                    <a:lnL w="6350" cap="flat" cmpd="sng" algn="ctr">
+                      <a:solidFill>
+                        <a:srgbClr val="E1E0D9"/>
+                      </a:solidFill>
+                      <a:prstDash val="solid"/>
+                      <a:round/>
+                      <a:headEnd type="none" w="med" len="med"/>
+                      <a:tailEnd type="none" w="med" len="med"/>
+                    </a:lnL>
+                    <a:lnR w="6350" cap="flat" cmpd="sng" algn="ctr">
+                      <a:solidFill>
+                        <a:srgbClr val="E1E0D9"/>
+                      </a:solidFill>
+                      <a:prstDash val="solid"/>
+                      <a:round/>
+                      <a:headEnd type="none" w="med" len="med"/>
+                      <a:tailEnd type="none" w="med" len="med"/>
+                    </a:lnR>
+                    <a:lnT w="6350" cap="flat" cmpd="sng" algn="ctr">
+                      <a:solidFill>
+                        <a:srgbClr val="E1E0D9"/>
+                      </a:solidFill>
+                      <a:prstDash val="solid"/>
+                      <a:round/>
+                      <a:headEnd type="none" w="med" len="med"/>
+                      <a:tailEnd type="none" w="med" len="med"/>
+                    </a:lnT>
+                    <a:lnB w="6350" cap="flat" cmpd="sng" algn="ctr">
+                      <a:solidFill>
+                        <a:srgbClr val="E1E0D9"/>
+                      </a:solidFill>
+                      <a:prstDash val="solid"/>
+                      <a:round/>
+                      <a:headEnd type="none" w="med" len="med"/>
+                      <a:tailEnd type="none" w="med" len="med"/>
+                    </a:lnB>
+                    <a:solidFill>
+                      <a:srgbClr val="FFFFFF"/>
+                    </a:solidFill>
+                  </a:tcPr>
+                </a:tc>
+              </a:tr>
+            </a:tbl>
+          </a:graphicData>
+        </a:graphic>
+      </p:graphicFrame>
+      <p:sp>
+        <p:nvSpPr>
+          <p:cNvPr id="5" name="Text 2"/>
+          <p:cNvSpPr/>
+          <p:nvPr/>
+        </p:nvSpPr>
+        <p:spPr>
+          <a:xfrm>
+            <a:off x="8092440" y="1417320"/>
+            <a:ext cx="3520440" cy="320040"/>
+          </a:xfrm>
+          <a:prstGeom prst="rect">
+            <a:avLst/>
+          </a:prstGeom>
+          <a:noFill/>
+          <a:ln/>
+        </p:spPr>
+        <p:txBody>
+          <a:bodyPr wrap="square" lIns="0" tIns="0" rIns="0" bIns="0" rtlCol="0" anchor="ctr"/>
+          <a:lstStyle/>
+          <a:p>
+            <a:pPr indent="0" marL="0">
+              <a:buNone/>
+            </a:pPr>
+            <a:r>
+              <a:rPr lang="en-US" sz="1550" b="1" dirty="0">
+                <a:solidFill>
+                  <a:srgbClr val="0B0B0B"/>
+                </a:solidFill>
+                <a:latin typeface="Calibri" pitchFamily="34" charset="0"/>
+                <a:ea typeface="Calibri" pitchFamily="34" charset="-122"/>
+                <a:cs typeface="Calibri" pitchFamily="34" charset="-120"/>
+              </a:rPr>
+              <a:t>Assign today — $0</a:t>
+            </a:r>
+            <a:endParaRPr lang="en-US" sz="1550" dirty="0"/>
+          </a:p>
+        </p:txBody>
+      </p:sp>
+      <p:sp>
+        <p:nvSpPr>
+          <p:cNvPr id="6" name="Text 3"/>
+          <p:cNvSpPr/>
+          <p:nvPr/>
+        </p:nvSpPr>
+        <p:spPr>
+          <a:xfrm>
+            <a:off x="8092440" y="1755648"/>
+            <a:ext cx="3520440" cy="1143000"/>
+          </a:xfrm>
+          <a:prstGeom prst="rect">
+            <a:avLst/>
+          </a:prstGeom>
+          <a:noFill/>
+          <a:ln/>
+        </p:spPr>
+        <p:txBody>
+          <a:bodyPr wrap="square" lIns="0" tIns="0" rIns="0" bIns="0" rtlCol="0" anchor="ctr"/>
+          <a:lstStyle/>
+          <a:p>
+            <a:pPr indent="0" marL="0">
+              <a:buNone/>
+            </a:pPr>
+            <a:r>
+              <a:rPr lang="en-US" sz="1100" dirty="0">
+                <a:solidFill>
+                  <a:srgbClr val="52514E"/>
+                </a:solidFill>
+                <a:latin typeface="Calibri" pitchFamily="34" charset="0"/>
+                <a:ea typeface="Calibri" pitchFamily="34" charset="-122"/>
+                <a:cs typeface="Calibri" pitchFamily="34" charset="-120"/>
+              </a:rPr>
+              <a:t>Incumbent accounts get named owners from existing leadership. The 590 hours of BD &amp; proposal time already spent YTD becomes a managed funnel instead of volunteer work.</a:t>
+            </a:r>
+            <a:endParaRPr lang="en-US" sz="1100" dirty="0"/>
+          </a:p>
+        </p:txBody>
+      </p:sp>
+      <p:sp>
+        <p:nvSpPr>
+          <p:cNvPr id="7" name="Text 4"/>
+          <p:cNvSpPr/>
+          <p:nvPr/>
+        </p:nvSpPr>
+        <p:spPr>
+          <a:xfrm>
+            <a:off x="8092440" y="2990088"/>
+            <a:ext cx="3520440" cy="320040"/>
+          </a:xfrm>
+          <a:prstGeom prst="rect">
+            <a:avLst/>
+          </a:prstGeom>
+          <a:noFill/>
+          <a:ln/>
+        </p:spPr>
+        <p:txBody>
+          <a:bodyPr wrap="square" lIns="0" tIns="0" rIns="0" bIns="0" rtlCol="0" anchor="ctr"/>
+          <a:lstStyle/>
+          <a:p>
+            <a:pPr indent="0" marL="0">
+              <a:buNone/>
+            </a:pPr>
+            <a:r>
+              <a:rPr lang="en-US" sz="1550" b="1" dirty="0">
+                <a:solidFill>
+                  <a:srgbClr val="2A78D6"/>
+                </a:solidFill>
+                <a:latin typeface="Calibri" pitchFamily="34" charset="0"/>
+                <a:ea typeface="Calibri" pitchFamily="34" charset="-122"/>
+                <a:cs typeface="Calibri" pitchFamily="34" charset="-120"/>
+              </a:rPr>
+              <a:t>Add one EPC Account Manager</a:t>
+            </a:r>
+            <a:endParaRPr lang="en-US" sz="1550" dirty="0"/>
+          </a:p>
+        </p:txBody>
+      </p:sp>
+      <p:sp>
+        <p:nvSpPr>
+          <p:cNvPr id="8" name="Text 5"/>
+          <p:cNvSpPr/>
+          <p:nvPr/>
+        </p:nvSpPr>
+        <p:spPr>
+          <a:xfrm>
+            <a:off x="8092440" y="3328416"/>
+            <a:ext cx="3520440" cy="1143000"/>
+          </a:xfrm>
+          <a:prstGeom prst="rect">
+            <a:avLst/>
+          </a:prstGeom>
+          <a:noFill/>
+          <a:ln/>
+        </p:spPr>
+        <p:txBody>
+          <a:bodyPr wrap="square" lIns="0" tIns="0" rIns="0" bIns="0" rtlCol="0" anchor="ctr"/>
+          <a:lstStyle/>
+          <a:p>
+            <a:pPr indent="0" marL="0">
+              <a:buNone/>
+            </a:pPr>
+            <a:r>
+              <a:rPr lang="en-US" sz="1100" dirty="0">
+                <a:solidFill>
+                  <a:srgbClr val="52514E"/>
+                </a:solidFill>
+                <a:latin typeface="Calibri" pitchFamily="34" charset="0"/>
+                <a:ea typeface="Calibri" pitchFamily="34" charset="-122"/>
+                <a:cs typeface="Calibri" pitchFamily="34" charset="-120"/>
+              </a:rPr>
+              <a:t>Dedicated to the co-op/municipal cluster and the Houston entry. A single EPC win repays the seat — 4–5% engineering pull-through to CVR plus construction margin to HWC.</a:t>
+            </a:r>
+            <a:endParaRPr lang="en-US" sz="1100" dirty="0"/>
+          </a:p>
+        </p:txBody>
+      </p:sp>
+      <p:sp>
+        <p:nvSpPr>
+          <p:cNvPr id="9" name="Text 6"/>
+          <p:cNvSpPr/>
+          <p:nvPr/>
+        </p:nvSpPr>
+        <p:spPr>
+          <a:xfrm>
+            <a:off x="8092440" y="4562856"/>
+            <a:ext cx="3520440" cy="320040"/>
+          </a:xfrm>
+          <a:prstGeom prst="rect">
+            <a:avLst/>
+          </a:prstGeom>
+          <a:noFill/>
+          <a:ln/>
+        </p:spPr>
+        <p:txBody>
+          <a:bodyPr wrap="square" lIns="0" tIns="0" rIns="0" bIns="0" rtlCol="0" anchor="ctr"/>
+          <a:lstStyle/>
+          <a:p>
+            <a:pPr indent="0" marL="0">
+              <a:buNone/>
+            </a:pPr>
+            <a:r>
+              <a:rPr lang="en-US" sz="1550" b="1" dirty="0">
+                <a:solidFill>
+                  <a:srgbClr val="0B0B0B"/>
+                </a:solidFill>
+                <a:latin typeface="Calibri" pitchFamily="34" charset="0"/>
+                <a:ea typeface="Calibri" pitchFamily="34" charset="-122"/>
+                <a:cs typeface="Calibri" pitchFamily="34" charset="-120"/>
+              </a:rPr>
+              <a:t>Run the cadence</a:t>
+            </a:r>
+            <a:endParaRPr lang="en-US" sz="1550" dirty="0"/>
+          </a:p>
+        </p:txBody>
+      </p:sp>
+      <p:sp>
+        <p:nvSpPr>
+          <p:cNvPr id="10" name="Text 7"/>
+          <p:cNvSpPr/>
+          <p:nvPr/>
+        </p:nvSpPr>
+        <p:spPr>
+          <a:xfrm>
+            <a:off x="8092440" y="4901184"/>
+            <a:ext cx="3520440" cy="1143000"/>
+          </a:xfrm>
+          <a:prstGeom prst="rect">
+            <a:avLst/>
+          </a:prstGeom>
+          <a:noFill/>
+          <a:ln/>
+        </p:spPr>
+        <p:txBody>
+          <a:bodyPr wrap="square" lIns="0" tIns="0" rIns="0" bIns="0" rtlCol="0" anchor="ctr"/>
+          <a:lstStyle/>
+          <a:p>
+            <a:pPr indent="0" marL="0">
+              <a:buNone/>
+            </a:pPr>
+            <a:r>
+              <a:rPr lang="en-US" sz="1100" dirty="0">
+                <a:solidFill>
+                  <a:srgbClr val="52514E"/>
+                </a:solidFill>
+                <a:latin typeface="Calibri" pitchFamily="34" charset="0"/>
+                <a:ea typeface="Calibri" pitchFamily="34" charset="-122"/>
+                <a:cs typeface="Calibri" pitchFamily="34" charset="-120"/>
+              </a:rPr>
+              <a:t>Monthly account reviews against the pipeline tab. Owners set win probabilities and award dates; BD hours get tracked per account, per the KPI report.</a:t>
+            </a:r>
+            <a:endParaRPr lang="en-US" sz="1100" dirty="0"/>
+          </a:p>
+        </p:txBody>
+      </p:sp>
+      <p:sp>
+        <p:nvSpPr>
+          <p:cNvPr id="11" name="Text 8"/>
+          <p:cNvSpPr/>
+          <p:nvPr/>
+        </p:nvSpPr>
+        <p:spPr>
+          <a:xfrm>
+            <a:off x="548640" y="6419088"/>
+            <a:ext cx="11064240" cy="320040"/>
+          </a:xfrm>
+          <a:prstGeom prst="rect">
+            <a:avLst/>
+          </a:prstGeom>
+          <a:noFill/>
+          <a:ln/>
+        </p:spPr>
+        <p:txBody>
+          <a:bodyPr wrap="square" lIns="0" tIns="0" rIns="0" bIns="0" rtlCol="0" anchor="ctr"/>
+          <a:lstStyle/>
+          <a:p>
+            <a:pPr indent="0" marL="0">
+              <a:buNone/>
+            </a:pPr>
+            <a:r>
+              <a:rPr lang="en-US" sz="950" dirty="0">
+                <a:solidFill>
+                  <a:srgbClr val="898781"/>
+                </a:solidFill>
+                <a:latin typeface="Calibri" pitchFamily="34" charset="0"/>
+                <a:ea typeface="Calibri" pitchFamily="34" charset="-122"/>
+                <a:cs typeface="Calibri" pitchFamily="34" charset="-120"/>
+              </a:rPr>
+              <a:t>* Proposed from current relationships on the KPI scorecards — to be confirmed with the team. YTD BD hours by account (KPI report): Great Lakes 56 · CenterPoint 35.5 · Consumers 26.5 · DTE 19.5 · NIPSCO 10 · AES 10 — plus 408 proposal hours.</a:t>
+            </a:r>
+            <a:endParaRPr lang="en-US" sz="950" dirty="0"/>
+          </a:p>
+        </p:txBody>
+      </p:sp>
+    </p:spTree>
+  </p:cSld>
+  <p:clrMapOvr>
+    <a:masterClrMapping/>
+  </p:clrMapOvr>
+</p:sld>
+</file>
+
+<file path=ppt/slides/slide15.xml><?xml version="1.0" encoding="utf-8"?>
+<p:sld xmlns:a="http://schemas.openxmlformats.org/drawingml/2006/main" xmlns:r="http://schemas.openxmlformats.org/officeDocument/2006/relationships" xmlns:p="http://schemas.openxmlformats.org/presentationml/2006/main">
+  <p:cSld name="Slide 15">
+    <p:spTree>
+      <p:nvGrpSpPr>
+        <p:cNvPr id="1" name=""/>
+        <p:cNvGrpSpPr/>
+        <p:nvPr/>
+      </p:nvGrpSpPr>
+      <p:grpSpPr>
+        <a:xfrm>
+          <a:off x="0" y="0"/>
+          <a:ext cx="0" cy="0"/>
+          <a:chOff x="0" y="0"/>
+          <a:chExt cx="0" cy="0"/>
+        </a:xfrm>
+      </p:grpSpPr>
+      <p:sp>
+        <p:nvSpPr>
+          <p:cNvPr id="2" name="Text 0"/>
+          <p:cNvSpPr/>
+          <p:nvPr/>
+        </p:nvSpPr>
+        <p:spPr>
+          <a:xfrm>
+            <a:off x="548640" y="292608"/>
+            <a:ext cx="11064240" cy="274320"/>
+          </a:xfrm>
+          <a:prstGeom prst="rect">
+            <a:avLst/>
+          </a:prstGeom>
+          <a:noFill/>
+          <a:ln/>
+        </p:spPr>
+        <p:txBody>
+          <a:bodyPr wrap="square" lIns="0" tIns="0" rIns="0" bIns="0" rtlCol="0" anchor="ctr"/>
+          <a:lstStyle/>
+          <a:p>
+            <a:pPr indent="0" marL="0">
+              <a:buNone/>
+            </a:pPr>
+            <a:r>
+              <a:rPr lang="en-US" sz="1100" b="1" dirty="0">
+                <a:solidFill>
+                  <a:srgbClr val="86B332"/>
+                </a:solidFill>
+                <a:latin typeface="Calibri" pitchFamily="34" charset="0"/>
+                <a:ea typeface="Calibri" pitchFamily="34" charset="-122"/>
+                <a:cs typeface="Calibri" pitchFamily="34" charset="-120"/>
+              </a:rPr>
+              <a:t>— </a:t>
+            </a:r>
+            <a:pPr indent="0" marL="0">
+              <a:buNone/>
+            </a:pPr>
+            <a:r>
+              <a:rPr lang="en-US" sz="1100" b="1" spc="200" kern="0" dirty="0">
+                <a:solidFill>
+                  <a:srgbClr val="52514E"/>
+                </a:solidFill>
+                <a:latin typeface="Calibri" pitchFamily="34" charset="0"/>
+                <a:ea typeface="Calibri" pitchFamily="34" charset="-122"/>
+                <a:cs typeface="Calibri" pitchFamily="34" charset="-120"/>
+              </a:rPr>
               <a:t>FORWARD VIEW — PHASE 2 MODEL, BASE SCENARIO</a:t>
             </a:r>
             <a:endParaRPr lang="en-US" sz="1100" dirty="0"/>
@@ -9803,9 +11961,9 @@
 </p:sld>
 </file>
 
-<file path=ppt/slides/slide15.xml><?xml version="1.0" encoding="utf-8"?>
+<file path=ppt/slides/slide16.xml><?xml version="1.0" encoding="utf-8"?>
 <p:sld xmlns:a="http://schemas.openxmlformats.org/drawingml/2006/main" xmlns:r="http://schemas.openxmlformats.org/officeDocument/2006/relationships" xmlns:p="http://schemas.openxmlformats.org/presentationml/2006/main">
-  <p:cSld name="Slide 15">
+  <p:cSld name="Slide 16">
     <p:spTree>
       <p:nvGrpSpPr>
         <p:cNvPr id="1" name=""/>
@@ -9914,7 +12072,7 @@
       </p:sp>
       <p:graphicFrame>
         <p:nvGraphicFramePr>
-          <p:cNvPr id="16" name="Table 0"/>
+          <p:cNvPr id="17" name="Table 0"/>
           <p:cNvGraphicFramePr>
             <a:graphicFrameLocks noGrp="1"/>
           </p:cNvGraphicFramePr>
@@ -11657,7 +13815,7 @@
       </p:graphicFrame>
       <p:graphicFrame>
         <p:nvGraphicFramePr>
-          <p:cNvPr id="31" name="Table 1"/>
+          <p:cNvPr id="33" name="Table 1"/>
           <p:cNvGraphicFramePr>
             <a:graphicFrameLocks noGrp="1"/>
           </p:cNvGraphicFramePr>
@@ -12512,7 +14670,7 @@
       </p:graphicFrame>
       <p:graphicFrame>
         <p:nvGraphicFramePr>
-          <p:cNvPr id="46" name="Table 2"/>
+          <p:cNvPr id="49" name="Table 2"/>
           <p:cNvGraphicFramePr>
             <a:graphicFrameLocks noGrp="1"/>
           </p:cNvGraphicFramePr>
@@ -14130,9 +16288,9 @@
 </p:sld>
 </file>
 
-<file path=ppt/slides/slide16.xml><?xml version="1.0" encoding="utf-8"?>
+<file path=ppt/slides/slide17.xml><?xml version="1.0" encoding="utf-8"?>
 <p:sld xmlns:a="http://schemas.openxmlformats.org/drawingml/2006/main" xmlns:r="http://schemas.openxmlformats.org/officeDocument/2006/relationships" xmlns:p="http://schemas.openxmlformats.org/presentationml/2006/main">
-  <p:cSld name="Slide 16">
+  <p:cSld name="Slide 17">
     <p:spTree>
       <p:nvGrpSpPr>
         <p:cNvPr id="1" name=""/>
@@ -14544,9 +16702,9 @@
 </p:sld>
 </file>
 
-<file path=ppt/slides/slide17.xml><?xml version="1.0" encoding="utf-8"?>
+<file path=ppt/slides/slide18.xml><?xml version="1.0" encoding="utf-8"?>
 <p:sld xmlns:a="http://schemas.openxmlformats.org/drawingml/2006/main" xmlns:r="http://schemas.openxmlformats.org/officeDocument/2006/relationships" xmlns:p="http://schemas.openxmlformats.org/presentationml/2006/main">
-  <p:cSld name="Slide 17">
+  <p:cSld name="Slide 18">
     <p:bg>
       <p:bgPr>
         <a:solidFill>

</xml_diff>

<commit_message>
BD slide: add overall BD Lead focused outside the current footprint
Highlighted top row of the account-coverage table adds a BD Lead (new
hire) owning expansion beyond MI/IN/IA — Gulf Coast/Texas, MISO/PJM
neighbors, data-center-driven build-out — and coordinating the account
managers. Right rail reframed as two added seats (BD Lead + EPC AM)
with the single-EPC-win payback argument, and the monthly cadence now
chaired by the BD Lead.

Co-Authored-By: Claude Fable 5 <noreply@anthropic.com>
Claude-Session: https://claude.ai/code/session_0145i7FWr3AQEo26DBw1x2c4
</commit_message>
<xml_diff>
--- a/reports/CVR_Deck_Jun2026.pptx
+++ b/reports/CVR_Deck_Jun2026.pptx
@@ -9830,6 +9830,212 @@
                         <a:buNone/>
                       </a:pPr>
                       <a:r>
+                        <a:rPr lang="en-US" sz="1000" b="1" dirty="0">
+                          <a:solidFill>
+                            <a:srgbClr val="0B0B0B"/>
+                          </a:solidFill>
+                          <a:latin typeface="Calibri" pitchFamily="34" charset="0"/>
+                          <a:ea typeface="Calibri" pitchFamily="34" charset="-122"/>
+                          <a:cs typeface="Calibri" pitchFamily="34" charset="-120"/>
+                        </a:rPr>
+                        <a:t>Outside current footprint</a:t>
+                      </a:r>
+                      <a:endParaRPr lang="en-US" sz="1000" dirty="0">
+                        <a:latin typeface="Calibri" charset="0"/>
+                        <a:ea typeface="Calibri" charset="0"/>
+                        <a:cs typeface="Calibri" charset="0"/>
+                      </a:endParaRPr>
+                    </a:p>
+                  </a:txBody>
+                  <a:tcPr marL="91440" marR="91440" marT="45720" marB="45720" anchor="ctr">
+                    <a:lnL w="6350" cap="flat" cmpd="sng" algn="ctr">
+                      <a:solidFill>
+                        <a:srgbClr val="E1E0D9"/>
+                      </a:solidFill>
+                      <a:prstDash val="solid"/>
+                      <a:round/>
+                      <a:headEnd type="none" w="med" len="med"/>
+                      <a:tailEnd type="none" w="med" len="med"/>
+                    </a:lnL>
+                    <a:lnR w="6350" cap="flat" cmpd="sng" algn="ctr">
+                      <a:solidFill>
+                        <a:srgbClr val="E1E0D9"/>
+                      </a:solidFill>
+                      <a:prstDash val="solid"/>
+                      <a:round/>
+                      <a:headEnd type="none" w="med" len="med"/>
+                      <a:tailEnd type="none" w="med" len="med"/>
+                    </a:lnR>
+                    <a:lnT w="6350" cap="flat" cmpd="sng" algn="ctr">
+                      <a:solidFill>
+                        <a:srgbClr val="E1E0D9"/>
+                      </a:solidFill>
+                      <a:prstDash val="solid"/>
+                      <a:round/>
+                      <a:headEnd type="none" w="med" len="med"/>
+                      <a:tailEnd type="none" w="med" len="med"/>
+                    </a:lnT>
+                    <a:lnB w="6350" cap="flat" cmpd="sng" algn="ctr">
+                      <a:solidFill>
+                        <a:srgbClr val="E1E0D9"/>
+                      </a:solidFill>
+                      <a:prstDash val="solid"/>
+                      <a:round/>
+                      <a:headEnd type="none" w="med" len="med"/>
+                      <a:tailEnd type="none" w="med" len="med"/>
+                    </a:lnB>
+                    <a:solidFill>
+                      <a:srgbClr val="EAF1FA"/>
+                    </a:solidFill>
+                  </a:tcPr>
+                </a:tc>
+                <a:tc>
+                  <a:txBody>
+                    <a:bodyPr/>
+                    <a:lstStyle/>
+                    <a:p>
+                      <a:pPr algn="l" indent="0" marL="0">
+                        <a:buNone/>
+                      </a:pPr>
+                      <a:r>
+                        <a:rPr lang="en-US" sz="1000" dirty="0">
+                          <a:solidFill>
+                            <a:srgbClr val="0B0B0B"/>
+                          </a:solidFill>
+                          <a:latin typeface="Calibri" pitchFamily="34" charset="0"/>
+                          <a:ea typeface="Calibri" pitchFamily="34" charset="-122"/>
+                          <a:cs typeface="Calibri" pitchFamily="34" charset="-120"/>
+                        </a:rPr>
+                        <a:t>New utilities &amp; regions beyond MI/IN/IA — Gulf Coast &amp; Texas, MISO/PJM neighbors, data-center-driven grid build-out</a:t>
+                      </a:r>
+                      <a:endParaRPr lang="en-US" sz="1000" dirty="0">
+                        <a:latin typeface="Calibri" charset="0"/>
+                        <a:ea typeface="Calibri" charset="0"/>
+                        <a:cs typeface="Calibri" charset="0"/>
+                      </a:endParaRPr>
+                    </a:p>
+                  </a:txBody>
+                  <a:tcPr marL="91440" marR="91440" marT="45720" marB="45720" anchor="ctr">
+                    <a:lnL w="6350" cap="flat" cmpd="sng" algn="ctr">
+                      <a:solidFill>
+                        <a:srgbClr val="E1E0D9"/>
+                      </a:solidFill>
+                      <a:prstDash val="solid"/>
+                      <a:round/>
+                      <a:headEnd type="none" w="med" len="med"/>
+                      <a:tailEnd type="none" w="med" len="med"/>
+                    </a:lnL>
+                    <a:lnR w="6350" cap="flat" cmpd="sng" algn="ctr">
+                      <a:solidFill>
+                        <a:srgbClr val="E1E0D9"/>
+                      </a:solidFill>
+                      <a:prstDash val="solid"/>
+                      <a:round/>
+                      <a:headEnd type="none" w="med" len="med"/>
+                      <a:tailEnd type="none" w="med" len="med"/>
+                    </a:lnR>
+                    <a:lnT w="6350" cap="flat" cmpd="sng" algn="ctr">
+                      <a:solidFill>
+                        <a:srgbClr val="E1E0D9"/>
+                      </a:solidFill>
+                      <a:prstDash val="solid"/>
+                      <a:round/>
+                      <a:headEnd type="none" w="med" len="med"/>
+                      <a:tailEnd type="none" w="med" len="med"/>
+                    </a:lnT>
+                    <a:lnB w="6350" cap="flat" cmpd="sng" algn="ctr">
+                      <a:solidFill>
+                        <a:srgbClr val="E1E0D9"/>
+                      </a:solidFill>
+                      <a:prstDash val="solid"/>
+                      <a:round/>
+                      <a:headEnd type="none" w="med" len="med"/>
+                      <a:tailEnd type="none" w="med" len="med"/>
+                    </a:lnB>
+                    <a:solidFill>
+                      <a:srgbClr val="EAF1FA"/>
+                    </a:solidFill>
+                  </a:tcPr>
+                </a:tc>
+                <a:tc>
+                  <a:txBody>
+                    <a:bodyPr/>
+                    <a:lstStyle/>
+                    <a:p>
+                      <a:pPr algn="l" indent="0" marL="0">
+                        <a:buNone/>
+                      </a:pPr>
+                      <a:r>
+                        <a:rPr lang="en-US" sz="1000" b="1" dirty="0">
+                          <a:solidFill>
+                            <a:srgbClr val="0B0B0B"/>
+                          </a:solidFill>
+                          <a:latin typeface="Calibri" pitchFamily="34" charset="0"/>
+                          <a:ea typeface="Calibri" pitchFamily="34" charset="-122"/>
+                          <a:cs typeface="Calibri" pitchFamily="34" charset="-120"/>
+                        </a:rPr>
+                        <a:t>BD Lead (new hire) — owns the map, coordinates all account managers</a:t>
+                      </a:r>
+                      <a:endParaRPr lang="en-US" sz="1000" dirty="0">
+                        <a:latin typeface="Calibri" charset="0"/>
+                        <a:ea typeface="Calibri" charset="0"/>
+                        <a:cs typeface="Calibri" charset="0"/>
+                      </a:endParaRPr>
+                    </a:p>
+                  </a:txBody>
+                  <a:tcPr marL="91440" marR="91440" marT="45720" marB="45720" anchor="ctr">
+                    <a:lnL w="6350" cap="flat" cmpd="sng" algn="ctr">
+                      <a:solidFill>
+                        <a:srgbClr val="E1E0D9"/>
+                      </a:solidFill>
+                      <a:prstDash val="solid"/>
+                      <a:round/>
+                      <a:headEnd type="none" w="med" len="med"/>
+                      <a:tailEnd type="none" w="med" len="med"/>
+                    </a:lnL>
+                    <a:lnR w="6350" cap="flat" cmpd="sng" algn="ctr">
+                      <a:solidFill>
+                        <a:srgbClr val="E1E0D9"/>
+                      </a:solidFill>
+                      <a:prstDash val="solid"/>
+                      <a:round/>
+                      <a:headEnd type="none" w="med" len="med"/>
+                      <a:tailEnd type="none" w="med" len="med"/>
+                    </a:lnR>
+                    <a:lnT w="6350" cap="flat" cmpd="sng" algn="ctr">
+                      <a:solidFill>
+                        <a:srgbClr val="E1E0D9"/>
+                      </a:solidFill>
+                      <a:prstDash val="solid"/>
+                      <a:round/>
+                      <a:headEnd type="none" w="med" len="med"/>
+                      <a:tailEnd type="none" w="med" len="med"/>
+                    </a:lnT>
+                    <a:lnB w="6350" cap="flat" cmpd="sng" algn="ctr">
+                      <a:solidFill>
+                        <a:srgbClr val="E1E0D9"/>
+                      </a:solidFill>
+                      <a:prstDash val="solid"/>
+                      <a:round/>
+                      <a:headEnd type="none" w="med" len="med"/>
+                      <a:tailEnd type="none" w="med" len="med"/>
+                    </a:lnB>
+                    <a:solidFill>
+                      <a:srgbClr val="EAF1FA"/>
+                    </a:solidFill>
+                  </a:tcPr>
+                </a:tc>
+              </a:tr>
+              <a:tr h="475488">
+                <a:tc>
+                  <a:txBody>
+                    <a:bodyPr/>
+                    <a:lstStyle/>
+                    <a:p>
+                      <a:pPr algn="l" indent="0" marL="0">
+                        <a:buNone/>
+                      </a:pPr>
+                      <a:r>
                         <a:rPr lang="en-US" sz="1000" dirty="0">
                           <a:solidFill>
                             <a:srgbClr val="0B0B0B"/>
@@ -11274,7 +11480,7 @@
         </p:nvSpPr>
         <p:spPr>
           <a:xfrm>
-            <a:off x="8092440" y="1417320"/>
+            <a:off x="8092440" y="1371600"/>
             <a:ext cx="3520440" cy="320040"/>
           </a:xfrm>
           <a:prstGeom prst="rect">
@@ -11291,7 +11497,7 @@
               <a:buNone/>
             </a:pPr>
             <a:r>
-              <a:rPr lang="en-US" sz="1550" b="1" dirty="0">
+              <a:rPr lang="en-US" sz="1500" b="1" dirty="0">
                 <a:solidFill>
                   <a:srgbClr val="0B0B0B"/>
                 </a:solidFill>
@@ -11301,7 +11507,7 @@
               </a:rPr>
               <a:t>Assign today — $0</a:t>
             </a:r>
-            <a:endParaRPr lang="en-US" sz="1550" dirty="0"/>
+            <a:endParaRPr lang="en-US" sz="1500" dirty="0"/>
           </a:p>
         </p:txBody>
       </p:sp>
@@ -11313,8 +11519,8 @@
         </p:nvSpPr>
         <p:spPr>
           <a:xfrm>
-            <a:off x="8092440" y="1755648"/>
-            <a:ext cx="3520440" cy="1143000"/>
+            <a:off x="8092440" y="1709928"/>
+            <a:ext cx="3520440" cy="1325880"/>
           </a:xfrm>
           <a:prstGeom prst="rect">
             <a:avLst/>
@@ -11330,7 +11536,7 @@
               <a:buNone/>
             </a:pPr>
             <a:r>
-              <a:rPr lang="en-US" sz="1100" dirty="0">
+              <a:rPr lang="en-US" sz="1050" dirty="0">
                 <a:solidFill>
                   <a:srgbClr val="52514E"/>
                 </a:solidFill>
@@ -11340,7 +11546,7 @@
               </a:rPr>
               <a:t>Incumbent accounts get named owners from existing leadership. The 590 hours of BD &amp; proposal time already spent YTD becomes a managed funnel instead of volunteer work.</a:t>
             </a:r>
-            <a:endParaRPr lang="en-US" sz="1100" dirty="0"/>
+            <a:endParaRPr lang="en-US" sz="1050" dirty="0"/>
           </a:p>
         </p:txBody>
       </p:sp>
@@ -11352,7 +11558,7 @@
         </p:nvSpPr>
         <p:spPr>
           <a:xfrm>
-            <a:off x="8092440" y="2990088"/>
+            <a:off x="8092440" y="3063240"/>
             <a:ext cx="3520440" cy="320040"/>
           </a:xfrm>
           <a:prstGeom prst="rect">
@@ -11369,7 +11575,7 @@
               <a:buNone/>
             </a:pPr>
             <a:r>
-              <a:rPr lang="en-US" sz="1550" b="1" dirty="0">
+              <a:rPr lang="en-US" sz="1500" b="1" dirty="0">
                 <a:solidFill>
                   <a:srgbClr val="2A78D6"/>
                 </a:solidFill>
@@ -11377,9 +11583,9 @@
                 <a:ea typeface="Calibri" pitchFamily="34" charset="-122"/>
                 <a:cs typeface="Calibri" pitchFamily="34" charset="-120"/>
               </a:rPr>
-              <a:t>Add one EPC Account Manager</a:t>
+              <a:t>Add two seats — BD Lead + AM</a:t>
             </a:r>
-            <a:endParaRPr lang="en-US" sz="1550" dirty="0"/>
+            <a:endParaRPr lang="en-US" sz="1500" dirty="0"/>
           </a:p>
         </p:txBody>
       </p:sp>
@@ -11391,8 +11597,8 @@
         </p:nvSpPr>
         <p:spPr>
           <a:xfrm>
-            <a:off x="8092440" y="3328416"/>
-            <a:ext cx="3520440" cy="1143000"/>
+            <a:off x="8092440" y="3401568"/>
+            <a:ext cx="3520440" cy="1325880"/>
           </a:xfrm>
           <a:prstGeom prst="rect">
             <a:avLst/>
@@ -11408,7 +11614,7 @@
               <a:buNone/>
             </a:pPr>
             <a:r>
-              <a:rPr lang="en-US" sz="1100" dirty="0">
+              <a:rPr lang="en-US" sz="1050" dirty="0">
                 <a:solidFill>
                   <a:srgbClr val="52514E"/>
                 </a:solidFill>
@@ -11416,9 +11622,9 @@
                 <a:ea typeface="Calibri" pitchFamily="34" charset="-122"/>
                 <a:cs typeface="Calibri" pitchFamily="34" charset="-120"/>
               </a:rPr>
-              <a:t>Dedicated to the co-op/municipal cluster and the Houston entry. A single EPC win repays the seat — 4–5% engineering pull-through to CVR plus construction margin to HWC.</a:t>
+              <a:t>The BD Lead hunts outside the footprint and owns the consolidated-offer story to new logos; the Account Manager works the co-op/municipal cluster and prospects. One EPC win repays both seats — 4–5% engineering pull-through to CVR plus construction margin to HWC.</a:t>
             </a:r>
-            <a:endParaRPr lang="en-US" sz="1100" dirty="0"/>
+            <a:endParaRPr lang="en-US" sz="1050" dirty="0"/>
           </a:p>
         </p:txBody>
       </p:sp>
@@ -11430,7 +11636,7 @@
         </p:nvSpPr>
         <p:spPr>
           <a:xfrm>
-            <a:off x="8092440" y="4562856"/>
+            <a:off x="8092440" y="4754880"/>
             <a:ext cx="3520440" cy="320040"/>
           </a:xfrm>
           <a:prstGeom prst="rect">
@@ -11447,7 +11653,7 @@
               <a:buNone/>
             </a:pPr>
             <a:r>
-              <a:rPr lang="en-US" sz="1550" b="1" dirty="0">
+              <a:rPr lang="en-US" sz="1500" b="1" dirty="0">
                 <a:solidFill>
                   <a:srgbClr val="0B0B0B"/>
                 </a:solidFill>
@@ -11457,7 +11663,7 @@
               </a:rPr>
               <a:t>Run the cadence</a:t>
             </a:r>
-            <a:endParaRPr lang="en-US" sz="1550" dirty="0"/>
+            <a:endParaRPr lang="en-US" sz="1500" dirty="0"/>
           </a:p>
         </p:txBody>
       </p:sp>
@@ -11469,8 +11675,8 @@
         </p:nvSpPr>
         <p:spPr>
           <a:xfrm>
-            <a:off x="8092440" y="4901184"/>
-            <a:ext cx="3520440" cy="1143000"/>
+            <a:off x="8092440" y="5093208"/>
+            <a:ext cx="3520440" cy="1325880"/>
           </a:xfrm>
           <a:prstGeom prst="rect">
             <a:avLst/>
@@ -11486,7 +11692,7 @@
               <a:buNone/>
             </a:pPr>
             <a:r>
-              <a:rPr lang="en-US" sz="1100" dirty="0">
+              <a:rPr lang="en-US" sz="1050" dirty="0">
                 <a:solidFill>
                   <a:srgbClr val="52514E"/>
                 </a:solidFill>
@@ -11494,9 +11700,9 @@
                 <a:ea typeface="Calibri" pitchFamily="34" charset="-122"/>
                 <a:cs typeface="Calibri" pitchFamily="34" charset="-120"/>
               </a:rPr>
-              <a:t>Monthly account reviews against the pipeline tab. Owners set win probabilities and award dates; BD hours get tracked per account, per the KPI report.</a:t>
+              <a:t>Monthly account reviews against the pipeline tab, chaired by the BD Lead. Owners set win probabilities and award dates; BD hours tracked per account.</a:t>
             </a:r>
-            <a:endParaRPr lang="en-US" sz="1100" dirty="0"/>
+            <a:endParaRPr lang="en-US" sz="1050" dirty="0"/>
           </a:p>
         </p:txBody>
       </p:sp>

</xml_diff>

<commit_message>
Add bid-engineering accounting slide with three options
New slide after Cash & Parent Note: 'EPC bid engineering: an item to
clean up, not a crisis.' Left column quantifies the facts (405 unbilled
bid hours ~$62.6K at card vs $30.1K H1 note interest; ~60% design
required to submit a fixed-price EPC bid = $250-380K pre-award exposure
on the $12.6M slate; non-billable bid hours drag CVR's own metrics).
Right column presents three options with intercompany bid-support
billing recommended, win/loss allocation second, and interest credit
third. Takeaway band frames the ask as alignment, not subsidy. Deck is
now 20 slides.

Co-Authored-By: Claude Fable 5 <noreply@anthropic.com>
Claude-Session: https://claude.ai/code/session_0145i7FWr3AQEo26DBw1x2c4
</commit_message>
<xml_diff>
--- a/reports/CVR_Deck_Jun2026.pptx
+++ b/reports/CVR_Deck_Jun2026.pptx
@@ -24,9 +24,10 @@
     <p:sldId id="272" r:id="rId18"/>
     <p:sldId id="273" r:id="rId19"/>
     <p:sldId id="274" r:id="rId20"/>
+    <p:sldId id="275" r:id="rId21"/>
   </p:sldIdLst>
   <p:notesMasterIdLst>
-    <p:notesMasterId r:id="rId21"/>
+    <p:notesMasterId r:id="rId22"/>
   </p:notesMasterIdLst>
   <p:sldSz cx="12192000" cy="6858000"/>
   <p:notesSz cx="6858000" cy="12192000"/>
@@ -1512,6 +1513,94 @@
             <a:fld id="{F7021451-1387-4CA6-816F-3879F97B5CBC}" type="slidenum">
               <a:rPr lang="en-US"/>
               <a:t>2</a:t>
+            </a:fld>
+            <a:endParaRPr lang="en-US"/>
+          </a:p>
+        </p:txBody>
+      </p:sp>
+    </p:spTree>
+    <p:extLst>
+      <p:ext uri="{BB962C8B-B14F-4D97-AF65-F5344CB8AC3E}">
+        <p14:creationId xmlns:p14="http://schemas.microsoft.com/office/powerpoint/2010/main" val="1024086991"/>
+      </p:ext>
+    </p:extLst>
+  </p:cSld>
+  <p:clrMapOvr>
+    <a:masterClrMapping/>
+  </p:clrMapOvr>
+</p:notes>
+</file>
+
+<file path=ppt/notesSlides/notesSlide20.xml><?xml version="1.0" encoding="utf-8"?>
+<p:notes xmlns:a="http://schemas.openxmlformats.org/drawingml/2006/main" xmlns:r="http://schemas.openxmlformats.org/officeDocument/2006/relationships" xmlns:p="http://schemas.openxmlformats.org/presentationml/2006/main">
+  <p:cSld>
+    <p:spTree>
+      <p:nvGrpSpPr>
+        <p:cNvPr id="1" name=""/>
+        <p:cNvGrpSpPr/>
+        <p:nvPr/>
+      </p:nvGrpSpPr>
+      <p:grpSpPr>
+        <a:xfrm>
+          <a:off x="0" y="0"/>
+          <a:ext cx="0" cy="0"/>
+          <a:chOff x="0" y="0"/>
+          <a:chExt cx="0" cy="0"/>
+        </a:xfrm>
+      </p:grpSpPr>
+      <p:sp>
+        <p:nvSpPr>
+          <p:cNvPr id="2" name="Slide Image Placeholder 1"/>
+          <p:cNvSpPr>
+            <a:spLocks noGrp="1" noRot="1" noChangeAspect="1"/>
+          </p:cNvSpPr>
+          <p:nvPr>
+            <p:ph type="sldImg"/>
+          </p:nvPr>
+        </p:nvSpPr>
+        <p:spPr/>
+      </p:sp>
+      <p:sp>
+        <p:nvSpPr>
+          <p:cNvPr id="3" name="Notes Placeholder 2"/>
+          <p:cNvSpPr>
+            <a:spLocks noGrp="1"/>
+          </p:cNvSpPr>
+          <p:nvPr>
+            <p:ph type="body" idx="1"/>
+          </p:nvPr>
+        </p:nvSpPr>
+        <p:spPr/>
+        <p:txBody>
+          <a:bodyPr/>
+          <a:lstStyle/>
+          <a:p>
+            <a:r>
+              <a:rPr lang="en-US" dirty="0"/>
+              <a:t/>
+            </a:r>
+            <a:endParaRPr lang="en-US" dirty="0"/>
+          </a:p>
+        </p:txBody>
+      </p:sp>
+      <p:sp>
+        <p:nvSpPr>
+          <p:cNvPr id="4" name="Slide Number Placeholder 3"/>
+          <p:cNvSpPr>
+            <a:spLocks noGrp="1"/>
+          </p:cNvSpPr>
+          <p:nvPr>
+            <p:ph type="sldNum" sz="quarter" idx="10"/>
+          </p:nvPr>
+        </p:nvSpPr>
+        <p:spPr/>
+        <p:txBody>
+          <a:bodyPr/>
+          <a:lstStyle/>
+          <a:p>
+            <a:fld id="{F7021451-1387-4CA6-816F-3879F97B5CBC}" type="slidenum">
+              <a:rPr lang="en-US"/>
+              <a:t>20</a:t>
             </a:fld>
             <a:endParaRPr lang="en-US"/>
           </a:p>
@@ -21890,6 +21979,2083 @@
 <file path=ppt/slides/slide19.xml><?xml version="1.0" encoding="utf-8"?>
 <p:sld xmlns:a="http://schemas.openxmlformats.org/drawingml/2006/main" xmlns:r="http://schemas.openxmlformats.org/officeDocument/2006/relationships" xmlns:p="http://schemas.openxmlformats.org/presentationml/2006/main">
   <p:cSld name="Slide 19">
+    <p:spTree>
+      <p:nvGrpSpPr>
+        <p:cNvPr id="1" name=""/>
+        <p:cNvGrpSpPr/>
+        <p:nvPr/>
+      </p:nvGrpSpPr>
+      <p:grpSpPr>
+        <a:xfrm>
+          <a:off x="0" y="0"/>
+          <a:ext cx="0" cy="0"/>
+          <a:chOff x="0" y="0"/>
+          <a:chExt cx="0" cy="0"/>
+        </a:xfrm>
+      </p:grpSpPr>
+      <p:sp>
+        <p:nvSpPr>
+          <p:cNvPr id="2" name="Text 0"/>
+          <p:cNvSpPr/>
+          <p:nvPr/>
+        </p:nvSpPr>
+        <p:spPr>
+          <a:xfrm>
+            <a:off x="548640" y="292608"/>
+            <a:ext cx="11064240" cy="274320"/>
+          </a:xfrm>
+          <a:prstGeom prst="rect">
+            <a:avLst/>
+          </a:prstGeom>
+          <a:noFill/>
+          <a:ln/>
+        </p:spPr>
+        <p:txBody>
+          <a:bodyPr wrap="square" lIns="0" tIns="0" rIns="0" bIns="0" rtlCol="0" anchor="ctr"/>
+          <a:lstStyle/>
+          <a:p>
+            <a:pPr indent="0" marL="0">
+              <a:buNone/>
+            </a:pPr>
+            <a:r>
+              <a:rPr lang="en-US" sz="1100" b="1" dirty="0">
+                <a:solidFill>
+                  <a:srgbClr val="86B332"/>
+                </a:solidFill>
+                <a:latin typeface="Calibri" pitchFamily="34" charset="0"/>
+                <a:ea typeface="Calibri" pitchFamily="34" charset="-122"/>
+                <a:cs typeface="Calibri" pitchFamily="34" charset="-120"/>
+              </a:rPr>
+              <a:t>— </a:t>
+            </a:r>
+            <a:pPr indent="0" marL="0">
+              <a:buNone/>
+            </a:pPr>
+            <a:r>
+              <a:rPr lang="en-US" sz="1100" b="1" spc="200" kern="0" dirty="0">
+                <a:solidFill>
+                  <a:srgbClr val="52514E"/>
+                </a:solidFill>
+                <a:latin typeface="Calibri" pitchFamily="34" charset="0"/>
+                <a:ea typeface="Calibri" pitchFamily="34" charset="-122"/>
+                <a:cs typeface="Calibri" pitchFamily="34" charset="-120"/>
+              </a:rPr>
+              <a:t>FORWARD VIEW — ACCOUNTING ALIGNMENT</a:t>
+            </a:r>
+            <a:endParaRPr lang="en-US" sz="1100" dirty="0"/>
+          </a:p>
+        </p:txBody>
+      </p:sp>
+      <p:sp>
+        <p:nvSpPr>
+          <p:cNvPr id="3" name="Text 1"/>
+          <p:cNvSpPr/>
+          <p:nvPr/>
+        </p:nvSpPr>
+        <p:spPr>
+          <a:xfrm>
+            <a:off x="548640" y="548640"/>
+            <a:ext cx="11064240" cy="502920"/>
+          </a:xfrm>
+          <a:prstGeom prst="rect">
+            <a:avLst/>
+          </a:prstGeom>
+          <a:noFill/>
+          <a:ln/>
+        </p:spPr>
+        <p:txBody>
+          <a:bodyPr wrap="square" lIns="0" tIns="0" rIns="0" bIns="0" rtlCol="0" anchor="ctr"/>
+          <a:lstStyle/>
+          <a:p>
+            <a:pPr indent="0" marL="0">
+              <a:buNone/>
+            </a:pPr>
+            <a:r>
+              <a:rPr lang="en-US" sz="2700" b="1" dirty="0">
+                <a:solidFill>
+                  <a:srgbClr val="0B0B0B"/>
+                </a:solidFill>
+                <a:latin typeface="Calibri" pitchFamily="34" charset="0"/>
+                <a:ea typeface="Calibri" pitchFamily="34" charset="-122"/>
+                <a:cs typeface="Calibri" pitchFamily="34" charset="-120"/>
+              </a:rPr>
+              <a:t>EPC bid engineering: an item to clean up, not a crisis</a:t>
+            </a:r>
+            <a:endParaRPr lang="en-US" sz="2700" dirty="0"/>
+          </a:p>
+        </p:txBody>
+      </p:sp>
+      <p:sp>
+        <p:nvSpPr>
+          <p:cNvPr id="4" name="Text 2"/>
+          <p:cNvSpPr/>
+          <p:nvPr/>
+        </p:nvSpPr>
+        <p:spPr>
+          <a:xfrm>
+            <a:off x="548640" y="1371600"/>
+            <a:ext cx="4572000" cy="320040"/>
+          </a:xfrm>
+          <a:prstGeom prst="rect">
+            <a:avLst/>
+          </a:prstGeom>
+          <a:noFill/>
+          <a:ln/>
+        </p:spPr>
+        <p:txBody>
+          <a:bodyPr wrap="square" lIns="0" tIns="0" rIns="0" bIns="0" rtlCol="0" anchor="ctr"/>
+          <a:lstStyle/>
+          <a:p>
+            <a:pPr indent="0" marL="0">
+              <a:buNone/>
+            </a:pPr>
+            <a:r>
+              <a:rPr lang="en-US" sz="1600" b="1" dirty="0">
+                <a:solidFill>
+                  <a:srgbClr val="0B0B0B"/>
+                </a:solidFill>
+                <a:latin typeface="Calibri" pitchFamily="34" charset="0"/>
+                <a:ea typeface="Calibri" pitchFamily="34" charset="-122"/>
+                <a:cs typeface="Calibri" pitchFamily="34" charset="-120"/>
+              </a:rPr>
+              <a:t>The facts</a:t>
+            </a:r>
+            <a:endParaRPr lang="en-US" sz="1600" dirty="0"/>
+          </a:p>
+        </p:txBody>
+      </p:sp>
+      <p:sp>
+        <p:nvSpPr>
+          <p:cNvPr id="5" name="Text 3"/>
+          <p:cNvSpPr/>
+          <p:nvPr/>
+        </p:nvSpPr>
+        <p:spPr>
+          <a:xfrm>
+            <a:off x="548640" y="1783080"/>
+            <a:ext cx="4572000" cy="329184"/>
+          </a:xfrm>
+          <a:prstGeom prst="rect">
+            <a:avLst/>
+          </a:prstGeom>
+          <a:noFill/>
+          <a:ln/>
+        </p:spPr>
+        <p:txBody>
+          <a:bodyPr wrap="square" lIns="0" tIns="0" rIns="0" bIns="0" rtlCol="0" anchor="ctr"/>
+          <a:lstStyle/>
+          <a:p>
+            <a:pPr indent="0" marL="0">
+              <a:buNone/>
+            </a:pPr>
+            <a:r>
+              <a:rPr lang="en-US" sz="1700" b="1" dirty="0">
+                <a:solidFill>
+                  <a:srgbClr val="2A78D6"/>
+                </a:solidFill>
+                <a:latin typeface="Calibri" pitchFamily="34" charset="0"/>
+                <a:ea typeface="Calibri" pitchFamily="34" charset="-122"/>
+                <a:cs typeface="Calibri" pitchFamily="34" charset="-120"/>
+              </a:rPr>
+              <a:t>405 hrs</a:t>
+            </a:r>
+            <a:endParaRPr lang="en-US" sz="1700" dirty="0"/>
+          </a:p>
+        </p:txBody>
+      </p:sp>
+      <p:sp>
+        <p:nvSpPr>
+          <p:cNvPr id="6" name="Text 4"/>
+          <p:cNvSpPr/>
+          <p:nvPr/>
+        </p:nvSpPr>
+        <p:spPr>
+          <a:xfrm>
+            <a:off x="548640" y="2112264"/>
+            <a:ext cx="4572000" cy="658368"/>
+          </a:xfrm>
+          <a:prstGeom prst="rect">
+            <a:avLst/>
+          </a:prstGeom>
+          <a:noFill/>
+          <a:ln/>
+        </p:spPr>
+        <p:txBody>
+          <a:bodyPr wrap="square" lIns="0" tIns="0" rIns="0" bIns="0" rtlCol="0" anchor="ctr"/>
+          <a:lstStyle/>
+          <a:p>
+            <a:pPr indent="0" marL="0">
+              <a:buNone/>
+            </a:pPr>
+            <a:r>
+              <a:rPr lang="en-US" sz="1050" dirty="0">
+                <a:solidFill>
+                  <a:srgbClr val="52514E"/>
+                </a:solidFill>
+                <a:latin typeface="Calibri" pitchFamily="34" charset="0"/>
+                <a:ea typeface="Calibri" pitchFamily="34" charset="-122"/>
+                <a:cs typeface="Calibri" pitchFamily="34" charset="-120"/>
+              </a:rPr>
+              <a:t>of bid engineering YTD — ≈$62.6K at card rates ($38.5K at cost), unbilled</a:t>
+            </a:r>
+            <a:endParaRPr lang="en-US" sz="1050" dirty="0"/>
+          </a:p>
+        </p:txBody>
+      </p:sp>
+      <p:sp>
+        <p:nvSpPr>
+          <p:cNvPr id="7" name="Text 5"/>
+          <p:cNvSpPr/>
+          <p:nvPr/>
+        </p:nvSpPr>
+        <p:spPr>
+          <a:xfrm>
+            <a:off x="548640" y="2807208"/>
+            <a:ext cx="4572000" cy="329184"/>
+          </a:xfrm>
+          <a:prstGeom prst="rect">
+            <a:avLst/>
+          </a:prstGeom>
+          <a:noFill/>
+          <a:ln/>
+        </p:spPr>
+        <p:txBody>
+          <a:bodyPr wrap="square" lIns="0" tIns="0" rIns="0" bIns="0" rtlCol="0" anchor="ctr"/>
+          <a:lstStyle/>
+          <a:p>
+            <a:pPr indent="0" marL="0">
+              <a:buNone/>
+            </a:pPr>
+            <a:r>
+              <a:rPr lang="en-US" sz="1700" b="1" dirty="0">
+                <a:solidFill>
+                  <a:srgbClr val="2A78D6"/>
+                </a:solidFill>
+                <a:latin typeface="Calibri" pitchFamily="34" charset="0"/>
+                <a:ea typeface="Calibri" pitchFamily="34" charset="-122"/>
+                <a:cs typeface="Calibri" pitchFamily="34" charset="-120"/>
+              </a:rPr>
+              <a:t>~60% design</a:t>
+            </a:r>
+            <a:endParaRPr lang="en-US" sz="1700" dirty="0"/>
+          </a:p>
+        </p:txBody>
+      </p:sp>
+      <p:sp>
+        <p:nvSpPr>
+          <p:cNvPr id="8" name="Text 6"/>
+          <p:cNvSpPr/>
+          <p:nvPr/>
+        </p:nvSpPr>
+        <p:spPr>
+          <a:xfrm>
+            <a:off x="548640" y="3136392"/>
+            <a:ext cx="4572000" cy="658368"/>
+          </a:xfrm>
+          <a:prstGeom prst="rect">
+            <a:avLst/>
+          </a:prstGeom>
+          <a:noFill/>
+          <a:ln/>
+        </p:spPr>
+        <p:txBody>
+          <a:bodyPr wrap="square" lIns="0" tIns="0" rIns="0" bIns="0" rtlCol="0" anchor="ctr"/>
+          <a:lstStyle/>
+          <a:p>
+            <a:pPr indent="0" marL="0">
+              <a:buNone/>
+            </a:pPr>
+            <a:r>
+              <a:rPr lang="en-US" sz="1050" dirty="0">
+                <a:solidFill>
+                  <a:srgbClr val="52514E"/>
+                </a:solidFill>
+                <a:latin typeface="Calibri" pitchFamily="34" charset="0"/>
+                <a:ea typeface="Calibri" pitchFamily="34" charset="-122"/>
+                <a:cs typeface="Calibri" pitchFamily="34" charset="-120"/>
+              </a:rPr>
+              <a:t>required before a fixed-price EPC bid can even be submitted — $250–380K of pre-award exposure on the $12.6M bid slate</a:t>
+            </a:r>
+            <a:endParaRPr lang="en-US" sz="1050" dirty="0"/>
+          </a:p>
+        </p:txBody>
+      </p:sp>
+      <p:sp>
+        <p:nvSpPr>
+          <p:cNvPr id="9" name="Text 7"/>
+          <p:cNvSpPr/>
+          <p:nvPr/>
+        </p:nvSpPr>
+        <p:spPr>
+          <a:xfrm>
+            <a:off x="548640" y="3831336"/>
+            <a:ext cx="4572000" cy="329184"/>
+          </a:xfrm>
+          <a:prstGeom prst="rect">
+            <a:avLst/>
+          </a:prstGeom>
+          <a:noFill/>
+          <a:ln/>
+        </p:spPr>
+        <p:txBody>
+          <a:bodyPr wrap="square" lIns="0" tIns="0" rIns="0" bIns="0" rtlCol="0" anchor="ctr"/>
+          <a:lstStyle/>
+          <a:p>
+            <a:pPr indent="0" marL="0">
+              <a:buNone/>
+            </a:pPr>
+            <a:r>
+              <a:rPr lang="en-US" sz="1700" b="1" dirty="0">
+                <a:solidFill>
+                  <a:srgbClr val="2A78D6"/>
+                </a:solidFill>
+                <a:latin typeface="Calibri" pitchFamily="34" charset="0"/>
+                <a:ea typeface="Calibri" pitchFamily="34" charset="-122"/>
+                <a:cs typeface="Calibri" pitchFamily="34" charset="-120"/>
+              </a:rPr>
+              <a:t>$30.1K</a:t>
+            </a:r>
+            <a:endParaRPr lang="en-US" sz="1700" dirty="0"/>
+          </a:p>
+        </p:txBody>
+      </p:sp>
+      <p:sp>
+        <p:nvSpPr>
+          <p:cNvPr id="10" name="Text 8"/>
+          <p:cNvSpPr/>
+          <p:nvPr/>
+        </p:nvSpPr>
+        <p:spPr>
+          <a:xfrm>
+            <a:off x="548640" y="4160520"/>
+            <a:ext cx="4572000" cy="658368"/>
+          </a:xfrm>
+          <a:prstGeom prst="rect">
+            <a:avLst/>
+          </a:prstGeom>
+          <a:noFill/>
+          <a:ln/>
+        </p:spPr>
+        <p:txBody>
+          <a:bodyPr wrap="square" lIns="0" tIns="0" rIns="0" bIns="0" rtlCol="0" anchor="ctr"/>
+          <a:lstStyle/>
+          <a:p>
+            <a:pPr indent="0" marL="0">
+              <a:buNone/>
+            </a:pPr>
+            <a:r>
+              <a:rPr lang="en-US" sz="1050" dirty="0">
+                <a:solidFill>
+                  <a:srgbClr val="52514E"/>
+                </a:solidFill>
+                <a:latin typeface="Calibri" pitchFamily="34" charset="0"/>
+                <a:ea typeface="Calibri" pitchFamily="34" charset="-122"/>
+                <a:cs typeface="Calibri" pitchFamily="34" charset="-120"/>
+              </a:rPr>
+              <a:t>of note interest charged to CVR in H1 — roughly a wash against bid engineering at cost</a:t>
+            </a:r>
+            <a:endParaRPr lang="en-US" sz="1050" dirty="0"/>
+          </a:p>
+        </p:txBody>
+      </p:sp>
+      <p:sp>
+        <p:nvSpPr>
+          <p:cNvPr id="11" name="Text 9"/>
+          <p:cNvSpPr/>
+          <p:nvPr/>
+        </p:nvSpPr>
+        <p:spPr>
+          <a:xfrm>
+            <a:off x="548640" y="4855464"/>
+            <a:ext cx="4572000" cy="329184"/>
+          </a:xfrm>
+          <a:prstGeom prst="rect">
+            <a:avLst/>
+          </a:prstGeom>
+          <a:noFill/>
+          <a:ln/>
+        </p:spPr>
+        <p:txBody>
+          <a:bodyPr wrap="square" lIns="0" tIns="0" rIns="0" bIns="0" rtlCol="0" anchor="ctr"/>
+          <a:lstStyle/>
+          <a:p>
+            <a:pPr indent="0" marL="0">
+              <a:buNone/>
+            </a:pPr>
+            <a:r>
+              <a:rPr lang="en-US" sz="1700" b="1" dirty="0">
+                <a:solidFill>
+                  <a:srgbClr val="E34948"/>
+                </a:solidFill>
+                <a:latin typeface="Calibri" pitchFamily="34" charset="0"/>
+                <a:ea typeface="Calibri" pitchFamily="34" charset="-122"/>
+                <a:cs typeface="Calibri" pitchFamily="34" charset="-120"/>
+              </a:rPr>
+              <a:t>The misalignment</a:t>
+            </a:r>
+            <a:endParaRPr lang="en-US" sz="1700" dirty="0"/>
+          </a:p>
+        </p:txBody>
+      </p:sp>
+      <p:sp>
+        <p:nvSpPr>
+          <p:cNvPr id="12" name="Text 10"/>
+          <p:cNvSpPr/>
+          <p:nvPr/>
+        </p:nvSpPr>
+        <p:spPr>
+          <a:xfrm>
+            <a:off x="548640" y="5184648"/>
+            <a:ext cx="4572000" cy="658368"/>
+          </a:xfrm>
+          <a:prstGeom prst="rect">
+            <a:avLst/>
+          </a:prstGeom>
+          <a:noFill/>
+          <a:ln/>
+        </p:spPr>
+        <p:txBody>
+          <a:bodyPr wrap="square" lIns="0" tIns="0" rIns="0" bIns="0" rtlCol="0" anchor="ctr"/>
+          <a:lstStyle/>
+          <a:p>
+            <a:pPr indent="0" marL="0">
+              <a:buNone/>
+            </a:pPr>
+            <a:r>
+              <a:rPr lang="en-US" sz="1050" dirty="0">
+                <a:solidFill>
+                  <a:srgbClr val="52514E"/>
+                </a:solidFill>
+                <a:latin typeface="Calibri" pitchFamily="34" charset="0"/>
+                <a:ea typeface="Calibri" pitchFamily="34" charset="-122"/>
+                <a:cs typeface="Calibri" pitchFamily="34" charset="-120"/>
+              </a:rPr>
+              <a:t>bid hours are non-billable, so every EPC pursuit CVR supports drags the metrics CVR is judged on — utilization, realization, OILI</a:t>
+            </a:r>
+            <a:endParaRPr lang="en-US" sz="1050" dirty="0"/>
+          </a:p>
+        </p:txBody>
+      </p:sp>
+      <p:sp>
+        <p:nvSpPr>
+          <p:cNvPr id="13" name="Shape 11"/>
+          <p:cNvSpPr/>
+          <p:nvPr/>
+        </p:nvSpPr>
+        <p:spPr>
+          <a:xfrm>
+            <a:off x="5577840" y="1371600"/>
+            <a:ext cx="6035040" cy="1353312"/>
+          </a:xfrm>
+          <a:prstGeom prst="roundRect">
+            <a:avLst>
+              <a:gd name="adj" fmla="val 4054"/>
+            </a:avLst>
+          </a:prstGeom>
+          <a:solidFill>
+            <a:srgbClr val="EAF1FA"/>
+          </a:solidFill>
+          <a:ln w="15875">
+            <a:solidFill>
+              <a:srgbClr val="2A78D6"/>
+            </a:solidFill>
+            <a:prstDash val="solid"/>
+          </a:ln>
+        </p:spPr>
+      </p:sp>
+      <p:sp>
+        <p:nvSpPr>
+          <p:cNvPr id="14" name="Shape 12"/>
+          <p:cNvSpPr/>
+          <p:nvPr/>
+        </p:nvSpPr>
+        <p:spPr>
+          <a:xfrm>
+            <a:off x="5760720" y="1536192"/>
+            <a:ext cx="384048" cy="384048"/>
+          </a:xfrm>
+          <a:prstGeom prst="ellipse">
+            <a:avLst/>
+          </a:prstGeom>
+          <a:solidFill>
+            <a:srgbClr val="2A78D6"/>
+          </a:solidFill>
+          <a:ln/>
+        </p:spPr>
+      </p:sp>
+      <p:sp>
+        <p:nvSpPr>
+          <p:cNvPr id="15" name="Text 13"/>
+          <p:cNvSpPr/>
+          <p:nvPr/>
+        </p:nvSpPr>
+        <p:spPr>
+          <a:xfrm>
+            <a:off x="5760720" y="1536192"/>
+            <a:ext cx="384048" cy="384048"/>
+          </a:xfrm>
+          <a:prstGeom prst="rect">
+            <a:avLst/>
+          </a:prstGeom>
+          <a:noFill/>
+          <a:ln/>
+        </p:spPr>
+        <p:txBody>
+          <a:bodyPr wrap="square" lIns="0" tIns="0" rIns="0" bIns="0" rtlCol="0" anchor="ctr"/>
+          <a:lstStyle/>
+          <a:p>
+            <a:pPr algn="ctr" indent="0" marL="0">
+              <a:buNone/>
+            </a:pPr>
+            <a:r>
+              <a:rPr lang="en-US" sz="1500" b="1" dirty="0">
+                <a:solidFill>
+                  <a:srgbClr val="FFFFFF"/>
+                </a:solidFill>
+                <a:latin typeface="Calibri" pitchFamily="34" charset="0"/>
+                <a:ea typeface="Calibri" pitchFamily="34" charset="-122"/>
+                <a:cs typeface="Calibri" pitchFamily="34" charset="-120"/>
+              </a:rPr>
+              <a:t>1</a:t>
+            </a:r>
+            <a:endParaRPr lang="en-US" sz="1500" dirty="0"/>
+          </a:p>
+        </p:txBody>
+      </p:sp>
+      <p:sp>
+        <p:nvSpPr>
+          <p:cNvPr id="16" name="Text 14"/>
+          <p:cNvSpPr/>
+          <p:nvPr/>
+        </p:nvSpPr>
+        <p:spPr>
+          <a:xfrm>
+            <a:off x="6291072" y="1499616"/>
+            <a:ext cx="5120640" cy="292608"/>
+          </a:xfrm>
+          <a:prstGeom prst="rect">
+            <a:avLst/>
+          </a:prstGeom>
+          <a:noFill/>
+          <a:ln/>
+        </p:spPr>
+        <p:txBody>
+          <a:bodyPr wrap="square" lIns="0" tIns="0" rIns="0" bIns="0" rtlCol="0" anchor="ctr"/>
+          <a:lstStyle/>
+          <a:p>
+            <a:pPr indent="0" marL="0">
+              <a:buNone/>
+            </a:pPr>
+            <a:r>
+              <a:rPr lang="en-US" sz="1400" b="1" dirty="0">
+                <a:solidFill>
+                  <a:srgbClr val="0B0B0B"/>
+                </a:solidFill>
+                <a:latin typeface="Calibri" pitchFamily="34" charset="0"/>
+                <a:ea typeface="Calibri" pitchFamily="34" charset="-122"/>
+                <a:cs typeface="Calibri" pitchFamily="34" charset="-120"/>
+              </a:rPr>
+              <a:t>Intercompany bid-support billing</a:t>
+            </a:r>
+            <a:pPr indent="0" marL="0">
+              <a:buNone/>
+            </a:pPr>
+            <a:r>
+              <a:rPr lang="en-US" sz="950" b="1" spc="150" kern="0" dirty="0">
+                <a:solidFill>
+                  <a:srgbClr val="2A78D6"/>
+                </a:solidFill>
+                <a:latin typeface="Calibri" pitchFamily="34" charset="0"/>
+                <a:ea typeface="Calibri" pitchFamily="34" charset="-122"/>
+                <a:cs typeface="Calibri" pitchFamily="34" charset="-120"/>
+              </a:rPr>
+              <a:t>   RECOMMENDED</a:t>
+            </a:r>
+            <a:endParaRPr lang="en-US" sz="1400" dirty="0"/>
+          </a:p>
+        </p:txBody>
+      </p:sp>
+      <p:sp>
+        <p:nvSpPr>
+          <p:cNvPr id="17" name="Text 15"/>
+          <p:cNvSpPr/>
+          <p:nvPr/>
+        </p:nvSpPr>
+        <p:spPr>
+          <a:xfrm>
+            <a:off x="6291072" y="1828800"/>
+            <a:ext cx="5120640" cy="822960"/>
+          </a:xfrm>
+          <a:prstGeom prst="rect">
+            <a:avLst/>
+          </a:prstGeom>
+          <a:noFill/>
+          <a:ln/>
+        </p:spPr>
+        <p:txBody>
+          <a:bodyPr wrap="square" lIns="0" tIns="0" rIns="0" bIns="0" rtlCol="0" anchor="ctr"/>
+          <a:lstStyle/>
+          <a:p>
+            <a:pPr indent="0" marL="0">
+              <a:buNone/>
+            </a:pPr>
+            <a:r>
+              <a:rPr lang="en-US" sz="1050" dirty="0">
+                <a:solidFill>
+                  <a:srgbClr val="52514E"/>
+                </a:solidFill>
+                <a:latin typeface="Calibri" pitchFamily="34" charset="0"/>
+                <a:ea typeface="Calibri" pitchFamily="34" charset="-122"/>
+                <a:cs typeface="Calibri" pitchFamily="34" charset="-120"/>
+              </a:rPr>
+              <a:t>HWC pays CVR for pre-award engineering on EPC pursuits (cost or card). Hours become billable; cost lands where the benefit lands. Standard EPC practice.</a:t>
+            </a:r>
+            <a:endParaRPr lang="en-US" sz="1050" dirty="0"/>
+          </a:p>
+        </p:txBody>
+      </p:sp>
+      <p:sp>
+        <p:nvSpPr>
+          <p:cNvPr id="18" name="Shape 16"/>
+          <p:cNvSpPr/>
+          <p:nvPr/>
+        </p:nvSpPr>
+        <p:spPr>
+          <a:xfrm>
+            <a:off x="5577840" y="2852928"/>
+            <a:ext cx="6035040" cy="1353312"/>
+          </a:xfrm>
+          <a:prstGeom prst="roundRect">
+            <a:avLst>
+              <a:gd name="adj" fmla="val 4054"/>
+            </a:avLst>
+          </a:prstGeom>
+          <a:solidFill>
+            <a:srgbClr val="F7F7F5"/>
+          </a:solidFill>
+          <a:ln w="9525">
+            <a:solidFill>
+              <a:srgbClr val="E1E0D9"/>
+            </a:solidFill>
+            <a:prstDash val="solid"/>
+          </a:ln>
+        </p:spPr>
+      </p:sp>
+      <p:sp>
+        <p:nvSpPr>
+          <p:cNvPr id="19" name="Shape 17"/>
+          <p:cNvSpPr/>
+          <p:nvPr/>
+        </p:nvSpPr>
+        <p:spPr>
+          <a:xfrm>
+            <a:off x="5760720" y="3017520"/>
+            <a:ext cx="384048" cy="384048"/>
+          </a:xfrm>
+          <a:prstGeom prst="ellipse">
+            <a:avLst/>
+          </a:prstGeom>
+          <a:solidFill>
+            <a:srgbClr val="2A78D6"/>
+          </a:solidFill>
+          <a:ln/>
+        </p:spPr>
+      </p:sp>
+      <p:sp>
+        <p:nvSpPr>
+          <p:cNvPr id="20" name="Text 18"/>
+          <p:cNvSpPr/>
+          <p:nvPr/>
+        </p:nvSpPr>
+        <p:spPr>
+          <a:xfrm>
+            <a:off x="5760720" y="3017520"/>
+            <a:ext cx="384048" cy="384048"/>
+          </a:xfrm>
+          <a:prstGeom prst="rect">
+            <a:avLst/>
+          </a:prstGeom>
+          <a:noFill/>
+          <a:ln/>
+        </p:spPr>
+        <p:txBody>
+          <a:bodyPr wrap="square" lIns="0" tIns="0" rIns="0" bIns="0" rtlCol="0" anchor="ctr"/>
+          <a:lstStyle/>
+          <a:p>
+            <a:pPr algn="ctr" indent="0" marL="0">
+              <a:buNone/>
+            </a:pPr>
+            <a:r>
+              <a:rPr lang="en-US" sz="1500" b="1" dirty="0">
+                <a:solidFill>
+                  <a:srgbClr val="FFFFFF"/>
+                </a:solidFill>
+                <a:latin typeface="Calibri" pitchFamily="34" charset="0"/>
+                <a:ea typeface="Calibri" pitchFamily="34" charset="-122"/>
+                <a:cs typeface="Calibri" pitchFamily="34" charset="-120"/>
+              </a:rPr>
+              <a:t>2</a:t>
+            </a:r>
+            <a:endParaRPr lang="en-US" sz="1500" dirty="0"/>
+          </a:p>
+        </p:txBody>
+      </p:sp>
+      <p:sp>
+        <p:nvSpPr>
+          <p:cNvPr id="21" name="Text 19"/>
+          <p:cNvSpPr/>
+          <p:nvPr/>
+        </p:nvSpPr>
+        <p:spPr>
+          <a:xfrm>
+            <a:off x="6291072" y="2980944"/>
+            <a:ext cx="5120640" cy="292608"/>
+          </a:xfrm>
+          <a:prstGeom prst="rect">
+            <a:avLst/>
+          </a:prstGeom>
+          <a:noFill/>
+          <a:ln/>
+        </p:spPr>
+        <p:txBody>
+          <a:bodyPr wrap="square" lIns="0" tIns="0" rIns="0" bIns="0" rtlCol="0" anchor="ctr"/>
+          <a:lstStyle/>
+          <a:p>
+            <a:pPr indent="0" marL="0">
+              <a:buNone/>
+            </a:pPr>
+            <a:r>
+              <a:rPr lang="en-US" sz="1400" b="1" dirty="0">
+                <a:solidFill>
+                  <a:srgbClr val="0B0B0B"/>
+                </a:solidFill>
+                <a:latin typeface="Calibri" pitchFamily="34" charset="0"/>
+                <a:ea typeface="Calibri" pitchFamily="34" charset="-122"/>
+                <a:cs typeface="Calibri" pitchFamily="34" charset="-120"/>
+              </a:rPr>
+              <a:t>Win / loss allocation</a:t>
+            </a:r>
+            <a:pPr indent="0" marL="0">
+              <a:buNone/>
+            </a:pPr>
+            <a:endParaRPr lang="en-US" sz="1400" dirty="0"/>
+          </a:p>
+        </p:txBody>
+      </p:sp>
+      <p:sp>
+        <p:nvSpPr>
+          <p:cNvPr id="22" name="Text 20"/>
+          <p:cNvSpPr/>
+          <p:nvPr/>
+        </p:nvSpPr>
+        <p:spPr>
+          <a:xfrm>
+            <a:off x="6291072" y="3310128"/>
+            <a:ext cx="5120640" cy="822960"/>
+          </a:xfrm>
+          <a:prstGeom prst="rect">
+            <a:avLst/>
+          </a:prstGeom>
+          <a:noFill/>
+          <a:ln/>
+        </p:spPr>
+        <p:txBody>
+          <a:bodyPr wrap="square" lIns="0" tIns="0" rIns="0" bIns="0" rtlCol="0" anchor="ctr"/>
+          <a:lstStyle/>
+          <a:p>
+            <a:pPr indent="0" marL="0">
+              <a:buNone/>
+            </a:pPr>
+            <a:r>
+              <a:rPr lang="en-US" sz="1050" dirty="0">
+                <a:solidFill>
+                  <a:srgbClr val="52514E"/>
+                </a:solidFill>
+                <a:latin typeface="Calibri" pitchFamily="34" charset="0"/>
+                <a:ea typeface="Calibri" pitchFamily="34" charset="-122"/>
+                <a:cs typeface="Calibri" pitchFamily="34" charset="-120"/>
+              </a:rPr>
+              <a:t>Bid engineering capitalizes to the pursuit — charged to the job on a win, absorbed by HWC as a BD expense on a loss.</a:t>
+            </a:r>
+            <a:endParaRPr lang="en-US" sz="1050" dirty="0"/>
+          </a:p>
+        </p:txBody>
+      </p:sp>
+      <p:sp>
+        <p:nvSpPr>
+          <p:cNvPr id="23" name="Shape 21"/>
+          <p:cNvSpPr/>
+          <p:nvPr/>
+        </p:nvSpPr>
+        <p:spPr>
+          <a:xfrm>
+            <a:off x="5577840" y="4334256"/>
+            <a:ext cx="6035040" cy="1353312"/>
+          </a:xfrm>
+          <a:prstGeom prst="roundRect">
+            <a:avLst>
+              <a:gd name="adj" fmla="val 4054"/>
+            </a:avLst>
+          </a:prstGeom>
+          <a:solidFill>
+            <a:srgbClr val="F7F7F5"/>
+          </a:solidFill>
+          <a:ln w="9525">
+            <a:solidFill>
+              <a:srgbClr val="E1E0D9"/>
+            </a:solidFill>
+            <a:prstDash val="solid"/>
+          </a:ln>
+        </p:spPr>
+      </p:sp>
+      <p:sp>
+        <p:nvSpPr>
+          <p:cNvPr id="24" name="Shape 22"/>
+          <p:cNvSpPr/>
+          <p:nvPr/>
+        </p:nvSpPr>
+        <p:spPr>
+          <a:xfrm>
+            <a:off x="5760720" y="4498848"/>
+            <a:ext cx="384048" cy="384048"/>
+          </a:xfrm>
+          <a:prstGeom prst="ellipse">
+            <a:avLst/>
+          </a:prstGeom>
+          <a:solidFill>
+            <a:srgbClr val="2A78D6"/>
+          </a:solidFill>
+          <a:ln/>
+        </p:spPr>
+      </p:sp>
+      <p:sp>
+        <p:nvSpPr>
+          <p:cNvPr id="25" name="Text 23"/>
+          <p:cNvSpPr/>
+          <p:nvPr/>
+        </p:nvSpPr>
+        <p:spPr>
+          <a:xfrm>
+            <a:off x="5760720" y="4498848"/>
+            <a:ext cx="384048" cy="384048"/>
+          </a:xfrm>
+          <a:prstGeom prst="rect">
+            <a:avLst/>
+          </a:prstGeom>
+          <a:noFill/>
+          <a:ln/>
+        </p:spPr>
+        <p:txBody>
+          <a:bodyPr wrap="square" lIns="0" tIns="0" rIns="0" bIns="0" rtlCol="0" anchor="ctr"/>
+          <a:lstStyle/>
+          <a:p>
+            <a:pPr algn="ctr" indent="0" marL="0">
+              <a:buNone/>
+            </a:pPr>
+            <a:r>
+              <a:rPr lang="en-US" sz="1500" b="1" dirty="0">
+                <a:solidFill>
+                  <a:srgbClr val="FFFFFF"/>
+                </a:solidFill>
+                <a:latin typeface="Calibri" pitchFamily="34" charset="0"/>
+                <a:ea typeface="Calibri" pitchFamily="34" charset="-122"/>
+                <a:cs typeface="Calibri" pitchFamily="34" charset="-120"/>
+              </a:rPr>
+              <a:t>3</a:t>
+            </a:r>
+            <a:endParaRPr lang="en-US" sz="1500" dirty="0"/>
+          </a:p>
+        </p:txBody>
+      </p:sp>
+      <p:sp>
+        <p:nvSpPr>
+          <p:cNvPr id="26" name="Text 24"/>
+          <p:cNvSpPr/>
+          <p:nvPr/>
+        </p:nvSpPr>
+        <p:spPr>
+          <a:xfrm>
+            <a:off x="6291072" y="4462272"/>
+            <a:ext cx="5120640" cy="292608"/>
+          </a:xfrm>
+          <a:prstGeom prst="rect">
+            <a:avLst/>
+          </a:prstGeom>
+          <a:noFill/>
+          <a:ln/>
+        </p:spPr>
+        <p:txBody>
+          <a:bodyPr wrap="square" lIns="0" tIns="0" rIns="0" bIns="0" rtlCol="0" anchor="ctr"/>
+          <a:lstStyle/>
+          <a:p>
+            <a:pPr indent="0" marL="0">
+              <a:buNone/>
+            </a:pPr>
+            <a:r>
+              <a:rPr lang="en-US" sz="1400" b="1" dirty="0">
+                <a:solidFill>
+                  <a:srgbClr val="0B0B0B"/>
+                </a:solidFill>
+                <a:latin typeface="Calibri" pitchFamily="34" charset="0"/>
+                <a:ea typeface="Calibri" pitchFamily="34" charset="-122"/>
+                <a:cs typeface="Calibri" pitchFamily="34" charset="-120"/>
+              </a:rPr>
+              <a:t>Interest credit against bid hours</a:t>
+            </a:r>
+            <a:pPr indent="0" marL="0">
+              <a:buNone/>
+            </a:pPr>
+            <a:endParaRPr lang="en-US" sz="1400" dirty="0"/>
+          </a:p>
+        </p:txBody>
+      </p:sp>
+      <p:sp>
+        <p:nvSpPr>
+          <p:cNvPr id="27" name="Text 25"/>
+          <p:cNvSpPr/>
+          <p:nvPr/>
+        </p:nvSpPr>
+        <p:spPr>
+          <a:xfrm>
+            <a:off x="6291072" y="4791456"/>
+            <a:ext cx="5120640" cy="822960"/>
+          </a:xfrm>
+          <a:prstGeom prst="rect">
+            <a:avLst/>
+          </a:prstGeom>
+          <a:noFill/>
+          <a:ln/>
+        </p:spPr>
+        <p:txBody>
+          <a:bodyPr wrap="square" lIns="0" tIns="0" rIns="0" bIns="0" rtlCol="0" anchor="ctr"/>
+          <a:lstStyle/>
+          <a:p>
+            <a:pPr indent="0" marL="0">
+              <a:buNone/>
+            </a:pPr>
+            <a:r>
+              <a:rPr lang="en-US" sz="1050" dirty="0">
+                <a:solidFill>
+                  <a:srgbClr val="52514E"/>
+                </a:solidFill>
+                <a:latin typeface="Calibri" pitchFamily="34" charset="0"/>
+                <a:ea typeface="Calibri" pitchFamily="34" charset="-122"/>
+                <a:cs typeface="Calibri" pitchFamily="34" charset="-120"/>
+              </a:rPr>
+              <a:t>Parent credits note interest against documented bid-support hours. Fixes the cash, but leaves the hours non-billable — the metrics stay misaligned.</a:t>
+            </a:r>
+            <a:endParaRPr lang="en-US" sz="1050" dirty="0"/>
+          </a:p>
+        </p:txBody>
+      </p:sp>
+      <p:sp>
+        <p:nvSpPr>
+          <p:cNvPr id="28" name="Shape 26"/>
+          <p:cNvSpPr/>
+          <p:nvPr/>
+        </p:nvSpPr>
+        <p:spPr>
+          <a:xfrm>
+            <a:off x="548640" y="5897880"/>
+            <a:ext cx="11064240" cy="457200"/>
+          </a:xfrm>
+          <a:prstGeom prst="roundRect">
+            <a:avLst>
+              <a:gd name="adj" fmla="val 10000"/>
+            </a:avLst>
+          </a:prstGeom>
+          <a:solidFill>
+            <a:srgbClr val="EAF1FA"/>
+          </a:solidFill>
+          <a:ln w="9525">
+            <a:solidFill>
+              <a:srgbClr val="E1E0D9"/>
+            </a:solidFill>
+            <a:prstDash val="solid"/>
+          </a:ln>
+        </p:spPr>
+      </p:sp>
+      <p:sp>
+        <p:nvSpPr>
+          <p:cNvPr id="29" name="Text 27"/>
+          <p:cNvSpPr/>
+          <p:nvPr/>
+        </p:nvSpPr>
+        <p:spPr>
+          <a:xfrm>
+            <a:off x="731520" y="5952744"/>
+            <a:ext cx="10698480" cy="347472"/>
+          </a:xfrm>
+          <a:prstGeom prst="rect">
+            <a:avLst/>
+          </a:prstGeom>
+          <a:noFill/>
+          <a:ln/>
+        </p:spPr>
+        <p:txBody>
+          <a:bodyPr wrap="square" lIns="0" tIns="0" rIns="0" bIns="0" rtlCol="0" anchor="ctr"/>
+          <a:lstStyle/>
+          <a:p>
+            <a:pPr indent="0" marL="0">
+              <a:buNone/>
+            </a:pPr>
+            <a:r>
+              <a:rPr lang="en-US" sz="1200" b="1" dirty="0">
+                <a:solidFill>
+                  <a:srgbClr val="0B0B0B"/>
+                </a:solidFill>
+                <a:latin typeface="Calibri" pitchFamily="34" charset="0"/>
+                <a:ea typeface="Calibri" pitchFamily="34" charset="-122"/>
+                <a:cs typeface="Calibri" pitchFamily="34" charset="-120"/>
+              </a:rPr>
+              <a:t>The ask is alignment, not subsidy.  </a:t>
+            </a:r>
+            <a:pPr indent="0" marL="0">
+              <a:buNone/>
+            </a:pPr>
+            <a:r>
+              <a:rPr lang="en-US" sz="1200" dirty="0">
+                <a:solidFill>
+                  <a:srgbClr val="52514E"/>
+                </a:solidFill>
+                <a:latin typeface="Calibri" pitchFamily="34" charset="0"/>
+                <a:ea typeface="Calibri" pitchFamily="34" charset="-122"/>
+                <a:cs typeface="Calibri" pitchFamily="34" charset="-120"/>
+              </a:rPr>
+              <a:t>Dollars are roughly a wash today — but as EPC volume scales, the accounting should reward the pursuit behavior the strategy demands.</a:t>
+            </a:r>
+            <a:endParaRPr lang="en-US" sz="1200" dirty="0"/>
+          </a:p>
+        </p:txBody>
+      </p:sp>
+      <p:sp>
+        <p:nvSpPr>
+          <p:cNvPr id="30" name="Text 28"/>
+          <p:cNvSpPr/>
+          <p:nvPr/>
+        </p:nvSpPr>
+        <p:spPr>
+          <a:xfrm>
+            <a:off x="548640" y="6419088"/>
+            <a:ext cx="11064240" cy="320040"/>
+          </a:xfrm>
+          <a:prstGeom prst="rect">
+            <a:avLst/>
+          </a:prstGeom>
+          <a:noFill/>
+          <a:ln/>
+        </p:spPr>
+        <p:txBody>
+          <a:bodyPr wrap="square" lIns="0" tIns="0" rIns="0" bIns="0" rtlCol="0" anchor="ctr"/>
+          <a:lstStyle/>
+          <a:p>
+            <a:pPr indent="0" marL="0">
+              <a:buNone/>
+            </a:pPr>
+            <a:r>
+              <a:rPr lang="en-US" sz="950" dirty="0">
+                <a:solidFill>
+                  <a:srgbClr val="898781"/>
+                </a:solidFill>
+                <a:latin typeface="Calibri" pitchFamily="34" charset="0"/>
+                <a:ea typeface="Calibri" pitchFamily="34" charset="-122"/>
+                <a:cs typeface="Calibri" pitchFamily="34" charset="-120"/>
+              </a:rPr>
+              <a:t>Bid hours per the KPI report (through 7/11/26); interest per the GL. Raise with the CFO alongside the note-terms discussion.</a:t>
+            </a:r>
+            <a:endParaRPr lang="en-US" sz="950" dirty="0"/>
+          </a:p>
+        </p:txBody>
+      </p:sp>
+    </p:spTree>
+  </p:cSld>
+  <p:clrMapOvr>
+    <a:masterClrMapping/>
+  </p:clrMapOvr>
+</p:sld>
+</file>
+
+<file path=ppt/slides/slide2.xml><?xml version="1.0" encoding="utf-8"?>
+<p:sld xmlns:a="http://schemas.openxmlformats.org/drawingml/2006/main" xmlns:r="http://schemas.openxmlformats.org/officeDocument/2006/relationships" xmlns:p="http://schemas.openxmlformats.org/presentationml/2006/main">
+  <p:cSld name="Slide 2">
+    <p:spTree>
+      <p:nvGrpSpPr>
+        <p:cNvPr id="1" name=""/>
+        <p:cNvGrpSpPr/>
+        <p:nvPr/>
+      </p:nvGrpSpPr>
+      <p:grpSpPr>
+        <a:xfrm>
+          <a:off x="0" y="0"/>
+          <a:ext cx="0" cy="0"/>
+          <a:chOff x="0" y="0"/>
+          <a:chExt cx="0" cy="0"/>
+        </a:xfrm>
+      </p:grpSpPr>
+      <p:sp>
+        <p:nvSpPr>
+          <p:cNvPr id="2" name="Text 0"/>
+          <p:cNvSpPr/>
+          <p:nvPr/>
+        </p:nvSpPr>
+        <p:spPr>
+          <a:xfrm>
+            <a:off x="548640" y="292608"/>
+            <a:ext cx="11064240" cy="274320"/>
+          </a:xfrm>
+          <a:prstGeom prst="rect">
+            <a:avLst/>
+          </a:prstGeom>
+          <a:noFill/>
+          <a:ln/>
+        </p:spPr>
+        <p:txBody>
+          <a:bodyPr wrap="square" lIns="0" tIns="0" rIns="0" bIns="0" rtlCol="0" anchor="ctr"/>
+          <a:lstStyle/>
+          <a:p>
+            <a:pPr indent="0" marL="0">
+              <a:buNone/>
+            </a:pPr>
+            <a:r>
+              <a:rPr lang="en-US" sz="1100" b="1" dirty="0">
+                <a:solidFill>
+                  <a:srgbClr val="86B332"/>
+                </a:solidFill>
+                <a:latin typeface="Calibri" pitchFamily="34" charset="0"/>
+                <a:ea typeface="Calibri" pitchFamily="34" charset="-122"/>
+                <a:cs typeface="Calibri" pitchFamily="34" charset="-120"/>
+              </a:rPr>
+              <a:t>— </a:t>
+            </a:r>
+            <a:pPr indent="0" marL="0">
+              <a:buNone/>
+            </a:pPr>
+            <a:r>
+              <a:rPr lang="en-US" sz="1100" b="1" spc="200" kern="0" dirty="0">
+                <a:solidFill>
+                  <a:srgbClr val="52514E"/>
+                </a:solidFill>
+                <a:latin typeface="Calibri" pitchFamily="34" charset="0"/>
+                <a:ea typeface="Calibri" pitchFamily="34" charset="-122"/>
+                <a:cs typeface="Calibri" pitchFamily="34" charset="-120"/>
+              </a:rPr>
+              <a:t>AGENDA</a:t>
+            </a:r>
+            <a:endParaRPr lang="en-US" sz="1100" dirty="0"/>
+          </a:p>
+        </p:txBody>
+      </p:sp>
+      <p:sp>
+        <p:nvSpPr>
+          <p:cNvPr id="3" name="Text 1"/>
+          <p:cNvSpPr/>
+          <p:nvPr/>
+        </p:nvSpPr>
+        <p:spPr>
+          <a:xfrm>
+            <a:off x="548640" y="548640"/>
+            <a:ext cx="11064240" cy="502920"/>
+          </a:xfrm>
+          <a:prstGeom prst="rect">
+            <a:avLst/>
+          </a:prstGeom>
+          <a:noFill/>
+          <a:ln/>
+        </p:spPr>
+        <p:txBody>
+          <a:bodyPr wrap="square" lIns="0" tIns="0" rIns="0" bIns="0" rtlCol="0" anchor="ctr"/>
+          <a:lstStyle/>
+          <a:p>
+            <a:pPr indent="0" marL="0">
+              <a:buNone/>
+            </a:pPr>
+            <a:r>
+              <a:rPr lang="en-US" sz="2700" b="1" dirty="0">
+                <a:solidFill>
+                  <a:srgbClr val="0B0B0B"/>
+                </a:solidFill>
+                <a:latin typeface="Calibri" pitchFamily="34" charset="0"/>
+                <a:ea typeface="Calibri" pitchFamily="34" charset="-122"/>
+                <a:cs typeface="Calibri" pitchFamily="34" charset="-120"/>
+              </a:rPr>
+              <a:t>What we'll cover</a:t>
+            </a:r>
+            <a:endParaRPr lang="en-US" sz="2700" dirty="0"/>
+          </a:p>
+        </p:txBody>
+      </p:sp>
+      <p:sp>
+        <p:nvSpPr>
+          <p:cNvPr id="4" name="Shape 2"/>
+          <p:cNvSpPr/>
+          <p:nvPr/>
+        </p:nvSpPr>
+        <p:spPr>
+          <a:xfrm>
+            <a:off x="548640" y="1481328"/>
+            <a:ext cx="402336" cy="402336"/>
+          </a:xfrm>
+          <a:prstGeom prst="ellipse">
+            <a:avLst/>
+          </a:prstGeom>
+          <a:solidFill>
+            <a:srgbClr val="2A78D6"/>
+          </a:solidFill>
+          <a:ln/>
+        </p:spPr>
+      </p:sp>
+      <p:sp>
+        <p:nvSpPr>
+          <p:cNvPr id="5" name="Text 3"/>
+          <p:cNvSpPr/>
+          <p:nvPr/>
+        </p:nvSpPr>
+        <p:spPr>
+          <a:xfrm>
+            <a:off x="548640" y="1481328"/>
+            <a:ext cx="402336" cy="402336"/>
+          </a:xfrm>
+          <a:prstGeom prst="rect">
+            <a:avLst/>
+          </a:prstGeom>
+          <a:noFill/>
+          <a:ln/>
+        </p:spPr>
+        <p:txBody>
+          <a:bodyPr wrap="square" lIns="0" tIns="0" rIns="0" bIns="0" rtlCol="0" anchor="ctr"/>
+          <a:lstStyle/>
+          <a:p>
+            <a:pPr algn="ctr" indent="0" marL="0">
+              <a:buNone/>
+            </a:pPr>
+            <a:r>
+              <a:rPr lang="en-US" sz="1500" b="1" dirty="0">
+                <a:solidFill>
+                  <a:srgbClr val="FFFFFF"/>
+                </a:solidFill>
+                <a:latin typeface="Calibri" pitchFamily="34" charset="0"/>
+                <a:ea typeface="Calibri" pitchFamily="34" charset="-122"/>
+                <a:cs typeface="Calibri" pitchFamily="34" charset="-120"/>
+              </a:rPr>
+              <a:t>1</a:t>
+            </a:r>
+            <a:endParaRPr lang="en-US" sz="1500" dirty="0"/>
+          </a:p>
+        </p:txBody>
+      </p:sp>
+      <p:sp>
+        <p:nvSpPr>
+          <p:cNvPr id="6" name="Text 4"/>
+          <p:cNvSpPr/>
+          <p:nvPr/>
+        </p:nvSpPr>
+        <p:spPr>
+          <a:xfrm>
+            <a:off x="1188720" y="1463040"/>
+            <a:ext cx="3383280" cy="411480"/>
+          </a:xfrm>
+          <a:prstGeom prst="rect">
+            <a:avLst/>
+          </a:prstGeom>
+          <a:noFill/>
+          <a:ln/>
+        </p:spPr>
+        <p:txBody>
+          <a:bodyPr wrap="square" lIns="0" tIns="0" rIns="0" bIns="0" rtlCol="0" anchor="ctr"/>
+          <a:lstStyle/>
+          <a:p>
+            <a:pPr indent="0" marL="0">
+              <a:buNone/>
+            </a:pPr>
+            <a:r>
+              <a:rPr lang="en-US" sz="1650" b="1" dirty="0">
+                <a:solidFill>
+                  <a:srgbClr val="0B0B0B"/>
+                </a:solidFill>
+                <a:latin typeface="Calibri" pitchFamily="34" charset="0"/>
+                <a:ea typeface="Calibri" pitchFamily="34" charset="-122"/>
+                <a:cs typeface="Calibri" pitchFamily="34" charset="-120"/>
+              </a:rPr>
+              <a:t>Where we stand</a:t>
+            </a:r>
+            <a:endParaRPr lang="en-US" sz="1650" dirty="0"/>
+          </a:p>
+        </p:txBody>
+      </p:sp>
+      <p:sp>
+        <p:nvSpPr>
+          <p:cNvPr id="7" name="Text 5"/>
+          <p:cNvSpPr/>
+          <p:nvPr/>
+        </p:nvSpPr>
+        <p:spPr>
+          <a:xfrm>
+            <a:off x="4754880" y="1463040"/>
+            <a:ext cx="6858000" cy="411480"/>
+          </a:xfrm>
+          <a:prstGeom prst="rect">
+            <a:avLst/>
+          </a:prstGeom>
+          <a:noFill/>
+          <a:ln/>
+        </p:spPr>
+        <p:txBody>
+          <a:bodyPr wrap="square" lIns="0" tIns="0" rIns="0" bIns="0" rtlCol="0" anchor="ctr"/>
+          <a:lstStyle/>
+          <a:p>
+            <a:pPr indent="0" marL="0">
+              <a:buNone/>
+            </a:pPr>
+            <a:r>
+              <a:rPr lang="en-US" sz="1200" dirty="0">
+                <a:solidFill>
+                  <a:srgbClr val="52514E"/>
+                </a:solidFill>
+                <a:latin typeface="Calibri" pitchFamily="34" charset="0"/>
+                <a:ea typeface="Calibri" pitchFamily="34" charset="-122"/>
+                <a:cs typeface="Calibri" pitchFamily="34" charset="-120"/>
+              </a:rPr>
+              <a:t>Executive summary · revenue vs plan &amp; prior year · gross margin vs budget · the rate ladder</a:t>
+            </a:r>
+            <a:endParaRPr lang="en-US" sz="1200" dirty="0"/>
+          </a:p>
+        </p:txBody>
+      </p:sp>
+      <p:sp>
+        <p:nvSpPr>
+          <p:cNvPr id="8" name="Shape 6"/>
+          <p:cNvSpPr/>
+          <p:nvPr/>
+        </p:nvSpPr>
+        <p:spPr>
+          <a:xfrm>
+            <a:off x="548640" y="2267712"/>
+            <a:ext cx="402336" cy="402336"/>
+          </a:xfrm>
+          <a:prstGeom prst="ellipse">
+            <a:avLst/>
+          </a:prstGeom>
+          <a:solidFill>
+            <a:srgbClr val="2A78D6"/>
+          </a:solidFill>
+          <a:ln/>
+        </p:spPr>
+      </p:sp>
+      <p:sp>
+        <p:nvSpPr>
+          <p:cNvPr id="9" name="Text 7"/>
+          <p:cNvSpPr/>
+          <p:nvPr/>
+        </p:nvSpPr>
+        <p:spPr>
+          <a:xfrm>
+            <a:off x="548640" y="2267712"/>
+            <a:ext cx="402336" cy="402336"/>
+          </a:xfrm>
+          <a:prstGeom prst="rect">
+            <a:avLst/>
+          </a:prstGeom>
+          <a:noFill/>
+          <a:ln/>
+        </p:spPr>
+        <p:txBody>
+          <a:bodyPr wrap="square" lIns="0" tIns="0" rIns="0" bIns="0" rtlCol="0" anchor="ctr"/>
+          <a:lstStyle/>
+          <a:p>
+            <a:pPr algn="ctr" indent="0" marL="0">
+              <a:buNone/>
+            </a:pPr>
+            <a:r>
+              <a:rPr lang="en-US" sz="1500" b="1" dirty="0">
+                <a:solidFill>
+                  <a:srgbClr val="FFFFFF"/>
+                </a:solidFill>
+                <a:latin typeface="Calibri" pitchFamily="34" charset="0"/>
+                <a:ea typeface="Calibri" pitchFamily="34" charset="-122"/>
+                <a:cs typeface="Calibri" pitchFamily="34" charset="-120"/>
+              </a:rPr>
+              <a:t>2</a:t>
+            </a:r>
+            <a:endParaRPr lang="en-US" sz="1500" dirty="0"/>
+          </a:p>
+        </p:txBody>
+      </p:sp>
+      <p:sp>
+        <p:nvSpPr>
+          <p:cNvPr id="10" name="Text 8"/>
+          <p:cNvSpPr/>
+          <p:nvPr/>
+        </p:nvSpPr>
+        <p:spPr>
+          <a:xfrm>
+            <a:off x="1188720" y="2249424"/>
+            <a:ext cx="3383280" cy="411480"/>
+          </a:xfrm>
+          <a:prstGeom prst="rect">
+            <a:avLst/>
+          </a:prstGeom>
+          <a:noFill/>
+          <a:ln/>
+        </p:spPr>
+        <p:txBody>
+          <a:bodyPr wrap="square" lIns="0" tIns="0" rIns="0" bIns="0" rtlCol="0" anchor="ctr"/>
+          <a:lstStyle/>
+          <a:p>
+            <a:pPr indent="0" marL="0">
+              <a:buNone/>
+            </a:pPr>
+            <a:r>
+              <a:rPr lang="en-US" sz="1650" b="1" dirty="0">
+                <a:solidFill>
+                  <a:srgbClr val="0B0B0B"/>
+                </a:solidFill>
+                <a:latin typeface="Calibri" pitchFamily="34" charset="0"/>
+                <a:ea typeface="Calibri" pitchFamily="34" charset="-122"/>
+                <a:cs typeface="Calibri" pitchFamily="34" charset="-120"/>
+              </a:rPr>
+              <a:t>Operating drivers</a:t>
+            </a:r>
+            <a:endParaRPr lang="en-US" sz="1650" dirty="0"/>
+          </a:p>
+        </p:txBody>
+      </p:sp>
+      <p:sp>
+        <p:nvSpPr>
+          <p:cNvPr id="11" name="Text 9"/>
+          <p:cNvSpPr/>
+          <p:nvPr/>
+        </p:nvSpPr>
+        <p:spPr>
+          <a:xfrm>
+            <a:off x="4754880" y="2249424"/>
+            <a:ext cx="6858000" cy="411480"/>
+          </a:xfrm>
+          <a:prstGeom prst="rect">
+            <a:avLst/>
+          </a:prstGeom>
+          <a:noFill/>
+          <a:ln/>
+        </p:spPr>
+        <p:txBody>
+          <a:bodyPr wrap="square" lIns="0" tIns="0" rIns="0" bIns="0" rtlCol="0" anchor="ctr"/>
+          <a:lstStyle/>
+          <a:p>
+            <a:pPr indent="0" marL="0">
+              <a:buNone/>
+            </a:pPr>
+            <a:r>
+              <a:rPr lang="en-US" sz="1200" dirty="0">
+                <a:solidFill>
+                  <a:srgbClr val="52514E"/>
+                </a:solidFill>
+                <a:latin typeface="Calibri" pitchFamily="34" charset="0"/>
+                <a:ea typeface="Calibri" pitchFamily="34" charset="-122"/>
+                <a:cs typeface="Calibri" pitchFamily="34" charset="-120"/>
+              </a:rPr>
+              <a:t>Staff &amp; headcount · utilization by person · sales by customer</a:t>
+            </a:r>
+            <a:endParaRPr lang="en-US" sz="1200" dirty="0"/>
+          </a:p>
+        </p:txBody>
+      </p:sp>
+      <p:sp>
+        <p:nvSpPr>
+          <p:cNvPr id="12" name="Shape 10"/>
+          <p:cNvSpPr/>
+          <p:nvPr/>
+        </p:nvSpPr>
+        <p:spPr>
+          <a:xfrm>
+            <a:off x="548640" y="3054096"/>
+            <a:ext cx="402336" cy="402336"/>
+          </a:xfrm>
+          <a:prstGeom prst="ellipse">
+            <a:avLst/>
+          </a:prstGeom>
+          <a:solidFill>
+            <a:srgbClr val="2A78D6"/>
+          </a:solidFill>
+          <a:ln/>
+        </p:spPr>
+      </p:sp>
+      <p:sp>
+        <p:nvSpPr>
+          <p:cNvPr id="13" name="Text 11"/>
+          <p:cNvSpPr/>
+          <p:nvPr/>
+        </p:nvSpPr>
+        <p:spPr>
+          <a:xfrm>
+            <a:off x="548640" y="3054096"/>
+            <a:ext cx="402336" cy="402336"/>
+          </a:xfrm>
+          <a:prstGeom prst="rect">
+            <a:avLst/>
+          </a:prstGeom>
+          <a:noFill/>
+          <a:ln/>
+        </p:spPr>
+        <p:txBody>
+          <a:bodyPr wrap="square" lIns="0" tIns="0" rIns="0" bIns="0" rtlCol="0" anchor="ctr"/>
+          <a:lstStyle/>
+          <a:p>
+            <a:pPr algn="ctr" indent="0" marL="0">
+              <a:buNone/>
+            </a:pPr>
+            <a:r>
+              <a:rPr lang="en-US" sz="1500" b="1" dirty="0">
+                <a:solidFill>
+                  <a:srgbClr val="FFFFFF"/>
+                </a:solidFill>
+                <a:latin typeface="Calibri" pitchFamily="34" charset="0"/>
+                <a:ea typeface="Calibri" pitchFamily="34" charset="-122"/>
+                <a:cs typeface="Calibri" pitchFamily="34" charset="-120"/>
+              </a:rPr>
+              <a:t>3</a:t>
+            </a:r>
+            <a:endParaRPr lang="en-US" sz="1500" dirty="0"/>
+          </a:p>
+        </p:txBody>
+      </p:sp>
+      <p:sp>
+        <p:nvSpPr>
+          <p:cNvPr id="14" name="Text 12"/>
+          <p:cNvSpPr/>
+          <p:nvPr/>
+        </p:nvSpPr>
+        <p:spPr>
+          <a:xfrm>
+            <a:off x="1188720" y="3035808"/>
+            <a:ext cx="3383280" cy="411480"/>
+          </a:xfrm>
+          <a:prstGeom prst="rect">
+            <a:avLst/>
+          </a:prstGeom>
+          <a:noFill/>
+          <a:ln/>
+        </p:spPr>
+        <p:txBody>
+          <a:bodyPr wrap="square" lIns="0" tIns="0" rIns="0" bIns="0" rtlCol="0" anchor="ctr"/>
+          <a:lstStyle/>
+          <a:p>
+            <a:pPr indent="0" marL="0">
+              <a:buNone/>
+            </a:pPr>
+            <a:r>
+              <a:rPr lang="en-US" sz="1650" b="1" dirty="0">
+                <a:solidFill>
+                  <a:srgbClr val="0B0B0B"/>
+                </a:solidFill>
+                <a:latin typeface="Calibri" pitchFamily="34" charset="0"/>
+                <a:ea typeface="Calibri" pitchFamily="34" charset="-122"/>
+                <a:cs typeface="Calibri" pitchFamily="34" charset="-120"/>
+              </a:rPr>
+              <a:t>Work in hand &amp; work to win</a:t>
+            </a:r>
+            <a:endParaRPr lang="en-US" sz="1650" dirty="0"/>
+          </a:p>
+        </p:txBody>
+      </p:sp>
+      <p:sp>
+        <p:nvSpPr>
+          <p:cNvPr id="15" name="Text 13"/>
+          <p:cNvSpPr/>
+          <p:nvPr/>
+        </p:nvSpPr>
+        <p:spPr>
+          <a:xfrm>
+            <a:off x="4754880" y="3035808"/>
+            <a:ext cx="6858000" cy="411480"/>
+          </a:xfrm>
+          <a:prstGeom prst="rect">
+            <a:avLst/>
+          </a:prstGeom>
+          <a:noFill/>
+          <a:ln/>
+        </p:spPr>
+        <p:txBody>
+          <a:bodyPr wrap="square" lIns="0" tIns="0" rIns="0" bIns="0" rtlCol="0" anchor="ctr"/>
+          <a:lstStyle/>
+          <a:p>
+            <a:pPr indent="0" marL="0">
+              <a:buNone/>
+            </a:pPr>
+            <a:r>
+              <a:rPr lang="en-US" sz="1200" dirty="0">
+                <a:solidFill>
+                  <a:srgbClr val="52514E"/>
+                </a:solidFill>
+                <a:latin typeface="Calibri" pitchFamily="34" charset="0"/>
+                <a:ea typeface="Calibri" pitchFamily="34" charset="-122"/>
+                <a:cs typeface="Calibri" pitchFamily="34" charset="-120"/>
+              </a:rPr>
+              <a:t>Backlog on active jobs · known pipeline opportunities</a:t>
+            </a:r>
+            <a:endParaRPr lang="en-US" sz="1200" dirty="0"/>
+          </a:p>
+        </p:txBody>
+      </p:sp>
+      <p:sp>
+        <p:nvSpPr>
+          <p:cNvPr id="16" name="Shape 14"/>
+          <p:cNvSpPr/>
+          <p:nvPr/>
+        </p:nvSpPr>
+        <p:spPr>
+          <a:xfrm>
+            <a:off x="548640" y="3840480"/>
+            <a:ext cx="402336" cy="402336"/>
+          </a:xfrm>
+          <a:prstGeom prst="ellipse">
+            <a:avLst/>
+          </a:prstGeom>
+          <a:solidFill>
+            <a:srgbClr val="2A78D6"/>
+          </a:solidFill>
+          <a:ln/>
+        </p:spPr>
+      </p:sp>
+      <p:sp>
+        <p:nvSpPr>
+          <p:cNvPr id="17" name="Text 15"/>
+          <p:cNvSpPr/>
+          <p:nvPr/>
+        </p:nvSpPr>
+        <p:spPr>
+          <a:xfrm>
+            <a:off x="548640" y="3840480"/>
+            <a:ext cx="402336" cy="402336"/>
+          </a:xfrm>
+          <a:prstGeom prst="rect">
+            <a:avLst/>
+          </a:prstGeom>
+          <a:noFill/>
+          <a:ln/>
+        </p:spPr>
+        <p:txBody>
+          <a:bodyPr wrap="square" lIns="0" tIns="0" rIns="0" bIns="0" rtlCol="0" anchor="ctr"/>
+          <a:lstStyle/>
+          <a:p>
+            <a:pPr algn="ctr" indent="0" marL="0">
+              <a:buNone/>
+            </a:pPr>
+            <a:r>
+              <a:rPr lang="en-US" sz="1500" b="1" dirty="0">
+                <a:solidFill>
+                  <a:srgbClr val="FFFFFF"/>
+                </a:solidFill>
+                <a:latin typeface="Calibri" pitchFamily="34" charset="0"/>
+                <a:ea typeface="Calibri" pitchFamily="34" charset="-122"/>
+                <a:cs typeface="Calibri" pitchFamily="34" charset="-120"/>
+              </a:rPr>
+              <a:t>4</a:t>
+            </a:r>
+            <a:endParaRPr lang="en-US" sz="1500" dirty="0"/>
+          </a:p>
+        </p:txBody>
+      </p:sp>
+      <p:sp>
+        <p:nvSpPr>
+          <p:cNvPr id="18" name="Text 16"/>
+          <p:cNvSpPr/>
+          <p:nvPr/>
+        </p:nvSpPr>
+        <p:spPr>
+          <a:xfrm>
+            <a:off x="1188720" y="3822192"/>
+            <a:ext cx="3383280" cy="411480"/>
+          </a:xfrm>
+          <a:prstGeom prst="rect">
+            <a:avLst/>
+          </a:prstGeom>
+          <a:noFill/>
+          <a:ln/>
+        </p:spPr>
+        <p:txBody>
+          <a:bodyPr wrap="square" lIns="0" tIns="0" rIns="0" bIns="0" rtlCol="0" anchor="ctr"/>
+          <a:lstStyle/>
+          <a:p>
+            <a:pPr indent="0" marL="0">
+              <a:buNone/>
+            </a:pPr>
+            <a:r>
+              <a:rPr lang="en-US" sz="1650" b="1" dirty="0">
+                <a:solidFill>
+                  <a:srgbClr val="0B0B0B"/>
+                </a:solidFill>
+                <a:latin typeface="Calibri" pitchFamily="34" charset="0"/>
+                <a:ea typeface="Calibri" pitchFamily="34" charset="-122"/>
+                <a:cs typeface="Calibri" pitchFamily="34" charset="-120"/>
+              </a:rPr>
+              <a:t>Strategy</a:t>
+            </a:r>
+            <a:endParaRPr lang="en-US" sz="1650" dirty="0"/>
+          </a:p>
+        </p:txBody>
+      </p:sp>
+      <p:sp>
+        <p:nvSpPr>
+          <p:cNvPr id="19" name="Text 17"/>
+          <p:cNvSpPr/>
+          <p:nvPr/>
+        </p:nvSpPr>
+        <p:spPr>
+          <a:xfrm>
+            <a:off x="4754880" y="3822192"/>
+            <a:ext cx="6858000" cy="411480"/>
+          </a:xfrm>
+          <a:prstGeom prst="rect">
+            <a:avLst/>
+          </a:prstGeom>
+          <a:noFill/>
+          <a:ln/>
+        </p:spPr>
+        <p:txBody>
+          <a:bodyPr wrap="square" lIns="0" tIns="0" rIns="0" bIns="0" rtlCol="0" anchor="ctr"/>
+          <a:lstStyle/>
+          <a:p>
+            <a:pPr indent="0" marL="0">
+              <a:buNone/>
+            </a:pPr>
+            <a:r>
+              <a:rPr lang="en-US" sz="1200" dirty="0">
+                <a:solidFill>
+                  <a:srgbClr val="52514E"/>
+                </a:solidFill>
+                <a:latin typeface="Calibri" pitchFamily="34" charset="0"/>
+                <a:ea typeface="Calibri" pitchFamily="34" charset="-122"/>
+                <a:cs typeface="Calibri" pitchFamily="34" charset="-120"/>
+              </a:rPr>
+              <a:t>One pursuit engine with HWC Estimating · the consolidated EPC offering · the addressable market · BD account ownership</a:t>
+            </a:r>
+            <a:endParaRPr lang="en-US" sz="1200" dirty="0"/>
+          </a:p>
+        </p:txBody>
+      </p:sp>
+      <p:sp>
+        <p:nvSpPr>
+          <p:cNvPr id="20" name="Shape 18"/>
+          <p:cNvSpPr/>
+          <p:nvPr/>
+        </p:nvSpPr>
+        <p:spPr>
+          <a:xfrm>
+            <a:off x="548640" y="4626864"/>
+            <a:ext cx="402336" cy="402336"/>
+          </a:xfrm>
+          <a:prstGeom prst="ellipse">
+            <a:avLst/>
+          </a:prstGeom>
+          <a:solidFill>
+            <a:srgbClr val="2A78D6"/>
+          </a:solidFill>
+          <a:ln/>
+        </p:spPr>
+      </p:sp>
+      <p:sp>
+        <p:nvSpPr>
+          <p:cNvPr id="21" name="Text 19"/>
+          <p:cNvSpPr/>
+          <p:nvPr/>
+        </p:nvSpPr>
+        <p:spPr>
+          <a:xfrm>
+            <a:off x="548640" y="4626864"/>
+            <a:ext cx="402336" cy="402336"/>
+          </a:xfrm>
+          <a:prstGeom prst="rect">
+            <a:avLst/>
+          </a:prstGeom>
+          <a:noFill/>
+          <a:ln/>
+        </p:spPr>
+        <p:txBody>
+          <a:bodyPr wrap="square" lIns="0" tIns="0" rIns="0" bIns="0" rtlCol="0" anchor="ctr"/>
+          <a:lstStyle/>
+          <a:p>
+            <a:pPr algn="ctr" indent="0" marL="0">
+              <a:buNone/>
+            </a:pPr>
+            <a:r>
+              <a:rPr lang="en-US" sz="1500" b="1" dirty="0">
+                <a:solidFill>
+                  <a:srgbClr val="FFFFFF"/>
+                </a:solidFill>
+                <a:latin typeface="Calibri" pitchFamily="34" charset="0"/>
+                <a:ea typeface="Calibri" pitchFamily="34" charset="-122"/>
+                <a:cs typeface="Calibri" pitchFamily="34" charset="-120"/>
+              </a:rPr>
+              <a:t>5</a:t>
+            </a:r>
+            <a:endParaRPr lang="en-US" sz="1500" dirty="0"/>
+          </a:p>
+        </p:txBody>
+      </p:sp>
+      <p:sp>
+        <p:nvSpPr>
+          <p:cNvPr id="22" name="Text 20"/>
+          <p:cNvSpPr/>
+          <p:nvPr/>
+        </p:nvSpPr>
+        <p:spPr>
+          <a:xfrm>
+            <a:off x="1188720" y="4608576"/>
+            <a:ext cx="3383280" cy="411480"/>
+          </a:xfrm>
+          <a:prstGeom prst="rect">
+            <a:avLst/>
+          </a:prstGeom>
+          <a:noFill/>
+          <a:ln/>
+        </p:spPr>
+        <p:txBody>
+          <a:bodyPr wrap="square" lIns="0" tIns="0" rIns="0" bIns="0" rtlCol="0" anchor="ctr"/>
+          <a:lstStyle/>
+          <a:p>
+            <a:pPr indent="0" marL="0">
+              <a:buNone/>
+            </a:pPr>
+            <a:r>
+              <a:rPr lang="en-US" sz="1650" b="1" dirty="0">
+                <a:solidFill>
+                  <a:srgbClr val="0B0B0B"/>
+                </a:solidFill>
+                <a:latin typeface="Calibri" pitchFamily="34" charset="0"/>
+                <a:ea typeface="Calibri" pitchFamily="34" charset="-122"/>
+                <a:cs typeface="Calibri" pitchFamily="34" charset="-120"/>
+              </a:rPr>
+              <a:t>Forward view</a:t>
+            </a:r>
+            <a:endParaRPr lang="en-US" sz="1650" dirty="0"/>
+          </a:p>
+        </p:txBody>
+      </p:sp>
+      <p:sp>
+        <p:nvSpPr>
+          <p:cNvPr id="23" name="Text 21"/>
+          <p:cNvSpPr/>
+          <p:nvPr/>
+        </p:nvSpPr>
+        <p:spPr>
+          <a:xfrm>
+            <a:off x="4754880" y="4608576"/>
+            <a:ext cx="6858000" cy="411480"/>
+          </a:xfrm>
+          <a:prstGeom prst="rect">
+            <a:avLst/>
+          </a:prstGeom>
+          <a:noFill/>
+          <a:ln/>
+        </p:spPr>
+        <p:txBody>
+          <a:bodyPr wrap="square" lIns="0" tIns="0" rIns="0" bIns="0" rtlCol="0" anchor="ctr"/>
+          <a:lstStyle/>
+          <a:p>
+            <a:pPr indent="0" marL="0">
+              <a:buNone/>
+            </a:pPr>
+            <a:r>
+              <a:rPr lang="en-US" sz="1200" dirty="0">
+                <a:solidFill>
+                  <a:srgbClr val="52514E"/>
+                </a:solidFill>
+                <a:latin typeface="Calibri" pitchFamily="34" charset="0"/>
+                <a:ea typeface="Calibri" pitchFamily="34" charset="-122"/>
+                <a:cs typeface="Calibri" pitchFamily="34" charset="-120"/>
+              </a:rPr>
+              <a:t>Forecast &amp; coverage · FY2026 landing and FY2027 scenarios · cash &amp; the parent note</a:t>
+            </a:r>
+            <a:endParaRPr lang="en-US" sz="1200" dirty="0"/>
+          </a:p>
+        </p:txBody>
+      </p:sp>
+      <p:sp>
+        <p:nvSpPr>
+          <p:cNvPr id="24" name="Shape 22"/>
+          <p:cNvSpPr/>
+          <p:nvPr/>
+        </p:nvSpPr>
+        <p:spPr>
+          <a:xfrm>
+            <a:off x="548640" y="5413248"/>
+            <a:ext cx="402336" cy="402336"/>
+          </a:xfrm>
+          <a:prstGeom prst="ellipse">
+            <a:avLst/>
+          </a:prstGeom>
+          <a:solidFill>
+            <a:srgbClr val="2A78D6"/>
+          </a:solidFill>
+          <a:ln/>
+        </p:spPr>
+      </p:sp>
+      <p:sp>
+        <p:nvSpPr>
+          <p:cNvPr id="25" name="Text 23"/>
+          <p:cNvSpPr/>
+          <p:nvPr/>
+        </p:nvSpPr>
+        <p:spPr>
+          <a:xfrm>
+            <a:off x="548640" y="5413248"/>
+            <a:ext cx="402336" cy="402336"/>
+          </a:xfrm>
+          <a:prstGeom prst="rect">
+            <a:avLst/>
+          </a:prstGeom>
+          <a:noFill/>
+          <a:ln/>
+        </p:spPr>
+        <p:txBody>
+          <a:bodyPr wrap="square" lIns="0" tIns="0" rIns="0" bIns="0" rtlCol="0" anchor="ctr"/>
+          <a:lstStyle/>
+          <a:p>
+            <a:pPr algn="ctr" indent="0" marL="0">
+              <a:buNone/>
+            </a:pPr>
+            <a:r>
+              <a:rPr lang="en-US" sz="1500" b="1" dirty="0">
+                <a:solidFill>
+                  <a:srgbClr val="FFFFFF"/>
+                </a:solidFill>
+                <a:latin typeface="Calibri" pitchFamily="34" charset="0"/>
+                <a:ea typeface="Calibri" pitchFamily="34" charset="-122"/>
+                <a:cs typeface="Calibri" pitchFamily="34" charset="-120"/>
+              </a:rPr>
+              <a:t>6</a:t>
+            </a:r>
+            <a:endParaRPr lang="en-US" sz="1500" dirty="0"/>
+          </a:p>
+        </p:txBody>
+      </p:sp>
+      <p:sp>
+        <p:nvSpPr>
+          <p:cNvPr id="26" name="Text 24"/>
+          <p:cNvSpPr/>
+          <p:nvPr/>
+        </p:nvSpPr>
+        <p:spPr>
+          <a:xfrm>
+            <a:off x="1188720" y="5394960"/>
+            <a:ext cx="3383280" cy="411480"/>
+          </a:xfrm>
+          <a:prstGeom prst="rect">
+            <a:avLst/>
+          </a:prstGeom>
+          <a:noFill/>
+          <a:ln/>
+        </p:spPr>
+        <p:txBody>
+          <a:bodyPr wrap="square" lIns="0" tIns="0" rIns="0" bIns="0" rtlCol="0" anchor="ctr"/>
+          <a:lstStyle/>
+          <a:p>
+            <a:pPr indent="0" marL="0">
+              <a:buNone/>
+            </a:pPr>
+            <a:r>
+              <a:rPr lang="en-US" sz="1650" b="1" dirty="0">
+                <a:solidFill>
+                  <a:srgbClr val="0B0B0B"/>
+                </a:solidFill>
+                <a:latin typeface="Calibri" pitchFamily="34" charset="0"/>
+                <a:ea typeface="Calibri" pitchFamily="34" charset="-122"/>
+                <a:cs typeface="Calibri" pitchFamily="34" charset="-120"/>
+              </a:rPr>
+              <a:t>Next 90 days</a:t>
+            </a:r>
+            <a:endParaRPr lang="en-US" sz="1650" dirty="0"/>
+          </a:p>
+        </p:txBody>
+      </p:sp>
+      <p:sp>
+        <p:nvSpPr>
+          <p:cNvPr id="27" name="Text 25"/>
+          <p:cNvSpPr/>
+          <p:nvPr/>
+        </p:nvSpPr>
+        <p:spPr>
+          <a:xfrm>
+            <a:off x="4754880" y="5394960"/>
+            <a:ext cx="6858000" cy="411480"/>
+          </a:xfrm>
+          <a:prstGeom prst="rect">
+            <a:avLst/>
+          </a:prstGeom>
+          <a:noFill/>
+          <a:ln/>
+        </p:spPr>
+        <p:txBody>
+          <a:bodyPr wrap="square" lIns="0" tIns="0" rIns="0" bIns="0" rtlCol="0" anchor="ctr"/>
+          <a:lstStyle/>
+          <a:p>
+            <a:pPr indent="0" marL="0">
+              <a:buNone/>
+            </a:pPr>
+            <a:r>
+              <a:rPr lang="en-US" sz="1200" dirty="0">
+                <a:solidFill>
+                  <a:srgbClr val="52514E"/>
+                </a:solidFill>
+                <a:latin typeface="Calibri" pitchFamily="34" charset="0"/>
+                <a:ea typeface="Calibri" pitchFamily="34" charset="-122"/>
+                <a:cs typeface="Calibri" pitchFamily="34" charset="-120"/>
+              </a:rPr>
+              <a:t>Priorities: realization, utilization, the Q4 pipeline, and the monthly rhythm</a:t>
+            </a:r>
+            <a:endParaRPr lang="en-US" sz="1200" dirty="0"/>
+          </a:p>
+        </p:txBody>
+      </p:sp>
+      <p:sp>
+        <p:nvSpPr>
+          <p:cNvPr id="28" name="Text 26"/>
+          <p:cNvSpPr/>
+          <p:nvPr/>
+        </p:nvSpPr>
+        <p:spPr>
+          <a:xfrm>
+            <a:off x="548640" y="6419088"/>
+            <a:ext cx="11064240" cy="320040"/>
+          </a:xfrm>
+          <a:prstGeom prst="rect">
+            <a:avLst/>
+          </a:prstGeom>
+          <a:noFill/>
+          <a:ln/>
+        </p:spPr>
+        <p:txBody>
+          <a:bodyPr wrap="square" lIns="0" tIns="0" rIns="0" bIns="0" rtlCol="0" anchor="ctr"/>
+          <a:lstStyle/>
+          <a:p>
+            <a:pPr indent="0" marL="0">
+              <a:buNone/>
+            </a:pPr>
+            <a:r>
+              <a:rPr lang="en-US" sz="950" dirty="0">
+                <a:solidFill>
+                  <a:srgbClr val="898781"/>
+                </a:solidFill>
+                <a:latin typeface="Calibri" pitchFamily="34" charset="0"/>
+                <a:ea typeface="Calibri" pitchFamily="34" charset="-122"/>
+                <a:cs typeface="Calibri" pitchFamily="34" charset="-120"/>
+              </a:rPr>
+              <a:t>CVR Engineering financial review &amp; forecast · June 2026</a:t>
+            </a:r>
+            <a:endParaRPr lang="en-US" sz="950" dirty="0"/>
+          </a:p>
+        </p:txBody>
+      </p:sp>
+    </p:spTree>
+  </p:cSld>
+  <p:clrMapOvr>
+    <a:masterClrMapping/>
+  </p:clrMapOvr>
+</p:sld>
+</file>
+
+<file path=ppt/slides/slide20.xml><?xml version="1.0" encoding="utf-8"?>
+<p:sld xmlns:a="http://schemas.openxmlformats.org/drawingml/2006/main" xmlns:r="http://schemas.openxmlformats.org/officeDocument/2006/relationships" xmlns:p="http://schemas.openxmlformats.org/presentationml/2006/main">
+  <p:cSld name="Slide 20">
     <p:bg>
       <p:bgPr>
         <a:solidFill>
@@ -22585,984 +24751,6 @@
                 <a:cs typeface="Calibri" pitchFamily="34" charset="-120"/>
               </a:rPr>
               <a:t>CVR Engineering · prepared July 2026 · model workbooks and data in the CVR---Financial repository</a:t>
-            </a:r>
-            <a:endParaRPr lang="en-US" sz="950" dirty="0"/>
-          </a:p>
-        </p:txBody>
-      </p:sp>
-    </p:spTree>
-  </p:cSld>
-  <p:clrMapOvr>
-    <a:masterClrMapping/>
-  </p:clrMapOvr>
-</p:sld>
-</file>
-
-<file path=ppt/slides/slide2.xml><?xml version="1.0" encoding="utf-8"?>
-<p:sld xmlns:a="http://schemas.openxmlformats.org/drawingml/2006/main" xmlns:r="http://schemas.openxmlformats.org/officeDocument/2006/relationships" xmlns:p="http://schemas.openxmlformats.org/presentationml/2006/main">
-  <p:cSld name="Slide 2">
-    <p:spTree>
-      <p:nvGrpSpPr>
-        <p:cNvPr id="1" name=""/>
-        <p:cNvGrpSpPr/>
-        <p:nvPr/>
-      </p:nvGrpSpPr>
-      <p:grpSpPr>
-        <a:xfrm>
-          <a:off x="0" y="0"/>
-          <a:ext cx="0" cy="0"/>
-          <a:chOff x="0" y="0"/>
-          <a:chExt cx="0" cy="0"/>
-        </a:xfrm>
-      </p:grpSpPr>
-      <p:sp>
-        <p:nvSpPr>
-          <p:cNvPr id="2" name="Text 0"/>
-          <p:cNvSpPr/>
-          <p:nvPr/>
-        </p:nvSpPr>
-        <p:spPr>
-          <a:xfrm>
-            <a:off x="548640" y="292608"/>
-            <a:ext cx="11064240" cy="274320"/>
-          </a:xfrm>
-          <a:prstGeom prst="rect">
-            <a:avLst/>
-          </a:prstGeom>
-          <a:noFill/>
-          <a:ln/>
-        </p:spPr>
-        <p:txBody>
-          <a:bodyPr wrap="square" lIns="0" tIns="0" rIns="0" bIns="0" rtlCol="0" anchor="ctr"/>
-          <a:lstStyle/>
-          <a:p>
-            <a:pPr indent="0" marL="0">
-              <a:buNone/>
-            </a:pPr>
-            <a:r>
-              <a:rPr lang="en-US" sz="1100" b="1" dirty="0">
-                <a:solidFill>
-                  <a:srgbClr val="86B332"/>
-                </a:solidFill>
-                <a:latin typeface="Calibri" pitchFamily="34" charset="0"/>
-                <a:ea typeface="Calibri" pitchFamily="34" charset="-122"/>
-                <a:cs typeface="Calibri" pitchFamily="34" charset="-120"/>
-              </a:rPr>
-              <a:t>— </a:t>
-            </a:r>
-            <a:pPr indent="0" marL="0">
-              <a:buNone/>
-            </a:pPr>
-            <a:r>
-              <a:rPr lang="en-US" sz="1100" b="1" spc="200" kern="0" dirty="0">
-                <a:solidFill>
-                  <a:srgbClr val="52514E"/>
-                </a:solidFill>
-                <a:latin typeface="Calibri" pitchFamily="34" charset="0"/>
-                <a:ea typeface="Calibri" pitchFamily="34" charset="-122"/>
-                <a:cs typeface="Calibri" pitchFamily="34" charset="-120"/>
-              </a:rPr>
-              <a:t>AGENDA</a:t>
-            </a:r>
-            <a:endParaRPr lang="en-US" sz="1100" dirty="0"/>
-          </a:p>
-        </p:txBody>
-      </p:sp>
-      <p:sp>
-        <p:nvSpPr>
-          <p:cNvPr id="3" name="Text 1"/>
-          <p:cNvSpPr/>
-          <p:nvPr/>
-        </p:nvSpPr>
-        <p:spPr>
-          <a:xfrm>
-            <a:off x="548640" y="548640"/>
-            <a:ext cx="11064240" cy="502920"/>
-          </a:xfrm>
-          <a:prstGeom prst="rect">
-            <a:avLst/>
-          </a:prstGeom>
-          <a:noFill/>
-          <a:ln/>
-        </p:spPr>
-        <p:txBody>
-          <a:bodyPr wrap="square" lIns="0" tIns="0" rIns="0" bIns="0" rtlCol="0" anchor="ctr"/>
-          <a:lstStyle/>
-          <a:p>
-            <a:pPr indent="0" marL="0">
-              <a:buNone/>
-            </a:pPr>
-            <a:r>
-              <a:rPr lang="en-US" sz="2700" b="1" dirty="0">
-                <a:solidFill>
-                  <a:srgbClr val="0B0B0B"/>
-                </a:solidFill>
-                <a:latin typeface="Calibri" pitchFamily="34" charset="0"/>
-                <a:ea typeface="Calibri" pitchFamily="34" charset="-122"/>
-                <a:cs typeface="Calibri" pitchFamily="34" charset="-120"/>
-              </a:rPr>
-              <a:t>What we'll cover</a:t>
-            </a:r>
-            <a:endParaRPr lang="en-US" sz="2700" dirty="0"/>
-          </a:p>
-        </p:txBody>
-      </p:sp>
-      <p:sp>
-        <p:nvSpPr>
-          <p:cNvPr id="4" name="Shape 2"/>
-          <p:cNvSpPr/>
-          <p:nvPr/>
-        </p:nvSpPr>
-        <p:spPr>
-          <a:xfrm>
-            <a:off x="548640" y="1481328"/>
-            <a:ext cx="402336" cy="402336"/>
-          </a:xfrm>
-          <a:prstGeom prst="ellipse">
-            <a:avLst/>
-          </a:prstGeom>
-          <a:solidFill>
-            <a:srgbClr val="2A78D6"/>
-          </a:solidFill>
-          <a:ln/>
-        </p:spPr>
-      </p:sp>
-      <p:sp>
-        <p:nvSpPr>
-          <p:cNvPr id="5" name="Text 3"/>
-          <p:cNvSpPr/>
-          <p:nvPr/>
-        </p:nvSpPr>
-        <p:spPr>
-          <a:xfrm>
-            <a:off x="548640" y="1481328"/>
-            <a:ext cx="402336" cy="402336"/>
-          </a:xfrm>
-          <a:prstGeom prst="rect">
-            <a:avLst/>
-          </a:prstGeom>
-          <a:noFill/>
-          <a:ln/>
-        </p:spPr>
-        <p:txBody>
-          <a:bodyPr wrap="square" lIns="0" tIns="0" rIns="0" bIns="0" rtlCol="0" anchor="ctr"/>
-          <a:lstStyle/>
-          <a:p>
-            <a:pPr algn="ctr" indent="0" marL="0">
-              <a:buNone/>
-            </a:pPr>
-            <a:r>
-              <a:rPr lang="en-US" sz="1500" b="1" dirty="0">
-                <a:solidFill>
-                  <a:srgbClr val="FFFFFF"/>
-                </a:solidFill>
-                <a:latin typeface="Calibri" pitchFamily="34" charset="0"/>
-                <a:ea typeface="Calibri" pitchFamily="34" charset="-122"/>
-                <a:cs typeface="Calibri" pitchFamily="34" charset="-120"/>
-              </a:rPr>
-              <a:t>1</a:t>
-            </a:r>
-            <a:endParaRPr lang="en-US" sz="1500" dirty="0"/>
-          </a:p>
-        </p:txBody>
-      </p:sp>
-      <p:sp>
-        <p:nvSpPr>
-          <p:cNvPr id="6" name="Text 4"/>
-          <p:cNvSpPr/>
-          <p:nvPr/>
-        </p:nvSpPr>
-        <p:spPr>
-          <a:xfrm>
-            <a:off x="1188720" y="1463040"/>
-            <a:ext cx="3383280" cy="411480"/>
-          </a:xfrm>
-          <a:prstGeom prst="rect">
-            <a:avLst/>
-          </a:prstGeom>
-          <a:noFill/>
-          <a:ln/>
-        </p:spPr>
-        <p:txBody>
-          <a:bodyPr wrap="square" lIns="0" tIns="0" rIns="0" bIns="0" rtlCol="0" anchor="ctr"/>
-          <a:lstStyle/>
-          <a:p>
-            <a:pPr indent="0" marL="0">
-              <a:buNone/>
-            </a:pPr>
-            <a:r>
-              <a:rPr lang="en-US" sz="1650" b="1" dirty="0">
-                <a:solidFill>
-                  <a:srgbClr val="0B0B0B"/>
-                </a:solidFill>
-                <a:latin typeface="Calibri" pitchFamily="34" charset="0"/>
-                <a:ea typeface="Calibri" pitchFamily="34" charset="-122"/>
-                <a:cs typeface="Calibri" pitchFamily="34" charset="-120"/>
-              </a:rPr>
-              <a:t>Where we stand</a:t>
-            </a:r>
-            <a:endParaRPr lang="en-US" sz="1650" dirty="0"/>
-          </a:p>
-        </p:txBody>
-      </p:sp>
-      <p:sp>
-        <p:nvSpPr>
-          <p:cNvPr id="7" name="Text 5"/>
-          <p:cNvSpPr/>
-          <p:nvPr/>
-        </p:nvSpPr>
-        <p:spPr>
-          <a:xfrm>
-            <a:off x="4754880" y="1463040"/>
-            <a:ext cx="6858000" cy="411480"/>
-          </a:xfrm>
-          <a:prstGeom prst="rect">
-            <a:avLst/>
-          </a:prstGeom>
-          <a:noFill/>
-          <a:ln/>
-        </p:spPr>
-        <p:txBody>
-          <a:bodyPr wrap="square" lIns="0" tIns="0" rIns="0" bIns="0" rtlCol="0" anchor="ctr"/>
-          <a:lstStyle/>
-          <a:p>
-            <a:pPr indent="0" marL="0">
-              <a:buNone/>
-            </a:pPr>
-            <a:r>
-              <a:rPr lang="en-US" sz="1200" dirty="0">
-                <a:solidFill>
-                  <a:srgbClr val="52514E"/>
-                </a:solidFill>
-                <a:latin typeface="Calibri" pitchFamily="34" charset="0"/>
-                <a:ea typeface="Calibri" pitchFamily="34" charset="-122"/>
-                <a:cs typeface="Calibri" pitchFamily="34" charset="-120"/>
-              </a:rPr>
-              <a:t>Executive summary · revenue vs plan &amp; prior year · gross margin vs budget · the rate ladder</a:t>
-            </a:r>
-            <a:endParaRPr lang="en-US" sz="1200" dirty="0"/>
-          </a:p>
-        </p:txBody>
-      </p:sp>
-      <p:sp>
-        <p:nvSpPr>
-          <p:cNvPr id="8" name="Shape 6"/>
-          <p:cNvSpPr/>
-          <p:nvPr/>
-        </p:nvSpPr>
-        <p:spPr>
-          <a:xfrm>
-            <a:off x="548640" y="2267712"/>
-            <a:ext cx="402336" cy="402336"/>
-          </a:xfrm>
-          <a:prstGeom prst="ellipse">
-            <a:avLst/>
-          </a:prstGeom>
-          <a:solidFill>
-            <a:srgbClr val="2A78D6"/>
-          </a:solidFill>
-          <a:ln/>
-        </p:spPr>
-      </p:sp>
-      <p:sp>
-        <p:nvSpPr>
-          <p:cNvPr id="9" name="Text 7"/>
-          <p:cNvSpPr/>
-          <p:nvPr/>
-        </p:nvSpPr>
-        <p:spPr>
-          <a:xfrm>
-            <a:off x="548640" y="2267712"/>
-            <a:ext cx="402336" cy="402336"/>
-          </a:xfrm>
-          <a:prstGeom prst="rect">
-            <a:avLst/>
-          </a:prstGeom>
-          <a:noFill/>
-          <a:ln/>
-        </p:spPr>
-        <p:txBody>
-          <a:bodyPr wrap="square" lIns="0" tIns="0" rIns="0" bIns="0" rtlCol="0" anchor="ctr"/>
-          <a:lstStyle/>
-          <a:p>
-            <a:pPr algn="ctr" indent="0" marL="0">
-              <a:buNone/>
-            </a:pPr>
-            <a:r>
-              <a:rPr lang="en-US" sz="1500" b="1" dirty="0">
-                <a:solidFill>
-                  <a:srgbClr val="FFFFFF"/>
-                </a:solidFill>
-                <a:latin typeface="Calibri" pitchFamily="34" charset="0"/>
-                <a:ea typeface="Calibri" pitchFamily="34" charset="-122"/>
-                <a:cs typeface="Calibri" pitchFamily="34" charset="-120"/>
-              </a:rPr>
-              <a:t>2</a:t>
-            </a:r>
-            <a:endParaRPr lang="en-US" sz="1500" dirty="0"/>
-          </a:p>
-        </p:txBody>
-      </p:sp>
-      <p:sp>
-        <p:nvSpPr>
-          <p:cNvPr id="10" name="Text 8"/>
-          <p:cNvSpPr/>
-          <p:nvPr/>
-        </p:nvSpPr>
-        <p:spPr>
-          <a:xfrm>
-            <a:off x="1188720" y="2249424"/>
-            <a:ext cx="3383280" cy="411480"/>
-          </a:xfrm>
-          <a:prstGeom prst="rect">
-            <a:avLst/>
-          </a:prstGeom>
-          <a:noFill/>
-          <a:ln/>
-        </p:spPr>
-        <p:txBody>
-          <a:bodyPr wrap="square" lIns="0" tIns="0" rIns="0" bIns="0" rtlCol="0" anchor="ctr"/>
-          <a:lstStyle/>
-          <a:p>
-            <a:pPr indent="0" marL="0">
-              <a:buNone/>
-            </a:pPr>
-            <a:r>
-              <a:rPr lang="en-US" sz="1650" b="1" dirty="0">
-                <a:solidFill>
-                  <a:srgbClr val="0B0B0B"/>
-                </a:solidFill>
-                <a:latin typeface="Calibri" pitchFamily="34" charset="0"/>
-                <a:ea typeface="Calibri" pitchFamily="34" charset="-122"/>
-                <a:cs typeface="Calibri" pitchFamily="34" charset="-120"/>
-              </a:rPr>
-              <a:t>Operating drivers</a:t>
-            </a:r>
-            <a:endParaRPr lang="en-US" sz="1650" dirty="0"/>
-          </a:p>
-        </p:txBody>
-      </p:sp>
-      <p:sp>
-        <p:nvSpPr>
-          <p:cNvPr id="11" name="Text 9"/>
-          <p:cNvSpPr/>
-          <p:nvPr/>
-        </p:nvSpPr>
-        <p:spPr>
-          <a:xfrm>
-            <a:off x="4754880" y="2249424"/>
-            <a:ext cx="6858000" cy="411480"/>
-          </a:xfrm>
-          <a:prstGeom prst="rect">
-            <a:avLst/>
-          </a:prstGeom>
-          <a:noFill/>
-          <a:ln/>
-        </p:spPr>
-        <p:txBody>
-          <a:bodyPr wrap="square" lIns="0" tIns="0" rIns="0" bIns="0" rtlCol="0" anchor="ctr"/>
-          <a:lstStyle/>
-          <a:p>
-            <a:pPr indent="0" marL="0">
-              <a:buNone/>
-            </a:pPr>
-            <a:r>
-              <a:rPr lang="en-US" sz="1200" dirty="0">
-                <a:solidFill>
-                  <a:srgbClr val="52514E"/>
-                </a:solidFill>
-                <a:latin typeface="Calibri" pitchFamily="34" charset="0"/>
-                <a:ea typeface="Calibri" pitchFamily="34" charset="-122"/>
-                <a:cs typeface="Calibri" pitchFamily="34" charset="-120"/>
-              </a:rPr>
-              <a:t>Staff &amp; headcount · utilization by person · sales by customer</a:t>
-            </a:r>
-            <a:endParaRPr lang="en-US" sz="1200" dirty="0"/>
-          </a:p>
-        </p:txBody>
-      </p:sp>
-      <p:sp>
-        <p:nvSpPr>
-          <p:cNvPr id="12" name="Shape 10"/>
-          <p:cNvSpPr/>
-          <p:nvPr/>
-        </p:nvSpPr>
-        <p:spPr>
-          <a:xfrm>
-            <a:off x="548640" y="3054096"/>
-            <a:ext cx="402336" cy="402336"/>
-          </a:xfrm>
-          <a:prstGeom prst="ellipse">
-            <a:avLst/>
-          </a:prstGeom>
-          <a:solidFill>
-            <a:srgbClr val="2A78D6"/>
-          </a:solidFill>
-          <a:ln/>
-        </p:spPr>
-      </p:sp>
-      <p:sp>
-        <p:nvSpPr>
-          <p:cNvPr id="13" name="Text 11"/>
-          <p:cNvSpPr/>
-          <p:nvPr/>
-        </p:nvSpPr>
-        <p:spPr>
-          <a:xfrm>
-            <a:off x="548640" y="3054096"/>
-            <a:ext cx="402336" cy="402336"/>
-          </a:xfrm>
-          <a:prstGeom prst="rect">
-            <a:avLst/>
-          </a:prstGeom>
-          <a:noFill/>
-          <a:ln/>
-        </p:spPr>
-        <p:txBody>
-          <a:bodyPr wrap="square" lIns="0" tIns="0" rIns="0" bIns="0" rtlCol="0" anchor="ctr"/>
-          <a:lstStyle/>
-          <a:p>
-            <a:pPr algn="ctr" indent="0" marL="0">
-              <a:buNone/>
-            </a:pPr>
-            <a:r>
-              <a:rPr lang="en-US" sz="1500" b="1" dirty="0">
-                <a:solidFill>
-                  <a:srgbClr val="FFFFFF"/>
-                </a:solidFill>
-                <a:latin typeface="Calibri" pitchFamily="34" charset="0"/>
-                <a:ea typeface="Calibri" pitchFamily="34" charset="-122"/>
-                <a:cs typeface="Calibri" pitchFamily="34" charset="-120"/>
-              </a:rPr>
-              <a:t>3</a:t>
-            </a:r>
-            <a:endParaRPr lang="en-US" sz="1500" dirty="0"/>
-          </a:p>
-        </p:txBody>
-      </p:sp>
-      <p:sp>
-        <p:nvSpPr>
-          <p:cNvPr id="14" name="Text 12"/>
-          <p:cNvSpPr/>
-          <p:nvPr/>
-        </p:nvSpPr>
-        <p:spPr>
-          <a:xfrm>
-            <a:off x="1188720" y="3035808"/>
-            <a:ext cx="3383280" cy="411480"/>
-          </a:xfrm>
-          <a:prstGeom prst="rect">
-            <a:avLst/>
-          </a:prstGeom>
-          <a:noFill/>
-          <a:ln/>
-        </p:spPr>
-        <p:txBody>
-          <a:bodyPr wrap="square" lIns="0" tIns="0" rIns="0" bIns="0" rtlCol="0" anchor="ctr"/>
-          <a:lstStyle/>
-          <a:p>
-            <a:pPr indent="0" marL="0">
-              <a:buNone/>
-            </a:pPr>
-            <a:r>
-              <a:rPr lang="en-US" sz="1650" b="1" dirty="0">
-                <a:solidFill>
-                  <a:srgbClr val="0B0B0B"/>
-                </a:solidFill>
-                <a:latin typeface="Calibri" pitchFamily="34" charset="0"/>
-                <a:ea typeface="Calibri" pitchFamily="34" charset="-122"/>
-                <a:cs typeface="Calibri" pitchFamily="34" charset="-120"/>
-              </a:rPr>
-              <a:t>Work in hand &amp; work to win</a:t>
-            </a:r>
-            <a:endParaRPr lang="en-US" sz="1650" dirty="0"/>
-          </a:p>
-        </p:txBody>
-      </p:sp>
-      <p:sp>
-        <p:nvSpPr>
-          <p:cNvPr id="15" name="Text 13"/>
-          <p:cNvSpPr/>
-          <p:nvPr/>
-        </p:nvSpPr>
-        <p:spPr>
-          <a:xfrm>
-            <a:off x="4754880" y="3035808"/>
-            <a:ext cx="6858000" cy="411480"/>
-          </a:xfrm>
-          <a:prstGeom prst="rect">
-            <a:avLst/>
-          </a:prstGeom>
-          <a:noFill/>
-          <a:ln/>
-        </p:spPr>
-        <p:txBody>
-          <a:bodyPr wrap="square" lIns="0" tIns="0" rIns="0" bIns="0" rtlCol="0" anchor="ctr"/>
-          <a:lstStyle/>
-          <a:p>
-            <a:pPr indent="0" marL="0">
-              <a:buNone/>
-            </a:pPr>
-            <a:r>
-              <a:rPr lang="en-US" sz="1200" dirty="0">
-                <a:solidFill>
-                  <a:srgbClr val="52514E"/>
-                </a:solidFill>
-                <a:latin typeface="Calibri" pitchFamily="34" charset="0"/>
-                <a:ea typeface="Calibri" pitchFamily="34" charset="-122"/>
-                <a:cs typeface="Calibri" pitchFamily="34" charset="-120"/>
-              </a:rPr>
-              <a:t>Backlog on active jobs · known pipeline opportunities</a:t>
-            </a:r>
-            <a:endParaRPr lang="en-US" sz="1200" dirty="0"/>
-          </a:p>
-        </p:txBody>
-      </p:sp>
-      <p:sp>
-        <p:nvSpPr>
-          <p:cNvPr id="16" name="Shape 14"/>
-          <p:cNvSpPr/>
-          <p:nvPr/>
-        </p:nvSpPr>
-        <p:spPr>
-          <a:xfrm>
-            <a:off x="548640" y="3840480"/>
-            <a:ext cx="402336" cy="402336"/>
-          </a:xfrm>
-          <a:prstGeom prst="ellipse">
-            <a:avLst/>
-          </a:prstGeom>
-          <a:solidFill>
-            <a:srgbClr val="2A78D6"/>
-          </a:solidFill>
-          <a:ln/>
-        </p:spPr>
-      </p:sp>
-      <p:sp>
-        <p:nvSpPr>
-          <p:cNvPr id="17" name="Text 15"/>
-          <p:cNvSpPr/>
-          <p:nvPr/>
-        </p:nvSpPr>
-        <p:spPr>
-          <a:xfrm>
-            <a:off x="548640" y="3840480"/>
-            <a:ext cx="402336" cy="402336"/>
-          </a:xfrm>
-          <a:prstGeom prst="rect">
-            <a:avLst/>
-          </a:prstGeom>
-          <a:noFill/>
-          <a:ln/>
-        </p:spPr>
-        <p:txBody>
-          <a:bodyPr wrap="square" lIns="0" tIns="0" rIns="0" bIns="0" rtlCol="0" anchor="ctr"/>
-          <a:lstStyle/>
-          <a:p>
-            <a:pPr algn="ctr" indent="0" marL="0">
-              <a:buNone/>
-            </a:pPr>
-            <a:r>
-              <a:rPr lang="en-US" sz="1500" b="1" dirty="0">
-                <a:solidFill>
-                  <a:srgbClr val="FFFFFF"/>
-                </a:solidFill>
-                <a:latin typeface="Calibri" pitchFamily="34" charset="0"/>
-                <a:ea typeface="Calibri" pitchFamily="34" charset="-122"/>
-                <a:cs typeface="Calibri" pitchFamily="34" charset="-120"/>
-              </a:rPr>
-              <a:t>4</a:t>
-            </a:r>
-            <a:endParaRPr lang="en-US" sz="1500" dirty="0"/>
-          </a:p>
-        </p:txBody>
-      </p:sp>
-      <p:sp>
-        <p:nvSpPr>
-          <p:cNvPr id="18" name="Text 16"/>
-          <p:cNvSpPr/>
-          <p:nvPr/>
-        </p:nvSpPr>
-        <p:spPr>
-          <a:xfrm>
-            <a:off x="1188720" y="3822192"/>
-            <a:ext cx="3383280" cy="411480"/>
-          </a:xfrm>
-          <a:prstGeom prst="rect">
-            <a:avLst/>
-          </a:prstGeom>
-          <a:noFill/>
-          <a:ln/>
-        </p:spPr>
-        <p:txBody>
-          <a:bodyPr wrap="square" lIns="0" tIns="0" rIns="0" bIns="0" rtlCol="0" anchor="ctr"/>
-          <a:lstStyle/>
-          <a:p>
-            <a:pPr indent="0" marL="0">
-              <a:buNone/>
-            </a:pPr>
-            <a:r>
-              <a:rPr lang="en-US" sz="1650" b="1" dirty="0">
-                <a:solidFill>
-                  <a:srgbClr val="0B0B0B"/>
-                </a:solidFill>
-                <a:latin typeface="Calibri" pitchFamily="34" charset="0"/>
-                <a:ea typeface="Calibri" pitchFamily="34" charset="-122"/>
-                <a:cs typeface="Calibri" pitchFamily="34" charset="-120"/>
-              </a:rPr>
-              <a:t>Strategy</a:t>
-            </a:r>
-            <a:endParaRPr lang="en-US" sz="1650" dirty="0"/>
-          </a:p>
-        </p:txBody>
-      </p:sp>
-      <p:sp>
-        <p:nvSpPr>
-          <p:cNvPr id="19" name="Text 17"/>
-          <p:cNvSpPr/>
-          <p:nvPr/>
-        </p:nvSpPr>
-        <p:spPr>
-          <a:xfrm>
-            <a:off x="4754880" y="3822192"/>
-            <a:ext cx="6858000" cy="411480"/>
-          </a:xfrm>
-          <a:prstGeom prst="rect">
-            <a:avLst/>
-          </a:prstGeom>
-          <a:noFill/>
-          <a:ln/>
-        </p:spPr>
-        <p:txBody>
-          <a:bodyPr wrap="square" lIns="0" tIns="0" rIns="0" bIns="0" rtlCol="0" anchor="ctr"/>
-          <a:lstStyle/>
-          <a:p>
-            <a:pPr indent="0" marL="0">
-              <a:buNone/>
-            </a:pPr>
-            <a:r>
-              <a:rPr lang="en-US" sz="1200" dirty="0">
-                <a:solidFill>
-                  <a:srgbClr val="52514E"/>
-                </a:solidFill>
-                <a:latin typeface="Calibri" pitchFamily="34" charset="0"/>
-                <a:ea typeface="Calibri" pitchFamily="34" charset="-122"/>
-                <a:cs typeface="Calibri" pitchFamily="34" charset="-120"/>
-              </a:rPr>
-              <a:t>One pursuit engine with HWC Estimating · the consolidated EPC offering · the addressable market · BD account ownership</a:t>
-            </a:r>
-            <a:endParaRPr lang="en-US" sz="1200" dirty="0"/>
-          </a:p>
-        </p:txBody>
-      </p:sp>
-      <p:sp>
-        <p:nvSpPr>
-          <p:cNvPr id="20" name="Shape 18"/>
-          <p:cNvSpPr/>
-          <p:nvPr/>
-        </p:nvSpPr>
-        <p:spPr>
-          <a:xfrm>
-            <a:off x="548640" y="4626864"/>
-            <a:ext cx="402336" cy="402336"/>
-          </a:xfrm>
-          <a:prstGeom prst="ellipse">
-            <a:avLst/>
-          </a:prstGeom>
-          <a:solidFill>
-            <a:srgbClr val="2A78D6"/>
-          </a:solidFill>
-          <a:ln/>
-        </p:spPr>
-      </p:sp>
-      <p:sp>
-        <p:nvSpPr>
-          <p:cNvPr id="21" name="Text 19"/>
-          <p:cNvSpPr/>
-          <p:nvPr/>
-        </p:nvSpPr>
-        <p:spPr>
-          <a:xfrm>
-            <a:off x="548640" y="4626864"/>
-            <a:ext cx="402336" cy="402336"/>
-          </a:xfrm>
-          <a:prstGeom prst="rect">
-            <a:avLst/>
-          </a:prstGeom>
-          <a:noFill/>
-          <a:ln/>
-        </p:spPr>
-        <p:txBody>
-          <a:bodyPr wrap="square" lIns="0" tIns="0" rIns="0" bIns="0" rtlCol="0" anchor="ctr"/>
-          <a:lstStyle/>
-          <a:p>
-            <a:pPr algn="ctr" indent="0" marL="0">
-              <a:buNone/>
-            </a:pPr>
-            <a:r>
-              <a:rPr lang="en-US" sz="1500" b="1" dirty="0">
-                <a:solidFill>
-                  <a:srgbClr val="FFFFFF"/>
-                </a:solidFill>
-                <a:latin typeface="Calibri" pitchFamily="34" charset="0"/>
-                <a:ea typeface="Calibri" pitchFamily="34" charset="-122"/>
-                <a:cs typeface="Calibri" pitchFamily="34" charset="-120"/>
-              </a:rPr>
-              <a:t>5</a:t>
-            </a:r>
-            <a:endParaRPr lang="en-US" sz="1500" dirty="0"/>
-          </a:p>
-        </p:txBody>
-      </p:sp>
-      <p:sp>
-        <p:nvSpPr>
-          <p:cNvPr id="22" name="Text 20"/>
-          <p:cNvSpPr/>
-          <p:nvPr/>
-        </p:nvSpPr>
-        <p:spPr>
-          <a:xfrm>
-            <a:off x="1188720" y="4608576"/>
-            <a:ext cx="3383280" cy="411480"/>
-          </a:xfrm>
-          <a:prstGeom prst="rect">
-            <a:avLst/>
-          </a:prstGeom>
-          <a:noFill/>
-          <a:ln/>
-        </p:spPr>
-        <p:txBody>
-          <a:bodyPr wrap="square" lIns="0" tIns="0" rIns="0" bIns="0" rtlCol="0" anchor="ctr"/>
-          <a:lstStyle/>
-          <a:p>
-            <a:pPr indent="0" marL="0">
-              <a:buNone/>
-            </a:pPr>
-            <a:r>
-              <a:rPr lang="en-US" sz="1650" b="1" dirty="0">
-                <a:solidFill>
-                  <a:srgbClr val="0B0B0B"/>
-                </a:solidFill>
-                <a:latin typeface="Calibri" pitchFamily="34" charset="0"/>
-                <a:ea typeface="Calibri" pitchFamily="34" charset="-122"/>
-                <a:cs typeface="Calibri" pitchFamily="34" charset="-120"/>
-              </a:rPr>
-              <a:t>Forward view</a:t>
-            </a:r>
-            <a:endParaRPr lang="en-US" sz="1650" dirty="0"/>
-          </a:p>
-        </p:txBody>
-      </p:sp>
-      <p:sp>
-        <p:nvSpPr>
-          <p:cNvPr id="23" name="Text 21"/>
-          <p:cNvSpPr/>
-          <p:nvPr/>
-        </p:nvSpPr>
-        <p:spPr>
-          <a:xfrm>
-            <a:off x="4754880" y="4608576"/>
-            <a:ext cx="6858000" cy="411480"/>
-          </a:xfrm>
-          <a:prstGeom prst="rect">
-            <a:avLst/>
-          </a:prstGeom>
-          <a:noFill/>
-          <a:ln/>
-        </p:spPr>
-        <p:txBody>
-          <a:bodyPr wrap="square" lIns="0" tIns="0" rIns="0" bIns="0" rtlCol="0" anchor="ctr"/>
-          <a:lstStyle/>
-          <a:p>
-            <a:pPr indent="0" marL="0">
-              <a:buNone/>
-            </a:pPr>
-            <a:r>
-              <a:rPr lang="en-US" sz="1200" dirty="0">
-                <a:solidFill>
-                  <a:srgbClr val="52514E"/>
-                </a:solidFill>
-                <a:latin typeface="Calibri" pitchFamily="34" charset="0"/>
-                <a:ea typeface="Calibri" pitchFamily="34" charset="-122"/>
-                <a:cs typeface="Calibri" pitchFamily="34" charset="-120"/>
-              </a:rPr>
-              <a:t>Forecast &amp; coverage · FY2026 landing and FY2027 scenarios · cash &amp; the parent note</a:t>
-            </a:r>
-            <a:endParaRPr lang="en-US" sz="1200" dirty="0"/>
-          </a:p>
-        </p:txBody>
-      </p:sp>
-      <p:sp>
-        <p:nvSpPr>
-          <p:cNvPr id="24" name="Shape 22"/>
-          <p:cNvSpPr/>
-          <p:nvPr/>
-        </p:nvSpPr>
-        <p:spPr>
-          <a:xfrm>
-            <a:off x="548640" y="5413248"/>
-            <a:ext cx="402336" cy="402336"/>
-          </a:xfrm>
-          <a:prstGeom prst="ellipse">
-            <a:avLst/>
-          </a:prstGeom>
-          <a:solidFill>
-            <a:srgbClr val="2A78D6"/>
-          </a:solidFill>
-          <a:ln/>
-        </p:spPr>
-      </p:sp>
-      <p:sp>
-        <p:nvSpPr>
-          <p:cNvPr id="25" name="Text 23"/>
-          <p:cNvSpPr/>
-          <p:nvPr/>
-        </p:nvSpPr>
-        <p:spPr>
-          <a:xfrm>
-            <a:off x="548640" y="5413248"/>
-            <a:ext cx="402336" cy="402336"/>
-          </a:xfrm>
-          <a:prstGeom prst="rect">
-            <a:avLst/>
-          </a:prstGeom>
-          <a:noFill/>
-          <a:ln/>
-        </p:spPr>
-        <p:txBody>
-          <a:bodyPr wrap="square" lIns="0" tIns="0" rIns="0" bIns="0" rtlCol="0" anchor="ctr"/>
-          <a:lstStyle/>
-          <a:p>
-            <a:pPr algn="ctr" indent="0" marL="0">
-              <a:buNone/>
-            </a:pPr>
-            <a:r>
-              <a:rPr lang="en-US" sz="1500" b="1" dirty="0">
-                <a:solidFill>
-                  <a:srgbClr val="FFFFFF"/>
-                </a:solidFill>
-                <a:latin typeface="Calibri" pitchFamily="34" charset="0"/>
-                <a:ea typeface="Calibri" pitchFamily="34" charset="-122"/>
-                <a:cs typeface="Calibri" pitchFamily="34" charset="-120"/>
-              </a:rPr>
-              <a:t>6</a:t>
-            </a:r>
-            <a:endParaRPr lang="en-US" sz="1500" dirty="0"/>
-          </a:p>
-        </p:txBody>
-      </p:sp>
-      <p:sp>
-        <p:nvSpPr>
-          <p:cNvPr id="26" name="Text 24"/>
-          <p:cNvSpPr/>
-          <p:nvPr/>
-        </p:nvSpPr>
-        <p:spPr>
-          <a:xfrm>
-            <a:off x="1188720" y="5394960"/>
-            <a:ext cx="3383280" cy="411480"/>
-          </a:xfrm>
-          <a:prstGeom prst="rect">
-            <a:avLst/>
-          </a:prstGeom>
-          <a:noFill/>
-          <a:ln/>
-        </p:spPr>
-        <p:txBody>
-          <a:bodyPr wrap="square" lIns="0" tIns="0" rIns="0" bIns="0" rtlCol="0" anchor="ctr"/>
-          <a:lstStyle/>
-          <a:p>
-            <a:pPr indent="0" marL="0">
-              <a:buNone/>
-            </a:pPr>
-            <a:r>
-              <a:rPr lang="en-US" sz="1650" b="1" dirty="0">
-                <a:solidFill>
-                  <a:srgbClr val="0B0B0B"/>
-                </a:solidFill>
-                <a:latin typeface="Calibri" pitchFamily="34" charset="0"/>
-                <a:ea typeface="Calibri" pitchFamily="34" charset="-122"/>
-                <a:cs typeface="Calibri" pitchFamily="34" charset="-120"/>
-              </a:rPr>
-              <a:t>Next 90 days</a:t>
-            </a:r>
-            <a:endParaRPr lang="en-US" sz="1650" dirty="0"/>
-          </a:p>
-        </p:txBody>
-      </p:sp>
-      <p:sp>
-        <p:nvSpPr>
-          <p:cNvPr id="27" name="Text 25"/>
-          <p:cNvSpPr/>
-          <p:nvPr/>
-        </p:nvSpPr>
-        <p:spPr>
-          <a:xfrm>
-            <a:off x="4754880" y="5394960"/>
-            <a:ext cx="6858000" cy="411480"/>
-          </a:xfrm>
-          <a:prstGeom prst="rect">
-            <a:avLst/>
-          </a:prstGeom>
-          <a:noFill/>
-          <a:ln/>
-        </p:spPr>
-        <p:txBody>
-          <a:bodyPr wrap="square" lIns="0" tIns="0" rIns="0" bIns="0" rtlCol="0" anchor="ctr"/>
-          <a:lstStyle/>
-          <a:p>
-            <a:pPr indent="0" marL="0">
-              <a:buNone/>
-            </a:pPr>
-            <a:r>
-              <a:rPr lang="en-US" sz="1200" dirty="0">
-                <a:solidFill>
-                  <a:srgbClr val="52514E"/>
-                </a:solidFill>
-                <a:latin typeface="Calibri" pitchFamily="34" charset="0"/>
-                <a:ea typeface="Calibri" pitchFamily="34" charset="-122"/>
-                <a:cs typeface="Calibri" pitchFamily="34" charset="-120"/>
-              </a:rPr>
-              <a:t>Priorities: realization, utilization, the Q4 pipeline, and the monthly rhythm</a:t>
-            </a:r>
-            <a:endParaRPr lang="en-US" sz="1200" dirty="0"/>
-          </a:p>
-        </p:txBody>
-      </p:sp>
-      <p:sp>
-        <p:nvSpPr>
-          <p:cNvPr id="28" name="Text 26"/>
-          <p:cNvSpPr/>
-          <p:nvPr/>
-        </p:nvSpPr>
-        <p:spPr>
-          <a:xfrm>
-            <a:off x="548640" y="6419088"/>
-            <a:ext cx="11064240" cy="320040"/>
-          </a:xfrm>
-          <a:prstGeom prst="rect">
-            <a:avLst/>
-          </a:prstGeom>
-          <a:noFill/>
-          <a:ln/>
-        </p:spPr>
-        <p:txBody>
-          <a:bodyPr wrap="square" lIns="0" tIns="0" rIns="0" bIns="0" rtlCol="0" anchor="ctr"/>
-          <a:lstStyle/>
-          <a:p>
-            <a:pPr indent="0" marL="0">
-              <a:buNone/>
-            </a:pPr>
-            <a:r>
-              <a:rPr lang="en-US" sz="950" dirty="0">
-                <a:solidFill>
-                  <a:srgbClr val="898781"/>
-                </a:solidFill>
-                <a:latin typeface="Calibri" pitchFamily="34" charset="0"/>
-                <a:ea typeface="Calibri" pitchFamily="34" charset="-122"/>
-                <a:cs typeface="Calibri" pitchFamily="34" charset="-120"/>
-              </a:rPr>
-              <a:t>CVR Engineering financial review &amp; forecast · June 2026</a:t>
             </a:r>
             <a:endParaRPr lang="en-US" sz="950" dirty="0"/>
           </a:p>

</xml_diff>

<commit_message>
Deck: add margin-by-role slide from COINS cost data
New slide 7 'Margin by role — a rate-card problem, quantified': grouped
bars of bill rate vs loaded cost per person (rendered to
reports/assets/margin.png from reports/margin_by_role.html), showing
Designer II underwater (0.77x) and Engineer III at ~6% margin at card.
Right rail draws the rate-card conclusion. Rate-ladder slide's third
callout updated from 'pending salary detail' to 'now sourced from the
COINS timesheet report'. Deck is now 21 slides.

Co-Authored-By: Claude Fable 5 <noreply@anthropic.com>
Claude-Session: https://claude.ai/code/session_0145i7FWr3AQEo26DBw1x2c4
</commit_message>
<xml_diff>
--- a/reports/CVR_Deck_Jun2026.pptx
+++ b/reports/CVR_Deck_Jun2026.pptx
@@ -25,9 +25,10 @@
     <p:sldId id="273" r:id="rId19"/>
     <p:sldId id="274" r:id="rId20"/>
     <p:sldId id="275" r:id="rId21"/>
+    <p:sldId id="276" r:id="rId22"/>
   </p:sldIdLst>
   <p:notesMasterIdLst>
-    <p:notesMasterId r:id="rId22"/>
+    <p:notesMasterId r:id="rId23"/>
   </p:notesMasterIdLst>
   <p:sldSz cx="12192000" cy="6858000"/>
   <p:notesSz cx="6858000" cy="12192000"/>
@@ -1601,6 +1602,94 @@
             <a:fld id="{F7021451-1387-4CA6-816F-3879F97B5CBC}" type="slidenum">
               <a:rPr lang="en-US"/>
               <a:t>20</a:t>
+            </a:fld>
+            <a:endParaRPr lang="en-US"/>
+          </a:p>
+        </p:txBody>
+      </p:sp>
+    </p:spTree>
+    <p:extLst>
+      <p:ext uri="{BB962C8B-B14F-4D97-AF65-F5344CB8AC3E}">
+        <p14:creationId xmlns:p14="http://schemas.microsoft.com/office/powerpoint/2010/main" val="1024086991"/>
+      </p:ext>
+    </p:extLst>
+  </p:cSld>
+  <p:clrMapOvr>
+    <a:masterClrMapping/>
+  </p:clrMapOvr>
+</p:notes>
+</file>
+
+<file path=ppt/notesSlides/notesSlide21.xml><?xml version="1.0" encoding="utf-8"?>
+<p:notes xmlns:a="http://schemas.openxmlformats.org/drawingml/2006/main" xmlns:r="http://schemas.openxmlformats.org/officeDocument/2006/relationships" xmlns:p="http://schemas.openxmlformats.org/presentationml/2006/main">
+  <p:cSld>
+    <p:spTree>
+      <p:nvGrpSpPr>
+        <p:cNvPr id="1" name=""/>
+        <p:cNvGrpSpPr/>
+        <p:nvPr/>
+      </p:nvGrpSpPr>
+      <p:grpSpPr>
+        <a:xfrm>
+          <a:off x="0" y="0"/>
+          <a:ext cx="0" cy="0"/>
+          <a:chOff x="0" y="0"/>
+          <a:chExt cx="0" cy="0"/>
+        </a:xfrm>
+      </p:grpSpPr>
+      <p:sp>
+        <p:nvSpPr>
+          <p:cNvPr id="2" name="Slide Image Placeholder 1"/>
+          <p:cNvSpPr>
+            <a:spLocks noGrp="1" noRot="1" noChangeAspect="1"/>
+          </p:cNvSpPr>
+          <p:nvPr>
+            <p:ph type="sldImg"/>
+          </p:nvPr>
+        </p:nvSpPr>
+        <p:spPr/>
+      </p:sp>
+      <p:sp>
+        <p:nvSpPr>
+          <p:cNvPr id="3" name="Notes Placeholder 2"/>
+          <p:cNvSpPr>
+            <a:spLocks noGrp="1"/>
+          </p:cNvSpPr>
+          <p:nvPr>
+            <p:ph type="body" idx="1"/>
+          </p:nvPr>
+        </p:nvSpPr>
+        <p:spPr/>
+        <p:txBody>
+          <a:bodyPr/>
+          <a:lstStyle/>
+          <a:p>
+            <a:r>
+              <a:rPr lang="en-US" dirty="0"/>
+              <a:t/>
+            </a:r>
+            <a:endParaRPr lang="en-US" dirty="0"/>
+          </a:p>
+        </p:txBody>
+      </p:sp>
+      <p:sp>
+        <p:nvSpPr>
+          <p:cNvPr id="4" name="Slide Number Placeholder 3"/>
+          <p:cNvSpPr>
+            <a:spLocks noGrp="1"/>
+          </p:cNvSpPr>
+          <p:nvPr>
+            <p:ph type="sldNum" sz="quarter" idx="10"/>
+          </p:nvPr>
+        </p:nvSpPr>
+        <p:spPr/>
+        <p:txBody>
+          <a:bodyPr/>
+          <a:lstStyle/>
+          <a:p>
+            <a:fld id="{F7021451-1387-4CA6-816F-3879F97B5CBC}" type="slidenum">
+              <a:rPr lang="en-US"/>
+              <a:t>21</a:t>
             </a:fld>
             <a:endParaRPr lang="en-US"/>
           </a:p>
@@ -2808,6 +2897,420 @@
                 <a:ea typeface="Calibri" pitchFamily="34" charset="-122"/>
                 <a:cs typeface="Calibri" pitchFamily="34" charset="-120"/>
               </a:rPr>
+              <a:t>OPERATING DRIVERS</a:t>
+            </a:r>
+            <a:endParaRPr lang="en-US" sz="1100" dirty="0"/>
+          </a:p>
+        </p:txBody>
+      </p:sp>
+      <p:sp>
+        <p:nvSpPr>
+          <p:cNvPr id="3" name="Text 1"/>
+          <p:cNvSpPr/>
+          <p:nvPr/>
+        </p:nvSpPr>
+        <p:spPr>
+          <a:xfrm>
+            <a:off x="548640" y="548640"/>
+            <a:ext cx="11064240" cy="502920"/>
+          </a:xfrm>
+          <a:prstGeom prst="rect">
+            <a:avLst/>
+          </a:prstGeom>
+          <a:noFill/>
+          <a:ln/>
+        </p:spPr>
+        <p:txBody>
+          <a:bodyPr wrap="square" lIns="0" tIns="0" rIns="0" bIns="0" rtlCol="0" anchor="ctr"/>
+          <a:lstStyle/>
+          <a:p>
+            <a:pPr indent="0" marL="0">
+              <a:buNone/>
+            </a:pPr>
+            <a:r>
+              <a:rPr lang="en-US" sz="2700" b="1" dirty="0">
+                <a:solidFill>
+                  <a:srgbClr val="0B0B0B"/>
+                </a:solidFill>
+                <a:latin typeface="Calibri" pitchFamily="34" charset="0"/>
+                <a:ea typeface="Calibri" pitchFamily="34" charset="-122"/>
+                <a:cs typeface="Calibri" pitchFamily="34" charset="-120"/>
+              </a:rPr>
+              <a:t>Sales by customer — YTD June 2026</a:t>
+            </a:r>
+            <a:endParaRPr lang="en-US" sz="2700" dirty="0"/>
+          </a:p>
+        </p:txBody>
+      </p:sp>
+      <p:pic>
+        <p:nvPicPr>
+          <p:cNvPr id="4" name="Image 0" descr="/home/user/CVR---Financial/reports/assets/cu.png">    </p:cNvPr>
+          <p:cNvPicPr>
+            <a:picLocks noChangeAspect="1"/>
+          </p:cNvPicPr>
+          <p:nvPr/>
+        </p:nvPicPr>
+        <p:blipFill>
+          <a:blip r:embed="rId1"/>
+          <a:stretch>
+            <a:fillRect/>
+          </a:stretch>
+        </p:blipFill>
+        <p:spPr>
+          <a:xfrm>
+            <a:off x="548640" y="2377440"/>
+            <a:ext cx="7863840" cy="1942310"/>
+          </a:xfrm>
+          <a:prstGeom prst="rect">
+            <a:avLst/>
+          </a:prstGeom>
+        </p:spPr>
+      </p:pic>
+      <p:sp>
+        <p:nvSpPr>
+          <p:cNvPr id="5" name="Text 2"/>
+          <p:cNvSpPr/>
+          <p:nvPr/>
+        </p:nvSpPr>
+        <p:spPr>
+          <a:xfrm>
+            <a:off x="8686800" y="1554480"/>
+            <a:ext cx="2926080" cy="457200"/>
+          </a:xfrm>
+          <a:prstGeom prst="rect">
+            <a:avLst/>
+          </a:prstGeom>
+          <a:noFill/>
+          <a:ln/>
+        </p:spPr>
+        <p:txBody>
+          <a:bodyPr wrap="square" lIns="0" tIns="0" rIns="0" bIns="0" rtlCol="0" anchor="ctr"/>
+          <a:lstStyle/>
+          <a:p>
+            <a:pPr indent="0" marL="0">
+              <a:buNone/>
+            </a:pPr>
+            <a:r>
+              <a:rPr lang="en-US" sz="2800" b="1" dirty="0">
+                <a:solidFill>
+                  <a:srgbClr val="E34948"/>
+                </a:solidFill>
+                <a:latin typeface="Calibri" pitchFamily="34" charset="0"/>
+                <a:ea typeface="Calibri" pitchFamily="34" charset="-122"/>
+                <a:cs typeface="Calibri" pitchFamily="34" charset="-120"/>
+              </a:rPr>
+              <a:t>69.7%</a:t>
+            </a:r>
+            <a:endParaRPr lang="en-US" sz="2800" dirty="0"/>
+          </a:p>
+        </p:txBody>
+      </p:sp>
+      <p:sp>
+        <p:nvSpPr>
+          <p:cNvPr id="6" name="Text 3"/>
+          <p:cNvSpPr/>
+          <p:nvPr/>
+        </p:nvSpPr>
+        <p:spPr>
+          <a:xfrm>
+            <a:off x="8686800" y="2011680"/>
+            <a:ext cx="2926080" cy="868680"/>
+          </a:xfrm>
+          <a:prstGeom prst="rect">
+            <a:avLst/>
+          </a:prstGeom>
+          <a:noFill/>
+          <a:ln/>
+        </p:spPr>
+        <p:txBody>
+          <a:bodyPr wrap="square" lIns="0" tIns="0" rIns="0" bIns="0" rtlCol="0" anchor="ctr"/>
+          <a:lstStyle/>
+          <a:p>
+            <a:pPr indent="0" marL="0">
+              <a:buNone/>
+            </a:pPr>
+            <a:r>
+              <a:rPr lang="en-US" sz="1200" dirty="0">
+                <a:solidFill>
+                  <a:srgbClr val="52514E"/>
+                </a:solidFill>
+                <a:latin typeface="Calibri" pitchFamily="34" charset="0"/>
+                <a:ea typeface="Calibri" pitchFamily="34" charset="-122"/>
+                <a:cs typeface="Calibri" pitchFamily="34" charset="-120"/>
+              </a:rPr>
+              <a:t>of revenue is CenterPoint — matching its ~70% share of billable hours</a:t>
+            </a:r>
+            <a:endParaRPr lang="en-US" sz="1200" dirty="0"/>
+          </a:p>
+        </p:txBody>
+      </p:sp>
+      <p:sp>
+        <p:nvSpPr>
+          <p:cNvPr id="7" name="Text 4"/>
+          <p:cNvSpPr/>
+          <p:nvPr/>
+        </p:nvSpPr>
+        <p:spPr>
+          <a:xfrm>
+            <a:off x="8686800" y="2926080"/>
+            <a:ext cx="2926080" cy="457200"/>
+          </a:xfrm>
+          <a:prstGeom prst="rect">
+            <a:avLst/>
+          </a:prstGeom>
+          <a:noFill/>
+          <a:ln/>
+        </p:spPr>
+        <p:txBody>
+          <a:bodyPr wrap="square" lIns="0" tIns="0" rIns="0" bIns="0" rtlCol="0" anchor="ctr"/>
+          <a:lstStyle/>
+          <a:p>
+            <a:pPr indent="0" marL="0">
+              <a:buNone/>
+            </a:pPr>
+            <a:r>
+              <a:rPr lang="en-US" sz="2800" b="1" dirty="0">
+                <a:solidFill>
+                  <a:srgbClr val="0B0B0B"/>
+                </a:solidFill>
+                <a:latin typeface="Calibri" pitchFamily="34" charset="0"/>
+                <a:ea typeface="Calibri" pitchFamily="34" charset="-122"/>
+                <a:cs typeface="Calibri" pitchFamily="34" charset="-120"/>
+              </a:rPr>
+              <a:t>20.2%</a:t>
+            </a:r>
+            <a:endParaRPr lang="en-US" sz="2800" dirty="0"/>
+          </a:p>
+        </p:txBody>
+      </p:sp>
+      <p:sp>
+        <p:nvSpPr>
+          <p:cNvPr id="8" name="Text 5"/>
+          <p:cNvSpPr/>
+          <p:nvPr/>
+        </p:nvSpPr>
+        <p:spPr>
+          <a:xfrm>
+            <a:off x="8686800" y="3383280"/>
+            <a:ext cx="2926080" cy="868680"/>
+          </a:xfrm>
+          <a:prstGeom prst="rect">
+            <a:avLst/>
+          </a:prstGeom>
+          <a:noFill/>
+          <a:ln/>
+        </p:spPr>
+        <p:txBody>
+          <a:bodyPr wrap="square" lIns="0" tIns="0" rIns="0" bIns="0" rtlCol="0" anchor="ctr"/>
+          <a:lstStyle/>
+          <a:p>
+            <a:pPr indent="0" marL="0">
+              <a:buNone/>
+            </a:pPr>
+            <a:r>
+              <a:rPr lang="en-US" sz="1200" dirty="0">
+                <a:solidFill>
+                  <a:srgbClr val="52514E"/>
+                </a:solidFill>
+                <a:latin typeface="Calibri" pitchFamily="34" charset="0"/>
+                <a:ea typeface="Calibri" pitchFamily="34" charset="-122"/>
+                <a:cs typeface="Calibri" pitchFamily="34" charset="-120"/>
+              </a:rPr>
+              <a:t>intercompany work for Hydaker-Wheatlake (rate treatment under review)</a:t>
+            </a:r>
+            <a:endParaRPr lang="en-US" sz="1200" dirty="0"/>
+          </a:p>
+        </p:txBody>
+      </p:sp>
+      <p:sp>
+        <p:nvSpPr>
+          <p:cNvPr id="9" name="Text 6"/>
+          <p:cNvSpPr/>
+          <p:nvPr/>
+        </p:nvSpPr>
+        <p:spPr>
+          <a:xfrm>
+            <a:off x="8686800" y="4297680"/>
+            <a:ext cx="2926080" cy="457200"/>
+          </a:xfrm>
+          <a:prstGeom prst="rect">
+            <a:avLst/>
+          </a:prstGeom>
+          <a:noFill/>
+          <a:ln/>
+        </p:spPr>
+        <p:txBody>
+          <a:bodyPr wrap="square" lIns="0" tIns="0" rIns="0" bIns="0" rtlCol="0" anchor="ctr"/>
+          <a:lstStyle/>
+          <a:p>
+            <a:pPr indent="0" marL="0">
+              <a:buNone/>
+            </a:pPr>
+            <a:r>
+              <a:rPr lang="en-US" sz="2800" b="1" dirty="0">
+                <a:solidFill>
+                  <a:srgbClr val="0B0B0B"/>
+                </a:solidFill>
+                <a:latin typeface="Calibri" pitchFamily="34" charset="0"/>
+                <a:ea typeface="Calibri" pitchFamily="34" charset="-122"/>
+                <a:cs typeface="Calibri" pitchFamily="34" charset="-120"/>
+              </a:rPr>
+              <a:t>~10%</a:t>
+            </a:r>
+            <a:endParaRPr lang="en-US" sz="2800" dirty="0"/>
+          </a:p>
+        </p:txBody>
+      </p:sp>
+      <p:sp>
+        <p:nvSpPr>
+          <p:cNvPr id="10" name="Text 7"/>
+          <p:cNvSpPr/>
+          <p:nvPr/>
+        </p:nvSpPr>
+        <p:spPr>
+          <a:xfrm>
+            <a:off x="8686800" y="4754880"/>
+            <a:ext cx="2926080" cy="868680"/>
+          </a:xfrm>
+          <a:prstGeom prst="rect">
+            <a:avLst/>
+          </a:prstGeom>
+          <a:noFill/>
+          <a:ln/>
+        </p:spPr>
+        <p:txBody>
+          <a:bodyPr wrap="square" lIns="0" tIns="0" rIns="0" bIns="0" rtlCol="0" anchor="ctr"/>
+          <a:lstStyle/>
+          <a:p>
+            <a:pPr indent="0" marL="0">
+              <a:buNone/>
+            </a:pPr>
+            <a:r>
+              <a:rPr lang="en-US" sz="1200" dirty="0">
+                <a:solidFill>
+                  <a:srgbClr val="52514E"/>
+                </a:solidFill>
+                <a:latin typeface="Calibri" pitchFamily="34" charset="0"/>
+                <a:ea typeface="Calibri" pitchFamily="34" charset="-122"/>
+                <a:cs typeface="Calibri" pitchFamily="34" charset="-120"/>
+              </a:rPr>
+              <a:t>all other external customers combined — diversification is the growth agenda</a:t>
+            </a:r>
+            <a:endParaRPr lang="en-US" sz="1200" dirty="0"/>
+          </a:p>
+        </p:txBody>
+      </p:sp>
+      <p:sp>
+        <p:nvSpPr>
+          <p:cNvPr id="11" name="Text 8"/>
+          <p:cNvSpPr/>
+          <p:nvPr/>
+        </p:nvSpPr>
+        <p:spPr>
+          <a:xfrm>
+            <a:off x="548640" y="6419088"/>
+            <a:ext cx="11064240" cy="320040"/>
+          </a:xfrm>
+          <a:prstGeom prst="rect">
+            <a:avLst/>
+          </a:prstGeom>
+          <a:noFill/>
+          <a:ln/>
+        </p:spPr>
+        <p:txBody>
+          <a:bodyPr wrap="square" lIns="0" tIns="0" rIns="0" bIns="0" rtlCol="0" anchor="ctr"/>
+          <a:lstStyle/>
+          <a:p>
+            <a:pPr indent="0" marL="0">
+              <a:buNone/>
+            </a:pPr>
+            <a:r>
+              <a:rPr lang="en-US" sz="950" dirty="0">
+                <a:solidFill>
+                  <a:srgbClr val="898781"/>
+                </a:solidFill>
+                <a:latin typeface="Calibri" pitchFamily="34" charset="0"/>
+                <a:ea typeface="Calibri" pitchFamily="34" charset="-122"/>
+                <a:cs typeface="Calibri" pitchFamily="34" charset="-120"/>
+              </a:rPr>
+              <a:t>GL sales-by-customer schedule, 6/30/26. Total $551.0K.</a:t>
+            </a:r>
+            <a:endParaRPr lang="en-US" sz="950" dirty="0"/>
+          </a:p>
+        </p:txBody>
+      </p:sp>
+    </p:spTree>
+  </p:cSld>
+  <p:clrMapOvr>
+    <a:masterClrMapping/>
+  </p:clrMapOvr>
+</p:sld>
+</file>
+
+<file path=ppt/slides/slide11.xml><?xml version="1.0" encoding="utf-8"?>
+<p:sld xmlns:a="http://schemas.openxmlformats.org/drawingml/2006/main" xmlns:r="http://schemas.openxmlformats.org/officeDocument/2006/relationships" xmlns:p="http://schemas.openxmlformats.org/presentationml/2006/main">
+  <p:cSld name="Slide 11">
+    <p:spTree>
+      <p:nvGrpSpPr>
+        <p:cNvPr id="1" name=""/>
+        <p:cNvGrpSpPr/>
+        <p:nvPr/>
+      </p:nvGrpSpPr>
+      <p:grpSpPr>
+        <a:xfrm>
+          <a:off x="0" y="0"/>
+          <a:ext cx="0" cy="0"/>
+          <a:chOff x="0" y="0"/>
+          <a:chExt cx="0" cy="0"/>
+        </a:xfrm>
+      </p:grpSpPr>
+      <p:sp>
+        <p:nvSpPr>
+          <p:cNvPr id="2" name="Text 0"/>
+          <p:cNvSpPr/>
+          <p:nvPr/>
+        </p:nvSpPr>
+        <p:spPr>
+          <a:xfrm>
+            <a:off x="548640" y="292608"/>
+            <a:ext cx="11064240" cy="274320"/>
+          </a:xfrm>
+          <a:prstGeom prst="rect">
+            <a:avLst/>
+          </a:prstGeom>
+          <a:noFill/>
+          <a:ln/>
+        </p:spPr>
+        <p:txBody>
+          <a:bodyPr wrap="square" lIns="0" tIns="0" rIns="0" bIns="0" rtlCol="0" anchor="ctr"/>
+          <a:lstStyle/>
+          <a:p>
+            <a:pPr indent="0" marL="0">
+              <a:buNone/>
+            </a:pPr>
+            <a:r>
+              <a:rPr lang="en-US" sz="1100" b="1" dirty="0">
+                <a:solidFill>
+                  <a:srgbClr val="86B332"/>
+                </a:solidFill>
+                <a:latin typeface="Calibri" pitchFamily="34" charset="0"/>
+                <a:ea typeface="Calibri" pitchFamily="34" charset="-122"/>
+                <a:cs typeface="Calibri" pitchFamily="34" charset="-120"/>
+              </a:rPr>
+              <a:t>— </a:t>
+            </a:r>
+            <a:pPr indent="0" marL="0">
+              <a:buNone/>
+            </a:pPr>
+            <a:r>
+              <a:rPr lang="en-US" sz="1100" b="1" spc="200" kern="0" dirty="0">
+                <a:solidFill>
+                  <a:srgbClr val="52514E"/>
+                </a:solidFill>
+                <a:latin typeface="Calibri" pitchFamily="34" charset="0"/>
+                <a:ea typeface="Calibri" pitchFamily="34" charset="-122"/>
+                <a:cs typeface="Calibri" pitchFamily="34" charset="-120"/>
+              </a:rPr>
               <a:t>WORK IN HAND</a:t>
             </a:r>
             <a:endParaRPr lang="en-US" sz="1100" dirty="0"/>
@@ -2855,7 +3358,7 @@
       </p:sp>
       <p:graphicFrame>
         <p:nvGraphicFramePr>
-          <p:cNvPr id="11" name="Table 0"/>
+          <p:cNvPr id="12" name="Table 0"/>
           <p:cNvGraphicFramePr>
             <a:graphicFrameLocks noGrp="1"/>
           </p:cNvGraphicFramePr>
@@ -7634,9 +8137,9 @@
 </p:sld>
 </file>
 
-<file path=ppt/slides/slide11.xml><?xml version="1.0" encoding="utf-8"?>
+<file path=ppt/slides/slide12.xml><?xml version="1.0" encoding="utf-8"?>
 <p:sld xmlns:a="http://schemas.openxmlformats.org/drawingml/2006/main" xmlns:r="http://schemas.openxmlformats.org/officeDocument/2006/relationships" xmlns:p="http://schemas.openxmlformats.org/presentationml/2006/main">
-  <p:cSld name="Slide 11">
+  <p:cSld name="Slide 12">
     <p:spTree>
       <p:nvGrpSpPr>
         <p:cNvPr id="1" name=""/>
@@ -7745,7 +8248,7 @@
       </p:sp>
       <p:graphicFrame>
         <p:nvGraphicFramePr>
-          <p:cNvPr id="12" name="Table 0"/>
+          <p:cNvPr id="13" name="Table 0"/>
           <p:cNvGraphicFramePr>
             <a:graphicFrameLocks noGrp="1"/>
           </p:cNvGraphicFramePr>
@@ -11850,9 +12353,9 @@
 </p:sld>
 </file>
 
-<file path=ppt/slides/slide12.xml><?xml version="1.0" encoding="utf-8"?>
+<file path=ppt/slides/slide13.xml><?xml version="1.0" encoding="utf-8"?>
 <p:sld xmlns:a="http://schemas.openxmlformats.org/drawingml/2006/main" xmlns:r="http://schemas.openxmlformats.org/officeDocument/2006/relationships" xmlns:p="http://schemas.openxmlformats.org/presentationml/2006/main">
-  <p:cSld name="Slide 12">
+  <p:cSld name="Slide 13">
     <p:spTree>
       <p:nvGrpSpPr>
         <p:cNvPr id="1" name=""/>
@@ -12582,9 +13085,9 @@
 </p:sld>
 </file>
 
-<file path=ppt/slides/slide13.xml><?xml version="1.0" encoding="utf-8"?>
+<file path=ppt/slides/slide14.xml><?xml version="1.0" encoding="utf-8"?>
 <p:sld xmlns:a="http://schemas.openxmlformats.org/drawingml/2006/main" xmlns:r="http://schemas.openxmlformats.org/officeDocument/2006/relationships" xmlns:p="http://schemas.openxmlformats.org/presentationml/2006/main">
-  <p:cSld name="Slide 13">
+  <p:cSld name="Slide 14">
     <p:spTree>
       <p:nvGrpSpPr>
         <p:cNvPr id="1" name=""/>
@@ -13522,9 +14025,9 @@
 </p:sld>
 </file>
 
-<file path=ppt/slides/slide14.xml><?xml version="1.0" encoding="utf-8"?>
+<file path=ppt/slides/slide15.xml><?xml version="1.0" encoding="utf-8"?>
 <p:sld xmlns:a="http://schemas.openxmlformats.org/drawingml/2006/main" xmlns:r="http://schemas.openxmlformats.org/officeDocument/2006/relationships" xmlns:p="http://schemas.openxmlformats.org/presentationml/2006/main">
-  <p:cSld name="Slide 14">
+  <p:cSld name="Slide 15">
     <p:spTree>
       <p:nvGrpSpPr>
         <p:cNvPr id="1" name=""/>
@@ -14546,9 +15049,9 @@
 </p:sld>
 </file>
 
-<file path=ppt/slides/slide15.xml><?xml version="1.0" encoding="utf-8"?>
+<file path=ppt/slides/slide16.xml><?xml version="1.0" encoding="utf-8"?>
 <p:sld xmlns:a="http://schemas.openxmlformats.org/drawingml/2006/main" xmlns:r="http://schemas.openxmlformats.org/officeDocument/2006/relationships" xmlns:p="http://schemas.openxmlformats.org/presentationml/2006/main">
-  <p:cSld name="Slide 15">
+  <p:cSld name="Slide 16">
     <p:spTree>
       <p:nvGrpSpPr>
         <p:cNvPr id="1" name=""/>
@@ -14657,7 +15160,7 @@
       </p:sp>
       <p:graphicFrame>
         <p:nvGraphicFramePr>
-          <p:cNvPr id="16" name="Table 0"/>
+          <p:cNvPr id="17" name="Table 0"/>
           <p:cNvGraphicFramePr>
             <a:graphicFrameLocks noGrp="1"/>
           </p:cNvGraphicFramePr>
@@ -16821,9 +17324,9 @@
 </p:sld>
 </file>
 
-<file path=ppt/slides/slide16.xml><?xml version="1.0" encoding="utf-8"?>
+<file path=ppt/slides/slide17.xml><?xml version="1.0" encoding="utf-8"?>
 <p:sld xmlns:a="http://schemas.openxmlformats.org/drawingml/2006/main" xmlns:r="http://schemas.openxmlformats.org/officeDocument/2006/relationships" xmlns:p="http://schemas.openxmlformats.org/presentationml/2006/main">
-  <p:cSld name="Slide 16">
+  <p:cSld name="Slide 17">
     <p:spTree>
       <p:nvGrpSpPr>
         <p:cNvPr id="1" name=""/>
@@ -17235,9 +17738,9 @@
 </p:sld>
 </file>
 
-<file path=ppt/slides/slide17.xml><?xml version="1.0" encoding="utf-8"?>
+<file path=ppt/slides/slide18.xml><?xml version="1.0" encoding="utf-8"?>
 <p:sld xmlns:a="http://schemas.openxmlformats.org/drawingml/2006/main" xmlns:r="http://schemas.openxmlformats.org/officeDocument/2006/relationships" xmlns:p="http://schemas.openxmlformats.org/presentationml/2006/main">
-  <p:cSld name="Slide 17">
+  <p:cSld name="Slide 18">
     <p:spTree>
       <p:nvGrpSpPr>
         <p:cNvPr id="1" name=""/>
@@ -17346,7 +17849,7 @@
       </p:sp>
       <p:graphicFrame>
         <p:nvGraphicFramePr>
-          <p:cNvPr id="18" name="Table 0"/>
+          <p:cNvPr id="19" name="Table 0"/>
           <p:cNvGraphicFramePr>
             <a:graphicFrameLocks noGrp="1"/>
           </p:cNvGraphicFramePr>
@@ -19089,7 +19592,7 @@
       </p:graphicFrame>
       <p:graphicFrame>
         <p:nvGraphicFramePr>
-          <p:cNvPr id="35" name="Table 1"/>
+          <p:cNvPr id="37" name="Table 1"/>
           <p:cNvGraphicFramePr>
             <a:graphicFrameLocks noGrp="1"/>
           </p:cNvGraphicFramePr>
@@ -19944,7 +20447,7 @@
       </p:graphicFrame>
       <p:graphicFrame>
         <p:nvGraphicFramePr>
-          <p:cNvPr id="52" name="Table 2"/>
+          <p:cNvPr id="55" name="Table 2"/>
           <p:cNvGraphicFramePr>
             <a:graphicFrameLocks noGrp="1"/>
           </p:cNvGraphicFramePr>
@@ -21562,9 +22065,9 @@
 </p:sld>
 </file>
 
-<file path=ppt/slides/slide18.xml><?xml version="1.0" encoding="utf-8"?>
+<file path=ppt/slides/slide19.xml><?xml version="1.0" encoding="utf-8"?>
 <p:sld xmlns:a="http://schemas.openxmlformats.org/drawingml/2006/main" xmlns:r="http://schemas.openxmlformats.org/officeDocument/2006/relationships" xmlns:p="http://schemas.openxmlformats.org/presentationml/2006/main">
-  <p:cSld name="Slide 18">
+  <p:cSld name="Slide 19">
     <p:spTree>
       <p:nvGrpSpPr>
         <p:cNvPr id="1" name=""/>
@@ -21976,9 +22479,987 @@
 </p:sld>
 </file>
 
-<file path=ppt/slides/slide19.xml><?xml version="1.0" encoding="utf-8"?>
+<file path=ppt/slides/slide2.xml><?xml version="1.0" encoding="utf-8"?>
 <p:sld xmlns:a="http://schemas.openxmlformats.org/drawingml/2006/main" xmlns:r="http://schemas.openxmlformats.org/officeDocument/2006/relationships" xmlns:p="http://schemas.openxmlformats.org/presentationml/2006/main">
-  <p:cSld name="Slide 19">
+  <p:cSld name="Slide 2">
+    <p:spTree>
+      <p:nvGrpSpPr>
+        <p:cNvPr id="1" name=""/>
+        <p:cNvGrpSpPr/>
+        <p:nvPr/>
+      </p:nvGrpSpPr>
+      <p:grpSpPr>
+        <a:xfrm>
+          <a:off x="0" y="0"/>
+          <a:ext cx="0" cy="0"/>
+          <a:chOff x="0" y="0"/>
+          <a:chExt cx="0" cy="0"/>
+        </a:xfrm>
+      </p:grpSpPr>
+      <p:sp>
+        <p:nvSpPr>
+          <p:cNvPr id="2" name="Text 0"/>
+          <p:cNvSpPr/>
+          <p:nvPr/>
+        </p:nvSpPr>
+        <p:spPr>
+          <a:xfrm>
+            <a:off x="548640" y="292608"/>
+            <a:ext cx="11064240" cy="274320"/>
+          </a:xfrm>
+          <a:prstGeom prst="rect">
+            <a:avLst/>
+          </a:prstGeom>
+          <a:noFill/>
+          <a:ln/>
+        </p:spPr>
+        <p:txBody>
+          <a:bodyPr wrap="square" lIns="0" tIns="0" rIns="0" bIns="0" rtlCol="0" anchor="ctr"/>
+          <a:lstStyle/>
+          <a:p>
+            <a:pPr indent="0" marL="0">
+              <a:buNone/>
+            </a:pPr>
+            <a:r>
+              <a:rPr lang="en-US" sz="1100" b="1" dirty="0">
+                <a:solidFill>
+                  <a:srgbClr val="86B332"/>
+                </a:solidFill>
+                <a:latin typeface="Calibri" pitchFamily="34" charset="0"/>
+                <a:ea typeface="Calibri" pitchFamily="34" charset="-122"/>
+                <a:cs typeface="Calibri" pitchFamily="34" charset="-120"/>
+              </a:rPr>
+              <a:t>— </a:t>
+            </a:r>
+            <a:pPr indent="0" marL="0">
+              <a:buNone/>
+            </a:pPr>
+            <a:r>
+              <a:rPr lang="en-US" sz="1100" b="1" spc="200" kern="0" dirty="0">
+                <a:solidFill>
+                  <a:srgbClr val="52514E"/>
+                </a:solidFill>
+                <a:latin typeface="Calibri" pitchFamily="34" charset="0"/>
+                <a:ea typeface="Calibri" pitchFamily="34" charset="-122"/>
+                <a:cs typeface="Calibri" pitchFamily="34" charset="-120"/>
+              </a:rPr>
+              <a:t>AGENDA</a:t>
+            </a:r>
+            <a:endParaRPr lang="en-US" sz="1100" dirty="0"/>
+          </a:p>
+        </p:txBody>
+      </p:sp>
+      <p:sp>
+        <p:nvSpPr>
+          <p:cNvPr id="3" name="Text 1"/>
+          <p:cNvSpPr/>
+          <p:nvPr/>
+        </p:nvSpPr>
+        <p:spPr>
+          <a:xfrm>
+            <a:off x="548640" y="548640"/>
+            <a:ext cx="11064240" cy="502920"/>
+          </a:xfrm>
+          <a:prstGeom prst="rect">
+            <a:avLst/>
+          </a:prstGeom>
+          <a:noFill/>
+          <a:ln/>
+        </p:spPr>
+        <p:txBody>
+          <a:bodyPr wrap="square" lIns="0" tIns="0" rIns="0" bIns="0" rtlCol="0" anchor="ctr"/>
+          <a:lstStyle/>
+          <a:p>
+            <a:pPr indent="0" marL="0">
+              <a:buNone/>
+            </a:pPr>
+            <a:r>
+              <a:rPr lang="en-US" sz="2700" b="1" dirty="0">
+                <a:solidFill>
+                  <a:srgbClr val="0B0B0B"/>
+                </a:solidFill>
+                <a:latin typeface="Calibri" pitchFamily="34" charset="0"/>
+                <a:ea typeface="Calibri" pitchFamily="34" charset="-122"/>
+                <a:cs typeface="Calibri" pitchFamily="34" charset="-120"/>
+              </a:rPr>
+              <a:t>What we'll cover</a:t>
+            </a:r>
+            <a:endParaRPr lang="en-US" sz="2700" dirty="0"/>
+          </a:p>
+        </p:txBody>
+      </p:sp>
+      <p:sp>
+        <p:nvSpPr>
+          <p:cNvPr id="4" name="Shape 2"/>
+          <p:cNvSpPr/>
+          <p:nvPr/>
+        </p:nvSpPr>
+        <p:spPr>
+          <a:xfrm>
+            <a:off x="548640" y="1481328"/>
+            <a:ext cx="402336" cy="402336"/>
+          </a:xfrm>
+          <a:prstGeom prst="ellipse">
+            <a:avLst/>
+          </a:prstGeom>
+          <a:solidFill>
+            <a:srgbClr val="2A78D6"/>
+          </a:solidFill>
+          <a:ln/>
+        </p:spPr>
+      </p:sp>
+      <p:sp>
+        <p:nvSpPr>
+          <p:cNvPr id="5" name="Text 3"/>
+          <p:cNvSpPr/>
+          <p:nvPr/>
+        </p:nvSpPr>
+        <p:spPr>
+          <a:xfrm>
+            <a:off x="548640" y="1481328"/>
+            <a:ext cx="402336" cy="402336"/>
+          </a:xfrm>
+          <a:prstGeom prst="rect">
+            <a:avLst/>
+          </a:prstGeom>
+          <a:noFill/>
+          <a:ln/>
+        </p:spPr>
+        <p:txBody>
+          <a:bodyPr wrap="square" lIns="0" tIns="0" rIns="0" bIns="0" rtlCol="0" anchor="ctr"/>
+          <a:lstStyle/>
+          <a:p>
+            <a:pPr algn="ctr" indent="0" marL="0">
+              <a:buNone/>
+            </a:pPr>
+            <a:r>
+              <a:rPr lang="en-US" sz="1500" b="1" dirty="0">
+                <a:solidFill>
+                  <a:srgbClr val="FFFFFF"/>
+                </a:solidFill>
+                <a:latin typeface="Calibri" pitchFamily="34" charset="0"/>
+                <a:ea typeface="Calibri" pitchFamily="34" charset="-122"/>
+                <a:cs typeface="Calibri" pitchFamily="34" charset="-120"/>
+              </a:rPr>
+              <a:t>1</a:t>
+            </a:r>
+            <a:endParaRPr lang="en-US" sz="1500" dirty="0"/>
+          </a:p>
+        </p:txBody>
+      </p:sp>
+      <p:sp>
+        <p:nvSpPr>
+          <p:cNvPr id="6" name="Text 4"/>
+          <p:cNvSpPr/>
+          <p:nvPr/>
+        </p:nvSpPr>
+        <p:spPr>
+          <a:xfrm>
+            <a:off x="1188720" y="1463040"/>
+            <a:ext cx="3383280" cy="411480"/>
+          </a:xfrm>
+          <a:prstGeom prst="rect">
+            <a:avLst/>
+          </a:prstGeom>
+          <a:noFill/>
+          <a:ln/>
+        </p:spPr>
+        <p:txBody>
+          <a:bodyPr wrap="square" lIns="0" tIns="0" rIns="0" bIns="0" rtlCol="0" anchor="ctr"/>
+          <a:lstStyle/>
+          <a:p>
+            <a:pPr indent="0" marL="0">
+              <a:buNone/>
+            </a:pPr>
+            <a:r>
+              <a:rPr lang="en-US" sz="1650" b="1" dirty="0">
+                <a:solidFill>
+                  <a:srgbClr val="0B0B0B"/>
+                </a:solidFill>
+                <a:latin typeface="Calibri" pitchFamily="34" charset="0"/>
+                <a:ea typeface="Calibri" pitchFamily="34" charset="-122"/>
+                <a:cs typeface="Calibri" pitchFamily="34" charset="-120"/>
+              </a:rPr>
+              <a:t>Where we stand</a:t>
+            </a:r>
+            <a:endParaRPr lang="en-US" sz="1650" dirty="0"/>
+          </a:p>
+        </p:txBody>
+      </p:sp>
+      <p:sp>
+        <p:nvSpPr>
+          <p:cNvPr id="7" name="Text 5"/>
+          <p:cNvSpPr/>
+          <p:nvPr/>
+        </p:nvSpPr>
+        <p:spPr>
+          <a:xfrm>
+            <a:off x="4754880" y="1463040"/>
+            <a:ext cx="6858000" cy="411480"/>
+          </a:xfrm>
+          <a:prstGeom prst="rect">
+            <a:avLst/>
+          </a:prstGeom>
+          <a:noFill/>
+          <a:ln/>
+        </p:spPr>
+        <p:txBody>
+          <a:bodyPr wrap="square" lIns="0" tIns="0" rIns="0" bIns="0" rtlCol="0" anchor="ctr"/>
+          <a:lstStyle/>
+          <a:p>
+            <a:pPr indent="0" marL="0">
+              <a:buNone/>
+            </a:pPr>
+            <a:r>
+              <a:rPr lang="en-US" sz="1200" dirty="0">
+                <a:solidFill>
+                  <a:srgbClr val="52514E"/>
+                </a:solidFill>
+                <a:latin typeface="Calibri" pitchFamily="34" charset="0"/>
+                <a:ea typeface="Calibri" pitchFamily="34" charset="-122"/>
+                <a:cs typeface="Calibri" pitchFamily="34" charset="-120"/>
+              </a:rPr>
+              <a:t>Executive summary · revenue vs plan &amp; prior year · gross margin vs budget · the rate ladder</a:t>
+            </a:r>
+            <a:endParaRPr lang="en-US" sz="1200" dirty="0"/>
+          </a:p>
+        </p:txBody>
+      </p:sp>
+      <p:sp>
+        <p:nvSpPr>
+          <p:cNvPr id="8" name="Shape 6"/>
+          <p:cNvSpPr/>
+          <p:nvPr/>
+        </p:nvSpPr>
+        <p:spPr>
+          <a:xfrm>
+            <a:off x="548640" y="2267712"/>
+            <a:ext cx="402336" cy="402336"/>
+          </a:xfrm>
+          <a:prstGeom prst="ellipse">
+            <a:avLst/>
+          </a:prstGeom>
+          <a:solidFill>
+            <a:srgbClr val="2A78D6"/>
+          </a:solidFill>
+          <a:ln/>
+        </p:spPr>
+      </p:sp>
+      <p:sp>
+        <p:nvSpPr>
+          <p:cNvPr id="9" name="Text 7"/>
+          <p:cNvSpPr/>
+          <p:nvPr/>
+        </p:nvSpPr>
+        <p:spPr>
+          <a:xfrm>
+            <a:off x="548640" y="2267712"/>
+            <a:ext cx="402336" cy="402336"/>
+          </a:xfrm>
+          <a:prstGeom prst="rect">
+            <a:avLst/>
+          </a:prstGeom>
+          <a:noFill/>
+          <a:ln/>
+        </p:spPr>
+        <p:txBody>
+          <a:bodyPr wrap="square" lIns="0" tIns="0" rIns="0" bIns="0" rtlCol="0" anchor="ctr"/>
+          <a:lstStyle/>
+          <a:p>
+            <a:pPr algn="ctr" indent="0" marL="0">
+              <a:buNone/>
+            </a:pPr>
+            <a:r>
+              <a:rPr lang="en-US" sz="1500" b="1" dirty="0">
+                <a:solidFill>
+                  <a:srgbClr val="FFFFFF"/>
+                </a:solidFill>
+                <a:latin typeface="Calibri" pitchFamily="34" charset="0"/>
+                <a:ea typeface="Calibri" pitchFamily="34" charset="-122"/>
+                <a:cs typeface="Calibri" pitchFamily="34" charset="-120"/>
+              </a:rPr>
+              <a:t>2</a:t>
+            </a:r>
+            <a:endParaRPr lang="en-US" sz="1500" dirty="0"/>
+          </a:p>
+        </p:txBody>
+      </p:sp>
+      <p:sp>
+        <p:nvSpPr>
+          <p:cNvPr id="10" name="Text 8"/>
+          <p:cNvSpPr/>
+          <p:nvPr/>
+        </p:nvSpPr>
+        <p:spPr>
+          <a:xfrm>
+            <a:off x="1188720" y="2249424"/>
+            <a:ext cx="3383280" cy="411480"/>
+          </a:xfrm>
+          <a:prstGeom prst="rect">
+            <a:avLst/>
+          </a:prstGeom>
+          <a:noFill/>
+          <a:ln/>
+        </p:spPr>
+        <p:txBody>
+          <a:bodyPr wrap="square" lIns="0" tIns="0" rIns="0" bIns="0" rtlCol="0" anchor="ctr"/>
+          <a:lstStyle/>
+          <a:p>
+            <a:pPr indent="0" marL="0">
+              <a:buNone/>
+            </a:pPr>
+            <a:r>
+              <a:rPr lang="en-US" sz="1650" b="1" dirty="0">
+                <a:solidFill>
+                  <a:srgbClr val="0B0B0B"/>
+                </a:solidFill>
+                <a:latin typeface="Calibri" pitchFamily="34" charset="0"/>
+                <a:ea typeface="Calibri" pitchFamily="34" charset="-122"/>
+                <a:cs typeface="Calibri" pitchFamily="34" charset="-120"/>
+              </a:rPr>
+              <a:t>Operating drivers</a:t>
+            </a:r>
+            <a:endParaRPr lang="en-US" sz="1650" dirty="0"/>
+          </a:p>
+        </p:txBody>
+      </p:sp>
+      <p:sp>
+        <p:nvSpPr>
+          <p:cNvPr id="11" name="Text 9"/>
+          <p:cNvSpPr/>
+          <p:nvPr/>
+        </p:nvSpPr>
+        <p:spPr>
+          <a:xfrm>
+            <a:off x="4754880" y="2249424"/>
+            <a:ext cx="6858000" cy="411480"/>
+          </a:xfrm>
+          <a:prstGeom prst="rect">
+            <a:avLst/>
+          </a:prstGeom>
+          <a:noFill/>
+          <a:ln/>
+        </p:spPr>
+        <p:txBody>
+          <a:bodyPr wrap="square" lIns="0" tIns="0" rIns="0" bIns="0" rtlCol="0" anchor="ctr"/>
+          <a:lstStyle/>
+          <a:p>
+            <a:pPr indent="0" marL="0">
+              <a:buNone/>
+            </a:pPr>
+            <a:r>
+              <a:rPr lang="en-US" sz="1200" dirty="0">
+                <a:solidFill>
+                  <a:srgbClr val="52514E"/>
+                </a:solidFill>
+                <a:latin typeface="Calibri" pitchFamily="34" charset="0"/>
+                <a:ea typeface="Calibri" pitchFamily="34" charset="-122"/>
+                <a:cs typeface="Calibri" pitchFamily="34" charset="-120"/>
+              </a:rPr>
+              <a:t>Staff &amp; headcount · utilization by person · sales by customer</a:t>
+            </a:r>
+            <a:endParaRPr lang="en-US" sz="1200" dirty="0"/>
+          </a:p>
+        </p:txBody>
+      </p:sp>
+      <p:sp>
+        <p:nvSpPr>
+          <p:cNvPr id="12" name="Shape 10"/>
+          <p:cNvSpPr/>
+          <p:nvPr/>
+        </p:nvSpPr>
+        <p:spPr>
+          <a:xfrm>
+            <a:off x="548640" y="3054096"/>
+            <a:ext cx="402336" cy="402336"/>
+          </a:xfrm>
+          <a:prstGeom prst="ellipse">
+            <a:avLst/>
+          </a:prstGeom>
+          <a:solidFill>
+            <a:srgbClr val="2A78D6"/>
+          </a:solidFill>
+          <a:ln/>
+        </p:spPr>
+      </p:sp>
+      <p:sp>
+        <p:nvSpPr>
+          <p:cNvPr id="13" name="Text 11"/>
+          <p:cNvSpPr/>
+          <p:nvPr/>
+        </p:nvSpPr>
+        <p:spPr>
+          <a:xfrm>
+            <a:off x="548640" y="3054096"/>
+            <a:ext cx="402336" cy="402336"/>
+          </a:xfrm>
+          <a:prstGeom prst="rect">
+            <a:avLst/>
+          </a:prstGeom>
+          <a:noFill/>
+          <a:ln/>
+        </p:spPr>
+        <p:txBody>
+          <a:bodyPr wrap="square" lIns="0" tIns="0" rIns="0" bIns="0" rtlCol="0" anchor="ctr"/>
+          <a:lstStyle/>
+          <a:p>
+            <a:pPr algn="ctr" indent="0" marL="0">
+              <a:buNone/>
+            </a:pPr>
+            <a:r>
+              <a:rPr lang="en-US" sz="1500" b="1" dirty="0">
+                <a:solidFill>
+                  <a:srgbClr val="FFFFFF"/>
+                </a:solidFill>
+                <a:latin typeface="Calibri" pitchFamily="34" charset="0"/>
+                <a:ea typeface="Calibri" pitchFamily="34" charset="-122"/>
+                <a:cs typeface="Calibri" pitchFamily="34" charset="-120"/>
+              </a:rPr>
+              <a:t>3</a:t>
+            </a:r>
+            <a:endParaRPr lang="en-US" sz="1500" dirty="0"/>
+          </a:p>
+        </p:txBody>
+      </p:sp>
+      <p:sp>
+        <p:nvSpPr>
+          <p:cNvPr id="14" name="Text 12"/>
+          <p:cNvSpPr/>
+          <p:nvPr/>
+        </p:nvSpPr>
+        <p:spPr>
+          <a:xfrm>
+            <a:off x="1188720" y="3035808"/>
+            <a:ext cx="3383280" cy="411480"/>
+          </a:xfrm>
+          <a:prstGeom prst="rect">
+            <a:avLst/>
+          </a:prstGeom>
+          <a:noFill/>
+          <a:ln/>
+        </p:spPr>
+        <p:txBody>
+          <a:bodyPr wrap="square" lIns="0" tIns="0" rIns="0" bIns="0" rtlCol="0" anchor="ctr"/>
+          <a:lstStyle/>
+          <a:p>
+            <a:pPr indent="0" marL="0">
+              <a:buNone/>
+            </a:pPr>
+            <a:r>
+              <a:rPr lang="en-US" sz="1650" b="1" dirty="0">
+                <a:solidFill>
+                  <a:srgbClr val="0B0B0B"/>
+                </a:solidFill>
+                <a:latin typeface="Calibri" pitchFamily="34" charset="0"/>
+                <a:ea typeface="Calibri" pitchFamily="34" charset="-122"/>
+                <a:cs typeface="Calibri" pitchFamily="34" charset="-120"/>
+              </a:rPr>
+              <a:t>Work in hand &amp; work to win</a:t>
+            </a:r>
+            <a:endParaRPr lang="en-US" sz="1650" dirty="0"/>
+          </a:p>
+        </p:txBody>
+      </p:sp>
+      <p:sp>
+        <p:nvSpPr>
+          <p:cNvPr id="15" name="Text 13"/>
+          <p:cNvSpPr/>
+          <p:nvPr/>
+        </p:nvSpPr>
+        <p:spPr>
+          <a:xfrm>
+            <a:off x="4754880" y="3035808"/>
+            <a:ext cx="6858000" cy="411480"/>
+          </a:xfrm>
+          <a:prstGeom prst="rect">
+            <a:avLst/>
+          </a:prstGeom>
+          <a:noFill/>
+          <a:ln/>
+        </p:spPr>
+        <p:txBody>
+          <a:bodyPr wrap="square" lIns="0" tIns="0" rIns="0" bIns="0" rtlCol="0" anchor="ctr"/>
+          <a:lstStyle/>
+          <a:p>
+            <a:pPr indent="0" marL="0">
+              <a:buNone/>
+            </a:pPr>
+            <a:r>
+              <a:rPr lang="en-US" sz="1200" dirty="0">
+                <a:solidFill>
+                  <a:srgbClr val="52514E"/>
+                </a:solidFill>
+                <a:latin typeface="Calibri" pitchFamily="34" charset="0"/>
+                <a:ea typeface="Calibri" pitchFamily="34" charset="-122"/>
+                <a:cs typeface="Calibri" pitchFamily="34" charset="-120"/>
+              </a:rPr>
+              <a:t>Backlog on active jobs · known pipeline opportunities</a:t>
+            </a:r>
+            <a:endParaRPr lang="en-US" sz="1200" dirty="0"/>
+          </a:p>
+        </p:txBody>
+      </p:sp>
+      <p:sp>
+        <p:nvSpPr>
+          <p:cNvPr id="16" name="Shape 14"/>
+          <p:cNvSpPr/>
+          <p:nvPr/>
+        </p:nvSpPr>
+        <p:spPr>
+          <a:xfrm>
+            <a:off x="548640" y="3840480"/>
+            <a:ext cx="402336" cy="402336"/>
+          </a:xfrm>
+          <a:prstGeom prst="ellipse">
+            <a:avLst/>
+          </a:prstGeom>
+          <a:solidFill>
+            <a:srgbClr val="2A78D6"/>
+          </a:solidFill>
+          <a:ln/>
+        </p:spPr>
+      </p:sp>
+      <p:sp>
+        <p:nvSpPr>
+          <p:cNvPr id="17" name="Text 15"/>
+          <p:cNvSpPr/>
+          <p:nvPr/>
+        </p:nvSpPr>
+        <p:spPr>
+          <a:xfrm>
+            <a:off x="548640" y="3840480"/>
+            <a:ext cx="402336" cy="402336"/>
+          </a:xfrm>
+          <a:prstGeom prst="rect">
+            <a:avLst/>
+          </a:prstGeom>
+          <a:noFill/>
+          <a:ln/>
+        </p:spPr>
+        <p:txBody>
+          <a:bodyPr wrap="square" lIns="0" tIns="0" rIns="0" bIns="0" rtlCol="0" anchor="ctr"/>
+          <a:lstStyle/>
+          <a:p>
+            <a:pPr algn="ctr" indent="0" marL="0">
+              <a:buNone/>
+            </a:pPr>
+            <a:r>
+              <a:rPr lang="en-US" sz="1500" b="1" dirty="0">
+                <a:solidFill>
+                  <a:srgbClr val="FFFFFF"/>
+                </a:solidFill>
+                <a:latin typeface="Calibri" pitchFamily="34" charset="0"/>
+                <a:ea typeface="Calibri" pitchFamily="34" charset="-122"/>
+                <a:cs typeface="Calibri" pitchFamily="34" charset="-120"/>
+              </a:rPr>
+              <a:t>4</a:t>
+            </a:r>
+            <a:endParaRPr lang="en-US" sz="1500" dirty="0"/>
+          </a:p>
+        </p:txBody>
+      </p:sp>
+      <p:sp>
+        <p:nvSpPr>
+          <p:cNvPr id="18" name="Text 16"/>
+          <p:cNvSpPr/>
+          <p:nvPr/>
+        </p:nvSpPr>
+        <p:spPr>
+          <a:xfrm>
+            <a:off x="1188720" y="3822192"/>
+            <a:ext cx="3383280" cy="411480"/>
+          </a:xfrm>
+          <a:prstGeom prst="rect">
+            <a:avLst/>
+          </a:prstGeom>
+          <a:noFill/>
+          <a:ln/>
+        </p:spPr>
+        <p:txBody>
+          <a:bodyPr wrap="square" lIns="0" tIns="0" rIns="0" bIns="0" rtlCol="0" anchor="ctr"/>
+          <a:lstStyle/>
+          <a:p>
+            <a:pPr indent="0" marL="0">
+              <a:buNone/>
+            </a:pPr>
+            <a:r>
+              <a:rPr lang="en-US" sz="1650" b="1" dirty="0">
+                <a:solidFill>
+                  <a:srgbClr val="0B0B0B"/>
+                </a:solidFill>
+                <a:latin typeface="Calibri" pitchFamily="34" charset="0"/>
+                <a:ea typeface="Calibri" pitchFamily="34" charset="-122"/>
+                <a:cs typeface="Calibri" pitchFamily="34" charset="-120"/>
+              </a:rPr>
+              <a:t>Strategy</a:t>
+            </a:r>
+            <a:endParaRPr lang="en-US" sz="1650" dirty="0"/>
+          </a:p>
+        </p:txBody>
+      </p:sp>
+      <p:sp>
+        <p:nvSpPr>
+          <p:cNvPr id="19" name="Text 17"/>
+          <p:cNvSpPr/>
+          <p:nvPr/>
+        </p:nvSpPr>
+        <p:spPr>
+          <a:xfrm>
+            <a:off x="4754880" y="3822192"/>
+            <a:ext cx="6858000" cy="411480"/>
+          </a:xfrm>
+          <a:prstGeom prst="rect">
+            <a:avLst/>
+          </a:prstGeom>
+          <a:noFill/>
+          <a:ln/>
+        </p:spPr>
+        <p:txBody>
+          <a:bodyPr wrap="square" lIns="0" tIns="0" rIns="0" bIns="0" rtlCol="0" anchor="ctr"/>
+          <a:lstStyle/>
+          <a:p>
+            <a:pPr indent="0" marL="0">
+              <a:buNone/>
+            </a:pPr>
+            <a:r>
+              <a:rPr lang="en-US" sz="1200" dirty="0">
+                <a:solidFill>
+                  <a:srgbClr val="52514E"/>
+                </a:solidFill>
+                <a:latin typeface="Calibri" pitchFamily="34" charset="0"/>
+                <a:ea typeface="Calibri" pitchFamily="34" charset="-122"/>
+                <a:cs typeface="Calibri" pitchFamily="34" charset="-120"/>
+              </a:rPr>
+              <a:t>One pursuit engine with HWC Estimating · the consolidated EPC offering · the addressable market · BD account ownership</a:t>
+            </a:r>
+            <a:endParaRPr lang="en-US" sz="1200" dirty="0"/>
+          </a:p>
+        </p:txBody>
+      </p:sp>
+      <p:sp>
+        <p:nvSpPr>
+          <p:cNvPr id="20" name="Shape 18"/>
+          <p:cNvSpPr/>
+          <p:nvPr/>
+        </p:nvSpPr>
+        <p:spPr>
+          <a:xfrm>
+            <a:off x="548640" y="4626864"/>
+            <a:ext cx="402336" cy="402336"/>
+          </a:xfrm>
+          <a:prstGeom prst="ellipse">
+            <a:avLst/>
+          </a:prstGeom>
+          <a:solidFill>
+            <a:srgbClr val="2A78D6"/>
+          </a:solidFill>
+          <a:ln/>
+        </p:spPr>
+      </p:sp>
+      <p:sp>
+        <p:nvSpPr>
+          <p:cNvPr id="21" name="Text 19"/>
+          <p:cNvSpPr/>
+          <p:nvPr/>
+        </p:nvSpPr>
+        <p:spPr>
+          <a:xfrm>
+            <a:off x="548640" y="4626864"/>
+            <a:ext cx="402336" cy="402336"/>
+          </a:xfrm>
+          <a:prstGeom prst="rect">
+            <a:avLst/>
+          </a:prstGeom>
+          <a:noFill/>
+          <a:ln/>
+        </p:spPr>
+        <p:txBody>
+          <a:bodyPr wrap="square" lIns="0" tIns="0" rIns="0" bIns="0" rtlCol="0" anchor="ctr"/>
+          <a:lstStyle/>
+          <a:p>
+            <a:pPr algn="ctr" indent="0" marL="0">
+              <a:buNone/>
+            </a:pPr>
+            <a:r>
+              <a:rPr lang="en-US" sz="1500" b="1" dirty="0">
+                <a:solidFill>
+                  <a:srgbClr val="FFFFFF"/>
+                </a:solidFill>
+                <a:latin typeface="Calibri" pitchFamily="34" charset="0"/>
+                <a:ea typeface="Calibri" pitchFamily="34" charset="-122"/>
+                <a:cs typeface="Calibri" pitchFamily="34" charset="-120"/>
+              </a:rPr>
+              <a:t>5</a:t>
+            </a:r>
+            <a:endParaRPr lang="en-US" sz="1500" dirty="0"/>
+          </a:p>
+        </p:txBody>
+      </p:sp>
+      <p:sp>
+        <p:nvSpPr>
+          <p:cNvPr id="22" name="Text 20"/>
+          <p:cNvSpPr/>
+          <p:nvPr/>
+        </p:nvSpPr>
+        <p:spPr>
+          <a:xfrm>
+            <a:off x="1188720" y="4608576"/>
+            <a:ext cx="3383280" cy="411480"/>
+          </a:xfrm>
+          <a:prstGeom prst="rect">
+            <a:avLst/>
+          </a:prstGeom>
+          <a:noFill/>
+          <a:ln/>
+        </p:spPr>
+        <p:txBody>
+          <a:bodyPr wrap="square" lIns="0" tIns="0" rIns="0" bIns="0" rtlCol="0" anchor="ctr"/>
+          <a:lstStyle/>
+          <a:p>
+            <a:pPr indent="0" marL="0">
+              <a:buNone/>
+            </a:pPr>
+            <a:r>
+              <a:rPr lang="en-US" sz="1650" b="1" dirty="0">
+                <a:solidFill>
+                  <a:srgbClr val="0B0B0B"/>
+                </a:solidFill>
+                <a:latin typeface="Calibri" pitchFamily="34" charset="0"/>
+                <a:ea typeface="Calibri" pitchFamily="34" charset="-122"/>
+                <a:cs typeface="Calibri" pitchFamily="34" charset="-120"/>
+              </a:rPr>
+              <a:t>Forward view</a:t>
+            </a:r>
+            <a:endParaRPr lang="en-US" sz="1650" dirty="0"/>
+          </a:p>
+        </p:txBody>
+      </p:sp>
+      <p:sp>
+        <p:nvSpPr>
+          <p:cNvPr id="23" name="Text 21"/>
+          <p:cNvSpPr/>
+          <p:nvPr/>
+        </p:nvSpPr>
+        <p:spPr>
+          <a:xfrm>
+            <a:off x="4754880" y="4608576"/>
+            <a:ext cx="6858000" cy="411480"/>
+          </a:xfrm>
+          <a:prstGeom prst="rect">
+            <a:avLst/>
+          </a:prstGeom>
+          <a:noFill/>
+          <a:ln/>
+        </p:spPr>
+        <p:txBody>
+          <a:bodyPr wrap="square" lIns="0" tIns="0" rIns="0" bIns="0" rtlCol="0" anchor="ctr"/>
+          <a:lstStyle/>
+          <a:p>
+            <a:pPr indent="0" marL="0">
+              <a:buNone/>
+            </a:pPr>
+            <a:r>
+              <a:rPr lang="en-US" sz="1200" dirty="0">
+                <a:solidFill>
+                  <a:srgbClr val="52514E"/>
+                </a:solidFill>
+                <a:latin typeface="Calibri" pitchFamily="34" charset="0"/>
+                <a:ea typeface="Calibri" pitchFamily="34" charset="-122"/>
+                <a:cs typeface="Calibri" pitchFamily="34" charset="-120"/>
+              </a:rPr>
+              <a:t>Forecast &amp; coverage · FY2026 landing and FY2027 scenarios · cash &amp; the parent note</a:t>
+            </a:r>
+            <a:endParaRPr lang="en-US" sz="1200" dirty="0"/>
+          </a:p>
+        </p:txBody>
+      </p:sp>
+      <p:sp>
+        <p:nvSpPr>
+          <p:cNvPr id="24" name="Shape 22"/>
+          <p:cNvSpPr/>
+          <p:nvPr/>
+        </p:nvSpPr>
+        <p:spPr>
+          <a:xfrm>
+            <a:off x="548640" y="5413248"/>
+            <a:ext cx="402336" cy="402336"/>
+          </a:xfrm>
+          <a:prstGeom prst="ellipse">
+            <a:avLst/>
+          </a:prstGeom>
+          <a:solidFill>
+            <a:srgbClr val="2A78D6"/>
+          </a:solidFill>
+          <a:ln/>
+        </p:spPr>
+      </p:sp>
+      <p:sp>
+        <p:nvSpPr>
+          <p:cNvPr id="25" name="Text 23"/>
+          <p:cNvSpPr/>
+          <p:nvPr/>
+        </p:nvSpPr>
+        <p:spPr>
+          <a:xfrm>
+            <a:off x="548640" y="5413248"/>
+            <a:ext cx="402336" cy="402336"/>
+          </a:xfrm>
+          <a:prstGeom prst="rect">
+            <a:avLst/>
+          </a:prstGeom>
+          <a:noFill/>
+          <a:ln/>
+        </p:spPr>
+        <p:txBody>
+          <a:bodyPr wrap="square" lIns="0" tIns="0" rIns="0" bIns="0" rtlCol="0" anchor="ctr"/>
+          <a:lstStyle/>
+          <a:p>
+            <a:pPr algn="ctr" indent="0" marL="0">
+              <a:buNone/>
+            </a:pPr>
+            <a:r>
+              <a:rPr lang="en-US" sz="1500" b="1" dirty="0">
+                <a:solidFill>
+                  <a:srgbClr val="FFFFFF"/>
+                </a:solidFill>
+                <a:latin typeface="Calibri" pitchFamily="34" charset="0"/>
+                <a:ea typeface="Calibri" pitchFamily="34" charset="-122"/>
+                <a:cs typeface="Calibri" pitchFamily="34" charset="-120"/>
+              </a:rPr>
+              <a:t>6</a:t>
+            </a:r>
+            <a:endParaRPr lang="en-US" sz="1500" dirty="0"/>
+          </a:p>
+        </p:txBody>
+      </p:sp>
+      <p:sp>
+        <p:nvSpPr>
+          <p:cNvPr id="26" name="Text 24"/>
+          <p:cNvSpPr/>
+          <p:nvPr/>
+        </p:nvSpPr>
+        <p:spPr>
+          <a:xfrm>
+            <a:off x="1188720" y="5394960"/>
+            <a:ext cx="3383280" cy="411480"/>
+          </a:xfrm>
+          <a:prstGeom prst="rect">
+            <a:avLst/>
+          </a:prstGeom>
+          <a:noFill/>
+          <a:ln/>
+        </p:spPr>
+        <p:txBody>
+          <a:bodyPr wrap="square" lIns="0" tIns="0" rIns="0" bIns="0" rtlCol="0" anchor="ctr"/>
+          <a:lstStyle/>
+          <a:p>
+            <a:pPr indent="0" marL="0">
+              <a:buNone/>
+            </a:pPr>
+            <a:r>
+              <a:rPr lang="en-US" sz="1650" b="1" dirty="0">
+                <a:solidFill>
+                  <a:srgbClr val="0B0B0B"/>
+                </a:solidFill>
+                <a:latin typeface="Calibri" pitchFamily="34" charset="0"/>
+                <a:ea typeface="Calibri" pitchFamily="34" charset="-122"/>
+                <a:cs typeface="Calibri" pitchFamily="34" charset="-120"/>
+              </a:rPr>
+              <a:t>Next 90 days</a:t>
+            </a:r>
+            <a:endParaRPr lang="en-US" sz="1650" dirty="0"/>
+          </a:p>
+        </p:txBody>
+      </p:sp>
+      <p:sp>
+        <p:nvSpPr>
+          <p:cNvPr id="27" name="Text 25"/>
+          <p:cNvSpPr/>
+          <p:nvPr/>
+        </p:nvSpPr>
+        <p:spPr>
+          <a:xfrm>
+            <a:off x="4754880" y="5394960"/>
+            <a:ext cx="6858000" cy="411480"/>
+          </a:xfrm>
+          <a:prstGeom prst="rect">
+            <a:avLst/>
+          </a:prstGeom>
+          <a:noFill/>
+          <a:ln/>
+        </p:spPr>
+        <p:txBody>
+          <a:bodyPr wrap="square" lIns="0" tIns="0" rIns="0" bIns="0" rtlCol="0" anchor="ctr"/>
+          <a:lstStyle/>
+          <a:p>
+            <a:pPr indent="0" marL="0">
+              <a:buNone/>
+            </a:pPr>
+            <a:r>
+              <a:rPr lang="en-US" sz="1200" dirty="0">
+                <a:solidFill>
+                  <a:srgbClr val="52514E"/>
+                </a:solidFill>
+                <a:latin typeface="Calibri" pitchFamily="34" charset="0"/>
+                <a:ea typeface="Calibri" pitchFamily="34" charset="-122"/>
+                <a:cs typeface="Calibri" pitchFamily="34" charset="-120"/>
+              </a:rPr>
+              <a:t>Priorities: realization, utilization, the Q4 pipeline, and the monthly rhythm</a:t>
+            </a:r>
+            <a:endParaRPr lang="en-US" sz="1200" dirty="0"/>
+          </a:p>
+        </p:txBody>
+      </p:sp>
+      <p:sp>
+        <p:nvSpPr>
+          <p:cNvPr id="28" name="Text 26"/>
+          <p:cNvSpPr/>
+          <p:nvPr/>
+        </p:nvSpPr>
+        <p:spPr>
+          <a:xfrm>
+            <a:off x="548640" y="6419088"/>
+            <a:ext cx="11064240" cy="320040"/>
+          </a:xfrm>
+          <a:prstGeom prst="rect">
+            <a:avLst/>
+          </a:prstGeom>
+          <a:noFill/>
+          <a:ln/>
+        </p:spPr>
+        <p:txBody>
+          <a:bodyPr wrap="square" lIns="0" tIns="0" rIns="0" bIns="0" rtlCol="0" anchor="ctr"/>
+          <a:lstStyle/>
+          <a:p>
+            <a:pPr indent="0" marL="0">
+              <a:buNone/>
+            </a:pPr>
+            <a:r>
+              <a:rPr lang="en-US" sz="950" dirty="0">
+                <a:solidFill>
+                  <a:srgbClr val="898781"/>
+                </a:solidFill>
+                <a:latin typeface="Calibri" pitchFamily="34" charset="0"/>
+                <a:ea typeface="Calibri" pitchFamily="34" charset="-122"/>
+                <a:cs typeface="Calibri" pitchFamily="34" charset="-120"/>
+              </a:rPr>
+              <a:t>CVR Engineering financial review &amp; forecast · June 2026</a:t>
+            </a:r>
+            <a:endParaRPr lang="en-US" sz="950" dirty="0"/>
+          </a:p>
+        </p:txBody>
+      </p:sp>
+    </p:spTree>
+  </p:cSld>
+  <p:clrMapOvr>
+    <a:masterClrMapping/>
+  </p:clrMapOvr>
+</p:sld>
+</file>
+
+<file path=ppt/slides/slide20.xml><?xml version="1.0" encoding="utf-8"?>
+<p:sld xmlns:a="http://schemas.openxmlformats.org/drawingml/2006/main" xmlns:r="http://schemas.openxmlformats.org/officeDocument/2006/relationships" xmlns:p="http://schemas.openxmlformats.org/presentationml/2006/main">
+  <p:cSld name="Slide 20">
     <p:spTree>
       <p:nvGrpSpPr>
         <p:cNvPr id="1" name=""/>
@@ -23075,987 +24556,9 @@
 </p:sld>
 </file>
 
-<file path=ppt/slides/slide2.xml><?xml version="1.0" encoding="utf-8"?>
+<file path=ppt/slides/slide21.xml><?xml version="1.0" encoding="utf-8"?>
 <p:sld xmlns:a="http://schemas.openxmlformats.org/drawingml/2006/main" xmlns:r="http://schemas.openxmlformats.org/officeDocument/2006/relationships" xmlns:p="http://schemas.openxmlformats.org/presentationml/2006/main">
-  <p:cSld name="Slide 2">
-    <p:spTree>
-      <p:nvGrpSpPr>
-        <p:cNvPr id="1" name=""/>
-        <p:cNvGrpSpPr/>
-        <p:nvPr/>
-      </p:nvGrpSpPr>
-      <p:grpSpPr>
-        <a:xfrm>
-          <a:off x="0" y="0"/>
-          <a:ext cx="0" cy="0"/>
-          <a:chOff x="0" y="0"/>
-          <a:chExt cx="0" cy="0"/>
-        </a:xfrm>
-      </p:grpSpPr>
-      <p:sp>
-        <p:nvSpPr>
-          <p:cNvPr id="2" name="Text 0"/>
-          <p:cNvSpPr/>
-          <p:nvPr/>
-        </p:nvSpPr>
-        <p:spPr>
-          <a:xfrm>
-            <a:off x="548640" y="292608"/>
-            <a:ext cx="11064240" cy="274320"/>
-          </a:xfrm>
-          <a:prstGeom prst="rect">
-            <a:avLst/>
-          </a:prstGeom>
-          <a:noFill/>
-          <a:ln/>
-        </p:spPr>
-        <p:txBody>
-          <a:bodyPr wrap="square" lIns="0" tIns="0" rIns="0" bIns="0" rtlCol="0" anchor="ctr"/>
-          <a:lstStyle/>
-          <a:p>
-            <a:pPr indent="0" marL="0">
-              <a:buNone/>
-            </a:pPr>
-            <a:r>
-              <a:rPr lang="en-US" sz="1100" b="1" dirty="0">
-                <a:solidFill>
-                  <a:srgbClr val="86B332"/>
-                </a:solidFill>
-                <a:latin typeface="Calibri" pitchFamily="34" charset="0"/>
-                <a:ea typeface="Calibri" pitchFamily="34" charset="-122"/>
-                <a:cs typeface="Calibri" pitchFamily="34" charset="-120"/>
-              </a:rPr>
-              <a:t>— </a:t>
-            </a:r>
-            <a:pPr indent="0" marL="0">
-              <a:buNone/>
-            </a:pPr>
-            <a:r>
-              <a:rPr lang="en-US" sz="1100" b="1" spc="200" kern="0" dirty="0">
-                <a:solidFill>
-                  <a:srgbClr val="52514E"/>
-                </a:solidFill>
-                <a:latin typeface="Calibri" pitchFamily="34" charset="0"/>
-                <a:ea typeface="Calibri" pitchFamily="34" charset="-122"/>
-                <a:cs typeface="Calibri" pitchFamily="34" charset="-120"/>
-              </a:rPr>
-              <a:t>AGENDA</a:t>
-            </a:r>
-            <a:endParaRPr lang="en-US" sz="1100" dirty="0"/>
-          </a:p>
-        </p:txBody>
-      </p:sp>
-      <p:sp>
-        <p:nvSpPr>
-          <p:cNvPr id="3" name="Text 1"/>
-          <p:cNvSpPr/>
-          <p:nvPr/>
-        </p:nvSpPr>
-        <p:spPr>
-          <a:xfrm>
-            <a:off x="548640" y="548640"/>
-            <a:ext cx="11064240" cy="502920"/>
-          </a:xfrm>
-          <a:prstGeom prst="rect">
-            <a:avLst/>
-          </a:prstGeom>
-          <a:noFill/>
-          <a:ln/>
-        </p:spPr>
-        <p:txBody>
-          <a:bodyPr wrap="square" lIns="0" tIns="0" rIns="0" bIns="0" rtlCol="0" anchor="ctr"/>
-          <a:lstStyle/>
-          <a:p>
-            <a:pPr indent="0" marL="0">
-              <a:buNone/>
-            </a:pPr>
-            <a:r>
-              <a:rPr lang="en-US" sz="2700" b="1" dirty="0">
-                <a:solidFill>
-                  <a:srgbClr val="0B0B0B"/>
-                </a:solidFill>
-                <a:latin typeface="Calibri" pitchFamily="34" charset="0"/>
-                <a:ea typeface="Calibri" pitchFamily="34" charset="-122"/>
-                <a:cs typeface="Calibri" pitchFamily="34" charset="-120"/>
-              </a:rPr>
-              <a:t>What we'll cover</a:t>
-            </a:r>
-            <a:endParaRPr lang="en-US" sz="2700" dirty="0"/>
-          </a:p>
-        </p:txBody>
-      </p:sp>
-      <p:sp>
-        <p:nvSpPr>
-          <p:cNvPr id="4" name="Shape 2"/>
-          <p:cNvSpPr/>
-          <p:nvPr/>
-        </p:nvSpPr>
-        <p:spPr>
-          <a:xfrm>
-            <a:off x="548640" y="1481328"/>
-            <a:ext cx="402336" cy="402336"/>
-          </a:xfrm>
-          <a:prstGeom prst="ellipse">
-            <a:avLst/>
-          </a:prstGeom>
-          <a:solidFill>
-            <a:srgbClr val="2A78D6"/>
-          </a:solidFill>
-          <a:ln/>
-        </p:spPr>
-      </p:sp>
-      <p:sp>
-        <p:nvSpPr>
-          <p:cNvPr id="5" name="Text 3"/>
-          <p:cNvSpPr/>
-          <p:nvPr/>
-        </p:nvSpPr>
-        <p:spPr>
-          <a:xfrm>
-            <a:off x="548640" y="1481328"/>
-            <a:ext cx="402336" cy="402336"/>
-          </a:xfrm>
-          <a:prstGeom prst="rect">
-            <a:avLst/>
-          </a:prstGeom>
-          <a:noFill/>
-          <a:ln/>
-        </p:spPr>
-        <p:txBody>
-          <a:bodyPr wrap="square" lIns="0" tIns="0" rIns="0" bIns="0" rtlCol="0" anchor="ctr"/>
-          <a:lstStyle/>
-          <a:p>
-            <a:pPr algn="ctr" indent="0" marL="0">
-              <a:buNone/>
-            </a:pPr>
-            <a:r>
-              <a:rPr lang="en-US" sz="1500" b="1" dirty="0">
-                <a:solidFill>
-                  <a:srgbClr val="FFFFFF"/>
-                </a:solidFill>
-                <a:latin typeface="Calibri" pitchFamily="34" charset="0"/>
-                <a:ea typeface="Calibri" pitchFamily="34" charset="-122"/>
-                <a:cs typeface="Calibri" pitchFamily="34" charset="-120"/>
-              </a:rPr>
-              <a:t>1</a:t>
-            </a:r>
-            <a:endParaRPr lang="en-US" sz="1500" dirty="0"/>
-          </a:p>
-        </p:txBody>
-      </p:sp>
-      <p:sp>
-        <p:nvSpPr>
-          <p:cNvPr id="6" name="Text 4"/>
-          <p:cNvSpPr/>
-          <p:nvPr/>
-        </p:nvSpPr>
-        <p:spPr>
-          <a:xfrm>
-            <a:off x="1188720" y="1463040"/>
-            <a:ext cx="3383280" cy="411480"/>
-          </a:xfrm>
-          <a:prstGeom prst="rect">
-            <a:avLst/>
-          </a:prstGeom>
-          <a:noFill/>
-          <a:ln/>
-        </p:spPr>
-        <p:txBody>
-          <a:bodyPr wrap="square" lIns="0" tIns="0" rIns="0" bIns="0" rtlCol="0" anchor="ctr"/>
-          <a:lstStyle/>
-          <a:p>
-            <a:pPr indent="0" marL="0">
-              <a:buNone/>
-            </a:pPr>
-            <a:r>
-              <a:rPr lang="en-US" sz="1650" b="1" dirty="0">
-                <a:solidFill>
-                  <a:srgbClr val="0B0B0B"/>
-                </a:solidFill>
-                <a:latin typeface="Calibri" pitchFamily="34" charset="0"/>
-                <a:ea typeface="Calibri" pitchFamily="34" charset="-122"/>
-                <a:cs typeface="Calibri" pitchFamily="34" charset="-120"/>
-              </a:rPr>
-              <a:t>Where we stand</a:t>
-            </a:r>
-            <a:endParaRPr lang="en-US" sz="1650" dirty="0"/>
-          </a:p>
-        </p:txBody>
-      </p:sp>
-      <p:sp>
-        <p:nvSpPr>
-          <p:cNvPr id="7" name="Text 5"/>
-          <p:cNvSpPr/>
-          <p:nvPr/>
-        </p:nvSpPr>
-        <p:spPr>
-          <a:xfrm>
-            <a:off x="4754880" y="1463040"/>
-            <a:ext cx="6858000" cy="411480"/>
-          </a:xfrm>
-          <a:prstGeom prst="rect">
-            <a:avLst/>
-          </a:prstGeom>
-          <a:noFill/>
-          <a:ln/>
-        </p:spPr>
-        <p:txBody>
-          <a:bodyPr wrap="square" lIns="0" tIns="0" rIns="0" bIns="0" rtlCol="0" anchor="ctr"/>
-          <a:lstStyle/>
-          <a:p>
-            <a:pPr indent="0" marL="0">
-              <a:buNone/>
-            </a:pPr>
-            <a:r>
-              <a:rPr lang="en-US" sz="1200" dirty="0">
-                <a:solidFill>
-                  <a:srgbClr val="52514E"/>
-                </a:solidFill>
-                <a:latin typeface="Calibri" pitchFamily="34" charset="0"/>
-                <a:ea typeface="Calibri" pitchFamily="34" charset="-122"/>
-                <a:cs typeface="Calibri" pitchFamily="34" charset="-120"/>
-              </a:rPr>
-              <a:t>Executive summary · revenue vs plan &amp; prior year · gross margin vs budget · the rate ladder</a:t>
-            </a:r>
-            <a:endParaRPr lang="en-US" sz="1200" dirty="0"/>
-          </a:p>
-        </p:txBody>
-      </p:sp>
-      <p:sp>
-        <p:nvSpPr>
-          <p:cNvPr id="8" name="Shape 6"/>
-          <p:cNvSpPr/>
-          <p:nvPr/>
-        </p:nvSpPr>
-        <p:spPr>
-          <a:xfrm>
-            <a:off x="548640" y="2267712"/>
-            <a:ext cx="402336" cy="402336"/>
-          </a:xfrm>
-          <a:prstGeom prst="ellipse">
-            <a:avLst/>
-          </a:prstGeom>
-          <a:solidFill>
-            <a:srgbClr val="2A78D6"/>
-          </a:solidFill>
-          <a:ln/>
-        </p:spPr>
-      </p:sp>
-      <p:sp>
-        <p:nvSpPr>
-          <p:cNvPr id="9" name="Text 7"/>
-          <p:cNvSpPr/>
-          <p:nvPr/>
-        </p:nvSpPr>
-        <p:spPr>
-          <a:xfrm>
-            <a:off x="548640" y="2267712"/>
-            <a:ext cx="402336" cy="402336"/>
-          </a:xfrm>
-          <a:prstGeom prst="rect">
-            <a:avLst/>
-          </a:prstGeom>
-          <a:noFill/>
-          <a:ln/>
-        </p:spPr>
-        <p:txBody>
-          <a:bodyPr wrap="square" lIns="0" tIns="0" rIns="0" bIns="0" rtlCol="0" anchor="ctr"/>
-          <a:lstStyle/>
-          <a:p>
-            <a:pPr algn="ctr" indent="0" marL="0">
-              <a:buNone/>
-            </a:pPr>
-            <a:r>
-              <a:rPr lang="en-US" sz="1500" b="1" dirty="0">
-                <a:solidFill>
-                  <a:srgbClr val="FFFFFF"/>
-                </a:solidFill>
-                <a:latin typeface="Calibri" pitchFamily="34" charset="0"/>
-                <a:ea typeface="Calibri" pitchFamily="34" charset="-122"/>
-                <a:cs typeface="Calibri" pitchFamily="34" charset="-120"/>
-              </a:rPr>
-              <a:t>2</a:t>
-            </a:r>
-            <a:endParaRPr lang="en-US" sz="1500" dirty="0"/>
-          </a:p>
-        </p:txBody>
-      </p:sp>
-      <p:sp>
-        <p:nvSpPr>
-          <p:cNvPr id="10" name="Text 8"/>
-          <p:cNvSpPr/>
-          <p:nvPr/>
-        </p:nvSpPr>
-        <p:spPr>
-          <a:xfrm>
-            <a:off x="1188720" y="2249424"/>
-            <a:ext cx="3383280" cy="411480"/>
-          </a:xfrm>
-          <a:prstGeom prst="rect">
-            <a:avLst/>
-          </a:prstGeom>
-          <a:noFill/>
-          <a:ln/>
-        </p:spPr>
-        <p:txBody>
-          <a:bodyPr wrap="square" lIns="0" tIns="0" rIns="0" bIns="0" rtlCol="0" anchor="ctr"/>
-          <a:lstStyle/>
-          <a:p>
-            <a:pPr indent="0" marL="0">
-              <a:buNone/>
-            </a:pPr>
-            <a:r>
-              <a:rPr lang="en-US" sz="1650" b="1" dirty="0">
-                <a:solidFill>
-                  <a:srgbClr val="0B0B0B"/>
-                </a:solidFill>
-                <a:latin typeface="Calibri" pitchFamily="34" charset="0"/>
-                <a:ea typeface="Calibri" pitchFamily="34" charset="-122"/>
-                <a:cs typeface="Calibri" pitchFamily="34" charset="-120"/>
-              </a:rPr>
-              <a:t>Operating drivers</a:t>
-            </a:r>
-            <a:endParaRPr lang="en-US" sz="1650" dirty="0"/>
-          </a:p>
-        </p:txBody>
-      </p:sp>
-      <p:sp>
-        <p:nvSpPr>
-          <p:cNvPr id="11" name="Text 9"/>
-          <p:cNvSpPr/>
-          <p:nvPr/>
-        </p:nvSpPr>
-        <p:spPr>
-          <a:xfrm>
-            <a:off x="4754880" y="2249424"/>
-            <a:ext cx="6858000" cy="411480"/>
-          </a:xfrm>
-          <a:prstGeom prst="rect">
-            <a:avLst/>
-          </a:prstGeom>
-          <a:noFill/>
-          <a:ln/>
-        </p:spPr>
-        <p:txBody>
-          <a:bodyPr wrap="square" lIns="0" tIns="0" rIns="0" bIns="0" rtlCol="0" anchor="ctr"/>
-          <a:lstStyle/>
-          <a:p>
-            <a:pPr indent="0" marL="0">
-              <a:buNone/>
-            </a:pPr>
-            <a:r>
-              <a:rPr lang="en-US" sz="1200" dirty="0">
-                <a:solidFill>
-                  <a:srgbClr val="52514E"/>
-                </a:solidFill>
-                <a:latin typeface="Calibri" pitchFamily="34" charset="0"/>
-                <a:ea typeface="Calibri" pitchFamily="34" charset="-122"/>
-                <a:cs typeface="Calibri" pitchFamily="34" charset="-120"/>
-              </a:rPr>
-              <a:t>Staff &amp; headcount · utilization by person · sales by customer</a:t>
-            </a:r>
-            <a:endParaRPr lang="en-US" sz="1200" dirty="0"/>
-          </a:p>
-        </p:txBody>
-      </p:sp>
-      <p:sp>
-        <p:nvSpPr>
-          <p:cNvPr id="12" name="Shape 10"/>
-          <p:cNvSpPr/>
-          <p:nvPr/>
-        </p:nvSpPr>
-        <p:spPr>
-          <a:xfrm>
-            <a:off x="548640" y="3054096"/>
-            <a:ext cx="402336" cy="402336"/>
-          </a:xfrm>
-          <a:prstGeom prst="ellipse">
-            <a:avLst/>
-          </a:prstGeom>
-          <a:solidFill>
-            <a:srgbClr val="2A78D6"/>
-          </a:solidFill>
-          <a:ln/>
-        </p:spPr>
-      </p:sp>
-      <p:sp>
-        <p:nvSpPr>
-          <p:cNvPr id="13" name="Text 11"/>
-          <p:cNvSpPr/>
-          <p:nvPr/>
-        </p:nvSpPr>
-        <p:spPr>
-          <a:xfrm>
-            <a:off x="548640" y="3054096"/>
-            <a:ext cx="402336" cy="402336"/>
-          </a:xfrm>
-          <a:prstGeom prst="rect">
-            <a:avLst/>
-          </a:prstGeom>
-          <a:noFill/>
-          <a:ln/>
-        </p:spPr>
-        <p:txBody>
-          <a:bodyPr wrap="square" lIns="0" tIns="0" rIns="0" bIns="0" rtlCol="0" anchor="ctr"/>
-          <a:lstStyle/>
-          <a:p>
-            <a:pPr algn="ctr" indent="0" marL="0">
-              <a:buNone/>
-            </a:pPr>
-            <a:r>
-              <a:rPr lang="en-US" sz="1500" b="1" dirty="0">
-                <a:solidFill>
-                  <a:srgbClr val="FFFFFF"/>
-                </a:solidFill>
-                <a:latin typeface="Calibri" pitchFamily="34" charset="0"/>
-                <a:ea typeface="Calibri" pitchFamily="34" charset="-122"/>
-                <a:cs typeface="Calibri" pitchFamily="34" charset="-120"/>
-              </a:rPr>
-              <a:t>3</a:t>
-            </a:r>
-            <a:endParaRPr lang="en-US" sz="1500" dirty="0"/>
-          </a:p>
-        </p:txBody>
-      </p:sp>
-      <p:sp>
-        <p:nvSpPr>
-          <p:cNvPr id="14" name="Text 12"/>
-          <p:cNvSpPr/>
-          <p:nvPr/>
-        </p:nvSpPr>
-        <p:spPr>
-          <a:xfrm>
-            <a:off x="1188720" y="3035808"/>
-            <a:ext cx="3383280" cy="411480"/>
-          </a:xfrm>
-          <a:prstGeom prst="rect">
-            <a:avLst/>
-          </a:prstGeom>
-          <a:noFill/>
-          <a:ln/>
-        </p:spPr>
-        <p:txBody>
-          <a:bodyPr wrap="square" lIns="0" tIns="0" rIns="0" bIns="0" rtlCol="0" anchor="ctr"/>
-          <a:lstStyle/>
-          <a:p>
-            <a:pPr indent="0" marL="0">
-              <a:buNone/>
-            </a:pPr>
-            <a:r>
-              <a:rPr lang="en-US" sz="1650" b="1" dirty="0">
-                <a:solidFill>
-                  <a:srgbClr val="0B0B0B"/>
-                </a:solidFill>
-                <a:latin typeface="Calibri" pitchFamily="34" charset="0"/>
-                <a:ea typeface="Calibri" pitchFamily="34" charset="-122"/>
-                <a:cs typeface="Calibri" pitchFamily="34" charset="-120"/>
-              </a:rPr>
-              <a:t>Work in hand &amp; work to win</a:t>
-            </a:r>
-            <a:endParaRPr lang="en-US" sz="1650" dirty="0"/>
-          </a:p>
-        </p:txBody>
-      </p:sp>
-      <p:sp>
-        <p:nvSpPr>
-          <p:cNvPr id="15" name="Text 13"/>
-          <p:cNvSpPr/>
-          <p:nvPr/>
-        </p:nvSpPr>
-        <p:spPr>
-          <a:xfrm>
-            <a:off x="4754880" y="3035808"/>
-            <a:ext cx="6858000" cy="411480"/>
-          </a:xfrm>
-          <a:prstGeom prst="rect">
-            <a:avLst/>
-          </a:prstGeom>
-          <a:noFill/>
-          <a:ln/>
-        </p:spPr>
-        <p:txBody>
-          <a:bodyPr wrap="square" lIns="0" tIns="0" rIns="0" bIns="0" rtlCol="0" anchor="ctr"/>
-          <a:lstStyle/>
-          <a:p>
-            <a:pPr indent="0" marL="0">
-              <a:buNone/>
-            </a:pPr>
-            <a:r>
-              <a:rPr lang="en-US" sz="1200" dirty="0">
-                <a:solidFill>
-                  <a:srgbClr val="52514E"/>
-                </a:solidFill>
-                <a:latin typeface="Calibri" pitchFamily="34" charset="0"/>
-                <a:ea typeface="Calibri" pitchFamily="34" charset="-122"/>
-                <a:cs typeface="Calibri" pitchFamily="34" charset="-120"/>
-              </a:rPr>
-              <a:t>Backlog on active jobs · known pipeline opportunities</a:t>
-            </a:r>
-            <a:endParaRPr lang="en-US" sz="1200" dirty="0"/>
-          </a:p>
-        </p:txBody>
-      </p:sp>
-      <p:sp>
-        <p:nvSpPr>
-          <p:cNvPr id="16" name="Shape 14"/>
-          <p:cNvSpPr/>
-          <p:nvPr/>
-        </p:nvSpPr>
-        <p:spPr>
-          <a:xfrm>
-            <a:off x="548640" y="3840480"/>
-            <a:ext cx="402336" cy="402336"/>
-          </a:xfrm>
-          <a:prstGeom prst="ellipse">
-            <a:avLst/>
-          </a:prstGeom>
-          <a:solidFill>
-            <a:srgbClr val="2A78D6"/>
-          </a:solidFill>
-          <a:ln/>
-        </p:spPr>
-      </p:sp>
-      <p:sp>
-        <p:nvSpPr>
-          <p:cNvPr id="17" name="Text 15"/>
-          <p:cNvSpPr/>
-          <p:nvPr/>
-        </p:nvSpPr>
-        <p:spPr>
-          <a:xfrm>
-            <a:off x="548640" y="3840480"/>
-            <a:ext cx="402336" cy="402336"/>
-          </a:xfrm>
-          <a:prstGeom prst="rect">
-            <a:avLst/>
-          </a:prstGeom>
-          <a:noFill/>
-          <a:ln/>
-        </p:spPr>
-        <p:txBody>
-          <a:bodyPr wrap="square" lIns="0" tIns="0" rIns="0" bIns="0" rtlCol="0" anchor="ctr"/>
-          <a:lstStyle/>
-          <a:p>
-            <a:pPr algn="ctr" indent="0" marL="0">
-              <a:buNone/>
-            </a:pPr>
-            <a:r>
-              <a:rPr lang="en-US" sz="1500" b="1" dirty="0">
-                <a:solidFill>
-                  <a:srgbClr val="FFFFFF"/>
-                </a:solidFill>
-                <a:latin typeface="Calibri" pitchFamily="34" charset="0"/>
-                <a:ea typeface="Calibri" pitchFamily="34" charset="-122"/>
-                <a:cs typeface="Calibri" pitchFamily="34" charset="-120"/>
-              </a:rPr>
-              <a:t>4</a:t>
-            </a:r>
-            <a:endParaRPr lang="en-US" sz="1500" dirty="0"/>
-          </a:p>
-        </p:txBody>
-      </p:sp>
-      <p:sp>
-        <p:nvSpPr>
-          <p:cNvPr id="18" name="Text 16"/>
-          <p:cNvSpPr/>
-          <p:nvPr/>
-        </p:nvSpPr>
-        <p:spPr>
-          <a:xfrm>
-            <a:off x="1188720" y="3822192"/>
-            <a:ext cx="3383280" cy="411480"/>
-          </a:xfrm>
-          <a:prstGeom prst="rect">
-            <a:avLst/>
-          </a:prstGeom>
-          <a:noFill/>
-          <a:ln/>
-        </p:spPr>
-        <p:txBody>
-          <a:bodyPr wrap="square" lIns="0" tIns="0" rIns="0" bIns="0" rtlCol="0" anchor="ctr"/>
-          <a:lstStyle/>
-          <a:p>
-            <a:pPr indent="0" marL="0">
-              <a:buNone/>
-            </a:pPr>
-            <a:r>
-              <a:rPr lang="en-US" sz="1650" b="1" dirty="0">
-                <a:solidFill>
-                  <a:srgbClr val="0B0B0B"/>
-                </a:solidFill>
-                <a:latin typeface="Calibri" pitchFamily="34" charset="0"/>
-                <a:ea typeface="Calibri" pitchFamily="34" charset="-122"/>
-                <a:cs typeface="Calibri" pitchFamily="34" charset="-120"/>
-              </a:rPr>
-              <a:t>Strategy</a:t>
-            </a:r>
-            <a:endParaRPr lang="en-US" sz="1650" dirty="0"/>
-          </a:p>
-        </p:txBody>
-      </p:sp>
-      <p:sp>
-        <p:nvSpPr>
-          <p:cNvPr id="19" name="Text 17"/>
-          <p:cNvSpPr/>
-          <p:nvPr/>
-        </p:nvSpPr>
-        <p:spPr>
-          <a:xfrm>
-            <a:off x="4754880" y="3822192"/>
-            <a:ext cx="6858000" cy="411480"/>
-          </a:xfrm>
-          <a:prstGeom prst="rect">
-            <a:avLst/>
-          </a:prstGeom>
-          <a:noFill/>
-          <a:ln/>
-        </p:spPr>
-        <p:txBody>
-          <a:bodyPr wrap="square" lIns="0" tIns="0" rIns="0" bIns="0" rtlCol="0" anchor="ctr"/>
-          <a:lstStyle/>
-          <a:p>
-            <a:pPr indent="0" marL="0">
-              <a:buNone/>
-            </a:pPr>
-            <a:r>
-              <a:rPr lang="en-US" sz="1200" dirty="0">
-                <a:solidFill>
-                  <a:srgbClr val="52514E"/>
-                </a:solidFill>
-                <a:latin typeface="Calibri" pitchFamily="34" charset="0"/>
-                <a:ea typeface="Calibri" pitchFamily="34" charset="-122"/>
-                <a:cs typeface="Calibri" pitchFamily="34" charset="-120"/>
-              </a:rPr>
-              <a:t>One pursuit engine with HWC Estimating · the consolidated EPC offering · the addressable market · BD account ownership</a:t>
-            </a:r>
-            <a:endParaRPr lang="en-US" sz="1200" dirty="0"/>
-          </a:p>
-        </p:txBody>
-      </p:sp>
-      <p:sp>
-        <p:nvSpPr>
-          <p:cNvPr id="20" name="Shape 18"/>
-          <p:cNvSpPr/>
-          <p:nvPr/>
-        </p:nvSpPr>
-        <p:spPr>
-          <a:xfrm>
-            <a:off x="548640" y="4626864"/>
-            <a:ext cx="402336" cy="402336"/>
-          </a:xfrm>
-          <a:prstGeom prst="ellipse">
-            <a:avLst/>
-          </a:prstGeom>
-          <a:solidFill>
-            <a:srgbClr val="2A78D6"/>
-          </a:solidFill>
-          <a:ln/>
-        </p:spPr>
-      </p:sp>
-      <p:sp>
-        <p:nvSpPr>
-          <p:cNvPr id="21" name="Text 19"/>
-          <p:cNvSpPr/>
-          <p:nvPr/>
-        </p:nvSpPr>
-        <p:spPr>
-          <a:xfrm>
-            <a:off x="548640" y="4626864"/>
-            <a:ext cx="402336" cy="402336"/>
-          </a:xfrm>
-          <a:prstGeom prst="rect">
-            <a:avLst/>
-          </a:prstGeom>
-          <a:noFill/>
-          <a:ln/>
-        </p:spPr>
-        <p:txBody>
-          <a:bodyPr wrap="square" lIns="0" tIns="0" rIns="0" bIns="0" rtlCol="0" anchor="ctr"/>
-          <a:lstStyle/>
-          <a:p>
-            <a:pPr algn="ctr" indent="0" marL="0">
-              <a:buNone/>
-            </a:pPr>
-            <a:r>
-              <a:rPr lang="en-US" sz="1500" b="1" dirty="0">
-                <a:solidFill>
-                  <a:srgbClr val="FFFFFF"/>
-                </a:solidFill>
-                <a:latin typeface="Calibri" pitchFamily="34" charset="0"/>
-                <a:ea typeface="Calibri" pitchFamily="34" charset="-122"/>
-                <a:cs typeface="Calibri" pitchFamily="34" charset="-120"/>
-              </a:rPr>
-              <a:t>5</a:t>
-            </a:r>
-            <a:endParaRPr lang="en-US" sz="1500" dirty="0"/>
-          </a:p>
-        </p:txBody>
-      </p:sp>
-      <p:sp>
-        <p:nvSpPr>
-          <p:cNvPr id="22" name="Text 20"/>
-          <p:cNvSpPr/>
-          <p:nvPr/>
-        </p:nvSpPr>
-        <p:spPr>
-          <a:xfrm>
-            <a:off x="1188720" y="4608576"/>
-            <a:ext cx="3383280" cy="411480"/>
-          </a:xfrm>
-          <a:prstGeom prst="rect">
-            <a:avLst/>
-          </a:prstGeom>
-          <a:noFill/>
-          <a:ln/>
-        </p:spPr>
-        <p:txBody>
-          <a:bodyPr wrap="square" lIns="0" tIns="0" rIns="0" bIns="0" rtlCol="0" anchor="ctr"/>
-          <a:lstStyle/>
-          <a:p>
-            <a:pPr indent="0" marL="0">
-              <a:buNone/>
-            </a:pPr>
-            <a:r>
-              <a:rPr lang="en-US" sz="1650" b="1" dirty="0">
-                <a:solidFill>
-                  <a:srgbClr val="0B0B0B"/>
-                </a:solidFill>
-                <a:latin typeface="Calibri" pitchFamily="34" charset="0"/>
-                <a:ea typeface="Calibri" pitchFamily="34" charset="-122"/>
-                <a:cs typeface="Calibri" pitchFamily="34" charset="-120"/>
-              </a:rPr>
-              <a:t>Forward view</a:t>
-            </a:r>
-            <a:endParaRPr lang="en-US" sz="1650" dirty="0"/>
-          </a:p>
-        </p:txBody>
-      </p:sp>
-      <p:sp>
-        <p:nvSpPr>
-          <p:cNvPr id="23" name="Text 21"/>
-          <p:cNvSpPr/>
-          <p:nvPr/>
-        </p:nvSpPr>
-        <p:spPr>
-          <a:xfrm>
-            <a:off x="4754880" y="4608576"/>
-            <a:ext cx="6858000" cy="411480"/>
-          </a:xfrm>
-          <a:prstGeom prst="rect">
-            <a:avLst/>
-          </a:prstGeom>
-          <a:noFill/>
-          <a:ln/>
-        </p:spPr>
-        <p:txBody>
-          <a:bodyPr wrap="square" lIns="0" tIns="0" rIns="0" bIns="0" rtlCol="0" anchor="ctr"/>
-          <a:lstStyle/>
-          <a:p>
-            <a:pPr indent="0" marL="0">
-              <a:buNone/>
-            </a:pPr>
-            <a:r>
-              <a:rPr lang="en-US" sz="1200" dirty="0">
-                <a:solidFill>
-                  <a:srgbClr val="52514E"/>
-                </a:solidFill>
-                <a:latin typeface="Calibri" pitchFamily="34" charset="0"/>
-                <a:ea typeface="Calibri" pitchFamily="34" charset="-122"/>
-                <a:cs typeface="Calibri" pitchFamily="34" charset="-120"/>
-              </a:rPr>
-              <a:t>Forecast &amp; coverage · FY2026 landing and FY2027 scenarios · cash &amp; the parent note</a:t>
-            </a:r>
-            <a:endParaRPr lang="en-US" sz="1200" dirty="0"/>
-          </a:p>
-        </p:txBody>
-      </p:sp>
-      <p:sp>
-        <p:nvSpPr>
-          <p:cNvPr id="24" name="Shape 22"/>
-          <p:cNvSpPr/>
-          <p:nvPr/>
-        </p:nvSpPr>
-        <p:spPr>
-          <a:xfrm>
-            <a:off x="548640" y="5413248"/>
-            <a:ext cx="402336" cy="402336"/>
-          </a:xfrm>
-          <a:prstGeom prst="ellipse">
-            <a:avLst/>
-          </a:prstGeom>
-          <a:solidFill>
-            <a:srgbClr val="2A78D6"/>
-          </a:solidFill>
-          <a:ln/>
-        </p:spPr>
-      </p:sp>
-      <p:sp>
-        <p:nvSpPr>
-          <p:cNvPr id="25" name="Text 23"/>
-          <p:cNvSpPr/>
-          <p:nvPr/>
-        </p:nvSpPr>
-        <p:spPr>
-          <a:xfrm>
-            <a:off x="548640" y="5413248"/>
-            <a:ext cx="402336" cy="402336"/>
-          </a:xfrm>
-          <a:prstGeom prst="rect">
-            <a:avLst/>
-          </a:prstGeom>
-          <a:noFill/>
-          <a:ln/>
-        </p:spPr>
-        <p:txBody>
-          <a:bodyPr wrap="square" lIns="0" tIns="0" rIns="0" bIns="0" rtlCol="0" anchor="ctr"/>
-          <a:lstStyle/>
-          <a:p>
-            <a:pPr algn="ctr" indent="0" marL="0">
-              <a:buNone/>
-            </a:pPr>
-            <a:r>
-              <a:rPr lang="en-US" sz="1500" b="1" dirty="0">
-                <a:solidFill>
-                  <a:srgbClr val="FFFFFF"/>
-                </a:solidFill>
-                <a:latin typeface="Calibri" pitchFamily="34" charset="0"/>
-                <a:ea typeface="Calibri" pitchFamily="34" charset="-122"/>
-                <a:cs typeface="Calibri" pitchFamily="34" charset="-120"/>
-              </a:rPr>
-              <a:t>6</a:t>
-            </a:r>
-            <a:endParaRPr lang="en-US" sz="1500" dirty="0"/>
-          </a:p>
-        </p:txBody>
-      </p:sp>
-      <p:sp>
-        <p:nvSpPr>
-          <p:cNvPr id="26" name="Text 24"/>
-          <p:cNvSpPr/>
-          <p:nvPr/>
-        </p:nvSpPr>
-        <p:spPr>
-          <a:xfrm>
-            <a:off x="1188720" y="5394960"/>
-            <a:ext cx="3383280" cy="411480"/>
-          </a:xfrm>
-          <a:prstGeom prst="rect">
-            <a:avLst/>
-          </a:prstGeom>
-          <a:noFill/>
-          <a:ln/>
-        </p:spPr>
-        <p:txBody>
-          <a:bodyPr wrap="square" lIns="0" tIns="0" rIns="0" bIns="0" rtlCol="0" anchor="ctr"/>
-          <a:lstStyle/>
-          <a:p>
-            <a:pPr indent="0" marL="0">
-              <a:buNone/>
-            </a:pPr>
-            <a:r>
-              <a:rPr lang="en-US" sz="1650" b="1" dirty="0">
-                <a:solidFill>
-                  <a:srgbClr val="0B0B0B"/>
-                </a:solidFill>
-                <a:latin typeface="Calibri" pitchFamily="34" charset="0"/>
-                <a:ea typeface="Calibri" pitchFamily="34" charset="-122"/>
-                <a:cs typeface="Calibri" pitchFamily="34" charset="-120"/>
-              </a:rPr>
-              <a:t>Next 90 days</a:t>
-            </a:r>
-            <a:endParaRPr lang="en-US" sz="1650" dirty="0"/>
-          </a:p>
-        </p:txBody>
-      </p:sp>
-      <p:sp>
-        <p:nvSpPr>
-          <p:cNvPr id="27" name="Text 25"/>
-          <p:cNvSpPr/>
-          <p:nvPr/>
-        </p:nvSpPr>
-        <p:spPr>
-          <a:xfrm>
-            <a:off x="4754880" y="5394960"/>
-            <a:ext cx="6858000" cy="411480"/>
-          </a:xfrm>
-          <a:prstGeom prst="rect">
-            <a:avLst/>
-          </a:prstGeom>
-          <a:noFill/>
-          <a:ln/>
-        </p:spPr>
-        <p:txBody>
-          <a:bodyPr wrap="square" lIns="0" tIns="0" rIns="0" bIns="0" rtlCol="0" anchor="ctr"/>
-          <a:lstStyle/>
-          <a:p>
-            <a:pPr indent="0" marL="0">
-              <a:buNone/>
-            </a:pPr>
-            <a:r>
-              <a:rPr lang="en-US" sz="1200" dirty="0">
-                <a:solidFill>
-                  <a:srgbClr val="52514E"/>
-                </a:solidFill>
-                <a:latin typeface="Calibri" pitchFamily="34" charset="0"/>
-                <a:ea typeface="Calibri" pitchFamily="34" charset="-122"/>
-                <a:cs typeface="Calibri" pitchFamily="34" charset="-120"/>
-              </a:rPr>
-              <a:t>Priorities: realization, utilization, the Q4 pipeline, and the monthly rhythm</a:t>
-            </a:r>
-            <a:endParaRPr lang="en-US" sz="1200" dirty="0"/>
-          </a:p>
-        </p:txBody>
-      </p:sp>
-      <p:sp>
-        <p:nvSpPr>
-          <p:cNvPr id="28" name="Text 26"/>
-          <p:cNvSpPr/>
-          <p:nvPr/>
-        </p:nvSpPr>
-        <p:spPr>
-          <a:xfrm>
-            <a:off x="548640" y="6419088"/>
-            <a:ext cx="11064240" cy="320040"/>
-          </a:xfrm>
-          <a:prstGeom prst="rect">
-            <a:avLst/>
-          </a:prstGeom>
-          <a:noFill/>
-          <a:ln/>
-        </p:spPr>
-        <p:txBody>
-          <a:bodyPr wrap="square" lIns="0" tIns="0" rIns="0" bIns="0" rtlCol="0" anchor="ctr"/>
-          <a:lstStyle/>
-          <a:p>
-            <a:pPr indent="0" marL="0">
-              <a:buNone/>
-            </a:pPr>
-            <a:r>
-              <a:rPr lang="en-US" sz="950" dirty="0">
-                <a:solidFill>
-                  <a:srgbClr val="898781"/>
-                </a:solidFill>
-                <a:latin typeface="Calibri" pitchFamily="34" charset="0"/>
-                <a:ea typeface="Calibri" pitchFamily="34" charset="-122"/>
-                <a:cs typeface="Calibri" pitchFamily="34" charset="-120"/>
-              </a:rPr>
-              <a:t>CVR Engineering financial review &amp; forecast · June 2026</a:t>
-            </a:r>
-            <a:endParaRPr lang="en-US" sz="950" dirty="0"/>
-          </a:p>
-        </p:txBody>
-      </p:sp>
-    </p:spTree>
-  </p:cSld>
-  <p:clrMapOvr>
-    <a:masterClrMapping/>
-  </p:clrMapOvr>
-</p:sld>
-</file>
-
-<file path=ppt/slides/slide20.xml><?xml version="1.0" encoding="utf-8"?>
-<p:sld xmlns:a="http://schemas.openxmlformats.org/drawingml/2006/main" xmlns:r="http://schemas.openxmlformats.org/officeDocument/2006/relationships" xmlns:p="http://schemas.openxmlformats.org/presentationml/2006/main">
-  <p:cSld name="Slide 20">
+  <p:cSld name="Slide 21">
     <p:bg>
       <p:bgPr>
         <a:solidFill>
@@ -27437,7 +27940,7 @@
                 <a:ea typeface="Calibri" pitchFamily="34" charset="-122"/>
                 <a:cs typeface="Calibri" pitchFamily="34" charset="-120"/>
               </a:rPr>
-              <a:t>Fix in flight</a:t>
+              <a:t>Now sourced</a:t>
             </a:r>
             <a:endParaRPr lang="en-US" sz="2600" dirty="0"/>
           </a:p>
@@ -27476,7 +27979,7 @@
                 <a:ea typeface="Calibri" pitchFamily="34" charset="-122"/>
                 <a:cs typeface="Calibri" pitchFamily="34" charset="-120"/>
               </a:rPr>
-              <a:t>gap decomposition block is built into the Phase 1 workbook, pending salary detail from finance</a:t>
+              <a:t>per-person cost rates confirmed from the COINS timesheet report — see the next slide</a:t>
             </a:r>
             <a:endParaRPr lang="en-US" sz="1200" dirty="0"/>
           </a:p>
@@ -27632,6 +28135,498 @@
                 <a:ea typeface="Calibri" pitchFamily="34" charset="-122"/>
                 <a:cs typeface="Calibri" pitchFamily="34" charset="-120"/>
               </a:rPr>
+              <a:t>Margin by role — a rate-card problem, quantified</a:t>
+            </a:r>
+            <a:endParaRPr lang="en-US" sz="2700" dirty="0"/>
+          </a:p>
+        </p:txBody>
+      </p:sp>
+      <p:pic>
+        <p:nvPicPr>
+          <p:cNvPr id="4" name="Image 0" descr="/home/user/CVR---Financial/reports/assets/margin.png">    </p:cNvPr>
+          <p:cNvPicPr>
+            <a:picLocks noChangeAspect="1"/>
+          </p:cNvPicPr>
+          <p:nvPr/>
+        </p:nvPicPr>
+        <p:blipFill>
+          <a:blip r:embed="rId1"/>
+          <a:stretch>
+            <a:fillRect/>
+          </a:stretch>
+        </p:blipFill>
+        <p:spPr>
+          <a:xfrm>
+            <a:off x="548640" y="1371600"/>
+            <a:ext cx="7589520" cy="3558081"/>
+          </a:xfrm>
+          <a:prstGeom prst="rect">
+            <a:avLst/>
+          </a:prstGeom>
+        </p:spPr>
+      </p:pic>
+      <p:sp>
+        <p:nvSpPr>
+          <p:cNvPr id="5" name="Text 2"/>
+          <p:cNvSpPr/>
+          <p:nvPr/>
+        </p:nvSpPr>
+        <p:spPr>
+          <a:xfrm>
+            <a:off x="8412480" y="1417320"/>
+            <a:ext cx="3200400" cy="301752"/>
+          </a:xfrm>
+          <a:prstGeom prst="rect">
+            <a:avLst/>
+          </a:prstGeom>
+          <a:noFill/>
+          <a:ln/>
+        </p:spPr>
+        <p:txBody>
+          <a:bodyPr wrap="square" lIns="0" tIns="0" rIns="0" bIns="0" rtlCol="0" anchor="ctr"/>
+          <a:lstStyle/>
+          <a:p>
+            <a:pPr indent="0" marL="0">
+              <a:buNone/>
+            </a:pPr>
+            <a:r>
+              <a:rPr lang="en-US" sz="1600" b="1" dirty="0">
+                <a:solidFill>
+                  <a:srgbClr val="E34948"/>
+                </a:solidFill>
+                <a:latin typeface="Calibri" pitchFamily="34" charset="0"/>
+                <a:ea typeface="Calibri" pitchFamily="34" charset="-122"/>
+                <a:cs typeface="Calibri" pitchFamily="34" charset="-120"/>
+              </a:rPr>
+              <a:t>Designer II</a:t>
+            </a:r>
+            <a:endParaRPr lang="en-US" sz="1600" dirty="0"/>
+          </a:p>
+        </p:txBody>
+      </p:sp>
+      <p:sp>
+        <p:nvSpPr>
+          <p:cNvPr id="6" name="Text 3"/>
+          <p:cNvSpPr/>
+          <p:nvPr/>
+        </p:nvSpPr>
+        <p:spPr>
+          <a:xfrm>
+            <a:off x="8412480" y="1737360"/>
+            <a:ext cx="3200400" cy="914400"/>
+          </a:xfrm>
+          <a:prstGeom prst="rect">
+            <a:avLst/>
+          </a:prstGeom>
+          <a:noFill/>
+          <a:ln/>
+        </p:spPr>
+        <p:txBody>
+          <a:bodyPr wrap="square" lIns="0" tIns="0" rIns="0" bIns="0" rtlCol="0" anchor="ctr"/>
+          <a:lstStyle/>
+          <a:p>
+            <a:pPr indent="0" marL="0">
+              <a:buNone/>
+            </a:pPr>
+            <a:r>
+              <a:rPr lang="en-US" sz="1150" dirty="0">
+                <a:solidFill>
+                  <a:srgbClr val="52514E"/>
+                </a:solidFill>
+                <a:latin typeface="Calibri" pitchFamily="34" charset="0"/>
+                <a:ea typeface="Calibri" pitchFamily="34" charset="-122"/>
+                <a:cs typeface="Calibri" pitchFamily="34" charset="-120"/>
+              </a:rPr>
+              <a:t>bills BELOW its own loaded cost ($96 vs $124) — underwater on every billable hour</a:t>
+            </a:r>
+            <a:endParaRPr lang="en-US" sz="1150" dirty="0"/>
+          </a:p>
+        </p:txBody>
+      </p:sp>
+      <p:sp>
+        <p:nvSpPr>
+          <p:cNvPr id="7" name="Text 4"/>
+          <p:cNvSpPr/>
+          <p:nvPr/>
+        </p:nvSpPr>
+        <p:spPr>
+          <a:xfrm>
+            <a:off x="8412480" y="2624328"/>
+            <a:ext cx="3200400" cy="301752"/>
+          </a:xfrm>
+          <a:prstGeom prst="rect">
+            <a:avLst/>
+          </a:prstGeom>
+          <a:noFill/>
+          <a:ln/>
+        </p:spPr>
+        <p:txBody>
+          <a:bodyPr wrap="square" lIns="0" tIns="0" rIns="0" bIns="0" rtlCol="0" anchor="ctr"/>
+          <a:lstStyle/>
+          <a:p>
+            <a:pPr indent="0" marL="0">
+              <a:buNone/>
+            </a:pPr>
+            <a:r>
+              <a:rPr lang="en-US" sz="1600" b="1" dirty="0">
+                <a:solidFill>
+                  <a:srgbClr val="E34948"/>
+                </a:solidFill>
+                <a:latin typeface="Calibri" pitchFamily="34" charset="0"/>
+                <a:ea typeface="Calibri" pitchFamily="34" charset="-122"/>
+                <a:cs typeface="Calibri" pitchFamily="34" charset="-120"/>
+              </a:rPr>
+              <a:t>Engineer III</a:t>
+            </a:r>
+            <a:endParaRPr lang="en-US" sz="1600" dirty="0"/>
+          </a:p>
+        </p:txBody>
+      </p:sp>
+      <p:sp>
+        <p:nvSpPr>
+          <p:cNvPr id="8" name="Text 5"/>
+          <p:cNvSpPr/>
+          <p:nvPr/>
+        </p:nvSpPr>
+        <p:spPr>
+          <a:xfrm>
+            <a:off x="8412480" y="2944368"/>
+            <a:ext cx="3200400" cy="914400"/>
+          </a:xfrm>
+          <a:prstGeom prst="rect">
+            <a:avLst/>
+          </a:prstGeom>
+          <a:noFill/>
+          <a:ln/>
+        </p:spPr>
+        <p:txBody>
+          <a:bodyPr wrap="square" lIns="0" tIns="0" rIns="0" bIns="0" rtlCol="0" anchor="ctr"/>
+          <a:lstStyle/>
+          <a:p>
+            <a:pPr indent="0" marL="0">
+              <a:buNone/>
+            </a:pPr>
+            <a:r>
+              <a:rPr lang="en-US" sz="1150" dirty="0">
+                <a:solidFill>
+                  <a:srgbClr val="52514E"/>
+                </a:solidFill>
+                <a:latin typeface="Calibri" pitchFamily="34" charset="0"/>
+                <a:ea typeface="Calibri" pitchFamily="34" charset="-122"/>
+                <a:cs typeface="Calibri" pitchFamily="34" charset="-120"/>
+              </a:rPr>
+              <a:t>≈6% margin at full card ($152 vs $144) — goes negative after 79% realization</a:t>
+            </a:r>
+            <a:endParaRPr lang="en-US" sz="1150" dirty="0"/>
+          </a:p>
+        </p:txBody>
+      </p:sp>
+      <p:sp>
+        <p:nvSpPr>
+          <p:cNvPr id="9" name="Text 6"/>
+          <p:cNvSpPr/>
+          <p:nvPr/>
+        </p:nvSpPr>
+        <p:spPr>
+          <a:xfrm>
+            <a:off x="8412480" y="3831336"/>
+            <a:ext cx="3200400" cy="301752"/>
+          </a:xfrm>
+          <a:prstGeom prst="rect">
+            <a:avLst/>
+          </a:prstGeom>
+          <a:noFill/>
+          <a:ln/>
+        </p:spPr>
+        <p:txBody>
+          <a:bodyPr wrap="square" lIns="0" tIns="0" rIns="0" bIns="0" rtlCol="0" anchor="ctr"/>
+          <a:lstStyle/>
+          <a:p>
+            <a:pPr indent="0" marL="0">
+              <a:buNone/>
+            </a:pPr>
+            <a:r>
+              <a:rPr lang="en-US" sz="1600" b="1" dirty="0">
+                <a:solidFill>
+                  <a:srgbClr val="0B0B0B"/>
+                </a:solidFill>
+                <a:latin typeface="Calibri" pitchFamily="34" charset="0"/>
+                <a:ea typeface="Calibri" pitchFamily="34" charset="-122"/>
+                <a:cs typeface="Calibri" pitchFamily="34" charset="-120"/>
+              </a:rPr>
+              <a:t>The pattern</a:t>
+            </a:r>
+            <a:endParaRPr lang="en-US" sz="1600" dirty="0"/>
+          </a:p>
+        </p:txBody>
+      </p:sp>
+      <p:sp>
+        <p:nvSpPr>
+          <p:cNvPr id="10" name="Text 7"/>
+          <p:cNvSpPr/>
+          <p:nvPr/>
+        </p:nvSpPr>
+        <p:spPr>
+          <a:xfrm>
+            <a:off x="8412480" y="4151376"/>
+            <a:ext cx="3200400" cy="914400"/>
+          </a:xfrm>
+          <a:prstGeom prst="rect">
+            <a:avLst/>
+          </a:prstGeom>
+          <a:noFill/>
+          <a:ln/>
+        </p:spPr>
+        <p:txBody>
+          <a:bodyPr wrap="square" lIns="0" tIns="0" rIns="0" bIns="0" rtlCol="0" anchor="ctr"/>
+          <a:lstStyle/>
+          <a:p>
+            <a:pPr indent="0" marL="0">
+              <a:buNone/>
+            </a:pPr>
+            <a:r>
+              <a:rPr lang="en-US" sz="1150" dirty="0">
+                <a:solidFill>
+                  <a:srgbClr val="52514E"/>
+                </a:solidFill>
+                <a:latin typeface="Calibri" pitchFamily="34" charset="0"/>
+                <a:ea typeface="Calibri" pitchFamily="34" charset="-122"/>
+                <a:cs typeface="Calibri" pitchFamily="34" charset="-120"/>
+              </a:rPr>
+              <a:t>mid-grades don't clear loaded cost with room to survive realization, overhead, and interest</a:t>
+            </a:r>
+            <a:endParaRPr lang="en-US" sz="1150" dirty="0"/>
+          </a:p>
+        </p:txBody>
+      </p:sp>
+      <p:sp>
+        <p:nvSpPr>
+          <p:cNvPr id="11" name="Text 8"/>
+          <p:cNvSpPr/>
+          <p:nvPr/>
+        </p:nvSpPr>
+        <p:spPr>
+          <a:xfrm>
+            <a:off x="8412480" y="5038344"/>
+            <a:ext cx="3200400" cy="301752"/>
+          </a:xfrm>
+          <a:prstGeom prst="rect">
+            <a:avLst/>
+          </a:prstGeom>
+          <a:noFill/>
+          <a:ln/>
+        </p:spPr>
+        <p:txBody>
+          <a:bodyPr wrap="square" lIns="0" tIns="0" rIns="0" bIns="0" rtlCol="0" anchor="ctr"/>
+          <a:lstStyle/>
+          <a:p>
+            <a:pPr indent="0" marL="0">
+              <a:buNone/>
+            </a:pPr>
+            <a:r>
+              <a:rPr lang="en-US" sz="1600" b="1" dirty="0">
+                <a:solidFill>
+                  <a:srgbClr val="2A78D6"/>
+                </a:solidFill>
+                <a:latin typeface="Calibri" pitchFamily="34" charset="0"/>
+                <a:ea typeface="Calibri" pitchFamily="34" charset="-122"/>
+                <a:cs typeface="Calibri" pitchFamily="34" charset="-120"/>
+              </a:rPr>
+              <a:t>The fix</a:t>
+            </a:r>
+            <a:endParaRPr lang="en-US" sz="1600" dirty="0"/>
+          </a:p>
+        </p:txBody>
+      </p:sp>
+      <p:sp>
+        <p:nvSpPr>
+          <p:cNvPr id="12" name="Text 9"/>
+          <p:cNvSpPr/>
+          <p:nvPr/>
+        </p:nvSpPr>
+        <p:spPr>
+          <a:xfrm>
+            <a:off x="8412480" y="5358384"/>
+            <a:ext cx="3200400" cy="914400"/>
+          </a:xfrm>
+          <a:prstGeom prst="rect">
+            <a:avLst/>
+          </a:prstGeom>
+          <a:noFill/>
+          <a:ln/>
+        </p:spPr>
+        <p:txBody>
+          <a:bodyPr wrap="square" lIns="0" tIns="0" rIns="0" bIns="0" rtlCol="0" anchor="ctr"/>
+          <a:lstStyle/>
+          <a:p>
+            <a:pPr indent="0" marL="0">
+              <a:buNone/>
+            </a:pPr>
+            <a:r>
+              <a:rPr lang="en-US" sz="1150" dirty="0">
+                <a:solidFill>
+                  <a:srgbClr val="52514E"/>
+                </a:solidFill>
+                <a:latin typeface="Calibri" pitchFamily="34" charset="0"/>
+                <a:ea typeface="Calibri" pitchFamily="34" charset="-122"/>
+                <a:cs typeface="Calibri" pitchFamily="34" charset="-120"/>
+              </a:rPr>
+              <a:t>a rate-card review, now defensible with actual per-person cost by grade</a:t>
+            </a:r>
+            <a:endParaRPr lang="en-US" sz="1150" dirty="0"/>
+          </a:p>
+        </p:txBody>
+      </p:sp>
+      <p:sp>
+        <p:nvSpPr>
+          <p:cNvPr id="13" name="Text 10"/>
+          <p:cNvSpPr/>
+          <p:nvPr/>
+        </p:nvSpPr>
+        <p:spPr>
+          <a:xfrm>
+            <a:off x="548640" y="6419088"/>
+            <a:ext cx="11064240" cy="320040"/>
+          </a:xfrm>
+          <a:prstGeom prst="rect">
+            <a:avLst/>
+          </a:prstGeom>
+          <a:noFill/>
+          <a:ln/>
+        </p:spPr>
+        <p:txBody>
+          <a:bodyPr wrap="square" lIns="0" tIns="0" rIns="0" bIns="0" rtlCol="0" anchor="ctr"/>
+          <a:lstStyle/>
+          <a:p>
+            <a:pPr indent="0" marL="0">
+              <a:buNone/>
+            </a:pPr>
+            <a:r>
+              <a:rPr lang="en-US" sz="950" dirty="0">
+                <a:solidFill>
+                  <a:srgbClr val="898781"/>
+                </a:solidFill>
+                <a:latin typeface="Calibri" pitchFamily="34" charset="0"/>
+                <a:ea typeface="Calibri" pitchFamily="34" charset="-122"/>
+                <a:cs typeface="Calibri" pitchFamily="34" charset="-120"/>
+              </a:rPr>
+              <a:t>Loaded cost = COINS standard cost rate × 1.338 (GL-derived burden). Cost rates are base/pay (burden-exclusive). Source: COINS Timesheet Costs Report, Jul 2026.</a:t>
+            </a:r>
+            <a:endParaRPr lang="en-US" sz="950" dirty="0"/>
+          </a:p>
+        </p:txBody>
+      </p:sp>
+    </p:spTree>
+  </p:cSld>
+  <p:clrMapOvr>
+    <a:masterClrMapping/>
+  </p:clrMapOvr>
+</p:sld>
+</file>
+
+<file path=ppt/slides/slide8.xml><?xml version="1.0" encoding="utf-8"?>
+<p:sld xmlns:a="http://schemas.openxmlformats.org/drawingml/2006/main" xmlns:r="http://schemas.openxmlformats.org/officeDocument/2006/relationships" xmlns:p="http://schemas.openxmlformats.org/presentationml/2006/main">
+  <p:cSld name="Slide 8">
+    <p:spTree>
+      <p:nvGrpSpPr>
+        <p:cNvPr id="1" name=""/>
+        <p:cNvGrpSpPr/>
+        <p:nvPr/>
+      </p:nvGrpSpPr>
+      <p:grpSpPr>
+        <a:xfrm>
+          <a:off x="0" y="0"/>
+          <a:ext cx="0" cy="0"/>
+          <a:chOff x="0" y="0"/>
+          <a:chExt cx="0" cy="0"/>
+        </a:xfrm>
+      </p:grpSpPr>
+      <p:sp>
+        <p:nvSpPr>
+          <p:cNvPr id="2" name="Text 0"/>
+          <p:cNvSpPr/>
+          <p:nvPr/>
+        </p:nvSpPr>
+        <p:spPr>
+          <a:xfrm>
+            <a:off x="548640" y="292608"/>
+            <a:ext cx="11064240" cy="274320"/>
+          </a:xfrm>
+          <a:prstGeom prst="rect">
+            <a:avLst/>
+          </a:prstGeom>
+          <a:noFill/>
+          <a:ln/>
+        </p:spPr>
+        <p:txBody>
+          <a:bodyPr wrap="square" lIns="0" tIns="0" rIns="0" bIns="0" rtlCol="0" anchor="ctr"/>
+          <a:lstStyle/>
+          <a:p>
+            <a:pPr indent="0" marL="0">
+              <a:buNone/>
+            </a:pPr>
+            <a:r>
+              <a:rPr lang="en-US" sz="1100" b="1" dirty="0">
+                <a:solidFill>
+                  <a:srgbClr val="86B332"/>
+                </a:solidFill>
+                <a:latin typeface="Calibri" pitchFamily="34" charset="0"/>
+                <a:ea typeface="Calibri" pitchFamily="34" charset="-122"/>
+                <a:cs typeface="Calibri" pitchFamily="34" charset="-120"/>
+              </a:rPr>
+              <a:t>— </a:t>
+            </a:r>
+            <a:pPr indent="0" marL="0">
+              <a:buNone/>
+            </a:pPr>
+            <a:r>
+              <a:rPr lang="en-US" sz="1100" b="1" spc="200" kern="0" dirty="0">
+                <a:solidFill>
+                  <a:srgbClr val="52514E"/>
+                </a:solidFill>
+                <a:latin typeface="Calibri" pitchFamily="34" charset="0"/>
+                <a:ea typeface="Calibri" pitchFamily="34" charset="-122"/>
+                <a:cs typeface="Calibri" pitchFamily="34" charset="-120"/>
+              </a:rPr>
+              <a:t>OPERATING DRIVERS</a:t>
+            </a:r>
+            <a:endParaRPr lang="en-US" sz="1100" dirty="0"/>
+          </a:p>
+        </p:txBody>
+      </p:sp>
+      <p:sp>
+        <p:nvSpPr>
+          <p:cNvPr id="3" name="Text 1"/>
+          <p:cNvSpPr/>
+          <p:nvPr/>
+        </p:nvSpPr>
+        <p:spPr>
+          <a:xfrm>
+            <a:off x="548640" y="548640"/>
+            <a:ext cx="11064240" cy="502920"/>
+          </a:xfrm>
+          <a:prstGeom prst="rect">
+            <a:avLst/>
+          </a:prstGeom>
+          <a:noFill/>
+          <a:ln/>
+        </p:spPr>
+        <p:txBody>
+          <a:bodyPr wrap="square" lIns="0" tIns="0" rIns="0" bIns="0" rtlCol="0" anchor="ctr"/>
+          <a:lstStyle/>
+          <a:p>
+            <a:pPr indent="0" marL="0">
+              <a:buNone/>
+            </a:pPr>
+            <a:r>
+              <a:rPr lang="en-US" sz="2700" b="1" dirty="0">
+                <a:solidFill>
+                  <a:srgbClr val="0B0B0B"/>
+                </a:solidFill>
+                <a:latin typeface="Calibri" pitchFamily="34" charset="0"/>
+                <a:ea typeface="Calibri" pitchFamily="34" charset="-122"/>
+                <a:cs typeface="Calibri" pitchFamily="34" charset="-120"/>
+              </a:rPr>
               <a:t>Staff &amp; headcount</a:t>
             </a:r>
             <a:endParaRPr lang="en-US" sz="2700" dirty="0"/>
@@ -27640,7 +28635,7 @@
       </p:sp>
       <p:graphicFrame>
         <p:nvGraphicFramePr>
-          <p:cNvPr id="8" name="Table 0"/>
+          <p:cNvPr id="9" name="Table 0"/>
           <p:cNvGraphicFramePr>
             <a:graphicFrameLocks noGrp="1"/>
           </p:cNvGraphicFramePr>
@@ -32818,9 +33813,9 @@
 </p:sld>
 </file>
 
-<file path=ppt/slides/slide8.xml><?xml version="1.0" encoding="utf-8"?>
+<file path=ppt/slides/slide9.xml><?xml version="1.0" encoding="utf-8"?>
 <p:sld xmlns:a="http://schemas.openxmlformats.org/drawingml/2006/main" xmlns:r="http://schemas.openxmlformats.org/officeDocument/2006/relationships" xmlns:p="http://schemas.openxmlformats.org/presentationml/2006/main">
-  <p:cSld name="Slide 8">
+  <p:cSld name="Slide 9">
     <p:spTree>
       <p:nvGrpSpPr>
         <p:cNvPr id="1" name=""/>
@@ -33219,420 +34214,6 @@
                 <a:cs typeface="Calibri" pitchFamily="34" charset="-120"/>
               </a:rPr>
               <a:t>Hours through 7/11/26. Randy Pynenberg (68 hrs) and Auston Hopson (18 hrs) have small YTD bases. Bids/BD time is tracked separately (405 hrs).</a:t>
-            </a:r>
-            <a:endParaRPr lang="en-US" sz="950" dirty="0"/>
-          </a:p>
-        </p:txBody>
-      </p:sp>
-    </p:spTree>
-  </p:cSld>
-  <p:clrMapOvr>
-    <a:masterClrMapping/>
-  </p:clrMapOvr>
-</p:sld>
-</file>
-
-<file path=ppt/slides/slide9.xml><?xml version="1.0" encoding="utf-8"?>
-<p:sld xmlns:a="http://schemas.openxmlformats.org/drawingml/2006/main" xmlns:r="http://schemas.openxmlformats.org/officeDocument/2006/relationships" xmlns:p="http://schemas.openxmlformats.org/presentationml/2006/main">
-  <p:cSld name="Slide 9">
-    <p:spTree>
-      <p:nvGrpSpPr>
-        <p:cNvPr id="1" name=""/>
-        <p:cNvGrpSpPr/>
-        <p:nvPr/>
-      </p:nvGrpSpPr>
-      <p:grpSpPr>
-        <a:xfrm>
-          <a:off x="0" y="0"/>
-          <a:ext cx="0" cy="0"/>
-          <a:chOff x="0" y="0"/>
-          <a:chExt cx="0" cy="0"/>
-        </a:xfrm>
-      </p:grpSpPr>
-      <p:sp>
-        <p:nvSpPr>
-          <p:cNvPr id="2" name="Text 0"/>
-          <p:cNvSpPr/>
-          <p:nvPr/>
-        </p:nvSpPr>
-        <p:spPr>
-          <a:xfrm>
-            <a:off x="548640" y="292608"/>
-            <a:ext cx="11064240" cy="274320"/>
-          </a:xfrm>
-          <a:prstGeom prst="rect">
-            <a:avLst/>
-          </a:prstGeom>
-          <a:noFill/>
-          <a:ln/>
-        </p:spPr>
-        <p:txBody>
-          <a:bodyPr wrap="square" lIns="0" tIns="0" rIns="0" bIns="0" rtlCol="0" anchor="ctr"/>
-          <a:lstStyle/>
-          <a:p>
-            <a:pPr indent="0" marL="0">
-              <a:buNone/>
-            </a:pPr>
-            <a:r>
-              <a:rPr lang="en-US" sz="1100" b="1" dirty="0">
-                <a:solidFill>
-                  <a:srgbClr val="86B332"/>
-                </a:solidFill>
-                <a:latin typeface="Calibri" pitchFamily="34" charset="0"/>
-                <a:ea typeface="Calibri" pitchFamily="34" charset="-122"/>
-                <a:cs typeface="Calibri" pitchFamily="34" charset="-120"/>
-              </a:rPr>
-              <a:t>— </a:t>
-            </a:r>
-            <a:pPr indent="0" marL="0">
-              <a:buNone/>
-            </a:pPr>
-            <a:r>
-              <a:rPr lang="en-US" sz="1100" b="1" spc="200" kern="0" dirty="0">
-                <a:solidFill>
-                  <a:srgbClr val="52514E"/>
-                </a:solidFill>
-                <a:latin typeface="Calibri" pitchFamily="34" charset="0"/>
-                <a:ea typeface="Calibri" pitchFamily="34" charset="-122"/>
-                <a:cs typeface="Calibri" pitchFamily="34" charset="-120"/>
-              </a:rPr>
-              <a:t>OPERATING DRIVERS</a:t>
-            </a:r>
-            <a:endParaRPr lang="en-US" sz="1100" dirty="0"/>
-          </a:p>
-        </p:txBody>
-      </p:sp>
-      <p:sp>
-        <p:nvSpPr>
-          <p:cNvPr id="3" name="Text 1"/>
-          <p:cNvSpPr/>
-          <p:nvPr/>
-        </p:nvSpPr>
-        <p:spPr>
-          <a:xfrm>
-            <a:off x="548640" y="548640"/>
-            <a:ext cx="11064240" cy="502920"/>
-          </a:xfrm>
-          <a:prstGeom prst="rect">
-            <a:avLst/>
-          </a:prstGeom>
-          <a:noFill/>
-          <a:ln/>
-        </p:spPr>
-        <p:txBody>
-          <a:bodyPr wrap="square" lIns="0" tIns="0" rIns="0" bIns="0" rtlCol="0" anchor="ctr"/>
-          <a:lstStyle/>
-          <a:p>
-            <a:pPr indent="0" marL="0">
-              <a:buNone/>
-            </a:pPr>
-            <a:r>
-              <a:rPr lang="en-US" sz="2700" b="1" dirty="0">
-                <a:solidFill>
-                  <a:srgbClr val="0B0B0B"/>
-                </a:solidFill>
-                <a:latin typeface="Calibri" pitchFamily="34" charset="0"/>
-                <a:ea typeface="Calibri" pitchFamily="34" charset="-122"/>
-                <a:cs typeface="Calibri" pitchFamily="34" charset="-120"/>
-              </a:rPr>
-              <a:t>Sales by customer — YTD June 2026</a:t>
-            </a:r>
-            <a:endParaRPr lang="en-US" sz="2700" dirty="0"/>
-          </a:p>
-        </p:txBody>
-      </p:sp>
-      <p:pic>
-        <p:nvPicPr>
-          <p:cNvPr id="4" name="Image 0" descr="/home/user/CVR---Financial/reports/assets/cu.png">    </p:cNvPr>
-          <p:cNvPicPr>
-            <a:picLocks noChangeAspect="1"/>
-          </p:cNvPicPr>
-          <p:nvPr/>
-        </p:nvPicPr>
-        <p:blipFill>
-          <a:blip r:embed="rId1"/>
-          <a:stretch>
-            <a:fillRect/>
-          </a:stretch>
-        </p:blipFill>
-        <p:spPr>
-          <a:xfrm>
-            <a:off x="548640" y="2377440"/>
-            <a:ext cx="7863840" cy="1942310"/>
-          </a:xfrm>
-          <a:prstGeom prst="rect">
-            <a:avLst/>
-          </a:prstGeom>
-        </p:spPr>
-      </p:pic>
-      <p:sp>
-        <p:nvSpPr>
-          <p:cNvPr id="5" name="Text 2"/>
-          <p:cNvSpPr/>
-          <p:nvPr/>
-        </p:nvSpPr>
-        <p:spPr>
-          <a:xfrm>
-            <a:off x="8686800" y="1554480"/>
-            <a:ext cx="2926080" cy="457200"/>
-          </a:xfrm>
-          <a:prstGeom prst="rect">
-            <a:avLst/>
-          </a:prstGeom>
-          <a:noFill/>
-          <a:ln/>
-        </p:spPr>
-        <p:txBody>
-          <a:bodyPr wrap="square" lIns="0" tIns="0" rIns="0" bIns="0" rtlCol="0" anchor="ctr"/>
-          <a:lstStyle/>
-          <a:p>
-            <a:pPr indent="0" marL="0">
-              <a:buNone/>
-            </a:pPr>
-            <a:r>
-              <a:rPr lang="en-US" sz="2800" b="1" dirty="0">
-                <a:solidFill>
-                  <a:srgbClr val="E34948"/>
-                </a:solidFill>
-                <a:latin typeface="Calibri" pitchFamily="34" charset="0"/>
-                <a:ea typeface="Calibri" pitchFamily="34" charset="-122"/>
-                <a:cs typeface="Calibri" pitchFamily="34" charset="-120"/>
-              </a:rPr>
-              <a:t>69.7%</a:t>
-            </a:r>
-            <a:endParaRPr lang="en-US" sz="2800" dirty="0"/>
-          </a:p>
-        </p:txBody>
-      </p:sp>
-      <p:sp>
-        <p:nvSpPr>
-          <p:cNvPr id="6" name="Text 3"/>
-          <p:cNvSpPr/>
-          <p:nvPr/>
-        </p:nvSpPr>
-        <p:spPr>
-          <a:xfrm>
-            <a:off x="8686800" y="2011680"/>
-            <a:ext cx="2926080" cy="868680"/>
-          </a:xfrm>
-          <a:prstGeom prst="rect">
-            <a:avLst/>
-          </a:prstGeom>
-          <a:noFill/>
-          <a:ln/>
-        </p:spPr>
-        <p:txBody>
-          <a:bodyPr wrap="square" lIns="0" tIns="0" rIns="0" bIns="0" rtlCol="0" anchor="ctr"/>
-          <a:lstStyle/>
-          <a:p>
-            <a:pPr indent="0" marL="0">
-              <a:buNone/>
-            </a:pPr>
-            <a:r>
-              <a:rPr lang="en-US" sz="1200" dirty="0">
-                <a:solidFill>
-                  <a:srgbClr val="52514E"/>
-                </a:solidFill>
-                <a:latin typeface="Calibri" pitchFamily="34" charset="0"/>
-                <a:ea typeface="Calibri" pitchFamily="34" charset="-122"/>
-                <a:cs typeface="Calibri" pitchFamily="34" charset="-120"/>
-              </a:rPr>
-              <a:t>of revenue is CenterPoint — matching its ~70% share of billable hours</a:t>
-            </a:r>
-            <a:endParaRPr lang="en-US" sz="1200" dirty="0"/>
-          </a:p>
-        </p:txBody>
-      </p:sp>
-      <p:sp>
-        <p:nvSpPr>
-          <p:cNvPr id="7" name="Text 4"/>
-          <p:cNvSpPr/>
-          <p:nvPr/>
-        </p:nvSpPr>
-        <p:spPr>
-          <a:xfrm>
-            <a:off x="8686800" y="2926080"/>
-            <a:ext cx="2926080" cy="457200"/>
-          </a:xfrm>
-          <a:prstGeom prst="rect">
-            <a:avLst/>
-          </a:prstGeom>
-          <a:noFill/>
-          <a:ln/>
-        </p:spPr>
-        <p:txBody>
-          <a:bodyPr wrap="square" lIns="0" tIns="0" rIns="0" bIns="0" rtlCol="0" anchor="ctr"/>
-          <a:lstStyle/>
-          <a:p>
-            <a:pPr indent="0" marL="0">
-              <a:buNone/>
-            </a:pPr>
-            <a:r>
-              <a:rPr lang="en-US" sz="2800" b="1" dirty="0">
-                <a:solidFill>
-                  <a:srgbClr val="0B0B0B"/>
-                </a:solidFill>
-                <a:latin typeface="Calibri" pitchFamily="34" charset="0"/>
-                <a:ea typeface="Calibri" pitchFamily="34" charset="-122"/>
-                <a:cs typeface="Calibri" pitchFamily="34" charset="-120"/>
-              </a:rPr>
-              <a:t>20.2%</a:t>
-            </a:r>
-            <a:endParaRPr lang="en-US" sz="2800" dirty="0"/>
-          </a:p>
-        </p:txBody>
-      </p:sp>
-      <p:sp>
-        <p:nvSpPr>
-          <p:cNvPr id="8" name="Text 5"/>
-          <p:cNvSpPr/>
-          <p:nvPr/>
-        </p:nvSpPr>
-        <p:spPr>
-          <a:xfrm>
-            <a:off x="8686800" y="3383280"/>
-            <a:ext cx="2926080" cy="868680"/>
-          </a:xfrm>
-          <a:prstGeom prst="rect">
-            <a:avLst/>
-          </a:prstGeom>
-          <a:noFill/>
-          <a:ln/>
-        </p:spPr>
-        <p:txBody>
-          <a:bodyPr wrap="square" lIns="0" tIns="0" rIns="0" bIns="0" rtlCol="0" anchor="ctr"/>
-          <a:lstStyle/>
-          <a:p>
-            <a:pPr indent="0" marL="0">
-              <a:buNone/>
-            </a:pPr>
-            <a:r>
-              <a:rPr lang="en-US" sz="1200" dirty="0">
-                <a:solidFill>
-                  <a:srgbClr val="52514E"/>
-                </a:solidFill>
-                <a:latin typeface="Calibri" pitchFamily="34" charset="0"/>
-                <a:ea typeface="Calibri" pitchFamily="34" charset="-122"/>
-                <a:cs typeface="Calibri" pitchFamily="34" charset="-120"/>
-              </a:rPr>
-              <a:t>intercompany work for Hydaker-Wheatlake (rate treatment under review)</a:t>
-            </a:r>
-            <a:endParaRPr lang="en-US" sz="1200" dirty="0"/>
-          </a:p>
-        </p:txBody>
-      </p:sp>
-      <p:sp>
-        <p:nvSpPr>
-          <p:cNvPr id="9" name="Text 6"/>
-          <p:cNvSpPr/>
-          <p:nvPr/>
-        </p:nvSpPr>
-        <p:spPr>
-          <a:xfrm>
-            <a:off x="8686800" y="4297680"/>
-            <a:ext cx="2926080" cy="457200"/>
-          </a:xfrm>
-          <a:prstGeom prst="rect">
-            <a:avLst/>
-          </a:prstGeom>
-          <a:noFill/>
-          <a:ln/>
-        </p:spPr>
-        <p:txBody>
-          <a:bodyPr wrap="square" lIns="0" tIns="0" rIns="0" bIns="0" rtlCol="0" anchor="ctr"/>
-          <a:lstStyle/>
-          <a:p>
-            <a:pPr indent="0" marL="0">
-              <a:buNone/>
-            </a:pPr>
-            <a:r>
-              <a:rPr lang="en-US" sz="2800" b="1" dirty="0">
-                <a:solidFill>
-                  <a:srgbClr val="0B0B0B"/>
-                </a:solidFill>
-                <a:latin typeface="Calibri" pitchFamily="34" charset="0"/>
-                <a:ea typeface="Calibri" pitchFamily="34" charset="-122"/>
-                <a:cs typeface="Calibri" pitchFamily="34" charset="-120"/>
-              </a:rPr>
-              <a:t>~10%</a:t>
-            </a:r>
-            <a:endParaRPr lang="en-US" sz="2800" dirty="0"/>
-          </a:p>
-        </p:txBody>
-      </p:sp>
-      <p:sp>
-        <p:nvSpPr>
-          <p:cNvPr id="10" name="Text 7"/>
-          <p:cNvSpPr/>
-          <p:nvPr/>
-        </p:nvSpPr>
-        <p:spPr>
-          <a:xfrm>
-            <a:off x="8686800" y="4754880"/>
-            <a:ext cx="2926080" cy="868680"/>
-          </a:xfrm>
-          <a:prstGeom prst="rect">
-            <a:avLst/>
-          </a:prstGeom>
-          <a:noFill/>
-          <a:ln/>
-        </p:spPr>
-        <p:txBody>
-          <a:bodyPr wrap="square" lIns="0" tIns="0" rIns="0" bIns="0" rtlCol="0" anchor="ctr"/>
-          <a:lstStyle/>
-          <a:p>
-            <a:pPr indent="0" marL="0">
-              <a:buNone/>
-            </a:pPr>
-            <a:r>
-              <a:rPr lang="en-US" sz="1200" dirty="0">
-                <a:solidFill>
-                  <a:srgbClr val="52514E"/>
-                </a:solidFill>
-                <a:latin typeface="Calibri" pitchFamily="34" charset="0"/>
-                <a:ea typeface="Calibri" pitchFamily="34" charset="-122"/>
-                <a:cs typeface="Calibri" pitchFamily="34" charset="-120"/>
-              </a:rPr>
-              <a:t>all other external customers combined — diversification is the growth agenda</a:t>
-            </a:r>
-            <a:endParaRPr lang="en-US" sz="1200" dirty="0"/>
-          </a:p>
-        </p:txBody>
-      </p:sp>
-      <p:sp>
-        <p:nvSpPr>
-          <p:cNvPr id="11" name="Text 8"/>
-          <p:cNvSpPr/>
-          <p:nvPr/>
-        </p:nvSpPr>
-        <p:spPr>
-          <a:xfrm>
-            <a:off x="548640" y="6419088"/>
-            <a:ext cx="11064240" cy="320040"/>
-          </a:xfrm>
-          <a:prstGeom prst="rect">
-            <a:avLst/>
-          </a:prstGeom>
-          <a:noFill/>
-          <a:ln/>
-        </p:spPr>
-        <p:txBody>
-          <a:bodyPr wrap="square" lIns="0" tIns="0" rIns="0" bIns="0" rtlCol="0" anchor="ctr"/>
-          <a:lstStyle/>
-          <a:p>
-            <a:pPr indent="0" marL="0">
-              <a:buNone/>
-            </a:pPr>
-            <a:r>
-              <a:rPr lang="en-US" sz="950" dirty="0">
-                <a:solidFill>
-                  <a:srgbClr val="898781"/>
-                </a:solidFill>
-                <a:latin typeface="Calibri" pitchFamily="34" charset="0"/>
-                <a:ea typeface="Calibri" pitchFamily="34" charset="-122"/>
-                <a:cs typeface="Calibri" pitchFamily="34" charset="-120"/>
-              </a:rPr>
-              <a:t>GL sales-by-customer schedule, 6/30/26. Total $551.0K.</a:t>
             </a:r>
             <a:endParaRPr lang="en-US" sz="950" dirty="0"/>
           </a:p>

</xml_diff>

<commit_message>
Reconcile Phase 2 forecast engine to finance's 2026 budget
Re-ground the forecast cost side on finance's budget: direct labor =
billable hrs x $54.89 (budget rate), total loaded labor $12,189/FTE-mo,
non-labor OpEx $21,748/mo, overhead $17,250/mo. Engine now reproduces
the budget dollar-for-dollar at the budget operating point. New 'vs
Budget' tab compares forecast to finance's monthly budget line by line.

More conservative (accurate) results: FY27 Base NI +$432K -> +$123K,
OILI 17.3% -> 4.9%; parent note now grows to $3.67M (+$231K) through
2027 rather than paying down; Upside reaches the 20% OILI aspiration.
Deck forward-view slides (exec summary, FY landing, scenarios, cash/
note), note.png, dashboard note chart, and PHASE2_FORECAST.md updated
to match.

Co-Authored-By: Claude Fable 5 <noreply@anthropic.com>
Claude-Session: https://claude.ai/code/session_0145i7FWr3AQEo26DBw1x2c4
</commit_message>
<xml_diff>
--- a/reports/CVR_Deck_Jun2026.pptx
+++ b/reports/CVR_Deck_Jun2026.pptx
@@ -18714,7 +18714,7 @@
                           <a:ea typeface="Calibri" pitchFamily="34" charset="-122"/>
                           <a:cs typeface="Calibri" pitchFamily="34" charset="-120"/>
                         </a:rPr>
-                        <a:t>422.4</a:t>
+                        <a:t>496.9</a:t>
                       </a:r>
                       <a:endParaRPr lang="en-US" sz="1100" dirty="0">
                         <a:latin typeface="Calibri" charset="0"/>
@@ -18782,7 +18782,7 @@
                           <a:ea typeface="Calibri" pitchFamily="34" charset="-122"/>
                           <a:cs typeface="Calibri" pitchFamily="34" charset="-120"/>
                         </a:rPr>
-                        <a:t>544.9</a:t>
+                        <a:t>619.4</a:t>
                       </a:r>
                       <a:endParaRPr lang="en-US" sz="1100" dirty="0">
                         <a:latin typeface="Calibri" charset="0"/>
@@ -19056,7 +19056,7 @@
                           <a:ea typeface="Calibri" pitchFamily="34" charset="-122"/>
                           <a:cs typeface="Calibri" pitchFamily="34" charset="-120"/>
                         </a:rPr>
-                        <a:t>−0.5</a:t>
+                        <a:t>−129.9</a:t>
                       </a:r>
                       <a:endParaRPr lang="en-US" sz="1100" dirty="0">
                         <a:latin typeface="Calibri" charset="0"/>
@@ -19124,7 +19124,7 @@
                           <a:ea typeface="Calibri" pitchFamily="34" charset="-122"/>
                           <a:cs typeface="Calibri" pitchFamily="34" charset="-120"/>
                         </a:rPr>
-                        <a:t>−291.0</a:t>
+                        <a:t>−420.4</a:t>
                       </a:r>
                       <a:endParaRPr lang="en-US" sz="1100" dirty="0">
                         <a:latin typeface="Calibri" charset="0"/>
@@ -19398,7 +19398,7 @@
                           <a:ea typeface="Calibri" pitchFamily="34" charset="-122"/>
                           <a:cs typeface="Calibri" pitchFamily="34" charset="-120"/>
                         </a:rPr>
-                        <a:t>−31.3</a:t>
+                        <a:t>−161.2</a:t>
                       </a:r>
                       <a:endParaRPr lang="en-US" sz="1100" dirty="0">
                         <a:latin typeface="Calibri" charset="0"/>
@@ -19466,7 +19466,7 @@
                           <a:ea typeface="Calibri" pitchFamily="34" charset="-122"/>
                           <a:cs typeface="Calibri" pitchFamily="34" charset="-120"/>
                         </a:rPr>
-                        <a:t>−351.8</a:t>
+                        <a:t>−481.7</a:t>
                       </a:r>
                       <a:endParaRPr lang="en-US" sz="1100" dirty="0">
                         <a:latin typeface="Calibri" charset="0"/>
@@ -20115,7 +20115,7 @@
                           <a:ea typeface="Calibri" pitchFamily="34" charset="-122"/>
                           <a:cs typeface="Calibri" pitchFamily="34" charset="-120"/>
                         </a:rPr>
-                        <a:t>+431.6</a:t>
+                        <a:t>+122.7</a:t>
                       </a:r>
                       <a:endParaRPr lang="en-US" sz="1100" dirty="0">
                         <a:latin typeface="Calibri" charset="0"/>
@@ -20321,7 +20321,7 @@
                           <a:ea typeface="Calibri" pitchFamily="34" charset="-122"/>
                           <a:cs typeface="Calibri" pitchFamily="34" charset="-120"/>
                         </a:rPr>
-                        <a:t>17.3%</a:t>
+                        <a:t>4.9%</a:t>
                       </a:r>
                       <a:endParaRPr lang="en-US" sz="1100" dirty="0">
                         <a:latin typeface="Calibri" charset="0"/>
@@ -20902,7 +20902,7 @@
                           <a:ea typeface="Calibri" pitchFamily="34" charset="-122"/>
                           <a:cs typeface="Calibri" pitchFamily="34" charset="-120"/>
                         </a:rPr>
-                        <a:t>−205</a:t>
+                        <a:t>−346</a:t>
                       </a:r>
                       <a:endParaRPr lang="en-US" sz="1050" dirty="0">
                         <a:latin typeface="Calibri" charset="0"/>
@@ -21038,7 +21038,7 @@
                           <a:ea typeface="Calibri" pitchFamily="34" charset="-122"/>
                           <a:cs typeface="Calibri" pitchFamily="34" charset="-120"/>
                         </a:rPr>
-                        <a:t>+1,054</a:t>
+                        <a:t>+689</a:t>
                       </a:r>
                       <a:endParaRPr lang="en-US" sz="1050" dirty="0">
                         <a:latin typeface="Calibri" charset="0"/>
@@ -21106,7 +21106,7 @@
                           <a:ea typeface="Calibri" pitchFamily="34" charset="-122"/>
                           <a:cs typeface="Calibri" pitchFamily="34" charset="-120"/>
                         </a:rPr>
-                        <a:t>30.7%</a:t>
+                        <a:t>20.0%</a:t>
                       </a:r>
                       <a:endParaRPr lang="en-US" sz="1050" dirty="0">
                         <a:latin typeface="Calibri" charset="0"/>
@@ -21244,7 +21244,7 @@
                           <a:ea typeface="Calibri" pitchFamily="34" charset="-122"/>
                           <a:cs typeface="Calibri" pitchFamily="34" charset="-120"/>
                         </a:rPr>
-                        <a:t>−352</a:t>
+                        <a:t>−482</a:t>
                       </a:r>
                       <a:endParaRPr lang="en-US" sz="1050" dirty="0">
                         <a:latin typeface="Calibri" charset="0"/>
@@ -21380,7 +21380,7 @@
                           <a:ea typeface="Calibri" pitchFamily="34" charset="-122"/>
                           <a:cs typeface="Calibri" pitchFamily="34" charset="-120"/>
                         </a:rPr>
-                        <a:t>+432</a:t>
+                        <a:t>+123</a:t>
                       </a:r>
                       <a:endParaRPr lang="en-US" sz="1050" dirty="0">
                         <a:latin typeface="Calibri" charset="0"/>
@@ -21448,7 +21448,7 @@
                           <a:ea typeface="Calibri" pitchFamily="34" charset="-122"/>
                           <a:cs typeface="Calibri" pitchFamily="34" charset="-120"/>
                         </a:rPr>
-                        <a:t>17.3%</a:t>
+                        <a:t>4.9%</a:t>
                       </a:r>
                       <a:endParaRPr lang="en-US" sz="1050" dirty="0">
                         <a:latin typeface="Calibri" charset="0"/>
@@ -21586,7 +21586,7 @@
                           <a:ea typeface="Calibri" pitchFamily="34" charset="-122"/>
                           <a:cs typeface="Calibri" pitchFamily="34" charset="-120"/>
                         </a:rPr>
-                        <a:t>−444</a:t>
+                        <a:t>−568</a:t>
                       </a:r>
                       <a:endParaRPr lang="en-US" sz="1050" dirty="0">
                         <a:latin typeface="Calibri" charset="0"/>
@@ -21722,7 +21722,7 @@
                           <a:ea typeface="Calibri" pitchFamily="34" charset="-122"/>
                           <a:cs typeface="Calibri" pitchFamily="34" charset="-120"/>
                         </a:rPr>
-                        <a:t>−205</a:t>
+                        <a:t>−458</a:t>
                       </a:r>
                       <a:endParaRPr lang="en-US" sz="1050" dirty="0">
                         <a:latin typeface="Calibri" charset="0"/>
@@ -21790,7 +21790,7 @@
                           <a:ea typeface="Calibri" pitchFamily="34" charset="-122"/>
                           <a:cs typeface="Calibri" pitchFamily="34" charset="-120"/>
                         </a:rPr>
-                        <a:t>−13.3%</a:t>
+                        <a:t>−29.7%</a:t>
                       </a:r>
                       <a:endParaRPr lang="en-US" sz="1050" dirty="0">
                         <a:latin typeface="Calibri" charset="0"/>
@@ -21949,7 +21949,7 @@
                 <a:ea typeface="Calibri" pitchFamily="34" charset="-122"/>
                 <a:cs typeface="Calibri" pitchFamily="34" charset="-120"/>
               </a:rPr>
-              <a:t>The 2026 budget is out of reach — socialize the re-forecast rather than track to a 2.7× H2 run-rate.</a:t>
+              <a:t>Cost is now finance's fully-loaded basis — the forecast reconciles to the budget dollar-for-dollar.</a:t>
             </a:r>
             <a:endParaRPr lang="en-US" sz="1200" dirty="0"/>
           </a:p>
@@ -21970,7 +21970,7 @@
                 <a:ea typeface="Calibri" pitchFamily="34" charset="-122"/>
                 <a:cs typeface="Calibri" pitchFamily="34" charset="-120"/>
               </a:rPr>
-              <a:t>Monthly net income turns positive in November 2026 in the Base case.</a:t>
+              <a:t>The 2026 budget is out of reach; the honest FY26 landing is ~$1.42M revenue and a $480K loss.</a:t>
             </a:r>
             <a:endParaRPr lang="en-US" sz="1200" dirty="0"/>
           </a:p>
@@ -21991,7 +21991,7 @@
                 <a:ea typeface="Calibri" pitchFamily="34" charset="-122"/>
                 <a:cs typeface="Calibri" pitchFamily="34" charset="-120"/>
               </a:rPr>
-              <a:t>The 20% OILI return is a performance goal — reachable. The $6M revenue is a capacity goal (~27 billable FTEs).</a:t>
+              <a:t>FY27 turns positive in the Base case (+$123K); the Upside path reaches the 20% OILI aspiration.</a:t>
             </a:r>
             <a:endParaRPr lang="en-US" sz="1200" dirty="0"/>
           </a:p>
@@ -22012,7 +22012,7 @@
                 <a:ea typeface="Calibri" pitchFamily="34" charset="-122"/>
                 <a:cs typeface="Calibri" pitchFamily="34" charset="-120"/>
               </a:rPr>
-              <a:t>Utilization and realization are the two levers that double revenue on the current roster.</a:t>
+              <a:t>Utilization and realization are the levers — the $6M / 20% target is a capacity build (~27 FTEs).</a:t>
             </a:r>
             <a:endParaRPr lang="en-US" sz="1200" dirty="0"/>
           </a:p>
@@ -22303,13 +22303,13 @@
             <a:r>
               <a:rPr lang="en-US" sz="3000" b="1" dirty="0">
                 <a:solidFill>
-                  <a:srgbClr val="0B0B0B"/>
+                  <a:srgbClr val="E34948"/>
                 </a:solidFill>
                 <a:latin typeface="Calibri" pitchFamily="34" charset="0"/>
                 <a:ea typeface="Calibri" pitchFamily="34" charset="-122"/>
                 <a:cs typeface="Calibri" pitchFamily="34" charset="-120"/>
               </a:rPr>
-              <a:t>$3.59M</a:t>
+              <a:t>$3.77M</a:t>
             </a:r>
             <a:endParaRPr lang="en-US" sz="3000" dirty="0"/>
           </a:p>
@@ -22348,7 +22348,7 @@
                 <a:ea typeface="Calibri" pitchFamily="34" charset="-122"/>
                 <a:cs typeface="Calibri" pitchFamily="34" charset="-120"/>
               </a:rPr>
-              <a:t>Base-case peak in Jan-27, then a steady decline</a:t>
+              <a:t>Base-case peak in mid-2027 — the note keeps growing while the turnaround builds</a:t>
             </a:r>
             <a:endParaRPr lang="en-US" sz="1200" dirty="0"/>
           </a:p>
@@ -22381,13 +22381,13 @@
             <a:r>
               <a:rPr lang="en-US" sz="3000" b="1" dirty="0">
                 <a:solidFill>
-                  <a:srgbClr val="006300"/>
+                  <a:srgbClr val="E34948"/>
                 </a:solidFill>
                 <a:latin typeface="Calibri" pitchFamily="34" charset="0"/>
                 <a:ea typeface="Calibri" pitchFamily="34" charset="-122"/>
                 <a:cs typeface="Calibri" pitchFamily="34" charset="-120"/>
               </a:rPr>
-              <a:t>−$209K</a:t>
+              <a:t>+$231K</a:t>
             </a:r>
             <a:endParaRPr lang="en-US" sz="3000" dirty="0"/>
           </a:p>
@@ -22426,7 +22426,7 @@
                 <a:ea typeface="Calibri" pitchFamily="34" charset="-122"/>
                 <a:cs typeface="Calibri" pitchFamily="34" charset="-120"/>
               </a:rPr>
-              <a:t>paydown by Dec-27 in the Base case; Downside grows it to $3.82M</a:t>
+              <a:t>still drawing by end-2027 in the Base case; only the Upside path flattens and repays it</a:t>
             </a:r>
             <a:endParaRPr lang="en-US" sz="1200" dirty="0"/>
           </a:p>
@@ -22465,7 +22465,7 @@
                 <a:ea typeface="Calibri" pitchFamily="34" charset="-122"/>
                 <a:cs typeface="Calibri" pitchFamily="34" charset="-120"/>
               </a:rPr>
-              <a:t>CVR holds no cash: deficits draw the note, surpluses repay it (~$5K/mo interest accrues). If the balance isn't flattening by Q1-27, the drivers aren't moving.</a:t>
+              <a:t>CVR holds no cash: deficits draw the note, surpluses repay it (~$5K/mo interest accrues). Reconciled to finance's fully-loaded cost — a more conservative trajectory than the prior estimate.</a:t>
             </a:r>
             <a:endParaRPr lang="en-US" sz="950" dirty="0"/>
           </a:p>
@@ -26393,7 +26393,7 @@
                 <a:ea typeface="Calibri" pitchFamily="34" charset="-122"/>
                 <a:cs typeface="Calibri" pitchFamily="34" charset="-120"/>
               </a:rPr>
-              <a:t>The Base forecast turns monthly net income positive in November 2026 and delivers a 17.3% OILI return in 2027 — with the $6M revenue goal requiring a deliberate capacity build beyond it.</a:t>
+              <a:t>The Base forecast (reconciled to finance's fully-loaded cost) turns FY2027 net income positive at +$123K — with the $6M / 20% OILI target requiring a deliberate capacity build beyond it.</a:t>
             </a:r>
             <a:endParaRPr lang="en-US" sz="1500" dirty="0"/>
           </a:p>
@@ -26576,7 +26576,7 @@
                 <a:ea typeface="Calibri" pitchFamily="34" charset="-122"/>
                 <a:cs typeface="Calibri" pitchFamily="34" charset="-120"/>
               </a:rPr>
-              <a:t>$1.42M rev · −$352K</a:t>
+              <a:t>$1.42M rev · −$482K</a:t>
             </a:r>
             <a:endParaRPr lang="en-US" sz="2100" dirty="0"/>
           </a:p>
@@ -26654,7 +26654,7 @@
                 <a:ea typeface="Calibri" pitchFamily="34" charset="-122"/>
                 <a:cs typeface="Calibri" pitchFamily="34" charset="-120"/>
               </a:rPr>
-              <a:t>$2.50M rev · +$432K</a:t>
+              <a:t>$2.50M rev · +$123K</a:t>
             </a:r>
             <a:endParaRPr lang="en-US" sz="2100" dirty="0"/>
           </a:p>

</xml_diff>

<commit_message>
Consumers pole replacement won ($300K) — move from pipeline to backlog
Consumers 2026 Pole Replacements awarded at $300K (up from the $276.5K
listed). Moved from probability-weighted pipeline to booked backlog at
100% across the model, deck, and dashboard:
- Phase 2 Backlog & Pipeline tab + Coverage Chart schedule arrays updated
- Deck: backlog table adds the won job (total $697K -> $997K); pipeline
  table marks it WON -> backlog (pending ex-won $1,900K / $950K weighted);
  coverage callouts 49%/21%/$1,724K -> 52%/30%/$1,609K; market slide and
  accounting slide EPC-paired figures updated ($12.6M -> $9.1M remaining)
- Dashboard coverage chart data + cov.png re-rendered

Co-Authored-By: Claude Fable 5 <noreply@anthropic.com>
Claude-Session: https://claude.ai/code/session_0145i7FWr3AQEo26DBw1x2c4
</commit_message>
<xml_diff>
--- a/reports/CVR_Deck_Jun2026.pptx
+++ b/reports/CVR_Deck_Jun2026.pptx
@@ -4216,6 +4216,416 @@
                         <a:buNone/>
                       </a:pPr>
                       <a:r>
+                        <a:rPr lang="en-US" sz="1050" b="1" dirty="0">
+                          <a:solidFill>
+                            <a:srgbClr val="006300"/>
+                          </a:solidFill>
+                          <a:latin typeface="Calibri" pitchFamily="34" charset="0"/>
+                          <a:ea typeface="Calibri" pitchFamily="34" charset="-122"/>
+                          <a:cs typeface="Calibri" pitchFamily="34" charset="-120"/>
+                        </a:rPr>
+                        <a:t>NEW</a:t>
+                      </a:r>
+                      <a:endParaRPr lang="en-US" sz="1050" dirty="0">
+                        <a:latin typeface="Calibri" charset="0"/>
+                        <a:ea typeface="Calibri" charset="0"/>
+                        <a:cs typeface="Calibri" charset="0"/>
+                      </a:endParaRPr>
+                    </a:p>
+                  </a:txBody>
+                  <a:tcPr marL="91440" marR="91440" marT="45720" marB="45720" anchor="ctr">
+                    <a:lnL w="6350" cap="flat" cmpd="sng" algn="ctr">
+                      <a:solidFill>
+                        <a:srgbClr val="E1E0D9"/>
+                      </a:solidFill>
+                      <a:prstDash val="solid"/>
+                      <a:round/>
+                      <a:headEnd type="none" w="med" len="med"/>
+                      <a:tailEnd type="none" w="med" len="med"/>
+                    </a:lnL>
+                    <a:lnR w="6350" cap="flat" cmpd="sng" algn="ctr">
+                      <a:solidFill>
+                        <a:srgbClr val="E1E0D9"/>
+                      </a:solidFill>
+                      <a:prstDash val="solid"/>
+                      <a:round/>
+                      <a:headEnd type="none" w="med" len="med"/>
+                      <a:tailEnd type="none" w="med" len="med"/>
+                    </a:lnR>
+                    <a:lnT w="6350" cap="flat" cmpd="sng" algn="ctr">
+                      <a:solidFill>
+                        <a:srgbClr val="E1E0D9"/>
+                      </a:solidFill>
+                      <a:prstDash val="solid"/>
+                      <a:round/>
+                      <a:headEnd type="none" w="med" len="med"/>
+                      <a:tailEnd type="none" w="med" len="med"/>
+                    </a:lnT>
+                    <a:lnB w="6350" cap="flat" cmpd="sng" algn="ctr">
+                      <a:solidFill>
+                        <a:srgbClr val="E1E0D9"/>
+                      </a:solidFill>
+                      <a:prstDash val="solid"/>
+                      <a:round/>
+                      <a:headEnd type="none" w="med" len="med"/>
+                      <a:tailEnd type="none" w="med" len="med"/>
+                    </a:lnB>
+                    <a:solidFill>
+                      <a:srgbClr val="FFFFFF"/>
+                    </a:solidFill>
+                  </a:tcPr>
+                </a:tc>
+                <a:tc>
+                  <a:txBody>
+                    <a:bodyPr/>
+                    <a:lstStyle/>
+                    <a:p>
+                      <a:pPr algn="l" indent="0" marL="0">
+                        <a:buNone/>
+                      </a:pPr>
+                      <a:r>
+                        <a:rPr lang="en-US" sz="1050" b="1" dirty="0">
+                          <a:solidFill>
+                            <a:srgbClr val="0B0B0B"/>
+                          </a:solidFill>
+                          <a:latin typeface="Calibri" pitchFamily="34" charset="0"/>
+                          <a:ea typeface="Calibri" pitchFamily="34" charset="-122"/>
+                          <a:cs typeface="Calibri" pitchFamily="34" charset="-120"/>
+                        </a:rPr>
+                        <a:t>Consumers — 2026 Pole Replacements (WON)</a:t>
+                      </a:r>
+                      <a:endParaRPr lang="en-US" sz="1050" dirty="0">
+                        <a:latin typeface="Calibri" charset="0"/>
+                        <a:ea typeface="Calibri" charset="0"/>
+                        <a:cs typeface="Calibri" charset="0"/>
+                      </a:endParaRPr>
+                    </a:p>
+                  </a:txBody>
+                  <a:tcPr marL="91440" marR="91440" marT="45720" marB="45720" anchor="ctr">
+                    <a:lnL w="6350" cap="flat" cmpd="sng" algn="ctr">
+                      <a:solidFill>
+                        <a:srgbClr val="E1E0D9"/>
+                      </a:solidFill>
+                      <a:prstDash val="solid"/>
+                      <a:round/>
+                      <a:headEnd type="none" w="med" len="med"/>
+                      <a:tailEnd type="none" w="med" len="med"/>
+                    </a:lnL>
+                    <a:lnR w="6350" cap="flat" cmpd="sng" algn="ctr">
+                      <a:solidFill>
+                        <a:srgbClr val="E1E0D9"/>
+                      </a:solidFill>
+                      <a:prstDash val="solid"/>
+                      <a:round/>
+                      <a:headEnd type="none" w="med" len="med"/>
+                      <a:tailEnd type="none" w="med" len="med"/>
+                    </a:lnR>
+                    <a:lnT w="6350" cap="flat" cmpd="sng" algn="ctr">
+                      <a:solidFill>
+                        <a:srgbClr val="E1E0D9"/>
+                      </a:solidFill>
+                      <a:prstDash val="solid"/>
+                      <a:round/>
+                      <a:headEnd type="none" w="med" len="med"/>
+                      <a:tailEnd type="none" w="med" len="med"/>
+                    </a:lnT>
+                    <a:lnB w="6350" cap="flat" cmpd="sng" algn="ctr">
+                      <a:solidFill>
+                        <a:srgbClr val="E1E0D9"/>
+                      </a:solidFill>
+                      <a:prstDash val="solid"/>
+                      <a:round/>
+                      <a:headEnd type="none" w="med" len="med"/>
+                      <a:tailEnd type="none" w="med" len="med"/>
+                    </a:lnB>
+                    <a:solidFill>
+                      <a:srgbClr val="FFFFFF"/>
+                    </a:solidFill>
+                  </a:tcPr>
+                </a:tc>
+                <a:tc>
+                  <a:txBody>
+                    <a:bodyPr/>
+                    <a:lstStyle/>
+                    <a:p>
+                      <a:pPr algn="l" indent="0" marL="0">
+                        <a:buNone/>
+                      </a:pPr>
+                      <a:r>
+                        <a:rPr lang="en-US" sz="1050" dirty="0">
+                          <a:solidFill>
+                            <a:srgbClr val="0B0B0B"/>
+                          </a:solidFill>
+                          <a:latin typeface="Calibri" pitchFamily="34" charset="0"/>
+                          <a:ea typeface="Calibri" pitchFamily="34" charset="-122"/>
+                          <a:cs typeface="Calibri" pitchFamily="34" charset="-120"/>
+                        </a:rPr>
+                        <a:t>$300.0K</a:t>
+                      </a:r>
+                      <a:endParaRPr lang="en-US" sz="1050" dirty="0">
+                        <a:latin typeface="Calibri" charset="0"/>
+                        <a:ea typeface="Calibri" charset="0"/>
+                        <a:cs typeface="Calibri" charset="0"/>
+                      </a:endParaRPr>
+                    </a:p>
+                  </a:txBody>
+                  <a:tcPr marL="91440" marR="91440" marT="45720" marB="45720" anchor="ctr">
+                    <a:lnL w="6350" cap="flat" cmpd="sng" algn="ctr">
+                      <a:solidFill>
+                        <a:srgbClr val="E1E0D9"/>
+                      </a:solidFill>
+                      <a:prstDash val="solid"/>
+                      <a:round/>
+                      <a:headEnd type="none" w="med" len="med"/>
+                      <a:tailEnd type="none" w="med" len="med"/>
+                    </a:lnL>
+                    <a:lnR w="6350" cap="flat" cmpd="sng" algn="ctr">
+                      <a:solidFill>
+                        <a:srgbClr val="E1E0D9"/>
+                      </a:solidFill>
+                      <a:prstDash val="solid"/>
+                      <a:round/>
+                      <a:headEnd type="none" w="med" len="med"/>
+                      <a:tailEnd type="none" w="med" len="med"/>
+                    </a:lnR>
+                    <a:lnT w="6350" cap="flat" cmpd="sng" algn="ctr">
+                      <a:solidFill>
+                        <a:srgbClr val="E1E0D9"/>
+                      </a:solidFill>
+                      <a:prstDash val="solid"/>
+                      <a:round/>
+                      <a:headEnd type="none" w="med" len="med"/>
+                      <a:tailEnd type="none" w="med" len="med"/>
+                    </a:lnT>
+                    <a:lnB w="6350" cap="flat" cmpd="sng" algn="ctr">
+                      <a:solidFill>
+                        <a:srgbClr val="E1E0D9"/>
+                      </a:solidFill>
+                      <a:prstDash val="solid"/>
+                      <a:round/>
+                      <a:headEnd type="none" w="med" len="med"/>
+                      <a:tailEnd type="none" w="med" len="med"/>
+                    </a:lnB>
+                    <a:solidFill>
+                      <a:srgbClr val="FFFFFF"/>
+                    </a:solidFill>
+                  </a:tcPr>
+                </a:tc>
+                <a:tc>
+                  <a:txBody>
+                    <a:bodyPr/>
+                    <a:lstStyle/>
+                    <a:p>
+                      <a:pPr algn="l" indent="0" marL="0">
+                        <a:buNone/>
+                      </a:pPr>
+                      <a:r>
+                        <a:rPr lang="en-US" sz="1050" dirty="0">
+                          <a:solidFill>
+                            <a:srgbClr val="0B0B0B"/>
+                          </a:solidFill>
+                          <a:latin typeface="Calibri" pitchFamily="34" charset="0"/>
+                          <a:ea typeface="Calibri" pitchFamily="34" charset="-122"/>
+                          <a:cs typeface="Calibri" pitchFamily="34" charset="-120"/>
+                        </a:rPr>
+                        <a:t>$0.0K</a:t>
+                      </a:r>
+                      <a:endParaRPr lang="en-US" sz="1050" dirty="0">
+                        <a:latin typeface="Calibri" charset="0"/>
+                        <a:ea typeface="Calibri" charset="0"/>
+                        <a:cs typeface="Calibri" charset="0"/>
+                      </a:endParaRPr>
+                    </a:p>
+                  </a:txBody>
+                  <a:tcPr marL="91440" marR="91440" marT="45720" marB="45720" anchor="ctr">
+                    <a:lnL w="6350" cap="flat" cmpd="sng" algn="ctr">
+                      <a:solidFill>
+                        <a:srgbClr val="E1E0D9"/>
+                      </a:solidFill>
+                      <a:prstDash val="solid"/>
+                      <a:round/>
+                      <a:headEnd type="none" w="med" len="med"/>
+                      <a:tailEnd type="none" w="med" len="med"/>
+                    </a:lnL>
+                    <a:lnR w="6350" cap="flat" cmpd="sng" algn="ctr">
+                      <a:solidFill>
+                        <a:srgbClr val="E1E0D9"/>
+                      </a:solidFill>
+                      <a:prstDash val="solid"/>
+                      <a:round/>
+                      <a:headEnd type="none" w="med" len="med"/>
+                      <a:tailEnd type="none" w="med" len="med"/>
+                    </a:lnR>
+                    <a:lnT w="6350" cap="flat" cmpd="sng" algn="ctr">
+                      <a:solidFill>
+                        <a:srgbClr val="E1E0D9"/>
+                      </a:solidFill>
+                      <a:prstDash val="solid"/>
+                      <a:round/>
+                      <a:headEnd type="none" w="med" len="med"/>
+                      <a:tailEnd type="none" w="med" len="med"/>
+                    </a:lnT>
+                    <a:lnB w="6350" cap="flat" cmpd="sng" algn="ctr">
+                      <a:solidFill>
+                        <a:srgbClr val="E1E0D9"/>
+                      </a:solidFill>
+                      <a:prstDash val="solid"/>
+                      <a:round/>
+                      <a:headEnd type="none" w="med" len="med"/>
+                      <a:tailEnd type="none" w="med" len="med"/>
+                    </a:lnB>
+                    <a:solidFill>
+                      <a:srgbClr val="FFFFFF"/>
+                    </a:solidFill>
+                  </a:tcPr>
+                </a:tc>
+                <a:tc>
+                  <a:txBody>
+                    <a:bodyPr/>
+                    <a:lstStyle/>
+                    <a:p>
+                      <a:pPr algn="l" indent="0" marL="0">
+                        <a:buNone/>
+                      </a:pPr>
+                      <a:r>
+                        <a:rPr lang="en-US" sz="1050" b="1" dirty="0">
+                          <a:solidFill>
+                            <a:srgbClr val="0B0B0B"/>
+                          </a:solidFill>
+                          <a:latin typeface="Calibri" pitchFamily="34" charset="0"/>
+                          <a:ea typeface="Calibri" pitchFamily="34" charset="-122"/>
+                          <a:cs typeface="Calibri" pitchFamily="34" charset="-120"/>
+                        </a:rPr>
+                        <a:t>$300.0K</a:t>
+                      </a:r>
+                      <a:endParaRPr lang="en-US" sz="1050" dirty="0">
+                        <a:latin typeface="Calibri" charset="0"/>
+                        <a:ea typeface="Calibri" charset="0"/>
+                        <a:cs typeface="Calibri" charset="0"/>
+                      </a:endParaRPr>
+                    </a:p>
+                  </a:txBody>
+                  <a:tcPr marL="91440" marR="91440" marT="45720" marB="45720" anchor="ctr">
+                    <a:lnL w="6350" cap="flat" cmpd="sng" algn="ctr">
+                      <a:solidFill>
+                        <a:srgbClr val="E1E0D9"/>
+                      </a:solidFill>
+                      <a:prstDash val="solid"/>
+                      <a:round/>
+                      <a:headEnd type="none" w="med" len="med"/>
+                      <a:tailEnd type="none" w="med" len="med"/>
+                    </a:lnL>
+                    <a:lnR w="6350" cap="flat" cmpd="sng" algn="ctr">
+                      <a:solidFill>
+                        <a:srgbClr val="E1E0D9"/>
+                      </a:solidFill>
+                      <a:prstDash val="solid"/>
+                      <a:round/>
+                      <a:headEnd type="none" w="med" len="med"/>
+                      <a:tailEnd type="none" w="med" len="med"/>
+                    </a:lnR>
+                    <a:lnT w="6350" cap="flat" cmpd="sng" algn="ctr">
+                      <a:solidFill>
+                        <a:srgbClr val="E1E0D9"/>
+                      </a:solidFill>
+                      <a:prstDash val="solid"/>
+                      <a:round/>
+                      <a:headEnd type="none" w="med" len="med"/>
+                      <a:tailEnd type="none" w="med" len="med"/>
+                    </a:lnT>
+                    <a:lnB w="6350" cap="flat" cmpd="sng" algn="ctr">
+                      <a:solidFill>
+                        <a:srgbClr val="E1E0D9"/>
+                      </a:solidFill>
+                      <a:prstDash val="solid"/>
+                      <a:round/>
+                      <a:headEnd type="none" w="med" len="med"/>
+                      <a:tailEnd type="none" w="med" len="med"/>
+                    </a:lnB>
+                    <a:solidFill>
+                      <a:srgbClr val="FFFFFF"/>
+                    </a:solidFill>
+                  </a:tcPr>
+                </a:tc>
+                <a:tc>
+                  <a:txBody>
+                    <a:bodyPr/>
+                    <a:lstStyle/>
+                    <a:p>
+                      <a:pPr algn="l" indent="0" marL="0">
+                        <a:buNone/>
+                      </a:pPr>
+                      <a:r>
+                        <a:rPr lang="en-US" sz="1050" dirty="0">
+                          <a:solidFill>
+                            <a:srgbClr val="0B0B0B"/>
+                          </a:solidFill>
+                          <a:latin typeface="Calibri" pitchFamily="34" charset="0"/>
+                          <a:ea typeface="Calibri" pitchFamily="34" charset="-122"/>
+                          <a:cs typeface="Calibri" pitchFamily="34" charset="-120"/>
+                        </a:rPr>
+                        <a:t>Dec-27</a:t>
+                      </a:r>
+                      <a:endParaRPr lang="en-US" sz="1050" dirty="0">
+                        <a:latin typeface="Calibri" charset="0"/>
+                        <a:ea typeface="Calibri" charset="0"/>
+                        <a:cs typeface="Calibri" charset="0"/>
+                      </a:endParaRPr>
+                    </a:p>
+                  </a:txBody>
+                  <a:tcPr marL="91440" marR="91440" marT="45720" marB="45720" anchor="ctr">
+                    <a:lnL w="6350" cap="flat" cmpd="sng" algn="ctr">
+                      <a:solidFill>
+                        <a:srgbClr val="E1E0D9"/>
+                      </a:solidFill>
+                      <a:prstDash val="solid"/>
+                      <a:round/>
+                      <a:headEnd type="none" w="med" len="med"/>
+                      <a:tailEnd type="none" w="med" len="med"/>
+                    </a:lnL>
+                    <a:lnR w="6350" cap="flat" cmpd="sng" algn="ctr">
+                      <a:solidFill>
+                        <a:srgbClr val="E1E0D9"/>
+                      </a:solidFill>
+                      <a:prstDash val="solid"/>
+                      <a:round/>
+                      <a:headEnd type="none" w="med" len="med"/>
+                      <a:tailEnd type="none" w="med" len="med"/>
+                    </a:lnR>
+                    <a:lnT w="6350" cap="flat" cmpd="sng" algn="ctr">
+                      <a:solidFill>
+                        <a:srgbClr val="E1E0D9"/>
+                      </a:solidFill>
+                      <a:prstDash val="solid"/>
+                      <a:round/>
+                      <a:headEnd type="none" w="med" len="med"/>
+                      <a:tailEnd type="none" w="med" len="med"/>
+                    </a:lnT>
+                    <a:lnB w="6350" cap="flat" cmpd="sng" algn="ctr">
+                      <a:solidFill>
+                        <a:srgbClr val="E1E0D9"/>
+                      </a:solidFill>
+                      <a:prstDash val="solid"/>
+                      <a:round/>
+                      <a:headEnd type="none" w="med" len="med"/>
+                      <a:tailEnd type="none" w="med" len="med"/>
+                    </a:lnB>
+                    <a:solidFill>
+                      <a:srgbClr val="FFFFFF"/>
+                    </a:solidFill>
+                  </a:tcPr>
+                </a:tc>
+              </a:tr>
+              <a:tr h="329184">
+                <a:tc>
+                  <a:txBody>
+                    <a:bodyPr/>
+                    <a:lstStyle/>
+                    <a:p>
+                      <a:pPr algn="l" indent="0" marL="0">
+                        <a:buNone/>
+                      </a:pPr>
+                      <a:r>
                         <a:rPr lang="en-US" sz="1050" dirty="0">
                           <a:solidFill>
                             <a:srgbClr val="0B0B0B"/>
@@ -7743,7 +8153,7 @@
                           <a:ea typeface="Calibri" pitchFamily="34" charset="-122"/>
                           <a:cs typeface="Calibri" pitchFamily="34" charset="-120"/>
                         </a:rPr>
-                        <a:t>$696.8K</a:t>
+                        <a:t>$996.8K</a:t>
                       </a:r>
                       <a:endParaRPr lang="en-US" sz="1050" dirty="0">
                         <a:latin typeface="Calibri" charset="0"/>
@@ -7889,7 +8299,7 @@
                 <a:ea typeface="Calibri" pitchFamily="34" charset="-122"/>
                 <a:cs typeface="Calibri" pitchFamily="34" charset="-120"/>
               </a:rPr>
-              <a:t>$697K</a:t>
+              <a:t>$997K</a:t>
             </a:r>
             <a:endParaRPr lang="en-US" sz="2800" dirty="0"/>
           </a:p>
@@ -7928,7 +8338,7 @@
                 <a:ea typeface="Calibri" pitchFamily="34" charset="-122"/>
                 <a:cs typeface="Calibri" pitchFamily="34" charset="-120"/>
               </a:rPr>
-              <a:t>booked work remaining — about 5 months of Base-forecast revenue</a:t>
+              <a:t>booked work remaining — up $300K on the new Consumers pole win</a:t>
             </a:r>
             <a:endParaRPr lang="en-US" sz="1200" dirty="0"/>
           </a:p>
@@ -8006,7 +8416,7 @@
                 <a:ea typeface="Calibri" pitchFamily="34" charset="-122"/>
                 <a:cs typeface="Calibri" pitchFamily="34" charset="-120"/>
               </a:rPr>
-              <a:t>carry 57% of it (New Baltimore, Leonard Rd), both finishing late 2027</a:t>
+              <a:t>carry over half of it (New Baltimore, Leonard Rd), both finishing late 2027</a:t>
             </a:r>
             <a:endParaRPr lang="en-US" sz="1200" dirty="0"/>
           </a:p>
@@ -8767,6 +9177,484 @@
                       <a:r>
                         <a:rPr lang="en-US" sz="1050" dirty="0">
                           <a:solidFill>
+                            <a:srgbClr val="006300"/>
+                          </a:solidFill>
+                          <a:latin typeface="Calibri" pitchFamily="34" charset="0"/>
+                          <a:ea typeface="Calibri" pitchFamily="34" charset="-122"/>
+                          <a:cs typeface="Calibri" pitchFamily="34" charset="-120"/>
+                        </a:rPr>
+                        <a:t>2026 Pole Replacements</a:t>
+                      </a:r>
+                      <a:endParaRPr lang="en-US" sz="1050" dirty="0">
+                        <a:latin typeface="Calibri" charset="0"/>
+                        <a:ea typeface="Calibri" charset="0"/>
+                        <a:cs typeface="Calibri" charset="0"/>
+                      </a:endParaRPr>
+                    </a:p>
+                  </a:txBody>
+                  <a:tcPr marL="91440" marR="91440" marT="45720" marB="45720" anchor="ctr">
+                    <a:lnL w="6350" cap="flat" cmpd="sng" algn="ctr">
+                      <a:solidFill>
+                        <a:srgbClr val="E1E0D9"/>
+                      </a:solidFill>
+                      <a:prstDash val="solid"/>
+                      <a:round/>
+                      <a:headEnd type="none" w="med" len="med"/>
+                      <a:tailEnd type="none" w="med" len="med"/>
+                    </a:lnL>
+                    <a:lnR w="6350" cap="flat" cmpd="sng" algn="ctr">
+                      <a:solidFill>
+                        <a:srgbClr val="E1E0D9"/>
+                      </a:solidFill>
+                      <a:prstDash val="solid"/>
+                      <a:round/>
+                      <a:headEnd type="none" w="med" len="med"/>
+                      <a:tailEnd type="none" w="med" len="med"/>
+                    </a:lnR>
+                    <a:lnT w="6350" cap="flat" cmpd="sng" algn="ctr">
+                      <a:solidFill>
+                        <a:srgbClr val="E1E0D9"/>
+                      </a:solidFill>
+                      <a:prstDash val="solid"/>
+                      <a:round/>
+                      <a:headEnd type="none" w="med" len="med"/>
+                      <a:tailEnd type="none" w="med" len="med"/>
+                    </a:lnT>
+                    <a:lnB w="6350" cap="flat" cmpd="sng" algn="ctr">
+                      <a:solidFill>
+                        <a:srgbClr val="E1E0D9"/>
+                      </a:solidFill>
+                      <a:prstDash val="solid"/>
+                      <a:round/>
+                      <a:headEnd type="none" w="med" len="med"/>
+                      <a:tailEnd type="none" w="med" len="med"/>
+                    </a:lnB>
+                    <a:solidFill>
+                      <a:srgbClr val="FFFFFF"/>
+                    </a:solidFill>
+                  </a:tcPr>
+                </a:tc>
+                <a:tc>
+                  <a:txBody>
+                    <a:bodyPr/>
+                    <a:lstStyle/>
+                    <a:p>
+                      <a:pPr algn="l" indent="0" marL="0">
+                        <a:buNone/>
+                      </a:pPr>
+                      <a:r>
+                        <a:rPr lang="en-US" sz="1050" dirty="0">
+                          <a:solidFill>
+                            <a:srgbClr val="006300"/>
+                          </a:solidFill>
+                          <a:latin typeface="Calibri" pitchFamily="34" charset="0"/>
+                          <a:ea typeface="Calibri" pitchFamily="34" charset="-122"/>
+                          <a:cs typeface="Calibri" pitchFamily="34" charset="-120"/>
+                        </a:rPr>
+                        <a:t>Consumers Energy</a:t>
+                      </a:r>
+                      <a:endParaRPr lang="en-US" sz="1050" dirty="0">
+                        <a:latin typeface="Calibri" charset="0"/>
+                        <a:ea typeface="Calibri" charset="0"/>
+                        <a:cs typeface="Calibri" charset="0"/>
+                      </a:endParaRPr>
+                    </a:p>
+                  </a:txBody>
+                  <a:tcPr marL="91440" marR="91440" marT="45720" marB="45720" anchor="ctr">
+                    <a:lnL w="6350" cap="flat" cmpd="sng" algn="ctr">
+                      <a:solidFill>
+                        <a:srgbClr val="E1E0D9"/>
+                      </a:solidFill>
+                      <a:prstDash val="solid"/>
+                      <a:round/>
+                      <a:headEnd type="none" w="med" len="med"/>
+                      <a:tailEnd type="none" w="med" len="med"/>
+                    </a:lnL>
+                    <a:lnR w="6350" cap="flat" cmpd="sng" algn="ctr">
+                      <a:solidFill>
+                        <a:srgbClr val="E1E0D9"/>
+                      </a:solidFill>
+                      <a:prstDash val="solid"/>
+                      <a:round/>
+                      <a:headEnd type="none" w="med" len="med"/>
+                      <a:tailEnd type="none" w="med" len="med"/>
+                    </a:lnR>
+                    <a:lnT w="6350" cap="flat" cmpd="sng" algn="ctr">
+                      <a:solidFill>
+                        <a:srgbClr val="E1E0D9"/>
+                      </a:solidFill>
+                      <a:prstDash val="solid"/>
+                      <a:round/>
+                      <a:headEnd type="none" w="med" len="med"/>
+                      <a:tailEnd type="none" w="med" len="med"/>
+                    </a:lnT>
+                    <a:lnB w="6350" cap="flat" cmpd="sng" algn="ctr">
+                      <a:solidFill>
+                        <a:srgbClr val="E1E0D9"/>
+                      </a:solidFill>
+                      <a:prstDash val="solid"/>
+                      <a:round/>
+                      <a:headEnd type="none" w="med" len="med"/>
+                      <a:tailEnd type="none" w="med" len="med"/>
+                    </a:lnB>
+                    <a:solidFill>
+                      <a:srgbClr val="FFFFFF"/>
+                    </a:solidFill>
+                  </a:tcPr>
+                </a:tc>
+                <a:tc>
+                  <a:txBody>
+                    <a:bodyPr/>
+                    <a:lstStyle/>
+                    <a:p>
+                      <a:pPr algn="l" indent="0" marL="0">
+                        <a:buNone/>
+                      </a:pPr>
+                      <a:r>
+                        <a:rPr lang="en-US" sz="1050" dirty="0">
+                          <a:solidFill>
+                            <a:srgbClr val="006300"/>
+                          </a:solidFill>
+                          <a:latin typeface="Calibri" pitchFamily="34" charset="0"/>
+                          <a:ea typeface="Calibri" pitchFamily="34" charset="-122"/>
+                          <a:cs typeface="Calibri" pitchFamily="34" charset="-120"/>
+                        </a:rPr>
+                        <a:t>$300.0K</a:t>
+                      </a:r>
+                      <a:endParaRPr lang="en-US" sz="1050" dirty="0">
+                        <a:latin typeface="Calibri" charset="0"/>
+                        <a:ea typeface="Calibri" charset="0"/>
+                        <a:cs typeface="Calibri" charset="0"/>
+                      </a:endParaRPr>
+                    </a:p>
+                  </a:txBody>
+                  <a:tcPr marL="91440" marR="91440" marT="45720" marB="45720" anchor="ctr">
+                    <a:lnL w="6350" cap="flat" cmpd="sng" algn="ctr">
+                      <a:solidFill>
+                        <a:srgbClr val="E1E0D9"/>
+                      </a:solidFill>
+                      <a:prstDash val="solid"/>
+                      <a:round/>
+                      <a:headEnd type="none" w="med" len="med"/>
+                      <a:tailEnd type="none" w="med" len="med"/>
+                    </a:lnL>
+                    <a:lnR w="6350" cap="flat" cmpd="sng" algn="ctr">
+                      <a:solidFill>
+                        <a:srgbClr val="E1E0D9"/>
+                      </a:solidFill>
+                      <a:prstDash val="solid"/>
+                      <a:round/>
+                      <a:headEnd type="none" w="med" len="med"/>
+                      <a:tailEnd type="none" w="med" len="med"/>
+                    </a:lnR>
+                    <a:lnT w="6350" cap="flat" cmpd="sng" algn="ctr">
+                      <a:solidFill>
+                        <a:srgbClr val="E1E0D9"/>
+                      </a:solidFill>
+                      <a:prstDash val="solid"/>
+                      <a:round/>
+                      <a:headEnd type="none" w="med" len="med"/>
+                      <a:tailEnd type="none" w="med" len="med"/>
+                    </a:lnT>
+                    <a:lnB w="6350" cap="flat" cmpd="sng" algn="ctr">
+                      <a:solidFill>
+                        <a:srgbClr val="E1E0D9"/>
+                      </a:solidFill>
+                      <a:prstDash val="solid"/>
+                      <a:round/>
+                      <a:headEnd type="none" w="med" len="med"/>
+                      <a:tailEnd type="none" w="med" len="med"/>
+                    </a:lnB>
+                    <a:solidFill>
+                      <a:srgbClr val="FFFFFF"/>
+                    </a:solidFill>
+                  </a:tcPr>
+                </a:tc>
+                <a:tc>
+                  <a:txBody>
+                    <a:bodyPr/>
+                    <a:lstStyle/>
+                    <a:p>
+                      <a:pPr algn="l" indent="0" marL="0">
+                        <a:buNone/>
+                      </a:pPr>
+                      <a:r>
+                        <a:rPr lang="en-US" sz="1050" dirty="0">
+                          <a:solidFill>
+                            <a:srgbClr val="006300"/>
+                          </a:solidFill>
+                          <a:latin typeface="Calibri" pitchFamily="34" charset="0"/>
+                          <a:ea typeface="Calibri" pitchFamily="34" charset="-122"/>
+                          <a:cs typeface="Calibri" pitchFamily="34" charset="-120"/>
+                        </a:rPr>
+                        <a:t>$3,451.1K</a:t>
+                      </a:r>
+                      <a:endParaRPr lang="en-US" sz="1050" dirty="0">
+                        <a:latin typeface="Calibri" charset="0"/>
+                        <a:ea typeface="Calibri" charset="0"/>
+                        <a:cs typeface="Calibri" charset="0"/>
+                      </a:endParaRPr>
+                    </a:p>
+                  </a:txBody>
+                  <a:tcPr marL="91440" marR="91440" marT="45720" marB="45720" anchor="ctr">
+                    <a:lnL w="6350" cap="flat" cmpd="sng" algn="ctr">
+                      <a:solidFill>
+                        <a:srgbClr val="E1E0D9"/>
+                      </a:solidFill>
+                      <a:prstDash val="solid"/>
+                      <a:round/>
+                      <a:headEnd type="none" w="med" len="med"/>
+                      <a:tailEnd type="none" w="med" len="med"/>
+                    </a:lnL>
+                    <a:lnR w="6350" cap="flat" cmpd="sng" algn="ctr">
+                      <a:solidFill>
+                        <a:srgbClr val="E1E0D9"/>
+                      </a:solidFill>
+                      <a:prstDash val="solid"/>
+                      <a:round/>
+                      <a:headEnd type="none" w="med" len="med"/>
+                      <a:tailEnd type="none" w="med" len="med"/>
+                    </a:lnR>
+                    <a:lnT w="6350" cap="flat" cmpd="sng" algn="ctr">
+                      <a:solidFill>
+                        <a:srgbClr val="E1E0D9"/>
+                      </a:solidFill>
+                      <a:prstDash val="solid"/>
+                      <a:round/>
+                      <a:headEnd type="none" w="med" len="med"/>
+                      <a:tailEnd type="none" w="med" len="med"/>
+                    </a:lnT>
+                    <a:lnB w="6350" cap="flat" cmpd="sng" algn="ctr">
+                      <a:solidFill>
+                        <a:srgbClr val="E1E0D9"/>
+                      </a:solidFill>
+                      <a:prstDash val="solid"/>
+                      <a:round/>
+                      <a:headEnd type="none" w="med" len="med"/>
+                      <a:tailEnd type="none" w="med" len="med"/>
+                    </a:lnB>
+                    <a:solidFill>
+                      <a:srgbClr val="FFFFFF"/>
+                    </a:solidFill>
+                  </a:tcPr>
+                </a:tc>
+                <a:tc>
+                  <a:txBody>
+                    <a:bodyPr/>
+                    <a:lstStyle/>
+                    <a:p>
+                      <a:pPr algn="l" indent="0" marL="0">
+                        <a:buNone/>
+                      </a:pPr>
+                      <a:r>
+                        <a:rPr lang="en-US" sz="1050" b="1" dirty="0">
+                          <a:solidFill>
+                            <a:srgbClr val="006300"/>
+                          </a:solidFill>
+                          <a:latin typeface="Calibri" pitchFamily="34" charset="0"/>
+                          <a:ea typeface="Calibri" pitchFamily="34" charset="-122"/>
+                          <a:cs typeface="Calibri" pitchFamily="34" charset="-120"/>
+                        </a:rPr>
+                        <a:t>WON</a:t>
+                      </a:r>
+                      <a:endParaRPr lang="en-US" sz="1050" dirty="0">
+                        <a:latin typeface="Calibri" charset="0"/>
+                        <a:ea typeface="Calibri" charset="0"/>
+                        <a:cs typeface="Calibri" charset="0"/>
+                      </a:endParaRPr>
+                    </a:p>
+                  </a:txBody>
+                  <a:tcPr marL="91440" marR="91440" marT="45720" marB="45720" anchor="ctr">
+                    <a:lnL w="6350" cap="flat" cmpd="sng" algn="ctr">
+                      <a:solidFill>
+                        <a:srgbClr val="E1E0D9"/>
+                      </a:solidFill>
+                      <a:prstDash val="solid"/>
+                      <a:round/>
+                      <a:headEnd type="none" w="med" len="med"/>
+                      <a:tailEnd type="none" w="med" len="med"/>
+                    </a:lnL>
+                    <a:lnR w="6350" cap="flat" cmpd="sng" algn="ctr">
+                      <a:solidFill>
+                        <a:srgbClr val="E1E0D9"/>
+                      </a:solidFill>
+                      <a:prstDash val="solid"/>
+                      <a:round/>
+                      <a:headEnd type="none" w="med" len="med"/>
+                      <a:tailEnd type="none" w="med" len="med"/>
+                    </a:lnR>
+                    <a:lnT w="6350" cap="flat" cmpd="sng" algn="ctr">
+                      <a:solidFill>
+                        <a:srgbClr val="E1E0D9"/>
+                      </a:solidFill>
+                      <a:prstDash val="solid"/>
+                      <a:round/>
+                      <a:headEnd type="none" w="med" len="med"/>
+                      <a:tailEnd type="none" w="med" len="med"/>
+                    </a:lnT>
+                    <a:lnB w="6350" cap="flat" cmpd="sng" algn="ctr">
+                      <a:solidFill>
+                        <a:srgbClr val="E1E0D9"/>
+                      </a:solidFill>
+                      <a:prstDash val="solid"/>
+                      <a:round/>
+                      <a:headEnd type="none" w="med" len="med"/>
+                      <a:tailEnd type="none" w="med" len="med"/>
+                    </a:lnB>
+                    <a:solidFill>
+                      <a:srgbClr val="FFFFFF"/>
+                    </a:solidFill>
+                  </a:tcPr>
+                </a:tc>
+                <a:tc>
+                  <a:txBody>
+                    <a:bodyPr/>
+                    <a:lstStyle/>
+                    <a:p>
+                      <a:pPr algn="l" indent="0" marL="0">
+                        <a:buNone/>
+                      </a:pPr>
+                      <a:r>
+                        <a:rPr lang="en-US" sz="1050" dirty="0">
+                          <a:solidFill>
+                            <a:srgbClr val="006300"/>
+                          </a:solidFill>
+                          <a:latin typeface="Calibri" pitchFamily="34" charset="0"/>
+                          <a:ea typeface="Calibri" pitchFamily="34" charset="-122"/>
+                          <a:cs typeface="Calibri" pitchFamily="34" charset="-120"/>
+                        </a:rPr>
+                        <a:t>→ backlog</a:t>
+                      </a:r>
+                      <a:endParaRPr lang="en-US" sz="1050" dirty="0">
+                        <a:latin typeface="Calibri" charset="0"/>
+                        <a:ea typeface="Calibri" charset="0"/>
+                        <a:cs typeface="Calibri" charset="0"/>
+                      </a:endParaRPr>
+                    </a:p>
+                  </a:txBody>
+                  <a:tcPr marL="91440" marR="91440" marT="45720" marB="45720" anchor="ctr">
+                    <a:lnL w="6350" cap="flat" cmpd="sng" algn="ctr">
+                      <a:solidFill>
+                        <a:srgbClr val="E1E0D9"/>
+                      </a:solidFill>
+                      <a:prstDash val="solid"/>
+                      <a:round/>
+                      <a:headEnd type="none" w="med" len="med"/>
+                      <a:tailEnd type="none" w="med" len="med"/>
+                    </a:lnL>
+                    <a:lnR w="6350" cap="flat" cmpd="sng" algn="ctr">
+                      <a:solidFill>
+                        <a:srgbClr val="E1E0D9"/>
+                      </a:solidFill>
+                      <a:prstDash val="solid"/>
+                      <a:round/>
+                      <a:headEnd type="none" w="med" len="med"/>
+                      <a:tailEnd type="none" w="med" len="med"/>
+                    </a:lnR>
+                    <a:lnT w="6350" cap="flat" cmpd="sng" algn="ctr">
+                      <a:solidFill>
+                        <a:srgbClr val="E1E0D9"/>
+                      </a:solidFill>
+                      <a:prstDash val="solid"/>
+                      <a:round/>
+                      <a:headEnd type="none" w="med" len="med"/>
+                      <a:tailEnd type="none" w="med" len="med"/>
+                    </a:lnT>
+                    <a:lnB w="6350" cap="flat" cmpd="sng" algn="ctr">
+                      <a:solidFill>
+                        <a:srgbClr val="E1E0D9"/>
+                      </a:solidFill>
+                      <a:prstDash val="solid"/>
+                      <a:round/>
+                      <a:headEnd type="none" w="med" len="med"/>
+                      <a:tailEnd type="none" w="med" len="med"/>
+                    </a:lnB>
+                    <a:solidFill>
+                      <a:srgbClr val="FFFFFF"/>
+                    </a:solidFill>
+                  </a:tcPr>
+                </a:tc>
+                <a:tc>
+                  <a:txBody>
+                    <a:bodyPr/>
+                    <a:lstStyle/>
+                    <a:p>
+                      <a:pPr algn="l" indent="0" marL="0">
+                        <a:buNone/>
+                      </a:pPr>
+                      <a:r>
+                        <a:rPr lang="en-US" sz="1050" dirty="0">
+                          <a:solidFill>
+                            <a:srgbClr val="0B0B0B"/>
+                          </a:solidFill>
+                          <a:latin typeface="Calibri" pitchFamily="34" charset="0"/>
+                          <a:ea typeface="Calibri" pitchFamily="34" charset="-122"/>
+                          <a:cs typeface="Calibri" pitchFamily="34" charset="-120"/>
+                        </a:rPr>
+                        <a:t>Q3-26</a:t>
+                      </a:r>
+                      <a:endParaRPr lang="en-US" sz="1050" dirty="0">
+                        <a:latin typeface="Calibri" charset="0"/>
+                        <a:ea typeface="Calibri" charset="0"/>
+                        <a:cs typeface="Calibri" charset="0"/>
+                      </a:endParaRPr>
+                    </a:p>
+                  </a:txBody>
+                  <a:tcPr marL="91440" marR="91440" marT="45720" marB="45720" anchor="ctr">
+                    <a:lnL w="6350" cap="flat" cmpd="sng" algn="ctr">
+                      <a:solidFill>
+                        <a:srgbClr val="E1E0D9"/>
+                      </a:solidFill>
+                      <a:prstDash val="solid"/>
+                      <a:round/>
+                      <a:headEnd type="none" w="med" len="med"/>
+                      <a:tailEnd type="none" w="med" len="med"/>
+                    </a:lnL>
+                    <a:lnR w="6350" cap="flat" cmpd="sng" algn="ctr">
+                      <a:solidFill>
+                        <a:srgbClr val="E1E0D9"/>
+                      </a:solidFill>
+                      <a:prstDash val="solid"/>
+                      <a:round/>
+                      <a:headEnd type="none" w="med" len="med"/>
+                      <a:tailEnd type="none" w="med" len="med"/>
+                    </a:lnR>
+                    <a:lnT w="6350" cap="flat" cmpd="sng" algn="ctr">
+                      <a:solidFill>
+                        <a:srgbClr val="E1E0D9"/>
+                      </a:solidFill>
+                      <a:prstDash val="solid"/>
+                      <a:round/>
+                      <a:headEnd type="none" w="med" len="med"/>
+                      <a:tailEnd type="none" w="med" len="med"/>
+                    </a:lnT>
+                    <a:lnB w="6350" cap="flat" cmpd="sng" algn="ctr">
+                      <a:solidFill>
+                        <a:srgbClr val="E1E0D9"/>
+                      </a:solidFill>
+                      <a:prstDash val="solid"/>
+                      <a:round/>
+                      <a:headEnd type="none" w="med" len="med"/>
+                      <a:tailEnd type="none" w="med" len="med"/>
+                    </a:lnB>
+                    <a:solidFill>
+                      <a:srgbClr val="FFFFFF"/>
+                    </a:solidFill>
+                  </a:tcPr>
+                </a:tc>
+              </a:tr>
+              <a:tr h="365760">
+                <a:tc>
+                  <a:txBody>
+                    <a:bodyPr/>
+                    <a:lstStyle/>
+                    <a:p>
+                      <a:pPr algn="l" indent="0" marL="0">
+                        <a:buNone/>
+                      </a:pPr>
+                      <a:r>
+                        <a:rPr lang="en-US" sz="1050" dirty="0">
+                          <a:solidFill>
                             <a:srgbClr val="0B0B0B"/>
                           </a:solidFill>
                           <a:latin typeface="Calibri" pitchFamily="34" charset="0"/>
@@ -9729,484 +10617,6 @@
                           <a:ea typeface="Calibri" pitchFamily="34" charset="-122"/>
                           <a:cs typeface="Calibri" pitchFamily="34" charset="-120"/>
                         </a:rPr>
-                        <a:t>2026 Pole Replacements</a:t>
-                      </a:r>
-                      <a:endParaRPr lang="en-US" sz="1050" dirty="0">
-                        <a:latin typeface="Calibri" charset="0"/>
-                        <a:ea typeface="Calibri" charset="0"/>
-                        <a:cs typeface="Calibri" charset="0"/>
-                      </a:endParaRPr>
-                    </a:p>
-                  </a:txBody>
-                  <a:tcPr marL="91440" marR="91440" marT="45720" marB="45720" anchor="ctr">
-                    <a:lnL w="6350" cap="flat" cmpd="sng" algn="ctr">
-                      <a:solidFill>
-                        <a:srgbClr val="E1E0D9"/>
-                      </a:solidFill>
-                      <a:prstDash val="solid"/>
-                      <a:round/>
-                      <a:headEnd type="none" w="med" len="med"/>
-                      <a:tailEnd type="none" w="med" len="med"/>
-                    </a:lnL>
-                    <a:lnR w="6350" cap="flat" cmpd="sng" algn="ctr">
-                      <a:solidFill>
-                        <a:srgbClr val="E1E0D9"/>
-                      </a:solidFill>
-                      <a:prstDash val="solid"/>
-                      <a:round/>
-                      <a:headEnd type="none" w="med" len="med"/>
-                      <a:tailEnd type="none" w="med" len="med"/>
-                    </a:lnR>
-                    <a:lnT w="6350" cap="flat" cmpd="sng" algn="ctr">
-                      <a:solidFill>
-                        <a:srgbClr val="E1E0D9"/>
-                      </a:solidFill>
-                      <a:prstDash val="solid"/>
-                      <a:round/>
-                      <a:headEnd type="none" w="med" len="med"/>
-                      <a:tailEnd type="none" w="med" len="med"/>
-                    </a:lnT>
-                    <a:lnB w="6350" cap="flat" cmpd="sng" algn="ctr">
-                      <a:solidFill>
-                        <a:srgbClr val="E1E0D9"/>
-                      </a:solidFill>
-                      <a:prstDash val="solid"/>
-                      <a:round/>
-                      <a:headEnd type="none" w="med" len="med"/>
-                      <a:tailEnd type="none" w="med" len="med"/>
-                    </a:lnB>
-                    <a:solidFill>
-                      <a:srgbClr val="FFFFFF"/>
-                    </a:solidFill>
-                  </a:tcPr>
-                </a:tc>
-                <a:tc>
-                  <a:txBody>
-                    <a:bodyPr/>
-                    <a:lstStyle/>
-                    <a:p>
-                      <a:pPr algn="l" indent="0" marL="0">
-                        <a:buNone/>
-                      </a:pPr>
-                      <a:r>
-                        <a:rPr lang="en-US" sz="1050" dirty="0">
-                          <a:solidFill>
-                            <a:srgbClr val="0B0B0B"/>
-                          </a:solidFill>
-                          <a:latin typeface="Calibri" pitchFamily="34" charset="0"/>
-                          <a:ea typeface="Calibri" pitchFamily="34" charset="-122"/>
-                          <a:cs typeface="Calibri" pitchFamily="34" charset="-120"/>
-                        </a:rPr>
-                        <a:t>Consumers Energy</a:t>
-                      </a:r>
-                      <a:endParaRPr lang="en-US" sz="1050" dirty="0">
-                        <a:latin typeface="Calibri" charset="0"/>
-                        <a:ea typeface="Calibri" charset="0"/>
-                        <a:cs typeface="Calibri" charset="0"/>
-                      </a:endParaRPr>
-                    </a:p>
-                  </a:txBody>
-                  <a:tcPr marL="91440" marR="91440" marT="45720" marB="45720" anchor="ctr">
-                    <a:lnL w="6350" cap="flat" cmpd="sng" algn="ctr">
-                      <a:solidFill>
-                        <a:srgbClr val="E1E0D9"/>
-                      </a:solidFill>
-                      <a:prstDash val="solid"/>
-                      <a:round/>
-                      <a:headEnd type="none" w="med" len="med"/>
-                      <a:tailEnd type="none" w="med" len="med"/>
-                    </a:lnL>
-                    <a:lnR w="6350" cap="flat" cmpd="sng" algn="ctr">
-                      <a:solidFill>
-                        <a:srgbClr val="E1E0D9"/>
-                      </a:solidFill>
-                      <a:prstDash val="solid"/>
-                      <a:round/>
-                      <a:headEnd type="none" w="med" len="med"/>
-                      <a:tailEnd type="none" w="med" len="med"/>
-                    </a:lnR>
-                    <a:lnT w="6350" cap="flat" cmpd="sng" algn="ctr">
-                      <a:solidFill>
-                        <a:srgbClr val="E1E0D9"/>
-                      </a:solidFill>
-                      <a:prstDash val="solid"/>
-                      <a:round/>
-                      <a:headEnd type="none" w="med" len="med"/>
-                      <a:tailEnd type="none" w="med" len="med"/>
-                    </a:lnT>
-                    <a:lnB w="6350" cap="flat" cmpd="sng" algn="ctr">
-                      <a:solidFill>
-                        <a:srgbClr val="E1E0D9"/>
-                      </a:solidFill>
-                      <a:prstDash val="solid"/>
-                      <a:round/>
-                      <a:headEnd type="none" w="med" len="med"/>
-                      <a:tailEnd type="none" w="med" len="med"/>
-                    </a:lnB>
-                    <a:solidFill>
-                      <a:srgbClr val="FFFFFF"/>
-                    </a:solidFill>
-                  </a:tcPr>
-                </a:tc>
-                <a:tc>
-                  <a:txBody>
-                    <a:bodyPr/>
-                    <a:lstStyle/>
-                    <a:p>
-                      <a:pPr algn="l" indent="0" marL="0">
-                        <a:buNone/>
-                      </a:pPr>
-                      <a:r>
-                        <a:rPr lang="en-US" sz="1050" dirty="0">
-                          <a:solidFill>
-                            <a:srgbClr val="0B0B0B"/>
-                          </a:solidFill>
-                          <a:latin typeface="Calibri" pitchFamily="34" charset="0"/>
-                          <a:ea typeface="Calibri" pitchFamily="34" charset="-122"/>
-                          <a:cs typeface="Calibri" pitchFamily="34" charset="-120"/>
-                        </a:rPr>
-                        <a:t>$276.5K</a:t>
-                      </a:r>
-                      <a:endParaRPr lang="en-US" sz="1050" dirty="0">
-                        <a:latin typeface="Calibri" charset="0"/>
-                        <a:ea typeface="Calibri" charset="0"/>
-                        <a:cs typeface="Calibri" charset="0"/>
-                      </a:endParaRPr>
-                    </a:p>
-                  </a:txBody>
-                  <a:tcPr marL="91440" marR="91440" marT="45720" marB="45720" anchor="ctr">
-                    <a:lnL w="6350" cap="flat" cmpd="sng" algn="ctr">
-                      <a:solidFill>
-                        <a:srgbClr val="E1E0D9"/>
-                      </a:solidFill>
-                      <a:prstDash val="solid"/>
-                      <a:round/>
-                      <a:headEnd type="none" w="med" len="med"/>
-                      <a:tailEnd type="none" w="med" len="med"/>
-                    </a:lnL>
-                    <a:lnR w="6350" cap="flat" cmpd="sng" algn="ctr">
-                      <a:solidFill>
-                        <a:srgbClr val="E1E0D9"/>
-                      </a:solidFill>
-                      <a:prstDash val="solid"/>
-                      <a:round/>
-                      <a:headEnd type="none" w="med" len="med"/>
-                      <a:tailEnd type="none" w="med" len="med"/>
-                    </a:lnR>
-                    <a:lnT w="6350" cap="flat" cmpd="sng" algn="ctr">
-                      <a:solidFill>
-                        <a:srgbClr val="E1E0D9"/>
-                      </a:solidFill>
-                      <a:prstDash val="solid"/>
-                      <a:round/>
-                      <a:headEnd type="none" w="med" len="med"/>
-                      <a:tailEnd type="none" w="med" len="med"/>
-                    </a:lnT>
-                    <a:lnB w="6350" cap="flat" cmpd="sng" algn="ctr">
-                      <a:solidFill>
-                        <a:srgbClr val="E1E0D9"/>
-                      </a:solidFill>
-                      <a:prstDash val="solid"/>
-                      <a:round/>
-                      <a:headEnd type="none" w="med" len="med"/>
-                      <a:tailEnd type="none" w="med" len="med"/>
-                    </a:lnB>
-                    <a:solidFill>
-                      <a:srgbClr val="FFFFFF"/>
-                    </a:solidFill>
-                  </a:tcPr>
-                </a:tc>
-                <a:tc>
-                  <a:txBody>
-                    <a:bodyPr/>
-                    <a:lstStyle/>
-                    <a:p>
-                      <a:pPr algn="l" indent="0" marL="0">
-                        <a:buNone/>
-                      </a:pPr>
-                      <a:r>
-                        <a:rPr lang="en-US" sz="1050" dirty="0">
-                          <a:solidFill>
-                            <a:srgbClr val="0B0B0B"/>
-                          </a:solidFill>
-                          <a:latin typeface="Calibri" pitchFamily="34" charset="0"/>
-                          <a:ea typeface="Calibri" pitchFamily="34" charset="-122"/>
-                          <a:cs typeface="Calibri" pitchFamily="34" charset="-120"/>
-                        </a:rPr>
-                        <a:t>$3,451.1K</a:t>
-                      </a:r>
-                      <a:endParaRPr lang="en-US" sz="1050" dirty="0">
-                        <a:latin typeface="Calibri" charset="0"/>
-                        <a:ea typeface="Calibri" charset="0"/>
-                        <a:cs typeface="Calibri" charset="0"/>
-                      </a:endParaRPr>
-                    </a:p>
-                  </a:txBody>
-                  <a:tcPr marL="91440" marR="91440" marT="45720" marB="45720" anchor="ctr">
-                    <a:lnL w="6350" cap="flat" cmpd="sng" algn="ctr">
-                      <a:solidFill>
-                        <a:srgbClr val="E1E0D9"/>
-                      </a:solidFill>
-                      <a:prstDash val="solid"/>
-                      <a:round/>
-                      <a:headEnd type="none" w="med" len="med"/>
-                      <a:tailEnd type="none" w="med" len="med"/>
-                    </a:lnL>
-                    <a:lnR w="6350" cap="flat" cmpd="sng" algn="ctr">
-                      <a:solidFill>
-                        <a:srgbClr val="E1E0D9"/>
-                      </a:solidFill>
-                      <a:prstDash val="solid"/>
-                      <a:round/>
-                      <a:headEnd type="none" w="med" len="med"/>
-                      <a:tailEnd type="none" w="med" len="med"/>
-                    </a:lnR>
-                    <a:lnT w="6350" cap="flat" cmpd="sng" algn="ctr">
-                      <a:solidFill>
-                        <a:srgbClr val="E1E0D9"/>
-                      </a:solidFill>
-                      <a:prstDash val="solid"/>
-                      <a:round/>
-                      <a:headEnd type="none" w="med" len="med"/>
-                      <a:tailEnd type="none" w="med" len="med"/>
-                    </a:lnT>
-                    <a:lnB w="6350" cap="flat" cmpd="sng" algn="ctr">
-                      <a:solidFill>
-                        <a:srgbClr val="E1E0D9"/>
-                      </a:solidFill>
-                      <a:prstDash val="solid"/>
-                      <a:round/>
-                      <a:headEnd type="none" w="med" len="med"/>
-                      <a:tailEnd type="none" w="med" len="med"/>
-                    </a:lnB>
-                    <a:solidFill>
-                      <a:srgbClr val="FFFFFF"/>
-                    </a:solidFill>
-                  </a:tcPr>
-                </a:tc>
-                <a:tc>
-                  <a:txBody>
-                    <a:bodyPr/>
-                    <a:lstStyle/>
-                    <a:p>
-                      <a:pPr algn="l" indent="0" marL="0">
-                        <a:buNone/>
-                      </a:pPr>
-                      <a:r>
-                        <a:rPr lang="en-US" sz="1050" dirty="0">
-                          <a:solidFill>
-                            <a:srgbClr val="0B0B0B"/>
-                          </a:solidFill>
-                          <a:latin typeface="Calibri" pitchFamily="34" charset="0"/>
-                          <a:ea typeface="Calibri" pitchFamily="34" charset="-122"/>
-                          <a:cs typeface="Calibri" pitchFamily="34" charset="-120"/>
-                        </a:rPr>
-                        <a:t>67%</a:t>
-                      </a:r>
-                      <a:endParaRPr lang="en-US" sz="1050" dirty="0">
-                        <a:latin typeface="Calibri" charset="0"/>
-                        <a:ea typeface="Calibri" charset="0"/>
-                        <a:cs typeface="Calibri" charset="0"/>
-                      </a:endParaRPr>
-                    </a:p>
-                  </a:txBody>
-                  <a:tcPr marL="91440" marR="91440" marT="45720" marB="45720" anchor="ctr">
-                    <a:lnL w="6350" cap="flat" cmpd="sng" algn="ctr">
-                      <a:solidFill>
-                        <a:srgbClr val="E1E0D9"/>
-                      </a:solidFill>
-                      <a:prstDash val="solid"/>
-                      <a:round/>
-                      <a:headEnd type="none" w="med" len="med"/>
-                      <a:tailEnd type="none" w="med" len="med"/>
-                    </a:lnL>
-                    <a:lnR w="6350" cap="flat" cmpd="sng" algn="ctr">
-                      <a:solidFill>
-                        <a:srgbClr val="E1E0D9"/>
-                      </a:solidFill>
-                      <a:prstDash val="solid"/>
-                      <a:round/>
-                      <a:headEnd type="none" w="med" len="med"/>
-                      <a:tailEnd type="none" w="med" len="med"/>
-                    </a:lnR>
-                    <a:lnT w="6350" cap="flat" cmpd="sng" algn="ctr">
-                      <a:solidFill>
-                        <a:srgbClr val="E1E0D9"/>
-                      </a:solidFill>
-                      <a:prstDash val="solid"/>
-                      <a:round/>
-                      <a:headEnd type="none" w="med" len="med"/>
-                      <a:tailEnd type="none" w="med" len="med"/>
-                    </a:lnT>
-                    <a:lnB w="6350" cap="flat" cmpd="sng" algn="ctr">
-                      <a:solidFill>
-                        <a:srgbClr val="E1E0D9"/>
-                      </a:solidFill>
-                      <a:prstDash val="solid"/>
-                      <a:round/>
-                      <a:headEnd type="none" w="med" len="med"/>
-                      <a:tailEnd type="none" w="med" len="med"/>
-                    </a:lnB>
-                    <a:solidFill>
-                      <a:srgbClr val="FFFFFF"/>
-                    </a:solidFill>
-                  </a:tcPr>
-                </a:tc>
-                <a:tc>
-                  <a:txBody>
-                    <a:bodyPr/>
-                    <a:lstStyle/>
-                    <a:p>
-                      <a:pPr algn="l" indent="0" marL="0">
-                        <a:buNone/>
-                      </a:pPr>
-                      <a:r>
-                        <a:rPr lang="en-US" sz="1050" dirty="0">
-                          <a:solidFill>
-                            <a:srgbClr val="0B0B0B"/>
-                          </a:solidFill>
-                          <a:latin typeface="Calibri" pitchFamily="34" charset="0"/>
-                          <a:ea typeface="Calibri" pitchFamily="34" charset="-122"/>
-                          <a:cs typeface="Calibri" pitchFamily="34" charset="-120"/>
-                        </a:rPr>
-                        <a:t>$185.2K</a:t>
-                      </a:r>
-                      <a:endParaRPr lang="en-US" sz="1050" dirty="0">
-                        <a:latin typeface="Calibri" charset="0"/>
-                        <a:ea typeface="Calibri" charset="0"/>
-                        <a:cs typeface="Calibri" charset="0"/>
-                      </a:endParaRPr>
-                    </a:p>
-                  </a:txBody>
-                  <a:tcPr marL="91440" marR="91440" marT="45720" marB="45720" anchor="ctr">
-                    <a:lnL w="6350" cap="flat" cmpd="sng" algn="ctr">
-                      <a:solidFill>
-                        <a:srgbClr val="E1E0D9"/>
-                      </a:solidFill>
-                      <a:prstDash val="solid"/>
-                      <a:round/>
-                      <a:headEnd type="none" w="med" len="med"/>
-                      <a:tailEnd type="none" w="med" len="med"/>
-                    </a:lnL>
-                    <a:lnR w="6350" cap="flat" cmpd="sng" algn="ctr">
-                      <a:solidFill>
-                        <a:srgbClr val="E1E0D9"/>
-                      </a:solidFill>
-                      <a:prstDash val="solid"/>
-                      <a:round/>
-                      <a:headEnd type="none" w="med" len="med"/>
-                      <a:tailEnd type="none" w="med" len="med"/>
-                    </a:lnR>
-                    <a:lnT w="6350" cap="flat" cmpd="sng" algn="ctr">
-                      <a:solidFill>
-                        <a:srgbClr val="E1E0D9"/>
-                      </a:solidFill>
-                      <a:prstDash val="solid"/>
-                      <a:round/>
-                      <a:headEnd type="none" w="med" len="med"/>
-                      <a:tailEnd type="none" w="med" len="med"/>
-                    </a:lnT>
-                    <a:lnB w="6350" cap="flat" cmpd="sng" algn="ctr">
-                      <a:solidFill>
-                        <a:srgbClr val="E1E0D9"/>
-                      </a:solidFill>
-                      <a:prstDash val="solid"/>
-                      <a:round/>
-                      <a:headEnd type="none" w="med" len="med"/>
-                      <a:tailEnd type="none" w="med" len="med"/>
-                    </a:lnB>
-                    <a:solidFill>
-                      <a:srgbClr val="FFFFFF"/>
-                    </a:solidFill>
-                  </a:tcPr>
-                </a:tc>
-                <a:tc>
-                  <a:txBody>
-                    <a:bodyPr/>
-                    <a:lstStyle/>
-                    <a:p>
-                      <a:pPr algn="l" indent="0" marL="0">
-                        <a:buNone/>
-                      </a:pPr>
-                      <a:r>
-                        <a:rPr lang="en-US" sz="1050" dirty="0">
-                          <a:solidFill>
-                            <a:srgbClr val="0B0B0B"/>
-                          </a:solidFill>
-                          <a:latin typeface="Calibri" pitchFamily="34" charset="0"/>
-                          <a:ea typeface="Calibri" pitchFamily="34" charset="-122"/>
-                          <a:cs typeface="Calibri" pitchFamily="34" charset="-120"/>
-                        </a:rPr>
-                        <a:t>Q4-26</a:t>
-                      </a:r>
-                      <a:endParaRPr lang="en-US" sz="1050" dirty="0">
-                        <a:latin typeface="Calibri" charset="0"/>
-                        <a:ea typeface="Calibri" charset="0"/>
-                        <a:cs typeface="Calibri" charset="0"/>
-                      </a:endParaRPr>
-                    </a:p>
-                  </a:txBody>
-                  <a:tcPr marL="91440" marR="91440" marT="45720" marB="45720" anchor="ctr">
-                    <a:lnL w="6350" cap="flat" cmpd="sng" algn="ctr">
-                      <a:solidFill>
-                        <a:srgbClr val="E1E0D9"/>
-                      </a:solidFill>
-                      <a:prstDash val="solid"/>
-                      <a:round/>
-                      <a:headEnd type="none" w="med" len="med"/>
-                      <a:tailEnd type="none" w="med" len="med"/>
-                    </a:lnL>
-                    <a:lnR w="6350" cap="flat" cmpd="sng" algn="ctr">
-                      <a:solidFill>
-                        <a:srgbClr val="E1E0D9"/>
-                      </a:solidFill>
-                      <a:prstDash val="solid"/>
-                      <a:round/>
-                      <a:headEnd type="none" w="med" len="med"/>
-                      <a:tailEnd type="none" w="med" len="med"/>
-                    </a:lnR>
-                    <a:lnT w="6350" cap="flat" cmpd="sng" algn="ctr">
-                      <a:solidFill>
-                        <a:srgbClr val="E1E0D9"/>
-                      </a:solidFill>
-                      <a:prstDash val="solid"/>
-                      <a:round/>
-                      <a:headEnd type="none" w="med" len="med"/>
-                      <a:tailEnd type="none" w="med" len="med"/>
-                    </a:lnT>
-                    <a:lnB w="6350" cap="flat" cmpd="sng" algn="ctr">
-                      <a:solidFill>
-                        <a:srgbClr val="E1E0D9"/>
-                      </a:solidFill>
-                      <a:prstDash val="solid"/>
-                      <a:round/>
-                      <a:headEnd type="none" w="med" len="med"/>
-                      <a:tailEnd type="none" w="med" len="med"/>
-                    </a:lnB>
-                    <a:solidFill>
-                      <a:srgbClr val="FFFFFF"/>
-                    </a:solidFill>
-                  </a:tcPr>
-                </a:tc>
-              </a:tr>
-              <a:tr h="365760">
-                <a:tc>
-                  <a:txBody>
-                    <a:bodyPr/>
-                    <a:lstStyle/>
-                    <a:p>
-                      <a:pPr algn="l" indent="0" marL="0">
-                        <a:buNone/>
-                      </a:pPr>
-                      <a:r>
-                        <a:rPr lang="en-US" sz="1050" dirty="0">
-                          <a:solidFill>
-                            <a:srgbClr val="0B0B0B"/>
-                          </a:solidFill>
-                          <a:latin typeface="Calibri" pitchFamily="34" charset="0"/>
-                          <a:ea typeface="Calibri" pitchFamily="34" charset="-122"/>
-                          <a:cs typeface="Calibri" pitchFamily="34" charset="-120"/>
-                        </a:rPr>
                         <a:t>Jacksonburg–Gateway 69kV</a:t>
                       </a:r>
                       <a:endParaRPr lang="en-US" sz="1050" dirty="0">
@@ -11698,7 +12108,7 @@
                           <a:ea typeface="Calibri" pitchFamily="34" charset="-122"/>
                           <a:cs typeface="Calibri" pitchFamily="34" charset="-120"/>
                         </a:rPr>
-                        <a:t>Total</a:t>
+                        <a:t>Pending total (ex-won)</a:t>
                       </a:r>
                       <a:endParaRPr lang="en-US" sz="1050" dirty="0">
                         <a:latin typeface="Calibri" charset="0"/>
@@ -11766,7 +12176,7 @@
                           <a:ea typeface="Calibri" pitchFamily="34" charset="-122"/>
                           <a:cs typeface="Calibri" pitchFamily="34" charset="-120"/>
                         </a:rPr>
-                        <a:t>$2,176.5K</a:t>
+                        <a:t>$1,900.0K</a:t>
                       </a:r>
                       <a:endParaRPr lang="en-US" sz="1050" dirty="0">
                         <a:latin typeface="Calibri" charset="0"/>
@@ -11834,7 +12244,7 @@
                           <a:ea typeface="Calibri" pitchFamily="34" charset="-122"/>
                           <a:cs typeface="Calibri" pitchFamily="34" charset="-120"/>
                         </a:rPr>
-                        <a:t>$12,590.5K</a:t>
+                        <a:t>$9,139.4K</a:t>
                       </a:r>
                       <a:endParaRPr lang="en-US" sz="1050" dirty="0">
                         <a:latin typeface="Calibri" charset="0"/>
@@ -11959,7 +12369,7 @@
                           <a:ea typeface="Calibri" pitchFamily="34" charset="-122"/>
                           <a:cs typeface="Calibri" pitchFamily="34" charset="-120"/>
                         </a:rPr>
-                        <a:t>$1,135.2K</a:t>
+                        <a:t>$950.0K</a:t>
                       </a:r>
                       <a:endParaRPr lang="en-US" sz="1050" dirty="0">
                         <a:latin typeface="Calibri" charset="0"/>
@@ -12099,13 +12509,13 @@
             <a:r>
               <a:rPr lang="en-US" sz="2800" b="1" dirty="0">
                 <a:solidFill>
-                  <a:srgbClr val="2A78D6"/>
+                  <a:srgbClr val="006300"/>
                 </a:solidFill>
                 <a:latin typeface="Calibri" pitchFamily="34" charset="0"/>
                 <a:ea typeface="Calibri" pitchFamily="34" charset="-122"/>
                 <a:cs typeface="Calibri" pitchFamily="34" charset="-120"/>
               </a:rPr>
-              <a:t>67%</a:t>
+              <a:t>WON</a:t>
             </a:r>
             <a:endParaRPr lang="en-US" sz="2800" dirty="0"/>
           </a:p>
@@ -12144,7 +12554,7 @@
                 <a:ea typeface="Calibri" pitchFamily="34" charset="-122"/>
                 <a:cs typeface="Calibri" pitchFamily="34" charset="-120"/>
               </a:rPr>
-              <a:t>2026 win rate to date (up from 50% in 2025)</a:t>
+              <a:t>Consumers pole replacements — $300K CVR scope now booked to backlog</a:t>
             </a:r>
             <a:endParaRPr lang="en-US" sz="1150" dirty="0"/>
           </a:p>
@@ -12261,7 +12671,7 @@
                 <a:ea typeface="Calibri" pitchFamily="34" charset="-122"/>
                 <a:cs typeface="Calibri" pitchFamily="34" charset="-120"/>
               </a:rPr>
-              <a:t>$1.5M</a:t>
+              <a:t>$1.6M</a:t>
             </a:r>
             <a:endParaRPr lang="en-US" sz="2800" dirty="0"/>
           </a:p>
@@ -13777,7 +14187,7 @@
                 <a:ea typeface="Calibri" pitchFamily="34" charset="-122"/>
                 <a:cs typeface="Calibri" pitchFamily="34" charset="-120"/>
               </a:rPr>
-              <a:t>$12.6M</a:t>
+              <a:t>$9.1M</a:t>
             </a:r>
             <a:endParaRPr lang="en-US" sz="2700" dirty="0"/>
           </a:p>
@@ -13816,7 +14226,7 @@
                 <a:ea typeface="Calibri" pitchFamily="34" charset="-122"/>
                 <a:cs typeface="Calibri" pitchFamily="34" charset="-120"/>
               </a:rPr>
-              <a:t>of EPC-paired bids already in market with Hoosier and Consumers</a:t>
+              <a:t>of EPC-paired bids still in market with Hoosier (Consumers pole program now won)</a:t>
             </a:r>
             <a:endParaRPr lang="en-US" sz="1150" dirty="0"/>
           </a:p>
@@ -14325,7 +14735,7 @@
                 <a:ea typeface="Calibri" pitchFamily="34" charset="-122"/>
                 <a:cs typeface="Calibri" pitchFamily="34" charset="-120"/>
               </a:rPr>
-              <a:t>Foothold: HVD line-sensor &amp; pole programs live; $3.5M EPC-paired pole-replacement bid pending</a:t>
+              <a:t>Foothold: HVD line-sensor program live; 2026 pole replacements WON ($300K CVR scope, $3.45M EPC-paired)</a:t>
             </a:r>
             <a:endParaRPr lang="en-US" sz="1000" dirty="0"/>
           </a:p>
@@ -17490,7 +17900,7 @@
                 <a:ea typeface="Calibri" pitchFamily="34" charset="-122"/>
                 <a:cs typeface="Calibri" pitchFamily="34" charset="-120"/>
               </a:rPr>
-              <a:t>49%</a:t>
+              <a:t>52%</a:t>
             </a:r>
             <a:endParaRPr lang="en-US" sz="3000" dirty="0"/>
           </a:p>
@@ -17568,7 +17978,7 @@
                 <a:ea typeface="Calibri" pitchFamily="34" charset="-122"/>
                 <a:cs typeface="Calibri" pitchFamily="34" charset="-120"/>
               </a:rPr>
-              <a:t>21%</a:t>
+              <a:t>30%</a:t>
             </a:r>
             <a:endParaRPr lang="en-US" sz="3000" dirty="0"/>
           </a:p>
@@ -17607,7 +18017,7 @@
                 <a:ea typeface="Calibri" pitchFamily="34" charset="-122"/>
                 <a:cs typeface="Calibri" pitchFamily="34" charset="-120"/>
               </a:rPr>
-              <a:t>covered by booked backlog alone</a:t>
+              <a:t>covered by booked backlog alone — up with the Consumers pole win</a:t>
             </a:r>
             <a:endParaRPr lang="en-US" sz="1200" dirty="0"/>
           </a:p>
@@ -17646,7 +18056,7 @@
                 <a:ea typeface="Calibri" pitchFamily="34" charset="-122"/>
                 <a:cs typeface="Calibri" pitchFamily="34" charset="-120"/>
               </a:rPr>
-              <a:t>$1,724K</a:t>
+              <a:t>$1,609K</a:t>
             </a:r>
             <a:endParaRPr lang="en-US" sz="3000" dirty="0"/>
           </a:p>
@@ -23755,7 +24165,7 @@
                 <a:ea typeface="Calibri" pitchFamily="34" charset="-122"/>
                 <a:cs typeface="Calibri" pitchFamily="34" charset="-120"/>
               </a:rPr>
-              <a:t>required before a fixed-price EPC bid can even be submitted — $250–380K of pre-award exposure on the $12.6M bid slate</a:t>
+              <a:t>required before a fixed-price EPC bid can even be submitted — $200–300K of pre-award exposure on the $9.1M bid slate still in market</a:t>
             </a:r>
             <a:endParaRPr lang="en-US" sz="1050" dirty="0"/>
           </a:p>

</xml_diff>

<commit_message>
Wire real IOU logos into addressable-market slide
Add Consumers, DTE, CenterPoint, and MidAmerican logos (trimmed to
reports/assets/logos/) so the addressable EPC market slide shows official
wordmarks in place of the colored-text fallback. Update the slide footnote
accordingly and rebuild the deck.
</commit_message>
<xml_diff>
--- a/reports/CVR_Deck_Jun2026.pptx
+++ b/reports/CVR_Deck_Jun2026.pptx
@@ -14571,55 +14571,39 @@
           </a:ln>
         </p:spPr>
       </p:sp>
-      <p:sp>
-        <p:nvSpPr>
-          <p:cNvPr id="5" name="Text 3"/>
-          <p:cNvSpPr/>
+      <p:pic>
+        <p:nvPicPr>
+          <p:cNvPr id="5" name="Image 0" descr="/home/user/CVR---Financial/reports/assets/logos/consumers.png">    </p:cNvPr>
+          <p:cNvPicPr>
+            <a:picLocks noChangeAspect="1"/>
+          </p:cNvPicPr>
           <p:nvPr/>
-        </p:nvSpPr>
+        </p:nvPicPr>
+        <p:blipFill>
+          <a:blip r:embed="rId1"/>
+          <a:srcRect l="0" r="0" t="0" b="0"/>
+          <a:stretch/>
+        </p:blipFill>
         <p:spPr>
           <a:xfrm>
             <a:off x="768096" y="1536192"/>
-            <a:ext cx="3566160" cy="310896"/>
+            <a:ext cx="2103120" cy="502920"/>
           </a:xfrm>
           <a:prstGeom prst="rect">
             <a:avLst/>
           </a:prstGeom>
-          <a:noFill/>
-          <a:ln/>
         </p:spPr>
-        <p:txBody>
-          <a:bodyPr wrap="square" lIns="0" tIns="0" rIns="0" bIns="0" rtlCol="0" anchor="ctr"/>
-          <a:lstStyle/>
-          <a:p>
-            <a:pPr indent="0" marL="0">
-              <a:buNone/>
-            </a:pPr>
-            <a:r>
-              <a:rPr lang="en-US" sz="1700" b="1" dirty="0">
-                <a:solidFill>
-                  <a:srgbClr val="0057B8"/>
-                </a:solidFill>
-                <a:latin typeface="Calibri" pitchFamily="34" charset="0"/>
-                <a:ea typeface="Calibri" pitchFamily="34" charset="-122"/>
-                <a:cs typeface="Calibri" pitchFamily="34" charset="-120"/>
-              </a:rPr>
-              <a:t>Consumers Energy</a:t>
-            </a:r>
-            <a:endParaRPr lang="en-US" sz="1700" dirty="0"/>
-          </a:p>
-        </p:txBody>
-      </p:sp>
-      <p:sp>
-        <p:nvSpPr>
-          <p:cNvPr id="6" name="Text 4"/>
+      </p:pic>
+      <p:sp>
+        <p:nvSpPr>
+          <p:cNvPr id="6" name="Text 3"/>
           <p:cNvSpPr/>
           <p:nvPr/>
         </p:nvSpPr>
         <p:spPr>
           <a:xfrm>
-            <a:off x="768096" y="1837944"/>
-            <a:ext cx="4206240" cy="237744"/>
+            <a:off x="3008376" y="1645920"/>
+            <a:ext cx="2377440" cy="274320"/>
           </a:xfrm>
           <a:prstGeom prst="rect">
             <a:avLst/>
@@ -14651,7 +14635,7 @@
       </p:sp>
       <p:sp>
         <p:nvSpPr>
-          <p:cNvPr id="7" name="Text 5"/>
+          <p:cNvPr id="7" name="Text 4"/>
           <p:cNvSpPr/>
           <p:nvPr/>
         </p:nvSpPr>
@@ -14704,7 +14688,7 @@
       </p:sp>
       <p:sp>
         <p:nvSpPr>
-          <p:cNvPr id="8" name="Text 6"/>
+          <p:cNvPr id="8" name="Text 5"/>
           <p:cNvSpPr/>
           <p:nvPr/>
         </p:nvSpPr>
@@ -14743,7 +14727,7 @@
       </p:sp>
       <p:sp>
         <p:nvSpPr>
-          <p:cNvPr id="9" name="Shape 7"/>
+          <p:cNvPr id="9" name="Shape 6"/>
           <p:cNvSpPr/>
           <p:nvPr/>
         </p:nvSpPr>
@@ -14768,55 +14752,39 @@
           </a:ln>
         </p:spPr>
       </p:sp>
-      <p:sp>
-        <p:nvSpPr>
-          <p:cNvPr id="10" name="Text 8"/>
-          <p:cNvSpPr/>
+      <p:pic>
+        <p:nvPicPr>
+          <p:cNvPr id="10" name="Image 1" descr="/home/user/CVR---Financial/reports/assets/logos/dte.png">    </p:cNvPr>
+          <p:cNvPicPr>
+            <a:picLocks noChangeAspect="1"/>
+          </p:cNvPicPr>
           <p:nvPr/>
-        </p:nvSpPr>
+        </p:nvPicPr>
+        <p:blipFill>
+          <a:blip r:embed="rId2"/>
+          <a:srcRect l="0" r="0" t="0" b="0"/>
+          <a:stretch/>
+        </p:blipFill>
         <p:spPr>
           <a:xfrm>
             <a:off x="6510528" y="1536192"/>
-            <a:ext cx="3566160" cy="310896"/>
+            <a:ext cx="2103120" cy="502920"/>
           </a:xfrm>
           <a:prstGeom prst="rect">
             <a:avLst/>
           </a:prstGeom>
-          <a:noFill/>
-          <a:ln/>
         </p:spPr>
-        <p:txBody>
-          <a:bodyPr wrap="square" lIns="0" tIns="0" rIns="0" bIns="0" rtlCol="0" anchor="ctr"/>
-          <a:lstStyle/>
-          <a:p>
-            <a:pPr indent="0" marL="0">
-              <a:buNone/>
-            </a:pPr>
-            <a:r>
-              <a:rPr lang="en-US" sz="1700" b="1" dirty="0">
-                <a:solidFill>
-                  <a:srgbClr val="16376C"/>
-                </a:solidFill>
-                <a:latin typeface="Calibri" pitchFamily="34" charset="0"/>
-                <a:ea typeface="Calibri" pitchFamily="34" charset="-122"/>
-                <a:cs typeface="Calibri" pitchFamily="34" charset="-120"/>
-              </a:rPr>
-              <a:t>DTE Energy</a:t>
-            </a:r>
-            <a:endParaRPr lang="en-US" sz="1700" dirty="0"/>
-          </a:p>
-        </p:txBody>
-      </p:sp>
-      <p:sp>
-        <p:nvSpPr>
-          <p:cNvPr id="11" name="Text 9"/>
+      </p:pic>
+      <p:sp>
+        <p:nvSpPr>
+          <p:cNvPr id="11" name="Text 7"/>
           <p:cNvSpPr/>
           <p:nvPr/>
         </p:nvSpPr>
         <p:spPr>
           <a:xfrm>
-            <a:off x="6510528" y="1837944"/>
-            <a:ext cx="4206240" cy="237744"/>
+            <a:off x="8750808" y="1645920"/>
+            <a:ext cx="2377440" cy="274320"/>
           </a:xfrm>
           <a:prstGeom prst="rect">
             <a:avLst/>
@@ -14848,7 +14816,7 @@
       </p:sp>
       <p:sp>
         <p:nvSpPr>
-          <p:cNvPr id="12" name="Text 10"/>
+          <p:cNvPr id="12" name="Text 8"/>
           <p:cNvSpPr/>
           <p:nvPr/>
         </p:nvSpPr>
@@ -14901,7 +14869,7 @@
       </p:sp>
       <p:sp>
         <p:nvSpPr>
-          <p:cNvPr id="13" name="Text 11"/>
+          <p:cNvPr id="13" name="Text 9"/>
           <p:cNvSpPr/>
           <p:nvPr/>
         </p:nvSpPr>
@@ -14940,7 +14908,7 @@
       </p:sp>
       <p:sp>
         <p:nvSpPr>
-          <p:cNvPr id="14" name="Shape 12"/>
+          <p:cNvPr id="14" name="Shape 10"/>
           <p:cNvSpPr/>
           <p:nvPr/>
         </p:nvSpPr>
@@ -14965,55 +14933,39 @@
           </a:ln>
         </p:spPr>
       </p:sp>
-      <p:sp>
-        <p:nvSpPr>
-          <p:cNvPr id="15" name="Text 13"/>
-          <p:cNvSpPr/>
+      <p:pic>
+        <p:nvPicPr>
+          <p:cNvPr id="15" name="Image 2" descr="/home/user/CVR---Financial/reports/assets/logos/centerpoint.png">    </p:cNvPr>
+          <p:cNvPicPr>
+            <a:picLocks noChangeAspect="1"/>
+          </p:cNvPicPr>
           <p:nvPr/>
-        </p:nvSpPr>
+        </p:nvPicPr>
+        <p:blipFill>
+          <a:blip r:embed="rId3"/>
+          <a:srcRect l="0" r="0" t="0" b="0"/>
+          <a:stretch/>
+        </p:blipFill>
         <p:spPr>
           <a:xfrm>
             <a:off x="768096" y="3749040"/>
-            <a:ext cx="3566160" cy="310896"/>
+            <a:ext cx="2103120" cy="502920"/>
           </a:xfrm>
           <a:prstGeom prst="rect">
             <a:avLst/>
           </a:prstGeom>
-          <a:noFill/>
-          <a:ln/>
         </p:spPr>
-        <p:txBody>
-          <a:bodyPr wrap="square" lIns="0" tIns="0" rIns="0" bIns="0" rtlCol="0" anchor="ctr"/>
-          <a:lstStyle/>
-          <a:p>
-            <a:pPr indent="0" marL="0">
-              <a:buNone/>
-            </a:pPr>
-            <a:r>
-              <a:rPr lang="en-US" sz="1700" b="1" dirty="0">
-                <a:solidFill>
-                  <a:srgbClr val="E31937"/>
-                </a:solidFill>
-                <a:latin typeface="Calibri" pitchFamily="34" charset="0"/>
-                <a:ea typeface="Calibri" pitchFamily="34" charset="-122"/>
-                <a:cs typeface="Calibri" pitchFamily="34" charset="-120"/>
-              </a:rPr>
-              <a:t>CenterPoint Energy</a:t>
-            </a:r>
-            <a:endParaRPr lang="en-US" sz="1700" dirty="0"/>
-          </a:p>
-        </p:txBody>
-      </p:sp>
-      <p:sp>
-        <p:nvSpPr>
-          <p:cNvPr id="16" name="Text 14"/>
+      </p:pic>
+      <p:sp>
+        <p:nvSpPr>
+          <p:cNvPr id="16" name="Text 11"/>
           <p:cNvSpPr/>
           <p:nvPr/>
         </p:nvSpPr>
         <p:spPr>
           <a:xfrm>
-            <a:off x="768096" y="4050792"/>
-            <a:ext cx="4206240" cy="237744"/>
+            <a:off x="3008376" y="3858768"/>
+            <a:ext cx="2377440" cy="274320"/>
           </a:xfrm>
           <a:prstGeom prst="rect">
             <a:avLst/>
@@ -15045,7 +14997,7 @@
       </p:sp>
       <p:sp>
         <p:nvSpPr>
-          <p:cNvPr id="17" name="Text 15"/>
+          <p:cNvPr id="17" name="Text 12"/>
           <p:cNvSpPr/>
           <p:nvPr/>
         </p:nvSpPr>
@@ -15098,7 +15050,7 @@
       </p:sp>
       <p:sp>
         <p:nvSpPr>
-          <p:cNvPr id="18" name="Text 16"/>
+          <p:cNvPr id="18" name="Text 13"/>
           <p:cNvSpPr/>
           <p:nvPr/>
         </p:nvSpPr>
@@ -15137,7 +15089,7 @@
       </p:sp>
       <p:sp>
         <p:nvSpPr>
-          <p:cNvPr id="19" name="Shape 17"/>
+          <p:cNvPr id="19" name="Shape 14"/>
           <p:cNvSpPr/>
           <p:nvPr/>
         </p:nvSpPr>
@@ -15162,55 +15114,39 @@
           </a:ln>
         </p:spPr>
       </p:sp>
-      <p:sp>
-        <p:nvSpPr>
-          <p:cNvPr id="20" name="Text 18"/>
-          <p:cNvSpPr/>
+      <p:pic>
+        <p:nvPicPr>
+          <p:cNvPr id="20" name="Image 3" descr="/home/user/CVR---Financial/reports/assets/logos/midamerican.png">    </p:cNvPr>
+          <p:cNvPicPr>
+            <a:picLocks noChangeAspect="1"/>
+          </p:cNvPicPr>
           <p:nvPr/>
-        </p:nvSpPr>
+        </p:nvPicPr>
+        <p:blipFill>
+          <a:blip r:embed="rId4"/>
+          <a:srcRect l="0" r="0" t="0" b="0"/>
+          <a:stretch/>
+        </p:blipFill>
         <p:spPr>
           <a:xfrm>
             <a:off x="6510528" y="3749040"/>
-            <a:ext cx="3566160" cy="310896"/>
+            <a:ext cx="2103120" cy="502920"/>
           </a:xfrm>
           <a:prstGeom prst="rect">
             <a:avLst/>
           </a:prstGeom>
-          <a:noFill/>
-          <a:ln/>
         </p:spPr>
-        <p:txBody>
-          <a:bodyPr wrap="square" lIns="0" tIns="0" rIns="0" bIns="0" rtlCol="0" anchor="ctr"/>
-          <a:lstStyle/>
-          <a:p>
-            <a:pPr indent="0" marL="0">
-              <a:buNone/>
-            </a:pPr>
-            <a:r>
-              <a:rPr lang="en-US" sz="1700" b="1" dirty="0">
-                <a:solidFill>
-                  <a:srgbClr val="14477D"/>
-                </a:solidFill>
-                <a:latin typeface="Calibri" pitchFamily="34" charset="0"/>
-                <a:ea typeface="Calibri" pitchFamily="34" charset="-122"/>
-                <a:cs typeface="Calibri" pitchFamily="34" charset="-120"/>
-              </a:rPr>
-              <a:t>MidAmerican Energy (MEC)</a:t>
-            </a:r>
-            <a:endParaRPr lang="en-US" sz="1700" dirty="0"/>
-          </a:p>
-        </p:txBody>
-      </p:sp>
-      <p:sp>
-        <p:nvSpPr>
-          <p:cNvPr id="21" name="Text 19"/>
+      </p:pic>
+      <p:sp>
+        <p:nvSpPr>
+          <p:cNvPr id="21" name="Text 15"/>
           <p:cNvSpPr/>
           <p:nvPr/>
         </p:nvSpPr>
         <p:spPr>
           <a:xfrm>
-            <a:off x="6510528" y="4050792"/>
-            <a:ext cx="4206240" cy="237744"/>
+            <a:off x="8750808" y="3858768"/>
+            <a:ext cx="2377440" cy="274320"/>
           </a:xfrm>
           <a:prstGeom prst="rect">
             <a:avLst/>
@@ -15242,7 +15178,7 @@
       </p:sp>
       <p:sp>
         <p:nvSpPr>
-          <p:cNvPr id="22" name="Text 20"/>
+          <p:cNvPr id="22" name="Text 16"/>
           <p:cNvSpPr/>
           <p:nvPr/>
         </p:nvSpPr>
@@ -15295,7 +15231,7 @@
       </p:sp>
       <p:sp>
         <p:nvSpPr>
-          <p:cNvPr id="23" name="Text 21"/>
+          <p:cNvPr id="23" name="Text 17"/>
           <p:cNvSpPr/>
           <p:nvPr/>
         </p:nvSpPr>
@@ -15334,7 +15270,7 @@
       </p:sp>
       <p:sp>
         <p:nvSpPr>
-          <p:cNvPr id="24" name="Shape 22"/>
+          <p:cNvPr id="24" name="Shape 18"/>
           <p:cNvSpPr/>
           <p:nvPr/>
         </p:nvSpPr>
@@ -15361,7 +15297,7 @@
       </p:sp>
       <p:sp>
         <p:nvSpPr>
-          <p:cNvPr id="25" name="Text 23"/>
+          <p:cNvPr id="25" name="Text 19"/>
           <p:cNvSpPr/>
           <p:nvPr/>
         </p:nvSpPr>
@@ -15414,7 +15350,7 @@
       </p:sp>
       <p:sp>
         <p:nvSpPr>
-          <p:cNvPr id="26" name="Text 24"/>
+          <p:cNvPr id="26" name="Text 20"/>
           <p:cNvSpPr/>
           <p:nvPr/>
         </p:nvSpPr>
@@ -15445,7 +15381,7 @@
                 <a:ea typeface="Calibri" pitchFamily="34" charset="-122"/>
                 <a:cs typeface="Calibri" pitchFamily="34" charset="-120"/>
               </a:rPr>
-              <a:t>Public sources: company capital-plan announcements and filings (Utility Dive, SEC 8-K, company releases), July 2026. Wordmarks shown; drop official logo files into reports/assets/logos/ and rebuild to swap them in.</a:t>
+              <a:t>Public sources: company capital-plan announcements and filings (Utility Dive, SEC 8-K, company releases), July 2026. Logos are the property of their respective owners; shown for internal reference only.</a:t>
             </a:r>
             <a:endParaRPr lang="en-US" sz="950" dirty="0"/>
           </a:p>

</xml_diff>

<commit_message>
Remove parent-note narrative; add national expansion-target slide
The USC 'note' is an intercompany cash-clearing true-up (single central
bank account), not a promissory note, so drop it from the deck: remove the
standalone Cash & Parent Note slide and scrub the note framing from the
agenda, the bid-engineering slide (facts/options/footnote), and priorities.

Add a 'new logos' expansion-target slide after the addressable-market slide
covering AEP (~$78B), FirstEnergy ($36B), PG&E ($73B), and Southern
Company ($81B) five-year capital plans, with placeholders for relationship
notes. Figures per latest 2025-2026 company disclosures.
</commit_message>
<xml_diff>
--- a/reports/CVR_Deck_Jun2026.pptx
+++ b/reports/CVR_Deck_Jun2026.pptx
@@ -15459,6 +15459,1030 @@
                 <a:ea typeface="Calibri" pitchFamily="34" charset="-122"/>
                 <a:cs typeface="Calibri" pitchFamily="34" charset="-120"/>
               </a:rPr>
+              <a:t>STRATEGY — BEYOND THE CURRENT FOOTPRINT</a:t>
+            </a:r>
+            <a:endParaRPr lang="en-US" sz="1100" dirty="0"/>
+          </a:p>
+        </p:txBody>
+      </p:sp>
+      <p:sp>
+        <p:nvSpPr>
+          <p:cNvPr id="3" name="Text 1"/>
+          <p:cNvSpPr/>
+          <p:nvPr/>
+        </p:nvSpPr>
+        <p:spPr>
+          <a:xfrm>
+            <a:off x="548640" y="548640"/>
+            <a:ext cx="11064240" cy="502920"/>
+          </a:xfrm>
+          <a:prstGeom prst="rect">
+            <a:avLst/>
+          </a:prstGeom>
+          <a:noFill/>
+          <a:ln/>
+        </p:spPr>
+        <p:txBody>
+          <a:bodyPr wrap="square" lIns="0" tIns="0" rIns="0" bIns="0" rtlCol="0" anchor="ctr"/>
+          <a:lstStyle/>
+          <a:p>
+            <a:pPr indent="0" marL="0">
+              <a:buNone/>
+            </a:pPr>
+            <a:r>
+              <a:rPr lang="en-US" sz="2700" b="1" dirty="0">
+                <a:solidFill>
+                  <a:srgbClr val="0B0B0B"/>
+                </a:solidFill>
+                <a:latin typeface="Calibri" pitchFamily="34" charset="0"/>
+                <a:ea typeface="Calibri" pitchFamily="34" charset="-122"/>
+                <a:cs typeface="Calibri" pitchFamily="34" charset="-120"/>
+              </a:rPr>
+              <a:t>Target “new logos” — the national expansion list</a:t>
+            </a:r>
+            <a:endParaRPr lang="en-US" sz="2700" dirty="0"/>
+          </a:p>
+        </p:txBody>
+      </p:sp>
+      <p:sp>
+        <p:nvSpPr>
+          <p:cNvPr id="4" name="Shape 2"/>
+          <p:cNvSpPr/>
+          <p:nvPr/>
+        </p:nvSpPr>
+        <p:spPr>
+          <a:xfrm>
+            <a:off x="548640" y="1371600"/>
+            <a:ext cx="5559552" cy="2084832"/>
+          </a:xfrm>
+          <a:prstGeom prst="roundRect">
+            <a:avLst>
+              <a:gd name="adj" fmla="val 2632"/>
+            </a:avLst>
+          </a:prstGeom>
+          <a:solidFill>
+            <a:srgbClr val="F7F7F5"/>
+          </a:solidFill>
+          <a:ln w="9525">
+            <a:solidFill>
+              <a:srgbClr val="E1E0D9"/>
+            </a:solidFill>
+            <a:prstDash val="solid"/>
+          </a:ln>
+        </p:spPr>
+      </p:sp>
+      <p:sp>
+        <p:nvSpPr>
+          <p:cNvPr id="5" name="Text 3"/>
+          <p:cNvSpPr/>
+          <p:nvPr/>
+        </p:nvSpPr>
+        <p:spPr>
+          <a:xfrm>
+            <a:off x="768096" y="1536192"/>
+            <a:ext cx="3566160" cy="310896"/>
+          </a:xfrm>
+          <a:prstGeom prst="rect">
+            <a:avLst/>
+          </a:prstGeom>
+          <a:noFill/>
+          <a:ln/>
+        </p:spPr>
+        <p:txBody>
+          <a:bodyPr wrap="square" lIns="0" tIns="0" rIns="0" bIns="0" rtlCol="0" anchor="ctr"/>
+          <a:lstStyle/>
+          <a:p>
+            <a:pPr indent="0" marL="0">
+              <a:buNone/>
+            </a:pPr>
+            <a:r>
+              <a:rPr lang="en-US" sz="1700" b="1" dirty="0">
+                <a:solidFill>
+                  <a:srgbClr val="F58025"/>
+                </a:solidFill>
+                <a:latin typeface="Calibri" pitchFamily="34" charset="0"/>
+                <a:ea typeface="Calibri" pitchFamily="34" charset="-122"/>
+                <a:cs typeface="Calibri" pitchFamily="34" charset="-120"/>
+              </a:rPr>
+              <a:t>AEP</a:t>
+            </a:r>
+            <a:endParaRPr lang="en-US" sz="1700" dirty="0"/>
+          </a:p>
+        </p:txBody>
+      </p:sp>
+      <p:sp>
+        <p:nvSpPr>
+          <p:cNvPr id="6" name="Text 4"/>
+          <p:cNvSpPr/>
+          <p:nvPr/>
+        </p:nvSpPr>
+        <p:spPr>
+          <a:xfrm>
+            <a:off x="768096" y="1837944"/>
+            <a:ext cx="4206240" cy="237744"/>
+          </a:xfrm>
+          <a:prstGeom prst="rect">
+            <a:avLst/>
+          </a:prstGeom>
+          <a:noFill/>
+          <a:ln/>
+        </p:spPr>
+        <p:txBody>
+          <a:bodyPr wrap="square" lIns="0" tIns="0" rIns="0" bIns="0" rtlCol="0" anchor="ctr"/>
+          <a:lstStyle/>
+          <a:p>
+            <a:pPr indent="0" marL="0">
+              <a:buNone/>
+            </a:pPr>
+            <a:r>
+              <a:rPr lang="en-US" sz="1000" dirty="0">
+                <a:solidFill>
+                  <a:srgbClr val="52514E"/>
+                </a:solidFill>
+                <a:latin typeface="Calibri" pitchFamily="34" charset="0"/>
+                <a:ea typeface="Calibri" pitchFamily="34" charset="-122"/>
+                <a:cs typeface="Calibri" pitchFamily="34" charset="-120"/>
+              </a:rPr>
+              <a:t>American Electric Power · 11-state footprint</a:t>
+            </a:r>
+            <a:endParaRPr lang="en-US" sz="1000" dirty="0"/>
+          </a:p>
+        </p:txBody>
+      </p:sp>
+      <p:sp>
+        <p:nvSpPr>
+          <p:cNvPr id="7" name="Text 5"/>
+          <p:cNvSpPr/>
+          <p:nvPr/>
+        </p:nvSpPr>
+        <p:spPr>
+          <a:xfrm>
+            <a:off x="768096" y="2157984"/>
+            <a:ext cx="5120640" cy="713232"/>
+          </a:xfrm>
+          <a:prstGeom prst="rect">
+            <a:avLst/>
+          </a:prstGeom>
+          <a:noFill/>
+          <a:ln/>
+        </p:spPr>
+        <p:txBody>
+          <a:bodyPr wrap="square" lIns="0" tIns="0" rIns="0" bIns="0" rtlCol="0" anchor="ctr"/>
+          <a:lstStyle/>
+          <a:p>
+            <a:pPr indent="0" marL="0">
+              <a:buNone/>
+            </a:pPr>
+            <a:r>
+              <a:rPr lang="en-US" sz="2400" b="1" dirty="0">
+                <a:solidFill>
+                  <a:srgbClr val="0B0B0B"/>
+                </a:solidFill>
+                <a:latin typeface="Calibri" pitchFamily="34" charset="0"/>
+                <a:ea typeface="Calibri" pitchFamily="34" charset="-122"/>
+                <a:cs typeface="Calibri" pitchFamily="34" charset="-120"/>
+              </a:rPr>
+              <a:t>$78B  </a:t>
+            </a:r>
+            <a:pPr indent="0" marL="0">
+              <a:buNone/>
+            </a:pPr>
+            <a:r>
+              <a:rPr lang="en-US" sz="1050" dirty="0">
+                <a:solidFill>
+                  <a:srgbClr val="52514E"/>
+                </a:solidFill>
+                <a:latin typeface="Calibri" pitchFamily="34" charset="0"/>
+                <a:ea typeface="Calibri" pitchFamily="34" charset="-122"/>
+                <a:cs typeface="Calibri" pitchFamily="34" charset="-120"/>
+              </a:rPr>
+              <a:t>Five-year capital plan raised to ~$78B (May 2026) on signed data-center load; largest transmission owner in the U.S.</a:t>
+            </a:r>
+            <a:endParaRPr lang="en-US" sz="2400" dirty="0"/>
+          </a:p>
+        </p:txBody>
+      </p:sp>
+      <p:sp>
+        <p:nvSpPr>
+          <p:cNvPr id="8" name="Text 6"/>
+          <p:cNvSpPr/>
+          <p:nvPr/>
+        </p:nvSpPr>
+        <p:spPr>
+          <a:xfrm>
+            <a:off x="768096" y="2944368"/>
+            <a:ext cx="5120640" cy="457200"/>
+          </a:xfrm>
+          <a:prstGeom prst="rect">
+            <a:avLst/>
+          </a:prstGeom>
+          <a:noFill/>
+          <a:ln/>
+        </p:spPr>
+        <p:txBody>
+          <a:bodyPr wrap="square" lIns="0" tIns="0" rIns="0" bIns="0" rtlCol="0" anchor="ctr"/>
+          <a:lstStyle/>
+          <a:p>
+            <a:pPr indent="0" marL="0">
+              <a:buNone/>
+            </a:pPr>
+            <a:r>
+              <a:rPr lang="en-US" sz="1000" i="1" dirty="0">
+                <a:solidFill>
+                  <a:srgbClr val="2A78D6"/>
+                </a:solidFill>
+                <a:latin typeface="Calibri" pitchFamily="34" charset="0"/>
+                <a:ea typeface="Calibri" pitchFamily="34" charset="-122"/>
+                <a:cs typeface="Calibri" pitchFamily="34" charset="-120"/>
+              </a:rPr>
+              <a:t>Where we stand: — to be added</a:t>
+            </a:r>
+            <a:endParaRPr lang="en-US" sz="1000" dirty="0"/>
+          </a:p>
+        </p:txBody>
+      </p:sp>
+      <p:sp>
+        <p:nvSpPr>
+          <p:cNvPr id="9" name="Shape 7"/>
+          <p:cNvSpPr/>
+          <p:nvPr/>
+        </p:nvSpPr>
+        <p:spPr>
+          <a:xfrm>
+            <a:off x="6291072" y="1371600"/>
+            <a:ext cx="5559552" cy="2084832"/>
+          </a:xfrm>
+          <a:prstGeom prst="roundRect">
+            <a:avLst>
+              <a:gd name="adj" fmla="val 2632"/>
+            </a:avLst>
+          </a:prstGeom>
+          <a:solidFill>
+            <a:srgbClr val="F7F7F5"/>
+          </a:solidFill>
+          <a:ln w="9525">
+            <a:solidFill>
+              <a:srgbClr val="E1E0D9"/>
+            </a:solidFill>
+            <a:prstDash val="solid"/>
+          </a:ln>
+        </p:spPr>
+      </p:sp>
+      <p:sp>
+        <p:nvSpPr>
+          <p:cNvPr id="10" name="Text 8"/>
+          <p:cNvSpPr/>
+          <p:nvPr/>
+        </p:nvSpPr>
+        <p:spPr>
+          <a:xfrm>
+            <a:off x="6510528" y="1536192"/>
+            <a:ext cx="3566160" cy="310896"/>
+          </a:xfrm>
+          <a:prstGeom prst="rect">
+            <a:avLst/>
+          </a:prstGeom>
+          <a:noFill/>
+          <a:ln/>
+        </p:spPr>
+        <p:txBody>
+          <a:bodyPr wrap="square" lIns="0" tIns="0" rIns="0" bIns="0" rtlCol="0" anchor="ctr"/>
+          <a:lstStyle/>
+          <a:p>
+            <a:pPr indent="0" marL="0">
+              <a:buNone/>
+            </a:pPr>
+            <a:r>
+              <a:rPr lang="en-US" sz="1700" b="1" dirty="0">
+                <a:solidFill>
+                  <a:srgbClr val="1C3F94"/>
+                </a:solidFill>
+                <a:latin typeface="Calibri" pitchFamily="34" charset="0"/>
+                <a:ea typeface="Calibri" pitchFamily="34" charset="-122"/>
+                <a:cs typeface="Calibri" pitchFamily="34" charset="-120"/>
+              </a:rPr>
+              <a:t>FirstEnergy</a:t>
+            </a:r>
+            <a:endParaRPr lang="en-US" sz="1700" dirty="0"/>
+          </a:p>
+        </p:txBody>
+      </p:sp>
+      <p:sp>
+        <p:nvSpPr>
+          <p:cNvPr id="11" name="Text 9"/>
+          <p:cNvSpPr/>
+          <p:nvPr/>
+        </p:nvSpPr>
+        <p:spPr>
+          <a:xfrm>
+            <a:off x="6510528" y="1837944"/>
+            <a:ext cx="4206240" cy="237744"/>
+          </a:xfrm>
+          <a:prstGeom prst="rect">
+            <a:avLst/>
+          </a:prstGeom>
+          <a:noFill/>
+          <a:ln/>
+        </p:spPr>
+        <p:txBody>
+          <a:bodyPr wrap="square" lIns="0" tIns="0" rIns="0" bIns="0" rtlCol="0" anchor="ctr"/>
+          <a:lstStyle/>
+          <a:p>
+            <a:pPr indent="0" marL="0">
+              <a:buNone/>
+            </a:pPr>
+            <a:r>
+              <a:rPr lang="en-US" sz="1000" dirty="0">
+                <a:solidFill>
+                  <a:srgbClr val="52514E"/>
+                </a:solidFill>
+                <a:latin typeface="Calibri" pitchFamily="34" charset="0"/>
+                <a:ea typeface="Calibri" pitchFamily="34" charset="-122"/>
+                <a:cs typeface="Calibri" pitchFamily="34" charset="-120"/>
+              </a:rPr>
+              <a:t>OH · PA · NJ · WV · MD · ~6M customers</a:t>
+            </a:r>
+            <a:endParaRPr lang="en-US" sz="1000" dirty="0"/>
+          </a:p>
+        </p:txBody>
+      </p:sp>
+      <p:sp>
+        <p:nvSpPr>
+          <p:cNvPr id="12" name="Text 10"/>
+          <p:cNvSpPr/>
+          <p:nvPr/>
+        </p:nvSpPr>
+        <p:spPr>
+          <a:xfrm>
+            <a:off x="6510528" y="2157984"/>
+            <a:ext cx="5120640" cy="713232"/>
+          </a:xfrm>
+          <a:prstGeom prst="rect">
+            <a:avLst/>
+          </a:prstGeom>
+          <a:noFill/>
+          <a:ln/>
+        </p:spPr>
+        <p:txBody>
+          <a:bodyPr wrap="square" lIns="0" tIns="0" rIns="0" bIns="0" rtlCol="0" anchor="ctr"/>
+          <a:lstStyle/>
+          <a:p>
+            <a:pPr indent="0" marL="0">
+              <a:buNone/>
+            </a:pPr>
+            <a:r>
+              <a:rPr lang="en-US" sz="2400" b="1" dirty="0">
+                <a:solidFill>
+                  <a:srgbClr val="0B0B0B"/>
+                </a:solidFill>
+                <a:latin typeface="Calibri" pitchFamily="34" charset="0"/>
+                <a:ea typeface="Calibri" pitchFamily="34" charset="-122"/>
+                <a:cs typeface="Calibri" pitchFamily="34" charset="-120"/>
+              </a:rPr>
+              <a:t>$36B  </a:t>
+            </a:r>
+            <a:pPr indent="0" marL="0">
+              <a:buNone/>
+            </a:pPr>
+            <a:r>
+              <a:rPr lang="en-US" sz="1050" dirty="0">
+                <a:solidFill>
+                  <a:srgbClr val="52514E"/>
+                </a:solidFill>
+                <a:latin typeface="Calibri" pitchFamily="34" charset="0"/>
+                <a:ea typeface="Calibri" pitchFamily="34" charset="-122"/>
+                <a:cs typeface="Calibri" pitchFamily="34" charset="-120"/>
+              </a:rPr>
+              <a:t>“Energize365” grid plan, 2026–30 — up ~30% vs. prior; transmission &amp; distribution modernization and reliability</a:t>
+            </a:r>
+            <a:endParaRPr lang="en-US" sz="2400" dirty="0"/>
+          </a:p>
+        </p:txBody>
+      </p:sp>
+      <p:sp>
+        <p:nvSpPr>
+          <p:cNvPr id="13" name="Text 11"/>
+          <p:cNvSpPr/>
+          <p:nvPr/>
+        </p:nvSpPr>
+        <p:spPr>
+          <a:xfrm>
+            <a:off x="6510528" y="2944368"/>
+            <a:ext cx="5120640" cy="457200"/>
+          </a:xfrm>
+          <a:prstGeom prst="rect">
+            <a:avLst/>
+          </a:prstGeom>
+          <a:noFill/>
+          <a:ln/>
+        </p:spPr>
+        <p:txBody>
+          <a:bodyPr wrap="square" lIns="0" tIns="0" rIns="0" bIns="0" rtlCol="0" anchor="ctr"/>
+          <a:lstStyle/>
+          <a:p>
+            <a:pPr indent="0" marL="0">
+              <a:buNone/>
+            </a:pPr>
+            <a:r>
+              <a:rPr lang="en-US" sz="1000" i="1" dirty="0">
+                <a:solidFill>
+                  <a:srgbClr val="2A78D6"/>
+                </a:solidFill>
+                <a:latin typeface="Calibri" pitchFamily="34" charset="0"/>
+                <a:ea typeface="Calibri" pitchFamily="34" charset="-122"/>
+                <a:cs typeface="Calibri" pitchFamily="34" charset="-120"/>
+              </a:rPr>
+              <a:t>Where we stand: — to be added</a:t>
+            </a:r>
+            <a:endParaRPr lang="en-US" sz="1000" dirty="0"/>
+          </a:p>
+        </p:txBody>
+      </p:sp>
+      <p:sp>
+        <p:nvSpPr>
+          <p:cNvPr id="14" name="Shape 12"/>
+          <p:cNvSpPr/>
+          <p:nvPr/>
+        </p:nvSpPr>
+        <p:spPr>
+          <a:xfrm>
+            <a:off x="548640" y="3584448"/>
+            <a:ext cx="5559552" cy="2084832"/>
+          </a:xfrm>
+          <a:prstGeom prst="roundRect">
+            <a:avLst>
+              <a:gd name="adj" fmla="val 2632"/>
+            </a:avLst>
+          </a:prstGeom>
+          <a:solidFill>
+            <a:srgbClr val="F7F7F5"/>
+          </a:solidFill>
+          <a:ln w="9525">
+            <a:solidFill>
+              <a:srgbClr val="E1E0D9"/>
+            </a:solidFill>
+            <a:prstDash val="solid"/>
+          </a:ln>
+        </p:spPr>
+      </p:sp>
+      <p:sp>
+        <p:nvSpPr>
+          <p:cNvPr id="15" name="Text 13"/>
+          <p:cNvSpPr/>
+          <p:nvPr/>
+        </p:nvSpPr>
+        <p:spPr>
+          <a:xfrm>
+            <a:off x="768096" y="3749040"/>
+            <a:ext cx="3566160" cy="310896"/>
+          </a:xfrm>
+          <a:prstGeom prst="rect">
+            <a:avLst/>
+          </a:prstGeom>
+          <a:noFill/>
+          <a:ln/>
+        </p:spPr>
+        <p:txBody>
+          <a:bodyPr wrap="square" lIns="0" tIns="0" rIns="0" bIns="0" rtlCol="0" anchor="ctr"/>
+          <a:lstStyle/>
+          <a:p>
+            <a:pPr indent="0" marL="0">
+              <a:buNone/>
+            </a:pPr>
+            <a:r>
+              <a:rPr lang="en-US" sz="1700" b="1" dirty="0">
+                <a:solidFill>
+                  <a:srgbClr val="0033A0"/>
+                </a:solidFill>
+                <a:latin typeface="Calibri" pitchFamily="34" charset="0"/>
+                <a:ea typeface="Calibri" pitchFamily="34" charset="-122"/>
+                <a:cs typeface="Calibri" pitchFamily="34" charset="-120"/>
+              </a:rPr>
+              <a:t>PG&amp;E</a:t>
+            </a:r>
+            <a:endParaRPr lang="en-US" sz="1700" dirty="0"/>
+          </a:p>
+        </p:txBody>
+      </p:sp>
+      <p:sp>
+        <p:nvSpPr>
+          <p:cNvPr id="16" name="Text 14"/>
+          <p:cNvSpPr/>
+          <p:nvPr/>
+        </p:nvSpPr>
+        <p:spPr>
+          <a:xfrm>
+            <a:off x="768096" y="4050792"/>
+            <a:ext cx="4206240" cy="237744"/>
+          </a:xfrm>
+          <a:prstGeom prst="rect">
+            <a:avLst/>
+          </a:prstGeom>
+          <a:noFill/>
+          <a:ln/>
+        </p:spPr>
+        <p:txBody>
+          <a:bodyPr wrap="square" lIns="0" tIns="0" rIns="0" bIns="0" rtlCol="0" anchor="ctr"/>
+          <a:lstStyle/>
+          <a:p>
+            <a:pPr indent="0" marL="0">
+              <a:buNone/>
+            </a:pPr>
+            <a:r>
+              <a:rPr lang="en-US" sz="1000" dirty="0">
+                <a:solidFill>
+                  <a:srgbClr val="52514E"/>
+                </a:solidFill>
+                <a:latin typeface="Calibri" pitchFamily="34" charset="0"/>
+                <a:ea typeface="Calibri" pitchFamily="34" charset="-122"/>
+                <a:cs typeface="Calibri" pitchFamily="34" charset="-120"/>
+              </a:rPr>
+              <a:t>Pacific Gas &amp; Electric · N. &amp; Central California</a:t>
+            </a:r>
+            <a:endParaRPr lang="en-US" sz="1000" dirty="0"/>
+          </a:p>
+        </p:txBody>
+      </p:sp>
+      <p:sp>
+        <p:nvSpPr>
+          <p:cNvPr id="17" name="Text 15"/>
+          <p:cNvSpPr/>
+          <p:nvPr/>
+        </p:nvSpPr>
+        <p:spPr>
+          <a:xfrm>
+            <a:off x="768096" y="4370832"/>
+            <a:ext cx="5120640" cy="713232"/>
+          </a:xfrm>
+          <a:prstGeom prst="rect">
+            <a:avLst/>
+          </a:prstGeom>
+          <a:noFill/>
+          <a:ln/>
+        </p:spPr>
+        <p:txBody>
+          <a:bodyPr wrap="square" lIns="0" tIns="0" rIns="0" bIns="0" rtlCol="0" anchor="ctr"/>
+          <a:lstStyle/>
+          <a:p>
+            <a:pPr indent="0" marL="0">
+              <a:buNone/>
+            </a:pPr>
+            <a:r>
+              <a:rPr lang="en-US" sz="2400" b="1" dirty="0">
+                <a:solidFill>
+                  <a:srgbClr val="0B0B0B"/>
+                </a:solidFill>
+                <a:latin typeface="Calibri" pitchFamily="34" charset="0"/>
+                <a:ea typeface="Calibri" pitchFamily="34" charset="-122"/>
+                <a:cs typeface="Calibri" pitchFamily="34" charset="-120"/>
+              </a:rPr>
+              <a:t>$73B  </a:t>
+            </a:r>
+            <a:pPr indent="0" marL="0">
+              <a:buNone/>
+            </a:pPr>
+            <a:r>
+              <a:rPr lang="en-US" sz="1050" dirty="0">
+                <a:solidFill>
+                  <a:srgbClr val="52514E"/>
+                </a:solidFill>
+                <a:latin typeface="Calibri" pitchFamily="34" charset="0"/>
+                <a:ea typeface="Calibri" pitchFamily="34" charset="-122"/>
+                <a:cs typeface="Calibri" pitchFamily="34" charset="-120"/>
+              </a:rPr>
+              <a:t>$73B 2026–30 capital plan — wildfire undergrounding, grid hardening, and data-center-driven load growth</a:t>
+            </a:r>
+            <a:endParaRPr lang="en-US" sz="2400" dirty="0"/>
+          </a:p>
+        </p:txBody>
+      </p:sp>
+      <p:sp>
+        <p:nvSpPr>
+          <p:cNvPr id="18" name="Text 16"/>
+          <p:cNvSpPr/>
+          <p:nvPr/>
+        </p:nvSpPr>
+        <p:spPr>
+          <a:xfrm>
+            <a:off x="768096" y="5157216"/>
+            <a:ext cx="5120640" cy="457200"/>
+          </a:xfrm>
+          <a:prstGeom prst="rect">
+            <a:avLst/>
+          </a:prstGeom>
+          <a:noFill/>
+          <a:ln/>
+        </p:spPr>
+        <p:txBody>
+          <a:bodyPr wrap="square" lIns="0" tIns="0" rIns="0" bIns="0" rtlCol="0" anchor="ctr"/>
+          <a:lstStyle/>
+          <a:p>
+            <a:pPr indent="0" marL="0">
+              <a:buNone/>
+            </a:pPr>
+            <a:r>
+              <a:rPr lang="en-US" sz="1000" i="1" dirty="0">
+                <a:solidFill>
+                  <a:srgbClr val="2A78D6"/>
+                </a:solidFill>
+                <a:latin typeface="Calibri" pitchFamily="34" charset="0"/>
+                <a:ea typeface="Calibri" pitchFamily="34" charset="-122"/>
+                <a:cs typeface="Calibri" pitchFamily="34" charset="-120"/>
+              </a:rPr>
+              <a:t>Where we stand: — to be added</a:t>
+            </a:r>
+            <a:endParaRPr lang="en-US" sz="1000" dirty="0"/>
+          </a:p>
+        </p:txBody>
+      </p:sp>
+      <p:sp>
+        <p:nvSpPr>
+          <p:cNvPr id="19" name="Shape 17"/>
+          <p:cNvSpPr/>
+          <p:nvPr/>
+        </p:nvSpPr>
+        <p:spPr>
+          <a:xfrm>
+            <a:off x="6291072" y="3584448"/>
+            <a:ext cx="5559552" cy="2084832"/>
+          </a:xfrm>
+          <a:prstGeom prst="roundRect">
+            <a:avLst>
+              <a:gd name="adj" fmla="val 2632"/>
+            </a:avLst>
+          </a:prstGeom>
+          <a:solidFill>
+            <a:srgbClr val="F7F7F5"/>
+          </a:solidFill>
+          <a:ln w="9525">
+            <a:solidFill>
+              <a:srgbClr val="E1E0D9"/>
+            </a:solidFill>
+            <a:prstDash val="solid"/>
+          </a:ln>
+        </p:spPr>
+      </p:sp>
+      <p:sp>
+        <p:nvSpPr>
+          <p:cNvPr id="20" name="Text 18"/>
+          <p:cNvSpPr/>
+          <p:nvPr/>
+        </p:nvSpPr>
+        <p:spPr>
+          <a:xfrm>
+            <a:off x="6510528" y="3749040"/>
+            <a:ext cx="3566160" cy="310896"/>
+          </a:xfrm>
+          <a:prstGeom prst="rect">
+            <a:avLst/>
+          </a:prstGeom>
+          <a:noFill/>
+          <a:ln/>
+        </p:spPr>
+        <p:txBody>
+          <a:bodyPr wrap="square" lIns="0" tIns="0" rIns="0" bIns="0" rtlCol="0" anchor="ctr"/>
+          <a:lstStyle/>
+          <a:p>
+            <a:pPr indent="0" marL="0">
+              <a:buNone/>
+            </a:pPr>
+            <a:r>
+              <a:rPr lang="en-US" sz="1700" b="1" dirty="0">
+                <a:solidFill>
+                  <a:srgbClr val="00539B"/>
+                </a:solidFill>
+                <a:latin typeface="Calibri" pitchFamily="34" charset="0"/>
+                <a:ea typeface="Calibri" pitchFamily="34" charset="-122"/>
+                <a:cs typeface="Calibri" pitchFamily="34" charset="-120"/>
+              </a:rPr>
+              <a:t>Southern Company</a:t>
+            </a:r>
+            <a:endParaRPr lang="en-US" sz="1700" dirty="0"/>
+          </a:p>
+        </p:txBody>
+      </p:sp>
+      <p:sp>
+        <p:nvSpPr>
+          <p:cNvPr id="21" name="Text 19"/>
+          <p:cNvSpPr/>
+          <p:nvPr/>
+        </p:nvSpPr>
+        <p:spPr>
+          <a:xfrm>
+            <a:off x="6510528" y="4050792"/>
+            <a:ext cx="4206240" cy="237744"/>
+          </a:xfrm>
+          <a:prstGeom prst="rect">
+            <a:avLst/>
+          </a:prstGeom>
+          <a:noFill/>
+          <a:ln/>
+        </p:spPr>
+        <p:txBody>
+          <a:bodyPr wrap="square" lIns="0" tIns="0" rIns="0" bIns="0" rtlCol="0" anchor="ctr"/>
+          <a:lstStyle/>
+          <a:p>
+            <a:pPr indent="0" marL="0">
+              <a:buNone/>
+            </a:pPr>
+            <a:r>
+              <a:rPr lang="en-US" sz="1000" dirty="0">
+                <a:solidFill>
+                  <a:srgbClr val="52514E"/>
+                </a:solidFill>
+                <a:latin typeface="Calibri" pitchFamily="34" charset="0"/>
+                <a:ea typeface="Calibri" pitchFamily="34" charset="-122"/>
+                <a:cs typeface="Calibri" pitchFamily="34" charset="-120"/>
+              </a:rPr>
+              <a:t>Georgia · Alabama · Mississippi · electric + gas</a:t>
+            </a:r>
+            <a:endParaRPr lang="en-US" sz="1000" dirty="0"/>
+          </a:p>
+        </p:txBody>
+      </p:sp>
+      <p:sp>
+        <p:nvSpPr>
+          <p:cNvPr id="22" name="Text 20"/>
+          <p:cNvSpPr/>
+          <p:nvPr/>
+        </p:nvSpPr>
+        <p:spPr>
+          <a:xfrm>
+            <a:off x="6510528" y="4370832"/>
+            <a:ext cx="5120640" cy="713232"/>
+          </a:xfrm>
+          <a:prstGeom prst="rect">
+            <a:avLst/>
+          </a:prstGeom>
+          <a:noFill/>
+          <a:ln/>
+        </p:spPr>
+        <p:txBody>
+          <a:bodyPr wrap="square" lIns="0" tIns="0" rIns="0" bIns="0" rtlCol="0" anchor="ctr"/>
+          <a:lstStyle/>
+          <a:p>
+            <a:pPr indent="0" marL="0">
+              <a:buNone/>
+            </a:pPr>
+            <a:r>
+              <a:rPr lang="en-US" sz="2400" b="1" dirty="0">
+                <a:solidFill>
+                  <a:srgbClr val="0B0B0B"/>
+                </a:solidFill>
+                <a:latin typeface="Calibri" pitchFamily="34" charset="0"/>
+                <a:ea typeface="Calibri" pitchFamily="34" charset="-122"/>
+                <a:cs typeface="Calibri" pitchFamily="34" charset="-120"/>
+              </a:rPr>
+              <a:t>$81B  </a:t>
+            </a:r>
+            <a:pPr indent="0" marL="0">
+              <a:buNone/>
+            </a:pPr>
+            <a:r>
+              <a:rPr lang="en-US" sz="1050" dirty="0">
+                <a:solidFill>
+                  <a:srgbClr val="52514E"/>
+                </a:solidFill>
+                <a:latin typeface="Calibri" pitchFamily="34" charset="0"/>
+                <a:ea typeface="Calibri" pitchFamily="34" charset="-122"/>
+                <a:cs typeface="Calibri" pitchFamily="34" charset="-120"/>
+              </a:rPr>
+              <a:t>Five-year plan raised to $81B (Feb 2026) — data-center &amp; manufacturing load; Georgia Power system growth</a:t>
+            </a:r>
+            <a:endParaRPr lang="en-US" sz="2400" dirty="0"/>
+          </a:p>
+        </p:txBody>
+      </p:sp>
+      <p:sp>
+        <p:nvSpPr>
+          <p:cNvPr id="23" name="Text 21"/>
+          <p:cNvSpPr/>
+          <p:nvPr/>
+        </p:nvSpPr>
+        <p:spPr>
+          <a:xfrm>
+            <a:off x="6510528" y="5157216"/>
+            <a:ext cx="5120640" cy="457200"/>
+          </a:xfrm>
+          <a:prstGeom prst="rect">
+            <a:avLst/>
+          </a:prstGeom>
+          <a:noFill/>
+          <a:ln/>
+        </p:spPr>
+        <p:txBody>
+          <a:bodyPr wrap="square" lIns="0" tIns="0" rIns="0" bIns="0" rtlCol="0" anchor="ctr"/>
+          <a:lstStyle/>
+          <a:p>
+            <a:pPr indent="0" marL="0">
+              <a:buNone/>
+            </a:pPr>
+            <a:r>
+              <a:rPr lang="en-US" sz="1000" i="1" dirty="0">
+                <a:solidFill>
+                  <a:srgbClr val="2A78D6"/>
+                </a:solidFill>
+                <a:latin typeface="Calibri" pitchFamily="34" charset="0"/>
+                <a:ea typeface="Calibri" pitchFamily="34" charset="-122"/>
+                <a:cs typeface="Calibri" pitchFamily="34" charset="-120"/>
+              </a:rPr>
+              <a:t>Where we stand: — to be added</a:t>
+            </a:r>
+            <a:endParaRPr lang="en-US" sz="1000" dirty="0"/>
+          </a:p>
+        </p:txBody>
+      </p:sp>
+      <p:sp>
+        <p:nvSpPr>
+          <p:cNvPr id="24" name="Shape 22"/>
+          <p:cNvSpPr/>
+          <p:nvPr/>
+        </p:nvSpPr>
+        <p:spPr>
+          <a:xfrm>
+            <a:off x="548640" y="5870448"/>
+            <a:ext cx="11064240" cy="475488"/>
+          </a:xfrm>
+          <a:prstGeom prst="roundRect">
+            <a:avLst>
+              <a:gd name="adj" fmla="val 9615"/>
+            </a:avLst>
+          </a:prstGeom>
+          <a:solidFill>
+            <a:srgbClr val="EAF1FA"/>
+          </a:solidFill>
+          <a:ln w="9525">
+            <a:solidFill>
+              <a:srgbClr val="E1E0D9"/>
+            </a:solidFill>
+            <a:prstDash val="solid"/>
+          </a:ln>
+        </p:spPr>
+      </p:sp>
+      <p:sp>
+        <p:nvSpPr>
+          <p:cNvPr id="25" name="Text 23"/>
+          <p:cNvSpPr/>
+          <p:nvPr/>
+        </p:nvSpPr>
+        <p:spPr>
+          <a:xfrm>
+            <a:off x="731520" y="5943600"/>
+            <a:ext cx="10698480" cy="329184"/>
+          </a:xfrm>
+          <a:prstGeom prst="rect">
+            <a:avLst/>
+          </a:prstGeom>
+          <a:noFill/>
+          <a:ln/>
+        </p:spPr>
+        <p:txBody>
+          <a:bodyPr wrap="square" lIns="0" tIns="0" rIns="0" bIns="0" rtlCol="0" anchor="ctr"/>
+          <a:lstStyle/>
+          <a:p>
+            <a:pPr indent="0" marL="0">
+              <a:buNone/>
+            </a:pPr>
+            <a:r>
+              <a:rPr lang="en-US" sz="1250" b="1" dirty="0">
+                <a:solidFill>
+                  <a:srgbClr val="0B0B0B"/>
+                </a:solidFill>
+                <a:latin typeface="Calibri" pitchFamily="34" charset="0"/>
+                <a:ea typeface="Calibri" pitchFamily="34" charset="-122"/>
+                <a:cs typeface="Calibri" pitchFamily="34" charset="-120"/>
+              </a:rPr>
+              <a:t>≈$268B in disclosed five-year capital plans across these four targets.  </a:t>
+            </a:r>
+            <a:pPr indent="0" marL="0">
+              <a:buNone/>
+            </a:pPr>
+            <a:r>
+              <a:rPr lang="en-US" sz="1250" dirty="0">
+                <a:solidFill>
+                  <a:srgbClr val="52514E"/>
+                </a:solidFill>
+                <a:latin typeface="Calibri" pitchFamily="34" charset="0"/>
+                <a:ea typeface="Calibri" pitchFamily="34" charset="-122"/>
+                <a:cs typeface="Calibri" pitchFamily="34" charset="-120"/>
+              </a:rPr>
+              <a:t>The BD Lead's national pursuit list — beyond the current Michigan / Indiana / Iowa base.</a:t>
+            </a:r>
+            <a:endParaRPr lang="en-US" sz="1250" dirty="0"/>
+          </a:p>
+        </p:txBody>
+      </p:sp>
+      <p:sp>
+        <p:nvSpPr>
+          <p:cNvPr id="26" name="Text 24"/>
+          <p:cNvSpPr/>
+          <p:nvPr/>
+        </p:nvSpPr>
+        <p:spPr>
+          <a:xfrm>
+            <a:off x="548640" y="6419088"/>
+            <a:ext cx="11064240" cy="320040"/>
+          </a:xfrm>
+          <a:prstGeom prst="rect">
+            <a:avLst/>
+          </a:prstGeom>
+          <a:noFill/>
+          <a:ln/>
+        </p:spPr>
+        <p:txBody>
+          <a:bodyPr wrap="square" lIns="0" tIns="0" rIns="0" bIns="0" rtlCol="0" anchor="ctr"/>
+          <a:lstStyle/>
+          <a:p>
+            <a:pPr indent="0" marL="0">
+              <a:buNone/>
+            </a:pPr>
+            <a:r>
+              <a:rPr lang="en-US" sz="950" dirty="0">
+                <a:solidFill>
+                  <a:srgbClr val="898781"/>
+                </a:solidFill>
+                <a:latin typeface="Calibri" pitchFamily="34" charset="0"/>
+                <a:ea typeface="Calibri" pitchFamily="34" charset="-122"/>
+                <a:cs typeface="Calibri" pitchFamily="34" charset="-120"/>
+              </a:rPr>
+              <a:t>Public sources: latest company capital-plan disclosures (Q1 2025–Q1 2026 earnings / SEC filings); plan windows vary (2025–29 to 2026–30) — confirm current guidance. Relationship notes to follow. Drop official logos into reports/assets/logos/ (aep.png, firstenergy.png, pge.png, southern.png) to swap the wordmarks.</a:t>
+            </a:r>
+            <a:endParaRPr lang="en-US" sz="950" dirty="0"/>
+          </a:p>
+        </p:txBody>
+      </p:sp>
+    </p:spTree>
+  </p:cSld>
+  <p:clrMapOvr>
+    <a:masterClrMapping/>
+  </p:clrMapOvr>
+</p:sld>
+</file>
+
+<file path=ppt/slides/slide17.xml><?xml version="1.0" encoding="utf-8"?>
+<p:sld xmlns:a="http://schemas.openxmlformats.org/drawingml/2006/main" xmlns:r="http://schemas.openxmlformats.org/officeDocument/2006/relationships" xmlns:p="http://schemas.openxmlformats.org/presentationml/2006/main">
+  <p:cSld name="Slide 17">
+    <p:spTree>
+      <p:nvGrpSpPr>
+        <p:cNvPr id="1" name=""/>
+        <p:cNvGrpSpPr/>
+        <p:nvPr/>
+      </p:nvGrpSpPr>
+      <p:grpSpPr>
+        <a:xfrm>
+          <a:off x="0" y="0"/>
+          <a:ext cx="0" cy="0"/>
+          <a:chOff x="0" y="0"/>
+          <a:chExt cx="0" cy="0"/>
+        </a:xfrm>
+      </p:grpSpPr>
+      <p:sp>
+        <p:nvSpPr>
+          <p:cNvPr id="2" name="Text 0"/>
+          <p:cNvSpPr/>
+          <p:nvPr/>
+        </p:nvSpPr>
+        <p:spPr>
+          <a:xfrm>
+            <a:off x="548640" y="292608"/>
+            <a:ext cx="11064240" cy="274320"/>
+          </a:xfrm>
+          <a:prstGeom prst="rect">
+            <a:avLst/>
+          </a:prstGeom>
+          <a:noFill/>
+          <a:ln/>
+        </p:spPr>
+        <p:txBody>
+          <a:bodyPr wrap="square" lIns="0" tIns="0" rIns="0" bIns="0" rtlCol="0" anchor="ctr"/>
+          <a:lstStyle/>
+          <a:p>
+            <a:pPr indent="0" marL="0">
+              <a:buNone/>
+            </a:pPr>
+            <a:r>
+              <a:rPr lang="en-US" sz="1100" b="1" dirty="0">
+                <a:solidFill>
+                  <a:srgbClr val="86B332"/>
+                </a:solidFill>
+                <a:latin typeface="Calibri" pitchFamily="34" charset="0"/>
+                <a:ea typeface="Calibri" pitchFamily="34" charset="-122"/>
+                <a:cs typeface="Calibri" pitchFamily="34" charset="-120"/>
+              </a:rPr>
+              <a:t>— </a:t>
+            </a:r>
+            <a:pPr indent="0" marL="0">
+              <a:buNone/>
+            </a:pPr>
+            <a:r>
+              <a:rPr lang="en-US" sz="1100" b="1" spc="200" kern="0" dirty="0">
+                <a:solidFill>
+                  <a:srgbClr val="52514E"/>
+                </a:solidFill>
+                <a:latin typeface="Calibri" pitchFamily="34" charset="0"/>
+                <a:ea typeface="Calibri" pitchFamily="34" charset="-122"/>
+                <a:cs typeface="Calibri" pitchFamily="34" charset="-120"/>
+              </a:rPr>
               <a:t>STRATEGY — BUSINESS DEVELOPMENT</a:t>
             </a:r>
             <a:endParaRPr lang="en-US" sz="1100" dirty="0"/>
@@ -15506,7 +16530,7 @@
       </p:sp>
       <p:graphicFrame>
         <p:nvGraphicFramePr>
-          <p:cNvPr id="17" name="Table 0"/>
+          <p:cNvPr id="18" name="Table 0"/>
           <p:cNvGraphicFramePr>
             <a:graphicFrameLocks noGrp="1"/>
           </p:cNvGraphicFramePr>
@@ -17670,9 +18694,9 @@
 </p:sld>
 </file>
 
-<file path=ppt/slides/slide17.xml><?xml version="1.0" encoding="utf-8"?>
+<file path=ppt/slides/slide18.xml><?xml version="1.0" encoding="utf-8"?>
 <p:sld xmlns:a="http://schemas.openxmlformats.org/drawingml/2006/main" xmlns:r="http://schemas.openxmlformats.org/officeDocument/2006/relationships" xmlns:p="http://schemas.openxmlformats.org/presentationml/2006/main">
-  <p:cSld name="Slide 17">
+  <p:cSld name="Slide 18">
     <p:spTree>
       <p:nvGrpSpPr>
         <p:cNvPr id="1" name=""/>
@@ -18084,9 +19108,9 @@
 </p:sld>
 </file>
 
-<file path=ppt/slides/slide18.xml><?xml version="1.0" encoding="utf-8"?>
+<file path=ppt/slides/slide19.xml><?xml version="1.0" encoding="utf-8"?>
 <p:sld xmlns:a="http://schemas.openxmlformats.org/drawingml/2006/main" xmlns:r="http://schemas.openxmlformats.org/officeDocument/2006/relationships" xmlns:p="http://schemas.openxmlformats.org/presentationml/2006/main">
-  <p:cSld name="Slide 18">
+  <p:cSld name="Slide 19">
     <p:spTree>
       <p:nvGrpSpPr>
         <p:cNvPr id="1" name=""/>
@@ -18195,7 +19219,7 @@
       </p:sp>
       <p:graphicFrame>
         <p:nvGraphicFramePr>
-          <p:cNvPr id="19" name="Table 0"/>
+          <p:cNvPr id="20" name="Table 0"/>
           <p:cNvGraphicFramePr>
             <a:graphicFrameLocks noGrp="1"/>
           </p:cNvGraphicFramePr>
@@ -19938,7 +20962,7 @@
       </p:graphicFrame>
       <p:graphicFrame>
         <p:nvGraphicFramePr>
-          <p:cNvPr id="37" name="Table 1"/>
+          <p:cNvPr id="39" name="Table 1"/>
           <p:cNvGraphicFramePr>
             <a:graphicFrameLocks noGrp="1"/>
           </p:cNvGraphicFramePr>
@@ -20793,7 +21817,7 @@
       </p:graphicFrame>
       <p:graphicFrame>
         <p:nvGraphicFramePr>
-          <p:cNvPr id="55" name="Table 2"/>
+          <p:cNvPr id="58" name="Table 2"/>
           <p:cNvGraphicFramePr>
             <a:graphicFrameLocks noGrp="1"/>
           </p:cNvGraphicFramePr>
@@ -22411,420 +23435,6 @@
 </p:sld>
 </file>
 
-<file path=ppt/slides/slide19.xml><?xml version="1.0" encoding="utf-8"?>
-<p:sld xmlns:a="http://schemas.openxmlformats.org/drawingml/2006/main" xmlns:r="http://schemas.openxmlformats.org/officeDocument/2006/relationships" xmlns:p="http://schemas.openxmlformats.org/presentationml/2006/main">
-  <p:cSld name="Slide 19">
-    <p:spTree>
-      <p:nvGrpSpPr>
-        <p:cNvPr id="1" name=""/>
-        <p:cNvGrpSpPr/>
-        <p:nvPr/>
-      </p:nvGrpSpPr>
-      <p:grpSpPr>
-        <a:xfrm>
-          <a:off x="0" y="0"/>
-          <a:ext cx="0" cy="0"/>
-          <a:chOff x="0" y="0"/>
-          <a:chExt cx="0" cy="0"/>
-        </a:xfrm>
-      </p:grpSpPr>
-      <p:sp>
-        <p:nvSpPr>
-          <p:cNvPr id="2" name="Text 0"/>
-          <p:cNvSpPr/>
-          <p:nvPr/>
-        </p:nvSpPr>
-        <p:spPr>
-          <a:xfrm>
-            <a:off x="548640" y="292608"/>
-            <a:ext cx="11064240" cy="274320"/>
-          </a:xfrm>
-          <a:prstGeom prst="rect">
-            <a:avLst/>
-          </a:prstGeom>
-          <a:noFill/>
-          <a:ln/>
-        </p:spPr>
-        <p:txBody>
-          <a:bodyPr wrap="square" lIns="0" tIns="0" rIns="0" bIns="0" rtlCol="0" anchor="ctr"/>
-          <a:lstStyle/>
-          <a:p>
-            <a:pPr indent="0" marL="0">
-              <a:buNone/>
-            </a:pPr>
-            <a:r>
-              <a:rPr lang="en-US" sz="1100" b="1" dirty="0">
-                <a:solidFill>
-                  <a:srgbClr val="86B332"/>
-                </a:solidFill>
-                <a:latin typeface="Calibri" pitchFamily="34" charset="0"/>
-                <a:ea typeface="Calibri" pitchFamily="34" charset="-122"/>
-                <a:cs typeface="Calibri" pitchFamily="34" charset="-120"/>
-              </a:rPr>
-              <a:t>— </a:t>
-            </a:r>
-            <a:pPr indent="0" marL="0">
-              <a:buNone/>
-            </a:pPr>
-            <a:r>
-              <a:rPr lang="en-US" sz="1100" b="1" spc="200" kern="0" dirty="0">
-                <a:solidFill>
-                  <a:srgbClr val="52514E"/>
-                </a:solidFill>
-                <a:latin typeface="Calibri" pitchFamily="34" charset="0"/>
-                <a:ea typeface="Calibri" pitchFamily="34" charset="-122"/>
-                <a:cs typeface="Calibri" pitchFamily="34" charset="-120"/>
-              </a:rPr>
-              <a:t>FORWARD VIEW</a:t>
-            </a:r>
-            <a:endParaRPr lang="en-US" sz="1100" dirty="0"/>
-          </a:p>
-        </p:txBody>
-      </p:sp>
-      <p:sp>
-        <p:nvSpPr>
-          <p:cNvPr id="3" name="Text 1"/>
-          <p:cNvSpPr/>
-          <p:nvPr/>
-        </p:nvSpPr>
-        <p:spPr>
-          <a:xfrm>
-            <a:off x="548640" y="548640"/>
-            <a:ext cx="11064240" cy="502920"/>
-          </a:xfrm>
-          <a:prstGeom prst="rect">
-            <a:avLst/>
-          </a:prstGeom>
-          <a:noFill/>
-          <a:ln/>
-        </p:spPr>
-        <p:txBody>
-          <a:bodyPr wrap="square" lIns="0" tIns="0" rIns="0" bIns="0" rtlCol="0" anchor="ctr"/>
-          <a:lstStyle/>
-          <a:p>
-            <a:pPr indent="0" marL="0">
-              <a:buNone/>
-            </a:pPr>
-            <a:r>
-              <a:rPr lang="en-US" sz="2700" b="1" dirty="0">
-                <a:solidFill>
-                  <a:srgbClr val="0B0B0B"/>
-                </a:solidFill>
-                <a:latin typeface="Calibri" pitchFamily="34" charset="0"/>
-                <a:ea typeface="Calibri" pitchFamily="34" charset="-122"/>
-                <a:cs typeface="Calibri" pitchFamily="34" charset="-120"/>
-              </a:rPr>
-              <a:t>Cash &amp; the USC parent note — the early-warning gauge</a:t>
-            </a:r>
-            <a:endParaRPr lang="en-US" sz="2700" dirty="0"/>
-          </a:p>
-        </p:txBody>
-      </p:sp>
-      <p:pic>
-        <p:nvPicPr>
-          <p:cNvPr id="4" name="Image 0" descr="/home/user/CVR---Financial/reports/assets/note.png">    </p:cNvPr>
-          <p:cNvPicPr>
-            <a:picLocks noChangeAspect="1"/>
-          </p:cNvPicPr>
-          <p:nvPr/>
-        </p:nvPicPr>
-        <p:blipFill>
-          <a:blip r:embed="rId1"/>
-          <a:stretch>
-            <a:fillRect/>
-          </a:stretch>
-        </p:blipFill>
-        <p:spPr>
-          <a:xfrm>
-            <a:off x="548640" y="1828800"/>
-            <a:ext cx="7315200" cy="3589576"/>
-          </a:xfrm>
-          <a:prstGeom prst="rect">
-            <a:avLst/>
-          </a:prstGeom>
-        </p:spPr>
-      </p:pic>
-      <p:sp>
-        <p:nvSpPr>
-          <p:cNvPr id="5" name="Text 2"/>
-          <p:cNvSpPr/>
-          <p:nvPr/>
-        </p:nvSpPr>
-        <p:spPr>
-          <a:xfrm>
-            <a:off x="8686800" y="1554480"/>
-            <a:ext cx="2926080" cy="457200"/>
-          </a:xfrm>
-          <a:prstGeom prst="rect">
-            <a:avLst/>
-          </a:prstGeom>
-          <a:noFill/>
-          <a:ln/>
-        </p:spPr>
-        <p:txBody>
-          <a:bodyPr wrap="square" lIns="0" tIns="0" rIns="0" bIns="0" rtlCol="0" anchor="ctr"/>
-          <a:lstStyle/>
-          <a:p>
-            <a:pPr indent="0" marL="0">
-              <a:buNone/>
-            </a:pPr>
-            <a:r>
-              <a:rPr lang="en-US" sz="3000" b="1" dirty="0">
-                <a:solidFill>
-                  <a:srgbClr val="0B0B0B"/>
-                </a:solidFill>
-                <a:latin typeface="Calibri" pitchFamily="34" charset="0"/>
-                <a:ea typeface="Calibri" pitchFamily="34" charset="-122"/>
-                <a:cs typeface="Calibri" pitchFamily="34" charset="-120"/>
-              </a:rPr>
-              <a:t>$3.44M</a:t>
-            </a:r>
-            <a:endParaRPr lang="en-US" sz="3000" dirty="0"/>
-          </a:p>
-        </p:txBody>
-      </p:sp>
-      <p:sp>
-        <p:nvSpPr>
-          <p:cNvPr id="6" name="Text 3"/>
-          <p:cNvSpPr/>
-          <p:nvPr/>
-        </p:nvSpPr>
-        <p:spPr>
-          <a:xfrm>
-            <a:off x="8686800" y="2011680"/>
-            <a:ext cx="2926080" cy="868680"/>
-          </a:xfrm>
-          <a:prstGeom prst="rect">
-            <a:avLst/>
-          </a:prstGeom>
-          <a:noFill/>
-          <a:ln/>
-        </p:spPr>
-        <p:txBody>
-          <a:bodyPr wrap="square" lIns="0" tIns="0" rIns="0" bIns="0" rtlCol="0" anchor="ctr"/>
-          <a:lstStyle/>
-          <a:p>
-            <a:pPr indent="0" marL="0">
-              <a:buNone/>
-            </a:pPr>
-            <a:r>
-              <a:rPr lang="en-US" sz="1200" dirty="0">
-                <a:solidFill>
-                  <a:srgbClr val="52514E"/>
-                </a:solidFill>
-                <a:latin typeface="Calibri" pitchFamily="34" charset="0"/>
-                <a:ea typeface="Calibri" pitchFamily="34" charset="-122"/>
-                <a:cs typeface="Calibri" pitchFamily="34" charset="-120"/>
-              </a:rPr>
-              <a:t>note balance at 6/30/26 — CVR's entire funding runs through this account</a:t>
-            </a:r>
-            <a:endParaRPr lang="en-US" sz="1200" dirty="0"/>
-          </a:p>
-        </p:txBody>
-      </p:sp>
-      <p:sp>
-        <p:nvSpPr>
-          <p:cNvPr id="7" name="Text 4"/>
-          <p:cNvSpPr/>
-          <p:nvPr/>
-        </p:nvSpPr>
-        <p:spPr>
-          <a:xfrm>
-            <a:off x="8686800" y="2926080"/>
-            <a:ext cx="2926080" cy="457200"/>
-          </a:xfrm>
-          <a:prstGeom prst="rect">
-            <a:avLst/>
-          </a:prstGeom>
-          <a:noFill/>
-          <a:ln/>
-        </p:spPr>
-        <p:txBody>
-          <a:bodyPr wrap="square" lIns="0" tIns="0" rIns="0" bIns="0" rtlCol="0" anchor="ctr"/>
-          <a:lstStyle/>
-          <a:p>
-            <a:pPr indent="0" marL="0">
-              <a:buNone/>
-            </a:pPr>
-            <a:r>
-              <a:rPr lang="en-US" sz="3000" b="1" dirty="0">
-                <a:solidFill>
-                  <a:srgbClr val="E34948"/>
-                </a:solidFill>
-                <a:latin typeface="Calibri" pitchFamily="34" charset="0"/>
-                <a:ea typeface="Calibri" pitchFamily="34" charset="-122"/>
-                <a:cs typeface="Calibri" pitchFamily="34" charset="-120"/>
-              </a:rPr>
-              <a:t>$3.77M</a:t>
-            </a:r>
-            <a:endParaRPr lang="en-US" sz="3000" dirty="0"/>
-          </a:p>
-        </p:txBody>
-      </p:sp>
-      <p:sp>
-        <p:nvSpPr>
-          <p:cNvPr id="8" name="Text 5"/>
-          <p:cNvSpPr/>
-          <p:nvPr/>
-        </p:nvSpPr>
-        <p:spPr>
-          <a:xfrm>
-            <a:off x="8686800" y="3383280"/>
-            <a:ext cx="2926080" cy="868680"/>
-          </a:xfrm>
-          <a:prstGeom prst="rect">
-            <a:avLst/>
-          </a:prstGeom>
-          <a:noFill/>
-          <a:ln/>
-        </p:spPr>
-        <p:txBody>
-          <a:bodyPr wrap="square" lIns="0" tIns="0" rIns="0" bIns="0" rtlCol="0" anchor="ctr"/>
-          <a:lstStyle/>
-          <a:p>
-            <a:pPr indent="0" marL="0">
-              <a:buNone/>
-            </a:pPr>
-            <a:r>
-              <a:rPr lang="en-US" sz="1200" dirty="0">
-                <a:solidFill>
-                  <a:srgbClr val="52514E"/>
-                </a:solidFill>
-                <a:latin typeface="Calibri" pitchFamily="34" charset="0"/>
-                <a:ea typeface="Calibri" pitchFamily="34" charset="-122"/>
-                <a:cs typeface="Calibri" pitchFamily="34" charset="-120"/>
-              </a:rPr>
-              <a:t>Base-case peak in mid-2027 — the note keeps growing while the turnaround builds</a:t>
-            </a:r>
-            <a:endParaRPr lang="en-US" sz="1200" dirty="0"/>
-          </a:p>
-        </p:txBody>
-      </p:sp>
-      <p:sp>
-        <p:nvSpPr>
-          <p:cNvPr id="9" name="Text 6"/>
-          <p:cNvSpPr/>
-          <p:nvPr/>
-        </p:nvSpPr>
-        <p:spPr>
-          <a:xfrm>
-            <a:off x="8686800" y="4297680"/>
-            <a:ext cx="2926080" cy="457200"/>
-          </a:xfrm>
-          <a:prstGeom prst="rect">
-            <a:avLst/>
-          </a:prstGeom>
-          <a:noFill/>
-          <a:ln/>
-        </p:spPr>
-        <p:txBody>
-          <a:bodyPr wrap="square" lIns="0" tIns="0" rIns="0" bIns="0" rtlCol="0" anchor="ctr"/>
-          <a:lstStyle/>
-          <a:p>
-            <a:pPr indent="0" marL="0">
-              <a:buNone/>
-            </a:pPr>
-            <a:r>
-              <a:rPr lang="en-US" sz="3000" b="1" dirty="0">
-                <a:solidFill>
-                  <a:srgbClr val="E34948"/>
-                </a:solidFill>
-                <a:latin typeface="Calibri" pitchFamily="34" charset="0"/>
-                <a:ea typeface="Calibri" pitchFamily="34" charset="-122"/>
-                <a:cs typeface="Calibri" pitchFamily="34" charset="-120"/>
-              </a:rPr>
-              <a:t>+$231K</a:t>
-            </a:r>
-            <a:endParaRPr lang="en-US" sz="3000" dirty="0"/>
-          </a:p>
-        </p:txBody>
-      </p:sp>
-      <p:sp>
-        <p:nvSpPr>
-          <p:cNvPr id="10" name="Text 7"/>
-          <p:cNvSpPr/>
-          <p:nvPr/>
-        </p:nvSpPr>
-        <p:spPr>
-          <a:xfrm>
-            <a:off x="8686800" y="4754880"/>
-            <a:ext cx="2926080" cy="868680"/>
-          </a:xfrm>
-          <a:prstGeom prst="rect">
-            <a:avLst/>
-          </a:prstGeom>
-          <a:noFill/>
-          <a:ln/>
-        </p:spPr>
-        <p:txBody>
-          <a:bodyPr wrap="square" lIns="0" tIns="0" rIns="0" bIns="0" rtlCol="0" anchor="ctr"/>
-          <a:lstStyle/>
-          <a:p>
-            <a:pPr indent="0" marL="0">
-              <a:buNone/>
-            </a:pPr>
-            <a:r>
-              <a:rPr lang="en-US" sz="1200" dirty="0">
-                <a:solidFill>
-                  <a:srgbClr val="52514E"/>
-                </a:solidFill>
-                <a:latin typeface="Calibri" pitchFamily="34" charset="0"/>
-                <a:ea typeface="Calibri" pitchFamily="34" charset="-122"/>
-                <a:cs typeface="Calibri" pitchFamily="34" charset="-120"/>
-              </a:rPr>
-              <a:t>still drawing by end-2027 in the Base case; only the Upside path flattens and repays it</a:t>
-            </a:r>
-            <a:endParaRPr lang="en-US" sz="1200" dirty="0"/>
-          </a:p>
-        </p:txBody>
-      </p:sp>
-      <p:sp>
-        <p:nvSpPr>
-          <p:cNvPr id="11" name="Text 8"/>
-          <p:cNvSpPr/>
-          <p:nvPr/>
-        </p:nvSpPr>
-        <p:spPr>
-          <a:xfrm>
-            <a:off x="548640" y="6419088"/>
-            <a:ext cx="11064240" cy="320040"/>
-          </a:xfrm>
-          <a:prstGeom prst="rect">
-            <a:avLst/>
-          </a:prstGeom>
-          <a:noFill/>
-          <a:ln/>
-        </p:spPr>
-        <p:txBody>
-          <a:bodyPr wrap="square" lIns="0" tIns="0" rIns="0" bIns="0" rtlCol="0" anchor="ctr"/>
-          <a:lstStyle/>
-          <a:p>
-            <a:pPr indent="0" marL="0">
-              <a:buNone/>
-            </a:pPr>
-            <a:r>
-              <a:rPr lang="en-US" sz="950" dirty="0">
-                <a:solidFill>
-                  <a:srgbClr val="898781"/>
-                </a:solidFill>
-                <a:latin typeface="Calibri" pitchFamily="34" charset="0"/>
-                <a:ea typeface="Calibri" pitchFamily="34" charset="-122"/>
-                <a:cs typeface="Calibri" pitchFamily="34" charset="-120"/>
-              </a:rPr>
-              <a:t>CVR holds no cash: deficits draw the note, surpluses repay it (~$5K/mo interest accrues). Reconciled to finance's fully-loaded cost — a more conservative trajectory than the prior estimate.</a:t>
-            </a:r>
-            <a:endParaRPr lang="en-US" sz="950" dirty="0"/>
-          </a:p>
-        </p:txBody>
-      </p:sp>
-    </p:spTree>
-  </p:cSld>
-  <p:clrMapOvr>
-    <a:masterClrMapping/>
-  </p:clrMapOvr>
-</p:sld>
-</file>
-
 <file path=ppt/slides/slide2.xml><?xml version="1.0" encoding="utf-8"?>
 <p:sld xmlns:a="http://schemas.openxmlformats.org/drawingml/2006/main" xmlns:r="http://schemas.openxmlformats.org/officeDocument/2006/relationships" xmlns:p="http://schemas.openxmlformats.org/presentationml/2006/main">
   <p:cSld name="Slide 2">
@@ -23476,7 +24086,7 @@
                 <a:ea typeface="Calibri" pitchFamily="34" charset="-122"/>
                 <a:cs typeface="Calibri" pitchFamily="34" charset="-120"/>
               </a:rPr>
-              <a:t>One pursuit engine with HWC Estimating · the consolidated EPC offering · the addressable market · BD account ownership</a:t>
+              <a:t>One pursuit engine with HWC Estimating · the consolidated EPC offering · the addressable market · national expansion targets · BD account ownership</a:t>
             </a:r>
             <a:endParaRPr lang="en-US" sz="1200" dirty="0"/>
           </a:p>
@@ -23613,7 +24223,7 @@
                 <a:ea typeface="Calibri" pitchFamily="34" charset="-122"/>
                 <a:cs typeface="Calibri" pitchFamily="34" charset="-120"/>
               </a:rPr>
-              <a:t>Forecast &amp; coverage · FY2026 landing and FY2027 scenarios · cash &amp; the parent note</a:t>
+              <a:t>Forecast &amp; coverage · FY2026 landing and FY2027 scenarios · EPC accounting alignment</a:t>
             </a:r>
             <a:endParaRPr lang="en-US" sz="1200" dirty="0"/>
           </a:p>
@@ -24140,7 +24750,7 @@
                 <a:ea typeface="Calibri" pitchFamily="34" charset="-122"/>
                 <a:cs typeface="Calibri" pitchFamily="34" charset="-120"/>
               </a:rPr>
-              <a:t>$30.1K</a:t>
+              <a:t>Absorbed today</a:t>
             </a:r>
             <a:endParaRPr lang="en-US" sz="1700" dirty="0"/>
           </a:p>
@@ -24179,7 +24789,7 @@
                 <a:ea typeface="Calibri" pitchFamily="34" charset="-122"/>
                 <a:cs typeface="Calibri" pitchFamily="34" charset="-120"/>
               </a:rPr>
-              <a:t>of note interest charged to CVR in H1 — roughly a wash against bid engineering at cost</a:t>
+              <a:t>these hours land in CVR's overhead with no offsetting credit — immaterial now, but it compounds as EPC pursuit volume grows</a:t>
             </a:r>
             <a:endParaRPr lang="en-US" sz="1050" dirty="0"/>
           </a:p>
@@ -24727,7 +25337,7 @@
                 <a:ea typeface="Calibri" pitchFamily="34" charset="-122"/>
                 <a:cs typeface="Calibri" pitchFamily="34" charset="-120"/>
               </a:rPr>
-              <a:t>Interest credit against bid hours</a:t>
+              <a:t>Carve it out of the metrics</a:t>
             </a:r>
             <a:pPr indent="0" marL="0">
               <a:buNone/>
@@ -24769,7 +25379,7 @@
                 <a:ea typeface="Calibri" pitchFamily="34" charset="-122"/>
                 <a:cs typeface="Calibri" pitchFamily="34" charset="-120"/>
               </a:rPr>
-              <a:t>Parent credits note interest against documented bid-support hours. Fixes the cash, but leaves the hours non-billable — the metrics stay misaligned.</a:t>
+              <a:t>Track bid-support hours in a separate BD cost pool so CVR's utilization and realization aren't penalized for pursuit work — a reporting fix, not a cash fix.</a:t>
             </a:r>
             <a:endParaRPr lang="en-US" sz="1050" dirty="0"/>
           </a:p>
@@ -24849,7 +25459,7 @@
                 <a:ea typeface="Calibri" pitchFamily="34" charset="-122"/>
                 <a:cs typeface="Calibri" pitchFamily="34" charset="-120"/>
               </a:rPr>
-              <a:t>Dollars are roughly a wash today — but as EPC volume scales, the accounting should reward the pursuit behavior the strategy demands.</a:t>
+              <a:t>The dollars are small today — but as EPC volume scales, the accounting should reward the pursuit behavior the strategy demands.</a:t>
             </a:r>
             <a:endParaRPr lang="en-US" sz="1200" dirty="0"/>
           </a:p>
@@ -24888,7 +25498,7 @@
                 <a:ea typeface="Calibri" pitchFamily="34" charset="-122"/>
                 <a:cs typeface="Calibri" pitchFamily="34" charset="-120"/>
               </a:rPr>
-              <a:t>Bid hours per the KPI report (through 7/11/26); interest per the GL. Raise with the CFO alongside the note-terms discussion.</a:t>
+              <a:t>Bid hours per the KPI report (through 7/11/26). Raise with the CFO as an EPC accounting-alignment item.</a:t>
             </a:r>
             <a:endParaRPr lang="en-US" sz="950" dirty="0"/>
           </a:p>
@@ -25560,7 +26170,7 @@
                 <a:ea typeface="Calibri" pitchFamily="34" charset="-122"/>
                 <a:cs typeface="Calibri" pitchFamily="34" charset="-120"/>
               </a:rPr>
-              <a:t>July close goes into the actuals-vs-forecast cadence; note-balance trajectory is the early-warning gauge for USC reporting.</a:t>
+              <a:t>July close goes into the actuals-vs-forecast cadence; the monthly cash draw on USC is the early-warning gauge for reporting.</a:t>
             </a:r>
             <a:endParaRPr lang="en-US" sz="1200" dirty="0"/>
           </a:p>

</xml_diff>

<commit_message>
Wire in expansion-target logos and relationship notes
Rasterize the four target logos supplied by the client (AEP svg, PG&E webp,
Southern png, FirstEnergy png) into reports/assets/logos/ so the national
expansion slide shows official marks. Add CVR-internal relationship notes
per account (AEP, FirstEnergy, PG&E, Southern) in place of the placeholders
and refresh the slide footnote.
</commit_message>
<xml_diff>
--- a/reports/CVR_Deck_Jun2026.pptx
+++ b/reports/CVR_Deck_Jun2026.pptx
@@ -15531,55 +15531,39 @@
           </a:ln>
         </p:spPr>
       </p:sp>
-      <p:sp>
-        <p:nvSpPr>
-          <p:cNvPr id="5" name="Text 3"/>
-          <p:cNvSpPr/>
+      <p:pic>
+        <p:nvPicPr>
+          <p:cNvPr id="5" name="Image 0" descr="/home/user/CVR---Financial/reports/assets/logos/aep.png">    </p:cNvPr>
+          <p:cNvPicPr>
+            <a:picLocks noChangeAspect="1"/>
+          </p:cNvPicPr>
           <p:nvPr/>
-        </p:nvSpPr>
+        </p:nvPicPr>
+        <p:blipFill>
+          <a:blip r:embed="rId1"/>
+          <a:srcRect l="0" r="0" t="0" b="0"/>
+          <a:stretch/>
+        </p:blipFill>
         <p:spPr>
           <a:xfrm>
             <a:off x="768096" y="1536192"/>
-            <a:ext cx="3566160" cy="310896"/>
+            <a:ext cx="2103120" cy="502920"/>
           </a:xfrm>
           <a:prstGeom prst="rect">
             <a:avLst/>
           </a:prstGeom>
-          <a:noFill/>
-          <a:ln/>
         </p:spPr>
-        <p:txBody>
-          <a:bodyPr wrap="square" lIns="0" tIns="0" rIns="0" bIns="0" rtlCol="0" anchor="ctr"/>
-          <a:lstStyle/>
-          <a:p>
-            <a:pPr indent="0" marL="0">
-              <a:buNone/>
-            </a:pPr>
-            <a:r>
-              <a:rPr lang="en-US" sz="1700" b="1" dirty="0">
-                <a:solidFill>
-                  <a:srgbClr val="F58025"/>
-                </a:solidFill>
-                <a:latin typeface="Calibri" pitchFamily="34" charset="0"/>
-                <a:ea typeface="Calibri" pitchFamily="34" charset="-122"/>
-                <a:cs typeface="Calibri" pitchFamily="34" charset="-120"/>
-              </a:rPr>
-              <a:t>AEP</a:t>
-            </a:r>
-            <a:endParaRPr lang="en-US" sz="1700" dirty="0"/>
-          </a:p>
-        </p:txBody>
-      </p:sp>
-      <p:sp>
-        <p:nvSpPr>
-          <p:cNvPr id="6" name="Text 4"/>
+      </p:pic>
+      <p:sp>
+        <p:nvSpPr>
+          <p:cNvPr id="6" name="Text 3"/>
           <p:cNvSpPr/>
           <p:nvPr/>
         </p:nvSpPr>
         <p:spPr>
           <a:xfrm>
-            <a:off x="768096" y="1837944"/>
-            <a:ext cx="4206240" cy="237744"/>
+            <a:off x="3008376" y="1645920"/>
+            <a:ext cx="2377440" cy="274320"/>
           </a:xfrm>
           <a:prstGeom prst="rect">
             <a:avLst/>
@@ -15611,7 +15595,7 @@
       </p:sp>
       <p:sp>
         <p:nvSpPr>
-          <p:cNvPr id="7" name="Text 5"/>
+          <p:cNvPr id="7" name="Text 4"/>
           <p:cNvSpPr/>
           <p:nvPr/>
         </p:nvSpPr>
@@ -15664,7 +15648,7 @@
       </p:sp>
       <p:sp>
         <p:nvSpPr>
-          <p:cNvPr id="8" name="Text 6"/>
+          <p:cNvPr id="8" name="Text 5"/>
           <p:cNvSpPr/>
           <p:nvPr/>
         </p:nvSpPr>
@@ -15695,7 +15679,7 @@
                 <a:ea typeface="Calibri" pitchFamily="34" charset="-122"/>
                 <a:cs typeface="Calibri" pitchFamily="34" charset="-120"/>
               </a:rPr>
-              <a:t>Where we stand: — to be added</a:t>
+              <a:t>Where we stand: new leadership post-BHE takeover; strong Director/PM and procurement relationships (JimC + potential BD).</a:t>
             </a:r>
             <a:endParaRPr lang="en-US" sz="1000" dirty="0"/>
           </a:p>
@@ -15703,7 +15687,7 @@
       </p:sp>
       <p:sp>
         <p:nvSpPr>
-          <p:cNvPr id="9" name="Shape 7"/>
+          <p:cNvPr id="9" name="Shape 6"/>
           <p:cNvSpPr/>
           <p:nvPr/>
         </p:nvSpPr>
@@ -15728,55 +15712,39 @@
           </a:ln>
         </p:spPr>
       </p:sp>
-      <p:sp>
-        <p:nvSpPr>
-          <p:cNvPr id="10" name="Text 8"/>
-          <p:cNvSpPr/>
+      <p:pic>
+        <p:nvPicPr>
+          <p:cNvPr id="10" name="Image 1" descr="/home/user/CVR---Financial/reports/assets/logos/firstenergy.png">    </p:cNvPr>
+          <p:cNvPicPr>
+            <a:picLocks noChangeAspect="1"/>
+          </p:cNvPicPr>
           <p:nvPr/>
-        </p:nvSpPr>
+        </p:nvPicPr>
+        <p:blipFill>
+          <a:blip r:embed="rId2"/>
+          <a:srcRect l="0" r="0" t="0" b="0"/>
+          <a:stretch/>
+        </p:blipFill>
         <p:spPr>
           <a:xfrm>
             <a:off x="6510528" y="1536192"/>
-            <a:ext cx="3566160" cy="310896"/>
+            <a:ext cx="2103120" cy="502920"/>
           </a:xfrm>
           <a:prstGeom prst="rect">
             <a:avLst/>
           </a:prstGeom>
-          <a:noFill/>
-          <a:ln/>
         </p:spPr>
-        <p:txBody>
-          <a:bodyPr wrap="square" lIns="0" tIns="0" rIns="0" bIns="0" rtlCol="0" anchor="ctr"/>
-          <a:lstStyle/>
-          <a:p>
-            <a:pPr indent="0" marL="0">
-              <a:buNone/>
-            </a:pPr>
-            <a:r>
-              <a:rPr lang="en-US" sz="1700" b="1" dirty="0">
-                <a:solidFill>
-                  <a:srgbClr val="1C3F94"/>
-                </a:solidFill>
-                <a:latin typeface="Calibri" pitchFamily="34" charset="0"/>
-                <a:ea typeface="Calibri" pitchFamily="34" charset="-122"/>
-                <a:cs typeface="Calibri" pitchFamily="34" charset="-120"/>
-              </a:rPr>
-              <a:t>FirstEnergy</a:t>
-            </a:r>
-            <a:endParaRPr lang="en-US" sz="1700" dirty="0"/>
-          </a:p>
-        </p:txBody>
-      </p:sp>
-      <p:sp>
-        <p:nvSpPr>
-          <p:cNvPr id="11" name="Text 9"/>
+      </p:pic>
+      <p:sp>
+        <p:nvSpPr>
+          <p:cNvPr id="11" name="Text 7"/>
           <p:cNvSpPr/>
           <p:nvPr/>
         </p:nvSpPr>
         <p:spPr>
           <a:xfrm>
-            <a:off x="6510528" y="1837944"/>
-            <a:ext cx="4206240" cy="237744"/>
+            <a:off x="8750808" y="1645920"/>
+            <a:ext cx="2377440" cy="274320"/>
           </a:xfrm>
           <a:prstGeom prst="rect">
             <a:avLst/>
@@ -15808,7 +15776,7 @@
       </p:sp>
       <p:sp>
         <p:nvSpPr>
-          <p:cNvPr id="12" name="Text 10"/>
+          <p:cNvPr id="12" name="Text 8"/>
           <p:cNvSpPr/>
           <p:nvPr/>
         </p:nvSpPr>
@@ -15861,7 +15829,7 @@
       </p:sp>
       <p:sp>
         <p:nvSpPr>
-          <p:cNvPr id="13" name="Text 11"/>
+          <p:cNvPr id="13" name="Text 9"/>
           <p:cNvSpPr/>
           <p:nvPr/>
         </p:nvSpPr>
@@ -15892,7 +15860,7 @@
                 <a:ea typeface="Calibri" pitchFamily="34" charset="-122"/>
                 <a:cs typeface="Calibri" pitchFamily="34" charset="-120"/>
               </a:rPr>
-              <a:t>Where we stand: — to be added</a:t>
+              <a:t>Where we stand: key C-suite relationships to leverage — an open door to EPC.</a:t>
             </a:r>
             <a:endParaRPr lang="en-US" sz="1000" dirty="0"/>
           </a:p>
@@ -15900,7 +15868,7 @@
       </p:sp>
       <p:sp>
         <p:nvSpPr>
-          <p:cNvPr id="14" name="Shape 12"/>
+          <p:cNvPr id="14" name="Shape 10"/>
           <p:cNvSpPr/>
           <p:nvPr/>
         </p:nvSpPr>
@@ -15925,55 +15893,39 @@
           </a:ln>
         </p:spPr>
       </p:sp>
-      <p:sp>
-        <p:nvSpPr>
-          <p:cNvPr id="15" name="Text 13"/>
-          <p:cNvSpPr/>
+      <p:pic>
+        <p:nvPicPr>
+          <p:cNvPr id="15" name="Image 2" descr="/home/user/CVR---Financial/reports/assets/logos/pge.png">    </p:cNvPr>
+          <p:cNvPicPr>
+            <a:picLocks noChangeAspect="1"/>
+          </p:cNvPicPr>
           <p:nvPr/>
-        </p:nvSpPr>
+        </p:nvPicPr>
+        <p:blipFill>
+          <a:blip r:embed="rId3"/>
+          <a:srcRect l="0" r="0" t="0" b="0"/>
+          <a:stretch/>
+        </p:blipFill>
         <p:spPr>
           <a:xfrm>
             <a:off x="768096" y="3749040"/>
-            <a:ext cx="3566160" cy="310896"/>
+            <a:ext cx="2103120" cy="502920"/>
           </a:xfrm>
           <a:prstGeom prst="rect">
             <a:avLst/>
           </a:prstGeom>
-          <a:noFill/>
-          <a:ln/>
         </p:spPr>
-        <p:txBody>
-          <a:bodyPr wrap="square" lIns="0" tIns="0" rIns="0" bIns="0" rtlCol="0" anchor="ctr"/>
-          <a:lstStyle/>
-          <a:p>
-            <a:pPr indent="0" marL="0">
-              <a:buNone/>
-            </a:pPr>
-            <a:r>
-              <a:rPr lang="en-US" sz="1700" b="1" dirty="0">
-                <a:solidFill>
-                  <a:srgbClr val="0033A0"/>
-                </a:solidFill>
-                <a:latin typeface="Calibri" pitchFamily="34" charset="0"/>
-                <a:ea typeface="Calibri" pitchFamily="34" charset="-122"/>
-                <a:cs typeface="Calibri" pitchFamily="34" charset="-120"/>
-              </a:rPr>
-              <a:t>PG&amp;E</a:t>
-            </a:r>
-            <a:endParaRPr lang="en-US" sz="1700" dirty="0"/>
-          </a:p>
-        </p:txBody>
-      </p:sp>
-      <p:sp>
-        <p:nvSpPr>
-          <p:cNvPr id="16" name="Text 14"/>
+      </p:pic>
+      <p:sp>
+        <p:nvSpPr>
+          <p:cNvPr id="16" name="Text 11"/>
           <p:cNvSpPr/>
           <p:nvPr/>
         </p:nvSpPr>
         <p:spPr>
           <a:xfrm>
-            <a:off x="768096" y="4050792"/>
-            <a:ext cx="4206240" cy="237744"/>
+            <a:off x="3008376" y="3858768"/>
+            <a:ext cx="2377440" cy="274320"/>
           </a:xfrm>
           <a:prstGeom prst="rect">
             <a:avLst/>
@@ -16005,7 +15957,7 @@
       </p:sp>
       <p:sp>
         <p:nvSpPr>
-          <p:cNvPr id="17" name="Text 15"/>
+          <p:cNvPr id="17" name="Text 12"/>
           <p:cNvSpPr/>
           <p:nvPr/>
         </p:nvSpPr>
@@ -16058,7 +16010,7 @@
       </p:sp>
       <p:sp>
         <p:nvSpPr>
-          <p:cNvPr id="18" name="Text 16"/>
+          <p:cNvPr id="18" name="Text 13"/>
           <p:cNvSpPr/>
           <p:nvPr/>
         </p:nvSpPr>
@@ -16089,7 +16041,7 @@
                 <a:ea typeface="Calibri" pitchFamily="34" charset="-122"/>
                 <a:cs typeface="Calibri" pitchFamily="34" charset="-120"/>
               </a:rPr>
-              <a:t>Where we stand: — to be added</a:t>
+              <a:t>Where we stand: BD-led — a potential long-term EPC relationship to build.</a:t>
             </a:r>
             <a:endParaRPr lang="en-US" sz="1000" dirty="0"/>
           </a:p>
@@ -16097,7 +16049,7 @@
       </p:sp>
       <p:sp>
         <p:nvSpPr>
-          <p:cNvPr id="19" name="Shape 17"/>
+          <p:cNvPr id="19" name="Shape 14"/>
           <p:cNvSpPr/>
           <p:nvPr/>
         </p:nvSpPr>
@@ -16122,55 +16074,39 @@
           </a:ln>
         </p:spPr>
       </p:sp>
-      <p:sp>
-        <p:nvSpPr>
-          <p:cNvPr id="20" name="Text 18"/>
-          <p:cNvSpPr/>
+      <p:pic>
+        <p:nvPicPr>
+          <p:cNvPr id="20" name="Image 3" descr="/home/user/CVR---Financial/reports/assets/logos/southern.png">    </p:cNvPr>
+          <p:cNvPicPr>
+            <a:picLocks noChangeAspect="1"/>
+          </p:cNvPicPr>
           <p:nvPr/>
-        </p:nvSpPr>
+        </p:nvPicPr>
+        <p:blipFill>
+          <a:blip r:embed="rId4"/>
+          <a:srcRect l="0" r="0" t="0" b="0"/>
+          <a:stretch/>
+        </p:blipFill>
         <p:spPr>
           <a:xfrm>
             <a:off x="6510528" y="3749040"/>
-            <a:ext cx="3566160" cy="310896"/>
+            <a:ext cx="2103120" cy="502920"/>
           </a:xfrm>
           <a:prstGeom prst="rect">
             <a:avLst/>
           </a:prstGeom>
-          <a:noFill/>
-          <a:ln/>
         </p:spPr>
-        <p:txBody>
-          <a:bodyPr wrap="square" lIns="0" tIns="0" rIns="0" bIns="0" rtlCol="0" anchor="ctr"/>
-          <a:lstStyle/>
-          <a:p>
-            <a:pPr indent="0" marL="0">
-              <a:buNone/>
-            </a:pPr>
-            <a:r>
-              <a:rPr lang="en-US" sz="1700" b="1" dirty="0">
-                <a:solidFill>
-                  <a:srgbClr val="00539B"/>
-                </a:solidFill>
-                <a:latin typeface="Calibri" pitchFamily="34" charset="0"/>
-                <a:ea typeface="Calibri" pitchFamily="34" charset="-122"/>
-                <a:cs typeface="Calibri" pitchFamily="34" charset="-120"/>
-              </a:rPr>
-              <a:t>Southern Company</a:t>
-            </a:r>
-            <a:endParaRPr lang="en-US" sz="1700" dirty="0"/>
-          </a:p>
-        </p:txBody>
-      </p:sp>
-      <p:sp>
-        <p:nvSpPr>
-          <p:cNvPr id="21" name="Text 19"/>
+      </p:pic>
+      <p:sp>
+        <p:nvSpPr>
+          <p:cNvPr id="21" name="Text 15"/>
           <p:cNvSpPr/>
           <p:nvPr/>
         </p:nvSpPr>
         <p:spPr>
           <a:xfrm>
-            <a:off x="6510528" y="4050792"/>
-            <a:ext cx="4206240" cy="237744"/>
+            <a:off x="8750808" y="3858768"/>
+            <a:ext cx="2377440" cy="274320"/>
           </a:xfrm>
           <a:prstGeom prst="rect">
             <a:avLst/>
@@ -16202,7 +16138,7 @@
       </p:sp>
       <p:sp>
         <p:nvSpPr>
-          <p:cNvPr id="22" name="Text 20"/>
+          <p:cNvPr id="22" name="Text 16"/>
           <p:cNvSpPr/>
           <p:nvPr/>
         </p:nvSpPr>
@@ -16255,7 +16191,7 @@
       </p:sp>
       <p:sp>
         <p:nvSpPr>
-          <p:cNvPr id="23" name="Text 21"/>
+          <p:cNvPr id="23" name="Text 17"/>
           <p:cNvSpPr/>
           <p:nvPr/>
         </p:nvSpPr>
@@ -16286,7 +16222,7 @@
                 <a:ea typeface="Calibri" pitchFamily="34" charset="-122"/>
                 <a:cs typeface="Calibri" pitchFamily="34" charset="-120"/>
               </a:rPr>
-              <a:t>Where we stand: — to be added</a:t>
+              <a:t>Where we stand: relationally weaker, but a major EPC distribution program at Georgia Power.</a:t>
             </a:r>
             <a:endParaRPr lang="en-US" sz="1000" dirty="0"/>
           </a:p>
@@ -16294,7 +16230,7 @@
       </p:sp>
       <p:sp>
         <p:nvSpPr>
-          <p:cNvPr id="24" name="Shape 22"/>
+          <p:cNvPr id="24" name="Shape 18"/>
           <p:cNvSpPr/>
           <p:nvPr/>
         </p:nvSpPr>
@@ -16321,7 +16257,7 @@
       </p:sp>
       <p:sp>
         <p:nvSpPr>
-          <p:cNvPr id="25" name="Text 23"/>
+          <p:cNvPr id="25" name="Text 19"/>
           <p:cNvSpPr/>
           <p:nvPr/>
         </p:nvSpPr>
@@ -16374,7 +16310,7 @@
       </p:sp>
       <p:sp>
         <p:nvSpPr>
-          <p:cNvPr id="26" name="Text 24"/>
+          <p:cNvPr id="26" name="Text 20"/>
           <p:cNvSpPr/>
           <p:nvPr/>
         </p:nvSpPr>
@@ -16405,7 +16341,7 @@
                 <a:ea typeface="Calibri" pitchFamily="34" charset="-122"/>
                 <a:cs typeface="Calibri" pitchFamily="34" charset="-120"/>
               </a:rPr>
-              <a:t>Public sources: latest company capital-plan disclosures (Q1 2025–Q1 2026 earnings / SEC filings); plan windows vary (2025–29 to 2026–30) — confirm current guidance. Relationship notes to follow. Drop official logos into reports/assets/logos/ (aep.png, firstenergy.png, pge.png, southern.png) to swap the wordmarks.</a:t>
+              <a:t>Public sources: latest company capital-plan disclosures (Q1 2025–Q1 2026 earnings / SEC filings); plan windows vary (2025–29 to 2026–30) — confirm current guidance. Relationship notes are CVR-internal account intel. Logos are the property of their respective owners.</a:t>
             </a:r>
             <a:endParaRPr lang="en-US" sz="950" dirty="0"/>
           </a:p>

</xml_diff>

<commit_message>
Add US footprint map slide with logos on service territories
New build_footprint_map.py renders a d3-geo/us-atlas US map: current-client
states tinted blue (MI, IA, IN, TX), expansion-target states amber, and each
utility logo placed on its territory with anchor dots/leaders. Insert the
rendered map as a new slide after the national expansion-target slide.
</commit_message>
<xml_diff>
--- a/reports/CVR_Deck_Jun2026.pptx
+++ b/reports/CVR_Deck_Jun2026.pptx
@@ -26,9 +26,10 @@
     <p:sldId id="274" r:id="rId20"/>
     <p:sldId id="275" r:id="rId21"/>
     <p:sldId id="276" r:id="rId22"/>
+    <p:sldId id="277" r:id="rId23"/>
   </p:sldIdLst>
   <p:notesMasterIdLst>
-    <p:notesMasterId r:id="rId23"/>
+    <p:notesMasterId r:id="rId24"/>
   </p:notesMasterIdLst>
   <p:sldSz cx="12192000" cy="6858000"/>
   <p:notesSz cx="6858000" cy="12192000"/>
@@ -1690,6 +1691,94 @@
             <a:fld id="{F7021451-1387-4CA6-816F-3879F97B5CBC}" type="slidenum">
               <a:rPr lang="en-US"/>
               <a:t>21</a:t>
+            </a:fld>
+            <a:endParaRPr lang="en-US"/>
+          </a:p>
+        </p:txBody>
+      </p:sp>
+    </p:spTree>
+    <p:extLst>
+      <p:ext uri="{BB962C8B-B14F-4D97-AF65-F5344CB8AC3E}">
+        <p14:creationId xmlns:p14="http://schemas.microsoft.com/office/powerpoint/2010/main" val="1024086991"/>
+      </p:ext>
+    </p:extLst>
+  </p:cSld>
+  <p:clrMapOvr>
+    <a:masterClrMapping/>
+  </p:clrMapOvr>
+</p:notes>
+</file>
+
+<file path=ppt/notesSlides/notesSlide22.xml><?xml version="1.0" encoding="utf-8"?>
+<p:notes xmlns:a="http://schemas.openxmlformats.org/drawingml/2006/main" xmlns:r="http://schemas.openxmlformats.org/officeDocument/2006/relationships" xmlns:p="http://schemas.openxmlformats.org/presentationml/2006/main">
+  <p:cSld>
+    <p:spTree>
+      <p:nvGrpSpPr>
+        <p:cNvPr id="1" name=""/>
+        <p:cNvGrpSpPr/>
+        <p:nvPr/>
+      </p:nvGrpSpPr>
+      <p:grpSpPr>
+        <a:xfrm>
+          <a:off x="0" y="0"/>
+          <a:ext cx="0" cy="0"/>
+          <a:chOff x="0" y="0"/>
+          <a:chExt cx="0" cy="0"/>
+        </a:xfrm>
+      </p:grpSpPr>
+      <p:sp>
+        <p:nvSpPr>
+          <p:cNvPr id="2" name="Slide Image Placeholder 1"/>
+          <p:cNvSpPr>
+            <a:spLocks noGrp="1" noRot="1" noChangeAspect="1"/>
+          </p:cNvSpPr>
+          <p:nvPr>
+            <p:ph type="sldImg"/>
+          </p:nvPr>
+        </p:nvSpPr>
+        <p:spPr/>
+      </p:sp>
+      <p:sp>
+        <p:nvSpPr>
+          <p:cNvPr id="3" name="Notes Placeholder 2"/>
+          <p:cNvSpPr>
+            <a:spLocks noGrp="1"/>
+          </p:cNvSpPr>
+          <p:nvPr>
+            <p:ph type="body" idx="1"/>
+          </p:nvPr>
+        </p:nvSpPr>
+        <p:spPr/>
+        <p:txBody>
+          <a:bodyPr/>
+          <a:lstStyle/>
+          <a:p>
+            <a:r>
+              <a:rPr lang="en-US" dirty="0"/>
+              <a:t/>
+            </a:r>
+            <a:endParaRPr lang="en-US" dirty="0"/>
+          </a:p>
+        </p:txBody>
+      </p:sp>
+      <p:sp>
+        <p:nvSpPr>
+          <p:cNvPr id="4" name="Slide Number Placeholder 3"/>
+          <p:cNvSpPr>
+            <a:spLocks noGrp="1"/>
+          </p:cNvSpPr>
+          <p:nvPr>
+            <p:ph type="sldNum" sz="quarter" idx="10"/>
+          </p:nvPr>
+        </p:nvSpPr>
+        <p:spPr/>
+        <p:txBody>
+          <a:bodyPr/>
+          <a:lstStyle/>
+          <a:p>
+            <a:fld id="{F7021451-1387-4CA6-816F-3879F97B5CBC}" type="slidenum">
+              <a:rPr lang="en-US"/>
+              <a:t>22</a:t>
             </a:fld>
             <a:endParaRPr lang="en-US"/>
           </a:p>
@@ -16419,6 +16508,186 @@
                 <a:ea typeface="Calibri" pitchFamily="34" charset="-122"/>
                 <a:cs typeface="Calibri" pitchFamily="34" charset="-120"/>
               </a:rPr>
+              <a:t>STRATEGY — WHERE WE PLAY AND WHERE WE'RE GOING</a:t>
+            </a:r>
+            <a:endParaRPr lang="en-US" sz="1100" dirty="0"/>
+          </a:p>
+        </p:txBody>
+      </p:sp>
+      <p:sp>
+        <p:nvSpPr>
+          <p:cNvPr id="3" name="Text 1"/>
+          <p:cNvSpPr/>
+          <p:nvPr/>
+        </p:nvSpPr>
+        <p:spPr>
+          <a:xfrm>
+            <a:off x="548640" y="548640"/>
+            <a:ext cx="11064240" cy="502920"/>
+          </a:xfrm>
+          <a:prstGeom prst="rect">
+            <a:avLst/>
+          </a:prstGeom>
+          <a:noFill/>
+          <a:ln/>
+        </p:spPr>
+        <p:txBody>
+          <a:bodyPr wrap="square" lIns="0" tIns="0" rIns="0" bIns="0" rtlCol="0" anchor="ctr"/>
+          <a:lstStyle/>
+          <a:p>
+            <a:pPr indent="0" marL="0">
+              <a:buNone/>
+            </a:pPr>
+            <a:r>
+              <a:rPr lang="en-US" sz="2700" b="1" dirty="0">
+                <a:solidFill>
+                  <a:srgbClr val="0B0B0B"/>
+                </a:solidFill>
+                <a:latin typeface="Calibri" pitchFamily="34" charset="0"/>
+                <a:ea typeface="Calibri" pitchFamily="34" charset="-122"/>
+                <a:cs typeface="Calibri" pitchFamily="34" charset="-120"/>
+              </a:rPr>
+              <a:t>CVR's EPC footprint and the national target map</a:t>
+            </a:r>
+            <a:endParaRPr lang="en-US" sz="2700" dirty="0"/>
+          </a:p>
+        </p:txBody>
+      </p:sp>
+      <p:pic>
+        <p:nvPicPr>
+          <p:cNvPr id="4" name="Image 0" descr="/home/user/CVR---Financial/reports/assets/footprint_map.png">    </p:cNvPr>
+          <p:cNvPicPr>
+            <a:picLocks noChangeAspect="1"/>
+          </p:cNvPicPr>
+          <p:nvPr/>
+        </p:nvPicPr>
+        <p:blipFill>
+          <a:blip r:embed="rId1"/>
+          <a:stretch>
+            <a:fillRect/>
+          </a:stretch>
+        </p:blipFill>
+        <p:spPr>
+          <a:xfrm>
+            <a:off x="1325880" y="1353312"/>
+            <a:ext cx="9509760" cy="5034579"/>
+          </a:xfrm>
+          <a:prstGeom prst="rect">
+            <a:avLst/>
+          </a:prstGeom>
+        </p:spPr>
+      </p:pic>
+      <p:sp>
+        <p:nvSpPr>
+          <p:cNvPr id="5" name="Text 2"/>
+          <p:cNvSpPr/>
+          <p:nvPr/>
+        </p:nvSpPr>
+        <p:spPr>
+          <a:xfrm>
+            <a:off x="548640" y="6419088"/>
+            <a:ext cx="11064240" cy="320040"/>
+          </a:xfrm>
+          <a:prstGeom prst="rect">
+            <a:avLst/>
+          </a:prstGeom>
+          <a:noFill/>
+          <a:ln/>
+        </p:spPr>
+        <p:txBody>
+          <a:bodyPr wrap="square" lIns="0" tIns="0" rIns="0" bIns="0" rtlCol="0" anchor="ctr"/>
+          <a:lstStyle/>
+          <a:p>
+            <a:pPr indent="0" marL="0">
+              <a:buNone/>
+            </a:pPr>
+            <a:r>
+              <a:rPr lang="en-US" sz="950" dirty="0">
+                <a:solidFill>
+                  <a:srgbClr val="898781"/>
+                </a:solidFill>
+                <a:latin typeface="Calibri" pitchFamily="34" charset="0"/>
+                <a:ea typeface="Calibri" pitchFamily="34" charset="-122"/>
+                <a:cs typeface="Calibri" pitchFamily="34" charset="-120"/>
+              </a:rPr>
+              <a:t>Blue = states with a current CVR client; amber = expansion-target service territories. State shading illustrates each utility's footprint, not CVR's contracted scope.</a:t>
+            </a:r>
+            <a:endParaRPr lang="en-US" sz="950" dirty="0"/>
+          </a:p>
+        </p:txBody>
+      </p:sp>
+    </p:spTree>
+  </p:cSld>
+  <p:clrMapOvr>
+    <a:masterClrMapping/>
+  </p:clrMapOvr>
+</p:sld>
+</file>
+
+<file path=ppt/slides/slide18.xml><?xml version="1.0" encoding="utf-8"?>
+<p:sld xmlns:a="http://schemas.openxmlformats.org/drawingml/2006/main" xmlns:r="http://schemas.openxmlformats.org/officeDocument/2006/relationships" xmlns:p="http://schemas.openxmlformats.org/presentationml/2006/main">
+  <p:cSld name="Slide 18">
+    <p:spTree>
+      <p:nvGrpSpPr>
+        <p:cNvPr id="1" name=""/>
+        <p:cNvGrpSpPr/>
+        <p:nvPr/>
+      </p:nvGrpSpPr>
+      <p:grpSpPr>
+        <a:xfrm>
+          <a:off x="0" y="0"/>
+          <a:ext cx="0" cy="0"/>
+          <a:chOff x="0" y="0"/>
+          <a:chExt cx="0" cy="0"/>
+        </a:xfrm>
+      </p:grpSpPr>
+      <p:sp>
+        <p:nvSpPr>
+          <p:cNvPr id="2" name="Text 0"/>
+          <p:cNvSpPr/>
+          <p:nvPr/>
+        </p:nvSpPr>
+        <p:spPr>
+          <a:xfrm>
+            <a:off x="548640" y="292608"/>
+            <a:ext cx="11064240" cy="274320"/>
+          </a:xfrm>
+          <a:prstGeom prst="rect">
+            <a:avLst/>
+          </a:prstGeom>
+          <a:noFill/>
+          <a:ln/>
+        </p:spPr>
+        <p:txBody>
+          <a:bodyPr wrap="square" lIns="0" tIns="0" rIns="0" bIns="0" rtlCol="0" anchor="ctr"/>
+          <a:lstStyle/>
+          <a:p>
+            <a:pPr indent="0" marL="0">
+              <a:buNone/>
+            </a:pPr>
+            <a:r>
+              <a:rPr lang="en-US" sz="1100" b="1" dirty="0">
+                <a:solidFill>
+                  <a:srgbClr val="86B332"/>
+                </a:solidFill>
+                <a:latin typeface="Calibri" pitchFamily="34" charset="0"/>
+                <a:ea typeface="Calibri" pitchFamily="34" charset="-122"/>
+                <a:cs typeface="Calibri" pitchFamily="34" charset="-120"/>
+              </a:rPr>
+              <a:t>— </a:t>
+            </a:r>
+            <a:pPr indent="0" marL="0">
+              <a:buNone/>
+            </a:pPr>
+            <a:r>
+              <a:rPr lang="en-US" sz="1100" b="1" spc="200" kern="0" dirty="0">
+                <a:solidFill>
+                  <a:srgbClr val="52514E"/>
+                </a:solidFill>
+                <a:latin typeface="Calibri" pitchFamily="34" charset="0"/>
+                <a:ea typeface="Calibri" pitchFamily="34" charset="-122"/>
+                <a:cs typeface="Calibri" pitchFamily="34" charset="-120"/>
+              </a:rPr>
               <a:t>STRATEGY — BUSINESS DEVELOPMENT</a:t>
             </a:r>
             <a:endParaRPr lang="en-US" sz="1100" dirty="0"/>
@@ -16466,7 +16735,7 @@
       </p:sp>
       <p:graphicFrame>
         <p:nvGraphicFramePr>
-          <p:cNvPr id="18" name="Table 0"/>
+          <p:cNvPr id="19" name="Table 0"/>
           <p:cNvGraphicFramePr>
             <a:graphicFrameLocks noGrp="1"/>
           </p:cNvGraphicFramePr>
@@ -18630,9 +18899,9 @@
 </p:sld>
 </file>
 
-<file path=ppt/slides/slide18.xml><?xml version="1.0" encoding="utf-8"?>
+<file path=ppt/slides/slide19.xml><?xml version="1.0" encoding="utf-8"?>
 <p:sld xmlns:a="http://schemas.openxmlformats.org/drawingml/2006/main" xmlns:r="http://schemas.openxmlformats.org/officeDocument/2006/relationships" xmlns:p="http://schemas.openxmlformats.org/presentationml/2006/main">
-  <p:cSld name="Slide 18">
+  <p:cSld name="Slide 19">
     <p:spTree>
       <p:nvGrpSpPr>
         <p:cNvPr id="1" name=""/>
@@ -19044,9 +19313,987 @@
 </p:sld>
 </file>
 
-<file path=ppt/slides/slide19.xml><?xml version="1.0" encoding="utf-8"?>
+<file path=ppt/slides/slide2.xml><?xml version="1.0" encoding="utf-8"?>
 <p:sld xmlns:a="http://schemas.openxmlformats.org/drawingml/2006/main" xmlns:r="http://schemas.openxmlformats.org/officeDocument/2006/relationships" xmlns:p="http://schemas.openxmlformats.org/presentationml/2006/main">
-  <p:cSld name="Slide 19">
+  <p:cSld name="Slide 2">
+    <p:spTree>
+      <p:nvGrpSpPr>
+        <p:cNvPr id="1" name=""/>
+        <p:cNvGrpSpPr/>
+        <p:nvPr/>
+      </p:nvGrpSpPr>
+      <p:grpSpPr>
+        <a:xfrm>
+          <a:off x="0" y="0"/>
+          <a:ext cx="0" cy="0"/>
+          <a:chOff x="0" y="0"/>
+          <a:chExt cx="0" cy="0"/>
+        </a:xfrm>
+      </p:grpSpPr>
+      <p:sp>
+        <p:nvSpPr>
+          <p:cNvPr id="2" name="Text 0"/>
+          <p:cNvSpPr/>
+          <p:nvPr/>
+        </p:nvSpPr>
+        <p:spPr>
+          <a:xfrm>
+            <a:off x="548640" y="292608"/>
+            <a:ext cx="11064240" cy="274320"/>
+          </a:xfrm>
+          <a:prstGeom prst="rect">
+            <a:avLst/>
+          </a:prstGeom>
+          <a:noFill/>
+          <a:ln/>
+        </p:spPr>
+        <p:txBody>
+          <a:bodyPr wrap="square" lIns="0" tIns="0" rIns="0" bIns="0" rtlCol="0" anchor="ctr"/>
+          <a:lstStyle/>
+          <a:p>
+            <a:pPr indent="0" marL="0">
+              <a:buNone/>
+            </a:pPr>
+            <a:r>
+              <a:rPr lang="en-US" sz="1100" b="1" dirty="0">
+                <a:solidFill>
+                  <a:srgbClr val="86B332"/>
+                </a:solidFill>
+                <a:latin typeface="Calibri" pitchFamily="34" charset="0"/>
+                <a:ea typeface="Calibri" pitchFamily="34" charset="-122"/>
+                <a:cs typeface="Calibri" pitchFamily="34" charset="-120"/>
+              </a:rPr>
+              <a:t>— </a:t>
+            </a:r>
+            <a:pPr indent="0" marL="0">
+              <a:buNone/>
+            </a:pPr>
+            <a:r>
+              <a:rPr lang="en-US" sz="1100" b="1" spc="200" kern="0" dirty="0">
+                <a:solidFill>
+                  <a:srgbClr val="52514E"/>
+                </a:solidFill>
+                <a:latin typeface="Calibri" pitchFamily="34" charset="0"/>
+                <a:ea typeface="Calibri" pitchFamily="34" charset="-122"/>
+                <a:cs typeface="Calibri" pitchFamily="34" charset="-120"/>
+              </a:rPr>
+              <a:t>AGENDA</a:t>
+            </a:r>
+            <a:endParaRPr lang="en-US" sz="1100" dirty="0"/>
+          </a:p>
+        </p:txBody>
+      </p:sp>
+      <p:sp>
+        <p:nvSpPr>
+          <p:cNvPr id="3" name="Text 1"/>
+          <p:cNvSpPr/>
+          <p:nvPr/>
+        </p:nvSpPr>
+        <p:spPr>
+          <a:xfrm>
+            <a:off x="548640" y="548640"/>
+            <a:ext cx="11064240" cy="502920"/>
+          </a:xfrm>
+          <a:prstGeom prst="rect">
+            <a:avLst/>
+          </a:prstGeom>
+          <a:noFill/>
+          <a:ln/>
+        </p:spPr>
+        <p:txBody>
+          <a:bodyPr wrap="square" lIns="0" tIns="0" rIns="0" bIns="0" rtlCol="0" anchor="ctr"/>
+          <a:lstStyle/>
+          <a:p>
+            <a:pPr indent="0" marL="0">
+              <a:buNone/>
+            </a:pPr>
+            <a:r>
+              <a:rPr lang="en-US" sz="2700" b="1" dirty="0">
+                <a:solidFill>
+                  <a:srgbClr val="0B0B0B"/>
+                </a:solidFill>
+                <a:latin typeface="Calibri" pitchFamily="34" charset="0"/>
+                <a:ea typeface="Calibri" pitchFamily="34" charset="-122"/>
+                <a:cs typeface="Calibri" pitchFamily="34" charset="-120"/>
+              </a:rPr>
+              <a:t>What we'll cover</a:t>
+            </a:r>
+            <a:endParaRPr lang="en-US" sz="2700" dirty="0"/>
+          </a:p>
+        </p:txBody>
+      </p:sp>
+      <p:sp>
+        <p:nvSpPr>
+          <p:cNvPr id="4" name="Shape 2"/>
+          <p:cNvSpPr/>
+          <p:nvPr/>
+        </p:nvSpPr>
+        <p:spPr>
+          <a:xfrm>
+            <a:off x="548640" y="1481328"/>
+            <a:ext cx="402336" cy="402336"/>
+          </a:xfrm>
+          <a:prstGeom prst="ellipse">
+            <a:avLst/>
+          </a:prstGeom>
+          <a:solidFill>
+            <a:srgbClr val="2A78D6"/>
+          </a:solidFill>
+          <a:ln/>
+        </p:spPr>
+      </p:sp>
+      <p:sp>
+        <p:nvSpPr>
+          <p:cNvPr id="5" name="Text 3"/>
+          <p:cNvSpPr/>
+          <p:nvPr/>
+        </p:nvSpPr>
+        <p:spPr>
+          <a:xfrm>
+            <a:off x="548640" y="1481328"/>
+            <a:ext cx="402336" cy="402336"/>
+          </a:xfrm>
+          <a:prstGeom prst="rect">
+            <a:avLst/>
+          </a:prstGeom>
+          <a:noFill/>
+          <a:ln/>
+        </p:spPr>
+        <p:txBody>
+          <a:bodyPr wrap="square" lIns="0" tIns="0" rIns="0" bIns="0" rtlCol="0" anchor="ctr"/>
+          <a:lstStyle/>
+          <a:p>
+            <a:pPr algn="ctr" indent="0" marL="0">
+              <a:buNone/>
+            </a:pPr>
+            <a:r>
+              <a:rPr lang="en-US" sz="1500" b="1" dirty="0">
+                <a:solidFill>
+                  <a:srgbClr val="FFFFFF"/>
+                </a:solidFill>
+                <a:latin typeface="Calibri" pitchFamily="34" charset="0"/>
+                <a:ea typeface="Calibri" pitchFamily="34" charset="-122"/>
+                <a:cs typeface="Calibri" pitchFamily="34" charset="-120"/>
+              </a:rPr>
+              <a:t>1</a:t>
+            </a:r>
+            <a:endParaRPr lang="en-US" sz="1500" dirty="0"/>
+          </a:p>
+        </p:txBody>
+      </p:sp>
+      <p:sp>
+        <p:nvSpPr>
+          <p:cNvPr id="6" name="Text 4"/>
+          <p:cNvSpPr/>
+          <p:nvPr/>
+        </p:nvSpPr>
+        <p:spPr>
+          <a:xfrm>
+            <a:off x="1188720" y="1463040"/>
+            <a:ext cx="3383280" cy="411480"/>
+          </a:xfrm>
+          <a:prstGeom prst="rect">
+            <a:avLst/>
+          </a:prstGeom>
+          <a:noFill/>
+          <a:ln/>
+        </p:spPr>
+        <p:txBody>
+          <a:bodyPr wrap="square" lIns="0" tIns="0" rIns="0" bIns="0" rtlCol="0" anchor="ctr"/>
+          <a:lstStyle/>
+          <a:p>
+            <a:pPr indent="0" marL="0">
+              <a:buNone/>
+            </a:pPr>
+            <a:r>
+              <a:rPr lang="en-US" sz="1650" b="1" dirty="0">
+                <a:solidFill>
+                  <a:srgbClr val="0B0B0B"/>
+                </a:solidFill>
+                <a:latin typeface="Calibri" pitchFamily="34" charset="0"/>
+                <a:ea typeface="Calibri" pitchFamily="34" charset="-122"/>
+                <a:cs typeface="Calibri" pitchFamily="34" charset="-120"/>
+              </a:rPr>
+              <a:t>Where we stand</a:t>
+            </a:r>
+            <a:endParaRPr lang="en-US" sz="1650" dirty="0"/>
+          </a:p>
+        </p:txBody>
+      </p:sp>
+      <p:sp>
+        <p:nvSpPr>
+          <p:cNvPr id="7" name="Text 5"/>
+          <p:cNvSpPr/>
+          <p:nvPr/>
+        </p:nvSpPr>
+        <p:spPr>
+          <a:xfrm>
+            <a:off x="4754880" y="1463040"/>
+            <a:ext cx="6858000" cy="411480"/>
+          </a:xfrm>
+          <a:prstGeom prst="rect">
+            <a:avLst/>
+          </a:prstGeom>
+          <a:noFill/>
+          <a:ln/>
+        </p:spPr>
+        <p:txBody>
+          <a:bodyPr wrap="square" lIns="0" tIns="0" rIns="0" bIns="0" rtlCol="0" anchor="ctr"/>
+          <a:lstStyle/>
+          <a:p>
+            <a:pPr indent="0" marL="0">
+              <a:buNone/>
+            </a:pPr>
+            <a:r>
+              <a:rPr lang="en-US" sz="1200" dirty="0">
+                <a:solidFill>
+                  <a:srgbClr val="52514E"/>
+                </a:solidFill>
+                <a:latin typeface="Calibri" pitchFamily="34" charset="0"/>
+                <a:ea typeface="Calibri" pitchFamily="34" charset="-122"/>
+                <a:cs typeface="Calibri" pitchFamily="34" charset="-120"/>
+              </a:rPr>
+              <a:t>Executive summary · revenue vs plan &amp; prior year · gross margin vs budget · the rate ladder</a:t>
+            </a:r>
+            <a:endParaRPr lang="en-US" sz="1200" dirty="0"/>
+          </a:p>
+        </p:txBody>
+      </p:sp>
+      <p:sp>
+        <p:nvSpPr>
+          <p:cNvPr id="8" name="Shape 6"/>
+          <p:cNvSpPr/>
+          <p:nvPr/>
+        </p:nvSpPr>
+        <p:spPr>
+          <a:xfrm>
+            <a:off x="548640" y="2267712"/>
+            <a:ext cx="402336" cy="402336"/>
+          </a:xfrm>
+          <a:prstGeom prst="ellipse">
+            <a:avLst/>
+          </a:prstGeom>
+          <a:solidFill>
+            <a:srgbClr val="2A78D6"/>
+          </a:solidFill>
+          <a:ln/>
+        </p:spPr>
+      </p:sp>
+      <p:sp>
+        <p:nvSpPr>
+          <p:cNvPr id="9" name="Text 7"/>
+          <p:cNvSpPr/>
+          <p:nvPr/>
+        </p:nvSpPr>
+        <p:spPr>
+          <a:xfrm>
+            <a:off x="548640" y="2267712"/>
+            <a:ext cx="402336" cy="402336"/>
+          </a:xfrm>
+          <a:prstGeom prst="rect">
+            <a:avLst/>
+          </a:prstGeom>
+          <a:noFill/>
+          <a:ln/>
+        </p:spPr>
+        <p:txBody>
+          <a:bodyPr wrap="square" lIns="0" tIns="0" rIns="0" bIns="0" rtlCol="0" anchor="ctr"/>
+          <a:lstStyle/>
+          <a:p>
+            <a:pPr algn="ctr" indent="0" marL="0">
+              <a:buNone/>
+            </a:pPr>
+            <a:r>
+              <a:rPr lang="en-US" sz="1500" b="1" dirty="0">
+                <a:solidFill>
+                  <a:srgbClr val="FFFFFF"/>
+                </a:solidFill>
+                <a:latin typeface="Calibri" pitchFamily="34" charset="0"/>
+                <a:ea typeface="Calibri" pitchFamily="34" charset="-122"/>
+                <a:cs typeface="Calibri" pitchFamily="34" charset="-120"/>
+              </a:rPr>
+              <a:t>2</a:t>
+            </a:r>
+            <a:endParaRPr lang="en-US" sz="1500" dirty="0"/>
+          </a:p>
+        </p:txBody>
+      </p:sp>
+      <p:sp>
+        <p:nvSpPr>
+          <p:cNvPr id="10" name="Text 8"/>
+          <p:cNvSpPr/>
+          <p:nvPr/>
+        </p:nvSpPr>
+        <p:spPr>
+          <a:xfrm>
+            <a:off x="1188720" y="2249424"/>
+            <a:ext cx="3383280" cy="411480"/>
+          </a:xfrm>
+          <a:prstGeom prst="rect">
+            <a:avLst/>
+          </a:prstGeom>
+          <a:noFill/>
+          <a:ln/>
+        </p:spPr>
+        <p:txBody>
+          <a:bodyPr wrap="square" lIns="0" tIns="0" rIns="0" bIns="0" rtlCol="0" anchor="ctr"/>
+          <a:lstStyle/>
+          <a:p>
+            <a:pPr indent="0" marL="0">
+              <a:buNone/>
+            </a:pPr>
+            <a:r>
+              <a:rPr lang="en-US" sz="1650" b="1" dirty="0">
+                <a:solidFill>
+                  <a:srgbClr val="0B0B0B"/>
+                </a:solidFill>
+                <a:latin typeface="Calibri" pitchFamily="34" charset="0"/>
+                <a:ea typeface="Calibri" pitchFamily="34" charset="-122"/>
+                <a:cs typeface="Calibri" pitchFamily="34" charset="-120"/>
+              </a:rPr>
+              <a:t>Operating drivers</a:t>
+            </a:r>
+            <a:endParaRPr lang="en-US" sz="1650" dirty="0"/>
+          </a:p>
+        </p:txBody>
+      </p:sp>
+      <p:sp>
+        <p:nvSpPr>
+          <p:cNvPr id="11" name="Text 9"/>
+          <p:cNvSpPr/>
+          <p:nvPr/>
+        </p:nvSpPr>
+        <p:spPr>
+          <a:xfrm>
+            <a:off x="4754880" y="2249424"/>
+            <a:ext cx="6858000" cy="411480"/>
+          </a:xfrm>
+          <a:prstGeom prst="rect">
+            <a:avLst/>
+          </a:prstGeom>
+          <a:noFill/>
+          <a:ln/>
+        </p:spPr>
+        <p:txBody>
+          <a:bodyPr wrap="square" lIns="0" tIns="0" rIns="0" bIns="0" rtlCol="0" anchor="ctr"/>
+          <a:lstStyle/>
+          <a:p>
+            <a:pPr indent="0" marL="0">
+              <a:buNone/>
+            </a:pPr>
+            <a:r>
+              <a:rPr lang="en-US" sz="1200" dirty="0">
+                <a:solidFill>
+                  <a:srgbClr val="52514E"/>
+                </a:solidFill>
+                <a:latin typeface="Calibri" pitchFamily="34" charset="0"/>
+                <a:ea typeface="Calibri" pitchFamily="34" charset="-122"/>
+                <a:cs typeface="Calibri" pitchFamily="34" charset="-120"/>
+              </a:rPr>
+              <a:t>Staff &amp; headcount · utilization by person · sales by customer</a:t>
+            </a:r>
+            <a:endParaRPr lang="en-US" sz="1200" dirty="0"/>
+          </a:p>
+        </p:txBody>
+      </p:sp>
+      <p:sp>
+        <p:nvSpPr>
+          <p:cNvPr id="12" name="Shape 10"/>
+          <p:cNvSpPr/>
+          <p:nvPr/>
+        </p:nvSpPr>
+        <p:spPr>
+          <a:xfrm>
+            <a:off x="548640" y="3054096"/>
+            <a:ext cx="402336" cy="402336"/>
+          </a:xfrm>
+          <a:prstGeom prst="ellipse">
+            <a:avLst/>
+          </a:prstGeom>
+          <a:solidFill>
+            <a:srgbClr val="2A78D6"/>
+          </a:solidFill>
+          <a:ln/>
+        </p:spPr>
+      </p:sp>
+      <p:sp>
+        <p:nvSpPr>
+          <p:cNvPr id="13" name="Text 11"/>
+          <p:cNvSpPr/>
+          <p:nvPr/>
+        </p:nvSpPr>
+        <p:spPr>
+          <a:xfrm>
+            <a:off x="548640" y="3054096"/>
+            <a:ext cx="402336" cy="402336"/>
+          </a:xfrm>
+          <a:prstGeom prst="rect">
+            <a:avLst/>
+          </a:prstGeom>
+          <a:noFill/>
+          <a:ln/>
+        </p:spPr>
+        <p:txBody>
+          <a:bodyPr wrap="square" lIns="0" tIns="0" rIns="0" bIns="0" rtlCol="0" anchor="ctr"/>
+          <a:lstStyle/>
+          <a:p>
+            <a:pPr algn="ctr" indent="0" marL="0">
+              <a:buNone/>
+            </a:pPr>
+            <a:r>
+              <a:rPr lang="en-US" sz="1500" b="1" dirty="0">
+                <a:solidFill>
+                  <a:srgbClr val="FFFFFF"/>
+                </a:solidFill>
+                <a:latin typeface="Calibri" pitchFamily="34" charset="0"/>
+                <a:ea typeface="Calibri" pitchFamily="34" charset="-122"/>
+                <a:cs typeface="Calibri" pitchFamily="34" charset="-120"/>
+              </a:rPr>
+              <a:t>3</a:t>
+            </a:r>
+            <a:endParaRPr lang="en-US" sz="1500" dirty="0"/>
+          </a:p>
+        </p:txBody>
+      </p:sp>
+      <p:sp>
+        <p:nvSpPr>
+          <p:cNvPr id="14" name="Text 12"/>
+          <p:cNvSpPr/>
+          <p:nvPr/>
+        </p:nvSpPr>
+        <p:spPr>
+          <a:xfrm>
+            <a:off x="1188720" y="3035808"/>
+            <a:ext cx="3383280" cy="411480"/>
+          </a:xfrm>
+          <a:prstGeom prst="rect">
+            <a:avLst/>
+          </a:prstGeom>
+          <a:noFill/>
+          <a:ln/>
+        </p:spPr>
+        <p:txBody>
+          <a:bodyPr wrap="square" lIns="0" tIns="0" rIns="0" bIns="0" rtlCol="0" anchor="ctr"/>
+          <a:lstStyle/>
+          <a:p>
+            <a:pPr indent="0" marL="0">
+              <a:buNone/>
+            </a:pPr>
+            <a:r>
+              <a:rPr lang="en-US" sz="1650" b="1" dirty="0">
+                <a:solidFill>
+                  <a:srgbClr val="0B0B0B"/>
+                </a:solidFill>
+                <a:latin typeface="Calibri" pitchFamily="34" charset="0"/>
+                <a:ea typeface="Calibri" pitchFamily="34" charset="-122"/>
+                <a:cs typeface="Calibri" pitchFamily="34" charset="-120"/>
+              </a:rPr>
+              <a:t>Work in hand &amp; work to win</a:t>
+            </a:r>
+            <a:endParaRPr lang="en-US" sz="1650" dirty="0"/>
+          </a:p>
+        </p:txBody>
+      </p:sp>
+      <p:sp>
+        <p:nvSpPr>
+          <p:cNvPr id="15" name="Text 13"/>
+          <p:cNvSpPr/>
+          <p:nvPr/>
+        </p:nvSpPr>
+        <p:spPr>
+          <a:xfrm>
+            <a:off x="4754880" y="3035808"/>
+            <a:ext cx="6858000" cy="411480"/>
+          </a:xfrm>
+          <a:prstGeom prst="rect">
+            <a:avLst/>
+          </a:prstGeom>
+          <a:noFill/>
+          <a:ln/>
+        </p:spPr>
+        <p:txBody>
+          <a:bodyPr wrap="square" lIns="0" tIns="0" rIns="0" bIns="0" rtlCol="0" anchor="ctr"/>
+          <a:lstStyle/>
+          <a:p>
+            <a:pPr indent="0" marL="0">
+              <a:buNone/>
+            </a:pPr>
+            <a:r>
+              <a:rPr lang="en-US" sz="1200" dirty="0">
+                <a:solidFill>
+                  <a:srgbClr val="52514E"/>
+                </a:solidFill>
+                <a:latin typeface="Calibri" pitchFamily="34" charset="0"/>
+                <a:ea typeface="Calibri" pitchFamily="34" charset="-122"/>
+                <a:cs typeface="Calibri" pitchFamily="34" charset="-120"/>
+              </a:rPr>
+              <a:t>Backlog on active jobs · known pipeline opportunities</a:t>
+            </a:r>
+            <a:endParaRPr lang="en-US" sz="1200" dirty="0"/>
+          </a:p>
+        </p:txBody>
+      </p:sp>
+      <p:sp>
+        <p:nvSpPr>
+          <p:cNvPr id="16" name="Shape 14"/>
+          <p:cNvSpPr/>
+          <p:nvPr/>
+        </p:nvSpPr>
+        <p:spPr>
+          <a:xfrm>
+            <a:off x="548640" y="3840480"/>
+            <a:ext cx="402336" cy="402336"/>
+          </a:xfrm>
+          <a:prstGeom prst="ellipse">
+            <a:avLst/>
+          </a:prstGeom>
+          <a:solidFill>
+            <a:srgbClr val="2A78D6"/>
+          </a:solidFill>
+          <a:ln/>
+        </p:spPr>
+      </p:sp>
+      <p:sp>
+        <p:nvSpPr>
+          <p:cNvPr id="17" name="Text 15"/>
+          <p:cNvSpPr/>
+          <p:nvPr/>
+        </p:nvSpPr>
+        <p:spPr>
+          <a:xfrm>
+            <a:off x="548640" y="3840480"/>
+            <a:ext cx="402336" cy="402336"/>
+          </a:xfrm>
+          <a:prstGeom prst="rect">
+            <a:avLst/>
+          </a:prstGeom>
+          <a:noFill/>
+          <a:ln/>
+        </p:spPr>
+        <p:txBody>
+          <a:bodyPr wrap="square" lIns="0" tIns="0" rIns="0" bIns="0" rtlCol="0" anchor="ctr"/>
+          <a:lstStyle/>
+          <a:p>
+            <a:pPr algn="ctr" indent="0" marL="0">
+              <a:buNone/>
+            </a:pPr>
+            <a:r>
+              <a:rPr lang="en-US" sz="1500" b="1" dirty="0">
+                <a:solidFill>
+                  <a:srgbClr val="FFFFFF"/>
+                </a:solidFill>
+                <a:latin typeface="Calibri" pitchFamily="34" charset="0"/>
+                <a:ea typeface="Calibri" pitchFamily="34" charset="-122"/>
+                <a:cs typeface="Calibri" pitchFamily="34" charset="-120"/>
+              </a:rPr>
+              <a:t>4</a:t>
+            </a:r>
+            <a:endParaRPr lang="en-US" sz="1500" dirty="0"/>
+          </a:p>
+        </p:txBody>
+      </p:sp>
+      <p:sp>
+        <p:nvSpPr>
+          <p:cNvPr id="18" name="Text 16"/>
+          <p:cNvSpPr/>
+          <p:nvPr/>
+        </p:nvSpPr>
+        <p:spPr>
+          <a:xfrm>
+            <a:off x="1188720" y="3822192"/>
+            <a:ext cx="3383280" cy="411480"/>
+          </a:xfrm>
+          <a:prstGeom prst="rect">
+            <a:avLst/>
+          </a:prstGeom>
+          <a:noFill/>
+          <a:ln/>
+        </p:spPr>
+        <p:txBody>
+          <a:bodyPr wrap="square" lIns="0" tIns="0" rIns="0" bIns="0" rtlCol="0" anchor="ctr"/>
+          <a:lstStyle/>
+          <a:p>
+            <a:pPr indent="0" marL="0">
+              <a:buNone/>
+            </a:pPr>
+            <a:r>
+              <a:rPr lang="en-US" sz="1650" b="1" dirty="0">
+                <a:solidFill>
+                  <a:srgbClr val="0B0B0B"/>
+                </a:solidFill>
+                <a:latin typeface="Calibri" pitchFamily="34" charset="0"/>
+                <a:ea typeface="Calibri" pitchFamily="34" charset="-122"/>
+                <a:cs typeface="Calibri" pitchFamily="34" charset="-120"/>
+              </a:rPr>
+              <a:t>Strategy</a:t>
+            </a:r>
+            <a:endParaRPr lang="en-US" sz="1650" dirty="0"/>
+          </a:p>
+        </p:txBody>
+      </p:sp>
+      <p:sp>
+        <p:nvSpPr>
+          <p:cNvPr id="19" name="Text 17"/>
+          <p:cNvSpPr/>
+          <p:nvPr/>
+        </p:nvSpPr>
+        <p:spPr>
+          <a:xfrm>
+            <a:off x="4754880" y="3822192"/>
+            <a:ext cx="6858000" cy="411480"/>
+          </a:xfrm>
+          <a:prstGeom prst="rect">
+            <a:avLst/>
+          </a:prstGeom>
+          <a:noFill/>
+          <a:ln/>
+        </p:spPr>
+        <p:txBody>
+          <a:bodyPr wrap="square" lIns="0" tIns="0" rIns="0" bIns="0" rtlCol="0" anchor="ctr"/>
+          <a:lstStyle/>
+          <a:p>
+            <a:pPr indent="0" marL="0">
+              <a:buNone/>
+            </a:pPr>
+            <a:r>
+              <a:rPr lang="en-US" sz="1200" dirty="0">
+                <a:solidFill>
+                  <a:srgbClr val="52514E"/>
+                </a:solidFill>
+                <a:latin typeface="Calibri" pitchFamily="34" charset="0"/>
+                <a:ea typeface="Calibri" pitchFamily="34" charset="-122"/>
+                <a:cs typeface="Calibri" pitchFamily="34" charset="-120"/>
+              </a:rPr>
+              <a:t>One pursuit engine with HWC Estimating · the consolidated EPC offering · the addressable market · national expansion targets · BD account ownership</a:t>
+            </a:r>
+            <a:endParaRPr lang="en-US" sz="1200" dirty="0"/>
+          </a:p>
+        </p:txBody>
+      </p:sp>
+      <p:sp>
+        <p:nvSpPr>
+          <p:cNvPr id="20" name="Shape 18"/>
+          <p:cNvSpPr/>
+          <p:nvPr/>
+        </p:nvSpPr>
+        <p:spPr>
+          <a:xfrm>
+            <a:off x="548640" y="4626864"/>
+            <a:ext cx="402336" cy="402336"/>
+          </a:xfrm>
+          <a:prstGeom prst="ellipse">
+            <a:avLst/>
+          </a:prstGeom>
+          <a:solidFill>
+            <a:srgbClr val="2A78D6"/>
+          </a:solidFill>
+          <a:ln/>
+        </p:spPr>
+      </p:sp>
+      <p:sp>
+        <p:nvSpPr>
+          <p:cNvPr id="21" name="Text 19"/>
+          <p:cNvSpPr/>
+          <p:nvPr/>
+        </p:nvSpPr>
+        <p:spPr>
+          <a:xfrm>
+            <a:off x="548640" y="4626864"/>
+            <a:ext cx="402336" cy="402336"/>
+          </a:xfrm>
+          <a:prstGeom prst="rect">
+            <a:avLst/>
+          </a:prstGeom>
+          <a:noFill/>
+          <a:ln/>
+        </p:spPr>
+        <p:txBody>
+          <a:bodyPr wrap="square" lIns="0" tIns="0" rIns="0" bIns="0" rtlCol="0" anchor="ctr"/>
+          <a:lstStyle/>
+          <a:p>
+            <a:pPr algn="ctr" indent="0" marL="0">
+              <a:buNone/>
+            </a:pPr>
+            <a:r>
+              <a:rPr lang="en-US" sz="1500" b="1" dirty="0">
+                <a:solidFill>
+                  <a:srgbClr val="FFFFFF"/>
+                </a:solidFill>
+                <a:latin typeface="Calibri" pitchFamily="34" charset="0"/>
+                <a:ea typeface="Calibri" pitchFamily="34" charset="-122"/>
+                <a:cs typeface="Calibri" pitchFamily="34" charset="-120"/>
+              </a:rPr>
+              <a:t>5</a:t>
+            </a:r>
+            <a:endParaRPr lang="en-US" sz="1500" dirty="0"/>
+          </a:p>
+        </p:txBody>
+      </p:sp>
+      <p:sp>
+        <p:nvSpPr>
+          <p:cNvPr id="22" name="Text 20"/>
+          <p:cNvSpPr/>
+          <p:nvPr/>
+        </p:nvSpPr>
+        <p:spPr>
+          <a:xfrm>
+            <a:off x="1188720" y="4608576"/>
+            <a:ext cx="3383280" cy="411480"/>
+          </a:xfrm>
+          <a:prstGeom prst="rect">
+            <a:avLst/>
+          </a:prstGeom>
+          <a:noFill/>
+          <a:ln/>
+        </p:spPr>
+        <p:txBody>
+          <a:bodyPr wrap="square" lIns="0" tIns="0" rIns="0" bIns="0" rtlCol="0" anchor="ctr"/>
+          <a:lstStyle/>
+          <a:p>
+            <a:pPr indent="0" marL="0">
+              <a:buNone/>
+            </a:pPr>
+            <a:r>
+              <a:rPr lang="en-US" sz="1650" b="1" dirty="0">
+                <a:solidFill>
+                  <a:srgbClr val="0B0B0B"/>
+                </a:solidFill>
+                <a:latin typeface="Calibri" pitchFamily="34" charset="0"/>
+                <a:ea typeface="Calibri" pitchFamily="34" charset="-122"/>
+                <a:cs typeface="Calibri" pitchFamily="34" charset="-120"/>
+              </a:rPr>
+              <a:t>Forward view</a:t>
+            </a:r>
+            <a:endParaRPr lang="en-US" sz="1650" dirty="0"/>
+          </a:p>
+        </p:txBody>
+      </p:sp>
+      <p:sp>
+        <p:nvSpPr>
+          <p:cNvPr id="23" name="Text 21"/>
+          <p:cNvSpPr/>
+          <p:nvPr/>
+        </p:nvSpPr>
+        <p:spPr>
+          <a:xfrm>
+            <a:off x="4754880" y="4608576"/>
+            <a:ext cx="6858000" cy="411480"/>
+          </a:xfrm>
+          <a:prstGeom prst="rect">
+            <a:avLst/>
+          </a:prstGeom>
+          <a:noFill/>
+          <a:ln/>
+        </p:spPr>
+        <p:txBody>
+          <a:bodyPr wrap="square" lIns="0" tIns="0" rIns="0" bIns="0" rtlCol="0" anchor="ctr"/>
+          <a:lstStyle/>
+          <a:p>
+            <a:pPr indent="0" marL="0">
+              <a:buNone/>
+            </a:pPr>
+            <a:r>
+              <a:rPr lang="en-US" sz="1200" dirty="0">
+                <a:solidFill>
+                  <a:srgbClr val="52514E"/>
+                </a:solidFill>
+                <a:latin typeface="Calibri" pitchFamily="34" charset="0"/>
+                <a:ea typeface="Calibri" pitchFamily="34" charset="-122"/>
+                <a:cs typeface="Calibri" pitchFamily="34" charset="-120"/>
+              </a:rPr>
+              <a:t>Forecast &amp; coverage · FY2026 landing and FY2027 scenarios · EPC accounting alignment</a:t>
+            </a:r>
+            <a:endParaRPr lang="en-US" sz="1200" dirty="0"/>
+          </a:p>
+        </p:txBody>
+      </p:sp>
+      <p:sp>
+        <p:nvSpPr>
+          <p:cNvPr id="24" name="Shape 22"/>
+          <p:cNvSpPr/>
+          <p:nvPr/>
+        </p:nvSpPr>
+        <p:spPr>
+          <a:xfrm>
+            <a:off x="548640" y="5413248"/>
+            <a:ext cx="402336" cy="402336"/>
+          </a:xfrm>
+          <a:prstGeom prst="ellipse">
+            <a:avLst/>
+          </a:prstGeom>
+          <a:solidFill>
+            <a:srgbClr val="2A78D6"/>
+          </a:solidFill>
+          <a:ln/>
+        </p:spPr>
+      </p:sp>
+      <p:sp>
+        <p:nvSpPr>
+          <p:cNvPr id="25" name="Text 23"/>
+          <p:cNvSpPr/>
+          <p:nvPr/>
+        </p:nvSpPr>
+        <p:spPr>
+          <a:xfrm>
+            <a:off x="548640" y="5413248"/>
+            <a:ext cx="402336" cy="402336"/>
+          </a:xfrm>
+          <a:prstGeom prst="rect">
+            <a:avLst/>
+          </a:prstGeom>
+          <a:noFill/>
+          <a:ln/>
+        </p:spPr>
+        <p:txBody>
+          <a:bodyPr wrap="square" lIns="0" tIns="0" rIns="0" bIns="0" rtlCol="0" anchor="ctr"/>
+          <a:lstStyle/>
+          <a:p>
+            <a:pPr algn="ctr" indent="0" marL="0">
+              <a:buNone/>
+            </a:pPr>
+            <a:r>
+              <a:rPr lang="en-US" sz="1500" b="1" dirty="0">
+                <a:solidFill>
+                  <a:srgbClr val="FFFFFF"/>
+                </a:solidFill>
+                <a:latin typeface="Calibri" pitchFamily="34" charset="0"/>
+                <a:ea typeface="Calibri" pitchFamily="34" charset="-122"/>
+                <a:cs typeface="Calibri" pitchFamily="34" charset="-120"/>
+              </a:rPr>
+              <a:t>6</a:t>
+            </a:r>
+            <a:endParaRPr lang="en-US" sz="1500" dirty="0"/>
+          </a:p>
+        </p:txBody>
+      </p:sp>
+      <p:sp>
+        <p:nvSpPr>
+          <p:cNvPr id="26" name="Text 24"/>
+          <p:cNvSpPr/>
+          <p:nvPr/>
+        </p:nvSpPr>
+        <p:spPr>
+          <a:xfrm>
+            <a:off x="1188720" y="5394960"/>
+            <a:ext cx="3383280" cy="411480"/>
+          </a:xfrm>
+          <a:prstGeom prst="rect">
+            <a:avLst/>
+          </a:prstGeom>
+          <a:noFill/>
+          <a:ln/>
+        </p:spPr>
+        <p:txBody>
+          <a:bodyPr wrap="square" lIns="0" tIns="0" rIns="0" bIns="0" rtlCol="0" anchor="ctr"/>
+          <a:lstStyle/>
+          <a:p>
+            <a:pPr indent="0" marL="0">
+              <a:buNone/>
+            </a:pPr>
+            <a:r>
+              <a:rPr lang="en-US" sz="1650" b="1" dirty="0">
+                <a:solidFill>
+                  <a:srgbClr val="0B0B0B"/>
+                </a:solidFill>
+                <a:latin typeface="Calibri" pitchFamily="34" charset="0"/>
+                <a:ea typeface="Calibri" pitchFamily="34" charset="-122"/>
+                <a:cs typeface="Calibri" pitchFamily="34" charset="-120"/>
+              </a:rPr>
+              <a:t>Next 90 days</a:t>
+            </a:r>
+            <a:endParaRPr lang="en-US" sz="1650" dirty="0"/>
+          </a:p>
+        </p:txBody>
+      </p:sp>
+      <p:sp>
+        <p:nvSpPr>
+          <p:cNvPr id="27" name="Text 25"/>
+          <p:cNvSpPr/>
+          <p:nvPr/>
+        </p:nvSpPr>
+        <p:spPr>
+          <a:xfrm>
+            <a:off x="4754880" y="5394960"/>
+            <a:ext cx="6858000" cy="411480"/>
+          </a:xfrm>
+          <a:prstGeom prst="rect">
+            <a:avLst/>
+          </a:prstGeom>
+          <a:noFill/>
+          <a:ln/>
+        </p:spPr>
+        <p:txBody>
+          <a:bodyPr wrap="square" lIns="0" tIns="0" rIns="0" bIns="0" rtlCol="0" anchor="ctr"/>
+          <a:lstStyle/>
+          <a:p>
+            <a:pPr indent="0" marL="0">
+              <a:buNone/>
+            </a:pPr>
+            <a:r>
+              <a:rPr lang="en-US" sz="1200" dirty="0">
+                <a:solidFill>
+                  <a:srgbClr val="52514E"/>
+                </a:solidFill>
+                <a:latin typeface="Calibri" pitchFamily="34" charset="0"/>
+                <a:ea typeface="Calibri" pitchFamily="34" charset="-122"/>
+                <a:cs typeface="Calibri" pitchFamily="34" charset="-120"/>
+              </a:rPr>
+              <a:t>Priorities: realization, utilization, the Q4 pipeline, and the monthly rhythm</a:t>
+            </a:r>
+            <a:endParaRPr lang="en-US" sz="1200" dirty="0"/>
+          </a:p>
+        </p:txBody>
+      </p:sp>
+      <p:sp>
+        <p:nvSpPr>
+          <p:cNvPr id="28" name="Text 26"/>
+          <p:cNvSpPr/>
+          <p:nvPr/>
+        </p:nvSpPr>
+        <p:spPr>
+          <a:xfrm>
+            <a:off x="548640" y="6419088"/>
+            <a:ext cx="11064240" cy="320040"/>
+          </a:xfrm>
+          <a:prstGeom prst="rect">
+            <a:avLst/>
+          </a:prstGeom>
+          <a:noFill/>
+          <a:ln/>
+        </p:spPr>
+        <p:txBody>
+          <a:bodyPr wrap="square" lIns="0" tIns="0" rIns="0" bIns="0" rtlCol="0" anchor="ctr"/>
+          <a:lstStyle/>
+          <a:p>
+            <a:pPr indent="0" marL="0">
+              <a:buNone/>
+            </a:pPr>
+            <a:r>
+              <a:rPr lang="en-US" sz="950" dirty="0">
+                <a:solidFill>
+                  <a:srgbClr val="898781"/>
+                </a:solidFill>
+                <a:latin typeface="Calibri" pitchFamily="34" charset="0"/>
+                <a:ea typeface="Calibri" pitchFamily="34" charset="-122"/>
+                <a:cs typeface="Calibri" pitchFamily="34" charset="-120"/>
+              </a:rPr>
+              <a:t>CVR Engineering financial review &amp; forecast · June 2026</a:t>
+            </a:r>
+            <a:endParaRPr lang="en-US" sz="950" dirty="0"/>
+          </a:p>
+        </p:txBody>
+      </p:sp>
+    </p:spTree>
+  </p:cSld>
+  <p:clrMapOvr>
+    <a:masterClrMapping/>
+  </p:clrMapOvr>
+</p:sld>
+</file>
+
+<file path=ppt/slides/slide20.xml><?xml version="1.0" encoding="utf-8"?>
+<p:sld xmlns:a="http://schemas.openxmlformats.org/drawingml/2006/main" xmlns:r="http://schemas.openxmlformats.org/officeDocument/2006/relationships" xmlns:p="http://schemas.openxmlformats.org/presentationml/2006/main">
+  <p:cSld name="Slide 20">
     <p:spTree>
       <p:nvGrpSpPr>
         <p:cNvPr id="1" name=""/>
@@ -19155,7 +20402,7 @@
       </p:sp>
       <p:graphicFrame>
         <p:nvGraphicFramePr>
-          <p:cNvPr id="20" name="Table 0"/>
+          <p:cNvPr id="21" name="Table 0"/>
           <p:cNvGraphicFramePr>
             <a:graphicFrameLocks noGrp="1"/>
           </p:cNvGraphicFramePr>
@@ -20898,7 +22145,7 @@
       </p:graphicFrame>
       <p:graphicFrame>
         <p:nvGraphicFramePr>
-          <p:cNvPr id="39" name="Table 1"/>
+          <p:cNvPr id="41" name="Table 1"/>
           <p:cNvGraphicFramePr>
             <a:graphicFrameLocks noGrp="1"/>
           </p:cNvGraphicFramePr>
@@ -21753,7 +23000,7 @@
       </p:graphicFrame>
       <p:graphicFrame>
         <p:nvGraphicFramePr>
-          <p:cNvPr id="58" name="Table 2"/>
+          <p:cNvPr id="61" name="Table 2"/>
           <p:cNvGraphicFramePr>
             <a:graphicFrameLocks noGrp="1"/>
           </p:cNvGraphicFramePr>
@@ -23371,987 +24618,9 @@
 </p:sld>
 </file>
 
-<file path=ppt/slides/slide2.xml><?xml version="1.0" encoding="utf-8"?>
+<file path=ppt/slides/slide21.xml><?xml version="1.0" encoding="utf-8"?>
 <p:sld xmlns:a="http://schemas.openxmlformats.org/drawingml/2006/main" xmlns:r="http://schemas.openxmlformats.org/officeDocument/2006/relationships" xmlns:p="http://schemas.openxmlformats.org/presentationml/2006/main">
-  <p:cSld name="Slide 2">
-    <p:spTree>
-      <p:nvGrpSpPr>
-        <p:cNvPr id="1" name=""/>
-        <p:cNvGrpSpPr/>
-        <p:nvPr/>
-      </p:nvGrpSpPr>
-      <p:grpSpPr>
-        <a:xfrm>
-          <a:off x="0" y="0"/>
-          <a:ext cx="0" cy="0"/>
-          <a:chOff x="0" y="0"/>
-          <a:chExt cx="0" cy="0"/>
-        </a:xfrm>
-      </p:grpSpPr>
-      <p:sp>
-        <p:nvSpPr>
-          <p:cNvPr id="2" name="Text 0"/>
-          <p:cNvSpPr/>
-          <p:nvPr/>
-        </p:nvSpPr>
-        <p:spPr>
-          <a:xfrm>
-            <a:off x="548640" y="292608"/>
-            <a:ext cx="11064240" cy="274320"/>
-          </a:xfrm>
-          <a:prstGeom prst="rect">
-            <a:avLst/>
-          </a:prstGeom>
-          <a:noFill/>
-          <a:ln/>
-        </p:spPr>
-        <p:txBody>
-          <a:bodyPr wrap="square" lIns="0" tIns="0" rIns="0" bIns="0" rtlCol="0" anchor="ctr"/>
-          <a:lstStyle/>
-          <a:p>
-            <a:pPr indent="0" marL="0">
-              <a:buNone/>
-            </a:pPr>
-            <a:r>
-              <a:rPr lang="en-US" sz="1100" b="1" dirty="0">
-                <a:solidFill>
-                  <a:srgbClr val="86B332"/>
-                </a:solidFill>
-                <a:latin typeface="Calibri" pitchFamily="34" charset="0"/>
-                <a:ea typeface="Calibri" pitchFamily="34" charset="-122"/>
-                <a:cs typeface="Calibri" pitchFamily="34" charset="-120"/>
-              </a:rPr>
-              <a:t>— </a:t>
-            </a:r>
-            <a:pPr indent="0" marL="0">
-              <a:buNone/>
-            </a:pPr>
-            <a:r>
-              <a:rPr lang="en-US" sz="1100" b="1" spc="200" kern="0" dirty="0">
-                <a:solidFill>
-                  <a:srgbClr val="52514E"/>
-                </a:solidFill>
-                <a:latin typeface="Calibri" pitchFamily="34" charset="0"/>
-                <a:ea typeface="Calibri" pitchFamily="34" charset="-122"/>
-                <a:cs typeface="Calibri" pitchFamily="34" charset="-120"/>
-              </a:rPr>
-              <a:t>AGENDA</a:t>
-            </a:r>
-            <a:endParaRPr lang="en-US" sz="1100" dirty="0"/>
-          </a:p>
-        </p:txBody>
-      </p:sp>
-      <p:sp>
-        <p:nvSpPr>
-          <p:cNvPr id="3" name="Text 1"/>
-          <p:cNvSpPr/>
-          <p:nvPr/>
-        </p:nvSpPr>
-        <p:spPr>
-          <a:xfrm>
-            <a:off x="548640" y="548640"/>
-            <a:ext cx="11064240" cy="502920"/>
-          </a:xfrm>
-          <a:prstGeom prst="rect">
-            <a:avLst/>
-          </a:prstGeom>
-          <a:noFill/>
-          <a:ln/>
-        </p:spPr>
-        <p:txBody>
-          <a:bodyPr wrap="square" lIns="0" tIns="0" rIns="0" bIns="0" rtlCol="0" anchor="ctr"/>
-          <a:lstStyle/>
-          <a:p>
-            <a:pPr indent="0" marL="0">
-              <a:buNone/>
-            </a:pPr>
-            <a:r>
-              <a:rPr lang="en-US" sz="2700" b="1" dirty="0">
-                <a:solidFill>
-                  <a:srgbClr val="0B0B0B"/>
-                </a:solidFill>
-                <a:latin typeface="Calibri" pitchFamily="34" charset="0"/>
-                <a:ea typeface="Calibri" pitchFamily="34" charset="-122"/>
-                <a:cs typeface="Calibri" pitchFamily="34" charset="-120"/>
-              </a:rPr>
-              <a:t>What we'll cover</a:t>
-            </a:r>
-            <a:endParaRPr lang="en-US" sz="2700" dirty="0"/>
-          </a:p>
-        </p:txBody>
-      </p:sp>
-      <p:sp>
-        <p:nvSpPr>
-          <p:cNvPr id="4" name="Shape 2"/>
-          <p:cNvSpPr/>
-          <p:nvPr/>
-        </p:nvSpPr>
-        <p:spPr>
-          <a:xfrm>
-            <a:off x="548640" y="1481328"/>
-            <a:ext cx="402336" cy="402336"/>
-          </a:xfrm>
-          <a:prstGeom prst="ellipse">
-            <a:avLst/>
-          </a:prstGeom>
-          <a:solidFill>
-            <a:srgbClr val="2A78D6"/>
-          </a:solidFill>
-          <a:ln/>
-        </p:spPr>
-      </p:sp>
-      <p:sp>
-        <p:nvSpPr>
-          <p:cNvPr id="5" name="Text 3"/>
-          <p:cNvSpPr/>
-          <p:nvPr/>
-        </p:nvSpPr>
-        <p:spPr>
-          <a:xfrm>
-            <a:off x="548640" y="1481328"/>
-            <a:ext cx="402336" cy="402336"/>
-          </a:xfrm>
-          <a:prstGeom prst="rect">
-            <a:avLst/>
-          </a:prstGeom>
-          <a:noFill/>
-          <a:ln/>
-        </p:spPr>
-        <p:txBody>
-          <a:bodyPr wrap="square" lIns="0" tIns="0" rIns="0" bIns="0" rtlCol="0" anchor="ctr"/>
-          <a:lstStyle/>
-          <a:p>
-            <a:pPr algn="ctr" indent="0" marL="0">
-              <a:buNone/>
-            </a:pPr>
-            <a:r>
-              <a:rPr lang="en-US" sz="1500" b="1" dirty="0">
-                <a:solidFill>
-                  <a:srgbClr val="FFFFFF"/>
-                </a:solidFill>
-                <a:latin typeface="Calibri" pitchFamily="34" charset="0"/>
-                <a:ea typeface="Calibri" pitchFamily="34" charset="-122"/>
-                <a:cs typeface="Calibri" pitchFamily="34" charset="-120"/>
-              </a:rPr>
-              <a:t>1</a:t>
-            </a:r>
-            <a:endParaRPr lang="en-US" sz="1500" dirty="0"/>
-          </a:p>
-        </p:txBody>
-      </p:sp>
-      <p:sp>
-        <p:nvSpPr>
-          <p:cNvPr id="6" name="Text 4"/>
-          <p:cNvSpPr/>
-          <p:nvPr/>
-        </p:nvSpPr>
-        <p:spPr>
-          <a:xfrm>
-            <a:off x="1188720" y="1463040"/>
-            <a:ext cx="3383280" cy="411480"/>
-          </a:xfrm>
-          <a:prstGeom prst="rect">
-            <a:avLst/>
-          </a:prstGeom>
-          <a:noFill/>
-          <a:ln/>
-        </p:spPr>
-        <p:txBody>
-          <a:bodyPr wrap="square" lIns="0" tIns="0" rIns="0" bIns="0" rtlCol="0" anchor="ctr"/>
-          <a:lstStyle/>
-          <a:p>
-            <a:pPr indent="0" marL="0">
-              <a:buNone/>
-            </a:pPr>
-            <a:r>
-              <a:rPr lang="en-US" sz="1650" b="1" dirty="0">
-                <a:solidFill>
-                  <a:srgbClr val="0B0B0B"/>
-                </a:solidFill>
-                <a:latin typeface="Calibri" pitchFamily="34" charset="0"/>
-                <a:ea typeface="Calibri" pitchFamily="34" charset="-122"/>
-                <a:cs typeface="Calibri" pitchFamily="34" charset="-120"/>
-              </a:rPr>
-              <a:t>Where we stand</a:t>
-            </a:r>
-            <a:endParaRPr lang="en-US" sz="1650" dirty="0"/>
-          </a:p>
-        </p:txBody>
-      </p:sp>
-      <p:sp>
-        <p:nvSpPr>
-          <p:cNvPr id="7" name="Text 5"/>
-          <p:cNvSpPr/>
-          <p:nvPr/>
-        </p:nvSpPr>
-        <p:spPr>
-          <a:xfrm>
-            <a:off x="4754880" y="1463040"/>
-            <a:ext cx="6858000" cy="411480"/>
-          </a:xfrm>
-          <a:prstGeom prst="rect">
-            <a:avLst/>
-          </a:prstGeom>
-          <a:noFill/>
-          <a:ln/>
-        </p:spPr>
-        <p:txBody>
-          <a:bodyPr wrap="square" lIns="0" tIns="0" rIns="0" bIns="0" rtlCol="0" anchor="ctr"/>
-          <a:lstStyle/>
-          <a:p>
-            <a:pPr indent="0" marL="0">
-              <a:buNone/>
-            </a:pPr>
-            <a:r>
-              <a:rPr lang="en-US" sz="1200" dirty="0">
-                <a:solidFill>
-                  <a:srgbClr val="52514E"/>
-                </a:solidFill>
-                <a:latin typeface="Calibri" pitchFamily="34" charset="0"/>
-                <a:ea typeface="Calibri" pitchFamily="34" charset="-122"/>
-                <a:cs typeface="Calibri" pitchFamily="34" charset="-120"/>
-              </a:rPr>
-              <a:t>Executive summary · revenue vs plan &amp; prior year · gross margin vs budget · the rate ladder</a:t>
-            </a:r>
-            <a:endParaRPr lang="en-US" sz="1200" dirty="0"/>
-          </a:p>
-        </p:txBody>
-      </p:sp>
-      <p:sp>
-        <p:nvSpPr>
-          <p:cNvPr id="8" name="Shape 6"/>
-          <p:cNvSpPr/>
-          <p:nvPr/>
-        </p:nvSpPr>
-        <p:spPr>
-          <a:xfrm>
-            <a:off x="548640" y="2267712"/>
-            <a:ext cx="402336" cy="402336"/>
-          </a:xfrm>
-          <a:prstGeom prst="ellipse">
-            <a:avLst/>
-          </a:prstGeom>
-          <a:solidFill>
-            <a:srgbClr val="2A78D6"/>
-          </a:solidFill>
-          <a:ln/>
-        </p:spPr>
-      </p:sp>
-      <p:sp>
-        <p:nvSpPr>
-          <p:cNvPr id="9" name="Text 7"/>
-          <p:cNvSpPr/>
-          <p:nvPr/>
-        </p:nvSpPr>
-        <p:spPr>
-          <a:xfrm>
-            <a:off x="548640" y="2267712"/>
-            <a:ext cx="402336" cy="402336"/>
-          </a:xfrm>
-          <a:prstGeom prst="rect">
-            <a:avLst/>
-          </a:prstGeom>
-          <a:noFill/>
-          <a:ln/>
-        </p:spPr>
-        <p:txBody>
-          <a:bodyPr wrap="square" lIns="0" tIns="0" rIns="0" bIns="0" rtlCol="0" anchor="ctr"/>
-          <a:lstStyle/>
-          <a:p>
-            <a:pPr algn="ctr" indent="0" marL="0">
-              <a:buNone/>
-            </a:pPr>
-            <a:r>
-              <a:rPr lang="en-US" sz="1500" b="1" dirty="0">
-                <a:solidFill>
-                  <a:srgbClr val="FFFFFF"/>
-                </a:solidFill>
-                <a:latin typeface="Calibri" pitchFamily="34" charset="0"/>
-                <a:ea typeface="Calibri" pitchFamily="34" charset="-122"/>
-                <a:cs typeface="Calibri" pitchFamily="34" charset="-120"/>
-              </a:rPr>
-              <a:t>2</a:t>
-            </a:r>
-            <a:endParaRPr lang="en-US" sz="1500" dirty="0"/>
-          </a:p>
-        </p:txBody>
-      </p:sp>
-      <p:sp>
-        <p:nvSpPr>
-          <p:cNvPr id="10" name="Text 8"/>
-          <p:cNvSpPr/>
-          <p:nvPr/>
-        </p:nvSpPr>
-        <p:spPr>
-          <a:xfrm>
-            <a:off x="1188720" y="2249424"/>
-            <a:ext cx="3383280" cy="411480"/>
-          </a:xfrm>
-          <a:prstGeom prst="rect">
-            <a:avLst/>
-          </a:prstGeom>
-          <a:noFill/>
-          <a:ln/>
-        </p:spPr>
-        <p:txBody>
-          <a:bodyPr wrap="square" lIns="0" tIns="0" rIns="0" bIns="0" rtlCol="0" anchor="ctr"/>
-          <a:lstStyle/>
-          <a:p>
-            <a:pPr indent="0" marL="0">
-              <a:buNone/>
-            </a:pPr>
-            <a:r>
-              <a:rPr lang="en-US" sz="1650" b="1" dirty="0">
-                <a:solidFill>
-                  <a:srgbClr val="0B0B0B"/>
-                </a:solidFill>
-                <a:latin typeface="Calibri" pitchFamily="34" charset="0"/>
-                <a:ea typeface="Calibri" pitchFamily="34" charset="-122"/>
-                <a:cs typeface="Calibri" pitchFamily="34" charset="-120"/>
-              </a:rPr>
-              <a:t>Operating drivers</a:t>
-            </a:r>
-            <a:endParaRPr lang="en-US" sz="1650" dirty="0"/>
-          </a:p>
-        </p:txBody>
-      </p:sp>
-      <p:sp>
-        <p:nvSpPr>
-          <p:cNvPr id="11" name="Text 9"/>
-          <p:cNvSpPr/>
-          <p:nvPr/>
-        </p:nvSpPr>
-        <p:spPr>
-          <a:xfrm>
-            <a:off x="4754880" y="2249424"/>
-            <a:ext cx="6858000" cy="411480"/>
-          </a:xfrm>
-          <a:prstGeom prst="rect">
-            <a:avLst/>
-          </a:prstGeom>
-          <a:noFill/>
-          <a:ln/>
-        </p:spPr>
-        <p:txBody>
-          <a:bodyPr wrap="square" lIns="0" tIns="0" rIns="0" bIns="0" rtlCol="0" anchor="ctr"/>
-          <a:lstStyle/>
-          <a:p>
-            <a:pPr indent="0" marL="0">
-              <a:buNone/>
-            </a:pPr>
-            <a:r>
-              <a:rPr lang="en-US" sz="1200" dirty="0">
-                <a:solidFill>
-                  <a:srgbClr val="52514E"/>
-                </a:solidFill>
-                <a:latin typeface="Calibri" pitchFamily="34" charset="0"/>
-                <a:ea typeface="Calibri" pitchFamily="34" charset="-122"/>
-                <a:cs typeface="Calibri" pitchFamily="34" charset="-120"/>
-              </a:rPr>
-              <a:t>Staff &amp; headcount · utilization by person · sales by customer</a:t>
-            </a:r>
-            <a:endParaRPr lang="en-US" sz="1200" dirty="0"/>
-          </a:p>
-        </p:txBody>
-      </p:sp>
-      <p:sp>
-        <p:nvSpPr>
-          <p:cNvPr id="12" name="Shape 10"/>
-          <p:cNvSpPr/>
-          <p:nvPr/>
-        </p:nvSpPr>
-        <p:spPr>
-          <a:xfrm>
-            <a:off x="548640" y="3054096"/>
-            <a:ext cx="402336" cy="402336"/>
-          </a:xfrm>
-          <a:prstGeom prst="ellipse">
-            <a:avLst/>
-          </a:prstGeom>
-          <a:solidFill>
-            <a:srgbClr val="2A78D6"/>
-          </a:solidFill>
-          <a:ln/>
-        </p:spPr>
-      </p:sp>
-      <p:sp>
-        <p:nvSpPr>
-          <p:cNvPr id="13" name="Text 11"/>
-          <p:cNvSpPr/>
-          <p:nvPr/>
-        </p:nvSpPr>
-        <p:spPr>
-          <a:xfrm>
-            <a:off x="548640" y="3054096"/>
-            <a:ext cx="402336" cy="402336"/>
-          </a:xfrm>
-          <a:prstGeom prst="rect">
-            <a:avLst/>
-          </a:prstGeom>
-          <a:noFill/>
-          <a:ln/>
-        </p:spPr>
-        <p:txBody>
-          <a:bodyPr wrap="square" lIns="0" tIns="0" rIns="0" bIns="0" rtlCol="0" anchor="ctr"/>
-          <a:lstStyle/>
-          <a:p>
-            <a:pPr algn="ctr" indent="0" marL="0">
-              <a:buNone/>
-            </a:pPr>
-            <a:r>
-              <a:rPr lang="en-US" sz="1500" b="1" dirty="0">
-                <a:solidFill>
-                  <a:srgbClr val="FFFFFF"/>
-                </a:solidFill>
-                <a:latin typeface="Calibri" pitchFamily="34" charset="0"/>
-                <a:ea typeface="Calibri" pitchFamily="34" charset="-122"/>
-                <a:cs typeface="Calibri" pitchFamily="34" charset="-120"/>
-              </a:rPr>
-              <a:t>3</a:t>
-            </a:r>
-            <a:endParaRPr lang="en-US" sz="1500" dirty="0"/>
-          </a:p>
-        </p:txBody>
-      </p:sp>
-      <p:sp>
-        <p:nvSpPr>
-          <p:cNvPr id="14" name="Text 12"/>
-          <p:cNvSpPr/>
-          <p:nvPr/>
-        </p:nvSpPr>
-        <p:spPr>
-          <a:xfrm>
-            <a:off x="1188720" y="3035808"/>
-            <a:ext cx="3383280" cy="411480"/>
-          </a:xfrm>
-          <a:prstGeom prst="rect">
-            <a:avLst/>
-          </a:prstGeom>
-          <a:noFill/>
-          <a:ln/>
-        </p:spPr>
-        <p:txBody>
-          <a:bodyPr wrap="square" lIns="0" tIns="0" rIns="0" bIns="0" rtlCol="0" anchor="ctr"/>
-          <a:lstStyle/>
-          <a:p>
-            <a:pPr indent="0" marL="0">
-              <a:buNone/>
-            </a:pPr>
-            <a:r>
-              <a:rPr lang="en-US" sz="1650" b="1" dirty="0">
-                <a:solidFill>
-                  <a:srgbClr val="0B0B0B"/>
-                </a:solidFill>
-                <a:latin typeface="Calibri" pitchFamily="34" charset="0"/>
-                <a:ea typeface="Calibri" pitchFamily="34" charset="-122"/>
-                <a:cs typeface="Calibri" pitchFamily="34" charset="-120"/>
-              </a:rPr>
-              <a:t>Work in hand &amp; work to win</a:t>
-            </a:r>
-            <a:endParaRPr lang="en-US" sz="1650" dirty="0"/>
-          </a:p>
-        </p:txBody>
-      </p:sp>
-      <p:sp>
-        <p:nvSpPr>
-          <p:cNvPr id="15" name="Text 13"/>
-          <p:cNvSpPr/>
-          <p:nvPr/>
-        </p:nvSpPr>
-        <p:spPr>
-          <a:xfrm>
-            <a:off x="4754880" y="3035808"/>
-            <a:ext cx="6858000" cy="411480"/>
-          </a:xfrm>
-          <a:prstGeom prst="rect">
-            <a:avLst/>
-          </a:prstGeom>
-          <a:noFill/>
-          <a:ln/>
-        </p:spPr>
-        <p:txBody>
-          <a:bodyPr wrap="square" lIns="0" tIns="0" rIns="0" bIns="0" rtlCol="0" anchor="ctr"/>
-          <a:lstStyle/>
-          <a:p>
-            <a:pPr indent="0" marL="0">
-              <a:buNone/>
-            </a:pPr>
-            <a:r>
-              <a:rPr lang="en-US" sz="1200" dirty="0">
-                <a:solidFill>
-                  <a:srgbClr val="52514E"/>
-                </a:solidFill>
-                <a:latin typeface="Calibri" pitchFamily="34" charset="0"/>
-                <a:ea typeface="Calibri" pitchFamily="34" charset="-122"/>
-                <a:cs typeface="Calibri" pitchFamily="34" charset="-120"/>
-              </a:rPr>
-              <a:t>Backlog on active jobs · known pipeline opportunities</a:t>
-            </a:r>
-            <a:endParaRPr lang="en-US" sz="1200" dirty="0"/>
-          </a:p>
-        </p:txBody>
-      </p:sp>
-      <p:sp>
-        <p:nvSpPr>
-          <p:cNvPr id="16" name="Shape 14"/>
-          <p:cNvSpPr/>
-          <p:nvPr/>
-        </p:nvSpPr>
-        <p:spPr>
-          <a:xfrm>
-            <a:off x="548640" y="3840480"/>
-            <a:ext cx="402336" cy="402336"/>
-          </a:xfrm>
-          <a:prstGeom prst="ellipse">
-            <a:avLst/>
-          </a:prstGeom>
-          <a:solidFill>
-            <a:srgbClr val="2A78D6"/>
-          </a:solidFill>
-          <a:ln/>
-        </p:spPr>
-      </p:sp>
-      <p:sp>
-        <p:nvSpPr>
-          <p:cNvPr id="17" name="Text 15"/>
-          <p:cNvSpPr/>
-          <p:nvPr/>
-        </p:nvSpPr>
-        <p:spPr>
-          <a:xfrm>
-            <a:off x="548640" y="3840480"/>
-            <a:ext cx="402336" cy="402336"/>
-          </a:xfrm>
-          <a:prstGeom prst="rect">
-            <a:avLst/>
-          </a:prstGeom>
-          <a:noFill/>
-          <a:ln/>
-        </p:spPr>
-        <p:txBody>
-          <a:bodyPr wrap="square" lIns="0" tIns="0" rIns="0" bIns="0" rtlCol="0" anchor="ctr"/>
-          <a:lstStyle/>
-          <a:p>
-            <a:pPr algn="ctr" indent="0" marL="0">
-              <a:buNone/>
-            </a:pPr>
-            <a:r>
-              <a:rPr lang="en-US" sz="1500" b="1" dirty="0">
-                <a:solidFill>
-                  <a:srgbClr val="FFFFFF"/>
-                </a:solidFill>
-                <a:latin typeface="Calibri" pitchFamily="34" charset="0"/>
-                <a:ea typeface="Calibri" pitchFamily="34" charset="-122"/>
-                <a:cs typeface="Calibri" pitchFamily="34" charset="-120"/>
-              </a:rPr>
-              <a:t>4</a:t>
-            </a:r>
-            <a:endParaRPr lang="en-US" sz="1500" dirty="0"/>
-          </a:p>
-        </p:txBody>
-      </p:sp>
-      <p:sp>
-        <p:nvSpPr>
-          <p:cNvPr id="18" name="Text 16"/>
-          <p:cNvSpPr/>
-          <p:nvPr/>
-        </p:nvSpPr>
-        <p:spPr>
-          <a:xfrm>
-            <a:off x="1188720" y="3822192"/>
-            <a:ext cx="3383280" cy="411480"/>
-          </a:xfrm>
-          <a:prstGeom prst="rect">
-            <a:avLst/>
-          </a:prstGeom>
-          <a:noFill/>
-          <a:ln/>
-        </p:spPr>
-        <p:txBody>
-          <a:bodyPr wrap="square" lIns="0" tIns="0" rIns="0" bIns="0" rtlCol="0" anchor="ctr"/>
-          <a:lstStyle/>
-          <a:p>
-            <a:pPr indent="0" marL="0">
-              <a:buNone/>
-            </a:pPr>
-            <a:r>
-              <a:rPr lang="en-US" sz="1650" b="1" dirty="0">
-                <a:solidFill>
-                  <a:srgbClr val="0B0B0B"/>
-                </a:solidFill>
-                <a:latin typeface="Calibri" pitchFamily="34" charset="0"/>
-                <a:ea typeface="Calibri" pitchFamily="34" charset="-122"/>
-                <a:cs typeface="Calibri" pitchFamily="34" charset="-120"/>
-              </a:rPr>
-              <a:t>Strategy</a:t>
-            </a:r>
-            <a:endParaRPr lang="en-US" sz="1650" dirty="0"/>
-          </a:p>
-        </p:txBody>
-      </p:sp>
-      <p:sp>
-        <p:nvSpPr>
-          <p:cNvPr id="19" name="Text 17"/>
-          <p:cNvSpPr/>
-          <p:nvPr/>
-        </p:nvSpPr>
-        <p:spPr>
-          <a:xfrm>
-            <a:off x="4754880" y="3822192"/>
-            <a:ext cx="6858000" cy="411480"/>
-          </a:xfrm>
-          <a:prstGeom prst="rect">
-            <a:avLst/>
-          </a:prstGeom>
-          <a:noFill/>
-          <a:ln/>
-        </p:spPr>
-        <p:txBody>
-          <a:bodyPr wrap="square" lIns="0" tIns="0" rIns="0" bIns="0" rtlCol="0" anchor="ctr"/>
-          <a:lstStyle/>
-          <a:p>
-            <a:pPr indent="0" marL="0">
-              <a:buNone/>
-            </a:pPr>
-            <a:r>
-              <a:rPr lang="en-US" sz="1200" dirty="0">
-                <a:solidFill>
-                  <a:srgbClr val="52514E"/>
-                </a:solidFill>
-                <a:latin typeface="Calibri" pitchFamily="34" charset="0"/>
-                <a:ea typeface="Calibri" pitchFamily="34" charset="-122"/>
-                <a:cs typeface="Calibri" pitchFamily="34" charset="-120"/>
-              </a:rPr>
-              <a:t>One pursuit engine with HWC Estimating · the consolidated EPC offering · the addressable market · national expansion targets · BD account ownership</a:t>
-            </a:r>
-            <a:endParaRPr lang="en-US" sz="1200" dirty="0"/>
-          </a:p>
-        </p:txBody>
-      </p:sp>
-      <p:sp>
-        <p:nvSpPr>
-          <p:cNvPr id="20" name="Shape 18"/>
-          <p:cNvSpPr/>
-          <p:nvPr/>
-        </p:nvSpPr>
-        <p:spPr>
-          <a:xfrm>
-            <a:off x="548640" y="4626864"/>
-            <a:ext cx="402336" cy="402336"/>
-          </a:xfrm>
-          <a:prstGeom prst="ellipse">
-            <a:avLst/>
-          </a:prstGeom>
-          <a:solidFill>
-            <a:srgbClr val="2A78D6"/>
-          </a:solidFill>
-          <a:ln/>
-        </p:spPr>
-      </p:sp>
-      <p:sp>
-        <p:nvSpPr>
-          <p:cNvPr id="21" name="Text 19"/>
-          <p:cNvSpPr/>
-          <p:nvPr/>
-        </p:nvSpPr>
-        <p:spPr>
-          <a:xfrm>
-            <a:off x="548640" y="4626864"/>
-            <a:ext cx="402336" cy="402336"/>
-          </a:xfrm>
-          <a:prstGeom prst="rect">
-            <a:avLst/>
-          </a:prstGeom>
-          <a:noFill/>
-          <a:ln/>
-        </p:spPr>
-        <p:txBody>
-          <a:bodyPr wrap="square" lIns="0" tIns="0" rIns="0" bIns="0" rtlCol="0" anchor="ctr"/>
-          <a:lstStyle/>
-          <a:p>
-            <a:pPr algn="ctr" indent="0" marL="0">
-              <a:buNone/>
-            </a:pPr>
-            <a:r>
-              <a:rPr lang="en-US" sz="1500" b="1" dirty="0">
-                <a:solidFill>
-                  <a:srgbClr val="FFFFFF"/>
-                </a:solidFill>
-                <a:latin typeface="Calibri" pitchFamily="34" charset="0"/>
-                <a:ea typeface="Calibri" pitchFamily="34" charset="-122"/>
-                <a:cs typeface="Calibri" pitchFamily="34" charset="-120"/>
-              </a:rPr>
-              <a:t>5</a:t>
-            </a:r>
-            <a:endParaRPr lang="en-US" sz="1500" dirty="0"/>
-          </a:p>
-        </p:txBody>
-      </p:sp>
-      <p:sp>
-        <p:nvSpPr>
-          <p:cNvPr id="22" name="Text 20"/>
-          <p:cNvSpPr/>
-          <p:nvPr/>
-        </p:nvSpPr>
-        <p:spPr>
-          <a:xfrm>
-            <a:off x="1188720" y="4608576"/>
-            <a:ext cx="3383280" cy="411480"/>
-          </a:xfrm>
-          <a:prstGeom prst="rect">
-            <a:avLst/>
-          </a:prstGeom>
-          <a:noFill/>
-          <a:ln/>
-        </p:spPr>
-        <p:txBody>
-          <a:bodyPr wrap="square" lIns="0" tIns="0" rIns="0" bIns="0" rtlCol="0" anchor="ctr"/>
-          <a:lstStyle/>
-          <a:p>
-            <a:pPr indent="0" marL="0">
-              <a:buNone/>
-            </a:pPr>
-            <a:r>
-              <a:rPr lang="en-US" sz="1650" b="1" dirty="0">
-                <a:solidFill>
-                  <a:srgbClr val="0B0B0B"/>
-                </a:solidFill>
-                <a:latin typeface="Calibri" pitchFamily="34" charset="0"/>
-                <a:ea typeface="Calibri" pitchFamily="34" charset="-122"/>
-                <a:cs typeface="Calibri" pitchFamily="34" charset="-120"/>
-              </a:rPr>
-              <a:t>Forward view</a:t>
-            </a:r>
-            <a:endParaRPr lang="en-US" sz="1650" dirty="0"/>
-          </a:p>
-        </p:txBody>
-      </p:sp>
-      <p:sp>
-        <p:nvSpPr>
-          <p:cNvPr id="23" name="Text 21"/>
-          <p:cNvSpPr/>
-          <p:nvPr/>
-        </p:nvSpPr>
-        <p:spPr>
-          <a:xfrm>
-            <a:off x="4754880" y="4608576"/>
-            <a:ext cx="6858000" cy="411480"/>
-          </a:xfrm>
-          <a:prstGeom prst="rect">
-            <a:avLst/>
-          </a:prstGeom>
-          <a:noFill/>
-          <a:ln/>
-        </p:spPr>
-        <p:txBody>
-          <a:bodyPr wrap="square" lIns="0" tIns="0" rIns="0" bIns="0" rtlCol="0" anchor="ctr"/>
-          <a:lstStyle/>
-          <a:p>
-            <a:pPr indent="0" marL="0">
-              <a:buNone/>
-            </a:pPr>
-            <a:r>
-              <a:rPr lang="en-US" sz="1200" dirty="0">
-                <a:solidFill>
-                  <a:srgbClr val="52514E"/>
-                </a:solidFill>
-                <a:latin typeface="Calibri" pitchFamily="34" charset="0"/>
-                <a:ea typeface="Calibri" pitchFamily="34" charset="-122"/>
-                <a:cs typeface="Calibri" pitchFamily="34" charset="-120"/>
-              </a:rPr>
-              <a:t>Forecast &amp; coverage · FY2026 landing and FY2027 scenarios · EPC accounting alignment</a:t>
-            </a:r>
-            <a:endParaRPr lang="en-US" sz="1200" dirty="0"/>
-          </a:p>
-        </p:txBody>
-      </p:sp>
-      <p:sp>
-        <p:nvSpPr>
-          <p:cNvPr id="24" name="Shape 22"/>
-          <p:cNvSpPr/>
-          <p:nvPr/>
-        </p:nvSpPr>
-        <p:spPr>
-          <a:xfrm>
-            <a:off x="548640" y="5413248"/>
-            <a:ext cx="402336" cy="402336"/>
-          </a:xfrm>
-          <a:prstGeom prst="ellipse">
-            <a:avLst/>
-          </a:prstGeom>
-          <a:solidFill>
-            <a:srgbClr val="2A78D6"/>
-          </a:solidFill>
-          <a:ln/>
-        </p:spPr>
-      </p:sp>
-      <p:sp>
-        <p:nvSpPr>
-          <p:cNvPr id="25" name="Text 23"/>
-          <p:cNvSpPr/>
-          <p:nvPr/>
-        </p:nvSpPr>
-        <p:spPr>
-          <a:xfrm>
-            <a:off x="548640" y="5413248"/>
-            <a:ext cx="402336" cy="402336"/>
-          </a:xfrm>
-          <a:prstGeom prst="rect">
-            <a:avLst/>
-          </a:prstGeom>
-          <a:noFill/>
-          <a:ln/>
-        </p:spPr>
-        <p:txBody>
-          <a:bodyPr wrap="square" lIns="0" tIns="0" rIns="0" bIns="0" rtlCol="0" anchor="ctr"/>
-          <a:lstStyle/>
-          <a:p>
-            <a:pPr algn="ctr" indent="0" marL="0">
-              <a:buNone/>
-            </a:pPr>
-            <a:r>
-              <a:rPr lang="en-US" sz="1500" b="1" dirty="0">
-                <a:solidFill>
-                  <a:srgbClr val="FFFFFF"/>
-                </a:solidFill>
-                <a:latin typeface="Calibri" pitchFamily="34" charset="0"/>
-                <a:ea typeface="Calibri" pitchFamily="34" charset="-122"/>
-                <a:cs typeface="Calibri" pitchFamily="34" charset="-120"/>
-              </a:rPr>
-              <a:t>6</a:t>
-            </a:r>
-            <a:endParaRPr lang="en-US" sz="1500" dirty="0"/>
-          </a:p>
-        </p:txBody>
-      </p:sp>
-      <p:sp>
-        <p:nvSpPr>
-          <p:cNvPr id="26" name="Text 24"/>
-          <p:cNvSpPr/>
-          <p:nvPr/>
-        </p:nvSpPr>
-        <p:spPr>
-          <a:xfrm>
-            <a:off x="1188720" y="5394960"/>
-            <a:ext cx="3383280" cy="411480"/>
-          </a:xfrm>
-          <a:prstGeom prst="rect">
-            <a:avLst/>
-          </a:prstGeom>
-          <a:noFill/>
-          <a:ln/>
-        </p:spPr>
-        <p:txBody>
-          <a:bodyPr wrap="square" lIns="0" tIns="0" rIns="0" bIns="0" rtlCol="0" anchor="ctr"/>
-          <a:lstStyle/>
-          <a:p>
-            <a:pPr indent="0" marL="0">
-              <a:buNone/>
-            </a:pPr>
-            <a:r>
-              <a:rPr lang="en-US" sz="1650" b="1" dirty="0">
-                <a:solidFill>
-                  <a:srgbClr val="0B0B0B"/>
-                </a:solidFill>
-                <a:latin typeface="Calibri" pitchFamily="34" charset="0"/>
-                <a:ea typeface="Calibri" pitchFamily="34" charset="-122"/>
-                <a:cs typeface="Calibri" pitchFamily="34" charset="-120"/>
-              </a:rPr>
-              <a:t>Next 90 days</a:t>
-            </a:r>
-            <a:endParaRPr lang="en-US" sz="1650" dirty="0"/>
-          </a:p>
-        </p:txBody>
-      </p:sp>
-      <p:sp>
-        <p:nvSpPr>
-          <p:cNvPr id="27" name="Text 25"/>
-          <p:cNvSpPr/>
-          <p:nvPr/>
-        </p:nvSpPr>
-        <p:spPr>
-          <a:xfrm>
-            <a:off x="4754880" y="5394960"/>
-            <a:ext cx="6858000" cy="411480"/>
-          </a:xfrm>
-          <a:prstGeom prst="rect">
-            <a:avLst/>
-          </a:prstGeom>
-          <a:noFill/>
-          <a:ln/>
-        </p:spPr>
-        <p:txBody>
-          <a:bodyPr wrap="square" lIns="0" tIns="0" rIns="0" bIns="0" rtlCol="0" anchor="ctr"/>
-          <a:lstStyle/>
-          <a:p>
-            <a:pPr indent="0" marL="0">
-              <a:buNone/>
-            </a:pPr>
-            <a:r>
-              <a:rPr lang="en-US" sz="1200" dirty="0">
-                <a:solidFill>
-                  <a:srgbClr val="52514E"/>
-                </a:solidFill>
-                <a:latin typeface="Calibri" pitchFamily="34" charset="0"/>
-                <a:ea typeface="Calibri" pitchFamily="34" charset="-122"/>
-                <a:cs typeface="Calibri" pitchFamily="34" charset="-120"/>
-              </a:rPr>
-              <a:t>Priorities: realization, utilization, the Q4 pipeline, and the monthly rhythm</a:t>
-            </a:r>
-            <a:endParaRPr lang="en-US" sz="1200" dirty="0"/>
-          </a:p>
-        </p:txBody>
-      </p:sp>
-      <p:sp>
-        <p:nvSpPr>
-          <p:cNvPr id="28" name="Text 26"/>
-          <p:cNvSpPr/>
-          <p:nvPr/>
-        </p:nvSpPr>
-        <p:spPr>
-          <a:xfrm>
-            <a:off x="548640" y="6419088"/>
-            <a:ext cx="11064240" cy="320040"/>
-          </a:xfrm>
-          <a:prstGeom prst="rect">
-            <a:avLst/>
-          </a:prstGeom>
-          <a:noFill/>
-          <a:ln/>
-        </p:spPr>
-        <p:txBody>
-          <a:bodyPr wrap="square" lIns="0" tIns="0" rIns="0" bIns="0" rtlCol="0" anchor="ctr"/>
-          <a:lstStyle/>
-          <a:p>
-            <a:pPr indent="0" marL="0">
-              <a:buNone/>
-            </a:pPr>
-            <a:r>
-              <a:rPr lang="en-US" sz="950" dirty="0">
-                <a:solidFill>
-                  <a:srgbClr val="898781"/>
-                </a:solidFill>
-                <a:latin typeface="Calibri" pitchFamily="34" charset="0"/>
-                <a:ea typeface="Calibri" pitchFamily="34" charset="-122"/>
-                <a:cs typeface="Calibri" pitchFamily="34" charset="-120"/>
-              </a:rPr>
-              <a:t>CVR Engineering financial review &amp; forecast · June 2026</a:t>
-            </a:r>
-            <a:endParaRPr lang="en-US" sz="950" dirty="0"/>
-          </a:p>
-        </p:txBody>
-      </p:sp>
-    </p:spTree>
-  </p:cSld>
-  <p:clrMapOvr>
-    <a:masterClrMapping/>
-  </p:clrMapOvr>
-</p:sld>
-</file>
-
-<file path=ppt/slides/slide20.xml><?xml version="1.0" encoding="utf-8"?>
-<p:sld xmlns:a="http://schemas.openxmlformats.org/drawingml/2006/main" xmlns:r="http://schemas.openxmlformats.org/officeDocument/2006/relationships" xmlns:p="http://schemas.openxmlformats.org/presentationml/2006/main">
-  <p:cSld name="Slide 20">
+  <p:cSld name="Slide 21">
     <p:spTree>
       <p:nvGrpSpPr>
         <p:cNvPr id="1" name=""/>
@@ -25448,9 +25717,9 @@
 </p:sld>
 </file>
 
-<file path=ppt/slides/slide21.xml><?xml version="1.0" encoding="utf-8"?>
+<file path=ppt/slides/slide22.xml><?xml version="1.0" encoding="utf-8"?>
 <p:sld xmlns:a="http://schemas.openxmlformats.org/drawingml/2006/main" xmlns:r="http://schemas.openxmlformats.org/officeDocument/2006/relationships" xmlns:p="http://schemas.openxmlformats.org/presentationml/2006/main">
-  <p:cSld name="Slide 21">
+  <p:cSld name="Slide 22">
     <p:bg>
       <p:bgPr>
         <a:solidFill>

</xml_diff>

<commit_message>
Add EPC at-scale (material-margin) business model to model + deck
Model a future-state where CVR performs $150M/yr EPC and captures the
engineering scope plus material margin while HWC keeps equipment and labor
margin. New 'EPC At-Scale Model' tab (drivers, material + engineering P&L,
combined CVR economics, per-project illustration, sensitivity grid) in the
Phase 2 workbook; new deck slide with the value-split bar and headline
economics (~$18.8M managed revenue, ~$7.6M operating income, 6.3x the goal).
Drivers: 35% materials share, 13% material margin (net ~2 pts carry), 8%
engineering pull-through. Documented in PHASE2_FORECAST.md.
</commit_message>
<xml_diff>
--- a/reports/CVR_Deck_Jun2026.pptx
+++ b/reports/CVR_Deck_Jun2026.pptx
@@ -27,9 +27,10 @@
     <p:sldId id="275" r:id="rId21"/>
     <p:sldId id="276" r:id="rId22"/>
     <p:sldId id="277" r:id="rId23"/>
+    <p:sldId id="278" r:id="rId24"/>
   </p:sldIdLst>
   <p:notesMasterIdLst>
-    <p:notesMasterId r:id="rId24"/>
+    <p:notesMasterId r:id="rId25"/>
   </p:notesMasterIdLst>
   <p:sldSz cx="12192000" cy="6858000"/>
   <p:notesSz cx="6858000" cy="12192000"/>
@@ -1779,6 +1780,94 @@
             <a:fld id="{F7021451-1387-4CA6-816F-3879F97B5CBC}" type="slidenum">
               <a:rPr lang="en-US"/>
               <a:t>22</a:t>
+            </a:fld>
+            <a:endParaRPr lang="en-US"/>
+          </a:p>
+        </p:txBody>
+      </p:sp>
+    </p:spTree>
+    <p:extLst>
+      <p:ext uri="{BB962C8B-B14F-4D97-AF65-F5344CB8AC3E}">
+        <p14:creationId xmlns:p14="http://schemas.microsoft.com/office/powerpoint/2010/main" val="1024086991"/>
+      </p:ext>
+    </p:extLst>
+  </p:cSld>
+  <p:clrMapOvr>
+    <a:masterClrMapping/>
+  </p:clrMapOvr>
+</p:notes>
+</file>
+
+<file path=ppt/notesSlides/notesSlide23.xml><?xml version="1.0" encoding="utf-8"?>
+<p:notes xmlns:a="http://schemas.openxmlformats.org/drawingml/2006/main" xmlns:r="http://schemas.openxmlformats.org/officeDocument/2006/relationships" xmlns:p="http://schemas.openxmlformats.org/presentationml/2006/main">
+  <p:cSld>
+    <p:spTree>
+      <p:nvGrpSpPr>
+        <p:cNvPr id="1" name=""/>
+        <p:cNvGrpSpPr/>
+        <p:nvPr/>
+      </p:nvGrpSpPr>
+      <p:grpSpPr>
+        <a:xfrm>
+          <a:off x="0" y="0"/>
+          <a:ext cx="0" cy="0"/>
+          <a:chOff x="0" y="0"/>
+          <a:chExt cx="0" cy="0"/>
+        </a:xfrm>
+      </p:grpSpPr>
+      <p:sp>
+        <p:nvSpPr>
+          <p:cNvPr id="2" name="Slide Image Placeholder 1"/>
+          <p:cNvSpPr>
+            <a:spLocks noGrp="1" noRot="1" noChangeAspect="1"/>
+          </p:cNvSpPr>
+          <p:nvPr>
+            <p:ph type="sldImg"/>
+          </p:nvPr>
+        </p:nvSpPr>
+        <p:spPr/>
+      </p:sp>
+      <p:sp>
+        <p:nvSpPr>
+          <p:cNvPr id="3" name="Notes Placeholder 2"/>
+          <p:cNvSpPr>
+            <a:spLocks noGrp="1"/>
+          </p:cNvSpPr>
+          <p:nvPr>
+            <p:ph type="body" idx="1"/>
+          </p:nvPr>
+        </p:nvSpPr>
+        <p:spPr/>
+        <p:txBody>
+          <a:bodyPr/>
+          <a:lstStyle/>
+          <a:p>
+            <a:r>
+              <a:rPr lang="en-US" dirty="0"/>
+              <a:t/>
+            </a:r>
+            <a:endParaRPr lang="en-US" dirty="0"/>
+          </a:p>
+        </p:txBody>
+      </p:sp>
+      <p:sp>
+        <p:nvSpPr>
+          <p:cNvPr id="4" name="Slide Number Placeholder 3"/>
+          <p:cNvSpPr>
+            <a:spLocks noGrp="1"/>
+          </p:cNvSpPr>
+          <p:nvPr>
+            <p:ph type="sldNum" sz="quarter" idx="10"/>
+          </p:nvPr>
+        </p:nvSpPr>
+        <p:spPr/>
+        <p:txBody>
+          <a:bodyPr/>
+          <a:lstStyle/>
+          <a:p>
+            <a:fld id="{F7021451-1387-4CA6-816F-3879F97B5CBC}" type="slidenum">
+              <a:rPr lang="en-US"/>
+              <a:t>23</a:t>
             </a:fld>
             <a:endParaRPr lang="en-US"/>
           </a:p>
@@ -24682,7 +24771,7 @@
                 <a:ea typeface="Calibri" pitchFamily="34" charset="-122"/>
                 <a:cs typeface="Calibri" pitchFamily="34" charset="-120"/>
               </a:rPr>
-              <a:t>FORWARD VIEW — ACCOUNTING ALIGNMENT</a:t>
+              <a:t>STRATEGY — THE REVISED BUSINESS MODEL</a:t>
             </a:r>
             <a:endParaRPr lang="en-US" sz="1100" dirty="0"/>
           </a:p>
@@ -24721,7 +24810,7 @@
                 <a:ea typeface="Calibri" pitchFamily="34" charset="-122"/>
                 <a:cs typeface="Calibri" pitchFamily="34" charset="-120"/>
               </a:rPr>
-              <a:t>EPC bid engineering: an item to clean up, not a crisis</a:t>
+              <a:t>At scale: CVR earns engineering + material margin</a:t>
             </a:r>
             <a:endParaRPr lang="en-US" sz="2700" dirty="0"/>
           </a:p>
@@ -24735,8 +24824,8 @@
         </p:nvSpPr>
         <p:spPr>
           <a:xfrm>
-            <a:off x="548640" y="1371600"/>
-            <a:ext cx="4572000" cy="320040"/>
+            <a:off x="548640" y="1207008"/>
+            <a:ext cx="11064240" cy="365760"/>
           </a:xfrm>
           <a:prstGeom prst="rect">
             <a:avLst/>
@@ -24752,7 +24841,7 @@
               <a:buNone/>
             </a:pPr>
             <a:r>
-              <a:rPr lang="en-US" sz="1600" b="1" dirty="0">
+              <a:rPr lang="en-US" sz="1400" dirty="0">
                 <a:solidFill>
                   <a:srgbClr val="0B0B0B"/>
                 </a:solidFill>
@@ -24760,9 +24849,65 @@
                 <a:ea typeface="Calibri" pitchFamily="34" charset="-122"/>
                 <a:cs typeface="Calibri" pitchFamily="34" charset="-120"/>
               </a:rPr>
-              <a:t>The facts</a:t>
-            </a:r>
-            <a:endParaRPr lang="en-US" sz="1600" dirty="0"/>
+              <a:t>Perform ~$150M of EPC a year and CVR captures the </a:t>
+            </a:r>
+            <a:pPr indent="0" marL="0">
+              <a:buNone/>
+            </a:pPr>
+            <a:r>
+              <a:rPr lang="en-US" sz="1400" b="1" dirty="0">
+                <a:solidFill>
+                  <a:srgbClr val="2A78D6"/>
+                </a:solidFill>
+                <a:latin typeface="Calibri" pitchFamily="34" charset="0"/>
+                <a:ea typeface="Calibri" pitchFamily="34" charset="-122"/>
+                <a:cs typeface="Calibri" pitchFamily="34" charset="-120"/>
+              </a:rPr>
+              <a:t>engineering scope</a:t>
+            </a:r>
+            <a:pPr indent="0" marL="0">
+              <a:buNone/>
+            </a:pPr>
+            <a:r>
+              <a:rPr lang="en-US" sz="1400" dirty="0">
+                <a:solidFill>
+                  <a:srgbClr val="0B0B0B"/>
+                </a:solidFill>
+                <a:latin typeface="Calibri" pitchFamily="34" charset="0"/>
+                <a:ea typeface="Calibri" pitchFamily="34" charset="-122"/>
+                <a:cs typeface="Calibri" pitchFamily="34" charset="-120"/>
+              </a:rPr>
+              <a:t> and the </a:t>
+            </a:r>
+            <a:pPr indent="0" marL="0">
+              <a:buNone/>
+            </a:pPr>
+            <a:r>
+              <a:rPr lang="en-US" sz="1400" b="1" dirty="0">
+                <a:solidFill>
+                  <a:srgbClr val="006300"/>
+                </a:solidFill>
+                <a:latin typeface="Calibri" pitchFamily="34" charset="0"/>
+                <a:ea typeface="Calibri" pitchFamily="34" charset="-122"/>
+                <a:cs typeface="Calibri" pitchFamily="34" charset="-120"/>
+              </a:rPr>
+              <a:t>material margin</a:t>
+            </a:r>
+            <a:pPr indent="0" marL="0">
+              <a:buNone/>
+            </a:pPr>
+            <a:r>
+              <a:rPr lang="en-US" sz="1400" dirty="0">
+                <a:solidFill>
+                  <a:srgbClr val="0B0B0B"/>
+                </a:solidFill>
+                <a:latin typeface="Calibri" pitchFamily="34" charset="0"/>
+                <a:ea typeface="Calibri" pitchFamily="34" charset="-122"/>
+                <a:cs typeface="Calibri" pitchFamily="34" charset="-120"/>
+              </a:rPr>
+              <a:t> — while HWC keeps the equipment and the labor / construction margin.</a:t>
+            </a:r>
+            <a:endParaRPr lang="en-US" sz="1400" dirty="0"/>
           </a:p>
         </p:txBody>
       </p:sp>
@@ -24774,8 +24919,8 @@
         </p:nvSpPr>
         <p:spPr>
           <a:xfrm>
-            <a:off x="548640" y="1783080"/>
-            <a:ext cx="4572000" cy="329184"/>
+            <a:off x="548640" y="1810512"/>
+            <a:ext cx="11064240" cy="237744"/>
           </a:xfrm>
           <a:prstGeom prst="rect">
             <a:avLst/>
@@ -24791,17 +24936,17 @@
               <a:buNone/>
             </a:pPr>
             <a:r>
-              <a:rPr lang="en-US" sz="1700" b="1" dirty="0">
+              <a:rPr lang="en-US" sz="1050" b="1" spc="150" kern="0" dirty="0">
                 <a:solidFill>
-                  <a:srgbClr val="2A78D6"/>
+                  <a:srgbClr val="52514E"/>
                 </a:solidFill>
                 <a:latin typeface="Calibri" pitchFamily="34" charset="0"/>
                 <a:ea typeface="Calibri" pitchFamily="34" charset="-122"/>
                 <a:cs typeface="Calibri" pitchFamily="34" charset="-120"/>
               </a:rPr>
-              <a:t>405 hrs</a:t>
-            </a:r>
-            <a:endParaRPr lang="en-US" sz="1700" dirty="0"/>
+              <a:t>WHERE THE $150M/YR PROGRAM REVENUE FLOWS</a:t>
+            </a:r>
+            <a:endParaRPr lang="en-US" sz="1050" dirty="0"/>
           </a:p>
         </p:txBody>
       </p:sp>
@@ -24813,8 +24958,8 @@
         </p:nvSpPr>
         <p:spPr>
           <a:xfrm>
-            <a:off x="548640" y="2112264"/>
-            <a:ext cx="4572000" cy="658368"/>
+            <a:off x="548640" y="2084832"/>
+            <a:ext cx="11064240" cy="274320"/>
           </a:xfrm>
           <a:prstGeom prst="rect">
             <a:avLst/>
@@ -24830,7 +24975,7 @@
               <a:buNone/>
             </a:pPr>
             <a:r>
-              <a:rPr lang="en-US" sz="1050" dirty="0">
+              <a:rPr lang="en-US" sz="1200" dirty="0">
                 <a:solidFill>
                   <a:srgbClr val="52514E"/>
                 </a:solidFill>
@@ -24838,22 +24983,278 @@
                 <a:ea typeface="Calibri" pitchFamily="34" charset="-122"/>
                 <a:cs typeface="Calibri" pitchFamily="34" charset="-120"/>
               </a:rPr>
-              <a:t>of bid engineering YTD — ≈$62.6K at card rates ($38.5K at cost), unbilled</a:t>
-            </a:r>
-            <a:endParaRPr lang="en-US" sz="1050" dirty="0"/>
+              <a:t>CVR captures the blue + green bands — </a:t>
+            </a:r>
+            <a:pPr indent="0" marL="0">
+              <a:buNone/>
+            </a:pPr>
+            <a:r>
+              <a:rPr lang="en-US" sz="1200" b="1" dirty="0">
+                <a:solidFill>
+                  <a:srgbClr val="0B0B0B"/>
+                </a:solidFill>
+                <a:latin typeface="Calibri" pitchFamily="34" charset="0"/>
+                <a:ea typeface="Calibri" pitchFamily="34" charset="-122"/>
+                <a:cs typeface="Calibri" pitchFamily="34" charset="-120"/>
+              </a:rPr>
+              <a:t>$18.8M managed revenue (12.5% of the program).</a:t>
+            </a:r>
+            <a:endParaRPr lang="en-US" sz="1200" dirty="0"/>
           </a:p>
         </p:txBody>
       </p:sp>
       <p:sp>
         <p:nvSpPr>
-          <p:cNvPr id="7" name="Text 5"/>
+          <p:cNvPr id="7" name="Shape 5"/>
           <p:cNvSpPr/>
           <p:nvPr/>
         </p:nvSpPr>
         <p:spPr>
           <a:xfrm>
-            <a:off x="548640" y="2807208"/>
-            <a:ext cx="4572000" cy="329184"/>
+            <a:off x="548640" y="2487168"/>
+            <a:ext cx="885139" cy="822960"/>
+          </a:xfrm>
+          <a:prstGeom prst="rect">
+            <a:avLst/>
+          </a:prstGeom>
+          <a:solidFill>
+            <a:srgbClr val="2A78D6"/>
+          </a:solidFill>
+          <a:ln w="12700">
+            <a:solidFill>
+              <a:srgbClr val="FFFFFF"/>
+            </a:solidFill>
+            <a:prstDash val="solid"/>
+          </a:ln>
+        </p:spPr>
+      </p:sp>
+      <p:sp>
+        <p:nvSpPr>
+          <p:cNvPr id="8" name="Text 6"/>
+          <p:cNvSpPr/>
+          <p:nvPr/>
+        </p:nvSpPr>
+        <p:spPr>
+          <a:xfrm>
+            <a:off x="548640" y="2487168"/>
+            <a:ext cx="885139" cy="822960"/>
+          </a:xfrm>
+          <a:prstGeom prst="rect">
+            <a:avLst/>
+          </a:prstGeom>
+          <a:noFill/>
+          <a:ln/>
+        </p:spPr>
+        <p:txBody>
+          <a:bodyPr wrap="square" lIns="0" tIns="0" rIns="0" bIns="0" rtlCol="0" anchor="ctr"/>
+          <a:lstStyle/>
+          <a:p>
+            <a:pPr algn="ctr" indent="0" marL="0">
+              <a:buNone/>
+            </a:pPr>
+            <a:r>
+              <a:rPr lang="en-US" sz="1100" b="1" dirty="0">
+                <a:solidFill>
+                  <a:srgbClr val="FFFFFF"/>
+                </a:solidFill>
+                <a:latin typeface="Calibri" pitchFamily="34" charset="0"/>
+                <a:ea typeface="Calibri" pitchFamily="34" charset="-122"/>
+                <a:cs typeface="Calibri" pitchFamily="34" charset="-120"/>
+              </a:rPr>
+              <a:t>$12.0M</a:t>
+            </a:r>
+            <a:endParaRPr lang="en-US" sz="1100" dirty="0"/>
+          </a:p>
+        </p:txBody>
+      </p:sp>
+      <p:sp>
+        <p:nvSpPr>
+          <p:cNvPr id="9" name="Shape 7"/>
+          <p:cNvSpPr/>
+          <p:nvPr/>
+        </p:nvSpPr>
+        <p:spPr>
+          <a:xfrm>
+            <a:off x="1433779" y="2487168"/>
+            <a:ext cx="503423" cy="822960"/>
+          </a:xfrm>
+          <a:prstGeom prst="rect">
+            <a:avLst/>
+          </a:prstGeom>
+          <a:solidFill>
+            <a:srgbClr val="86B332"/>
+          </a:solidFill>
+          <a:ln w="12700">
+            <a:solidFill>
+              <a:srgbClr val="FFFFFF"/>
+            </a:solidFill>
+            <a:prstDash val="solid"/>
+          </a:ln>
+        </p:spPr>
+      </p:sp>
+      <p:sp>
+        <p:nvSpPr>
+          <p:cNvPr id="10" name="Shape 8"/>
+          <p:cNvSpPr/>
+          <p:nvPr/>
+        </p:nvSpPr>
+        <p:spPr>
+          <a:xfrm>
+            <a:off x="1937202" y="2487168"/>
+            <a:ext cx="3369061" cy="822960"/>
+          </a:xfrm>
+          <a:prstGeom prst="rect">
+            <a:avLst/>
+          </a:prstGeom>
+          <a:solidFill>
+            <a:srgbClr val="D8D6CE"/>
+          </a:solidFill>
+          <a:ln w="12700">
+            <a:solidFill>
+              <a:srgbClr val="FFFFFF"/>
+            </a:solidFill>
+            <a:prstDash val="solid"/>
+          </a:ln>
+        </p:spPr>
+      </p:sp>
+      <p:sp>
+        <p:nvSpPr>
+          <p:cNvPr id="11" name="Text 9"/>
+          <p:cNvSpPr/>
+          <p:nvPr/>
+        </p:nvSpPr>
+        <p:spPr>
+          <a:xfrm>
+            <a:off x="1937202" y="2487168"/>
+            <a:ext cx="3369061" cy="822960"/>
+          </a:xfrm>
+          <a:prstGeom prst="rect">
+            <a:avLst/>
+          </a:prstGeom>
+          <a:noFill/>
+          <a:ln/>
+        </p:spPr>
+        <p:txBody>
+          <a:bodyPr wrap="square" lIns="0" tIns="0" rIns="0" bIns="0" rtlCol="0" anchor="ctr"/>
+          <a:lstStyle/>
+          <a:p>
+            <a:pPr algn="ctr" indent="0" marL="0">
+              <a:buNone/>
+            </a:pPr>
+            <a:r>
+              <a:rPr lang="en-US" sz="1100" b="1" dirty="0">
+                <a:solidFill>
+                  <a:srgbClr val="0B0B0B"/>
+                </a:solidFill>
+                <a:latin typeface="Calibri" pitchFamily="34" charset="0"/>
+                <a:ea typeface="Calibri" pitchFamily="34" charset="-122"/>
+                <a:cs typeface="Calibri" pitchFamily="34" charset="-120"/>
+              </a:rPr>
+              <a:t>Materials at cost · $45.7M</a:t>
+            </a:r>
+            <a:endParaRPr lang="en-US" sz="1100" dirty="0"/>
+          </a:p>
+        </p:txBody>
+      </p:sp>
+      <p:sp>
+        <p:nvSpPr>
+          <p:cNvPr id="12" name="Shape 10"/>
+          <p:cNvSpPr/>
+          <p:nvPr/>
+        </p:nvSpPr>
+        <p:spPr>
+          <a:xfrm>
+            <a:off x="5306263" y="2487168"/>
+            <a:ext cx="6306617" cy="822960"/>
+          </a:xfrm>
+          <a:prstGeom prst="rect">
+            <a:avLst/>
+          </a:prstGeom>
+          <a:solidFill>
+            <a:srgbClr val="AEB4B9"/>
+          </a:solidFill>
+          <a:ln w="12700">
+            <a:solidFill>
+              <a:srgbClr val="FFFFFF"/>
+            </a:solidFill>
+            <a:prstDash val="solid"/>
+          </a:ln>
+        </p:spPr>
+      </p:sp>
+      <p:sp>
+        <p:nvSpPr>
+          <p:cNvPr id="13" name="Text 11"/>
+          <p:cNvSpPr/>
+          <p:nvPr/>
+        </p:nvSpPr>
+        <p:spPr>
+          <a:xfrm>
+            <a:off x="5306263" y="2487168"/>
+            <a:ext cx="6306617" cy="822960"/>
+          </a:xfrm>
+          <a:prstGeom prst="rect">
+            <a:avLst/>
+          </a:prstGeom>
+          <a:noFill/>
+          <a:ln/>
+        </p:spPr>
+        <p:txBody>
+          <a:bodyPr wrap="square" lIns="0" tIns="0" rIns="0" bIns="0" rtlCol="0" anchor="ctr"/>
+          <a:lstStyle/>
+          <a:p>
+            <a:pPr algn="ctr" indent="0" marL="0">
+              <a:buNone/>
+            </a:pPr>
+            <a:r>
+              <a:rPr lang="en-US" sz="1100" b="1" dirty="0">
+                <a:solidFill>
+                  <a:srgbClr val="FFFFFF"/>
+                </a:solidFill>
+                <a:latin typeface="Calibri" pitchFamily="34" charset="0"/>
+                <a:ea typeface="Calibri" pitchFamily="34" charset="-122"/>
+                <a:cs typeface="Calibri" pitchFamily="34" charset="-120"/>
+              </a:rPr>
+              <a:t>HWC — equipment + labor + construction · $85.5M</a:t>
+            </a:r>
+            <a:endParaRPr lang="en-US" sz="1100" dirty="0"/>
+          </a:p>
+        </p:txBody>
+      </p:sp>
+      <p:sp>
+        <p:nvSpPr>
+          <p:cNvPr id="14" name="Shape 12"/>
+          <p:cNvSpPr/>
+          <p:nvPr/>
+        </p:nvSpPr>
+        <p:spPr>
+          <a:xfrm>
+            <a:off x="548640" y="3538728"/>
+            <a:ext cx="182880" cy="182880"/>
+          </a:xfrm>
+          <a:prstGeom prst="rect">
+            <a:avLst/>
+          </a:prstGeom>
+          <a:solidFill>
+            <a:srgbClr val="2A78D6"/>
+          </a:solidFill>
+          <a:ln w="6350">
+            <a:solidFill>
+              <a:srgbClr val="E1E0D9"/>
+            </a:solidFill>
+            <a:prstDash val="solid"/>
+          </a:ln>
+        </p:spPr>
+      </p:sp>
+      <p:sp>
+        <p:nvSpPr>
+          <p:cNvPr id="15" name="Text 13"/>
+          <p:cNvSpPr/>
+          <p:nvPr/>
+        </p:nvSpPr>
+        <p:spPr>
+          <a:xfrm>
+            <a:off x="822960" y="3493008"/>
+            <a:ext cx="5212080" cy="274320"/>
           </a:xfrm>
           <a:prstGeom prst="rect">
             <a:avLst/>
@@ -24869,30 +25270,55 @@
               <a:buNone/>
             </a:pPr>
             <a:r>
-              <a:rPr lang="en-US" sz="1700" b="1" dirty="0">
+              <a:rPr lang="en-US" sz="1150" dirty="0">
                 <a:solidFill>
-                  <a:srgbClr val="2A78D6"/>
+                  <a:srgbClr val="52514E"/>
                 </a:solidFill>
                 <a:latin typeface="Calibri" pitchFamily="34" charset="0"/>
                 <a:ea typeface="Calibri" pitchFamily="34" charset="-122"/>
                 <a:cs typeface="Calibri" pitchFamily="34" charset="-120"/>
               </a:rPr>
-              <a:t>~60% design</a:t>
-            </a:r>
-            <a:endParaRPr lang="en-US" sz="1700" dirty="0"/>
+              <a:t>CVR engineering — $12.0M (8%)</a:t>
+            </a:r>
+            <a:endParaRPr lang="en-US" sz="1150" dirty="0"/>
           </a:p>
         </p:txBody>
       </p:sp>
       <p:sp>
         <p:nvSpPr>
-          <p:cNvPr id="8" name="Text 6"/>
+          <p:cNvPr id="16" name="Shape 14"/>
           <p:cNvSpPr/>
           <p:nvPr/>
         </p:nvSpPr>
         <p:spPr>
           <a:xfrm>
-            <a:off x="548640" y="3136392"/>
-            <a:ext cx="4572000" cy="658368"/>
+            <a:off x="6172200" y="3538728"/>
+            <a:ext cx="182880" cy="182880"/>
+          </a:xfrm>
+          <a:prstGeom prst="rect">
+            <a:avLst/>
+          </a:prstGeom>
+          <a:solidFill>
+            <a:srgbClr val="86B332"/>
+          </a:solidFill>
+          <a:ln w="6350">
+            <a:solidFill>
+              <a:srgbClr val="E1E0D9"/>
+            </a:solidFill>
+            <a:prstDash val="solid"/>
+          </a:ln>
+        </p:spPr>
+      </p:sp>
+      <p:sp>
+        <p:nvSpPr>
+          <p:cNvPr id="17" name="Text 15"/>
+          <p:cNvSpPr/>
+          <p:nvPr/>
+        </p:nvSpPr>
+        <p:spPr>
+          <a:xfrm>
+            <a:off x="6446520" y="3493008"/>
+            <a:ext cx="5212080" cy="274320"/>
           </a:xfrm>
           <a:prstGeom prst="rect">
             <a:avLst/>
@@ -24908,7 +25334,7 @@
               <a:buNone/>
             </a:pPr>
             <a:r>
-              <a:rPr lang="en-US" sz="1050" dirty="0">
+              <a:rPr lang="en-US" sz="1150" dirty="0">
                 <a:solidFill>
                   <a:srgbClr val="52514E"/>
                 </a:solidFill>
@@ -24916,22 +25342,47 @@
                 <a:ea typeface="Calibri" pitchFamily="34" charset="-122"/>
                 <a:cs typeface="Calibri" pitchFamily="34" charset="-120"/>
               </a:rPr>
-              <a:t>required before a fixed-price EPC bid can even be submitted — $200–300K of pre-award exposure on the $9.1M bid slate still in market</a:t>
-            </a:r>
-            <a:endParaRPr lang="en-US" sz="1050" dirty="0"/>
+              <a:t>CVR material margin — $6.8M (4.6%)</a:t>
+            </a:r>
+            <a:endParaRPr lang="en-US" sz="1150" dirty="0"/>
           </a:p>
         </p:txBody>
       </p:sp>
       <p:sp>
         <p:nvSpPr>
-          <p:cNvPr id="9" name="Text 7"/>
+          <p:cNvPr id="18" name="Shape 16"/>
           <p:cNvSpPr/>
           <p:nvPr/>
         </p:nvSpPr>
         <p:spPr>
           <a:xfrm>
-            <a:off x="548640" y="3831336"/>
-            <a:ext cx="4572000" cy="329184"/>
+            <a:off x="548640" y="3849624"/>
+            <a:ext cx="182880" cy="182880"/>
+          </a:xfrm>
+          <a:prstGeom prst="rect">
+            <a:avLst/>
+          </a:prstGeom>
+          <a:solidFill>
+            <a:srgbClr val="D8D6CE"/>
+          </a:solidFill>
+          <a:ln w="6350">
+            <a:solidFill>
+              <a:srgbClr val="E1E0D9"/>
+            </a:solidFill>
+            <a:prstDash val="solid"/>
+          </a:ln>
+        </p:spPr>
+      </p:sp>
+      <p:sp>
+        <p:nvSpPr>
+          <p:cNvPr id="19" name="Text 17"/>
+          <p:cNvSpPr/>
+          <p:nvPr/>
+        </p:nvSpPr>
+        <p:spPr>
+          <a:xfrm>
+            <a:off x="822960" y="3803904"/>
+            <a:ext cx="5212080" cy="274320"/>
           </a:xfrm>
           <a:prstGeom prst="rect">
             <a:avLst/>
@@ -24947,30 +25398,55 @@
               <a:buNone/>
             </a:pPr>
             <a:r>
-              <a:rPr lang="en-US" sz="1700" b="1" dirty="0">
+              <a:rPr lang="en-US" sz="1150" dirty="0">
                 <a:solidFill>
-                  <a:srgbClr val="2A78D6"/>
+                  <a:srgbClr val="52514E"/>
                 </a:solidFill>
                 <a:latin typeface="Calibri" pitchFamily="34" charset="0"/>
                 <a:ea typeface="Calibri" pitchFamily="34" charset="-122"/>
                 <a:cs typeface="Calibri" pitchFamily="34" charset="-120"/>
               </a:rPr>
-              <a:t>Absorbed today</a:t>
-            </a:r>
-            <a:endParaRPr lang="en-US" sz="1700" dirty="0"/>
+              <a:t>Materials at cost (pass-through) — $45.7M (30%)</a:t>
+            </a:r>
+            <a:endParaRPr lang="en-US" sz="1150" dirty="0"/>
           </a:p>
         </p:txBody>
       </p:sp>
       <p:sp>
         <p:nvSpPr>
-          <p:cNvPr id="10" name="Text 8"/>
+          <p:cNvPr id="20" name="Shape 18"/>
           <p:cNvSpPr/>
           <p:nvPr/>
         </p:nvSpPr>
         <p:spPr>
           <a:xfrm>
-            <a:off x="548640" y="4160520"/>
-            <a:ext cx="4572000" cy="658368"/>
+            <a:off x="6172200" y="3849624"/>
+            <a:ext cx="182880" cy="182880"/>
+          </a:xfrm>
+          <a:prstGeom prst="rect">
+            <a:avLst/>
+          </a:prstGeom>
+          <a:solidFill>
+            <a:srgbClr val="AEB4B9"/>
+          </a:solidFill>
+          <a:ln w="6350">
+            <a:solidFill>
+              <a:srgbClr val="E1E0D9"/>
+            </a:solidFill>
+            <a:prstDash val="solid"/>
+          </a:ln>
+        </p:spPr>
+      </p:sp>
+      <p:sp>
+        <p:nvSpPr>
+          <p:cNvPr id="21" name="Text 19"/>
+          <p:cNvSpPr/>
+          <p:nvPr/>
+        </p:nvSpPr>
+        <p:spPr>
+          <a:xfrm>
+            <a:off x="6446520" y="3803904"/>
+            <a:ext cx="5212080" cy="274320"/>
           </a:xfrm>
           <a:prstGeom prst="rect">
             <a:avLst/>
@@ -24986,7 +25462,7 @@
               <a:buNone/>
             </a:pPr>
             <a:r>
-              <a:rPr lang="en-US" sz="1050" dirty="0">
+              <a:rPr lang="en-US" sz="1150" dirty="0">
                 <a:solidFill>
                   <a:srgbClr val="52514E"/>
                 </a:solidFill>
@@ -24994,282 +25470,26 @@
                 <a:ea typeface="Calibri" pitchFamily="34" charset="-122"/>
                 <a:cs typeface="Calibri" pitchFamily="34" charset="-120"/>
               </a:rPr>
-              <a:t>these hours land in CVR's overhead with no offsetting credit — immaterial now, but it compounds as EPC pursuit volume grows</a:t>
-            </a:r>
-            <a:endParaRPr lang="en-US" sz="1050" dirty="0"/>
+              <a:t>HWC equipment + labor + construction — $85.5M (57%)</a:t>
+            </a:r>
+            <a:endParaRPr lang="en-US" sz="1150" dirty="0"/>
           </a:p>
         </p:txBody>
       </p:sp>
       <p:sp>
         <p:nvSpPr>
-          <p:cNvPr id="11" name="Text 9"/>
+          <p:cNvPr id="22" name="Shape 20"/>
           <p:cNvSpPr/>
           <p:nvPr/>
         </p:nvSpPr>
         <p:spPr>
           <a:xfrm>
-            <a:off x="548640" y="4855464"/>
-            <a:ext cx="4572000" cy="329184"/>
-          </a:xfrm>
-          <a:prstGeom prst="rect">
-            <a:avLst/>
-          </a:prstGeom>
-          <a:noFill/>
-          <a:ln/>
-        </p:spPr>
-        <p:txBody>
-          <a:bodyPr wrap="square" lIns="0" tIns="0" rIns="0" bIns="0" rtlCol="0" anchor="ctr"/>
-          <a:lstStyle/>
-          <a:p>
-            <a:pPr indent="0" marL="0">
-              <a:buNone/>
-            </a:pPr>
-            <a:r>
-              <a:rPr lang="en-US" sz="1700" b="1" dirty="0">
-                <a:solidFill>
-                  <a:srgbClr val="E34948"/>
-                </a:solidFill>
-                <a:latin typeface="Calibri" pitchFamily="34" charset="0"/>
-                <a:ea typeface="Calibri" pitchFamily="34" charset="-122"/>
-                <a:cs typeface="Calibri" pitchFamily="34" charset="-120"/>
-              </a:rPr>
-              <a:t>The misalignment</a:t>
-            </a:r>
-            <a:endParaRPr lang="en-US" sz="1700" dirty="0"/>
-          </a:p>
-        </p:txBody>
-      </p:sp>
-      <p:sp>
-        <p:nvSpPr>
-          <p:cNvPr id="12" name="Text 10"/>
-          <p:cNvSpPr/>
-          <p:nvPr/>
-        </p:nvSpPr>
-        <p:spPr>
-          <a:xfrm>
-            <a:off x="548640" y="5184648"/>
-            <a:ext cx="4572000" cy="658368"/>
-          </a:xfrm>
-          <a:prstGeom prst="rect">
-            <a:avLst/>
-          </a:prstGeom>
-          <a:noFill/>
-          <a:ln/>
-        </p:spPr>
-        <p:txBody>
-          <a:bodyPr wrap="square" lIns="0" tIns="0" rIns="0" bIns="0" rtlCol="0" anchor="ctr"/>
-          <a:lstStyle/>
-          <a:p>
-            <a:pPr indent="0" marL="0">
-              <a:buNone/>
-            </a:pPr>
-            <a:r>
-              <a:rPr lang="en-US" sz="1050" dirty="0">
-                <a:solidFill>
-                  <a:srgbClr val="52514E"/>
-                </a:solidFill>
-                <a:latin typeface="Calibri" pitchFamily="34" charset="0"/>
-                <a:ea typeface="Calibri" pitchFamily="34" charset="-122"/>
-                <a:cs typeface="Calibri" pitchFamily="34" charset="-120"/>
-              </a:rPr>
-              <a:t>bid hours are non-billable, so every EPC pursuit CVR supports drags the metrics CVR is judged on — utilization, realization, OILI</a:t>
-            </a:r>
-            <a:endParaRPr lang="en-US" sz="1050" dirty="0"/>
-          </a:p>
-        </p:txBody>
-      </p:sp>
-      <p:sp>
-        <p:nvSpPr>
-          <p:cNvPr id="13" name="Shape 11"/>
-          <p:cNvSpPr/>
-          <p:nvPr/>
-        </p:nvSpPr>
-        <p:spPr>
-          <a:xfrm>
-            <a:off x="5577840" y="1371600"/>
-            <a:ext cx="6035040" cy="1353312"/>
+            <a:off x="548640" y="4224528"/>
+            <a:ext cx="2095805" cy="1024128"/>
           </a:xfrm>
           <a:prstGeom prst="roundRect">
             <a:avLst>
-              <a:gd name="adj" fmla="val 4054"/>
-            </a:avLst>
-          </a:prstGeom>
-          <a:solidFill>
-            <a:srgbClr val="EAF1FA"/>
-          </a:solidFill>
-          <a:ln w="15875">
-            <a:solidFill>
-              <a:srgbClr val="2A78D6"/>
-            </a:solidFill>
-            <a:prstDash val="solid"/>
-          </a:ln>
-        </p:spPr>
-      </p:sp>
-      <p:sp>
-        <p:nvSpPr>
-          <p:cNvPr id="14" name="Shape 12"/>
-          <p:cNvSpPr/>
-          <p:nvPr/>
-        </p:nvSpPr>
-        <p:spPr>
-          <a:xfrm>
-            <a:off x="5760720" y="1536192"/>
-            <a:ext cx="384048" cy="384048"/>
-          </a:xfrm>
-          <a:prstGeom prst="ellipse">
-            <a:avLst/>
-          </a:prstGeom>
-          <a:solidFill>
-            <a:srgbClr val="2A78D6"/>
-          </a:solidFill>
-          <a:ln/>
-        </p:spPr>
-      </p:sp>
-      <p:sp>
-        <p:nvSpPr>
-          <p:cNvPr id="15" name="Text 13"/>
-          <p:cNvSpPr/>
-          <p:nvPr/>
-        </p:nvSpPr>
-        <p:spPr>
-          <a:xfrm>
-            <a:off x="5760720" y="1536192"/>
-            <a:ext cx="384048" cy="384048"/>
-          </a:xfrm>
-          <a:prstGeom prst="rect">
-            <a:avLst/>
-          </a:prstGeom>
-          <a:noFill/>
-          <a:ln/>
-        </p:spPr>
-        <p:txBody>
-          <a:bodyPr wrap="square" lIns="0" tIns="0" rIns="0" bIns="0" rtlCol="0" anchor="ctr"/>
-          <a:lstStyle/>
-          <a:p>
-            <a:pPr algn="ctr" indent="0" marL="0">
-              <a:buNone/>
-            </a:pPr>
-            <a:r>
-              <a:rPr lang="en-US" sz="1500" b="1" dirty="0">
-                <a:solidFill>
-                  <a:srgbClr val="FFFFFF"/>
-                </a:solidFill>
-                <a:latin typeface="Calibri" pitchFamily="34" charset="0"/>
-                <a:ea typeface="Calibri" pitchFamily="34" charset="-122"/>
-                <a:cs typeface="Calibri" pitchFamily="34" charset="-120"/>
-              </a:rPr>
-              <a:t>1</a:t>
-            </a:r>
-            <a:endParaRPr lang="en-US" sz="1500" dirty="0"/>
-          </a:p>
-        </p:txBody>
-      </p:sp>
-      <p:sp>
-        <p:nvSpPr>
-          <p:cNvPr id="16" name="Text 14"/>
-          <p:cNvSpPr/>
-          <p:nvPr/>
-        </p:nvSpPr>
-        <p:spPr>
-          <a:xfrm>
-            <a:off x="6291072" y="1499616"/>
-            <a:ext cx="5120640" cy="292608"/>
-          </a:xfrm>
-          <a:prstGeom prst="rect">
-            <a:avLst/>
-          </a:prstGeom>
-          <a:noFill/>
-          <a:ln/>
-        </p:spPr>
-        <p:txBody>
-          <a:bodyPr wrap="square" lIns="0" tIns="0" rIns="0" bIns="0" rtlCol="0" anchor="ctr"/>
-          <a:lstStyle/>
-          <a:p>
-            <a:pPr indent="0" marL="0">
-              <a:buNone/>
-            </a:pPr>
-            <a:r>
-              <a:rPr lang="en-US" sz="1400" b="1" dirty="0">
-                <a:solidFill>
-                  <a:srgbClr val="0B0B0B"/>
-                </a:solidFill>
-                <a:latin typeface="Calibri" pitchFamily="34" charset="0"/>
-                <a:ea typeface="Calibri" pitchFamily="34" charset="-122"/>
-                <a:cs typeface="Calibri" pitchFamily="34" charset="-120"/>
-              </a:rPr>
-              <a:t>Intercompany bid-support billing</a:t>
-            </a:r>
-            <a:pPr indent="0" marL="0">
-              <a:buNone/>
-            </a:pPr>
-            <a:r>
-              <a:rPr lang="en-US" sz="950" b="1" spc="150" kern="0" dirty="0">
-                <a:solidFill>
-                  <a:srgbClr val="2A78D6"/>
-                </a:solidFill>
-                <a:latin typeface="Calibri" pitchFamily="34" charset="0"/>
-                <a:ea typeface="Calibri" pitchFamily="34" charset="-122"/>
-                <a:cs typeface="Calibri" pitchFamily="34" charset="-120"/>
-              </a:rPr>
-              <a:t>   RECOMMENDED</a:t>
-            </a:r>
-            <a:endParaRPr lang="en-US" sz="1400" dirty="0"/>
-          </a:p>
-        </p:txBody>
-      </p:sp>
-      <p:sp>
-        <p:nvSpPr>
-          <p:cNvPr id="17" name="Text 15"/>
-          <p:cNvSpPr/>
-          <p:nvPr/>
-        </p:nvSpPr>
-        <p:spPr>
-          <a:xfrm>
-            <a:off x="6291072" y="1828800"/>
-            <a:ext cx="5120640" cy="822960"/>
-          </a:xfrm>
-          <a:prstGeom prst="rect">
-            <a:avLst/>
-          </a:prstGeom>
-          <a:noFill/>
-          <a:ln/>
-        </p:spPr>
-        <p:txBody>
-          <a:bodyPr wrap="square" lIns="0" tIns="0" rIns="0" bIns="0" rtlCol="0" anchor="ctr"/>
-          <a:lstStyle/>
-          <a:p>
-            <a:pPr indent="0" marL="0">
-              <a:buNone/>
-            </a:pPr>
-            <a:r>
-              <a:rPr lang="en-US" sz="1050" dirty="0">
-                <a:solidFill>
-                  <a:srgbClr val="52514E"/>
-                </a:solidFill>
-                <a:latin typeface="Calibri" pitchFamily="34" charset="0"/>
-                <a:ea typeface="Calibri" pitchFamily="34" charset="-122"/>
-                <a:cs typeface="Calibri" pitchFamily="34" charset="-120"/>
-              </a:rPr>
-              <a:t>HWC pays CVR for pre-award engineering on EPC pursuits (cost or card). Hours become billable; cost lands where the benefit lands. Standard EPC practice.</a:t>
-            </a:r>
-            <a:endParaRPr lang="en-US" sz="1050" dirty="0"/>
-          </a:p>
-        </p:txBody>
-      </p:sp>
-      <p:sp>
-        <p:nvSpPr>
-          <p:cNvPr id="18" name="Shape 16"/>
-          <p:cNvSpPr/>
-          <p:nvPr/>
-        </p:nvSpPr>
-        <p:spPr>
-          <a:xfrm>
-            <a:off x="5577840" y="2852928"/>
-            <a:ext cx="6035040" cy="1353312"/>
-          </a:xfrm>
-          <a:prstGeom prst="roundRect">
-            <a:avLst>
-              <a:gd name="adj" fmla="val 4054"/>
+              <a:gd name="adj" fmla="val 5357"/>
             </a:avLst>
           </a:prstGeom>
           <a:solidFill>
@@ -25285,115 +25505,14 @@
       </p:sp>
       <p:sp>
         <p:nvSpPr>
-          <p:cNvPr id="19" name="Shape 17"/>
+          <p:cNvPr id="23" name="Text 21"/>
           <p:cNvSpPr/>
           <p:nvPr/>
         </p:nvSpPr>
         <p:spPr>
           <a:xfrm>
-            <a:off x="5760720" y="3017520"/>
-            <a:ext cx="384048" cy="384048"/>
-          </a:xfrm>
-          <a:prstGeom prst="ellipse">
-            <a:avLst/>
-          </a:prstGeom>
-          <a:solidFill>
-            <a:srgbClr val="2A78D6"/>
-          </a:solidFill>
-          <a:ln/>
-        </p:spPr>
-      </p:sp>
-      <p:sp>
-        <p:nvSpPr>
-          <p:cNvPr id="20" name="Text 18"/>
-          <p:cNvSpPr/>
-          <p:nvPr/>
-        </p:nvSpPr>
-        <p:spPr>
-          <a:xfrm>
-            <a:off x="5760720" y="3017520"/>
-            <a:ext cx="384048" cy="384048"/>
-          </a:xfrm>
-          <a:prstGeom prst="rect">
-            <a:avLst/>
-          </a:prstGeom>
-          <a:noFill/>
-          <a:ln/>
-        </p:spPr>
-        <p:txBody>
-          <a:bodyPr wrap="square" lIns="0" tIns="0" rIns="0" bIns="0" rtlCol="0" anchor="ctr"/>
-          <a:lstStyle/>
-          <a:p>
-            <a:pPr algn="ctr" indent="0" marL="0">
-              <a:buNone/>
-            </a:pPr>
-            <a:r>
-              <a:rPr lang="en-US" sz="1500" b="1" dirty="0">
-                <a:solidFill>
-                  <a:srgbClr val="FFFFFF"/>
-                </a:solidFill>
-                <a:latin typeface="Calibri" pitchFamily="34" charset="0"/>
-                <a:ea typeface="Calibri" pitchFamily="34" charset="-122"/>
-                <a:cs typeface="Calibri" pitchFamily="34" charset="-120"/>
-              </a:rPr>
-              <a:t>2</a:t>
-            </a:r>
-            <a:endParaRPr lang="en-US" sz="1500" dirty="0"/>
-          </a:p>
-        </p:txBody>
-      </p:sp>
-      <p:sp>
-        <p:nvSpPr>
-          <p:cNvPr id="21" name="Text 19"/>
-          <p:cNvSpPr/>
-          <p:nvPr/>
-        </p:nvSpPr>
-        <p:spPr>
-          <a:xfrm>
-            <a:off x="6291072" y="2980944"/>
-            <a:ext cx="5120640" cy="292608"/>
-          </a:xfrm>
-          <a:prstGeom prst="rect">
-            <a:avLst/>
-          </a:prstGeom>
-          <a:noFill/>
-          <a:ln/>
-        </p:spPr>
-        <p:txBody>
-          <a:bodyPr wrap="square" lIns="0" tIns="0" rIns="0" bIns="0" rtlCol="0" anchor="ctr"/>
-          <a:lstStyle/>
-          <a:p>
-            <a:pPr indent="0" marL="0">
-              <a:buNone/>
-            </a:pPr>
-            <a:r>
-              <a:rPr lang="en-US" sz="1400" b="1" dirty="0">
-                <a:solidFill>
-                  <a:srgbClr val="0B0B0B"/>
-                </a:solidFill>
-                <a:latin typeface="Calibri" pitchFamily="34" charset="0"/>
-                <a:ea typeface="Calibri" pitchFamily="34" charset="-122"/>
-                <a:cs typeface="Calibri" pitchFamily="34" charset="-120"/>
-              </a:rPr>
-              <a:t>Win / loss allocation</a:t>
-            </a:r>
-            <a:pPr indent="0" marL="0">
-              <a:buNone/>
-            </a:pPr>
-            <a:endParaRPr lang="en-US" sz="1400" dirty="0"/>
-          </a:p>
-        </p:txBody>
-      </p:sp>
-      <p:sp>
-        <p:nvSpPr>
-          <p:cNvPr id="22" name="Text 20"/>
-          <p:cNvSpPr/>
-          <p:nvPr/>
-        </p:nvSpPr>
-        <p:spPr>
-          <a:xfrm>
-            <a:off x="6291072" y="3310128"/>
-            <a:ext cx="5120640" cy="822960"/>
+            <a:off x="676656" y="4297680"/>
+            <a:ext cx="1839773" cy="237744"/>
           </a:xfrm>
           <a:prstGeom prst="rect">
             <a:avLst/>
@@ -25417,7 +25536,7 @@
                 <a:ea typeface="Calibri" pitchFamily="34" charset="-122"/>
                 <a:cs typeface="Calibri" pitchFamily="34" charset="-120"/>
               </a:rPr>
-              <a:t>Bid engineering capitalizes to the pursuit — charged to the job on a win, absorbed by HWC as a BD expense on a loss.</a:t>
+              <a:t>CVR managed revenue</a:t>
             </a:r>
             <a:endParaRPr lang="en-US" sz="1050" dirty="0"/>
           </a:p>
@@ -25425,18 +25544,96 @@
       </p:sp>
       <p:sp>
         <p:nvSpPr>
-          <p:cNvPr id="23" name="Shape 21"/>
+          <p:cNvPr id="24" name="Text 22"/>
           <p:cNvSpPr/>
           <p:nvPr/>
         </p:nvSpPr>
         <p:spPr>
           <a:xfrm>
-            <a:off x="5577840" y="4334256"/>
-            <a:ext cx="6035040" cy="1353312"/>
+            <a:off x="676656" y="4498848"/>
+            <a:ext cx="1839773" cy="457200"/>
+          </a:xfrm>
+          <a:prstGeom prst="rect">
+            <a:avLst/>
+          </a:prstGeom>
+          <a:noFill/>
+          <a:ln/>
+        </p:spPr>
+        <p:txBody>
+          <a:bodyPr wrap="square" lIns="0" tIns="0" rIns="0" bIns="0" rtlCol="0" anchor="ctr"/>
+          <a:lstStyle/>
+          <a:p>
+            <a:pPr indent="0" marL="0">
+              <a:buNone/>
+            </a:pPr>
+            <a:r>
+              <a:rPr lang="en-US" sz="2500" b="1" dirty="0">
+                <a:solidFill>
+                  <a:srgbClr val="0B0B0B"/>
+                </a:solidFill>
+                <a:latin typeface="Calibri" pitchFamily="34" charset="0"/>
+                <a:ea typeface="Calibri" pitchFamily="34" charset="-122"/>
+                <a:cs typeface="Calibri" pitchFamily="34" charset="-120"/>
+              </a:rPr>
+              <a:t>$18.8M</a:t>
+            </a:r>
+            <a:endParaRPr lang="en-US" sz="2500" dirty="0"/>
+          </a:p>
+        </p:txBody>
+      </p:sp>
+      <p:sp>
+        <p:nvSpPr>
+          <p:cNvPr id="25" name="Text 23"/>
+          <p:cNvSpPr/>
+          <p:nvPr/>
+        </p:nvSpPr>
+        <p:spPr>
+          <a:xfrm>
+            <a:off x="676656" y="4937760"/>
+            <a:ext cx="1839773" cy="256032"/>
+          </a:xfrm>
+          <a:prstGeom prst="rect">
+            <a:avLst/>
+          </a:prstGeom>
+          <a:noFill/>
+          <a:ln/>
+        </p:spPr>
+        <p:txBody>
+          <a:bodyPr wrap="square" lIns="0" tIns="0" rIns="0" bIns="0" rtlCol="0" anchor="ctr"/>
+          <a:lstStyle/>
+          <a:p>
+            <a:pPr indent="0" marL="0">
+              <a:buNone/>
+            </a:pPr>
+            <a:r>
+              <a:rPr lang="en-US" sz="950" dirty="0">
+                <a:solidFill>
+                  <a:srgbClr val="52514E"/>
+                </a:solidFill>
+                <a:latin typeface="Calibri" pitchFamily="34" charset="0"/>
+                <a:ea typeface="Calibri" pitchFamily="34" charset="-122"/>
+                <a:cs typeface="Calibri" pitchFamily="34" charset="-120"/>
+              </a:rPr>
+              <a:t>engineering + material margin</a:t>
+            </a:r>
+            <a:endParaRPr lang="en-US" sz="950" dirty="0"/>
+          </a:p>
+        </p:txBody>
+      </p:sp>
+      <p:sp>
+        <p:nvSpPr>
+          <p:cNvPr id="26" name="Shape 24"/>
+          <p:cNvSpPr/>
+          <p:nvPr/>
+        </p:nvSpPr>
+        <p:spPr>
+          <a:xfrm>
+            <a:off x="2790749" y="4224528"/>
+            <a:ext cx="2095805" cy="1024128"/>
           </a:xfrm>
           <a:prstGeom prst="roundRect">
             <a:avLst>
-              <a:gd name="adj" fmla="val 4054"/>
+              <a:gd name="adj" fmla="val 5357"/>
             </a:avLst>
           </a:prstGeom>
           <a:solidFill>
@@ -25452,115 +25649,14 @@
       </p:sp>
       <p:sp>
         <p:nvSpPr>
-          <p:cNvPr id="24" name="Shape 22"/>
-          <p:cNvSpPr/>
-          <p:nvPr/>
-        </p:nvSpPr>
-        <p:spPr>
-          <a:xfrm>
-            <a:off x="5760720" y="4498848"/>
-            <a:ext cx="384048" cy="384048"/>
-          </a:xfrm>
-          <a:prstGeom prst="ellipse">
-            <a:avLst/>
-          </a:prstGeom>
-          <a:solidFill>
-            <a:srgbClr val="2A78D6"/>
-          </a:solidFill>
-          <a:ln/>
-        </p:spPr>
-      </p:sp>
-      <p:sp>
-        <p:nvSpPr>
-          <p:cNvPr id="25" name="Text 23"/>
-          <p:cNvSpPr/>
-          <p:nvPr/>
-        </p:nvSpPr>
-        <p:spPr>
-          <a:xfrm>
-            <a:off x="5760720" y="4498848"/>
-            <a:ext cx="384048" cy="384048"/>
-          </a:xfrm>
-          <a:prstGeom prst="rect">
-            <a:avLst/>
-          </a:prstGeom>
-          <a:noFill/>
-          <a:ln/>
-        </p:spPr>
-        <p:txBody>
-          <a:bodyPr wrap="square" lIns="0" tIns="0" rIns="0" bIns="0" rtlCol="0" anchor="ctr"/>
-          <a:lstStyle/>
-          <a:p>
-            <a:pPr algn="ctr" indent="0" marL="0">
-              <a:buNone/>
-            </a:pPr>
-            <a:r>
-              <a:rPr lang="en-US" sz="1500" b="1" dirty="0">
-                <a:solidFill>
-                  <a:srgbClr val="FFFFFF"/>
-                </a:solidFill>
-                <a:latin typeface="Calibri" pitchFamily="34" charset="0"/>
-                <a:ea typeface="Calibri" pitchFamily="34" charset="-122"/>
-                <a:cs typeface="Calibri" pitchFamily="34" charset="-120"/>
-              </a:rPr>
-              <a:t>3</a:t>
-            </a:r>
-            <a:endParaRPr lang="en-US" sz="1500" dirty="0"/>
-          </a:p>
-        </p:txBody>
-      </p:sp>
-      <p:sp>
-        <p:nvSpPr>
-          <p:cNvPr id="26" name="Text 24"/>
-          <p:cNvSpPr/>
-          <p:nvPr/>
-        </p:nvSpPr>
-        <p:spPr>
-          <a:xfrm>
-            <a:off x="6291072" y="4462272"/>
-            <a:ext cx="5120640" cy="292608"/>
-          </a:xfrm>
-          <a:prstGeom prst="rect">
-            <a:avLst/>
-          </a:prstGeom>
-          <a:noFill/>
-          <a:ln/>
-        </p:spPr>
-        <p:txBody>
-          <a:bodyPr wrap="square" lIns="0" tIns="0" rIns="0" bIns="0" rtlCol="0" anchor="ctr"/>
-          <a:lstStyle/>
-          <a:p>
-            <a:pPr indent="0" marL="0">
-              <a:buNone/>
-            </a:pPr>
-            <a:r>
-              <a:rPr lang="en-US" sz="1400" b="1" dirty="0">
-                <a:solidFill>
-                  <a:srgbClr val="0B0B0B"/>
-                </a:solidFill>
-                <a:latin typeface="Calibri" pitchFamily="34" charset="0"/>
-                <a:ea typeface="Calibri" pitchFamily="34" charset="-122"/>
-                <a:cs typeface="Calibri" pitchFamily="34" charset="-120"/>
-              </a:rPr>
-              <a:t>Carve it out of the metrics</a:t>
-            </a:r>
-            <a:pPr indent="0" marL="0">
-              <a:buNone/>
-            </a:pPr>
-            <a:endParaRPr lang="en-US" sz="1400" dirty="0"/>
-          </a:p>
-        </p:txBody>
-      </p:sp>
-      <p:sp>
-        <p:nvSpPr>
           <p:cNvPr id="27" name="Text 25"/>
           <p:cNvSpPr/>
           <p:nvPr/>
         </p:nvSpPr>
         <p:spPr>
           <a:xfrm>
-            <a:off x="6291072" y="4791456"/>
-            <a:ext cx="5120640" cy="822960"/>
+            <a:off x="2918765" y="4297680"/>
+            <a:ext cx="1839773" cy="237744"/>
           </a:xfrm>
           <a:prstGeom prst="rect">
             <a:avLst/>
@@ -25584,7 +25680,7 @@
                 <a:ea typeface="Calibri" pitchFamily="34" charset="-122"/>
                 <a:cs typeface="Calibri" pitchFamily="34" charset="-120"/>
               </a:rPr>
-              <a:t>Track bid-support hours in a separate BD cost pool so CVR's utilization and realization aren't penalized for pursuit work — a reporting fix, not a cash fix.</a:t>
+              <a:t>CVR gross profit</a:t>
             </a:r>
             <a:endParaRPr lang="en-US" sz="1050" dirty="0"/>
           </a:p>
@@ -25592,18 +25688,528 @@
       </p:sp>
       <p:sp>
         <p:nvSpPr>
-          <p:cNvPr id="28" name="Shape 26"/>
+          <p:cNvPr id="28" name="Text 26"/>
           <p:cNvSpPr/>
           <p:nvPr/>
         </p:nvSpPr>
         <p:spPr>
           <a:xfrm>
-            <a:off x="548640" y="5897880"/>
-            <a:ext cx="11064240" cy="457200"/>
+            <a:off x="2918765" y="4498848"/>
+            <a:ext cx="1839773" cy="457200"/>
+          </a:xfrm>
+          <a:prstGeom prst="rect">
+            <a:avLst/>
+          </a:prstGeom>
+          <a:noFill/>
+          <a:ln/>
+        </p:spPr>
+        <p:txBody>
+          <a:bodyPr wrap="square" lIns="0" tIns="0" rIns="0" bIns="0" rtlCol="0" anchor="ctr"/>
+          <a:lstStyle/>
+          <a:p>
+            <a:pPr indent="0" marL="0">
+              <a:buNone/>
+            </a:pPr>
+            <a:r>
+              <a:rPr lang="en-US" sz="2500" b="1" dirty="0">
+                <a:solidFill>
+                  <a:srgbClr val="0B0B0B"/>
+                </a:solidFill>
+                <a:latin typeface="Calibri" pitchFamily="34" charset="0"/>
+                <a:ea typeface="Calibri" pitchFamily="34" charset="-122"/>
+                <a:cs typeface="Calibri" pitchFamily="34" charset="-120"/>
+              </a:rPr>
+              <a:t>$14.0M</a:t>
+            </a:r>
+            <a:endParaRPr lang="en-US" sz="2500" dirty="0"/>
+          </a:p>
+        </p:txBody>
+      </p:sp>
+      <p:sp>
+        <p:nvSpPr>
+          <p:cNvPr id="29" name="Text 27"/>
+          <p:cNvSpPr/>
+          <p:nvPr/>
+        </p:nvSpPr>
+        <p:spPr>
+          <a:xfrm>
+            <a:off x="2918765" y="4937760"/>
+            <a:ext cx="1839773" cy="256032"/>
+          </a:xfrm>
+          <a:prstGeom prst="rect">
+            <a:avLst/>
+          </a:prstGeom>
+          <a:noFill/>
+          <a:ln/>
+        </p:spPr>
+        <p:txBody>
+          <a:bodyPr wrap="square" lIns="0" tIns="0" rIns="0" bIns="0" rtlCol="0" anchor="ctr"/>
+          <a:lstStyle/>
+          <a:p>
+            <a:pPr indent="0" marL="0">
+              <a:buNone/>
+            </a:pPr>
+            <a:r>
+              <a:rPr lang="en-US" sz="950" dirty="0">
+                <a:solidFill>
+                  <a:srgbClr val="52514E"/>
+                </a:solidFill>
+                <a:latin typeface="Calibri" pitchFamily="34" charset="0"/>
+                <a:ea typeface="Calibri" pitchFamily="34" charset="-122"/>
+                <a:cs typeface="Calibri" pitchFamily="34" charset="-120"/>
+              </a:rPr>
+              <a:t>eng GP + material margin</a:t>
+            </a:r>
+            <a:endParaRPr lang="en-US" sz="950" dirty="0"/>
+          </a:p>
+        </p:txBody>
+      </p:sp>
+      <p:sp>
+        <p:nvSpPr>
+          <p:cNvPr id="30" name="Shape 28"/>
+          <p:cNvSpPr/>
+          <p:nvPr/>
+        </p:nvSpPr>
+        <p:spPr>
+          <a:xfrm>
+            <a:off x="5032858" y="4224528"/>
+            <a:ext cx="2095805" cy="1024128"/>
           </a:xfrm>
           <a:prstGeom prst="roundRect">
             <a:avLst>
-              <a:gd name="adj" fmla="val 10000"/>
+              <a:gd name="adj" fmla="val 5357"/>
+            </a:avLst>
+          </a:prstGeom>
+          <a:solidFill>
+            <a:srgbClr val="F7F7F5"/>
+          </a:solidFill>
+          <a:ln w="9525">
+            <a:solidFill>
+              <a:srgbClr val="E1E0D9"/>
+            </a:solidFill>
+            <a:prstDash val="solid"/>
+          </a:ln>
+        </p:spPr>
+      </p:sp>
+      <p:sp>
+        <p:nvSpPr>
+          <p:cNvPr id="31" name="Text 29"/>
+          <p:cNvSpPr/>
+          <p:nvPr/>
+        </p:nvSpPr>
+        <p:spPr>
+          <a:xfrm>
+            <a:off x="5160874" y="4297680"/>
+            <a:ext cx="1839773" cy="237744"/>
+          </a:xfrm>
+          <a:prstGeom prst="rect">
+            <a:avLst/>
+          </a:prstGeom>
+          <a:noFill/>
+          <a:ln/>
+        </p:spPr>
+        <p:txBody>
+          <a:bodyPr wrap="square" lIns="0" tIns="0" rIns="0" bIns="0" rtlCol="0" anchor="ctr"/>
+          <a:lstStyle/>
+          <a:p>
+            <a:pPr indent="0" marL="0">
+              <a:buNone/>
+            </a:pPr>
+            <a:r>
+              <a:rPr lang="en-US" sz="1050" dirty="0">
+                <a:solidFill>
+                  <a:srgbClr val="52514E"/>
+                </a:solidFill>
+                <a:latin typeface="Calibri" pitchFamily="34" charset="0"/>
+                <a:ea typeface="Calibri" pitchFamily="34" charset="-122"/>
+                <a:cs typeface="Calibri" pitchFamily="34" charset="-120"/>
+              </a:rPr>
+              <a:t>CVR operating income</a:t>
+            </a:r>
+            <a:endParaRPr lang="en-US" sz="1050" dirty="0"/>
+          </a:p>
+        </p:txBody>
+      </p:sp>
+      <p:sp>
+        <p:nvSpPr>
+          <p:cNvPr id="32" name="Text 30"/>
+          <p:cNvSpPr/>
+          <p:nvPr/>
+        </p:nvSpPr>
+        <p:spPr>
+          <a:xfrm>
+            <a:off x="5160874" y="4498848"/>
+            <a:ext cx="1839773" cy="457200"/>
+          </a:xfrm>
+          <a:prstGeom prst="rect">
+            <a:avLst/>
+          </a:prstGeom>
+          <a:noFill/>
+          <a:ln/>
+        </p:spPr>
+        <p:txBody>
+          <a:bodyPr wrap="square" lIns="0" tIns="0" rIns="0" bIns="0" rtlCol="0" anchor="ctr"/>
+          <a:lstStyle/>
+          <a:p>
+            <a:pPr indent="0" marL="0">
+              <a:buNone/>
+            </a:pPr>
+            <a:r>
+              <a:rPr lang="en-US" sz="2500" b="1" dirty="0">
+                <a:solidFill>
+                  <a:srgbClr val="006300"/>
+                </a:solidFill>
+                <a:latin typeface="Calibri" pitchFamily="34" charset="0"/>
+                <a:ea typeface="Calibri" pitchFamily="34" charset="-122"/>
+                <a:cs typeface="Calibri" pitchFamily="34" charset="-120"/>
+              </a:rPr>
+              <a:t>$7.6M</a:t>
+            </a:r>
+            <a:endParaRPr lang="en-US" sz="2500" dirty="0"/>
+          </a:p>
+        </p:txBody>
+      </p:sp>
+      <p:sp>
+        <p:nvSpPr>
+          <p:cNvPr id="33" name="Text 31"/>
+          <p:cNvSpPr/>
+          <p:nvPr/>
+        </p:nvSpPr>
+        <p:spPr>
+          <a:xfrm>
+            <a:off x="5160874" y="4937760"/>
+            <a:ext cx="1839773" cy="256032"/>
+          </a:xfrm>
+          <a:prstGeom prst="rect">
+            <a:avLst/>
+          </a:prstGeom>
+          <a:noFill/>
+          <a:ln/>
+        </p:spPr>
+        <p:txBody>
+          <a:bodyPr wrap="square" lIns="0" tIns="0" rIns="0" bIns="0" rtlCol="0" anchor="ctr"/>
+          <a:lstStyle/>
+          <a:p>
+            <a:pPr indent="0" marL="0">
+              <a:buNone/>
+            </a:pPr>
+            <a:r>
+              <a:rPr lang="en-US" sz="950" dirty="0">
+                <a:solidFill>
+                  <a:srgbClr val="52514E"/>
+                </a:solidFill>
+                <a:latin typeface="Calibri" pitchFamily="34" charset="0"/>
+                <a:ea typeface="Calibri" pitchFamily="34" charset="-122"/>
+                <a:cs typeface="Calibri" pitchFamily="34" charset="-120"/>
+              </a:rPr>
+              <a:t>steady-state OILI</a:t>
+            </a:r>
+            <a:endParaRPr lang="en-US" sz="950" dirty="0"/>
+          </a:p>
+        </p:txBody>
+      </p:sp>
+      <p:sp>
+        <p:nvSpPr>
+          <p:cNvPr id="34" name="Shape 32"/>
+          <p:cNvSpPr/>
+          <p:nvPr/>
+        </p:nvSpPr>
+        <p:spPr>
+          <a:xfrm>
+            <a:off x="7274966" y="4224528"/>
+            <a:ext cx="2095805" cy="1024128"/>
+          </a:xfrm>
+          <a:prstGeom prst="roundRect">
+            <a:avLst>
+              <a:gd name="adj" fmla="val 5357"/>
+            </a:avLst>
+          </a:prstGeom>
+          <a:solidFill>
+            <a:srgbClr val="F7F7F5"/>
+          </a:solidFill>
+          <a:ln w="9525">
+            <a:solidFill>
+              <a:srgbClr val="E1E0D9"/>
+            </a:solidFill>
+            <a:prstDash val="solid"/>
+          </a:ln>
+        </p:spPr>
+      </p:sp>
+      <p:sp>
+        <p:nvSpPr>
+          <p:cNvPr id="35" name="Text 33"/>
+          <p:cNvSpPr/>
+          <p:nvPr/>
+        </p:nvSpPr>
+        <p:spPr>
+          <a:xfrm>
+            <a:off x="7402982" y="4297680"/>
+            <a:ext cx="1839773" cy="237744"/>
+          </a:xfrm>
+          <a:prstGeom prst="rect">
+            <a:avLst/>
+          </a:prstGeom>
+          <a:noFill/>
+          <a:ln/>
+        </p:spPr>
+        <p:txBody>
+          <a:bodyPr wrap="square" lIns="0" tIns="0" rIns="0" bIns="0" rtlCol="0" anchor="ctr"/>
+          <a:lstStyle/>
+          <a:p>
+            <a:pPr indent="0" marL="0">
+              <a:buNone/>
+            </a:pPr>
+            <a:r>
+              <a:rPr lang="en-US" sz="1050" dirty="0">
+                <a:solidFill>
+                  <a:srgbClr val="52514E"/>
+                </a:solidFill>
+                <a:latin typeface="Calibri" pitchFamily="34" charset="0"/>
+                <a:ea typeface="Calibri" pitchFamily="34" charset="-122"/>
+                <a:cs typeface="Calibri" pitchFamily="34" charset="-120"/>
+              </a:rPr>
+              <a:t>vs the $6M / 20% goal</a:t>
+            </a:r>
+            <a:endParaRPr lang="en-US" sz="1050" dirty="0"/>
+          </a:p>
+        </p:txBody>
+      </p:sp>
+      <p:sp>
+        <p:nvSpPr>
+          <p:cNvPr id="36" name="Text 34"/>
+          <p:cNvSpPr/>
+          <p:nvPr/>
+        </p:nvSpPr>
+        <p:spPr>
+          <a:xfrm>
+            <a:off x="7402982" y="4498848"/>
+            <a:ext cx="1839773" cy="457200"/>
+          </a:xfrm>
+          <a:prstGeom prst="rect">
+            <a:avLst/>
+          </a:prstGeom>
+          <a:noFill/>
+          <a:ln/>
+        </p:spPr>
+        <p:txBody>
+          <a:bodyPr wrap="square" lIns="0" tIns="0" rIns="0" bIns="0" rtlCol="0" anchor="ctr"/>
+          <a:lstStyle/>
+          <a:p>
+            <a:pPr indent="0" marL="0">
+              <a:buNone/>
+            </a:pPr>
+            <a:r>
+              <a:rPr lang="en-US" sz="2500" b="1" dirty="0">
+                <a:solidFill>
+                  <a:srgbClr val="2A78D6"/>
+                </a:solidFill>
+                <a:latin typeface="Calibri" pitchFamily="34" charset="0"/>
+                <a:ea typeface="Calibri" pitchFamily="34" charset="-122"/>
+                <a:cs typeface="Calibri" pitchFamily="34" charset="-120"/>
+              </a:rPr>
+              <a:t>6.3×</a:t>
+            </a:r>
+            <a:endParaRPr lang="en-US" sz="2500" dirty="0"/>
+          </a:p>
+        </p:txBody>
+      </p:sp>
+      <p:sp>
+        <p:nvSpPr>
+          <p:cNvPr id="37" name="Text 35"/>
+          <p:cNvSpPr/>
+          <p:nvPr/>
+        </p:nvSpPr>
+        <p:spPr>
+          <a:xfrm>
+            <a:off x="7402982" y="4937760"/>
+            <a:ext cx="1839773" cy="256032"/>
+          </a:xfrm>
+          <a:prstGeom prst="rect">
+            <a:avLst/>
+          </a:prstGeom>
+          <a:noFill/>
+          <a:ln/>
+        </p:spPr>
+        <p:txBody>
+          <a:bodyPr wrap="square" lIns="0" tIns="0" rIns="0" bIns="0" rtlCol="0" anchor="ctr"/>
+          <a:lstStyle/>
+          <a:p>
+            <a:pPr indent="0" marL="0">
+              <a:buNone/>
+            </a:pPr>
+            <a:r>
+              <a:rPr lang="en-US" sz="950" dirty="0">
+                <a:solidFill>
+                  <a:srgbClr val="52514E"/>
+                </a:solidFill>
+                <a:latin typeface="Calibri" pitchFamily="34" charset="0"/>
+                <a:ea typeface="Calibri" pitchFamily="34" charset="-122"/>
+                <a:cs typeface="Calibri" pitchFamily="34" charset="-120"/>
+              </a:rPr>
+              <a:t>the goal operating profit</a:t>
+            </a:r>
+            <a:endParaRPr lang="en-US" sz="950" dirty="0"/>
+          </a:p>
+        </p:txBody>
+      </p:sp>
+      <p:sp>
+        <p:nvSpPr>
+          <p:cNvPr id="38" name="Shape 36"/>
+          <p:cNvSpPr/>
+          <p:nvPr/>
+        </p:nvSpPr>
+        <p:spPr>
+          <a:xfrm>
+            <a:off x="9517075" y="4224528"/>
+            <a:ext cx="2095805" cy="1024128"/>
+          </a:xfrm>
+          <a:prstGeom prst="roundRect">
+            <a:avLst>
+              <a:gd name="adj" fmla="val 5357"/>
+            </a:avLst>
+          </a:prstGeom>
+          <a:solidFill>
+            <a:srgbClr val="F7F7F5"/>
+          </a:solidFill>
+          <a:ln w="9525">
+            <a:solidFill>
+              <a:srgbClr val="E1E0D9"/>
+            </a:solidFill>
+            <a:prstDash val="solid"/>
+          </a:ln>
+        </p:spPr>
+      </p:sp>
+      <p:sp>
+        <p:nvSpPr>
+          <p:cNvPr id="39" name="Text 37"/>
+          <p:cNvSpPr/>
+          <p:nvPr/>
+        </p:nvSpPr>
+        <p:spPr>
+          <a:xfrm>
+            <a:off x="9645091" y="4297680"/>
+            <a:ext cx="1839773" cy="237744"/>
+          </a:xfrm>
+          <a:prstGeom prst="rect">
+            <a:avLst/>
+          </a:prstGeom>
+          <a:noFill/>
+          <a:ln/>
+        </p:spPr>
+        <p:txBody>
+          <a:bodyPr wrap="square" lIns="0" tIns="0" rIns="0" bIns="0" rtlCol="0" anchor="ctr"/>
+          <a:lstStyle/>
+          <a:p>
+            <a:pPr indent="0" marL="0">
+              <a:buNone/>
+            </a:pPr>
+            <a:r>
+              <a:rPr lang="en-US" sz="1050" dirty="0">
+                <a:solidFill>
+                  <a:srgbClr val="52514E"/>
+                </a:solidFill>
+                <a:latin typeface="Calibri" pitchFamily="34" charset="0"/>
+                <a:ea typeface="Calibri" pitchFamily="34" charset="-122"/>
+                <a:cs typeface="Calibri" pitchFamily="34" charset="-120"/>
+              </a:rPr>
+              <a:t>Working capital</a:t>
+            </a:r>
+            <a:endParaRPr lang="en-US" sz="1050" dirty="0"/>
+          </a:p>
+        </p:txBody>
+      </p:sp>
+      <p:sp>
+        <p:nvSpPr>
+          <p:cNvPr id="40" name="Text 38"/>
+          <p:cNvSpPr/>
+          <p:nvPr/>
+        </p:nvSpPr>
+        <p:spPr>
+          <a:xfrm>
+            <a:off x="9645091" y="4498848"/>
+            <a:ext cx="1839773" cy="457200"/>
+          </a:xfrm>
+          <a:prstGeom prst="rect">
+            <a:avLst/>
+          </a:prstGeom>
+          <a:noFill/>
+          <a:ln/>
+        </p:spPr>
+        <p:txBody>
+          <a:bodyPr wrap="square" lIns="0" tIns="0" rIns="0" bIns="0" rtlCol="0" anchor="ctr"/>
+          <a:lstStyle/>
+          <a:p>
+            <a:pPr indent="0" marL="0">
+              <a:buNone/>
+            </a:pPr>
+            <a:r>
+              <a:rPr lang="en-US" sz="2500" b="1" dirty="0">
+                <a:solidFill>
+                  <a:srgbClr val="E34948"/>
+                </a:solidFill>
+                <a:latin typeface="Calibri" pitchFamily="34" charset="0"/>
+                <a:ea typeface="Calibri" pitchFamily="34" charset="-122"/>
+                <a:cs typeface="Calibri" pitchFamily="34" charset="-120"/>
+              </a:rPr>
+              <a:t>~$6.5M</a:t>
+            </a:r>
+            <a:endParaRPr lang="en-US" sz="2500" dirty="0"/>
+          </a:p>
+        </p:txBody>
+      </p:sp>
+      <p:sp>
+        <p:nvSpPr>
+          <p:cNvPr id="41" name="Text 39"/>
+          <p:cNvSpPr/>
+          <p:nvPr/>
+        </p:nvSpPr>
+        <p:spPr>
+          <a:xfrm>
+            <a:off x="9645091" y="4937760"/>
+            <a:ext cx="1839773" cy="256032"/>
+          </a:xfrm>
+          <a:prstGeom prst="rect">
+            <a:avLst/>
+          </a:prstGeom>
+          <a:noFill/>
+          <a:ln/>
+        </p:spPr>
+        <p:txBody>
+          <a:bodyPr wrap="square" lIns="0" tIns="0" rIns="0" bIns="0" rtlCol="0" anchor="ctr"/>
+          <a:lstStyle/>
+          <a:p>
+            <a:pPr indent="0" marL="0">
+              <a:buNone/>
+            </a:pPr>
+            <a:r>
+              <a:rPr lang="en-US" sz="950" dirty="0">
+                <a:solidFill>
+                  <a:srgbClr val="52514E"/>
+                </a:solidFill>
+                <a:latin typeface="Calibri" pitchFamily="34" charset="0"/>
+                <a:ea typeface="Calibri" pitchFamily="34" charset="-122"/>
+                <a:cs typeface="Calibri" pitchFamily="34" charset="-120"/>
+              </a:rPr>
+              <a:t>materials carry — needs a facility</a:t>
+            </a:r>
+            <a:endParaRPr lang="en-US" sz="950" dirty="0"/>
+          </a:p>
+        </p:txBody>
+      </p:sp>
+      <p:sp>
+        <p:nvSpPr>
+          <p:cNvPr id="42" name="Shape 40"/>
+          <p:cNvSpPr/>
+          <p:nvPr/>
+        </p:nvSpPr>
+        <p:spPr>
+          <a:xfrm>
+            <a:off x="548640" y="5468112"/>
+            <a:ext cx="11064240" cy="493776"/>
+          </a:xfrm>
+          <a:prstGeom prst="roundRect">
+            <a:avLst>
+              <a:gd name="adj" fmla="val 9259"/>
             </a:avLst>
           </a:prstGeom>
           <a:solidFill>
@@ -25619,14 +26225,14 @@
       </p:sp>
       <p:sp>
         <p:nvSpPr>
-          <p:cNvPr id="29" name="Text 27"/>
+          <p:cNvPr id="43" name="Text 41"/>
           <p:cNvSpPr/>
           <p:nvPr/>
         </p:nvSpPr>
         <p:spPr>
           <a:xfrm>
-            <a:off x="731520" y="5952744"/>
-            <a:ext cx="10698480" cy="347472"/>
+            <a:off x="731520" y="5541264"/>
+            <a:ext cx="10698480" cy="365760"/>
           </a:xfrm>
           <a:prstGeom prst="rect">
             <a:avLst/>
@@ -25642,7 +26248,7 @@
               <a:buNone/>
             </a:pPr>
             <a:r>
-              <a:rPr lang="en-US" sz="1200" b="1" dirty="0">
+              <a:rPr lang="en-US" sz="1100" b="1" dirty="0">
                 <a:solidFill>
                   <a:srgbClr val="0B0B0B"/>
                 </a:solidFill>
@@ -25650,13 +26256,13 @@
                 <a:ea typeface="Calibri" pitchFamily="34" charset="-122"/>
                 <a:cs typeface="Calibri" pitchFamily="34" charset="-120"/>
               </a:rPr>
-              <a:t>The ask is alignment, not subsidy.  </a:t>
+              <a:t>Steady-state at $150M/yr — a future-state target, not the current forecast.  </a:t>
             </a:r>
             <a:pPr indent="0" marL="0">
               <a:buNone/>
             </a:pPr>
             <a:r>
-              <a:rPr lang="en-US" sz="1200" dirty="0">
+              <a:rPr lang="en-US" sz="1100" dirty="0">
                 <a:solidFill>
                   <a:srgbClr val="52514E"/>
                 </a:solidFill>
@@ -25664,15 +26270,15 @@
                 <a:ea typeface="Calibri" pitchFamily="34" charset="-122"/>
                 <a:cs typeface="Calibri" pitchFamily="34" charset="-120"/>
               </a:rPr>
-              <a:t>The dollars are small today — but as EPC volume scales, the accounting should reward the pursuit behavior the strategy demands.</a:t>
-            </a:r>
-            <a:endParaRPr lang="en-US" sz="1200" dirty="0"/>
+              <a:t>CVR would carry ~$6.5M working capital and material procurement / price risk; confirm payment terms and a financing line with USC / HWC.</a:t>
+            </a:r>
+            <a:endParaRPr lang="en-US" sz="1100" dirty="0"/>
           </a:p>
         </p:txBody>
       </p:sp>
       <p:sp>
         <p:nvSpPr>
-          <p:cNvPr id="30" name="Text 28"/>
+          <p:cNvPr id="44" name="Text 42"/>
           <p:cNvSpPr/>
           <p:nvPr/>
         </p:nvSpPr>
@@ -25703,7 +26309,7 @@
                 <a:ea typeface="Calibri" pitchFamily="34" charset="-122"/>
                 <a:cs typeface="Calibri" pitchFamily="34" charset="-120"/>
               </a:rPr>
-              <a:t>Bid hours per the KPI report (through 7/11/26). Raise with the CFO as an EPC accounting-alignment item.</a:t>
+              <a:t>Drivers editable in CVR_Model_Phase2_Forecast.xlsx → 'EPC At-Scale Model' tab: 35% materials share · 13% material margin (net ~2 pts carry) · 8% engineering pull-through · 15% engineering operating margin.</a:t>
             </a:r>
             <a:endParaRPr lang="en-US" sz="950" dirty="0"/>
           </a:p>
@@ -25720,6 +26326,1105 @@
 <file path=ppt/slides/slide22.xml><?xml version="1.0" encoding="utf-8"?>
 <p:sld xmlns:a="http://schemas.openxmlformats.org/drawingml/2006/main" xmlns:r="http://schemas.openxmlformats.org/officeDocument/2006/relationships" xmlns:p="http://schemas.openxmlformats.org/presentationml/2006/main">
   <p:cSld name="Slide 22">
+    <p:spTree>
+      <p:nvGrpSpPr>
+        <p:cNvPr id="1" name=""/>
+        <p:cNvGrpSpPr/>
+        <p:nvPr/>
+      </p:nvGrpSpPr>
+      <p:grpSpPr>
+        <a:xfrm>
+          <a:off x="0" y="0"/>
+          <a:ext cx="0" cy="0"/>
+          <a:chOff x="0" y="0"/>
+          <a:chExt cx="0" cy="0"/>
+        </a:xfrm>
+      </p:grpSpPr>
+      <p:sp>
+        <p:nvSpPr>
+          <p:cNvPr id="2" name="Text 0"/>
+          <p:cNvSpPr/>
+          <p:nvPr/>
+        </p:nvSpPr>
+        <p:spPr>
+          <a:xfrm>
+            <a:off x="548640" y="292608"/>
+            <a:ext cx="11064240" cy="274320"/>
+          </a:xfrm>
+          <a:prstGeom prst="rect">
+            <a:avLst/>
+          </a:prstGeom>
+          <a:noFill/>
+          <a:ln/>
+        </p:spPr>
+        <p:txBody>
+          <a:bodyPr wrap="square" lIns="0" tIns="0" rIns="0" bIns="0" rtlCol="0" anchor="ctr"/>
+          <a:lstStyle/>
+          <a:p>
+            <a:pPr indent="0" marL="0">
+              <a:buNone/>
+            </a:pPr>
+            <a:r>
+              <a:rPr lang="en-US" sz="1100" b="1" dirty="0">
+                <a:solidFill>
+                  <a:srgbClr val="86B332"/>
+                </a:solidFill>
+                <a:latin typeface="Calibri" pitchFamily="34" charset="0"/>
+                <a:ea typeface="Calibri" pitchFamily="34" charset="-122"/>
+                <a:cs typeface="Calibri" pitchFamily="34" charset="-120"/>
+              </a:rPr>
+              <a:t>— </a:t>
+            </a:r>
+            <a:pPr indent="0" marL="0">
+              <a:buNone/>
+            </a:pPr>
+            <a:r>
+              <a:rPr lang="en-US" sz="1100" b="1" spc="200" kern="0" dirty="0">
+                <a:solidFill>
+                  <a:srgbClr val="52514E"/>
+                </a:solidFill>
+                <a:latin typeface="Calibri" pitchFamily="34" charset="0"/>
+                <a:ea typeface="Calibri" pitchFamily="34" charset="-122"/>
+                <a:cs typeface="Calibri" pitchFamily="34" charset="-120"/>
+              </a:rPr>
+              <a:t>FORWARD VIEW — ACCOUNTING ALIGNMENT</a:t>
+            </a:r>
+            <a:endParaRPr lang="en-US" sz="1100" dirty="0"/>
+          </a:p>
+        </p:txBody>
+      </p:sp>
+      <p:sp>
+        <p:nvSpPr>
+          <p:cNvPr id="3" name="Text 1"/>
+          <p:cNvSpPr/>
+          <p:nvPr/>
+        </p:nvSpPr>
+        <p:spPr>
+          <a:xfrm>
+            <a:off x="548640" y="548640"/>
+            <a:ext cx="11064240" cy="502920"/>
+          </a:xfrm>
+          <a:prstGeom prst="rect">
+            <a:avLst/>
+          </a:prstGeom>
+          <a:noFill/>
+          <a:ln/>
+        </p:spPr>
+        <p:txBody>
+          <a:bodyPr wrap="square" lIns="0" tIns="0" rIns="0" bIns="0" rtlCol="0" anchor="ctr"/>
+          <a:lstStyle/>
+          <a:p>
+            <a:pPr indent="0" marL="0">
+              <a:buNone/>
+            </a:pPr>
+            <a:r>
+              <a:rPr lang="en-US" sz="2700" b="1" dirty="0">
+                <a:solidFill>
+                  <a:srgbClr val="0B0B0B"/>
+                </a:solidFill>
+                <a:latin typeface="Calibri" pitchFamily="34" charset="0"/>
+                <a:ea typeface="Calibri" pitchFamily="34" charset="-122"/>
+                <a:cs typeface="Calibri" pitchFamily="34" charset="-120"/>
+              </a:rPr>
+              <a:t>EPC bid engineering: an item to clean up, not a crisis</a:t>
+            </a:r>
+            <a:endParaRPr lang="en-US" sz="2700" dirty="0"/>
+          </a:p>
+        </p:txBody>
+      </p:sp>
+      <p:sp>
+        <p:nvSpPr>
+          <p:cNvPr id="4" name="Text 2"/>
+          <p:cNvSpPr/>
+          <p:nvPr/>
+        </p:nvSpPr>
+        <p:spPr>
+          <a:xfrm>
+            <a:off x="548640" y="1371600"/>
+            <a:ext cx="4572000" cy="320040"/>
+          </a:xfrm>
+          <a:prstGeom prst="rect">
+            <a:avLst/>
+          </a:prstGeom>
+          <a:noFill/>
+          <a:ln/>
+        </p:spPr>
+        <p:txBody>
+          <a:bodyPr wrap="square" lIns="0" tIns="0" rIns="0" bIns="0" rtlCol="0" anchor="ctr"/>
+          <a:lstStyle/>
+          <a:p>
+            <a:pPr indent="0" marL="0">
+              <a:buNone/>
+            </a:pPr>
+            <a:r>
+              <a:rPr lang="en-US" sz="1600" b="1" dirty="0">
+                <a:solidFill>
+                  <a:srgbClr val="0B0B0B"/>
+                </a:solidFill>
+                <a:latin typeface="Calibri" pitchFamily="34" charset="0"/>
+                <a:ea typeface="Calibri" pitchFamily="34" charset="-122"/>
+                <a:cs typeface="Calibri" pitchFamily="34" charset="-120"/>
+              </a:rPr>
+              <a:t>The facts</a:t>
+            </a:r>
+            <a:endParaRPr lang="en-US" sz="1600" dirty="0"/>
+          </a:p>
+        </p:txBody>
+      </p:sp>
+      <p:sp>
+        <p:nvSpPr>
+          <p:cNvPr id="5" name="Text 3"/>
+          <p:cNvSpPr/>
+          <p:nvPr/>
+        </p:nvSpPr>
+        <p:spPr>
+          <a:xfrm>
+            <a:off x="548640" y="1783080"/>
+            <a:ext cx="4572000" cy="329184"/>
+          </a:xfrm>
+          <a:prstGeom prst="rect">
+            <a:avLst/>
+          </a:prstGeom>
+          <a:noFill/>
+          <a:ln/>
+        </p:spPr>
+        <p:txBody>
+          <a:bodyPr wrap="square" lIns="0" tIns="0" rIns="0" bIns="0" rtlCol="0" anchor="ctr"/>
+          <a:lstStyle/>
+          <a:p>
+            <a:pPr indent="0" marL="0">
+              <a:buNone/>
+            </a:pPr>
+            <a:r>
+              <a:rPr lang="en-US" sz="1700" b="1" dirty="0">
+                <a:solidFill>
+                  <a:srgbClr val="2A78D6"/>
+                </a:solidFill>
+                <a:latin typeface="Calibri" pitchFamily="34" charset="0"/>
+                <a:ea typeface="Calibri" pitchFamily="34" charset="-122"/>
+                <a:cs typeface="Calibri" pitchFamily="34" charset="-120"/>
+              </a:rPr>
+              <a:t>405 hrs</a:t>
+            </a:r>
+            <a:endParaRPr lang="en-US" sz="1700" dirty="0"/>
+          </a:p>
+        </p:txBody>
+      </p:sp>
+      <p:sp>
+        <p:nvSpPr>
+          <p:cNvPr id="6" name="Text 4"/>
+          <p:cNvSpPr/>
+          <p:nvPr/>
+        </p:nvSpPr>
+        <p:spPr>
+          <a:xfrm>
+            <a:off x="548640" y="2112264"/>
+            <a:ext cx="4572000" cy="658368"/>
+          </a:xfrm>
+          <a:prstGeom prst="rect">
+            <a:avLst/>
+          </a:prstGeom>
+          <a:noFill/>
+          <a:ln/>
+        </p:spPr>
+        <p:txBody>
+          <a:bodyPr wrap="square" lIns="0" tIns="0" rIns="0" bIns="0" rtlCol="0" anchor="ctr"/>
+          <a:lstStyle/>
+          <a:p>
+            <a:pPr indent="0" marL="0">
+              <a:buNone/>
+            </a:pPr>
+            <a:r>
+              <a:rPr lang="en-US" sz="1050" dirty="0">
+                <a:solidFill>
+                  <a:srgbClr val="52514E"/>
+                </a:solidFill>
+                <a:latin typeface="Calibri" pitchFamily="34" charset="0"/>
+                <a:ea typeface="Calibri" pitchFamily="34" charset="-122"/>
+                <a:cs typeface="Calibri" pitchFamily="34" charset="-120"/>
+              </a:rPr>
+              <a:t>of bid engineering YTD — ≈$62.6K at card rates ($38.5K at cost), unbilled</a:t>
+            </a:r>
+            <a:endParaRPr lang="en-US" sz="1050" dirty="0"/>
+          </a:p>
+        </p:txBody>
+      </p:sp>
+      <p:sp>
+        <p:nvSpPr>
+          <p:cNvPr id="7" name="Text 5"/>
+          <p:cNvSpPr/>
+          <p:nvPr/>
+        </p:nvSpPr>
+        <p:spPr>
+          <a:xfrm>
+            <a:off x="548640" y="2807208"/>
+            <a:ext cx="4572000" cy="329184"/>
+          </a:xfrm>
+          <a:prstGeom prst="rect">
+            <a:avLst/>
+          </a:prstGeom>
+          <a:noFill/>
+          <a:ln/>
+        </p:spPr>
+        <p:txBody>
+          <a:bodyPr wrap="square" lIns="0" tIns="0" rIns="0" bIns="0" rtlCol="0" anchor="ctr"/>
+          <a:lstStyle/>
+          <a:p>
+            <a:pPr indent="0" marL="0">
+              <a:buNone/>
+            </a:pPr>
+            <a:r>
+              <a:rPr lang="en-US" sz="1700" b="1" dirty="0">
+                <a:solidFill>
+                  <a:srgbClr val="2A78D6"/>
+                </a:solidFill>
+                <a:latin typeface="Calibri" pitchFamily="34" charset="0"/>
+                <a:ea typeface="Calibri" pitchFamily="34" charset="-122"/>
+                <a:cs typeface="Calibri" pitchFamily="34" charset="-120"/>
+              </a:rPr>
+              <a:t>~60% design</a:t>
+            </a:r>
+            <a:endParaRPr lang="en-US" sz="1700" dirty="0"/>
+          </a:p>
+        </p:txBody>
+      </p:sp>
+      <p:sp>
+        <p:nvSpPr>
+          <p:cNvPr id="8" name="Text 6"/>
+          <p:cNvSpPr/>
+          <p:nvPr/>
+        </p:nvSpPr>
+        <p:spPr>
+          <a:xfrm>
+            <a:off x="548640" y="3136392"/>
+            <a:ext cx="4572000" cy="658368"/>
+          </a:xfrm>
+          <a:prstGeom prst="rect">
+            <a:avLst/>
+          </a:prstGeom>
+          <a:noFill/>
+          <a:ln/>
+        </p:spPr>
+        <p:txBody>
+          <a:bodyPr wrap="square" lIns="0" tIns="0" rIns="0" bIns="0" rtlCol="0" anchor="ctr"/>
+          <a:lstStyle/>
+          <a:p>
+            <a:pPr indent="0" marL="0">
+              <a:buNone/>
+            </a:pPr>
+            <a:r>
+              <a:rPr lang="en-US" sz="1050" dirty="0">
+                <a:solidFill>
+                  <a:srgbClr val="52514E"/>
+                </a:solidFill>
+                <a:latin typeface="Calibri" pitchFamily="34" charset="0"/>
+                <a:ea typeface="Calibri" pitchFamily="34" charset="-122"/>
+                <a:cs typeface="Calibri" pitchFamily="34" charset="-120"/>
+              </a:rPr>
+              <a:t>required before a fixed-price EPC bid can even be submitted — $200–300K of pre-award exposure on the $9.1M bid slate still in market</a:t>
+            </a:r>
+            <a:endParaRPr lang="en-US" sz="1050" dirty="0"/>
+          </a:p>
+        </p:txBody>
+      </p:sp>
+      <p:sp>
+        <p:nvSpPr>
+          <p:cNvPr id="9" name="Text 7"/>
+          <p:cNvSpPr/>
+          <p:nvPr/>
+        </p:nvSpPr>
+        <p:spPr>
+          <a:xfrm>
+            <a:off x="548640" y="3831336"/>
+            <a:ext cx="4572000" cy="329184"/>
+          </a:xfrm>
+          <a:prstGeom prst="rect">
+            <a:avLst/>
+          </a:prstGeom>
+          <a:noFill/>
+          <a:ln/>
+        </p:spPr>
+        <p:txBody>
+          <a:bodyPr wrap="square" lIns="0" tIns="0" rIns="0" bIns="0" rtlCol="0" anchor="ctr"/>
+          <a:lstStyle/>
+          <a:p>
+            <a:pPr indent="0" marL="0">
+              <a:buNone/>
+            </a:pPr>
+            <a:r>
+              <a:rPr lang="en-US" sz="1700" b="1" dirty="0">
+                <a:solidFill>
+                  <a:srgbClr val="2A78D6"/>
+                </a:solidFill>
+                <a:latin typeface="Calibri" pitchFamily="34" charset="0"/>
+                <a:ea typeface="Calibri" pitchFamily="34" charset="-122"/>
+                <a:cs typeface="Calibri" pitchFamily="34" charset="-120"/>
+              </a:rPr>
+              <a:t>Absorbed today</a:t>
+            </a:r>
+            <a:endParaRPr lang="en-US" sz="1700" dirty="0"/>
+          </a:p>
+        </p:txBody>
+      </p:sp>
+      <p:sp>
+        <p:nvSpPr>
+          <p:cNvPr id="10" name="Text 8"/>
+          <p:cNvSpPr/>
+          <p:nvPr/>
+        </p:nvSpPr>
+        <p:spPr>
+          <a:xfrm>
+            <a:off x="548640" y="4160520"/>
+            <a:ext cx="4572000" cy="658368"/>
+          </a:xfrm>
+          <a:prstGeom prst="rect">
+            <a:avLst/>
+          </a:prstGeom>
+          <a:noFill/>
+          <a:ln/>
+        </p:spPr>
+        <p:txBody>
+          <a:bodyPr wrap="square" lIns="0" tIns="0" rIns="0" bIns="0" rtlCol="0" anchor="ctr"/>
+          <a:lstStyle/>
+          <a:p>
+            <a:pPr indent="0" marL="0">
+              <a:buNone/>
+            </a:pPr>
+            <a:r>
+              <a:rPr lang="en-US" sz="1050" dirty="0">
+                <a:solidFill>
+                  <a:srgbClr val="52514E"/>
+                </a:solidFill>
+                <a:latin typeface="Calibri" pitchFamily="34" charset="0"/>
+                <a:ea typeface="Calibri" pitchFamily="34" charset="-122"/>
+                <a:cs typeface="Calibri" pitchFamily="34" charset="-120"/>
+              </a:rPr>
+              <a:t>these hours land in CVR's overhead with no offsetting credit — immaterial now, but it compounds as EPC pursuit volume grows</a:t>
+            </a:r>
+            <a:endParaRPr lang="en-US" sz="1050" dirty="0"/>
+          </a:p>
+        </p:txBody>
+      </p:sp>
+      <p:sp>
+        <p:nvSpPr>
+          <p:cNvPr id="11" name="Text 9"/>
+          <p:cNvSpPr/>
+          <p:nvPr/>
+        </p:nvSpPr>
+        <p:spPr>
+          <a:xfrm>
+            <a:off x="548640" y="4855464"/>
+            <a:ext cx="4572000" cy="329184"/>
+          </a:xfrm>
+          <a:prstGeom prst="rect">
+            <a:avLst/>
+          </a:prstGeom>
+          <a:noFill/>
+          <a:ln/>
+        </p:spPr>
+        <p:txBody>
+          <a:bodyPr wrap="square" lIns="0" tIns="0" rIns="0" bIns="0" rtlCol="0" anchor="ctr"/>
+          <a:lstStyle/>
+          <a:p>
+            <a:pPr indent="0" marL="0">
+              <a:buNone/>
+            </a:pPr>
+            <a:r>
+              <a:rPr lang="en-US" sz="1700" b="1" dirty="0">
+                <a:solidFill>
+                  <a:srgbClr val="E34948"/>
+                </a:solidFill>
+                <a:latin typeface="Calibri" pitchFamily="34" charset="0"/>
+                <a:ea typeface="Calibri" pitchFamily="34" charset="-122"/>
+                <a:cs typeface="Calibri" pitchFamily="34" charset="-120"/>
+              </a:rPr>
+              <a:t>The misalignment</a:t>
+            </a:r>
+            <a:endParaRPr lang="en-US" sz="1700" dirty="0"/>
+          </a:p>
+        </p:txBody>
+      </p:sp>
+      <p:sp>
+        <p:nvSpPr>
+          <p:cNvPr id="12" name="Text 10"/>
+          <p:cNvSpPr/>
+          <p:nvPr/>
+        </p:nvSpPr>
+        <p:spPr>
+          <a:xfrm>
+            <a:off x="548640" y="5184648"/>
+            <a:ext cx="4572000" cy="658368"/>
+          </a:xfrm>
+          <a:prstGeom prst="rect">
+            <a:avLst/>
+          </a:prstGeom>
+          <a:noFill/>
+          <a:ln/>
+        </p:spPr>
+        <p:txBody>
+          <a:bodyPr wrap="square" lIns="0" tIns="0" rIns="0" bIns="0" rtlCol="0" anchor="ctr"/>
+          <a:lstStyle/>
+          <a:p>
+            <a:pPr indent="0" marL="0">
+              <a:buNone/>
+            </a:pPr>
+            <a:r>
+              <a:rPr lang="en-US" sz="1050" dirty="0">
+                <a:solidFill>
+                  <a:srgbClr val="52514E"/>
+                </a:solidFill>
+                <a:latin typeface="Calibri" pitchFamily="34" charset="0"/>
+                <a:ea typeface="Calibri" pitchFamily="34" charset="-122"/>
+                <a:cs typeface="Calibri" pitchFamily="34" charset="-120"/>
+              </a:rPr>
+              <a:t>bid hours are non-billable, so every EPC pursuit CVR supports drags the metrics CVR is judged on — utilization, realization, OILI</a:t>
+            </a:r>
+            <a:endParaRPr lang="en-US" sz="1050" dirty="0"/>
+          </a:p>
+        </p:txBody>
+      </p:sp>
+      <p:sp>
+        <p:nvSpPr>
+          <p:cNvPr id="13" name="Shape 11"/>
+          <p:cNvSpPr/>
+          <p:nvPr/>
+        </p:nvSpPr>
+        <p:spPr>
+          <a:xfrm>
+            <a:off x="5577840" y="1371600"/>
+            <a:ext cx="6035040" cy="1353312"/>
+          </a:xfrm>
+          <a:prstGeom prst="roundRect">
+            <a:avLst>
+              <a:gd name="adj" fmla="val 4054"/>
+            </a:avLst>
+          </a:prstGeom>
+          <a:solidFill>
+            <a:srgbClr val="EAF1FA"/>
+          </a:solidFill>
+          <a:ln w="15875">
+            <a:solidFill>
+              <a:srgbClr val="2A78D6"/>
+            </a:solidFill>
+            <a:prstDash val="solid"/>
+          </a:ln>
+        </p:spPr>
+      </p:sp>
+      <p:sp>
+        <p:nvSpPr>
+          <p:cNvPr id="14" name="Shape 12"/>
+          <p:cNvSpPr/>
+          <p:nvPr/>
+        </p:nvSpPr>
+        <p:spPr>
+          <a:xfrm>
+            <a:off x="5760720" y="1536192"/>
+            <a:ext cx="384048" cy="384048"/>
+          </a:xfrm>
+          <a:prstGeom prst="ellipse">
+            <a:avLst/>
+          </a:prstGeom>
+          <a:solidFill>
+            <a:srgbClr val="2A78D6"/>
+          </a:solidFill>
+          <a:ln/>
+        </p:spPr>
+      </p:sp>
+      <p:sp>
+        <p:nvSpPr>
+          <p:cNvPr id="15" name="Text 13"/>
+          <p:cNvSpPr/>
+          <p:nvPr/>
+        </p:nvSpPr>
+        <p:spPr>
+          <a:xfrm>
+            <a:off x="5760720" y="1536192"/>
+            <a:ext cx="384048" cy="384048"/>
+          </a:xfrm>
+          <a:prstGeom prst="rect">
+            <a:avLst/>
+          </a:prstGeom>
+          <a:noFill/>
+          <a:ln/>
+        </p:spPr>
+        <p:txBody>
+          <a:bodyPr wrap="square" lIns="0" tIns="0" rIns="0" bIns="0" rtlCol="0" anchor="ctr"/>
+          <a:lstStyle/>
+          <a:p>
+            <a:pPr algn="ctr" indent="0" marL="0">
+              <a:buNone/>
+            </a:pPr>
+            <a:r>
+              <a:rPr lang="en-US" sz="1500" b="1" dirty="0">
+                <a:solidFill>
+                  <a:srgbClr val="FFFFFF"/>
+                </a:solidFill>
+                <a:latin typeface="Calibri" pitchFamily="34" charset="0"/>
+                <a:ea typeface="Calibri" pitchFamily="34" charset="-122"/>
+                <a:cs typeface="Calibri" pitchFamily="34" charset="-120"/>
+              </a:rPr>
+              <a:t>1</a:t>
+            </a:r>
+            <a:endParaRPr lang="en-US" sz="1500" dirty="0"/>
+          </a:p>
+        </p:txBody>
+      </p:sp>
+      <p:sp>
+        <p:nvSpPr>
+          <p:cNvPr id="16" name="Text 14"/>
+          <p:cNvSpPr/>
+          <p:nvPr/>
+        </p:nvSpPr>
+        <p:spPr>
+          <a:xfrm>
+            <a:off x="6291072" y="1499616"/>
+            <a:ext cx="5120640" cy="292608"/>
+          </a:xfrm>
+          <a:prstGeom prst="rect">
+            <a:avLst/>
+          </a:prstGeom>
+          <a:noFill/>
+          <a:ln/>
+        </p:spPr>
+        <p:txBody>
+          <a:bodyPr wrap="square" lIns="0" tIns="0" rIns="0" bIns="0" rtlCol="0" anchor="ctr"/>
+          <a:lstStyle/>
+          <a:p>
+            <a:pPr indent="0" marL="0">
+              <a:buNone/>
+            </a:pPr>
+            <a:r>
+              <a:rPr lang="en-US" sz="1400" b="1" dirty="0">
+                <a:solidFill>
+                  <a:srgbClr val="0B0B0B"/>
+                </a:solidFill>
+                <a:latin typeface="Calibri" pitchFamily="34" charset="0"/>
+                <a:ea typeface="Calibri" pitchFamily="34" charset="-122"/>
+                <a:cs typeface="Calibri" pitchFamily="34" charset="-120"/>
+              </a:rPr>
+              <a:t>Intercompany bid-support billing</a:t>
+            </a:r>
+            <a:pPr indent="0" marL="0">
+              <a:buNone/>
+            </a:pPr>
+            <a:r>
+              <a:rPr lang="en-US" sz="950" b="1" spc="150" kern="0" dirty="0">
+                <a:solidFill>
+                  <a:srgbClr val="2A78D6"/>
+                </a:solidFill>
+                <a:latin typeface="Calibri" pitchFamily="34" charset="0"/>
+                <a:ea typeface="Calibri" pitchFamily="34" charset="-122"/>
+                <a:cs typeface="Calibri" pitchFamily="34" charset="-120"/>
+              </a:rPr>
+              <a:t>   RECOMMENDED</a:t>
+            </a:r>
+            <a:endParaRPr lang="en-US" sz="1400" dirty="0"/>
+          </a:p>
+        </p:txBody>
+      </p:sp>
+      <p:sp>
+        <p:nvSpPr>
+          <p:cNvPr id="17" name="Text 15"/>
+          <p:cNvSpPr/>
+          <p:nvPr/>
+        </p:nvSpPr>
+        <p:spPr>
+          <a:xfrm>
+            <a:off x="6291072" y="1828800"/>
+            <a:ext cx="5120640" cy="822960"/>
+          </a:xfrm>
+          <a:prstGeom prst="rect">
+            <a:avLst/>
+          </a:prstGeom>
+          <a:noFill/>
+          <a:ln/>
+        </p:spPr>
+        <p:txBody>
+          <a:bodyPr wrap="square" lIns="0" tIns="0" rIns="0" bIns="0" rtlCol="0" anchor="ctr"/>
+          <a:lstStyle/>
+          <a:p>
+            <a:pPr indent="0" marL="0">
+              <a:buNone/>
+            </a:pPr>
+            <a:r>
+              <a:rPr lang="en-US" sz="1050" dirty="0">
+                <a:solidFill>
+                  <a:srgbClr val="52514E"/>
+                </a:solidFill>
+                <a:latin typeface="Calibri" pitchFamily="34" charset="0"/>
+                <a:ea typeface="Calibri" pitchFamily="34" charset="-122"/>
+                <a:cs typeface="Calibri" pitchFamily="34" charset="-120"/>
+              </a:rPr>
+              <a:t>HWC pays CVR for pre-award engineering on EPC pursuits (cost or card). Hours become billable; cost lands where the benefit lands. Standard EPC practice.</a:t>
+            </a:r>
+            <a:endParaRPr lang="en-US" sz="1050" dirty="0"/>
+          </a:p>
+        </p:txBody>
+      </p:sp>
+      <p:sp>
+        <p:nvSpPr>
+          <p:cNvPr id="18" name="Shape 16"/>
+          <p:cNvSpPr/>
+          <p:nvPr/>
+        </p:nvSpPr>
+        <p:spPr>
+          <a:xfrm>
+            <a:off x="5577840" y="2852928"/>
+            <a:ext cx="6035040" cy="1353312"/>
+          </a:xfrm>
+          <a:prstGeom prst="roundRect">
+            <a:avLst>
+              <a:gd name="adj" fmla="val 4054"/>
+            </a:avLst>
+          </a:prstGeom>
+          <a:solidFill>
+            <a:srgbClr val="F7F7F5"/>
+          </a:solidFill>
+          <a:ln w="9525">
+            <a:solidFill>
+              <a:srgbClr val="E1E0D9"/>
+            </a:solidFill>
+            <a:prstDash val="solid"/>
+          </a:ln>
+        </p:spPr>
+      </p:sp>
+      <p:sp>
+        <p:nvSpPr>
+          <p:cNvPr id="19" name="Shape 17"/>
+          <p:cNvSpPr/>
+          <p:nvPr/>
+        </p:nvSpPr>
+        <p:spPr>
+          <a:xfrm>
+            <a:off x="5760720" y="3017520"/>
+            <a:ext cx="384048" cy="384048"/>
+          </a:xfrm>
+          <a:prstGeom prst="ellipse">
+            <a:avLst/>
+          </a:prstGeom>
+          <a:solidFill>
+            <a:srgbClr val="2A78D6"/>
+          </a:solidFill>
+          <a:ln/>
+        </p:spPr>
+      </p:sp>
+      <p:sp>
+        <p:nvSpPr>
+          <p:cNvPr id="20" name="Text 18"/>
+          <p:cNvSpPr/>
+          <p:nvPr/>
+        </p:nvSpPr>
+        <p:spPr>
+          <a:xfrm>
+            <a:off x="5760720" y="3017520"/>
+            <a:ext cx="384048" cy="384048"/>
+          </a:xfrm>
+          <a:prstGeom prst="rect">
+            <a:avLst/>
+          </a:prstGeom>
+          <a:noFill/>
+          <a:ln/>
+        </p:spPr>
+        <p:txBody>
+          <a:bodyPr wrap="square" lIns="0" tIns="0" rIns="0" bIns="0" rtlCol="0" anchor="ctr"/>
+          <a:lstStyle/>
+          <a:p>
+            <a:pPr algn="ctr" indent="0" marL="0">
+              <a:buNone/>
+            </a:pPr>
+            <a:r>
+              <a:rPr lang="en-US" sz="1500" b="1" dirty="0">
+                <a:solidFill>
+                  <a:srgbClr val="FFFFFF"/>
+                </a:solidFill>
+                <a:latin typeface="Calibri" pitchFamily="34" charset="0"/>
+                <a:ea typeface="Calibri" pitchFamily="34" charset="-122"/>
+                <a:cs typeface="Calibri" pitchFamily="34" charset="-120"/>
+              </a:rPr>
+              <a:t>2</a:t>
+            </a:r>
+            <a:endParaRPr lang="en-US" sz="1500" dirty="0"/>
+          </a:p>
+        </p:txBody>
+      </p:sp>
+      <p:sp>
+        <p:nvSpPr>
+          <p:cNvPr id="21" name="Text 19"/>
+          <p:cNvSpPr/>
+          <p:nvPr/>
+        </p:nvSpPr>
+        <p:spPr>
+          <a:xfrm>
+            <a:off x="6291072" y="2980944"/>
+            <a:ext cx="5120640" cy="292608"/>
+          </a:xfrm>
+          <a:prstGeom prst="rect">
+            <a:avLst/>
+          </a:prstGeom>
+          <a:noFill/>
+          <a:ln/>
+        </p:spPr>
+        <p:txBody>
+          <a:bodyPr wrap="square" lIns="0" tIns="0" rIns="0" bIns="0" rtlCol="0" anchor="ctr"/>
+          <a:lstStyle/>
+          <a:p>
+            <a:pPr indent="0" marL="0">
+              <a:buNone/>
+            </a:pPr>
+            <a:r>
+              <a:rPr lang="en-US" sz="1400" b="1" dirty="0">
+                <a:solidFill>
+                  <a:srgbClr val="0B0B0B"/>
+                </a:solidFill>
+                <a:latin typeface="Calibri" pitchFamily="34" charset="0"/>
+                <a:ea typeface="Calibri" pitchFamily="34" charset="-122"/>
+                <a:cs typeface="Calibri" pitchFamily="34" charset="-120"/>
+              </a:rPr>
+              <a:t>Win / loss allocation</a:t>
+            </a:r>
+            <a:pPr indent="0" marL="0">
+              <a:buNone/>
+            </a:pPr>
+            <a:endParaRPr lang="en-US" sz="1400" dirty="0"/>
+          </a:p>
+        </p:txBody>
+      </p:sp>
+      <p:sp>
+        <p:nvSpPr>
+          <p:cNvPr id="22" name="Text 20"/>
+          <p:cNvSpPr/>
+          <p:nvPr/>
+        </p:nvSpPr>
+        <p:spPr>
+          <a:xfrm>
+            <a:off x="6291072" y="3310128"/>
+            <a:ext cx="5120640" cy="822960"/>
+          </a:xfrm>
+          <a:prstGeom prst="rect">
+            <a:avLst/>
+          </a:prstGeom>
+          <a:noFill/>
+          <a:ln/>
+        </p:spPr>
+        <p:txBody>
+          <a:bodyPr wrap="square" lIns="0" tIns="0" rIns="0" bIns="0" rtlCol="0" anchor="ctr"/>
+          <a:lstStyle/>
+          <a:p>
+            <a:pPr indent="0" marL="0">
+              <a:buNone/>
+            </a:pPr>
+            <a:r>
+              <a:rPr lang="en-US" sz="1050" dirty="0">
+                <a:solidFill>
+                  <a:srgbClr val="52514E"/>
+                </a:solidFill>
+                <a:latin typeface="Calibri" pitchFamily="34" charset="0"/>
+                <a:ea typeface="Calibri" pitchFamily="34" charset="-122"/>
+                <a:cs typeface="Calibri" pitchFamily="34" charset="-120"/>
+              </a:rPr>
+              <a:t>Bid engineering capitalizes to the pursuit — charged to the job on a win, absorbed by HWC as a BD expense on a loss.</a:t>
+            </a:r>
+            <a:endParaRPr lang="en-US" sz="1050" dirty="0"/>
+          </a:p>
+        </p:txBody>
+      </p:sp>
+      <p:sp>
+        <p:nvSpPr>
+          <p:cNvPr id="23" name="Shape 21"/>
+          <p:cNvSpPr/>
+          <p:nvPr/>
+        </p:nvSpPr>
+        <p:spPr>
+          <a:xfrm>
+            <a:off x="5577840" y="4334256"/>
+            <a:ext cx="6035040" cy="1353312"/>
+          </a:xfrm>
+          <a:prstGeom prst="roundRect">
+            <a:avLst>
+              <a:gd name="adj" fmla="val 4054"/>
+            </a:avLst>
+          </a:prstGeom>
+          <a:solidFill>
+            <a:srgbClr val="F7F7F5"/>
+          </a:solidFill>
+          <a:ln w="9525">
+            <a:solidFill>
+              <a:srgbClr val="E1E0D9"/>
+            </a:solidFill>
+            <a:prstDash val="solid"/>
+          </a:ln>
+        </p:spPr>
+      </p:sp>
+      <p:sp>
+        <p:nvSpPr>
+          <p:cNvPr id="24" name="Shape 22"/>
+          <p:cNvSpPr/>
+          <p:nvPr/>
+        </p:nvSpPr>
+        <p:spPr>
+          <a:xfrm>
+            <a:off x="5760720" y="4498848"/>
+            <a:ext cx="384048" cy="384048"/>
+          </a:xfrm>
+          <a:prstGeom prst="ellipse">
+            <a:avLst/>
+          </a:prstGeom>
+          <a:solidFill>
+            <a:srgbClr val="2A78D6"/>
+          </a:solidFill>
+          <a:ln/>
+        </p:spPr>
+      </p:sp>
+      <p:sp>
+        <p:nvSpPr>
+          <p:cNvPr id="25" name="Text 23"/>
+          <p:cNvSpPr/>
+          <p:nvPr/>
+        </p:nvSpPr>
+        <p:spPr>
+          <a:xfrm>
+            <a:off x="5760720" y="4498848"/>
+            <a:ext cx="384048" cy="384048"/>
+          </a:xfrm>
+          <a:prstGeom prst="rect">
+            <a:avLst/>
+          </a:prstGeom>
+          <a:noFill/>
+          <a:ln/>
+        </p:spPr>
+        <p:txBody>
+          <a:bodyPr wrap="square" lIns="0" tIns="0" rIns="0" bIns="0" rtlCol="0" anchor="ctr"/>
+          <a:lstStyle/>
+          <a:p>
+            <a:pPr algn="ctr" indent="0" marL="0">
+              <a:buNone/>
+            </a:pPr>
+            <a:r>
+              <a:rPr lang="en-US" sz="1500" b="1" dirty="0">
+                <a:solidFill>
+                  <a:srgbClr val="FFFFFF"/>
+                </a:solidFill>
+                <a:latin typeface="Calibri" pitchFamily="34" charset="0"/>
+                <a:ea typeface="Calibri" pitchFamily="34" charset="-122"/>
+                <a:cs typeface="Calibri" pitchFamily="34" charset="-120"/>
+              </a:rPr>
+              <a:t>3</a:t>
+            </a:r>
+            <a:endParaRPr lang="en-US" sz="1500" dirty="0"/>
+          </a:p>
+        </p:txBody>
+      </p:sp>
+      <p:sp>
+        <p:nvSpPr>
+          <p:cNvPr id="26" name="Text 24"/>
+          <p:cNvSpPr/>
+          <p:nvPr/>
+        </p:nvSpPr>
+        <p:spPr>
+          <a:xfrm>
+            <a:off x="6291072" y="4462272"/>
+            <a:ext cx="5120640" cy="292608"/>
+          </a:xfrm>
+          <a:prstGeom prst="rect">
+            <a:avLst/>
+          </a:prstGeom>
+          <a:noFill/>
+          <a:ln/>
+        </p:spPr>
+        <p:txBody>
+          <a:bodyPr wrap="square" lIns="0" tIns="0" rIns="0" bIns="0" rtlCol="0" anchor="ctr"/>
+          <a:lstStyle/>
+          <a:p>
+            <a:pPr indent="0" marL="0">
+              <a:buNone/>
+            </a:pPr>
+            <a:r>
+              <a:rPr lang="en-US" sz="1400" b="1" dirty="0">
+                <a:solidFill>
+                  <a:srgbClr val="0B0B0B"/>
+                </a:solidFill>
+                <a:latin typeface="Calibri" pitchFamily="34" charset="0"/>
+                <a:ea typeface="Calibri" pitchFamily="34" charset="-122"/>
+                <a:cs typeface="Calibri" pitchFamily="34" charset="-120"/>
+              </a:rPr>
+              <a:t>Carve it out of the metrics</a:t>
+            </a:r>
+            <a:pPr indent="0" marL="0">
+              <a:buNone/>
+            </a:pPr>
+            <a:endParaRPr lang="en-US" sz="1400" dirty="0"/>
+          </a:p>
+        </p:txBody>
+      </p:sp>
+      <p:sp>
+        <p:nvSpPr>
+          <p:cNvPr id="27" name="Text 25"/>
+          <p:cNvSpPr/>
+          <p:nvPr/>
+        </p:nvSpPr>
+        <p:spPr>
+          <a:xfrm>
+            <a:off x="6291072" y="4791456"/>
+            <a:ext cx="5120640" cy="822960"/>
+          </a:xfrm>
+          <a:prstGeom prst="rect">
+            <a:avLst/>
+          </a:prstGeom>
+          <a:noFill/>
+          <a:ln/>
+        </p:spPr>
+        <p:txBody>
+          <a:bodyPr wrap="square" lIns="0" tIns="0" rIns="0" bIns="0" rtlCol="0" anchor="ctr"/>
+          <a:lstStyle/>
+          <a:p>
+            <a:pPr indent="0" marL="0">
+              <a:buNone/>
+            </a:pPr>
+            <a:r>
+              <a:rPr lang="en-US" sz="1050" dirty="0">
+                <a:solidFill>
+                  <a:srgbClr val="52514E"/>
+                </a:solidFill>
+                <a:latin typeface="Calibri" pitchFamily="34" charset="0"/>
+                <a:ea typeface="Calibri" pitchFamily="34" charset="-122"/>
+                <a:cs typeface="Calibri" pitchFamily="34" charset="-120"/>
+              </a:rPr>
+              <a:t>Track bid-support hours in a separate BD cost pool so CVR's utilization and realization aren't penalized for pursuit work — a reporting fix, not a cash fix.</a:t>
+            </a:r>
+            <a:endParaRPr lang="en-US" sz="1050" dirty="0"/>
+          </a:p>
+        </p:txBody>
+      </p:sp>
+      <p:sp>
+        <p:nvSpPr>
+          <p:cNvPr id="28" name="Shape 26"/>
+          <p:cNvSpPr/>
+          <p:nvPr/>
+        </p:nvSpPr>
+        <p:spPr>
+          <a:xfrm>
+            <a:off x="548640" y="5897880"/>
+            <a:ext cx="11064240" cy="457200"/>
+          </a:xfrm>
+          <a:prstGeom prst="roundRect">
+            <a:avLst>
+              <a:gd name="adj" fmla="val 10000"/>
+            </a:avLst>
+          </a:prstGeom>
+          <a:solidFill>
+            <a:srgbClr val="EAF1FA"/>
+          </a:solidFill>
+          <a:ln w="9525">
+            <a:solidFill>
+              <a:srgbClr val="E1E0D9"/>
+            </a:solidFill>
+            <a:prstDash val="solid"/>
+          </a:ln>
+        </p:spPr>
+      </p:sp>
+      <p:sp>
+        <p:nvSpPr>
+          <p:cNvPr id="29" name="Text 27"/>
+          <p:cNvSpPr/>
+          <p:nvPr/>
+        </p:nvSpPr>
+        <p:spPr>
+          <a:xfrm>
+            <a:off x="731520" y="5952744"/>
+            <a:ext cx="10698480" cy="347472"/>
+          </a:xfrm>
+          <a:prstGeom prst="rect">
+            <a:avLst/>
+          </a:prstGeom>
+          <a:noFill/>
+          <a:ln/>
+        </p:spPr>
+        <p:txBody>
+          <a:bodyPr wrap="square" lIns="0" tIns="0" rIns="0" bIns="0" rtlCol="0" anchor="ctr"/>
+          <a:lstStyle/>
+          <a:p>
+            <a:pPr indent="0" marL="0">
+              <a:buNone/>
+            </a:pPr>
+            <a:r>
+              <a:rPr lang="en-US" sz="1200" b="1" dirty="0">
+                <a:solidFill>
+                  <a:srgbClr val="0B0B0B"/>
+                </a:solidFill>
+                <a:latin typeface="Calibri" pitchFamily="34" charset="0"/>
+                <a:ea typeface="Calibri" pitchFamily="34" charset="-122"/>
+                <a:cs typeface="Calibri" pitchFamily="34" charset="-120"/>
+              </a:rPr>
+              <a:t>The ask is alignment, not subsidy.  </a:t>
+            </a:r>
+            <a:pPr indent="0" marL="0">
+              <a:buNone/>
+            </a:pPr>
+            <a:r>
+              <a:rPr lang="en-US" sz="1200" dirty="0">
+                <a:solidFill>
+                  <a:srgbClr val="52514E"/>
+                </a:solidFill>
+                <a:latin typeface="Calibri" pitchFamily="34" charset="0"/>
+                <a:ea typeface="Calibri" pitchFamily="34" charset="-122"/>
+                <a:cs typeface="Calibri" pitchFamily="34" charset="-120"/>
+              </a:rPr>
+              <a:t>The dollars are small today — but as EPC volume scales, the accounting should reward the pursuit behavior the strategy demands.</a:t>
+            </a:r>
+            <a:endParaRPr lang="en-US" sz="1200" dirty="0"/>
+          </a:p>
+        </p:txBody>
+      </p:sp>
+      <p:sp>
+        <p:nvSpPr>
+          <p:cNvPr id="30" name="Text 28"/>
+          <p:cNvSpPr/>
+          <p:nvPr/>
+        </p:nvSpPr>
+        <p:spPr>
+          <a:xfrm>
+            <a:off x="548640" y="6419088"/>
+            <a:ext cx="11064240" cy="320040"/>
+          </a:xfrm>
+          <a:prstGeom prst="rect">
+            <a:avLst/>
+          </a:prstGeom>
+          <a:noFill/>
+          <a:ln/>
+        </p:spPr>
+        <p:txBody>
+          <a:bodyPr wrap="square" lIns="0" tIns="0" rIns="0" bIns="0" rtlCol="0" anchor="ctr"/>
+          <a:lstStyle/>
+          <a:p>
+            <a:pPr indent="0" marL="0">
+              <a:buNone/>
+            </a:pPr>
+            <a:r>
+              <a:rPr lang="en-US" sz="950" dirty="0">
+                <a:solidFill>
+                  <a:srgbClr val="898781"/>
+                </a:solidFill>
+                <a:latin typeface="Calibri" pitchFamily="34" charset="0"/>
+                <a:ea typeface="Calibri" pitchFamily="34" charset="-122"/>
+                <a:cs typeface="Calibri" pitchFamily="34" charset="-120"/>
+              </a:rPr>
+              <a:t>Bid hours per the KPI report (through 7/11/26). Raise with the CFO as an EPC accounting-alignment item.</a:t>
+            </a:r>
+            <a:endParaRPr lang="en-US" sz="950" dirty="0"/>
+          </a:p>
+        </p:txBody>
+      </p:sp>
+    </p:spTree>
+  </p:cSld>
+  <p:clrMapOvr>
+    <a:masterClrMapping/>
+  </p:clrMapOvr>
+</p:sld>
+</file>
+
+<file path=ppt/slides/slide23.xml><?xml version="1.0" encoding="utf-8"?>
+<p:sld xmlns:a="http://schemas.openxmlformats.org/drawingml/2006/main" xmlns:r="http://schemas.openxmlformats.org/officeDocument/2006/relationships" xmlns:p="http://schemas.openxmlformats.org/presentationml/2006/main">
+  <p:cSld name="Slide 23">
     <p:bg>
       <p:bgPr>
         <a:solidFill>

</xml_diff>

<commit_message>
Add CEO/COO ask slide + FY-Summary at-scale block; lead priorities with BD hire
Deck now closes on the investment ask: a dedicated BD resource (~$300K/yr
all-in) to convert AEP and FirstEnergy (both warm), with warm-target cards,
payback tiles (one EPC win covers it; $7.6M at-scale upside), and a decision
line. Priorities #1 becomes 'Fund the BD resource — now.'

Workbook: FY Summary surfaces the at-scale model (managed revenue, operating
income, OILI margin, multiple of goal) beside the near-term scenarios.
</commit_message>
<xml_diff>
--- a/reports/CVR_Deck_Jun2026.pptx
+++ b/reports/CVR_Deck_Jun2026.pptx
@@ -28,9 +28,10 @@
     <p:sldId id="276" r:id="rId22"/>
     <p:sldId id="277" r:id="rId23"/>
     <p:sldId id="278" r:id="rId24"/>
+    <p:sldId id="279" r:id="rId25"/>
   </p:sldIdLst>
   <p:notesMasterIdLst>
-    <p:notesMasterId r:id="rId25"/>
+    <p:notesMasterId r:id="rId26"/>
   </p:notesMasterIdLst>
   <p:sldSz cx="12192000" cy="6858000"/>
   <p:notesSz cx="6858000" cy="12192000"/>
@@ -1868,6 +1869,94 @@
             <a:fld id="{F7021451-1387-4CA6-816F-3879F97B5CBC}" type="slidenum">
               <a:rPr lang="en-US"/>
               <a:t>23</a:t>
+            </a:fld>
+            <a:endParaRPr lang="en-US"/>
+          </a:p>
+        </p:txBody>
+      </p:sp>
+    </p:spTree>
+    <p:extLst>
+      <p:ext uri="{BB962C8B-B14F-4D97-AF65-F5344CB8AC3E}">
+        <p14:creationId xmlns:p14="http://schemas.microsoft.com/office/powerpoint/2010/main" val="1024086991"/>
+      </p:ext>
+    </p:extLst>
+  </p:cSld>
+  <p:clrMapOvr>
+    <a:masterClrMapping/>
+  </p:clrMapOvr>
+</p:notes>
+</file>
+
+<file path=ppt/notesSlides/notesSlide24.xml><?xml version="1.0" encoding="utf-8"?>
+<p:notes xmlns:a="http://schemas.openxmlformats.org/drawingml/2006/main" xmlns:r="http://schemas.openxmlformats.org/officeDocument/2006/relationships" xmlns:p="http://schemas.openxmlformats.org/presentationml/2006/main">
+  <p:cSld>
+    <p:spTree>
+      <p:nvGrpSpPr>
+        <p:cNvPr id="1" name=""/>
+        <p:cNvGrpSpPr/>
+        <p:nvPr/>
+      </p:nvGrpSpPr>
+      <p:grpSpPr>
+        <a:xfrm>
+          <a:off x="0" y="0"/>
+          <a:ext cx="0" cy="0"/>
+          <a:chOff x="0" y="0"/>
+          <a:chExt cx="0" cy="0"/>
+        </a:xfrm>
+      </p:grpSpPr>
+      <p:sp>
+        <p:nvSpPr>
+          <p:cNvPr id="2" name="Slide Image Placeholder 1"/>
+          <p:cNvSpPr>
+            <a:spLocks noGrp="1" noRot="1" noChangeAspect="1"/>
+          </p:cNvSpPr>
+          <p:nvPr>
+            <p:ph type="sldImg"/>
+          </p:nvPr>
+        </p:nvSpPr>
+        <p:spPr/>
+      </p:sp>
+      <p:sp>
+        <p:nvSpPr>
+          <p:cNvPr id="3" name="Notes Placeholder 2"/>
+          <p:cNvSpPr>
+            <a:spLocks noGrp="1"/>
+          </p:cNvSpPr>
+          <p:nvPr>
+            <p:ph type="body" idx="1"/>
+          </p:nvPr>
+        </p:nvSpPr>
+        <p:spPr/>
+        <p:txBody>
+          <a:bodyPr/>
+          <a:lstStyle/>
+          <a:p>
+            <a:r>
+              <a:rPr lang="en-US" dirty="0"/>
+              <a:t/>
+            </a:r>
+            <a:endParaRPr lang="en-US" dirty="0"/>
+          </a:p>
+        </p:txBody>
+      </p:sp>
+      <p:sp>
+        <p:nvSpPr>
+          <p:cNvPr id="4" name="Slide Number Placeholder 3"/>
+          <p:cNvSpPr>
+            <a:spLocks noGrp="1"/>
+          </p:cNvSpPr>
+          <p:nvPr>
+            <p:ph type="sldNum" sz="quarter" idx="10"/>
+          </p:nvPr>
+        </p:nvSpPr>
+        <p:spPr/>
+        <p:txBody>
+          <a:bodyPr/>
+          <a:lstStyle/>
+          <a:p>
+            <a:fld id="{F7021451-1387-4CA6-816F-3879F97B5CBC}" type="slidenum">
+              <a:rPr lang="en-US"/>
+              <a:t>24</a:t>
             </a:fld>
             <a:endParaRPr lang="en-US"/>
           </a:p>
@@ -27630,7 +27719,7 @@
                 <a:ea typeface="Calibri" pitchFamily="34" charset="-122"/>
                 <a:cs typeface="Calibri" pitchFamily="34" charset="-120"/>
               </a:rPr>
-              <a:t>Close the realization gap</a:t>
+              <a:t>Fund the BD resource — now</a:t>
             </a:r>
             <a:endParaRPr lang="en-US" sz="1600" dirty="0"/>
           </a:p>
@@ -27669,7 +27758,7 @@
                 <a:ea typeface="Calibri" pitchFamily="34" charset="-122"/>
                 <a:cs typeface="Calibri" pitchFamily="34" charset="-120"/>
               </a:rPr>
-              <a:t>Decompose the $145K H1 gap: confirm intercompany rate treatment for HWC work, chase billing lag, stop write-offs. Worth up to $32 more per billable hour.</a:t>
+              <a:t>One dedicated BD hire (~$300K/yr all-in) to convert AEP and FirstEnergy — both warm. A single mid-size EPC award pays it back in year one.</a:t>
             </a:r>
             <a:endParaRPr lang="en-US" sz="1200" dirty="0"/>
           </a:p>
@@ -27767,7 +27856,7 @@
                 <a:ea typeface="Calibri" pitchFamily="34" charset="-122"/>
                 <a:cs typeface="Calibri" pitchFamily="34" charset="-120"/>
               </a:rPr>
-              <a:t>Lift utilization toward targets</a:t>
+              <a:t>Win the near-term pipeline</a:t>
             </a:r>
             <a:endParaRPr lang="en-US" sz="1600" dirty="0"/>
           </a:p>
@@ -27806,7 +27895,7 @@
                 <a:ea typeface="Calibri" pitchFamily="34" charset="-122"/>
                 <a:cs typeface="Calibri" pitchFamily="34" charset="-120"/>
               </a:rPr>
-              <a:t>Focused plans for the three largest gaps; fill non-billable time with the bid backlog. Reaching targets adds ~27% capacity with zero hires.</a:t>
+              <a:t>Lansing BWL audit is the biggest swing ($1,350K); land the Hoosier/Consumers EPC-paired work — each EPC win pulls engineering + material margin to CVR.</a:t>
             </a:r>
             <a:endParaRPr lang="en-US" sz="1200" dirty="0"/>
           </a:p>
@@ -27904,7 +27993,7 @@
                 <a:ea typeface="Calibri" pitchFamily="34" charset="-122"/>
                 <a:cs typeface="Calibri" pitchFamily="34" charset="-120"/>
               </a:rPr>
-              <a:t>Win the Q4 pipeline</a:t>
+              <a:t>Lift utilization and realization</a:t>
             </a:r>
             <a:endParaRPr lang="en-US" sz="1600" dirty="0"/>
           </a:p>
@@ -27943,7 +28032,7 @@
                 <a:ea typeface="Calibri" pitchFamily="34" charset="-122"/>
                 <a:cs typeface="Calibri" pitchFamily="34" charset="-120"/>
               </a:rPr>
-              <a:t>Lansing BWL audit is the single biggest swing ($1,350K). Land the Hoosier/Consumers EPC-paired work — each EPC win pulls 4–5% engineering scope with it.</a:t>
+              <a:t>Close the $145K H1 realization gap (confirm HWC rate treatment, chase billing lag) and fill non-billable time with the bid backlog — ~27% more capacity, no hires.</a:t>
             </a:r>
             <a:endParaRPr lang="en-US" sz="1200" dirty="0"/>
           </a:p>
@@ -28080,7 +28169,7 @@
                 <a:ea typeface="Calibri" pitchFamily="34" charset="-122"/>
                 <a:cs typeface="Calibri" pitchFamily="34" charset="-120"/>
               </a:rPr>
-              <a:t>July close goes into the actuals-vs-forecast cadence; the monthly cash draw on USC is the early-warning gauge for reporting.</a:t>
+              <a:t>July close into the actuals-vs-forecast cadence; the monthly cash draw on USC is the early-warning gauge for reporting.</a:t>
             </a:r>
             <a:endParaRPr lang="en-US" sz="1200" dirty="0"/>
           </a:p>
@@ -28120,6 +28209,1328 @@
                 <a:cs typeface="Calibri" pitchFamily="34" charset="-120"/>
               </a:rPr>
               <a:t>CVR Engineering · prepared July 2026 · model workbooks and data in the CVR---Financial repository</a:t>
+            </a:r>
+            <a:endParaRPr lang="en-US" sz="950" dirty="0"/>
+          </a:p>
+        </p:txBody>
+      </p:sp>
+    </p:spTree>
+  </p:cSld>
+  <p:clrMapOvr>
+    <a:masterClrMapping/>
+  </p:clrMapOvr>
+</p:sld>
+</file>
+
+<file path=ppt/slides/slide24.xml><?xml version="1.0" encoding="utf-8"?>
+<p:sld xmlns:a="http://schemas.openxmlformats.org/drawingml/2006/main" xmlns:r="http://schemas.openxmlformats.org/officeDocument/2006/relationships" xmlns:p="http://schemas.openxmlformats.org/presentationml/2006/main">
+  <p:cSld name="Slide 24">
+    <p:spTree>
+      <p:nvGrpSpPr>
+        <p:cNvPr id="1" name=""/>
+        <p:cNvGrpSpPr/>
+        <p:nvPr/>
+      </p:nvGrpSpPr>
+      <p:grpSpPr>
+        <a:xfrm>
+          <a:off x="0" y="0"/>
+          <a:ext cx="0" cy="0"/>
+          <a:chOff x="0" y="0"/>
+          <a:chExt cx="0" cy="0"/>
+        </a:xfrm>
+      </p:grpSpPr>
+      <p:sp>
+        <p:nvSpPr>
+          <p:cNvPr id="2" name="Text 0"/>
+          <p:cNvSpPr/>
+          <p:nvPr/>
+        </p:nvSpPr>
+        <p:spPr>
+          <a:xfrm>
+            <a:off x="548640" y="292608"/>
+            <a:ext cx="11064240" cy="274320"/>
+          </a:xfrm>
+          <a:prstGeom prst="rect">
+            <a:avLst/>
+          </a:prstGeom>
+          <a:noFill/>
+          <a:ln/>
+        </p:spPr>
+        <p:txBody>
+          <a:bodyPr wrap="square" lIns="0" tIns="0" rIns="0" bIns="0" rtlCol="0" anchor="ctr"/>
+          <a:lstStyle/>
+          <a:p>
+            <a:pPr indent="0" marL="0">
+              <a:buNone/>
+            </a:pPr>
+            <a:r>
+              <a:rPr lang="en-US" sz="1100" b="1" dirty="0">
+                <a:solidFill>
+                  <a:srgbClr val="86B332"/>
+                </a:solidFill>
+                <a:latin typeface="Calibri" pitchFamily="34" charset="0"/>
+                <a:ea typeface="Calibri" pitchFamily="34" charset="-122"/>
+                <a:cs typeface="Calibri" pitchFamily="34" charset="-120"/>
+              </a:rPr>
+              <a:t>— </a:t>
+            </a:r>
+            <a:pPr indent="0" marL="0">
+              <a:buNone/>
+            </a:pPr>
+            <a:r>
+              <a:rPr lang="en-US" sz="1100" b="1" spc="200" kern="0" dirty="0">
+                <a:solidFill>
+                  <a:srgbClr val="52514E"/>
+                </a:solidFill>
+                <a:latin typeface="Calibri" pitchFamily="34" charset="0"/>
+                <a:ea typeface="Calibri" pitchFamily="34" charset="-122"/>
+                <a:cs typeface="Calibri" pitchFamily="34" charset="-120"/>
+              </a:rPr>
+              <a:t>THE DECISION</a:t>
+            </a:r>
+            <a:endParaRPr lang="en-US" sz="1100" dirty="0"/>
+          </a:p>
+        </p:txBody>
+      </p:sp>
+      <p:sp>
+        <p:nvSpPr>
+          <p:cNvPr id="3" name="Text 1"/>
+          <p:cNvSpPr/>
+          <p:nvPr/>
+        </p:nvSpPr>
+        <p:spPr>
+          <a:xfrm>
+            <a:off x="548640" y="548640"/>
+            <a:ext cx="11064240" cy="502920"/>
+          </a:xfrm>
+          <a:prstGeom prst="rect">
+            <a:avLst/>
+          </a:prstGeom>
+          <a:noFill/>
+          <a:ln/>
+        </p:spPr>
+        <p:txBody>
+          <a:bodyPr wrap="square" lIns="0" tIns="0" rIns="0" bIns="0" rtlCol="0" anchor="ctr"/>
+          <a:lstStyle/>
+          <a:p>
+            <a:pPr indent="0" marL="0">
+              <a:buNone/>
+            </a:pPr>
+            <a:r>
+              <a:rPr lang="en-US" sz="2700" b="1" dirty="0">
+                <a:solidFill>
+                  <a:srgbClr val="0B0B0B"/>
+                </a:solidFill>
+                <a:latin typeface="Calibri" pitchFamily="34" charset="0"/>
+                <a:ea typeface="Calibri" pitchFamily="34" charset="-122"/>
+                <a:cs typeface="Calibri" pitchFamily="34" charset="-120"/>
+              </a:rPr>
+              <a:t>The ask: a BD resource to convert AEP + FirstEnergy</a:t>
+            </a:r>
+            <a:endParaRPr lang="en-US" sz="2700" dirty="0"/>
+          </a:p>
+        </p:txBody>
+      </p:sp>
+      <p:sp>
+        <p:nvSpPr>
+          <p:cNvPr id="4" name="Text 2"/>
+          <p:cNvSpPr/>
+          <p:nvPr/>
+        </p:nvSpPr>
+        <p:spPr>
+          <a:xfrm>
+            <a:off x="548640" y="1170432"/>
+            <a:ext cx="11064240" cy="365760"/>
+          </a:xfrm>
+          <a:prstGeom prst="rect">
+            <a:avLst/>
+          </a:prstGeom>
+          <a:noFill/>
+          <a:ln/>
+        </p:spPr>
+        <p:txBody>
+          <a:bodyPr wrap="square" lIns="0" tIns="0" rIns="0" bIns="0" rtlCol="0" anchor="ctr"/>
+          <a:lstStyle/>
+          <a:p>
+            <a:pPr indent="0" marL="0">
+              <a:buNone/>
+            </a:pPr>
+            <a:r>
+              <a:rPr lang="en-US" sz="1350" dirty="0">
+                <a:solidFill>
+                  <a:srgbClr val="0B0B0B"/>
+                </a:solidFill>
+                <a:latin typeface="Calibri" pitchFamily="34" charset="0"/>
+                <a:ea typeface="Calibri" pitchFamily="34" charset="-122"/>
+                <a:cs typeface="Calibri" pitchFamily="34" charset="-120"/>
+              </a:rPr>
+              <a:t>Two warm IOU targets and a consolidated EPC-with-HWC offering that's ready — the missing piece is dedicated pursuit capacity.</a:t>
+            </a:r>
+            <a:endParaRPr lang="en-US" sz="1350" dirty="0"/>
+          </a:p>
+        </p:txBody>
+      </p:sp>
+      <p:sp>
+        <p:nvSpPr>
+          <p:cNvPr id="5" name="Shape 3"/>
+          <p:cNvSpPr/>
+          <p:nvPr/>
+        </p:nvSpPr>
+        <p:spPr>
+          <a:xfrm>
+            <a:off x="548640" y="1600200"/>
+            <a:ext cx="5303520" cy="1874520"/>
+          </a:xfrm>
+          <a:prstGeom prst="roundRect">
+            <a:avLst>
+              <a:gd name="adj" fmla="val 2927"/>
+            </a:avLst>
+          </a:prstGeom>
+          <a:solidFill>
+            <a:srgbClr val="F7F7F5"/>
+          </a:solidFill>
+          <a:ln w="9525">
+            <a:solidFill>
+              <a:srgbClr val="E1E0D9"/>
+            </a:solidFill>
+            <a:prstDash val="solid"/>
+          </a:ln>
+        </p:spPr>
+      </p:sp>
+      <p:pic>
+        <p:nvPicPr>
+          <p:cNvPr id="6" name="Image 0" descr="/home/user/CVR---Financial/reports/assets/logos/aep.png">    </p:cNvPr>
+          <p:cNvPicPr>
+            <a:picLocks noChangeAspect="1"/>
+          </p:cNvPicPr>
+          <p:nvPr/>
+        </p:nvPicPr>
+        <p:blipFill>
+          <a:blip r:embed="rId1"/>
+          <a:srcRect l="0" r="0" t="0" b="0"/>
+          <a:stretch/>
+        </p:blipFill>
+        <p:spPr>
+          <a:xfrm>
+            <a:off x="768096" y="1783080"/>
+            <a:ext cx="2103120" cy="502920"/>
+          </a:xfrm>
+          <a:prstGeom prst="rect">
+            <a:avLst/>
+          </a:prstGeom>
+        </p:spPr>
+      </p:pic>
+      <p:sp>
+        <p:nvSpPr>
+          <p:cNvPr id="7" name="Text 4"/>
+          <p:cNvSpPr/>
+          <p:nvPr/>
+        </p:nvSpPr>
+        <p:spPr>
+          <a:xfrm>
+            <a:off x="3008376" y="1892808"/>
+            <a:ext cx="2377440" cy="274320"/>
+          </a:xfrm>
+          <a:prstGeom prst="rect">
+            <a:avLst/>
+          </a:prstGeom>
+          <a:noFill/>
+          <a:ln/>
+        </p:spPr>
+        <p:txBody>
+          <a:bodyPr wrap="square" lIns="0" tIns="0" rIns="0" bIns="0" rtlCol="0" anchor="ctr"/>
+          <a:lstStyle/>
+          <a:p>
+            <a:pPr indent="0" marL="0">
+              <a:buNone/>
+            </a:pPr>
+            <a:r>
+              <a:rPr lang="en-US" sz="1000" dirty="0">
+                <a:solidFill>
+                  <a:srgbClr val="52514E"/>
+                </a:solidFill>
+                <a:latin typeface="Calibri" pitchFamily="34" charset="0"/>
+                <a:ea typeface="Calibri" pitchFamily="34" charset="-122"/>
+                <a:cs typeface="Calibri" pitchFamily="34" charset="-120"/>
+              </a:rPr>
+              <a:t>~$78B capital plan · 11-state footprint</a:t>
+            </a:r>
+            <a:endParaRPr lang="en-US" sz="1000" dirty="0"/>
+          </a:p>
+        </p:txBody>
+      </p:sp>
+      <p:sp>
+        <p:nvSpPr>
+          <p:cNvPr id="8" name="Text 5"/>
+          <p:cNvSpPr/>
+          <p:nvPr/>
+        </p:nvSpPr>
+        <p:spPr>
+          <a:xfrm>
+            <a:off x="768096" y="2468880"/>
+            <a:ext cx="4864608" cy="502920"/>
+          </a:xfrm>
+          <a:prstGeom prst="rect">
+            <a:avLst/>
+          </a:prstGeom>
+          <a:noFill/>
+          <a:ln/>
+        </p:spPr>
+        <p:txBody>
+          <a:bodyPr wrap="square" lIns="0" tIns="0" rIns="0" bIns="0" rtlCol="0" anchor="ctr"/>
+          <a:lstStyle/>
+          <a:p>
+            <a:pPr indent="0" marL="0">
+              <a:buNone/>
+            </a:pPr>
+            <a:r>
+              <a:rPr lang="en-US" sz="1100" b="1" dirty="0">
+                <a:solidFill>
+                  <a:srgbClr val="0B0B0B"/>
+                </a:solidFill>
+                <a:latin typeface="Calibri" pitchFamily="34" charset="0"/>
+                <a:ea typeface="Calibri" pitchFamily="34" charset="-122"/>
+                <a:cs typeface="Calibri" pitchFamily="34" charset="-120"/>
+              </a:rPr>
+              <a:t>Why warm:  </a:t>
+            </a:r>
+            <a:pPr indent="0" marL="0">
+              <a:buNone/>
+            </a:pPr>
+            <a:r>
+              <a:rPr lang="en-US" sz="1100" dirty="0">
+                <a:solidFill>
+                  <a:srgbClr val="52514E"/>
+                </a:solidFill>
+                <a:latin typeface="Calibri" pitchFamily="34" charset="0"/>
+                <a:ea typeface="Calibri" pitchFamily="34" charset="-122"/>
+                <a:cs typeface="Calibri" pitchFamily="34" charset="-120"/>
+              </a:rPr>
+              <a:t>New leadership post-BHE takeover; strong Director/PM + procurement relationships (JimC + potential BD).</a:t>
+            </a:r>
+            <a:endParaRPr lang="en-US" sz="1100" dirty="0"/>
+          </a:p>
+        </p:txBody>
+      </p:sp>
+      <p:sp>
+        <p:nvSpPr>
+          <p:cNvPr id="9" name="Text 6"/>
+          <p:cNvSpPr/>
+          <p:nvPr/>
+        </p:nvSpPr>
+        <p:spPr>
+          <a:xfrm>
+            <a:off x="768096" y="2971800"/>
+            <a:ext cx="4864608" cy="457200"/>
+          </a:xfrm>
+          <a:prstGeom prst="rect">
+            <a:avLst/>
+          </a:prstGeom>
+          <a:noFill/>
+          <a:ln/>
+        </p:spPr>
+        <p:txBody>
+          <a:bodyPr wrap="square" lIns="0" tIns="0" rIns="0" bIns="0" rtlCol="0" anchor="ctr"/>
+          <a:lstStyle/>
+          <a:p>
+            <a:pPr indent="0" marL="0">
+              <a:buNone/>
+            </a:pPr>
+            <a:r>
+              <a:rPr lang="en-US" sz="1100" b="1" dirty="0">
+                <a:solidFill>
+                  <a:srgbClr val="0B0B0B"/>
+                </a:solidFill>
+                <a:latin typeface="Calibri" pitchFamily="34" charset="0"/>
+                <a:ea typeface="Calibri" pitchFamily="34" charset="-122"/>
+                <a:cs typeface="Calibri" pitchFamily="34" charset="-120"/>
+              </a:rPr>
+              <a:t>Entry:  </a:t>
+            </a:r>
+            <a:pPr indent="0" marL="0">
+              <a:buNone/>
+            </a:pPr>
+            <a:r>
+              <a:rPr lang="en-US" sz="1100" dirty="0">
+                <a:solidFill>
+                  <a:srgbClr val="52514E"/>
+                </a:solidFill>
+                <a:latin typeface="Calibri" pitchFamily="34" charset="0"/>
+                <a:ea typeface="Calibri" pitchFamily="34" charset="-122"/>
+                <a:cs typeface="Calibri" pitchFamily="34" charset="-120"/>
+              </a:rPr>
+              <a:t>Transmission &amp; distribution substation EPC — CVR engineering + material margin, HWC construction.</a:t>
+            </a:r>
+            <a:endParaRPr lang="en-US" sz="1100" dirty="0"/>
+          </a:p>
+        </p:txBody>
+      </p:sp>
+      <p:sp>
+        <p:nvSpPr>
+          <p:cNvPr id="10" name="Shape 7"/>
+          <p:cNvSpPr/>
+          <p:nvPr/>
+        </p:nvSpPr>
+        <p:spPr>
+          <a:xfrm>
+            <a:off x="6309360" y="1600200"/>
+            <a:ext cx="5303520" cy="1874520"/>
+          </a:xfrm>
+          <a:prstGeom prst="roundRect">
+            <a:avLst>
+              <a:gd name="adj" fmla="val 2927"/>
+            </a:avLst>
+          </a:prstGeom>
+          <a:solidFill>
+            <a:srgbClr val="F7F7F5"/>
+          </a:solidFill>
+          <a:ln w="9525">
+            <a:solidFill>
+              <a:srgbClr val="E1E0D9"/>
+            </a:solidFill>
+            <a:prstDash val="solid"/>
+          </a:ln>
+        </p:spPr>
+      </p:sp>
+      <p:pic>
+        <p:nvPicPr>
+          <p:cNvPr id="11" name="Image 1" descr="/home/user/CVR---Financial/reports/assets/logos/firstenergy.png">    </p:cNvPr>
+          <p:cNvPicPr>
+            <a:picLocks noChangeAspect="1"/>
+          </p:cNvPicPr>
+          <p:nvPr/>
+        </p:nvPicPr>
+        <p:blipFill>
+          <a:blip r:embed="rId2"/>
+          <a:srcRect l="0" r="0" t="0" b="0"/>
+          <a:stretch/>
+        </p:blipFill>
+        <p:spPr>
+          <a:xfrm>
+            <a:off x="6528816" y="1783080"/>
+            <a:ext cx="2103120" cy="502920"/>
+          </a:xfrm>
+          <a:prstGeom prst="rect">
+            <a:avLst/>
+          </a:prstGeom>
+        </p:spPr>
+      </p:pic>
+      <p:sp>
+        <p:nvSpPr>
+          <p:cNvPr id="12" name="Text 8"/>
+          <p:cNvSpPr/>
+          <p:nvPr/>
+        </p:nvSpPr>
+        <p:spPr>
+          <a:xfrm>
+            <a:off x="8769096" y="1892808"/>
+            <a:ext cx="2377440" cy="274320"/>
+          </a:xfrm>
+          <a:prstGeom prst="rect">
+            <a:avLst/>
+          </a:prstGeom>
+          <a:noFill/>
+          <a:ln/>
+        </p:spPr>
+        <p:txBody>
+          <a:bodyPr wrap="square" lIns="0" tIns="0" rIns="0" bIns="0" rtlCol="0" anchor="ctr"/>
+          <a:lstStyle/>
+          <a:p>
+            <a:pPr indent="0" marL="0">
+              <a:buNone/>
+            </a:pPr>
+            <a:r>
+              <a:rPr lang="en-US" sz="1000" dirty="0">
+                <a:solidFill>
+                  <a:srgbClr val="52514E"/>
+                </a:solidFill>
+                <a:latin typeface="Calibri" pitchFamily="34" charset="0"/>
+                <a:ea typeface="Calibri" pitchFamily="34" charset="-122"/>
+                <a:cs typeface="Calibri" pitchFamily="34" charset="-120"/>
+              </a:rPr>
+              <a:t>$36B “Energize365” grid plan (2026–30)</a:t>
+            </a:r>
+            <a:endParaRPr lang="en-US" sz="1000" dirty="0"/>
+          </a:p>
+        </p:txBody>
+      </p:sp>
+      <p:sp>
+        <p:nvSpPr>
+          <p:cNvPr id="13" name="Text 9"/>
+          <p:cNvSpPr/>
+          <p:nvPr/>
+        </p:nvSpPr>
+        <p:spPr>
+          <a:xfrm>
+            <a:off x="6528816" y="2468880"/>
+            <a:ext cx="4864608" cy="502920"/>
+          </a:xfrm>
+          <a:prstGeom prst="rect">
+            <a:avLst/>
+          </a:prstGeom>
+          <a:noFill/>
+          <a:ln/>
+        </p:spPr>
+        <p:txBody>
+          <a:bodyPr wrap="square" lIns="0" tIns="0" rIns="0" bIns="0" rtlCol="0" anchor="ctr"/>
+          <a:lstStyle/>
+          <a:p>
+            <a:pPr indent="0" marL="0">
+              <a:buNone/>
+            </a:pPr>
+            <a:r>
+              <a:rPr lang="en-US" sz="1100" b="1" dirty="0">
+                <a:solidFill>
+                  <a:srgbClr val="0B0B0B"/>
+                </a:solidFill>
+                <a:latin typeface="Calibri" pitchFamily="34" charset="0"/>
+                <a:ea typeface="Calibri" pitchFamily="34" charset="-122"/>
+                <a:cs typeface="Calibri" pitchFamily="34" charset="-120"/>
+              </a:rPr>
+              <a:t>Why warm:  </a:t>
+            </a:r>
+            <a:pPr indent="0" marL="0">
+              <a:buNone/>
+            </a:pPr>
+            <a:r>
+              <a:rPr lang="en-US" sz="1100" dirty="0">
+                <a:solidFill>
+                  <a:srgbClr val="52514E"/>
+                </a:solidFill>
+                <a:latin typeface="Calibri" pitchFamily="34" charset="0"/>
+                <a:ea typeface="Calibri" pitchFamily="34" charset="-122"/>
+                <a:cs typeface="Calibri" pitchFamily="34" charset="-120"/>
+              </a:rPr>
+              <a:t>Key C-suite relationships to leverage — an open door to EPC.</a:t>
+            </a:r>
+            <a:endParaRPr lang="en-US" sz="1100" dirty="0"/>
+          </a:p>
+        </p:txBody>
+      </p:sp>
+      <p:sp>
+        <p:nvSpPr>
+          <p:cNvPr id="14" name="Text 10"/>
+          <p:cNvSpPr/>
+          <p:nvPr/>
+        </p:nvSpPr>
+        <p:spPr>
+          <a:xfrm>
+            <a:off x="6528816" y="2971800"/>
+            <a:ext cx="4864608" cy="457200"/>
+          </a:xfrm>
+          <a:prstGeom prst="rect">
+            <a:avLst/>
+          </a:prstGeom>
+          <a:noFill/>
+          <a:ln/>
+        </p:spPr>
+        <p:txBody>
+          <a:bodyPr wrap="square" lIns="0" tIns="0" rIns="0" bIns="0" rtlCol="0" anchor="ctr"/>
+          <a:lstStyle/>
+          <a:p>
+            <a:pPr indent="0" marL="0">
+              <a:buNone/>
+            </a:pPr>
+            <a:r>
+              <a:rPr lang="en-US" sz="1100" b="1" dirty="0">
+                <a:solidFill>
+                  <a:srgbClr val="0B0B0B"/>
+                </a:solidFill>
+                <a:latin typeface="Calibri" pitchFamily="34" charset="0"/>
+                <a:ea typeface="Calibri" pitchFamily="34" charset="-122"/>
+                <a:cs typeface="Calibri" pitchFamily="34" charset="-120"/>
+              </a:rPr>
+              <a:t>Entry:  </a:t>
+            </a:r>
+            <a:pPr indent="0" marL="0">
+              <a:buNone/>
+            </a:pPr>
+            <a:r>
+              <a:rPr lang="en-US" sz="1100" dirty="0">
+                <a:solidFill>
+                  <a:srgbClr val="52514E"/>
+                </a:solidFill>
+                <a:latin typeface="Calibri" pitchFamily="34" charset="0"/>
+                <a:ea typeface="Calibri" pitchFamily="34" charset="-122"/>
+                <a:cs typeface="Calibri" pitchFamily="34" charset="-120"/>
+              </a:rPr>
+              <a:t>Grid-modernization &amp; substation programs across OH · PA · NJ · WV · MD.</a:t>
+            </a:r>
+            <a:endParaRPr lang="en-US" sz="1100" dirty="0"/>
+          </a:p>
+        </p:txBody>
+      </p:sp>
+      <p:sp>
+        <p:nvSpPr>
+          <p:cNvPr id="15" name="Shape 11"/>
+          <p:cNvSpPr/>
+          <p:nvPr/>
+        </p:nvSpPr>
+        <p:spPr>
+          <a:xfrm>
+            <a:off x="548640" y="3611880"/>
+            <a:ext cx="11064240" cy="603504"/>
+          </a:xfrm>
+          <a:prstGeom prst="roundRect">
+            <a:avLst>
+              <a:gd name="adj" fmla="val 9091"/>
+            </a:avLst>
+          </a:prstGeom>
+          <a:solidFill>
+            <a:srgbClr val="EAF1FA"/>
+          </a:solidFill>
+          <a:ln w="12700">
+            <a:solidFill>
+              <a:srgbClr val="2A78D6"/>
+            </a:solidFill>
+            <a:prstDash val="solid"/>
+          </a:ln>
+        </p:spPr>
+      </p:sp>
+      <p:sp>
+        <p:nvSpPr>
+          <p:cNvPr id="16" name="Text 12"/>
+          <p:cNvSpPr/>
+          <p:nvPr/>
+        </p:nvSpPr>
+        <p:spPr>
+          <a:xfrm>
+            <a:off x="777240" y="3611880"/>
+            <a:ext cx="10607040" cy="603504"/>
+          </a:xfrm>
+          <a:prstGeom prst="rect">
+            <a:avLst/>
+          </a:prstGeom>
+          <a:noFill/>
+          <a:ln/>
+        </p:spPr>
+        <p:txBody>
+          <a:bodyPr wrap="square" lIns="0" tIns="0" rIns="0" bIns="0" rtlCol="0" anchor="ctr"/>
+          <a:lstStyle/>
+          <a:p>
+            <a:pPr indent="0" marL="0">
+              <a:buNone/>
+            </a:pPr>
+            <a:r>
+              <a:rPr lang="en-US" sz="1600" b="1" dirty="0">
+                <a:solidFill>
+                  <a:srgbClr val="2A78D6"/>
+                </a:solidFill>
+                <a:latin typeface="Calibri" pitchFamily="34" charset="0"/>
+                <a:ea typeface="Calibri" pitchFamily="34" charset="-122"/>
+                <a:cs typeface="Calibri" pitchFamily="34" charset="-120"/>
+              </a:rPr>
+              <a:t>The ask:  </a:t>
+            </a:r>
+            <a:pPr indent="0" marL="0">
+              <a:buNone/>
+            </a:pPr>
+            <a:r>
+              <a:rPr lang="en-US" sz="1600" b="1" dirty="0">
+                <a:solidFill>
+                  <a:srgbClr val="0B0B0B"/>
+                </a:solidFill>
+                <a:latin typeface="Calibri" pitchFamily="34" charset="0"/>
+                <a:ea typeface="Calibri" pitchFamily="34" charset="-122"/>
+                <a:cs typeface="Calibri" pitchFamily="34" charset="-120"/>
+              </a:rPr>
+              <a:t>fund one BD resource now — </a:t>
+            </a:r>
+            <a:pPr indent="0" marL="0">
+              <a:buNone/>
+            </a:pPr>
+            <a:r>
+              <a:rPr lang="en-US" sz="1600" b="1" dirty="0">
+                <a:solidFill>
+                  <a:srgbClr val="2A78D6"/>
+                </a:solidFill>
+                <a:latin typeface="Calibri" pitchFamily="34" charset="0"/>
+                <a:ea typeface="Calibri" pitchFamily="34" charset="-122"/>
+                <a:cs typeface="Calibri" pitchFamily="34" charset="-120"/>
+              </a:rPr>
+              <a:t>~$300K/yr all-in</a:t>
+            </a:r>
+            <a:pPr indent="0" marL="0">
+              <a:buNone/>
+            </a:pPr>
+            <a:r>
+              <a:rPr lang="en-US" sz="1600" b="1" dirty="0">
+                <a:solidFill>
+                  <a:srgbClr val="0B0B0B"/>
+                </a:solidFill>
+                <a:latin typeface="Calibri" pitchFamily="34" charset="0"/>
+                <a:ea typeface="Calibri" pitchFamily="34" charset="-122"/>
+                <a:cs typeface="Calibri" pitchFamily="34" charset="-120"/>
+              </a:rPr>
+              <a:t> — dedicated to AEP + FirstEnergy pursuit.</a:t>
+            </a:r>
+            <a:endParaRPr lang="en-US" sz="1600" dirty="0"/>
+          </a:p>
+        </p:txBody>
+      </p:sp>
+      <p:sp>
+        <p:nvSpPr>
+          <p:cNvPr id="17" name="Shape 13"/>
+          <p:cNvSpPr/>
+          <p:nvPr/>
+        </p:nvSpPr>
+        <p:spPr>
+          <a:xfrm>
+            <a:off x="548640" y="4370832"/>
+            <a:ext cx="2656332" cy="1024128"/>
+          </a:xfrm>
+          <a:prstGeom prst="roundRect">
+            <a:avLst>
+              <a:gd name="adj" fmla="val 5357"/>
+            </a:avLst>
+          </a:prstGeom>
+          <a:solidFill>
+            <a:srgbClr val="F7F7F5"/>
+          </a:solidFill>
+          <a:ln w="9525">
+            <a:solidFill>
+              <a:srgbClr val="E1E0D9"/>
+            </a:solidFill>
+            <a:prstDash val="solid"/>
+          </a:ln>
+        </p:spPr>
+      </p:sp>
+      <p:sp>
+        <p:nvSpPr>
+          <p:cNvPr id="18" name="Text 14"/>
+          <p:cNvSpPr/>
+          <p:nvPr/>
+        </p:nvSpPr>
+        <p:spPr>
+          <a:xfrm>
+            <a:off x="676656" y="4443984"/>
+            <a:ext cx="2400300" cy="237744"/>
+          </a:xfrm>
+          <a:prstGeom prst="rect">
+            <a:avLst/>
+          </a:prstGeom>
+          <a:noFill/>
+          <a:ln/>
+        </p:spPr>
+        <p:txBody>
+          <a:bodyPr wrap="square" lIns="0" tIns="0" rIns="0" bIns="0" rtlCol="0" anchor="ctr"/>
+          <a:lstStyle/>
+          <a:p>
+            <a:pPr indent="0" marL="0">
+              <a:buNone/>
+            </a:pPr>
+            <a:r>
+              <a:rPr lang="en-US" sz="1050" dirty="0">
+                <a:solidFill>
+                  <a:srgbClr val="52514E"/>
+                </a:solidFill>
+                <a:latin typeface="Calibri" pitchFamily="34" charset="0"/>
+                <a:ea typeface="Calibri" pitchFamily="34" charset="-122"/>
+                <a:cs typeface="Calibri" pitchFamily="34" charset="-120"/>
+              </a:rPr>
+              <a:t>BD investment</a:t>
+            </a:r>
+            <a:endParaRPr lang="en-US" sz="1050" dirty="0"/>
+          </a:p>
+        </p:txBody>
+      </p:sp>
+      <p:sp>
+        <p:nvSpPr>
+          <p:cNvPr id="19" name="Text 15"/>
+          <p:cNvSpPr/>
+          <p:nvPr/>
+        </p:nvSpPr>
+        <p:spPr>
+          <a:xfrm>
+            <a:off x="676656" y="4645152"/>
+            <a:ext cx="2400300" cy="457200"/>
+          </a:xfrm>
+          <a:prstGeom prst="rect">
+            <a:avLst/>
+          </a:prstGeom>
+          <a:noFill/>
+          <a:ln/>
+        </p:spPr>
+        <p:txBody>
+          <a:bodyPr wrap="square" lIns="0" tIns="0" rIns="0" bIns="0" rtlCol="0" anchor="ctr"/>
+          <a:lstStyle/>
+          <a:p>
+            <a:pPr indent="0" marL="0">
+              <a:buNone/>
+            </a:pPr>
+            <a:r>
+              <a:rPr lang="en-US" sz="2500" b="1" dirty="0">
+                <a:solidFill>
+                  <a:srgbClr val="0B0B0B"/>
+                </a:solidFill>
+                <a:latin typeface="Calibri" pitchFamily="34" charset="0"/>
+                <a:ea typeface="Calibri" pitchFamily="34" charset="-122"/>
+                <a:cs typeface="Calibri" pitchFamily="34" charset="-120"/>
+              </a:rPr>
+              <a:t>~$300K/yr</a:t>
+            </a:r>
+            <a:endParaRPr lang="en-US" sz="2500" dirty="0"/>
+          </a:p>
+        </p:txBody>
+      </p:sp>
+      <p:sp>
+        <p:nvSpPr>
+          <p:cNvPr id="20" name="Text 16"/>
+          <p:cNvSpPr/>
+          <p:nvPr/>
+        </p:nvSpPr>
+        <p:spPr>
+          <a:xfrm>
+            <a:off x="676656" y="5084064"/>
+            <a:ext cx="2400300" cy="256032"/>
+          </a:xfrm>
+          <a:prstGeom prst="rect">
+            <a:avLst/>
+          </a:prstGeom>
+          <a:noFill/>
+          <a:ln/>
+        </p:spPr>
+        <p:txBody>
+          <a:bodyPr wrap="square" lIns="0" tIns="0" rIns="0" bIns="0" rtlCol="0" anchor="ctr"/>
+          <a:lstStyle/>
+          <a:p>
+            <a:pPr indent="0" marL="0">
+              <a:buNone/>
+            </a:pPr>
+            <a:r>
+              <a:rPr lang="en-US" sz="950" dirty="0">
+                <a:solidFill>
+                  <a:srgbClr val="52514E"/>
+                </a:solidFill>
+                <a:latin typeface="Calibri" pitchFamily="34" charset="0"/>
+                <a:ea typeface="Calibri" pitchFamily="34" charset="-122"/>
+                <a:cs typeface="Calibri" pitchFamily="34" charset="-120"/>
+              </a:rPr>
+              <a:t>one senior BD resource, all-in</a:t>
+            </a:r>
+            <a:endParaRPr lang="en-US" sz="950" dirty="0"/>
+          </a:p>
+        </p:txBody>
+      </p:sp>
+      <p:sp>
+        <p:nvSpPr>
+          <p:cNvPr id="21" name="Shape 17"/>
+          <p:cNvSpPr/>
+          <p:nvPr/>
+        </p:nvSpPr>
+        <p:spPr>
+          <a:xfrm>
+            <a:off x="3351276" y="4370832"/>
+            <a:ext cx="2656332" cy="1024128"/>
+          </a:xfrm>
+          <a:prstGeom prst="roundRect">
+            <a:avLst>
+              <a:gd name="adj" fmla="val 5357"/>
+            </a:avLst>
+          </a:prstGeom>
+          <a:solidFill>
+            <a:srgbClr val="F7F7F5"/>
+          </a:solidFill>
+          <a:ln w="9525">
+            <a:solidFill>
+              <a:srgbClr val="E1E0D9"/>
+            </a:solidFill>
+            <a:prstDash val="solid"/>
+          </a:ln>
+        </p:spPr>
+      </p:sp>
+      <p:sp>
+        <p:nvSpPr>
+          <p:cNvPr id="22" name="Text 18"/>
+          <p:cNvSpPr/>
+          <p:nvPr/>
+        </p:nvSpPr>
+        <p:spPr>
+          <a:xfrm>
+            <a:off x="3479292" y="4443984"/>
+            <a:ext cx="2400300" cy="237744"/>
+          </a:xfrm>
+          <a:prstGeom prst="rect">
+            <a:avLst/>
+          </a:prstGeom>
+          <a:noFill/>
+          <a:ln/>
+        </p:spPr>
+        <p:txBody>
+          <a:bodyPr wrap="square" lIns="0" tIns="0" rIns="0" bIns="0" rtlCol="0" anchor="ctr"/>
+          <a:lstStyle/>
+          <a:p>
+            <a:pPr indent="0" marL="0">
+              <a:buNone/>
+            </a:pPr>
+            <a:r>
+              <a:rPr lang="en-US" sz="1050" dirty="0">
+                <a:solidFill>
+                  <a:srgbClr val="52514E"/>
+                </a:solidFill>
+                <a:latin typeface="Calibri" pitchFamily="34" charset="0"/>
+                <a:ea typeface="Calibri" pitchFamily="34" charset="-122"/>
+                <a:cs typeface="Calibri" pitchFamily="34" charset="-120"/>
+              </a:rPr>
+              <a:t>One EPC win covers it</a:t>
+            </a:r>
+            <a:endParaRPr lang="en-US" sz="1050" dirty="0"/>
+          </a:p>
+        </p:txBody>
+      </p:sp>
+      <p:sp>
+        <p:nvSpPr>
+          <p:cNvPr id="23" name="Text 19"/>
+          <p:cNvSpPr/>
+          <p:nvPr/>
+        </p:nvSpPr>
+        <p:spPr>
+          <a:xfrm>
+            <a:off x="3479292" y="4645152"/>
+            <a:ext cx="2400300" cy="457200"/>
+          </a:xfrm>
+          <a:prstGeom prst="rect">
+            <a:avLst/>
+          </a:prstGeom>
+          <a:noFill/>
+          <a:ln/>
+        </p:spPr>
+        <p:txBody>
+          <a:bodyPr wrap="square" lIns="0" tIns="0" rIns="0" bIns="0" rtlCol="0" anchor="ctr"/>
+          <a:lstStyle/>
+          <a:p>
+            <a:pPr indent="0" marL="0">
+              <a:buNone/>
+            </a:pPr>
+            <a:r>
+              <a:rPr lang="en-US" sz="2500" b="1" dirty="0">
+                <a:solidFill>
+                  <a:srgbClr val="006300"/>
+                </a:solidFill>
+                <a:latin typeface="Calibri" pitchFamily="34" charset="0"/>
+                <a:ea typeface="Calibri" pitchFamily="34" charset="-122"/>
+                <a:cs typeface="Calibri" pitchFamily="34" charset="-120"/>
+              </a:rPr>
+              <a:t>~$0.43M</a:t>
+            </a:r>
+            <a:endParaRPr lang="en-US" sz="2500" dirty="0"/>
+          </a:p>
+        </p:txBody>
+      </p:sp>
+      <p:sp>
+        <p:nvSpPr>
+          <p:cNvPr id="24" name="Text 20"/>
+          <p:cNvSpPr/>
+          <p:nvPr/>
+        </p:nvSpPr>
+        <p:spPr>
+          <a:xfrm>
+            <a:off x="3479292" y="5084064"/>
+            <a:ext cx="2400300" cy="256032"/>
+          </a:xfrm>
+          <a:prstGeom prst="rect">
+            <a:avLst/>
+          </a:prstGeom>
+          <a:noFill/>
+          <a:ln/>
+        </p:spPr>
+        <p:txBody>
+          <a:bodyPr wrap="square" lIns="0" tIns="0" rIns="0" bIns="0" rtlCol="0" anchor="ctr"/>
+          <a:lstStyle/>
+          <a:p>
+            <a:pPr indent="0" marL="0">
+              <a:buNone/>
+            </a:pPr>
+            <a:r>
+              <a:rPr lang="en-US" sz="950" dirty="0">
+                <a:solidFill>
+                  <a:srgbClr val="52514E"/>
+                </a:solidFill>
+                <a:latin typeface="Calibri" pitchFamily="34" charset="0"/>
+                <a:ea typeface="Calibri" pitchFamily="34" charset="-122"/>
+                <a:cs typeface="Calibri" pitchFamily="34" charset="-120"/>
+              </a:rPr>
+              <a:t>CVR take on a single $3.45M job</a:t>
+            </a:r>
+            <a:endParaRPr lang="en-US" sz="950" dirty="0"/>
+          </a:p>
+        </p:txBody>
+      </p:sp>
+      <p:sp>
+        <p:nvSpPr>
+          <p:cNvPr id="25" name="Shape 21"/>
+          <p:cNvSpPr/>
+          <p:nvPr/>
+        </p:nvSpPr>
+        <p:spPr>
+          <a:xfrm>
+            <a:off x="6153912" y="4370832"/>
+            <a:ext cx="2656332" cy="1024128"/>
+          </a:xfrm>
+          <a:prstGeom prst="roundRect">
+            <a:avLst>
+              <a:gd name="adj" fmla="val 5357"/>
+            </a:avLst>
+          </a:prstGeom>
+          <a:solidFill>
+            <a:srgbClr val="F7F7F5"/>
+          </a:solidFill>
+          <a:ln w="9525">
+            <a:solidFill>
+              <a:srgbClr val="E1E0D9"/>
+            </a:solidFill>
+            <a:prstDash val="solid"/>
+          </a:ln>
+        </p:spPr>
+      </p:sp>
+      <p:sp>
+        <p:nvSpPr>
+          <p:cNvPr id="26" name="Text 22"/>
+          <p:cNvSpPr/>
+          <p:nvPr/>
+        </p:nvSpPr>
+        <p:spPr>
+          <a:xfrm>
+            <a:off x="6281928" y="4443984"/>
+            <a:ext cx="2400300" cy="237744"/>
+          </a:xfrm>
+          <a:prstGeom prst="rect">
+            <a:avLst/>
+          </a:prstGeom>
+          <a:noFill/>
+          <a:ln/>
+        </p:spPr>
+        <p:txBody>
+          <a:bodyPr wrap="square" lIns="0" tIns="0" rIns="0" bIns="0" rtlCol="0" anchor="ctr"/>
+          <a:lstStyle/>
+          <a:p>
+            <a:pPr indent="0" marL="0">
+              <a:buNone/>
+            </a:pPr>
+            <a:r>
+              <a:rPr lang="en-US" sz="1050" dirty="0">
+                <a:solidFill>
+                  <a:srgbClr val="52514E"/>
+                </a:solidFill>
+                <a:latin typeface="Calibri" pitchFamily="34" charset="0"/>
+                <a:ea typeface="Calibri" pitchFamily="34" charset="-122"/>
+                <a:cs typeface="Calibri" pitchFamily="34" charset="-120"/>
+              </a:rPr>
+              <a:t>At 10% of the vision</a:t>
+            </a:r>
+            <a:endParaRPr lang="en-US" sz="1050" dirty="0"/>
+          </a:p>
+        </p:txBody>
+      </p:sp>
+      <p:sp>
+        <p:nvSpPr>
+          <p:cNvPr id="27" name="Text 23"/>
+          <p:cNvSpPr/>
+          <p:nvPr/>
+        </p:nvSpPr>
+        <p:spPr>
+          <a:xfrm>
+            <a:off x="6281928" y="4645152"/>
+            <a:ext cx="2400300" cy="457200"/>
+          </a:xfrm>
+          <a:prstGeom prst="rect">
+            <a:avLst/>
+          </a:prstGeom>
+          <a:noFill/>
+          <a:ln/>
+        </p:spPr>
+        <p:txBody>
+          <a:bodyPr wrap="square" lIns="0" tIns="0" rIns="0" bIns="0" rtlCol="0" anchor="ctr"/>
+          <a:lstStyle/>
+          <a:p>
+            <a:pPr indent="0" marL="0">
+              <a:buNone/>
+            </a:pPr>
+            <a:r>
+              <a:rPr lang="en-US" sz="2500" b="1" dirty="0">
+                <a:solidFill>
+                  <a:srgbClr val="2A78D6"/>
+                </a:solidFill>
+                <a:latin typeface="Calibri" pitchFamily="34" charset="0"/>
+                <a:ea typeface="Calibri" pitchFamily="34" charset="-122"/>
+                <a:cs typeface="Calibri" pitchFamily="34" charset="-120"/>
+              </a:rPr>
+              <a:t>~$0.76M</a:t>
+            </a:r>
+            <a:endParaRPr lang="en-US" sz="2500" dirty="0"/>
+          </a:p>
+        </p:txBody>
+      </p:sp>
+      <p:sp>
+        <p:nvSpPr>
+          <p:cNvPr id="28" name="Text 24"/>
+          <p:cNvSpPr/>
+          <p:nvPr/>
+        </p:nvSpPr>
+        <p:spPr>
+          <a:xfrm>
+            <a:off x="6281928" y="5084064"/>
+            <a:ext cx="2400300" cy="256032"/>
+          </a:xfrm>
+          <a:prstGeom prst="rect">
+            <a:avLst/>
+          </a:prstGeom>
+          <a:noFill/>
+          <a:ln/>
+        </p:spPr>
+        <p:txBody>
+          <a:bodyPr wrap="square" lIns="0" tIns="0" rIns="0" bIns="0" rtlCol="0" anchor="ctr"/>
+          <a:lstStyle/>
+          <a:p>
+            <a:pPr indent="0" marL="0">
+              <a:buNone/>
+            </a:pPr>
+            <a:r>
+              <a:rPr lang="en-US" sz="950" dirty="0">
+                <a:solidFill>
+                  <a:srgbClr val="52514E"/>
+                </a:solidFill>
+                <a:latin typeface="Calibri" pitchFamily="34" charset="0"/>
+                <a:ea typeface="Calibri" pitchFamily="34" charset="-122"/>
+                <a:cs typeface="Calibri" pitchFamily="34" charset="-120"/>
+              </a:rPr>
+              <a:t>CVR OI at ~$15M/yr EPC</a:t>
+            </a:r>
+            <a:endParaRPr lang="en-US" sz="950" dirty="0"/>
+          </a:p>
+        </p:txBody>
+      </p:sp>
+      <p:sp>
+        <p:nvSpPr>
+          <p:cNvPr id="29" name="Shape 25"/>
+          <p:cNvSpPr/>
+          <p:nvPr/>
+        </p:nvSpPr>
+        <p:spPr>
+          <a:xfrm>
+            <a:off x="8956548" y="4370832"/>
+            <a:ext cx="2656332" cy="1024128"/>
+          </a:xfrm>
+          <a:prstGeom prst="roundRect">
+            <a:avLst>
+              <a:gd name="adj" fmla="val 5357"/>
+            </a:avLst>
+          </a:prstGeom>
+          <a:solidFill>
+            <a:srgbClr val="F7F7F5"/>
+          </a:solidFill>
+          <a:ln w="9525">
+            <a:solidFill>
+              <a:srgbClr val="E1E0D9"/>
+            </a:solidFill>
+            <a:prstDash val="solid"/>
+          </a:ln>
+        </p:spPr>
+      </p:sp>
+      <p:sp>
+        <p:nvSpPr>
+          <p:cNvPr id="30" name="Text 26"/>
+          <p:cNvSpPr/>
+          <p:nvPr/>
+        </p:nvSpPr>
+        <p:spPr>
+          <a:xfrm>
+            <a:off x="9084564" y="4443984"/>
+            <a:ext cx="2400300" cy="237744"/>
+          </a:xfrm>
+          <a:prstGeom prst="rect">
+            <a:avLst/>
+          </a:prstGeom>
+          <a:noFill/>
+          <a:ln/>
+        </p:spPr>
+        <p:txBody>
+          <a:bodyPr wrap="square" lIns="0" tIns="0" rIns="0" bIns="0" rtlCol="0" anchor="ctr"/>
+          <a:lstStyle/>
+          <a:p>
+            <a:pPr indent="0" marL="0">
+              <a:buNone/>
+            </a:pPr>
+            <a:r>
+              <a:rPr lang="en-US" sz="1050" dirty="0">
+                <a:solidFill>
+                  <a:srgbClr val="52514E"/>
+                </a:solidFill>
+                <a:latin typeface="Calibri" pitchFamily="34" charset="0"/>
+                <a:ea typeface="Calibri" pitchFamily="34" charset="-122"/>
+                <a:cs typeface="Calibri" pitchFamily="34" charset="-120"/>
+              </a:rPr>
+              <a:t>Full at-scale upside</a:t>
+            </a:r>
+            <a:endParaRPr lang="en-US" sz="1050" dirty="0"/>
+          </a:p>
+        </p:txBody>
+      </p:sp>
+      <p:sp>
+        <p:nvSpPr>
+          <p:cNvPr id="31" name="Text 27"/>
+          <p:cNvSpPr/>
+          <p:nvPr/>
+        </p:nvSpPr>
+        <p:spPr>
+          <a:xfrm>
+            <a:off x="9084564" y="4645152"/>
+            <a:ext cx="2400300" cy="457200"/>
+          </a:xfrm>
+          <a:prstGeom prst="rect">
+            <a:avLst/>
+          </a:prstGeom>
+          <a:noFill/>
+          <a:ln/>
+        </p:spPr>
+        <p:txBody>
+          <a:bodyPr wrap="square" lIns="0" tIns="0" rIns="0" bIns="0" rtlCol="0" anchor="ctr"/>
+          <a:lstStyle/>
+          <a:p>
+            <a:pPr indent="0" marL="0">
+              <a:buNone/>
+            </a:pPr>
+            <a:r>
+              <a:rPr lang="en-US" sz="2500" b="1" dirty="0">
+                <a:solidFill>
+                  <a:srgbClr val="006300"/>
+                </a:solidFill>
+                <a:latin typeface="Calibri" pitchFamily="34" charset="0"/>
+                <a:ea typeface="Calibri" pitchFamily="34" charset="-122"/>
+                <a:cs typeface="Calibri" pitchFamily="34" charset="-120"/>
+              </a:rPr>
+              <a:t>$7.6M</a:t>
+            </a:r>
+            <a:endParaRPr lang="en-US" sz="2500" dirty="0"/>
+          </a:p>
+        </p:txBody>
+      </p:sp>
+      <p:sp>
+        <p:nvSpPr>
+          <p:cNvPr id="32" name="Text 28"/>
+          <p:cNvSpPr/>
+          <p:nvPr/>
+        </p:nvSpPr>
+        <p:spPr>
+          <a:xfrm>
+            <a:off x="9084564" y="5084064"/>
+            <a:ext cx="2400300" cy="256032"/>
+          </a:xfrm>
+          <a:prstGeom prst="rect">
+            <a:avLst/>
+          </a:prstGeom>
+          <a:noFill/>
+          <a:ln/>
+        </p:spPr>
+        <p:txBody>
+          <a:bodyPr wrap="square" lIns="0" tIns="0" rIns="0" bIns="0" rtlCol="0" anchor="ctr"/>
+          <a:lstStyle/>
+          <a:p>
+            <a:pPr indent="0" marL="0">
+              <a:buNone/>
+            </a:pPr>
+            <a:r>
+              <a:rPr lang="en-US" sz="950" dirty="0">
+                <a:solidFill>
+                  <a:srgbClr val="52514E"/>
+                </a:solidFill>
+                <a:latin typeface="Calibri" pitchFamily="34" charset="0"/>
+                <a:ea typeface="Calibri" pitchFamily="34" charset="-122"/>
+                <a:cs typeface="Calibri" pitchFamily="34" charset="-120"/>
+              </a:rPr>
+              <a:t>CVR OI at $150M/yr</a:t>
+            </a:r>
+            <a:endParaRPr lang="en-US" sz="950" dirty="0"/>
+          </a:p>
+        </p:txBody>
+      </p:sp>
+      <p:sp>
+        <p:nvSpPr>
+          <p:cNvPr id="33" name="Text 29"/>
+          <p:cNvSpPr/>
+          <p:nvPr/>
+        </p:nvSpPr>
+        <p:spPr>
+          <a:xfrm>
+            <a:off x="548640" y="5596128"/>
+            <a:ext cx="11064240" cy="320040"/>
+          </a:xfrm>
+          <a:prstGeom prst="rect">
+            <a:avLst/>
+          </a:prstGeom>
+          <a:noFill/>
+          <a:ln/>
+        </p:spPr>
+        <p:txBody>
+          <a:bodyPr wrap="square" lIns="0" tIns="0" rIns="0" bIns="0" rtlCol="0" anchor="ctr"/>
+          <a:lstStyle/>
+          <a:p>
+            <a:pPr indent="0" marL="0">
+              <a:buNone/>
+            </a:pPr>
+            <a:r>
+              <a:rPr lang="en-US" sz="1300" b="1" dirty="0">
+                <a:solidFill>
+                  <a:srgbClr val="0B0B0B"/>
+                </a:solidFill>
+                <a:latin typeface="Calibri" pitchFamily="34" charset="0"/>
+                <a:ea typeface="Calibri" pitchFamily="34" charset="-122"/>
+                <a:cs typeface="Calibri" pitchFamily="34" charset="-120"/>
+              </a:rPr>
+              <a:t>Decision requested:  </a:t>
+            </a:r>
+            <a:pPr indent="0" marL="0">
+              <a:buNone/>
+            </a:pPr>
+            <a:r>
+              <a:rPr lang="en-US" sz="1300" dirty="0">
+                <a:solidFill>
+                  <a:srgbClr val="52514E"/>
+                </a:solidFill>
+                <a:latin typeface="Calibri" pitchFamily="34" charset="0"/>
+                <a:ea typeface="Calibri" pitchFamily="34" charset="-122"/>
+                <a:cs typeface="Calibri" pitchFamily="34" charset="-120"/>
+              </a:rPr>
+              <a:t>approve the BD hire now to open AEP + FirstEnergy pursuit immediately.</a:t>
+            </a:r>
+            <a:endParaRPr lang="en-US" sz="1300" dirty="0"/>
+          </a:p>
+        </p:txBody>
+      </p:sp>
+      <p:sp>
+        <p:nvSpPr>
+          <p:cNvPr id="34" name="Text 30"/>
+          <p:cNvSpPr/>
+          <p:nvPr/>
+        </p:nvSpPr>
+        <p:spPr>
+          <a:xfrm>
+            <a:off x="548640" y="6419088"/>
+            <a:ext cx="11064240" cy="320040"/>
+          </a:xfrm>
+          <a:prstGeom prst="rect">
+            <a:avLst/>
+          </a:prstGeom>
+          <a:noFill/>
+          <a:ln/>
+        </p:spPr>
+        <p:txBody>
+          <a:bodyPr wrap="square" lIns="0" tIns="0" rIns="0" bIns="0" rtlCol="0" anchor="ctr"/>
+          <a:lstStyle/>
+          <a:p>
+            <a:pPr indent="0" marL="0">
+              <a:buNone/>
+            </a:pPr>
+            <a:r>
+              <a:rPr lang="en-US" sz="950" dirty="0">
+                <a:solidFill>
+                  <a:srgbClr val="898781"/>
+                </a:solidFill>
+                <a:latin typeface="Calibri" pitchFamily="34" charset="0"/>
+                <a:ea typeface="Calibri" pitchFamily="34" charset="-122"/>
+                <a:cs typeface="Calibri" pitchFamily="34" charset="-120"/>
+              </a:rPr>
+              <a:t>BD cost ~$300K/yr all-in (base + benefits + travel). Returns per the 'EPC At-Scale Model' tab; a single mid-size EPC award pays back the resource in year one.</a:t>
             </a:r>
             <a:endParaRPr lang="en-US" sz="950" dirty="0"/>
           </a:p>

</xml_diff>

<commit_message>
Reword AEP note to 'management changes'; set BD resource at $400K/yr all-in
Replace the AEP 'post-BHE takeover' wording with 'recent management changes'
on the expansion and ask slides, and raise the all-in BD resource cost from
~$300K to ~$400K/yr across the ask band, tile, footnote, and priorities.
</commit_message>
<xml_diff>
--- a/reports/CVR_Deck_Jun2026.pptx
+++ b/reports/CVR_Deck_Jun2026.pptx
@@ -15946,7 +15946,7 @@
                 <a:ea typeface="Calibri" pitchFamily="34" charset="-122"/>
                 <a:cs typeface="Calibri" pitchFamily="34" charset="-120"/>
               </a:rPr>
-              <a:t>Where we stand: new leadership post-BHE takeover; strong Director/PM and procurement relationships (JimC + potential BD).</a:t>
+              <a:t>Where we stand: recent management changes; strong Director/PM and procurement relationships (JimC + potential BD).</a:t>
             </a:r>
             <a:endParaRPr lang="en-US" sz="1000" dirty="0"/>
           </a:p>
@@ -27758,7 +27758,7 @@
                 <a:ea typeface="Calibri" pitchFamily="34" charset="-122"/>
                 <a:cs typeface="Calibri" pitchFamily="34" charset="-120"/>
               </a:rPr>
-              <a:t>One dedicated BD hire (~$300K/yr all-in) to convert AEP and FirstEnergy — both warm. A single mid-size EPC award pays it back in year one.</a:t>
+              <a:t>One dedicated BD hire (~$400K/yr all-in) to convert AEP and FirstEnergy — both warm. A single mid-size EPC award pays it back in year one.</a:t>
             </a:r>
             <a:endParaRPr lang="en-US" sz="1200" dirty="0"/>
           </a:p>
@@ -28506,7 +28506,7 @@
                 <a:ea typeface="Calibri" pitchFamily="34" charset="-122"/>
                 <a:cs typeface="Calibri" pitchFamily="34" charset="-120"/>
               </a:rPr>
-              <a:t>New leadership post-BHE takeover; strong Director/PM + procurement relationships (JimC + potential BD).</a:t>
+              <a:t>Recent management changes; strong Director/PM + procurement relationships (JimC + potential BD).</a:t>
             </a:r>
             <a:endParaRPr lang="en-US" sz="1100" dirty="0"/>
           </a:p>
@@ -28848,7 +28848,7 @@
                 <a:ea typeface="Calibri" pitchFamily="34" charset="-122"/>
                 <a:cs typeface="Calibri" pitchFamily="34" charset="-120"/>
               </a:rPr>
-              <a:t>~$300K/yr all-in</a:t>
+              <a:t>~$400K/yr all-in</a:t>
             </a:r>
             <a:pPr indent="0" marL="0">
               <a:buNone/>
@@ -28967,7 +28967,7 @@
                 <a:ea typeface="Calibri" pitchFamily="34" charset="-122"/>
                 <a:cs typeface="Calibri" pitchFamily="34" charset="-120"/>
               </a:rPr>
-              <a:t>~$300K/yr</a:t>
+              <a:t>~$400K/yr</a:t>
             </a:r>
             <a:endParaRPr lang="en-US" sz="2500" dirty="0"/>
           </a:p>
@@ -29530,7 +29530,7 @@
                 <a:ea typeface="Calibri" pitchFamily="34" charset="-122"/>
                 <a:cs typeface="Calibri" pitchFamily="34" charset="-120"/>
               </a:rPr>
-              <a:t>BD cost ~$300K/yr all-in (base + benefits + travel). Returns per the 'EPC At-Scale Model' tab; a single mid-size EPC award pays back the resource in year one.</a:t>
+              <a:t>BD cost ~$400K/yr all-in (base + benefits + travel). Returns per the 'EPC At-Scale Model' tab; a single mid-size EPC award pays back the resource in year one.</a:t>
             </a:r>
             <a:endParaRPr lang="en-US" sz="950" dirty="0"/>
           </a:p>

</xml_diff>

<commit_message>
Update model, deck, and dashboard to the 7/25/2026 CVR/EPC KPI package
Reconcile to the week-ending 7/25 package: team billable utilization 59.0% ->
60.8% with refreshed per-person hours/billable %; Consumers pole award booked
at its official $276.45K CVR value (was $300K); win rate 67% -> 69%; backlog
total $997K -> $973K; Renaissance 345kV off hold and new MEC VanMeter 161kV
pursuit both now in bid (Sep-26, EPC-paired). Refresh KPI dates to 7/25 and
re-render utilization/coverage charts. H1 financials, BD hours, and MEC EPC
values are unchanged. Also make render_deck_charts merge the manifest so the
separately-rendered margin chart survives a re-render.
</commit_message>
<xml_diff>
--- a/reports/CVR_Deck_Jun2026.pptx
+++ b/reports/CVR_Deck_Jun2026.pptx
@@ -3086,7 +3086,7 @@
                 <a:ea typeface="Calibri" pitchFamily="34" charset="-122"/>
                 <a:cs typeface="Calibri" pitchFamily="34" charset="-120"/>
               </a:rPr>
-              <a:t>Sources: GL financial statements 6/30/26 · CVR &amp; EPC KPI report 7/11/26 · 2026 rate sheet · Phase 1 &amp; 2 model workbooks</a:t>
+              <a:t>Sources: GL financial statements 6/30/26 · CVR &amp; EPC KPI report 7/25/26 · 2026 rate sheet · Phase 1 &amp; 2 model workbooks</a:t>
             </a:r>
             <a:endParaRPr lang="en-US" sz="1050" dirty="0"/>
           </a:p>
@@ -4627,7 +4627,7 @@
                           <a:ea typeface="Calibri" pitchFamily="34" charset="-122"/>
                           <a:cs typeface="Calibri" pitchFamily="34" charset="-120"/>
                         </a:rPr>
-                        <a:t>$300.0K</a:t>
+                        <a:t>$276.5K</a:t>
                       </a:r>
                       <a:endParaRPr lang="en-US" sz="1050" dirty="0">
                         <a:latin typeface="Calibri" charset="0"/>
@@ -4763,7 +4763,7 @@
                           <a:ea typeface="Calibri" pitchFamily="34" charset="-122"/>
                           <a:cs typeface="Calibri" pitchFamily="34" charset="-120"/>
                         </a:rPr>
-                        <a:t>$300.0K</a:t>
+                        <a:t>$276.5K</a:t>
                       </a:r>
                       <a:endParaRPr lang="en-US" sz="1050" dirty="0">
                         <a:latin typeface="Calibri" charset="0"/>
@@ -8420,7 +8420,7 @@
                           <a:ea typeface="Calibri" pitchFamily="34" charset="-122"/>
                           <a:cs typeface="Calibri" pitchFamily="34" charset="-120"/>
                         </a:rPr>
-                        <a:t>$996.8K</a:t>
+                        <a:t>$973.3K</a:t>
                       </a:r>
                       <a:endParaRPr lang="en-US" sz="1050" dirty="0">
                         <a:latin typeface="Calibri" charset="0"/>
@@ -8566,7 +8566,7 @@
                 <a:ea typeface="Calibri" pitchFamily="34" charset="-122"/>
                 <a:cs typeface="Calibri" pitchFamily="34" charset="-120"/>
               </a:rPr>
-              <a:t>$997K</a:t>
+              <a:t>$973K</a:t>
             </a:r>
             <a:endParaRPr lang="en-US" sz="2800" dirty="0"/>
           </a:p>
@@ -8605,7 +8605,7 @@
                 <a:ea typeface="Calibri" pitchFamily="34" charset="-122"/>
                 <a:cs typeface="Calibri" pitchFamily="34" charset="-120"/>
               </a:rPr>
-              <a:t>booked work remaining — up $300K on the new Consumers pole win</a:t>
+              <a:t>booked work remaining — up $276K on the new Consumers pole win</a:t>
             </a:r>
             <a:endParaRPr lang="en-US" sz="1200" dirty="0"/>
           </a:p>
@@ -8800,7 +8800,7 @@
                 <a:ea typeface="Calibri" pitchFamily="34" charset="-122"/>
                 <a:cs typeface="Calibri" pitchFamily="34" charset="-120"/>
               </a:rPr>
-              <a:t>KPI project scorecard, week ending 7/11/26. Remaining = PO value − billed to date; excludes cost-overrun exposure tracked on the scorecard.</a:t>
+              <a:t>KPI project scorecard, week ending 7/25/26. Remaining = PO value − billed to date; excludes cost-overrun exposure tracked on the scorecard.</a:t>
             </a:r>
             <a:endParaRPr lang="en-US" sz="950" dirty="0"/>
           </a:p>
@@ -9586,7 +9586,7 @@
                           <a:ea typeface="Calibri" pitchFamily="34" charset="-122"/>
                           <a:cs typeface="Calibri" pitchFamily="34" charset="-120"/>
                         </a:rPr>
-                        <a:t>$300.0K</a:t>
+                        <a:t>$276.5K</a:t>
                       </a:r>
                       <a:endParaRPr lang="en-US" sz="1050" dirty="0">
                         <a:latin typeface="Calibri" charset="0"/>
@@ -11832,6 +11832,74 @@
                         <a:buNone/>
                       </a:pPr>
                       <a:r>
+                        <a:rPr lang="en-US" sz="1050" b="1" dirty="0">
+                          <a:solidFill>
+                            <a:srgbClr val="0B0B0B"/>
+                          </a:solidFill>
+                          <a:latin typeface="Calibri" pitchFamily="34" charset="0"/>
+                          <a:ea typeface="Calibri" pitchFamily="34" charset="-122"/>
+                          <a:cs typeface="Calibri" pitchFamily="34" charset="-120"/>
+                        </a:rPr>
+                        <a:t>VanMeter 161kV Substation ‡</a:t>
+                      </a:r>
+                      <a:endParaRPr lang="en-US" sz="1050" dirty="0">
+                        <a:latin typeface="Calibri" charset="0"/>
+                        <a:ea typeface="Calibri" charset="0"/>
+                        <a:cs typeface="Calibri" charset="0"/>
+                      </a:endParaRPr>
+                    </a:p>
+                  </a:txBody>
+                  <a:tcPr marL="91440" marR="91440" marT="45720" marB="45720" anchor="ctr">
+                    <a:lnL w="6350" cap="flat" cmpd="sng" algn="ctr">
+                      <a:solidFill>
+                        <a:srgbClr val="E1E0D9"/>
+                      </a:solidFill>
+                      <a:prstDash val="solid"/>
+                      <a:round/>
+                      <a:headEnd type="none" w="med" len="med"/>
+                      <a:tailEnd type="none" w="med" len="med"/>
+                    </a:lnL>
+                    <a:lnR w="6350" cap="flat" cmpd="sng" algn="ctr">
+                      <a:solidFill>
+                        <a:srgbClr val="E1E0D9"/>
+                      </a:solidFill>
+                      <a:prstDash val="solid"/>
+                      <a:round/>
+                      <a:headEnd type="none" w="med" len="med"/>
+                      <a:tailEnd type="none" w="med" len="med"/>
+                    </a:lnR>
+                    <a:lnT w="6350" cap="flat" cmpd="sng" algn="ctr">
+                      <a:solidFill>
+                        <a:srgbClr val="E1E0D9"/>
+                      </a:solidFill>
+                      <a:prstDash val="solid"/>
+                      <a:round/>
+                      <a:headEnd type="none" w="med" len="med"/>
+                      <a:tailEnd type="none" w="med" len="med"/>
+                    </a:lnT>
+                    <a:lnB w="6350" cap="flat" cmpd="sng" algn="ctr">
+                      <a:solidFill>
+                        <a:srgbClr val="E1E0D9"/>
+                      </a:solidFill>
+                      <a:prstDash val="solid"/>
+                      <a:round/>
+                      <a:headEnd type="none" w="med" len="med"/>
+                      <a:tailEnd type="none" w="med" len="med"/>
+                    </a:lnB>
+                    <a:solidFill>
+                      <a:srgbClr val="FFFFFF"/>
+                    </a:solidFill>
+                  </a:tcPr>
+                </a:tc>
+                <a:tc>
+                  <a:txBody>
+                    <a:bodyPr/>
+                    <a:lstStyle/>
+                    <a:p>
+                      <a:pPr algn="l" indent="0" marL="0">
+                        <a:buNone/>
+                      </a:pPr>
+                      <a:r>
                         <a:rPr lang="en-US" sz="1050" dirty="0">
                           <a:solidFill>
                             <a:srgbClr val="0B0B0B"/>
@@ -11840,7 +11908,417 @@
                           <a:ea typeface="Calibri" pitchFamily="34" charset="-122"/>
                           <a:cs typeface="Calibri" pitchFamily="34" charset="-120"/>
                         </a:rPr>
-                        <a:t>Renaissance 345kV Substation</a:t>
+                        <a:t>MEC (MidAmerican)</a:t>
+                      </a:r>
+                      <a:endParaRPr lang="en-US" sz="1050" dirty="0">
+                        <a:latin typeface="Calibri" charset="0"/>
+                        <a:ea typeface="Calibri" charset="0"/>
+                        <a:cs typeface="Calibri" charset="0"/>
+                      </a:endParaRPr>
+                    </a:p>
+                  </a:txBody>
+                  <a:tcPr marL="91440" marR="91440" marT="45720" marB="45720" anchor="ctr">
+                    <a:lnL w="6350" cap="flat" cmpd="sng" algn="ctr">
+                      <a:solidFill>
+                        <a:srgbClr val="E1E0D9"/>
+                      </a:solidFill>
+                      <a:prstDash val="solid"/>
+                      <a:round/>
+                      <a:headEnd type="none" w="med" len="med"/>
+                      <a:tailEnd type="none" w="med" len="med"/>
+                    </a:lnL>
+                    <a:lnR w="6350" cap="flat" cmpd="sng" algn="ctr">
+                      <a:solidFill>
+                        <a:srgbClr val="E1E0D9"/>
+                      </a:solidFill>
+                      <a:prstDash val="solid"/>
+                      <a:round/>
+                      <a:headEnd type="none" w="med" len="med"/>
+                      <a:tailEnd type="none" w="med" len="med"/>
+                    </a:lnR>
+                    <a:lnT w="6350" cap="flat" cmpd="sng" algn="ctr">
+                      <a:solidFill>
+                        <a:srgbClr val="E1E0D9"/>
+                      </a:solidFill>
+                      <a:prstDash val="solid"/>
+                      <a:round/>
+                      <a:headEnd type="none" w="med" len="med"/>
+                      <a:tailEnd type="none" w="med" len="med"/>
+                    </a:lnT>
+                    <a:lnB w="6350" cap="flat" cmpd="sng" algn="ctr">
+                      <a:solidFill>
+                        <a:srgbClr val="E1E0D9"/>
+                      </a:solidFill>
+                      <a:prstDash val="solid"/>
+                      <a:round/>
+                      <a:headEnd type="none" w="med" len="med"/>
+                      <a:tailEnd type="none" w="med" len="med"/>
+                    </a:lnB>
+                    <a:solidFill>
+                      <a:srgbClr val="FFFFFF"/>
+                    </a:solidFill>
+                  </a:tcPr>
+                </a:tc>
+                <a:tc>
+                  <a:txBody>
+                    <a:bodyPr/>
+                    <a:lstStyle/>
+                    <a:p>
+                      <a:pPr algn="l" indent="0" marL="0">
+                        <a:buNone/>
+                      </a:pPr>
+                      <a:r>
+                        <a:rPr lang="en-US" sz="1050" dirty="0">
+                          <a:solidFill>
+                            <a:srgbClr val="0B0B0B"/>
+                          </a:solidFill>
+                          <a:latin typeface="Calibri" pitchFamily="34" charset="0"/>
+                          <a:ea typeface="Calibri" pitchFamily="34" charset="-122"/>
+                          <a:cs typeface="Calibri" pitchFamily="34" charset="-120"/>
+                        </a:rPr>
+                        <a:t>TBD</a:t>
+                      </a:r>
+                      <a:endParaRPr lang="en-US" sz="1050" dirty="0">
+                        <a:latin typeface="Calibri" charset="0"/>
+                        <a:ea typeface="Calibri" charset="0"/>
+                        <a:cs typeface="Calibri" charset="0"/>
+                      </a:endParaRPr>
+                    </a:p>
+                  </a:txBody>
+                  <a:tcPr marL="91440" marR="91440" marT="45720" marB="45720" anchor="ctr">
+                    <a:lnL w="6350" cap="flat" cmpd="sng" algn="ctr">
+                      <a:solidFill>
+                        <a:srgbClr val="E1E0D9"/>
+                      </a:solidFill>
+                      <a:prstDash val="solid"/>
+                      <a:round/>
+                      <a:headEnd type="none" w="med" len="med"/>
+                      <a:tailEnd type="none" w="med" len="med"/>
+                    </a:lnL>
+                    <a:lnR w="6350" cap="flat" cmpd="sng" algn="ctr">
+                      <a:solidFill>
+                        <a:srgbClr val="E1E0D9"/>
+                      </a:solidFill>
+                      <a:prstDash val="solid"/>
+                      <a:round/>
+                      <a:headEnd type="none" w="med" len="med"/>
+                      <a:tailEnd type="none" w="med" len="med"/>
+                    </a:lnR>
+                    <a:lnT w="6350" cap="flat" cmpd="sng" algn="ctr">
+                      <a:solidFill>
+                        <a:srgbClr val="E1E0D9"/>
+                      </a:solidFill>
+                      <a:prstDash val="solid"/>
+                      <a:round/>
+                      <a:headEnd type="none" w="med" len="med"/>
+                      <a:tailEnd type="none" w="med" len="med"/>
+                    </a:lnT>
+                    <a:lnB w="6350" cap="flat" cmpd="sng" algn="ctr">
+                      <a:solidFill>
+                        <a:srgbClr val="E1E0D9"/>
+                      </a:solidFill>
+                      <a:prstDash val="solid"/>
+                      <a:round/>
+                      <a:headEnd type="none" w="med" len="med"/>
+                      <a:tailEnd type="none" w="med" len="med"/>
+                    </a:lnB>
+                    <a:solidFill>
+                      <a:srgbClr val="FFFFFF"/>
+                    </a:solidFill>
+                  </a:tcPr>
+                </a:tc>
+                <a:tc>
+                  <a:txBody>
+                    <a:bodyPr/>
+                    <a:lstStyle/>
+                    <a:p>
+                      <a:pPr algn="l" indent="0" marL="0">
+                        <a:buNone/>
+                      </a:pPr>
+                      <a:r>
+                        <a:rPr lang="en-US" sz="1050" dirty="0">
+                          <a:solidFill>
+                            <a:srgbClr val="2A78D6"/>
+                          </a:solidFill>
+                          <a:latin typeface="Calibri" pitchFamily="34" charset="0"/>
+                          <a:ea typeface="Calibri" pitchFamily="34" charset="-122"/>
+                          <a:cs typeface="Calibri" pitchFamily="34" charset="-120"/>
+                        </a:rPr>
+                        <a:t>EPC-paired</a:t>
+                      </a:r>
+                      <a:endParaRPr lang="en-US" sz="1050" dirty="0">
+                        <a:latin typeface="Calibri" charset="0"/>
+                        <a:ea typeface="Calibri" charset="0"/>
+                        <a:cs typeface="Calibri" charset="0"/>
+                      </a:endParaRPr>
+                    </a:p>
+                  </a:txBody>
+                  <a:tcPr marL="91440" marR="91440" marT="45720" marB="45720" anchor="ctr">
+                    <a:lnL w="6350" cap="flat" cmpd="sng" algn="ctr">
+                      <a:solidFill>
+                        <a:srgbClr val="E1E0D9"/>
+                      </a:solidFill>
+                      <a:prstDash val="solid"/>
+                      <a:round/>
+                      <a:headEnd type="none" w="med" len="med"/>
+                      <a:tailEnd type="none" w="med" len="med"/>
+                    </a:lnL>
+                    <a:lnR w="6350" cap="flat" cmpd="sng" algn="ctr">
+                      <a:solidFill>
+                        <a:srgbClr val="E1E0D9"/>
+                      </a:solidFill>
+                      <a:prstDash val="solid"/>
+                      <a:round/>
+                      <a:headEnd type="none" w="med" len="med"/>
+                      <a:tailEnd type="none" w="med" len="med"/>
+                    </a:lnR>
+                    <a:lnT w="6350" cap="flat" cmpd="sng" algn="ctr">
+                      <a:solidFill>
+                        <a:srgbClr val="E1E0D9"/>
+                      </a:solidFill>
+                      <a:prstDash val="solid"/>
+                      <a:round/>
+                      <a:headEnd type="none" w="med" len="med"/>
+                      <a:tailEnd type="none" w="med" len="med"/>
+                    </a:lnT>
+                    <a:lnB w="6350" cap="flat" cmpd="sng" algn="ctr">
+                      <a:solidFill>
+                        <a:srgbClr val="E1E0D9"/>
+                      </a:solidFill>
+                      <a:prstDash val="solid"/>
+                      <a:round/>
+                      <a:headEnd type="none" w="med" len="med"/>
+                      <a:tailEnd type="none" w="med" len="med"/>
+                    </a:lnB>
+                    <a:solidFill>
+                      <a:srgbClr val="FFFFFF"/>
+                    </a:solidFill>
+                  </a:tcPr>
+                </a:tc>
+                <a:tc>
+                  <a:txBody>
+                    <a:bodyPr/>
+                    <a:lstStyle/>
+                    <a:p>
+                      <a:pPr algn="l" indent="0" marL="0">
+                        <a:buNone/>
+                      </a:pPr>
+                      <a:r>
+                        <a:rPr lang="en-US" sz="1050" b="1" dirty="0">
+                          <a:solidFill>
+                            <a:srgbClr val="2A78D6"/>
+                          </a:solidFill>
+                          <a:latin typeface="Calibri" pitchFamily="34" charset="0"/>
+                          <a:ea typeface="Calibri" pitchFamily="34" charset="-122"/>
+                          <a:cs typeface="Calibri" pitchFamily="34" charset="-120"/>
+                        </a:rPr>
+                        <a:t>in bid</a:t>
+                      </a:r>
+                      <a:endParaRPr lang="en-US" sz="1050" dirty="0">
+                        <a:latin typeface="Calibri" charset="0"/>
+                        <a:ea typeface="Calibri" charset="0"/>
+                        <a:cs typeface="Calibri" charset="0"/>
+                      </a:endParaRPr>
+                    </a:p>
+                  </a:txBody>
+                  <a:tcPr marL="91440" marR="91440" marT="45720" marB="45720" anchor="ctr">
+                    <a:lnL w="6350" cap="flat" cmpd="sng" algn="ctr">
+                      <a:solidFill>
+                        <a:srgbClr val="E1E0D9"/>
+                      </a:solidFill>
+                      <a:prstDash val="solid"/>
+                      <a:round/>
+                      <a:headEnd type="none" w="med" len="med"/>
+                      <a:tailEnd type="none" w="med" len="med"/>
+                    </a:lnL>
+                    <a:lnR w="6350" cap="flat" cmpd="sng" algn="ctr">
+                      <a:solidFill>
+                        <a:srgbClr val="E1E0D9"/>
+                      </a:solidFill>
+                      <a:prstDash val="solid"/>
+                      <a:round/>
+                      <a:headEnd type="none" w="med" len="med"/>
+                      <a:tailEnd type="none" w="med" len="med"/>
+                    </a:lnR>
+                    <a:lnT w="6350" cap="flat" cmpd="sng" algn="ctr">
+                      <a:solidFill>
+                        <a:srgbClr val="E1E0D9"/>
+                      </a:solidFill>
+                      <a:prstDash val="solid"/>
+                      <a:round/>
+                      <a:headEnd type="none" w="med" len="med"/>
+                      <a:tailEnd type="none" w="med" len="med"/>
+                    </a:lnT>
+                    <a:lnB w="6350" cap="flat" cmpd="sng" algn="ctr">
+                      <a:solidFill>
+                        <a:srgbClr val="E1E0D9"/>
+                      </a:solidFill>
+                      <a:prstDash val="solid"/>
+                      <a:round/>
+                      <a:headEnd type="none" w="med" len="med"/>
+                      <a:tailEnd type="none" w="med" len="med"/>
+                    </a:lnB>
+                    <a:solidFill>
+                      <a:srgbClr val="FFFFFF"/>
+                    </a:solidFill>
+                  </a:tcPr>
+                </a:tc>
+                <a:tc>
+                  <a:txBody>
+                    <a:bodyPr/>
+                    <a:lstStyle/>
+                    <a:p>
+                      <a:pPr algn="l" indent="0" marL="0">
+                        <a:buNone/>
+                      </a:pPr>
+                      <a:r>
+                        <a:rPr lang="en-US" sz="1050" dirty="0">
+                          <a:solidFill>
+                            <a:srgbClr val="0B0B0B"/>
+                          </a:solidFill>
+                          <a:latin typeface="Calibri" pitchFamily="34" charset="0"/>
+                          <a:ea typeface="Calibri" pitchFamily="34" charset="-122"/>
+                          <a:cs typeface="Calibri" pitchFamily="34" charset="-120"/>
+                        </a:rPr>
+                        <a:t>—</a:t>
+                      </a:r>
+                      <a:endParaRPr lang="en-US" sz="1050" dirty="0">
+                        <a:latin typeface="Calibri" charset="0"/>
+                        <a:ea typeface="Calibri" charset="0"/>
+                        <a:cs typeface="Calibri" charset="0"/>
+                      </a:endParaRPr>
+                    </a:p>
+                  </a:txBody>
+                  <a:tcPr marL="91440" marR="91440" marT="45720" marB="45720" anchor="ctr">
+                    <a:lnL w="6350" cap="flat" cmpd="sng" algn="ctr">
+                      <a:solidFill>
+                        <a:srgbClr val="E1E0D9"/>
+                      </a:solidFill>
+                      <a:prstDash val="solid"/>
+                      <a:round/>
+                      <a:headEnd type="none" w="med" len="med"/>
+                      <a:tailEnd type="none" w="med" len="med"/>
+                    </a:lnL>
+                    <a:lnR w="6350" cap="flat" cmpd="sng" algn="ctr">
+                      <a:solidFill>
+                        <a:srgbClr val="E1E0D9"/>
+                      </a:solidFill>
+                      <a:prstDash val="solid"/>
+                      <a:round/>
+                      <a:headEnd type="none" w="med" len="med"/>
+                      <a:tailEnd type="none" w="med" len="med"/>
+                    </a:lnR>
+                    <a:lnT w="6350" cap="flat" cmpd="sng" algn="ctr">
+                      <a:solidFill>
+                        <a:srgbClr val="E1E0D9"/>
+                      </a:solidFill>
+                      <a:prstDash val="solid"/>
+                      <a:round/>
+                      <a:headEnd type="none" w="med" len="med"/>
+                      <a:tailEnd type="none" w="med" len="med"/>
+                    </a:lnT>
+                    <a:lnB w="6350" cap="flat" cmpd="sng" algn="ctr">
+                      <a:solidFill>
+                        <a:srgbClr val="E1E0D9"/>
+                      </a:solidFill>
+                      <a:prstDash val="solid"/>
+                      <a:round/>
+                      <a:headEnd type="none" w="med" len="med"/>
+                      <a:tailEnd type="none" w="med" len="med"/>
+                    </a:lnB>
+                    <a:solidFill>
+                      <a:srgbClr val="FFFFFF"/>
+                    </a:solidFill>
+                  </a:tcPr>
+                </a:tc>
+                <a:tc>
+                  <a:txBody>
+                    <a:bodyPr/>
+                    <a:lstStyle/>
+                    <a:p>
+                      <a:pPr algn="l" indent="0" marL="0">
+                        <a:buNone/>
+                      </a:pPr>
+                      <a:r>
+                        <a:rPr lang="en-US" sz="1050" dirty="0">
+                          <a:solidFill>
+                            <a:srgbClr val="0B0B0B"/>
+                          </a:solidFill>
+                          <a:latin typeface="Calibri" pitchFamily="34" charset="0"/>
+                          <a:ea typeface="Calibri" pitchFamily="34" charset="-122"/>
+                          <a:cs typeface="Calibri" pitchFamily="34" charset="-120"/>
+                        </a:rPr>
+                        <a:t>Sep-26</a:t>
+                      </a:r>
+                      <a:endParaRPr lang="en-US" sz="1050" dirty="0">
+                        <a:latin typeface="Calibri" charset="0"/>
+                        <a:ea typeface="Calibri" charset="0"/>
+                        <a:cs typeface="Calibri" charset="0"/>
+                      </a:endParaRPr>
+                    </a:p>
+                  </a:txBody>
+                  <a:tcPr marL="91440" marR="91440" marT="45720" marB="45720" anchor="ctr">
+                    <a:lnL w="6350" cap="flat" cmpd="sng" algn="ctr">
+                      <a:solidFill>
+                        <a:srgbClr val="E1E0D9"/>
+                      </a:solidFill>
+                      <a:prstDash val="solid"/>
+                      <a:round/>
+                      <a:headEnd type="none" w="med" len="med"/>
+                      <a:tailEnd type="none" w="med" len="med"/>
+                    </a:lnL>
+                    <a:lnR w="6350" cap="flat" cmpd="sng" algn="ctr">
+                      <a:solidFill>
+                        <a:srgbClr val="E1E0D9"/>
+                      </a:solidFill>
+                      <a:prstDash val="solid"/>
+                      <a:round/>
+                      <a:headEnd type="none" w="med" len="med"/>
+                      <a:tailEnd type="none" w="med" len="med"/>
+                    </a:lnR>
+                    <a:lnT w="6350" cap="flat" cmpd="sng" algn="ctr">
+                      <a:solidFill>
+                        <a:srgbClr val="E1E0D9"/>
+                      </a:solidFill>
+                      <a:prstDash val="solid"/>
+                      <a:round/>
+                      <a:headEnd type="none" w="med" len="med"/>
+                      <a:tailEnd type="none" w="med" len="med"/>
+                    </a:lnT>
+                    <a:lnB w="6350" cap="flat" cmpd="sng" algn="ctr">
+                      <a:solidFill>
+                        <a:srgbClr val="E1E0D9"/>
+                      </a:solidFill>
+                      <a:prstDash val="solid"/>
+                      <a:round/>
+                      <a:headEnd type="none" w="med" len="med"/>
+                      <a:tailEnd type="none" w="med" len="med"/>
+                    </a:lnB>
+                    <a:solidFill>
+                      <a:srgbClr val="FFFFFF"/>
+                    </a:solidFill>
+                  </a:tcPr>
+                </a:tc>
+              </a:tr>
+              <a:tr h="365760">
+                <a:tc>
+                  <a:txBody>
+                    <a:bodyPr/>
+                    <a:lstStyle/>
+                    <a:p>
+                      <a:pPr algn="l" indent="0" marL="0">
+                        <a:buNone/>
+                      </a:pPr>
+                      <a:r>
+                        <a:rPr lang="en-US" sz="1050" b="1" dirty="0">
+                          <a:solidFill>
+                            <a:srgbClr val="0B0B0B"/>
+                          </a:solidFill>
+                          <a:latin typeface="Calibri" pitchFamily="34" charset="0"/>
+                          <a:ea typeface="Calibri" pitchFamily="34" charset="-122"/>
+                          <a:cs typeface="Calibri" pitchFamily="34" charset="-120"/>
+                        </a:rPr>
+                        <a:t>Renaissance 345kV (6 MOD switches) ‡</a:t>
                       </a:r>
                       <a:endParaRPr lang="en-US" sz="1050" dirty="0">
                         <a:latin typeface="Calibri" charset="0"/>
@@ -12104,15 +12582,15 @@
                         <a:buNone/>
                       </a:pPr>
                       <a:r>
-                        <a:rPr lang="en-US" sz="1050" dirty="0">
+                        <a:rPr lang="en-US" sz="1050" b="1" dirty="0">
                           <a:solidFill>
-                            <a:srgbClr val="0B0B0B"/>
+                            <a:srgbClr val="2A78D6"/>
                           </a:solidFill>
                           <a:latin typeface="Calibri" pitchFamily="34" charset="0"/>
                           <a:ea typeface="Calibri" pitchFamily="34" charset="-122"/>
                           <a:cs typeface="Calibri" pitchFamily="34" charset="-120"/>
                         </a:rPr>
-                        <a:t>on hold</a:t>
+                        <a:t>in bid</a:t>
                       </a:r>
                       <a:endParaRPr lang="en-US" sz="1050" dirty="0">
                         <a:latin typeface="Calibri" charset="0"/>
@@ -12248,7 +12726,7 @@
                           <a:ea typeface="Calibri" pitchFamily="34" charset="-122"/>
                           <a:cs typeface="Calibri" pitchFamily="34" charset="-120"/>
                         </a:rPr>
-                        <a:t>hold</a:t>
+                        <a:t>Sep-26</a:t>
                       </a:r>
                       <a:endParaRPr lang="en-US" sz="1050" dirty="0">
                         <a:latin typeface="Calibri" charset="0"/>
@@ -12821,7 +13299,7 @@
                 <a:ea typeface="Calibri" pitchFamily="34" charset="-122"/>
                 <a:cs typeface="Calibri" pitchFamily="34" charset="-120"/>
               </a:rPr>
-              <a:t>Consumers pole replacements — $300K CVR scope now booked to backlog</a:t>
+              <a:t>Consumers pole replacements — $276K CVR scope now booked to backlog</a:t>
             </a:r>
             <a:endParaRPr lang="en-US" sz="1150" dirty="0"/>
           </a:p>
@@ -13016,7 +13494,7 @@
                 <a:ea typeface="Calibri" pitchFamily="34" charset="-122"/>
                 <a:cs typeface="Calibri" pitchFamily="34" charset="-120"/>
               </a:rPr>
-              <a:t>KPI current-bids page, 7/11/26. Win probabilities are planning placeholders (2026 win rate or 50%) — Estimating to own final numbers and award dates.</a:t>
+              <a:t>KPI current-bids page, 7/25/26. ‡ Newly in bid (due Sep-26), both EPC-paired: MEC VanMeter (greenfield 161kV + 6 mi transmission) and DTE Renaissance (off hold). Win probabilities are planning placeholders (2026 win rate 69% or 50%) — Estimating to own final numbers.</a:t>
             </a:r>
             <a:endParaRPr lang="en-US" sz="950" dirty="0"/>
           </a:p>
@@ -14610,7 +15088,7 @@
                 <a:ea typeface="Calibri" pitchFamily="34" charset="-122"/>
                 <a:cs typeface="Calibri" pitchFamily="34" charset="-120"/>
               </a:rPr>
-              <a:t>67%</a:t>
+              <a:t>69%</a:t>
             </a:r>
             <a:endParaRPr lang="en-US" sz="2700" dirty="0"/>
           </a:p>
@@ -14986,7 +15464,7 @@
                 <a:ea typeface="Calibri" pitchFamily="34" charset="-122"/>
                 <a:cs typeface="Calibri" pitchFamily="34" charset="-120"/>
               </a:rPr>
-              <a:t>Foothold: HVD line-sensor program live; 2026 pole replacements WON ($300K CVR scope, $3.45M EPC-paired)</a:t>
+              <a:t>Foothold: HVD line-sensor program live; 2026 pole replacements WON ($276K CVR scope, $3.45M EPC-paired)</a:t>
             </a:r>
             <a:endParaRPr lang="en-US" sz="1000" dirty="0"/>
           </a:p>
@@ -15167,7 +15645,7 @@
                 <a:ea typeface="Calibri" pitchFamily="34" charset="-122"/>
                 <a:cs typeface="Calibri" pitchFamily="34" charset="-120"/>
               </a:rPr>
-              <a:t>Foothold: New Baltimore &amp; Catalina conversions ($2.3M PO); Renaissance 345kV bid on hold</a:t>
+              <a:t>Foothold: New Baltimore &amp; Catalina conversions ($2.3M PO); Renaissance 345kV bid active (due Sep-26)</a:t>
             </a:r>
             <a:endParaRPr lang="en-US" sz="1000" dirty="0"/>
           </a:p>
@@ -17848,7 +18326,7 @@
                           <a:ea typeface="Calibri" pitchFamily="34" charset="-122"/>
                           <a:cs typeface="Calibri" pitchFamily="34" charset="-120"/>
                         </a:rPr>
-                        <a:t>Conversion program follow-on; revive the Renaissance 345kV pursuit</a:t>
+                        <a:t>Conversion program follow-on; advance the Renaissance 345kV pursuit (now in bid)</a:t>
                       </a:r>
                       <a:endParaRPr lang="en-US" sz="1000" dirty="0">
                         <a:latin typeface="Calibri" charset="0"/>
@@ -26647,7 +27125,7 @@
                 <a:ea typeface="Calibri" pitchFamily="34" charset="-122"/>
                 <a:cs typeface="Calibri" pitchFamily="34" charset="-120"/>
               </a:rPr>
-              <a:t>Bid hours per the KPI report (through 7/11/26). Raise with the CFO as an EPC accounting-alignment item.</a:t>
+              <a:t>Bid hours per the KPI report (through 7/25/26). Raise with the CFO as an EPC accounting-alignment item.</a:t>
             </a:r>
             <a:endParaRPr lang="en-US" sz="950" dirty="0"/>
           </a:p>
@@ -29478,7 +29956,7 @@
                 <a:ea typeface="Calibri" pitchFamily="34" charset="-122"/>
                 <a:cs typeface="Calibri" pitchFamily="34" charset="-120"/>
               </a:rPr>
-              <a:t>59.0%</a:t>
+              <a:t>60.8%</a:t>
             </a:r>
             <a:endParaRPr lang="en-US" sz="2500" dirty="0"/>
           </a:p>
@@ -29767,7 +30245,7 @@
                 <a:ea typeface="Calibri" pitchFamily="34" charset="-122"/>
                 <a:cs typeface="Calibri" pitchFamily="34" charset="-120"/>
               </a:rPr>
-              <a:t>The team realizes ~$122/hr against a $154/hr rate card at 59% utilization. Closing those two gaps roughly doubles revenue on the current roster.</a:t>
+              <a:t>The team realizes ~$122/hr against a $154/hr rate card at 61% utilization. Closing those two gaps roughly doubles revenue on the current roster.</a:t>
             </a:r>
             <a:endParaRPr lang="en-US" sz="1500" dirty="0"/>
           </a:p>
@@ -31445,7 +31923,7 @@
                 <a:ea typeface="Calibri" pitchFamily="34" charset="-122"/>
                 <a:cs typeface="Calibri" pitchFamily="34" charset="-120"/>
               </a:rPr>
-              <a:t>H1 2026: 4,747 billable hours (through 7/11) · blended card rate mix-weighted from actual billable hours by classification.</a:t>
+              <a:t>H1 2026: 5,116 billable hours (through 7/25) · blended card rate mix-weighted from actual billable hours by classification.</a:t>
             </a:r>
             <a:endParaRPr lang="en-US" sz="950" dirty="0"/>
           </a:p>
@@ -32585,7 +33063,7 @@
                           <a:ea typeface="Calibri" pitchFamily="34" charset="-122"/>
                           <a:cs typeface="Calibri" pitchFamily="34" charset="-120"/>
                         </a:rPr>
-                        <a:t>847</a:t>
+                        <a:t>881</a:t>
                       </a:r>
                       <a:endParaRPr lang="en-US" sz="1000" dirty="0">
                         <a:latin typeface="Calibri" charset="0"/>
@@ -32653,7 +33131,7 @@
                           <a:ea typeface="Calibri" pitchFamily="34" charset="-122"/>
                           <a:cs typeface="Calibri" pitchFamily="34" charset="-120"/>
                         </a:rPr>
-                        <a:t>32.7%</a:t>
+                        <a:t>35.3%</a:t>
                       </a:r>
                       <a:endParaRPr lang="en-US" sz="1000" dirty="0">
                         <a:latin typeface="Calibri" charset="0"/>
@@ -32927,7 +33405,7 @@
                           <a:ea typeface="Calibri" pitchFamily="34" charset="-122"/>
                           <a:cs typeface="Calibri" pitchFamily="34" charset="-120"/>
                         </a:rPr>
-                        <a:t>952</a:t>
+                        <a:t>994</a:t>
                       </a:r>
                       <a:endParaRPr lang="en-US" sz="1000" dirty="0">
                         <a:latin typeface="Calibri" charset="0"/>
@@ -32995,7 +33473,7 @@
                           <a:ea typeface="Calibri" pitchFamily="34" charset="-122"/>
                           <a:cs typeface="Calibri" pitchFamily="34" charset="-120"/>
                         </a:rPr>
-                        <a:t>66.9%</a:t>
+                        <a:t>68.3%</a:t>
                       </a:r>
                       <a:endParaRPr lang="en-US" sz="1000" dirty="0">
                         <a:latin typeface="Calibri" charset="0"/>
@@ -34295,7 +34773,7 @@
                           <a:ea typeface="Calibri" pitchFamily="34" charset="-122"/>
                           <a:cs typeface="Calibri" pitchFamily="34" charset="-120"/>
                         </a:rPr>
-                        <a:t>1,045</a:t>
+                        <a:t>1,118</a:t>
                       </a:r>
                       <a:endParaRPr lang="en-US" sz="1000" dirty="0">
                         <a:latin typeface="Calibri" charset="0"/>
@@ -34363,7 +34841,7 @@
                           <a:ea typeface="Calibri" pitchFamily="34" charset="-122"/>
                           <a:cs typeface="Calibri" pitchFamily="34" charset="-120"/>
                         </a:rPr>
-                        <a:t>74.4%</a:t>
+                        <a:t>76.0%</a:t>
                       </a:r>
                       <a:endParaRPr lang="en-US" sz="1000" dirty="0">
                         <a:latin typeface="Calibri" charset="0"/>
@@ -34637,7 +35115,7 @@
                           <a:ea typeface="Calibri" pitchFamily="34" charset="-122"/>
                           <a:cs typeface="Calibri" pitchFamily="34" charset="-120"/>
                         </a:rPr>
-                        <a:t>992</a:t>
+                        <a:t>1,070</a:t>
                       </a:r>
                       <a:endParaRPr lang="en-US" sz="1000" dirty="0">
                         <a:latin typeface="Calibri" charset="0"/>
@@ -34705,7 +35183,7 @@
                           <a:ea typeface="Calibri" pitchFamily="34" charset="-122"/>
                           <a:cs typeface="Calibri" pitchFamily="34" charset="-120"/>
                         </a:rPr>
-                        <a:t>62.5%</a:t>
+                        <a:t>65.2%</a:t>
                       </a:r>
                       <a:endParaRPr lang="en-US" sz="1000" dirty="0">
                         <a:latin typeface="Calibri" charset="0"/>
@@ -35321,7 +35799,7 @@
                           <a:ea typeface="Calibri" pitchFamily="34" charset="-122"/>
                           <a:cs typeface="Calibri" pitchFamily="34" charset="-120"/>
                         </a:rPr>
-                        <a:t>1,017</a:t>
+                        <a:t>1,111</a:t>
                       </a:r>
                       <a:endParaRPr lang="en-US" sz="1000" dirty="0">
                         <a:latin typeface="Calibri" charset="0"/>
@@ -35389,7 +35867,7 @@
                           <a:ea typeface="Calibri" pitchFamily="34" charset="-122"/>
                           <a:cs typeface="Calibri" pitchFamily="34" charset="-120"/>
                         </a:rPr>
-                        <a:t>79.6%</a:t>
+                        <a:t>81.4%</a:t>
                       </a:r>
                       <a:endParaRPr lang="en-US" sz="1000" dirty="0">
                         <a:latin typeface="Calibri" charset="0"/>
@@ -36347,7 +36825,7 @@
                           <a:ea typeface="Calibri" pitchFamily="34" charset="-122"/>
                           <a:cs typeface="Calibri" pitchFamily="34" charset="-120"/>
                         </a:rPr>
-                        <a:t>985</a:t>
+                        <a:t>1,030</a:t>
                       </a:r>
                       <a:endParaRPr lang="en-US" sz="1000" dirty="0">
                         <a:latin typeface="Calibri" charset="0"/>
@@ -36415,7 +36893,7 @@
                           <a:ea typeface="Calibri" pitchFamily="34" charset="-122"/>
                           <a:cs typeface="Calibri" pitchFamily="34" charset="-120"/>
                         </a:rPr>
-                        <a:t>57.6%</a:t>
+                        <a:t>59.4%</a:t>
                       </a:r>
                       <a:endParaRPr lang="en-US" sz="1000" dirty="0">
                         <a:latin typeface="Calibri" charset="0"/>
@@ -36689,7 +37167,7 @@
                           <a:ea typeface="Calibri" pitchFamily="34" charset="-122"/>
                           <a:cs typeface="Calibri" pitchFamily="34" charset="-120"/>
                         </a:rPr>
-                        <a:t>18</a:t>
+                        <a:t>22</a:t>
                       </a:r>
                       <a:endParaRPr lang="en-US" sz="1000" dirty="0">
                         <a:latin typeface="Calibri" charset="0"/>
@@ -37406,7 +37884,7 @@
                 <a:ea typeface="Calibri" pitchFamily="34" charset="-122"/>
                 <a:cs typeface="Calibri" pitchFamily="34" charset="-120"/>
               </a:rPr>
-              <a:t>59.0%</a:t>
+              <a:t>60.8%</a:t>
             </a:r>
             <a:endParaRPr lang="en-US" sz="2800" dirty="0"/>
           </a:p>
@@ -37640,7 +38118,7 @@
                 <a:ea typeface="Calibri" pitchFamily="34" charset="-122"/>
                 <a:cs typeface="Calibri" pitchFamily="34" charset="-120"/>
               </a:rPr>
-              <a:t>Hours through 7/11/26. Randy Pynenberg (68 hrs) and Auston Hopson (18 hrs) have small YTD bases. Bids/BD time is tracked separately (405 hrs).</a:t>
+              <a:t>Hours through 7/25/26. Randy Pynenberg (68 hrs) and Auston Hopson (22 hrs) have small YTD bases. Bids/BD time is tracked separately (405 hrs).</a:t>
             </a:r>
             <a:endParaRPr lang="en-US" sz="950" dirty="0"/>
           </a:p>

</xml_diff>